<commit_message>
Limit claims to documented hh API data; move verification items to slide notes
</commit_message>
<xml_diff>
--- a/Skillaz-hh-Integration.pptx
+++ b/Skillaz-hh-Integration.pptx
@@ -2,22 +2,22 @@
 <file path=ppt/presentation.xml><?xml version="1.0" encoding="utf-8"?>
 <p:presentation xmlns:p="http://schemas.openxmlformats.org/presentationml/2006/main">
   <p:sldMasterIdLst>
-    <p:sldMasterId xmlns:r="http://schemas.openxmlformats.org/officeDocument/2006/relationships" id="2147483648" r:id="R6e80ef1a162e4fd3"/>
+    <p:sldMasterId xmlns:r="http://schemas.openxmlformats.org/officeDocument/2006/relationships" id="2147483648" r:id="Rec1853f8204c4558"/>
   </p:sldMasterIdLst>
   <p:notesMasterIdLst>
-    <p:notesMasterId xmlns:r="http://schemas.openxmlformats.org/officeDocument/2006/relationships" r:id="Re4ae23bae7de4b63"/>
+    <p:notesMasterId xmlns:r="http://schemas.openxmlformats.org/officeDocument/2006/relationships" r:id="R3539e99b55144c49"/>
   </p:notesMasterIdLst>
   <p:sldIdLst>
-    <p:sldId xmlns:r="http://schemas.openxmlformats.org/officeDocument/2006/relationships" id="256" r:id="R55a922722db346a5"/>
-    <p:sldId xmlns:r="http://schemas.openxmlformats.org/officeDocument/2006/relationships" id="257" r:id="R6e4dfc543e004e9a"/>
-    <p:sldId xmlns:r="http://schemas.openxmlformats.org/officeDocument/2006/relationships" id="258" r:id="R4dfaa530abcc431d"/>
-    <p:sldId xmlns:r="http://schemas.openxmlformats.org/officeDocument/2006/relationships" id="259" r:id="R9c67d7ddd70b4e1c"/>
-    <p:sldId xmlns:r="http://schemas.openxmlformats.org/officeDocument/2006/relationships" id="260" r:id="R7f8bf03db34045cd"/>
-    <p:sldId xmlns:r="http://schemas.openxmlformats.org/officeDocument/2006/relationships" id="261" r:id="R01d53324e0794cf4"/>
-    <p:sldId xmlns:r="http://schemas.openxmlformats.org/officeDocument/2006/relationships" id="262" r:id="Rf9d17afe583149e9"/>
-    <p:sldId xmlns:r="http://schemas.openxmlformats.org/officeDocument/2006/relationships" id="263" r:id="R323554efdd004371"/>
-    <p:sldId xmlns:r="http://schemas.openxmlformats.org/officeDocument/2006/relationships" id="264" r:id="R2327c85aee504466"/>
-    <p:sldId xmlns:r="http://schemas.openxmlformats.org/officeDocument/2006/relationships" id="265" r:id="Rfb3c2faa106b4ee2"/>
+    <p:sldId xmlns:r="http://schemas.openxmlformats.org/officeDocument/2006/relationships" id="256" r:id="R8133d69ff5ac4641"/>
+    <p:sldId xmlns:r="http://schemas.openxmlformats.org/officeDocument/2006/relationships" id="257" r:id="Rbf9bfd30a9dc41e1"/>
+    <p:sldId xmlns:r="http://schemas.openxmlformats.org/officeDocument/2006/relationships" id="258" r:id="Rc51783c445f94a2d"/>
+    <p:sldId xmlns:r="http://schemas.openxmlformats.org/officeDocument/2006/relationships" id="259" r:id="Rc8d420f9a86a4a64"/>
+    <p:sldId xmlns:r="http://schemas.openxmlformats.org/officeDocument/2006/relationships" id="260" r:id="Rce7a6ee2316646df"/>
+    <p:sldId xmlns:r="http://schemas.openxmlformats.org/officeDocument/2006/relationships" id="261" r:id="R051fed3287a3455e"/>
+    <p:sldId xmlns:r="http://schemas.openxmlformats.org/officeDocument/2006/relationships" id="262" r:id="Rfb77e45367db4aeb"/>
+    <p:sldId xmlns:r="http://schemas.openxmlformats.org/officeDocument/2006/relationships" id="263" r:id="Rb37a7979a4544d44"/>
+    <p:sldId xmlns:r="http://schemas.openxmlformats.org/officeDocument/2006/relationships" id="264" r:id="R9becae8d96b4464d"/>
+    <p:sldId xmlns:r="http://schemas.openxmlformats.org/officeDocument/2006/relationships" id="265" r:id="Rcbdde80158f84570"/>
   </p:sldIdLst>
   <p:sldSz cx="10692384" cy="6007608"/>
   <p:notesSz cx="6858000" cy="9144000"/>
@@ -451,7 +451,7 @@
           <a:lstStyle xmlns:a="http://schemas.openxmlformats.org/drawingml/2006/main"/>
           <a:p xmlns:a="http://schemas.openxmlformats.org/drawingml/2006/main">
             <a:r>
-              <a:t>Источник: Presentation-Razbor-Doopros.pdf, предоставленная пользователем презентация Skillaz × hh.ru. Возможности интеграции описаны в исходной презентации, работоспособность не проверена.</a:t>
+              <a:t>ПРОВЕРКА API, 16.10.2026. Источники: https://api.hh.ru/openapi/specification/public ; https://api.hh.ru/openapi/redoc#tag/Otklikipriglasheniya-rabotodatelya/operation/get-negotiation-item . В официальных примерах GET /negotiations/{id} и списка откликов есть ai_assistant.neuro_response и ai_assistant.neuro_invite. Реальный авторизованный запрос от Skillaz не выполнялся; доступность для конкретного клиента, полнота, гарантии и условия оплаты не подтверждены. Источник экранов: предоставленный Presentation-Razbor-Doopros.pdf.</a:t>
             </a:r>
           </a:p>
           <a:p xmlns:a="http://schemas.openxmlformats.org/drawingml/2006/main">
@@ -461,17 +461,7 @@
           </a:p>
           <a:p xmlns:a="http://schemas.openxmlformats.org/drawingml/2006/main">
             <a:r>
-              <a:t>НЕПОДТВЕРЖДЁННЫЕ ВОЗМОЖНОСТИ</a:t>
-            </a:r>
-          </a:p>
-          <a:p xmlns:a="http://schemas.openxmlformats.org/drawingml/2006/main">
-            <a:r>
-              <a:t>Подтвердить доступность Нейроразбора и Доопроса в текущей версии, состав данных в карточке. Исходные экраны являются иллюстрациями из презентации, а не проверкой продукта.</a:t>
-            </a:r>
-          </a:p>
-          <a:p xmlns:a="http://schemas.openxmlformats.org/drawingml/2006/main">
-            <a:r>
-              <a:t>Комментарий для выступления: интеграция переносит результаты ИИ-помощника hh в рабочий процесс Skillaz.</a:t>
+              <a:t>Позиционирование: публичная документация описывает получение результатов ИИ, но не подтверждает готовую интеграцию Skillaz. Проверить токен приложения Skillaz, доступ клиента, наличие ai_assistant в реальном отклике и продуктовый релиз. Не обещать работу в карточке до проверки.</a:t>
             </a:r>
           </a:p>
         </p:txBody>
@@ -541,7 +531,7 @@
           <a:lstStyle xmlns:a="http://schemas.openxmlformats.org/drawingml/2006/main"/>
           <a:p xmlns:a="http://schemas.openxmlformats.org/drawingml/2006/main">
             <a:r>
-              <a:t>Источник: Presentation-Razbor-Doopros.pdf, предоставленная пользователем презентация Skillaz × hh.ru. Возможности интеграции описаны в исходной презентации, работоспособность не проверена.</a:t>
+              <a:t>ПРОВЕРКА API, 16.10.2026. Источники: https://api.hh.ru/openapi/specification/public ; https://api.hh.ru/openapi/redoc#tag/Otklikipriglasheniya-rabotodatelya/operation/get-negotiation-item . В официальных примерах GET /negotiations/{id} и списка откликов есть ai_assistant.neuro_response и ai_assistant.neuro_invite. Реальный авторизованный запрос от Skillaz не выполнялся; доступность для конкретного клиента, полнота, гарантии и условия оплаты не подтверждены. Источник экранов: предоставленный Presentation-Razbor-Doopros.pdf.</a:t>
             </a:r>
           </a:p>
           <a:p xmlns:a="http://schemas.openxmlformats.org/drawingml/2006/main">
@@ -551,17 +541,7 @@
           </a:p>
           <a:p xmlns:a="http://schemas.openxmlformats.org/drawingml/2006/main">
             <a:r>
-              <a:t>УСЛОВИЯ ПИЛОТА ТРЕБУЮТ СОГЛАСОВАНИЯ</a:t>
-            </a:r>
-          </a:p>
-          <a:p xmlns:a="http://schemas.openxmlformats.org/drawingml/2006/main">
-            <a:r>
-              <a:t>Подтвердить сроки подключения и пилота, стоимость, объём откликов, ответственность сторон и критерии приёмки. Срок «две недели» и гарантированные проценты эффекта не заявляются.</a:t>
-            </a:r>
-          </a:p>
-          <a:p xmlns:a="http://schemas.openxmlformats.org/drawingml/2006/main">
-            <a:r>
-              <a:t>Результат: замеры времени, качество данных, обратная связь команды и расчёт стоимости использования.</a:t>
+              <a:t>Перед пилотом: получить реальный отклик с завершённым разбором и доопросом, выполнить GET /negotiations/{id} от приложения Skillaz, проверить ai_assistant и сопоставление данных. Запросить у hh документацию партнёрских методов, права, ограничения и коммерческие условия. Сроки, цена пилота, объём, ответственность и критерии приёмки не подтверждены.</a:t>
             </a:r>
           </a:p>
         </p:txBody>
@@ -631,7 +611,7 @@
           <a:lstStyle xmlns:a="http://schemas.openxmlformats.org/drawingml/2006/main"/>
           <a:p xmlns:a="http://schemas.openxmlformats.org/drawingml/2006/main">
             <a:r>
-              <a:t>Источник: Presentation-Razbor-Doopros.pdf, предоставленная пользователем презентация Skillaz × hh.ru. Возможности интеграции описаны в исходной презентации, работоспособность не проверена.</a:t>
+              <a:t>ПРОВЕРКА API, 16.10.2026. Источники: https://api.hh.ru/openapi/specification/public ; https://api.hh.ru/openapi/redoc#tag/Otklikipriglasheniya-rabotodatelya/operation/get-negotiation-item . В официальных примерах GET /negotiations/{id} и списка откликов есть ai_assistant.neuro_response и ai_assistant.neuro_invite. Реальный авторизованный запрос от Skillaz не выполнялся; доступность для конкретного клиента, полнота, гарантии и условия оплаты не подтверждены. Источник экранов: предоставленный Presentation-Razbor-Doopros.pdf.</a:t>
             </a:r>
           </a:p>
           <a:p xmlns:a="http://schemas.openxmlformats.org/drawingml/2006/main">
@@ -641,12 +621,7 @@
           </a:p>
           <a:p xmlns:a="http://schemas.openxmlformats.org/drawingml/2006/main">
             <a:r>
-              <a:t>ПРОВЕРИТЬ ПЕРЕД ПУБЛИКАЦИЕЙ</a:t>
-            </a:r>
-          </a:p>
-          <a:p xmlns:a="http://schemas.openxmlformats.org/drawingml/2006/main">
-            <a:r>
-              <a:t>Схема иллюстративная. Подтвердить ручные шаги у клиента и исключить операции, уже автоматизированные текущим обменом. Сокращение действий является гипотезой для пилота, а не измеренным результатом.</a:t>
+              <a:t>Подтверждены примеры данных neuro_response и neuro_invite. Блок найден в examples; подробной схемы ai_assistant в проверенной спецификации нет. Нужны реальные ответы API, перечень значений, nullable-поля и условия появления блока. Сокращение ручных действий — гипотеза пилота.</a:t>
             </a:r>
           </a:p>
         </p:txBody>
@@ -716,7 +691,7 @@
           <a:lstStyle xmlns:a="http://schemas.openxmlformats.org/drawingml/2006/main"/>
           <a:p xmlns:a="http://schemas.openxmlformats.org/drawingml/2006/main">
             <a:r>
-              <a:t>Источник: Presentation-Razbor-Doopros.pdf, предоставленная пользователем презентация Skillaz × hh.ru. Возможности интеграции описаны в исходной презентации, работоспособность не проверена.</a:t>
+              <a:t>ПРОВЕРКА API, 16.10.2026. Источники: https://api.hh.ru/openapi/specification/public ; https://api.hh.ru/openapi/redoc#tag/Otklikipriglasheniya-rabotodatelya/operation/get-negotiation-item . В официальных примерах GET /negotiations/{id} и списка откликов есть ai_assistant.neuro_response и ai_assistant.neuro_invite. Реальный авторизованный запрос от Skillaz не выполнялся; доступность для конкретного клиента, полнота, гарантии и условия оплаты не подтверждены. Источник экранов: предоставленный Presentation-Razbor-Doopros.pdf.</a:t>
             </a:r>
           </a:p>
           <a:p xmlns:a="http://schemas.openxmlformats.org/drawingml/2006/main">
@@ -726,22 +701,7 @@
           </a:p>
           <a:p xmlns:a="http://schemas.openxmlformats.org/drawingml/2006/main">
             <a:r>
-              <a:t>ИСТОЧНИК hh: https://feedback.hh.ru/knowledge-base/article/022833</a:t>
-            </a:r>
-          </a:p>
-          <a:p xmlns:a="http://schemas.openxmlformats.org/drawingml/2006/main">
-            <a:r>
-              <a:t>НЕПОДТВЕРЖДЁННЫЕ ВОЗМОЖНОСТИ SKILLAZ</a:t>
-            </a:r>
-          </a:p>
-          <a:p xmlns:a="http://schemas.openxmlformats.org/drawingml/2006/main">
-            <a:r>
-              <a:t>Подтвердить все пункты правой колонки: категории, подробный разбор, запись ответов в предусмотренные поля. Особенно важно отличать структурированные поля от текстовой выжимки. Совпадение возможностей не подтверждает техническую архитектуру.</a:t>
-            </a:r>
-          </a:p>
-          <a:p xmlns:a="http://schemas.openxmlformats.org/drawingml/2006/main">
-            <a:r>
-              <a:t>Исходная презентация: слайды 5–11.</a:t>
+              <a:t>Таблица отражает только поля официального примера API. Требуют проверки: показ результата в воронке Skillaz, работа с категориями, отображение подробного разбора, привязка вопросов к полям и автоматическое заполнение карточки. Цитата ответа в API не равна готовому структурированному полю Skillaz.</a:t>
             </a:r>
           </a:p>
         </p:txBody>
@@ -811,7 +771,7 @@
           <a:lstStyle xmlns:a="http://schemas.openxmlformats.org/drawingml/2006/main"/>
           <a:p xmlns:a="http://schemas.openxmlformats.org/drawingml/2006/main">
             <a:r>
-              <a:t>Источник: Presentation-Razbor-Doopros.pdf, предоставленная пользователем презентация Skillaz × hh.ru. Возможности интеграции описаны в исходной презентации, работоспособность не проверена.</a:t>
+              <a:t>ПРОВЕРКА API, 16.10.2026. Источники: https://api.hh.ru/openapi/specification/public ; https://api.hh.ru/openapi/redoc#tag/Otklikipriglasheniya-rabotodatelya/operation/get-negotiation-item . В официальных примерах GET /negotiations/{id} и списка откликов есть ai_assistant.neuro_response и ai_assistant.neuro_invite. Реальный авторизованный запрос от Skillaz не выполнялся; доступность для конкретного клиента, полнота, гарантии и условия оплаты не подтверждены. Источник экранов: предоставленный Presentation-Razbor-Doopros.pdf.</a:t>
             </a:r>
           </a:p>
           <a:p xmlns:a="http://schemas.openxmlformats.org/drawingml/2006/main">
@@ -821,17 +781,7 @@
           </a:p>
           <a:p xmlns:a="http://schemas.openxmlformats.org/drawingml/2006/main">
             <a:r>
-              <a:t>НЕПОДТВЕРЖДЁННЫЕ ВОЗМОЖНОСТИ</a:t>
-            </a:r>
-          </a:p>
-          <a:p xmlns:a="http://schemas.openxmlformats.org/drawingml/2006/main">
-            <a:r>
-              <a:t>Подтвердить настройки из Skillaz, условия запуска, обновление результатов и исключения, требующие перехода в hh.ru. Скорость обмена не обещается. Доопрос относится к новым откликам согласно документации hh: https://feedback.hh.ru/knowledge-base/article/022833</a:t>
-            </a:r>
-          </a:p>
-          <a:p xmlns:a="http://schemas.openxmlformats.org/drawingml/2006/main">
-            <a:r>
-              <a:t>Исходная презентация: слайды 7 и 12.</a:t>
+              <a:t>НЕПОДТВЕРЖДЁННЫЕ ВОЗМОЖНОСТИ: настройка критериев и включение ИИ из Skillaz; запуск доопроса и управление вопросами через API; повторный разбор; получение уведомлений об изменении результатов. Публичные методы управления этими функциями не найдены. Отсутствие в публичной документации не исключает партнёрский API. Проверить периодичность обновлений и условия доступа.</a:t>
             </a:r>
           </a:p>
         </p:txBody>
@@ -901,7 +851,7 @@
           <a:lstStyle xmlns:a="http://schemas.openxmlformats.org/drawingml/2006/main"/>
           <a:p xmlns:a="http://schemas.openxmlformats.org/drawingml/2006/main">
             <a:r>
-              <a:t>Источник: Presentation-Razbor-Doopros.pdf, предоставленная пользователем презентация Skillaz × hh.ru. Возможности интеграции описаны в исходной презентации, работоспособность не проверена.</a:t>
+              <a:t>ПРОВЕРКА API, 16.10.2026. Источники: https://api.hh.ru/openapi/specification/public ; https://api.hh.ru/openapi/redoc#tag/Otklikipriglasheniya-rabotodatelya/operation/get-negotiation-item . В официальных примерах GET /negotiations/{id} и списка откликов есть ai_assistant.neuro_response и ai_assistant.neuro_invite. Реальный авторизованный запрос от Skillaz не выполнялся; доступность для конкретного клиента, полнота, гарантии и условия оплаты не подтверждены. Источник экранов: предоставленный Presentation-Razbor-Doopros.pdf.</a:t>
             </a:r>
           </a:p>
           <a:p xmlns:a="http://schemas.openxmlformats.org/drawingml/2006/main">
@@ -911,17 +861,7 @@
           </a:p>
           <a:p xmlns:a="http://schemas.openxmlformats.org/drawingml/2006/main">
             <a:r>
-              <a:t>НЕПОДТВЕРЖДЁННЫЕ ВОЗМОЖНОСТИ</a:t>
-            </a:r>
-          </a:p>
-          <a:p xmlns:a="http://schemas.openxmlformats.org/drawingml/2006/main">
-            <a:r>
-              <a:t>Проверить названия категорий, фильтр, счётчик и наличие цитат в текущей версии Skillaz. Экран взят из исходного PDF, слайд 6, и не является подтверждением реализации.</a:t>
-            </a:r>
-          </a:p>
-          <a:p xmlns:a="http://schemas.openxmlformats.org/drawingml/2006/main">
-            <a:r>
-              <a:t>Комментарий: категория задаёт приоритет просмотра, а не окончательное решение о найме.</a:t>
+              <a:t>Скриншот сохранён из исходного PDF, слайд 6, как иллюстрация, а не свидетельство проверенной интеграции. Проверить наличие фильтров, счётчиков, названия категорий и сопоставление decision со статусами Skillaz. Не интерпретировать ACCEPT из примера как полный перечень категорий.</a:t>
             </a:r>
           </a:p>
         </p:txBody>
@@ -991,7 +931,7 @@
           <a:lstStyle xmlns:a="http://schemas.openxmlformats.org/drawingml/2006/main"/>
           <a:p xmlns:a="http://schemas.openxmlformats.org/drawingml/2006/main">
             <a:r>
-              <a:t>Источник: Presentation-Razbor-Doopros.pdf, предоставленная пользователем презентация Skillaz × hh.ru. Возможности интеграции описаны в исходной презентации, работоспособность не проверена.</a:t>
+              <a:t>ПРОВЕРКА API, 16.10.2026. Источники: https://api.hh.ru/openapi/specification/public ; https://api.hh.ru/openapi/redoc#tag/Otklikipriglasheniya-rabotodatelya/operation/get-negotiation-item . В официальных примерах GET /negotiations/{id} и списка откликов есть ai_assistant.neuro_response и ai_assistant.neuro_invite. Реальный авторизованный запрос от Skillaz не выполнялся; доступность для конкретного клиента, полнота, гарантии и условия оплаты не подтверждены. Источник экранов: предоставленный Presentation-Razbor-Doopros.pdf.</a:t>
             </a:r>
           </a:p>
           <a:p xmlns:a="http://schemas.openxmlformats.org/drawingml/2006/main">
@@ -1001,22 +941,7 @@
           </a:p>
           <a:p xmlns:a="http://schemas.openxmlformats.org/drawingml/2006/main">
             <a:r>
-              <a:t>НЕПОДТВЕРЖДЁННЫЕ ВОЗМОЖНОСТИ</a:t>
-            </a:r>
-          </a:p>
-          <a:p xmlns:a="http://schemas.openxmlformats.org/drawingml/2006/main">
-            <a:r>
-              <a:t>Подтвердить список полей и формат записи, обработку неоднозначных ответов, доступ к исходному ответу. Показанный сценарий является иллюстрацией, не реальным диалогом. Если доступна только выжимка, заменить обещание заполнения поля на сохранение кратких итогов.</a:t>
-            </a:r>
-          </a:p>
-          <a:p xmlns:a="http://schemas.openxmlformats.org/drawingml/2006/main">
-            <a:r>
-              <a:t>Источник возможностей hh: https://feedback.hh.ru/knowledge-base/article/022833</a:t>
-            </a:r>
-          </a:p>
-          <a:p xmlns:a="http://schemas.openxmlformats.org/drawingml/2006/main">
-            <a:r>
-              <a:t>Исходная презентация: слайды 5, 12–13.</a:t>
+              <a:t>Диалог на слайде иллюстративный. Подтверждены question и quote в answers_to_questions_from_employer. Требуют проверки: запуск доопроса из Skillaz, настройка вопросов через API, автоматическое заполнение полей, типизация ответов, разбор неоднозначных ответов, обработка пропусков и повторных ответов.</a:t>
             </a:r>
           </a:p>
         </p:txBody>
@@ -1086,7 +1011,7 @@
           <a:lstStyle xmlns:a="http://schemas.openxmlformats.org/drawingml/2006/main"/>
           <a:p xmlns:a="http://schemas.openxmlformats.org/drawingml/2006/main">
             <a:r>
-              <a:t>Источник: Presentation-Razbor-Doopros.pdf, предоставленная пользователем презентация Skillaz × hh.ru. Возможности интеграции описаны в исходной презентации, работоспособность не проверена.</a:t>
+              <a:t>ПРОВЕРКА API, 16.10.2026. Источники: https://api.hh.ru/openapi/specification/public ; https://api.hh.ru/openapi/redoc#tag/Otklikipriglasheniya-rabotodatelya/operation/get-negotiation-item . В официальных примерах GET /negotiations/{id} и списка откликов есть ai_assistant.neuro_response и ai_assistant.neuro_invite. Реальный авторизованный запрос от Skillaz не выполнялся; доступность для конкретного клиента, полнота, гарантии и условия оплаты не подтверждены. Источник экранов: предоставленный Presentation-Razbor-Doopros.pdf.</a:t>
             </a:r>
           </a:p>
           <a:p xmlns:a="http://schemas.openxmlformats.org/drawingml/2006/main">
@@ -1096,17 +1021,7 @@
           </a:p>
           <a:p xmlns:a="http://schemas.openxmlformats.org/drawingml/2006/main">
             <a:r>
-              <a:t>НЕПОДТВЕРЖДЁННЫЕ ВОЗМОЖНОСТИ</a:t>
-            </a:r>
-          </a:p>
-          <a:p xmlns:a="http://schemas.openxmlformats.org/drawingml/2006/main">
-            <a:r>
-              <a:t>Журнал изменений, типы событий, права доступа и сохранение ручной категории требуют проверки. Схема справа — пример событий, не скриншот журнала. Если журнала нет в релизе, удалить правую колонку и оставить проверку оценки и ручную корректировку.</a:t>
-            </a:r>
-          </a:p>
-          <a:p xmlns:a="http://schemas.openxmlformats.org/drawingml/2006/main">
-            <a:r>
-              <a:t>Источник: исходная презентация, слайды 10–11.</a:t>
+              <a:t>Скриншот сохранён из исходного PDF, слайд 11. Подтверждены поля критериев is_met, explanation, source. Требуют проверки: ручная смена категории в Skillaz; синхронизация с hh; сохранение ручного решения после повторного анализа; журнал изменений, права и типы событий. Схема истории изменений удалена из основного содержания.</a:t>
             </a:r>
           </a:p>
         </p:txBody>
@@ -1176,7 +1091,7 @@
           <a:lstStyle xmlns:a="http://schemas.openxmlformats.org/drawingml/2006/main"/>
           <a:p xmlns:a="http://schemas.openxmlformats.org/drawingml/2006/main">
             <a:r>
-              <a:t>Источник: Presentation-Razbor-Doopros.pdf, предоставленная пользователем презентация Skillaz × hh.ru. Возможности интеграции описаны в исходной презентации, работоспособность не проверена.</a:t>
+              <a:t>ПРОВЕРКА API, 16.10.2026. Источники: https://api.hh.ru/openapi/specification/public ; https://api.hh.ru/openapi/redoc#tag/Otklikipriglasheniya-rabotodatelya/operation/get-negotiation-item . В официальных примерах GET /negotiations/{id} и списка откликов есть ai_assistant.neuro_response и ai_assistant.neuro_invite. Реальный авторизованный запрос от Skillaz не выполнялся; доступность для конкретного клиента, полнота, гарантии и условия оплаты не подтверждены. Источник экранов: предоставленный Presentation-Razbor-Doopros.pdf.</a:t>
             </a:r>
           </a:p>
           <a:p xmlns:a="http://schemas.openxmlformats.org/drawingml/2006/main">
@@ -1186,17 +1101,7 @@
           </a:p>
           <a:p xmlns:a="http://schemas.openxmlformats.org/drawingml/2006/main">
             <a:r>
-              <a:t>МЕТОДИКА ПИЛОТА</a:t>
-            </a:r>
-          </a:p>
-          <a:p xmlns:a="http://schemas.openxmlformats.org/drawingml/2006/main">
-            <a:r>
-              <a:t>Сравнивать ИИ-помощника непосредственно в hh.ru и те же возможности через Skillaz. Согласовать сопоставимые вакансии, нагрузку, период и способ замеров. Не приписывать интеграции общий эффект ИИ. Числа в таблице заполняются после пилота. Высвобождённые часы не равны автоматическому сокращению расходов.</a:t>
-            </a:r>
-          </a:p>
-          <a:p xmlns:a="http://schemas.openxmlformats.org/drawingml/2006/main">
-            <a:r>
-              <a:t>Дополнительно считать долю ручных исправлений.</a:t>
+              <a:t>Это план пилота, а не подтверждённый эффект. После технической проверки сравнить сопоставимые вакансии и нагрузку: работа с ИИ непосредственно в hh.ru и через Skillaz. Не приписывать интеграции общий эффект ИИ. Сэкономленные часы не равны гарантированному сокращению расходов.</a:t>
             </a:r>
           </a:p>
         </p:txBody>
@@ -1266,7 +1171,7 @@
           <a:lstStyle xmlns:a="http://schemas.openxmlformats.org/drawingml/2006/main"/>
           <a:p xmlns:a="http://schemas.openxmlformats.org/drawingml/2006/main">
             <a:r>
-              <a:t>Источник: Presentation-Razbor-Doopros.pdf, предоставленная пользователем презентация Skillaz × hh.ru. Возможности интеграции описаны в исходной презентации, работоспособность не проверена.</a:t>
+              <a:t>ПРОВЕРКА API, 16.10.2026. Источники: https://api.hh.ru/openapi/specification/public ; https://api.hh.ru/openapi/redoc#tag/Otklikipriglasheniya-rabotodatelya/operation/get-negotiation-item . В официальных примерах GET /negotiations/{id} и списка откликов есть ai_assistant.neuro_response и ai_assistant.neuro_invite. Реальный авторизованный запрос от Skillaz не выполнялся; доступность для конкретного клиента, полнота, гарантии и условия оплаты не подтверждены. Источник экранов: предоставленный Presentation-Razbor-Doopros.pdf.</a:t>
             </a:r>
           </a:p>
           <a:p xmlns:a="http://schemas.openxmlformats.org/drawingml/2006/main">
@@ -1276,22 +1181,7 @@
           </a:p>
           <a:p xmlns:a="http://schemas.openxmlformats.org/drawingml/2006/main">
             <a:r>
-              <a:t>НЕПОДТВЕРЖДЁННЫЕ УСЛОВИЯ ОПЛАТЫ</a:t>
-            </a:r>
-          </a:p>
-          <a:p xmlns:a="http://schemas.openxmlformats.org/drawingml/2006/main">
-            <a:r>
-              <a:t>Показана предлагаемая структура предложения, а не утверждённый тариф. До отправки клиенту подтвердить: входит ли использование ИИ hh в цену Skillaz, как учитывается уже оплаченный тариф hh, единицу тарификации, включённый объём, оплату Доопроса и превышений, состав внедрения и сопровождения, SLA. Сопровождение может входить в подписку. Цены исходной презентации не перенесены, поскольку модель оплаты не подтверждена.</a:t>
-            </a:r>
-          </a:p>
-          <a:p xmlns:a="http://schemas.openxmlformats.org/drawingml/2006/main">
-            <a:r>
-              <a:t>Контекст hh на 16.10.2026: https://feedback.hh.ru/knowledge-base/article/001622374</a:t>
-            </a:r>
-          </a:p>
-          <a:p xmlns:a="http://schemas.openxmlformats.org/drawingml/2006/main">
-            <a:r>
-              <a:t>ИИ-помощник входит в некоторые тарифы hh при соблюдении условий. Нельзя обещать отсутствие двойной оплаты без договорного подтверждения.</a:t>
+              <a:t>НЕПОДТВЕРЖДЁННЫЕ УСЛОВИЯ ОПЛАТЫ: стоимость доступа к ИИ и API hh, входит ли она в тариф Skillaz, учёт уже оплаченных услуг hh, единица тарификации, лимиты, превышения, оплата доопроса, внедрение, сопровождение, SLA. Разделение на внедрение/использование/сопровождение было гипотезой предложения, не утверждённым тарифом. Условия оплаты не вынесены на слайд.</a:t>
             </a:r>
           </a:p>
         </p:txBody>
@@ -1338,7 +1228,7 @@
           <p:cNvPr id="3" name="Title">
             <a:extLst xmlns:a="http://schemas.openxmlformats.org/drawingml/2006/main">
               <a:ext uri="{FF2B5EF4-FFF2-40B4-BE49-F238E27FC236}">
-                <a16:creationId xmlns:a16="http://schemas.microsoft.com/office/drawing/2014/main" id="{6919AF77-D511-49EC-BF20-1001C7B16349}"/>
+                <a16:creationId xmlns:a16="http://schemas.microsoft.com/office/drawing/2014/main" id="{0C3792D1-71BB-495F-ACCB-1489563BA02B}"/>
               </a:ext>
             </a:extLst>
           </p:cNvPr>
@@ -1495,7 +1385,7 @@
           <p:cNvPr id="2" name="Subtitle">
             <a:extLst xmlns:a="http://schemas.openxmlformats.org/drawingml/2006/main">
               <a:ext uri="{FF2B5EF4-FFF2-40B4-BE49-F238E27FC236}">
-                <a16:creationId xmlns:a16="http://schemas.microsoft.com/office/drawing/2014/main" id="{7D70D8FF-A6C8-451E-A897-D7E2E93E5211}"/>
+                <a16:creationId xmlns:a16="http://schemas.microsoft.com/office/drawing/2014/main" id="{9A760E3B-5755-4D4B-86E9-F8B36CB710B0}"/>
               </a:ext>
             </a:extLst>
           </p:cNvPr>
@@ -1669,7 +1559,7 @@
           <p:cNvPr id="2" name="Section title">
             <a:extLst xmlns:a="http://schemas.openxmlformats.org/drawingml/2006/main">
               <a:ext uri="{FF2B5EF4-FFF2-40B4-BE49-F238E27FC236}">
-                <a16:creationId xmlns:a16="http://schemas.microsoft.com/office/drawing/2014/main" id="{C483225B-674C-4669-9BAA-5F4C7759D45F}"/>
+                <a16:creationId xmlns:a16="http://schemas.microsoft.com/office/drawing/2014/main" id="{FE4EF8BB-1AEE-426D-BB43-5AB271BD7120}"/>
               </a:ext>
             </a:extLst>
           </p:cNvPr>
@@ -1843,7 +1733,7 @@
           <p:cNvPr id="3" name="Title">
             <a:extLst xmlns:a="http://schemas.openxmlformats.org/drawingml/2006/main">
               <a:ext uri="{FF2B5EF4-FFF2-40B4-BE49-F238E27FC236}">
-                <a16:creationId xmlns:a16="http://schemas.microsoft.com/office/drawing/2014/main" id="{14949310-DCAE-436A-B4B4-44EB70CEB474}"/>
+                <a16:creationId xmlns:a16="http://schemas.microsoft.com/office/drawing/2014/main" id="{AE0FAF67-0D0C-4509-9381-7E9E782FCBEB}"/>
               </a:ext>
             </a:extLst>
           </p:cNvPr>
@@ -2000,7 +1890,7 @@
           <p:cNvPr id="2" name="Body">
             <a:extLst xmlns:a="http://schemas.openxmlformats.org/drawingml/2006/main">
               <a:ext uri="{FF2B5EF4-FFF2-40B4-BE49-F238E27FC236}">
-                <a16:creationId xmlns:a16="http://schemas.microsoft.com/office/drawing/2014/main" id="{23523668-00EF-4F46-BA22-F2B993EBFF05}"/>
+                <a16:creationId xmlns:a16="http://schemas.microsoft.com/office/drawing/2014/main" id="{BB7EA8C2-D827-4D30-96C2-BC00D87FF53A}"/>
               </a:ext>
             </a:extLst>
           </p:cNvPr>
@@ -2174,7 +2064,7 @@
           <p:cNvPr id="4" name="Title">
             <a:extLst xmlns:a="http://schemas.openxmlformats.org/drawingml/2006/main">
               <a:ext uri="{FF2B5EF4-FFF2-40B4-BE49-F238E27FC236}">
-                <a16:creationId xmlns:a16="http://schemas.microsoft.com/office/drawing/2014/main" id="{4A848E67-A1E3-4833-A1C2-0773B9960A38}"/>
+                <a16:creationId xmlns:a16="http://schemas.microsoft.com/office/drawing/2014/main" id="{6B41E622-2BB8-4CC1-BA78-1C848A32F5AF}"/>
               </a:ext>
             </a:extLst>
           </p:cNvPr>
@@ -2331,7 +2221,7 @@
           <p:cNvPr id="2" name="Left column">
             <a:extLst xmlns:a="http://schemas.openxmlformats.org/drawingml/2006/main">
               <a:ext uri="{FF2B5EF4-FFF2-40B4-BE49-F238E27FC236}">
-                <a16:creationId xmlns:a16="http://schemas.microsoft.com/office/drawing/2014/main" id="{6E76E690-3F44-4854-A35F-0F2D8F462F2D}"/>
+                <a16:creationId xmlns:a16="http://schemas.microsoft.com/office/drawing/2014/main" id="{6C31319B-7A21-4F0B-8D15-B8FA8259D9E7}"/>
               </a:ext>
             </a:extLst>
           </p:cNvPr>
@@ -2488,7 +2378,7 @@
           <p:cNvPr id="3" name="Right column">
             <a:extLst xmlns:a="http://schemas.openxmlformats.org/drawingml/2006/main">
               <a:ext uri="{FF2B5EF4-FFF2-40B4-BE49-F238E27FC236}">
-                <a16:creationId xmlns:a16="http://schemas.microsoft.com/office/drawing/2014/main" id="{FEB929FE-AF87-4513-85D5-6C9918D309D2}"/>
+                <a16:creationId xmlns:a16="http://schemas.microsoft.com/office/drawing/2014/main" id="{4E3BD7D9-4764-4FAD-B358-99E98A093346}"/>
               </a:ext>
             </a:extLst>
           </p:cNvPr>
@@ -2662,7 +2552,7 @@
           <p:cNvPr id="3" name="Title">
             <a:extLst xmlns:a="http://schemas.openxmlformats.org/drawingml/2006/main">
               <a:ext uri="{FF2B5EF4-FFF2-40B4-BE49-F238E27FC236}">
-                <a16:creationId xmlns:a16="http://schemas.microsoft.com/office/drawing/2014/main" id="{A04E3675-3064-4D9B-A639-9541D33316A2}"/>
+                <a16:creationId xmlns:a16="http://schemas.microsoft.com/office/drawing/2014/main" id="{89E1C9B9-7847-4619-91AF-4687D064D034}"/>
               </a:ext>
             </a:extLst>
           </p:cNvPr>
@@ -2819,7 +2709,7 @@
           <p:cNvPr id="2" name="Left column">
             <a:extLst xmlns:a="http://schemas.openxmlformats.org/drawingml/2006/main">
               <a:ext uri="{FF2B5EF4-FFF2-40B4-BE49-F238E27FC236}">
-                <a16:creationId xmlns:a16="http://schemas.microsoft.com/office/drawing/2014/main" id="{1E27A717-B127-46FB-BA94-32EB64108460}"/>
+                <a16:creationId xmlns:a16="http://schemas.microsoft.com/office/drawing/2014/main" id="{158E8202-CB85-4B64-9E24-6A9711CC6D13}"/>
               </a:ext>
             </a:extLst>
           </p:cNvPr>
@@ -3014,12 +2904,12 @@
   </p:cSld>
   <p:clrMap bg1="lt1" tx1="dk1" bg2="lt2" tx2="dk2" accent1="accent1" accent2="accent2" accent3="accent3" accent4="accent4" accent5="accent5" accent6="accent6" hlink="hlink" folHlink="folHlink"/>
   <p:sldLayoutIdLst>
-    <p:sldLayoutId xmlns:r="http://schemas.openxmlformats.org/officeDocument/2006/relationships" id="2147483649" r:id="R14dd0df2b3004263"/>
-    <p:sldLayoutId xmlns:r="http://schemas.openxmlformats.org/officeDocument/2006/relationships" id="2147483650" r:id="R2f456d507a4441b4"/>
-    <p:sldLayoutId xmlns:r="http://schemas.openxmlformats.org/officeDocument/2006/relationships" id="2147483651" r:id="R34061a04112848e9"/>
-    <p:sldLayoutId xmlns:r="http://schemas.openxmlformats.org/officeDocument/2006/relationships" id="2147483652" r:id="Rc221547fcefd40ab"/>
-    <p:sldLayoutId xmlns:r="http://schemas.openxmlformats.org/officeDocument/2006/relationships" id="2147483653" r:id="R3c67878045d94dba"/>
-    <p:sldLayoutId xmlns:r="http://schemas.openxmlformats.org/officeDocument/2006/relationships" id="2147483654" r:id="Re4984de8fedc447a"/>
+    <p:sldLayoutId xmlns:r="http://schemas.openxmlformats.org/officeDocument/2006/relationships" id="2147483649" r:id="Ra3360ede91714130"/>
+    <p:sldLayoutId xmlns:r="http://schemas.openxmlformats.org/officeDocument/2006/relationships" id="2147483650" r:id="R6f7dc655eaa04427"/>
+    <p:sldLayoutId xmlns:r="http://schemas.openxmlformats.org/officeDocument/2006/relationships" id="2147483651" r:id="R9cebfb75f3a94d31"/>
+    <p:sldLayoutId xmlns:r="http://schemas.openxmlformats.org/officeDocument/2006/relationships" id="2147483652" r:id="R7cc6affc99c04715"/>
+    <p:sldLayoutId xmlns:r="http://schemas.openxmlformats.org/officeDocument/2006/relationships" id="2147483653" r:id="R99407181344d46a3"/>
+    <p:sldLayoutId xmlns:r="http://schemas.openxmlformats.org/officeDocument/2006/relationships" id="2147483654" r:id="R783fda3549694cd4"/>
   </p:sldLayoutIdLst>
   <p:txStyles>
     <p:titleStyle>
@@ -3570,7 +3460,7 @@
           <p:cNvPr id="11" name="">
             <a:extLst xmlns:a="http://schemas.openxmlformats.org/drawingml/2006/main">
               <a:ext uri="{FF2B5EF4-FFF2-40B4-BE49-F238E27FC236}">
-                <a16:creationId xmlns:a16="http://schemas.microsoft.com/office/drawing/2014/main" id="{07495B6F-BDDA-4309-8CF0-DC3A056EDC8A}"/>
+                <a16:creationId xmlns:a16="http://schemas.microsoft.com/office/drawing/2014/main" id="{5C5A12FB-FCD2-47A9-831B-28F9BB344CF7}"/>
               </a:ext>
             </a:extLst>
           </p:cNvPr>
@@ -3580,7 +3470,7 @@
           <p:nvPr/>
         </p:nvPicPr>
         <p:blipFill>
-          <a:blip xmlns:r="http://schemas.openxmlformats.org/officeDocument/2006/relationships" xmlns:a="http://schemas.openxmlformats.org/drawingml/2006/main" r:embed="R7bff0f74633d4e6a"/>
+          <a:blip xmlns:r="http://schemas.openxmlformats.org/officeDocument/2006/relationships" xmlns:a="http://schemas.openxmlformats.org/drawingml/2006/main" r:embed="Rf75e69d75f014172"/>
           <a:stretch xmlns:a="http://schemas.openxmlformats.org/drawingml/2006/main"/>
         </p:blipFill>
         <p:spPr>
@@ -3598,7 +3488,7 @@
           <p:cNvPr id="2" name="">
             <a:extLst xmlns:a="http://schemas.openxmlformats.org/drawingml/2006/main">
               <a:ext uri="{FF2B5EF4-FFF2-40B4-BE49-F238E27FC236}">
-                <a16:creationId xmlns:a16="http://schemas.microsoft.com/office/drawing/2014/main" id="{B8E5D352-939D-45A6-A62C-086D52665664}"/>
+                <a16:creationId xmlns:a16="http://schemas.microsoft.com/office/drawing/2014/main" id="{C8309E26-A284-41F2-BBE7-9880D781AC71}"/>
               </a:ext>
             </a:extLst>
           </p:cNvPr>
@@ -3656,7 +3546,7 @@
                 <a:ea typeface="Courier New"/>
                 <a:cs typeface="Courier New"/>
               </a:rPr>
-              <a:t>ИНТЕГРАЦИЯ ДЛЯ КОМАНД ПОДБОРА</a:t>
+              <a:t>ДАННЫЕ ДЛЯ ИНТЕГРАЦИИ</a:t>
             </a:r>
           </a:p>
         </p:txBody>
@@ -3666,7 +3556,7 @@
           <p:cNvPr id="3" name="">
             <a:extLst xmlns:a="http://schemas.openxmlformats.org/drawingml/2006/main">
               <a:ext uri="{FF2B5EF4-FFF2-40B4-BE49-F238E27FC236}">
-                <a16:creationId xmlns:a16="http://schemas.microsoft.com/office/drawing/2014/main" id="{7B076E53-EC62-4CE8-BD77-EBB68A573E00}"/>
+                <a16:creationId xmlns:a16="http://schemas.microsoft.com/office/drawing/2014/main" id="{BE3393D1-853D-4B2A-AB2B-A47D9FBC9DCF}"/>
               </a:ext>
             </a:extLst>
           </p:cNvPr>
@@ -3734,7 +3624,7 @@
           <p:cNvPr id="4" name="">
             <a:extLst xmlns:a="http://schemas.openxmlformats.org/drawingml/2006/main">
               <a:ext uri="{FF2B5EF4-FFF2-40B4-BE49-F238E27FC236}">
-                <a16:creationId xmlns:a16="http://schemas.microsoft.com/office/drawing/2014/main" id="{3EE62F9C-6420-473E-BFF8-63525CEED9BF}"/>
+                <a16:creationId xmlns:a16="http://schemas.microsoft.com/office/drawing/2014/main" id="{9DBF8EC0-3AC2-43C5-A328-F4EE7DE153A5}"/>
               </a:ext>
             </a:extLst>
           </p:cNvPr>
@@ -3802,7 +3692,7 @@
           <p:cNvPr id="5" name="">
             <a:extLst xmlns:a="http://schemas.openxmlformats.org/drawingml/2006/main">
               <a:ext uri="{FF2B5EF4-FFF2-40B4-BE49-F238E27FC236}">
-                <a16:creationId xmlns:a16="http://schemas.microsoft.com/office/drawing/2014/main" id="{7A242A25-FC23-4484-8416-57806DE0823D}"/>
+                <a16:creationId xmlns:a16="http://schemas.microsoft.com/office/drawing/2014/main" id="{29AADA15-05BD-492A-9481-E4353D2DF22E}"/>
               </a:ext>
             </a:extLst>
           </p:cNvPr>
@@ -3870,7 +3760,7 @@
           <p:cNvPr id="6" name="">
             <a:extLst xmlns:a="http://schemas.openxmlformats.org/drawingml/2006/main">
               <a:ext uri="{FF2B5EF4-FFF2-40B4-BE49-F238E27FC236}">
-                <a16:creationId xmlns:a16="http://schemas.microsoft.com/office/drawing/2014/main" id="{F3CB2139-90BA-4AB4-A70A-1A0B60A5BF64}"/>
+                <a16:creationId xmlns:a16="http://schemas.microsoft.com/office/drawing/2014/main" id="{5CD3D56D-80FB-41D0-8C40-B0ABA24C987F}"/>
               </a:ext>
             </a:extLst>
           </p:cNvPr>
@@ -3900,7 +3790,7 @@
           <p:cNvPr id="7" name="">
             <a:extLst xmlns:a="http://schemas.openxmlformats.org/drawingml/2006/main">
               <a:ext uri="{FF2B5EF4-FFF2-40B4-BE49-F238E27FC236}">
-                <a16:creationId xmlns:a16="http://schemas.microsoft.com/office/drawing/2014/main" id="{83C955E9-84EB-474A-9E27-3ABC698BA96C}"/>
+                <a16:creationId xmlns:a16="http://schemas.microsoft.com/office/drawing/2014/main" id="{C760562A-62B9-4CAE-A2BD-3C649F1FE10B}"/>
               </a:ext>
             </a:extLst>
           </p:cNvPr>
@@ -3958,7 +3848,7 @@
                 <a:ea typeface="Arial"/>
                 <a:cs typeface="Arial"/>
               </a:rPr>
-              <a:t>ИИ-помощник hh.ru</a:t>
+              <a:t>ИИ-разбор hh.ru</a:t>
             </a:r>
           </a:p>
           <a:p xmlns:a="http://schemas.openxmlformats.org/drawingml/2006/main">
@@ -3981,7 +3871,7 @@
                 <a:ea typeface="Arial"/>
                 <a:cs typeface="Arial"/>
               </a:rPr>
-              <a:t>в Skillaz</a:t>
+              <a:t>и данные для Skillaz</a:t>
             </a:r>
           </a:p>
         </p:txBody>
@@ -3991,7 +3881,7 @@
           <p:cNvPr id="8" name="">
             <a:extLst xmlns:a="http://schemas.openxmlformats.org/drawingml/2006/main">
               <a:ext uri="{FF2B5EF4-FFF2-40B4-BE49-F238E27FC236}">
-                <a16:creationId xmlns:a16="http://schemas.microsoft.com/office/drawing/2014/main" id="{08ED65E3-A831-48A9-9522-A4C8301112F0}"/>
+                <a16:creationId xmlns:a16="http://schemas.microsoft.com/office/drawing/2014/main" id="{73085196-6DB4-4EF6-ACE5-307862CBE6F5}"/>
               </a:ext>
             </a:extLst>
           </p:cNvPr>
@@ -4049,7 +3939,7 @@
                 <a:ea typeface="Arial"/>
                 <a:cs typeface="Arial"/>
               </a:rPr>
-              <a:t>Разбор откликов и ответы кандидатов</a:t>
+              <a:t>Результаты разбора и ответы кандидатов</a:t>
             </a:r>
           </a:p>
           <a:p xmlns:a="http://schemas.openxmlformats.org/drawingml/2006/main">
@@ -4072,7 +3962,7 @@
                 <a:ea typeface="Arial"/>
                 <a:cs typeface="Arial"/>
               </a:rPr>
-              <a:t>в вашей воронке подбора</a:t>
+              <a:t>в публичной документации API hh.ru</a:t>
             </a:r>
           </a:p>
         </p:txBody>
@@ -4082,7 +3972,7 @@
           <p:cNvPr id="9" name="">
             <a:extLst xmlns:a="http://schemas.openxmlformats.org/drawingml/2006/main">
               <a:ext uri="{FF2B5EF4-FFF2-40B4-BE49-F238E27FC236}">
-                <a16:creationId xmlns:a16="http://schemas.microsoft.com/office/drawing/2014/main" id="{6AC53A38-E9BB-47C1-8D58-51531A7E23F0}"/>
+                <a16:creationId xmlns:a16="http://schemas.microsoft.com/office/drawing/2014/main" id="{4C38CBB7-9517-4ED1-A262-CEF8A55EFD86}"/>
               </a:ext>
             </a:extLst>
           </p:cNvPr>
@@ -4150,7 +4040,7 @@
           <p:cNvPr id="10" name="">
             <a:extLst xmlns:a="http://schemas.openxmlformats.org/drawingml/2006/main">
               <a:ext uri="{FF2B5EF4-FFF2-40B4-BE49-F238E27FC236}">
-                <a16:creationId xmlns:a16="http://schemas.microsoft.com/office/drawing/2014/main" id="{A77E738D-F981-4D35-B809-84CB1C0EC8A6}"/>
+                <a16:creationId xmlns:a16="http://schemas.microsoft.com/office/drawing/2014/main" id="{CF181324-708B-4C25-92C9-7DE7FB9B9BED}"/>
               </a:ext>
             </a:extLst>
           </p:cNvPr>
@@ -4239,7 +4129,7 @@
     </p:spTree>
     <p:extLst>
       <p:ext uri="{BB962C8B-B14F-4D97-AF65-F5344CB8AC3E}">
-        <p14:creationId xmlns:p14="http://schemas.microsoft.com/office/powerpoint/2010/main" val="1886423884"/>
+        <p14:creationId xmlns:p14="http://schemas.microsoft.com/office/powerpoint/2010/main" val="2032271722"/>
       </p:ext>
     </p:extLst>
   </p:cSld>
@@ -4270,7 +4160,7 @@
           <p:cNvPr id="21" name="">
             <a:extLst xmlns:a="http://schemas.openxmlformats.org/drawingml/2006/main">
               <a:ext uri="{FF2B5EF4-FFF2-40B4-BE49-F238E27FC236}">
-                <a16:creationId xmlns:a16="http://schemas.microsoft.com/office/drawing/2014/main" id="{CB3EAB90-704D-4B1F-89E8-FC3F4DD5ADC2}"/>
+                <a16:creationId xmlns:a16="http://schemas.microsoft.com/office/drawing/2014/main" id="{48D92C47-6A89-48F6-833F-48C2338DD1BB}"/>
               </a:ext>
             </a:extLst>
           </p:cNvPr>
@@ -4280,7 +4170,7 @@
           <p:nvPr/>
         </p:nvPicPr>
         <p:blipFill>
-          <a:blip xmlns:r="http://schemas.openxmlformats.org/officeDocument/2006/relationships" xmlns:a="http://schemas.openxmlformats.org/drawingml/2006/main" r:embed="R8dc13fb9147742af"/>
+          <a:blip xmlns:r="http://schemas.openxmlformats.org/officeDocument/2006/relationships" xmlns:a="http://schemas.openxmlformats.org/drawingml/2006/main" r:embed="R9796431a3f894f28"/>
           <a:stretch xmlns:a="http://schemas.openxmlformats.org/drawingml/2006/main"/>
         </p:blipFill>
         <p:spPr>
@@ -4298,7 +4188,7 @@
           <p:cNvPr id="2" name="">
             <a:extLst xmlns:a="http://schemas.openxmlformats.org/drawingml/2006/main">
               <a:ext uri="{FF2B5EF4-FFF2-40B4-BE49-F238E27FC236}">
-                <a16:creationId xmlns:a16="http://schemas.microsoft.com/office/drawing/2014/main" id="{B1209695-872B-4A05-90C1-82667159E55E}"/>
+                <a16:creationId xmlns:a16="http://schemas.microsoft.com/office/drawing/2014/main" id="{14B6C61A-958B-4AE1-BA68-2D44F4105FF9}"/>
               </a:ext>
             </a:extLst>
           </p:cNvPr>
@@ -4366,7 +4256,7 @@
           <p:cNvPr id="3" name="">
             <a:extLst xmlns:a="http://schemas.openxmlformats.org/drawingml/2006/main">
               <a:ext uri="{FF2B5EF4-FFF2-40B4-BE49-F238E27FC236}">
-                <a16:creationId xmlns:a16="http://schemas.microsoft.com/office/drawing/2014/main" id="{5FE236D0-B42E-4761-B639-7FD231F4F82B}"/>
+                <a16:creationId xmlns:a16="http://schemas.microsoft.com/office/drawing/2014/main" id="{96F91C62-3109-4500-910A-914D486B1280}"/>
               </a:ext>
             </a:extLst>
           </p:cNvPr>
@@ -4434,7 +4324,7 @@
           <p:cNvPr id="4" name="">
             <a:extLst xmlns:a="http://schemas.openxmlformats.org/drawingml/2006/main">
               <a:ext uri="{FF2B5EF4-FFF2-40B4-BE49-F238E27FC236}">
-                <a16:creationId xmlns:a16="http://schemas.microsoft.com/office/drawing/2014/main" id="{8283BA07-F3AA-4152-9B4B-61FF48037A69}"/>
+                <a16:creationId xmlns:a16="http://schemas.microsoft.com/office/drawing/2014/main" id="{C1C6A9FE-924E-4181-9C09-CBA571F465A6}"/>
               </a:ext>
             </a:extLst>
           </p:cNvPr>
@@ -4502,7 +4392,7 @@
           <p:cNvPr id="5" name="">
             <a:extLst xmlns:a="http://schemas.openxmlformats.org/drawingml/2006/main">
               <a:ext uri="{FF2B5EF4-FFF2-40B4-BE49-F238E27FC236}">
-                <a16:creationId xmlns:a16="http://schemas.microsoft.com/office/drawing/2014/main" id="{A733F7F5-EC7A-49C8-A467-50E0BB85292C}"/>
+                <a16:creationId xmlns:a16="http://schemas.microsoft.com/office/drawing/2014/main" id="{138A445C-A8CB-460E-B028-5C93C4DF766A}"/>
               </a:ext>
             </a:extLst>
           </p:cNvPr>
@@ -4570,7 +4460,7 @@
           <p:cNvPr id="6" name="">
             <a:extLst xmlns:a="http://schemas.openxmlformats.org/drawingml/2006/main">
               <a:ext uri="{FF2B5EF4-FFF2-40B4-BE49-F238E27FC236}">
-                <a16:creationId xmlns:a16="http://schemas.microsoft.com/office/drawing/2014/main" id="{94543BD4-25EF-4184-867B-2FDFA757AB25}"/>
+                <a16:creationId xmlns:a16="http://schemas.microsoft.com/office/drawing/2014/main" id="{832EF101-D76F-4C9D-ABBA-4F3D5FF5046A}"/>
               </a:ext>
             </a:extLst>
           </p:cNvPr>
@@ -4600,7 +4490,7 @@
           <p:cNvPr id="7" name="">
             <a:extLst xmlns:a="http://schemas.openxmlformats.org/drawingml/2006/main">
               <a:ext uri="{FF2B5EF4-FFF2-40B4-BE49-F238E27FC236}">
-                <a16:creationId xmlns:a16="http://schemas.microsoft.com/office/drawing/2014/main" id="{4B8CE665-55F7-42FD-9AD5-5C671D4C7F82}"/>
+                <a16:creationId xmlns:a16="http://schemas.microsoft.com/office/drawing/2014/main" id="{038861D7-E52E-42C8-B440-A00AFD358FF6}"/>
               </a:ext>
             </a:extLst>
           </p:cNvPr>
@@ -4658,7 +4548,7 @@
                 <a:ea typeface="Arial"/>
                 <a:cs typeface="Arial"/>
               </a:rPr>
-              <a:t>Одна команда. Измеримый результат.</a:t>
+              <a:t>Пилот интеграции со Skillaz</a:t>
             </a:r>
           </a:p>
         </p:txBody>
@@ -4668,7 +4558,7 @@
           <p:cNvPr id="8" name="">
             <a:extLst xmlns:a="http://schemas.openxmlformats.org/drawingml/2006/main">
               <a:ext uri="{FF2B5EF4-FFF2-40B4-BE49-F238E27FC236}">
-                <a16:creationId xmlns:a16="http://schemas.microsoft.com/office/drawing/2014/main" id="{C54AA64F-34A2-4B36-8268-38FB30D62C6D}"/>
+                <a16:creationId xmlns:a16="http://schemas.microsoft.com/office/drawing/2014/main" id="{7E1DFCBB-B7B6-4899-BC0A-A5FB55F643DE}"/>
               </a:ext>
             </a:extLst>
           </p:cNvPr>
@@ -4736,7 +4626,7 @@
           <p:cNvPr id="9" name="">
             <a:extLst xmlns:a="http://schemas.openxmlformats.org/drawingml/2006/main">
               <a:ext uri="{FF2B5EF4-FFF2-40B4-BE49-F238E27FC236}">
-                <a16:creationId xmlns:a16="http://schemas.microsoft.com/office/drawing/2014/main" id="{FBA72C8E-4E4A-4711-BF14-94C344B5F01C}"/>
+                <a16:creationId xmlns:a16="http://schemas.microsoft.com/office/drawing/2014/main" id="{B8785707-F9EF-44B3-A833-16D11F1CA997}"/>
               </a:ext>
             </a:extLst>
           </p:cNvPr>
@@ -4804,7 +4694,7 @@
           <p:cNvPr id="10" name="">
             <a:extLst xmlns:a="http://schemas.openxmlformats.org/drawingml/2006/main">
               <a:ext uri="{FF2B5EF4-FFF2-40B4-BE49-F238E27FC236}">
-                <a16:creationId xmlns:a16="http://schemas.microsoft.com/office/drawing/2014/main" id="{E40A4A02-A007-4C4D-9F08-7EE553D911CF}"/>
+                <a16:creationId xmlns:a16="http://schemas.microsoft.com/office/drawing/2014/main" id="{8D066444-230E-4D69-B963-622581587BF1}"/>
               </a:ext>
             </a:extLst>
           </p:cNvPr>
@@ -4872,7 +4762,7 @@
           <p:cNvPr id="11" name="">
             <a:extLst xmlns:a="http://schemas.openxmlformats.org/drawingml/2006/main">
               <a:ext uri="{FF2B5EF4-FFF2-40B4-BE49-F238E27FC236}">
-                <a16:creationId xmlns:a16="http://schemas.microsoft.com/office/drawing/2014/main" id="{08C89849-4026-48A5-B87D-0183BB4413EC}"/>
+                <a16:creationId xmlns:a16="http://schemas.microsoft.com/office/drawing/2014/main" id="{DFFE5E12-9DA9-47C4-A6AC-4AF55A1E41A3}"/>
               </a:ext>
             </a:extLst>
           </p:cNvPr>
@@ -4940,7 +4830,7 @@
           <p:cNvPr id="12" name="">
             <a:extLst xmlns:a="http://schemas.openxmlformats.org/drawingml/2006/main">
               <a:ext uri="{FF2B5EF4-FFF2-40B4-BE49-F238E27FC236}">
-                <a16:creationId xmlns:a16="http://schemas.microsoft.com/office/drawing/2014/main" id="{314D7D75-19F6-4DD6-8991-5778CD6FB19E}"/>
+                <a16:creationId xmlns:a16="http://schemas.microsoft.com/office/drawing/2014/main" id="{A3E1628E-4B39-42B9-ADD4-EB9F225CD5B9}"/>
               </a:ext>
             </a:extLst>
           </p:cNvPr>
@@ -5008,7 +4898,7 @@
           <p:cNvPr id="13" name="">
             <a:extLst xmlns:a="http://schemas.openxmlformats.org/drawingml/2006/main">
               <a:ext uri="{FF2B5EF4-FFF2-40B4-BE49-F238E27FC236}">
-                <a16:creationId xmlns:a16="http://schemas.microsoft.com/office/drawing/2014/main" id="{89AFA675-52F0-48D0-A20A-843E6EE86119}"/>
+                <a16:creationId xmlns:a16="http://schemas.microsoft.com/office/drawing/2014/main" id="{25678793-9CEE-494F-A130-DEE188316827}"/>
               </a:ext>
             </a:extLst>
           </p:cNvPr>
@@ -5066,7 +4956,7 @@
                 <a:ea typeface="Arial"/>
                 <a:cs typeface="Arial"/>
               </a:rPr>
-              <a:t>Критерии, поля карточки и проверка обмена</a:t>
+              <a:t>Тестовый отклик и проверка получения данных</a:t>
             </a:r>
           </a:p>
         </p:txBody>
@@ -5076,7 +4966,7 @@
           <p:cNvPr id="14" name="">
             <a:extLst xmlns:a="http://schemas.openxmlformats.org/drawingml/2006/main">
               <a:ext uri="{FF2B5EF4-FFF2-40B4-BE49-F238E27FC236}">
-                <a16:creationId xmlns:a16="http://schemas.microsoft.com/office/drawing/2014/main" id="{B33165A0-CDAC-412F-93DA-583C2F638FB8}"/>
+                <a16:creationId xmlns:a16="http://schemas.microsoft.com/office/drawing/2014/main" id="{8384F246-653A-4F2F-A845-584105E74EBD}"/>
               </a:ext>
             </a:extLst>
           </p:cNvPr>
@@ -5144,7 +5034,7 @@
           <p:cNvPr id="15" name="">
             <a:extLst xmlns:a="http://schemas.openxmlformats.org/drawingml/2006/main">
               <a:ext uri="{FF2B5EF4-FFF2-40B4-BE49-F238E27FC236}">
-                <a16:creationId xmlns:a16="http://schemas.microsoft.com/office/drawing/2014/main" id="{7B6F2558-290B-4B96-83C5-EB700DEBE743}"/>
+                <a16:creationId xmlns:a16="http://schemas.microsoft.com/office/drawing/2014/main" id="{FC777212-140F-4DAE-8476-1E3D50A07947}"/>
               </a:ext>
             </a:extLst>
           </p:cNvPr>
@@ -5212,7 +5102,7 @@
           <p:cNvPr id="16" name="">
             <a:extLst xmlns:a="http://schemas.openxmlformats.org/drawingml/2006/main">
               <a:ext uri="{FF2B5EF4-FFF2-40B4-BE49-F238E27FC236}">
-                <a16:creationId xmlns:a16="http://schemas.microsoft.com/office/drawing/2014/main" id="{D9ED8D18-F3BC-4F9B-98EA-0C9C70F39280}"/>
+                <a16:creationId xmlns:a16="http://schemas.microsoft.com/office/drawing/2014/main" id="{EF2FF0EF-1E4B-47AE-BFFD-A860B74CDCF8}"/>
               </a:ext>
             </a:extLst>
           </p:cNvPr>
@@ -5280,7 +5170,7 @@
           <p:cNvPr id="17" name="">
             <a:extLst xmlns:a="http://schemas.openxmlformats.org/drawingml/2006/main">
               <a:ext uri="{FF2B5EF4-FFF2-40B4-BE49-F238E27FC236}">
-                <a16:creationId xmlns:a16="http://schemas.microsoft.com/office/drawing/2014/main" id="{243E9BF1-3980-4169-9B1F-DE9118912D50}"/>
+                <a16:creationId xmlns:a16="http://schemas.microsoft.com/office/drawing/2014/main" id="{5F1201B8-D20B-4D16-A6CB-3D1B74D4C20A}"/>
               </a:ext>
             </a:extLst>
           </p:cNvPr>
@@ -5348,7 +5238,7 @@
           <p:cNvPr id="18" name="">
             <a:extLst xmlns:a="http://schemas.openxmlformats.org/drawingml/2006/main">
               <a:ext uri="{FF2B5EF4-FFF2-40B4-BE49-F238E27FC236}">
-                <a16:creationId xmlns:a16="http://schemas.microsoft.com/office/drawing/2014/main" id="{B107AED6-751A-4995-9838-DF7D8D6F4078}"/>
+                <a16:creationId xmlns:a16="http://schemas.microsoft.com/office/drawing/2014/main" id="{C32EA530-5379-4A2E-BCB4-87C3BD057387}"/>
               </a:ext>
             </a:extLst>
           </p:cNvPr>
@@ -5416,7 +5306,7 @@
           <p:cNvPr id="19" name="">
             <a:extLst xmlns:a="http://schemas.openxmlformats.org/drawingml/2006/main">
               <a:ext uri="{FF2B5EF4-FFF2-40B4-BE49-F238E27FC236}">
-                <a16:creationId xmlns:a16="http://schemas.microsoft.com/office/drawing/2014/main" id="{DACF39CE-2B69-4886-BC5C-E1AAB75A7182}"/>
+                <a16:creationId xmlns:a16="http://schemas.microsoft.com/office/drawing/2014/main" id="{E619D480-92F4-4506-BDE9-EBD63023EB92}"/>
               </a:ext>
             </a:extLst>
           </p:cNvPr>
@@ -5484,7 +5374,7 @@
           <p:cNvPr id="20" name="">
             <a:extLst xmlns:a="http://schemas.openxmlformats.org/drawingml/2006/main">
               <a:ext uri="{FF2B5EF4-FFF2-40B4-BE49-F238E27FC236}">
-                <a16:creationId xmlns:a16="http://schemas.microsoft.com/office/drawing/2014/main" id="{5A3DCDBA-A811-45A6-AFB2-F0C2C30B08CC}"/>
+                <a16:creationId xmlns:a16="http://schemas.microsoft.com/office/drawing/2014/main" id="{97497242-C585-473D-A209-51EAD3E14979}"/>
               </a:ext>
             </a:extLst>
           </p:cNvPr>
@@ -5550,7 +5440,7 @@
     </p:spTree>
     <p:extLst>
       <p:ext uri="{BB962C8B-B14F-4D97-AF65-F5344CB8AC3E}">
-        <p14:creationId xmlns:p14="http://schemas.microsoft.com/office/powerpoint/2010/main" val="863492059"/>
+        <p14:creationId xmlns:p14="http://schemas.microsoft.com/office/powerpoint/2010/main" val="875101982"/>
       </p:ext>
     </p:extLst>
   </p:cSld>
@@ -5581,7 +5471,7 @@
           <p:cNvPr id="15" name="">
             <a:extLst xmlns:a="http://schemas.openxmlformats.org/drawingml/2006/main">
               <a:ext uri="{FF2B5EF4-FFF2-40B4-BE49-F238E27FC236}">
-                <a16:creationId xmlns:a16="http://schemas.microsoft.com/office/drawing/2014/main" id="{BDD8CA94-A198-4981-B726-AE94A28BCFCF}"/>
+                <a16:creationId xmlns:a16="http://schemas.microsoft.com/office/drawing/2014/main" id="{E45057E6-9778-461E-9D00-937176DC049C}"/>
               </a:ext>
             </a:extLst>
           </p:cNvPr>
@@ -5591,7 +5481,7 @@
           <p:nvPr/>
         </p:nvPicPr>
         <p:blipFill>
-          <a:blip xmlns:r="http://schemas.openxmlformats.org/officeDocument/2006/relationships" xmlns:a="http://schemas.openxmlformats.org/drawingml/2006/main" r:embed="R2f04d5ca89684b0c"/>
+          <a:blip xmlns:r="http://schemas.openxmlformats.org/officeDocument/2006/relationships" xmlns:a="http://schemas.openxmlformats.org/drawingml/2006/main" r:embed="Rb602084c2a6b4afc"/>
           <a:stretch xmlns:a="http://schemas.openxmlformats.org/drawingml/2006/main"/>
         </p:blipFill>
         <p:spPr>
@@ -5609,7 +5499,7 @@
           <p:cNvPr id="2" name="">
             <a:extLst xmlns:a="http://schemas.openxmlformats.org/drawingml/2006/main">
               <a:ext uri="{FF2B5EF4-FFF2-40B4-BE49-F238E27FC236}">
-                <a16:creationId xmlns:a16="http://schemas.microsoft.com/office/drawing/2014/main" id="{70CA10EA-0B86-49E8-BB5A-F021BC7BEBF7}"/>
+                <a16:creationId xmlns:a16="http://schemas.microsoft.com/office/drawing/2014/main" id="{B6BCC6EA-593E-49ED-9B8B-412ADDA4BB2D}"/>
               </a:ext>
             </a:extLst>
           </p:cNvPr>
@@ -5677,7 +5567,7 @@
           <p:cNvPr id="3" name="">
             <a:extLst xmlns:a="http://schemas.openxmlformats.org/drawingml/2006/main">
               <a:ext uri="{FF2B5EF4-FFF2-40B4-BE49-F238E27FC236}">
-                <a16:creationId xmlns:a16="http://schemas.microsoft.com/office/drawing/2014/main" id="{C1B07899-29FC-499F-82BA-BAECEBB0B839}"/>
+                <a16:creationId xmlns:a16="http://schemas.microsoft.com/office/drawing/2014/main" id="{FDD3C684-A789-4DE5-A7C8-875E64090624}"/>
               </a:ext>
             </a:extLst>
           </p:cNvPr>
@@ -5735,7 +5625,7 @@
                 <a:ea typeface="Arial"/>
                 <a:cs typeface="Arial"/>
               </a:rPr>
-              <a:t>Сколько действий занимает</a:t>
+              <a:t>Какие данные описаны</a:t>
             </a:r>
           </a:p>
           <a:p xmlns:a="http://schemas.openxmlformats.org/drawingml/2006/main">
@@ -5758,7 +5648,7 @@
                 <a:ea typeface="Arial"/>
                 <a:cs typeface="Arial"/>
               </a:rPr>
-              <a:t>обработка одного отклика?</a:t>
+              <a:t>в API hh.ru</a:t>
             </a:r>
           </a:p>
         </p:txBody>
@@ -5768,7 +5658,7 @@
           <p:cNvPr id="4" name="">
             <a:extLst xmlns:a="http://schemas.openxmlformats.org/drawingml/2006/main">
               <a:ext uri="{FF2B5EF4-FFF2-40B4-BE49-F238E27FC236}">
-                <a16:creationId xmlns:a16="http://schemas.microsoft.com/office/drawing/2014/main" id="{A1886865-B23F-432E-A449-239ABE316C39}"/>
+                <a16:creationId xmlns:a16="http://schemas.microsoft.com/office/drawing/2014/main" id="{06088BA2-AB6C-4D81-AB22-0AD0E703CD9D}"/>
               </a:ext>
             </a:extLst>
           </p:cNvPr>
@@ -5836,7 +5726,7 @@
           <p:cNvPr id="5" name="">
             <a:extLst xmlns:a="http://schemas.openxmlformats.org/drawingml/2006/main">
               <a:ext uri="{FF2B5EF4-FFF2-40B4-BE49-F238E27FC236}">
-                <a16:creationId xmlns:a16="http://schemas.microsoft.com/office/drawing/2014/main" id="{1B923ABE-0087-4266-B516-A7EB007CC9C7}"/>
+                <a16:creationId xmlns:a16="http://schemas.microsoft.com/office/drawing/2014/main" id="{8C50068A-31A3-4A12-95E4-10A8E9689408}"/>
               </a:ext>
             </a:extLst>
           </p:cNvPr>
@@ -5904,7 +5794,7 @@
           <p:cNvPr id="6" name="">
             <a:extLst xmlns:a="http://schemas.openxmlformats.org/drawingml/2006/main">
               <a:ext uri="{FF2B5EF4-FFF2-40B4-BE49-F238E27FC236}">
-                <a16:creationId xmlns:a16="http://schemas.microsoft.com/office/drawing/2014/main" id="{0921FB6F-D7B1-468C-8EE0-7519E985EFF2}"/>
+                <a16:creationId xmlns:a16="http://schemas.microsoft.com/office/drawing/2014/main" id="{D3AA3F42-07BD-42FB-A867-E2B376B919D7}"/>
               </a:ext>
             </a:extLst>
           </p:cNvPr>
@@ -5972,7 +5862,7 @@
           <p:cNvPr id="7" name="">
             <a:extLst xmlns:a="http://schemas.openxmlformats.org/drawingml/2006/main">
               <a:ext uri="{FF2B5EF4-FFF2-40B4-BE49-F238E27FC236}">
-                <a16:creationId xmlns:a16="http://schemas.microsoft.com/office/drawing/2014/main" id="{2EF87A2D-C297-4C69-9E22-DB5E41B52848}"/>
+                <a16:creationId xmlns:a16="http://schemas.microsoft.com/office/drawing/2014/main" id="{AF04AEB8-487D-453F-B4D3-FCBD23DF9F83}"/>
               </a:ext>
             </a:extLst>
           </p:cNvPr>
@@ -6030,7 +5920,7 @@
                 <a:ea typeface="Courier New"/>
                 <a:cs typeface="Courier New"/>
               </a:rPr>
-              <a:t>БЕЗ ИНТЕГРАЦИИ</a:t>
+              <a:t>РАЗБОР РЕЗЮМЕ</a:t>
             </a:r>
           </a:p>
         </p:txBody>
@@ -6040,7 +5930,7 @@
           <p:cNvPr id="8" name="">
             <a:extLst xmlns:a="http://schemas.openxmlformats.org/drawingml/2006/main">
               <a:ext uri="{FF2B5EF4-FFF2-40B4-BE49-F238E27FC236}">
-                <a16:creationId xmlns:a16="http://schemas.microsoft.com/office/drawing/2014/main" id="{BB1CC680-D984-4B43-A12D-F080AB4A7DEC}"/>
+                <a16:creationId xmlns:a16="http://schemas.microsoft.com/office/drawing/2014/main" id="{6E526D7A-6F82-4539-AE86-4829BDBB54F1}"/>
               </a:ext>
             </a:extLst>
           </p:cNvPr>
@@ -6098,7 +5988,7 @@
                 <a:ea typeface="Arial"/>
                 <a:cs typeface="Arial"/>
               </a:rPr>
-              <a:t>Результат в hh.ru</a:t>
+              <a:t>Оценка и основания</a:t>
             </a:r>
           </a:p>
         </p:txBody>
@@ -6108,7 +5998,7 @@
           <p:cNvPr id="9" name="">
             <a:extLst xmlns:a="http://schemas.openxmlformats.org/drawingml/2006/main">
               <a:ext uri="{FF2B5EF4-FFF2-40B4-BE49-F238E27FC236}">
-                <a16:creationId xmlns:a16="http://schemas.microsoft.com/office/drawing/2014/main" id="{2092516B-7C1B-45DD-8718-4EB389E4D86E}"/>
+                <a16:creationId xmlns:a16="http://schemas.microsoft.com/office/drawing/2014/main" id="{82976782-ECDE-4162-8B41-AAD840F9BCC6}"/>
               </a:ext>
             </a:extLst>
           </p:cNvPr>
@@ -6166,7 +6056,7 @@
                 <a:ea typeface="Arial"/>
                 <a:cs typeface="Arial"/>
               </a:rPr>
-              <a:t>Просмотр оценки и ответов</a:t>
+              <a:t>Результат оценки</a:t>
             </a:r>
           </a:p>
           <a:p xmlns:a="http://schemas.openxmlformats.org/drawingml/2006/main">
@@ -6189,7 +6079,7 @@
                 <a:ea typeface="Arial"/>
                 <a:cs typeface="Arial"/>
               </a:rPr>
-              <a:t>Перенос сведений в Skillaz</a:t>
+              <a:t>Краткая сводка</a:t>
             </a:r>
           </a:p>
           <a:p xmlns:a="http://schemas.openxmlformats.org/drawingml/2006/main">
@@ -6212,7 +6102,7 @@
                 <a:ea typeface="Arial"/>
                 <a:cs typeface="Arial"/>
               </a:rPr>
-              <a:t>Обновление карточки</a:t>
+              <a:t>Выполнение критериев</a:t>
             </a:r>
           </a:p>
           <a:p xmlns:a="http://schemas.openxmlformats.org/drawingml/2006/main">
@@ -6235,7 +6125,7 @@
                 <a:ea typeface="Arial"/>
                 <a:cs typeface="Arial"/>
               </a:rPr>
-              <a:t>Передача на следующий этап</a:t>
+              <a:t>Объяснение по каждому критерию</a:t>
             </a:r>
           </a:p>
         </p:txBody>
@@ -6245,7 +6135,7 @@
           <p:cNvPr id="10" name="">
             <a:extLst xmlns:a="http://schemas.openxmlformats.org/drawingml/2006/main">
               <a:ext uri="{FF2B5EF4-FFF2-40B4-BE49-F238E27FC236}">
-                <a16:creationId xmlns:a16="http://schemas.microsoft.com/office/drawing/2014/main" id="{40751541-E5FD-4A6F-B3F5-F3CD10690203}"/>
+                <a16:creationId xmlns:a16="http://schemas.microsoft.com/office/drawing/2014/main" id="{EDD77568-8068-41F1-AE12-C2A713AD6B8C}"/>
               </a:ext>
             </a:extLst>
           </p:cNvPr>
@@ -6275,7 +6165,7 @@
           <p:cNvPr id="11" name="">
             <a:extLst xmlns:a="http://schemas.openxmlformats.org/drawingml/2006/main">
               <a:ext uri="{FF2B5EF4-FFF2-40B4-BE49-F238E27FC236}">
-                <a16:creationId xmlns:a16="http://schemas.microsoft.com/office/drawing/2014/main" id="{9B854BC1-EC03-42E6-8532-9C0FE75A34A9}"/>
+                <a16:creationId xmlns:a16="http://schemas.microsoft.com/office/drawing/2014/main" id="{7824D4E7-39DA-4FB2-81D4-70CC131D48D7}"/>
               </a:ext>
             </a:extLst>
           </p:cNvPr>
@@ -6333,7 +6223,7 @@
                 <a:ea typeface="Courier New"/>
                 <a:cs typeface="Courier New"/>
               </a:rPr>
-              <a:t>С ИНТЕГРАЦИЕЙ</a:t>
+              <a:t>ОТВЕТЫ КАНДИДАТА</a:t>
             </a:r>
           </a:p>
         </p:txBody>
@@ -6343,7 +6233,7 @@
           <p:cNvPr id="12" name="">
             <a:extLst xmlns:a="http://schemas.openxmlformats.org/drawingml/2006/main">
               <a:ext uri="{FF2B5EF4-FFF2-40B4-BE49-F238E27FC236}">
-                <a16:creationId xmlns:a16="http://schemas.microsoft.com/office/drawing/2014/main" id="{EC10A90C-4C79-49D4-B7F8-9EA04F501C45}"/>
+                <a16:creationId xmlns:a16="http://schemas.microsoft.com/office/drawing/2014/main" id="{A9625768-437E-4081-8785-3AD7902B921F}"/>
               </a:ext>
             </a:extLst>
           </p:cNvPr>
@@ -6401,7 +6291,7 @@
                 <a:ea typeface="Arial"/>
                 <a:cs typeface="Arial"/>
               </a:rPr>
-              <a:t>Результат в Skillaz</a:t>
+              <a:t>Вопросы и ответы</a:t>
             </a:r>
           </a:p>
         </p:txBody>
@@ -6411,7 +6301,7 @@
           <p:cNvPr id="13" name="">
             <a:extLst xmlns:a="http://schemas.openxmlformats.org/drawingml/2006/main">
               <a:ext uri="{FF2B5EF4-FFF2-40B4-BE49-F238E27FC236}">
-                <a16:creationId xmlns:a16="http://schemas.microsoft.com/office/drawing/2014/main" id="{6EC5EB6F-91BE-41A1-AA00-8F40E752D805}"/>
+                <a16:creationId xmlns:a16="http://schemas.microsoft.com/office/drawing/2014/main" id="{C6FBB2B3-DF04-43BA-B384-C85A82B692B6}"/>
               </a:ext>
             </a:extLst>
           </p:cNvPr>
@@ -6469,7 +6359,7 @@
                 <a:ea typeface="Arial"/>
                 <a:cs typeface="Arial"/>
               </a:rPr>
-              <a:t>Просмотр информации в карточке</a:t>
+              <a:t>Вопрос работодателя</a:t>
             </a:r>
           </a:p>
           <a:p xmlns:a="http://schemas.openxmlformats.org/drawingml/2006/main">
@@ -6492,7 +6382,7 @@
                 <a:ea typeface="Arial"/>
                 <a:cs typeface="Arial"/>
               </a:rPr>
-              <a:t>Решение рекрутёра</a:t>
+              <a:t>Цитата ответа кандидата</a:t>
             </a:r>
           </a:p>
           <a:p xmlns:a="http://schemas.openxmlformats.org/drawingml/2006/main">
@@ -6515,7 +6405,7 @@
                 <a:ea typeface="Arial"/>
                 <a:cs typeface="Arial"/>
               </a:rPr>
-              <a:t>Следующий этап</a:t>
+              <a:t>Статус ответов и вопросы кандидата</a:t>
             </a:r>
           </a:p>
         </p:txBody>
@@ -6525,7 +6415,7 @@
           <p:cNvPr id="14" name="">
             <a:extLst xmlns:a="http://schemas.openxmlformats.org/drawingml/2006/main">
               <a:ext uri="{FF2B5EF4-FFF2-40B4-BE49-F238E27FC236}">
-                <a16:creationId xmlns:a16="http://schemas.microsoft.com/office/drawing/2014/main" id="{3B2069DD-2208-4674-9CDD-F6B5C032413E}"/>
+                <a16:creationId xmlns:a16="http://schemas.microsoft.com/office/drawing/2014/main" id="{0B342E77-0647-40DE-8900-9F52C748BCEC}"/>
               </a:ext>
             </a:extLst>
           </p:cNvPr>
@@ -6583,7 +6473,7 @@
                 <a:ea typeface="Arial"/>
                 <a:cs typeface="Arial"/>
               </a:rPr>
-              <a:t>Меньше ручных шагов между результатом ИИ и действием рекрутёра.</a:t>
+              <a:t>Эти данные приведены в официальных примерах ответа API hh.ru.</a:t>
             </a:r>
           </a:p>
         </p:txBody>
@@ -6591,7 +6481,7 @@
     </p:spTree>
     <p:extLst>
       <p:ext uri="{BB962C8B-B14F-4D97-AF65-F5344CB8AC3E}">
-        <p14:creationId xmlns:p14="http://schemas.microsoft.com/office/powerpoint/2010/main" val="1053601816"/>
+        <p14:creationId xmlns:p14="http://schemas.microsoft.com/office/powerpoint/2010/main" val="1268114413"/>
       </p:ext>
     </p:extLst>
   </p:cSld>
@@ -6622,7 +6512,7 @@
           <p:cNvPr id="9" name="">
             <a:extLst xmlns:a="http://schemas.openxmlformats.org/drawingml/2006/main">
               <a:ext uri="{FF2B5EF4-FFF2-40B4-BE49-F238E27FC236}">
-                <a16:creationId xmlns:a16="http://schemas.microsoft.com/office/drawing/2014/main" id="{EF596B71-329F-4009-944A-95DD0D8F6CC6}"/>
+                <a16:creationId xmlns:a16="http://schemas.microsoft.com/office/drawing/2014/main" id="{62A5C534-EBF5-4079-8077-B9C1C50FE6FA}"/>
               </a:ext>
             </a:extLst>
           </p:cNvPr>
@@ -6632,7 +6522,7 @@
           <p:nvPr/>
         </p:nvPicPr>
         <p:blipFill>
-          <a:blip xmlns:r="http://schemas.openxmlformats.org/officeDocument/2006/relationships" xmlns:a="http://schemas.openxmlformats.org/drawingml/2006/main" r:embed="R78d108b493b9416c"/>
+          <a:blip xmlns:r="http://schemas.openxmlformats.org/officeDocument/2006/relationships" xmlns:a="http://schemas.openxmlformats.org/drawingml/2006/main" r:embed="R6994967d1a004831"/>
           <a:stretch xmlns:a="http://schemas.openxmlformats.org/drawingml/2006/main"/>
         </p:blipFill>
         <p:spPr>
@@ -6650,7 +6540,7 @@
           <p:cNvPr id="2" name="">
             <a:extLst xmlns:a="http://schemas.openxmlformats.org/drawingml/2006/main">
               <a:ext uri="{FF2B5EF4-FFF2-40B4-BE49-F238E27FC236}">
-                <a16:creationId xmlns:a16="http://schemas.microsoft.com/office/drawing/2014/main" id="{054A7A13-BE08-461A-94C9-38E24A776C7D}"/>
+                <a16:creationId xmlns:a16="http://schemas.microsoft.com/office/drawing/2014/main" id="{5CAC21E0-820F-4EBE-A44C-908671F291EB}"/>
               </a:ext>
             </a:extLst>
           </p:cNvPr>
@@ -6718,7 +6608,7 @@
           <p:cNvPr id="3" name="">
             <a:extLst xmlns:a="http://schemas.openxmlformats.org/drawingml/2006/main">
               <a:ext uri="{FF2B5EF4-FFF2-40B4-BE49-F238E27FC236}">
-                <a16:creationId xmlns:a16="http://schemas.microsoft.com/office/drawing/2014/main" id="{05CF5A50-B5B3-4EE4-930B-751A10048AE1}"/>
+                <a16:creationId xmlns:a16="http://schemas.microsoft.com/office/drawing/2014/main" id="{C852FB7C-673B-477E-8587-C5BEA81EF740}"/>
               </a:ext>
             </a:extLst>
           </p:cNvPr>
@@ -6776,7 +6666,7 @@
                 <a:ea typeface="Arial"/>
                 <a:cs typeface="Arial"/>
               </a:rPr>
-              <a:t>Что делает hh.ru,</a:t>
+              <a:t>Результаты ИИ</a:t>
             </a:r>
           </a:p>
           <a:p xmlns:a="http://schemas.openxmlformats.org/drawingml/2006/main">
@@ -6799,7 +6689,7 @@
                 <a:ea typeface="Arial"/>
                 <a:cs typeface="Arial"/>
               </a:rPr>
-              <a:t>что добавляет Skillaz</a:t>
+              <a:t>в документации API hh.ru</a:t>
             </a:r>
           </a:p>
         </p:txBody>
@@ -6809,7 +6699,7 @@
           <p:cNvPr id="4" name="">
             <a:extLst xmlns:a="http://schemas.openxmlformats.org/drawingml/2006/main">
               <a:ext uri="{FF2B5EF4-FFF2-40B4-BE49-F238E27FC236}">
-                <a16:creationId xmlns:a16="http://schemas.microsoft.com/office/drawing/2014/main" id="{81C561A8-3AC0-4644-ABC1-6B98E1C2E74D}"/>
+                <a16:creationId xmlns:a16="http://schemas.microsoft.com/office/drawing/2014/main" id="{1C6794CB-491E-48E6-9D30-EC384B037ED8}"/>
               </a:ext>
             </a:extLst>
           </p:cNvPr>
@@ -6877,7 +6767,7 @@
           <p:cNvPr id="5" name="">
             <a:extLst xmlns:a="http://schemas.openxmlformats.org/drawingml/2006/main">
               <a:ext uri="{FF2B5EF4-FFF2-40B4-BE49-F238E27FC236}">
-                <a16:creationId xmlns:a16="http://schemas.microsoft.com/office/drawing/2014/main" id="{5AA8BADA-69D2-44CE-9975-7834040C554A}"/>
+                <a16:creationId xmlns:a16="http://schemas.microsoft.com/office/drawing/2014/main" id="{52789DD2-7605-4CE6-A8AF-0B495DF740F2}"/>
               </a:ext>
             </a:extLst>
           </p:cNvPr>
@@ -6945,7 +6835,7 @@
           <p:cNvPr id="6" name="">
             <a:extLst xmlns:a="http://schemas.openxmlformats.org/drawingml/2006/main">
               <a:ext uri="{FF2B5EF4-FFF2-40B4-BE49-F238E27FC236}">
-                <a16:creationId xmlns:a16="http://schemas.microsoft.com/office/drawing/2014/main" id="{4C4C5211-31BB-4182-9D65-6FC88EFFB8FC}"/>
+                <a16:creationId xmlns:a16="http://schemas.microsoft.com/office/drawing/2014/main" id="{EF5D73B5-A47F-4951-B667-F58E44D2712B}"/>
               </a:ext>
             </a:extLst>
           </p:cNvPr>
@@ -7013,7 +6903,7 @@
           <p:cNvPr id="7" name="">
             <a:extLst xmlns:a="http://schemas.openxmlformats.org/drawingml/2006/main">
               <a:ext uri="{FF2B5EF4-FFF2-40B4-BE49-F238E27FC236}">
-                <a16:creationId xmlns:a16="http://schemas.microsoft.com/office/drawing/2014/main" id="{9BB92F67-5DEB-4EE3-8AB0-673C615BD277}"/>
+                <a16:creationId xmlns:a16="http://schemas.microsoft.com/office/drawing/2014/main" id="{4BB2493D-2DCC-4C26-A42E-8A7098862515}"/>
               </a:ext>
             </a:extLst>
           </p:cNvPr>
@@ -7047,7 +6937,7 @@
                           <a:ea typeface="Arial"/>
                           <a:cs typeface="Arial"/>
                         </a:rPr>
-                        <a:t>ИИ-помощник hh.ru</a:t>
+                        <a:t>Результат работы ИИ</a:t>
                       </a:r>
                     </a:p>
                   </a:txBody>
@@ -7095,7 +6985,7 @@
                           <a:ea typeface="Arial"/>
                           <a:cs typeface="Arial"/>
                         </a:rPr>
-                        <a:t>Интеграция со Skillaz</a:t>
+                        <a:t>Данные в примере ответа API</a:t>
                       </a:r>
                     </a:p>
                   </a:txBody>
@@ -7139,7 +7029,7 @@
                           <a:ea typeface="Arial"/>
                           <a:cs typeface="Arial"/>
                         </a:rPr>
-                        <a:t>Анализирует резюме по требованиям</a:t>
+                        <a:t>Итог разбора</a:t>
                       </a:r>
                     </a:p>
                   </a:txBody>
@@ -7181,7 +7071,7 @@
                           <a:ea typeface="Arial"/>
                           <a:cs typeface="Arial"/>
                         </a:rPr>
-                        <a:t>Показывает результат в воронке</a:t>
+                        <a:t>Решение ИИ и краткая сводка</a:t>
                       </a:r>
                     </a:p>
                   </a:txBody>
@@ -7219,7 +7109,7 @@
                           <a:ea typeface="Arial"/>
                           <a:cs typeface="Arial"/>
                         </a:rPr>
-                        <a:t>Распределяет отклики по категориям</a:t>
+                        <a:t>Проверка требований</a:t>
                       </a:r>
                     </a:p>
                   </a:txBody>
@@ -7261,7 +7151,7 @@
                           <a:ea typeface="Arial"/>
                           <a:cs typeface="Arial"/>
                         </a:rPr>
-                        <a:t>Даёт работать с категориями в ATS</a:t>
+                        <a:t>Критерии и степень выполнения</a:t>
                       </a:r>
                     </a:p>
                   </a:txBody>
@@ -7299,7 +7189,7 @@
                           <a:ea typeface="Arial"/>
                           <a:cs typeface="Arial"/>
                         </a:rPr>
-                        <a:t>Объясняет соответствие критериям</a:t>
+                        <a:t>Основания оценки</a:t>
                       </a:r>
                     </a:p>
                   </a:txBody>
@@ -7341,7 +7231,7 @@
                           <a:ea typeface="Arial"/>
                           <a:cs typeface="Arial"/>
                         </a:rPr>
-                        <a:t>Размещает разбор в карточке</a:t>
+                        <a:t>Объяснение и источник информации</a:t>
                       </a:r>
                     </a:p>
                   </a:txBody>
@@ -7379,7 +7269,7 @@
                           <a:ea typeface="Arial"/>
                           <a:cs typeface="Arial"/>
                         </a:rPr>
-                        <a:t>Уточняет информацию в чате</a:t>
+                        <a:t>Ответы кандидата</a:t>
                       </a:r>
                     </a:p>
                   </a:txBody>
@@ -7421,7 +7311,7 @@
                           <a:ea typeface="Arial"/>
                           <a:cs typeface="Arial"/>
                         </a:rPr>
-                        <a:t>Сохраняет ответы в поля карточки</a:t>
+                        <a:t>Вопросы и цитаты ответов</a:t>
                       </a:r>
                     </a:p>
                   </a:txBody>
@@ -7453,7 +7343,7 @@
           <p:cNvPr id="8" name="">
             <a:extLst xmlns:a="http://schemas.openxmlformats.org/drawingml/2006/main">
               <a:ext uri="{FF2B5EF4-FFF2-40B4-BE49-F238E27FC236}">
-                <a16:creationId xmlns:a16="http://schemas.microsoft.com/office/drawing/2014/main" id="{D05FBFED-8EE1-4251-A873-A56E903CEA08}"/>
+                <a16:creationId xmlns:a16="http://schemas.microsoft.com/office/drawing/2014/main" id="{87D20C70-87F5-4C7B-98F9-3DB4D92624D8}"/>
               </a:ext>
             </a:extLst>
           </p:cNvPr>
@@ -7511,7 +7401,7 @@
                 <a:ea typeface="Arial"/>
                 <a:cs typeface="Arial"/>
               </a:rPr>
-              <a:t>Результаты ИИ доступны там, где команда ведёт подбор.</a:t>
+              <a:t>Публичный пример API описывает получение результатов ИИ.</a:t>
             </a:r>
           </a:p>
         </p:txBody>
@@ -7519,7 +7409,7 @@
     </p:spTree>
     <p:extLst>
       <p:ext uri="{BB962C8B-B14F-4D97-AF65-F5344CB8AC3E}">
-        <p14:creationId xmlns:p14="http://schemas.microsoft.com/office/powerpoint/2010/main" val="2056020839"/>
+        <p14:creationId xmlns:p14="http://schemas.microsoft.com/office/powerpoint/2010/main" val="364600141"/>
       </p:ext>
     </p:extLst>
   </p:cSld>
@@ -7550,7 +7440,7 @@
           <p:cNvPr id="19" name="">
             <a:extLst xmlns:a="http://schemas.openxmlformats.org/drawingml/2006/main">
               <a:ext uri="{FF2B5EF4-FFF2-40B4-BE49-F238E27FC236}">
-                <a16:creationId xmlns:a16="http://schemas.microsoft.com/office/drawing/2014/main" id="{0234C834-1947-4FFF-97E6-EE1B01847B0F}"/>
+                <a16:creationId xmlns:a16="http://schemas.microsoft.com/office/drawing/2014/main" id="{D76A4182-4740-4E70-B917-EA29F8BB5209}"/>
               </a:ext>
             </a:extLst>
           </p:cNvPr>
@@ -7560,7 +7450,7 @@
           <p:nvPr/>
         </p:nvPicPr>
         <p:blipFill>
-          <a:blip xmlns:r="http://schemas.openxmlformats.org/officeDocument/2006/relationships" xmlns:a="http://schemas.openxmlformats.org/drawingml/2006/main" r:embed="Ref286c42a568426f"/>
+          <a:blip xmlns:r="http://schemas.openxmlformats.org/officeDocument/2006/relationships" xmlns:a="http://schemas.openxmlformats.org/drawingml/2006/main" r:embed="Rb0430e2231ff4f95"/>
           <a:stretch xmlns:a="http://schemas.openxmlformats.org/drawingml/2006/main"/>
         </p:blipFill>
         <p:spPr>
@@ -7578,7 +7468,7 @@
           <p:cNvPr id="2" name="">
             <a:extLst xmlns:a="http://schemas.openxmlformats.org/drawingml/2006/main">
               <a:ext uri="{FF2B5EF4-FFF2-40B4-BE49-F238E27FC236}">
-                <a16:creationId xmlns:a16="http://schemas.microsoft.com/office/drawing/2014/main" id="{A4544C35-9202-44B8-B940-0C5F7E123A35}"/>
+                <a16:creationId xmlns:a16="http://schemas.microsoft.com/office/drawing/2014/main" id="{39A09D0A-8109-4AC8-AC5D-EC22D641A31A}"/>
               </a:ext>
             </a:extLst>
           </p:cNvPr>
@@ -7646,7 +7536,7 @@
           <p:cNvPr id="3" name="">
             <a:extLst xmlns:a="http://schemas.openxmlformats.org/drawingml/2006/main">
               <a:ext uri="{FF2B5EF4-FFF2-40B4-BE49-F238E27FC236}">
-                <a16:creationId xmlns:a16="http://schemas.microsoft.com/office/drawing/2014/main" id="{E7B860BF-F2C6-40D9-9BFE-4576C56DA2A5}"/>
+                <a16:creationId xmlns:a16="http://schemas.microsoft.com/office/drawing/2014/main" id="{7322CCDF-0BD7-4F92-AC02-A435F7D676FC}"/>
               </a:ext>
             </a:extLst>
           </p:cNvPr>
@@ -7704,7 +7594,7 @@
                 <a:ea typeface="Arial"/>
                 <a:cs typeface="Arial"/>
               </a:rPr>
-              <a:t>От отклика до следующего этапа</a:t>
+              <a:t>Получение результатов ИИ</a:t>
             </a:r>
           </a:p>
         </p:txBody>
@@ -7714,7 +7604,7 @@
           <p:cNvPr id="4" name="">
             <a:extLst xmlns:a="http://schemas.openxmlformats.org/drawingml/2006/main">
               <a:ext uri="{FF2B5EF4-FFF2-40B4-BE49-F238E27FC236}">
-                <a16:creationId xmlns:a16="http://schemas.microsoft.com/office/drawing/2014/main" id="{D4C9BB65-7FD7-426C-9D77-F4AA708DC3B6}"/>
+                <a16:creationId xmlns:a16="http://schemas.microsoft.com/office/drawing/2014/main" id="{A8DDED11-A9D1-4E8A-8955-E0865A236C03}"/>
               </a:ext>
             </a:extLst>
           </p:cNvPr>
@@ -7782,7 +7672,7 @@
           <p:cNvPr id="5" name="">
             <a:extLst xmlns:a="http://schemas.openxmlformats.org/drawingml/2006/main">
               <a:ext uri="{FF2B5EF4-FFF2-40B4-BE49-F238E27FC236}">
-                <a16:creationId xmlns:a16="http://schemas.microsoft.com/office/drawing/2014/main" id="{94996CB9-6748-4941-A1E2-CF8645D07FA1}"/>
+                <a16:creationId xmlns:a16="http://schemas.microsoft.com/office/drawing/2014/main" id="{A06CAEAD-D163-4886-BE53-5BFDB8652936}"/>
               </a:ext>
             </a:extLst>
           </p:cNvPr>
@@ -7850,7 +7740,7 @@
           <p:cNvPr id="6" name="">
             <a:extLst xmlns:a="http://schemas.openxmlformats.org/drawingml/2006/main">
               <a:ext uri="{FF2B5EF4-FFF2-40B4-BE49-F238E27FC236}">
-                <a16:creationId xmlns:a16="http://schemas.microsoft.com/office/drawing/2014/main" id="{969C7848-EF8D-48B8-9348-9C686486F75B}"/>
+                <a16:creationId xmlns:a16="http://schemas.microsoft.com/office/drawing/2014/main" id="{068B0571-5158-4010-903B-E7BAEDBE92D5}"/>
               </a:ext>
             </a:extLst>
           </p:cNvPr>
@@ -7918,7 +7808,7 @@
           <p:cNvPr id="7" name="">
             <a:extLst xmlns:a="http://schemas.openxmlformats.org/drawingml/2006/main">
               <a:ext uri="{FF2B5EF4-FFF2-40B4-BE49-F238E27FC236}">
-                <a16:creationId xmlns:a16="http://schemas.microsoft.com/office/drawing/2014/main" id="{5E1677DB-77C7-4FE1-852B-A01728BE7D7F}"/>
+                <a16:creationId xmlns:a16="http://schemas.microsoft.com/office/drawing/2014/main" id="{BE97FCB3-9919-4896-9C57-A5232856A434}"/>
               </a:ext>
             </a:extLst>
           </p:cNvPr>
@@ -7986,7 +7876,7 @@
           <p:cNvPr id="8" name="">
             <a:extLst xmlns:a="http://schemas.openxmlformats.org/drawingml/2006/main">
               <a:ext uri="{FF2B5EF4-FFF2-40B4-BE49-F238E27FC236}">
-                <a16:creationId xmlns:a16="http://schemas.microsoft.com/office/drawing/2014/main" id="{CE6753F6-40F8-4238-AEB3-5727AED71D42}"/>
+                <a16:creationId xmlns:a16="http://schemas.microsoft.com/office/drawing/2014/main" id="{45EE418D-F9F6-4DAB-A5E7-C1B809612EC1}"/>
               </a:ext>
             </a:extLst>
           </p:cNvPr>
@@ -8044,7 +7934,7 @@
                 <a:ea typeface="Arial"/>
                 <a:cs typeface="Arial"/>
               </a:rPr>
-              <a:t>Требования в Skillaz</a:t>
+              <a:t>Настройка в hh.ru</a:t>
             </a:r>
           </a:p>
         </p:txBody>
@@ -8054,7 +7944,7 @@
           <p:cNvPr id="9" name="">
             <a:extLst xmlns:a="http://schemas.openxmlformats.org/drawingml/2006/main">
               <a:ext uri="{FF2B5EF4-FFF2-40B4-BE49-F238E27FC236}">
-                <a16:creationId xmlns:a16="http://schemas.microsoft.com/office/drawing/2014/main" id="{FDF326F0-A90B-4E89-821A-839B7D18110D}"/>
+                <a16:creationId xmlns:a16="http://schemas.microsoft.com/office/drawing/2014/main" id="{BEDB52AB-A5BA-4724-B09F-06979F78A8F5}"/>
               </a:ext>
             </a:extLst>
           </p:cNvPr>
@@ -8112,7 +8002,7 @@
                 <a:ea typeface="Arial"/>
                 <a:cs typeface="Arial"/>
               </a:rPr>
-              <a:t>Рекрутёр определяет критерии и включает нужные функции.</a:t>
+              <a:t>Критерии разбора и вопросы задаются в интерфейсе hh.ru.</a:t>
             </a:r>
           </a:p>
         </p:txBody>
@@ -8122,7 +8012,7 @@
           <p:cNvPr id="10" name="">
             <a:extLst xmlns:a="http://schemas.openxmlformats.org/drawingml/2006/main">
               <a:ext uri="{FF2B5EF4-FFF2-40B4-BE49-F238E27FC236}">
-                <a16:creationId xmlns:a16="http://schemas.microsoft.com/office/drawing/2014/main" id="{F9639747-46D9-4A6A-BA2C-C035FDA25E4B}"/>
+                <a16:creationId xmlns:a16="http://schemas.microsoft.com/office/drawing/2014/main" id="{C36891B1-133C-49EB-A812-9BEFFAF5961E}"/>
               </a:ext>
             </a:extLst>
           </p:cNvPr>
@@ -8190,7 +8080,7 @@
           <p:cNvPr id="11" name="">
             <a:extLst xmlns:a="http://schemas.openxmlformats.org/drawingml/2006/main">
               <a:ext uri="{FF2B5EF4-FFF2-40B4-BE49-F238E27FC236}">
-                <a16:creationId xmlns:a16="http://schemas.microsoft.com/office/drawing/2014/main" id="{B11F4414-75A9-4E9C-BEB0-E8B1E10D1869}"/>
+                <a16:creationId xmlns:a16="http://schemas.microsoft.com/office/drawing/2014/main" id="{4A2624B1-E903-4C31-856D-D5256B78FD08}"/>
               </a:ext>
             </a:extLst>
           </p:cNvPr>
@@ -8258,7 +8148,7 @@
           <p:cNvPr id="12" name="">
             <a:extLst xmlns:a="http://schemas.openxmlformats.org/drawingml/2006/main">
               <a:ext uri="{FF2B5EF4-FFF2-40B4-BE49-F238E27FC236}">
-                <a16:creationId xmlns:a16="http://schemas.microsoft.com/office/drawing/2014/main" id="{DC176D6F-1EA2-4C06-86A2-3DB672D4ACE8}"/>
+                <a16:creationId xmlns:a16="http://schemas.microsoft.com/office/drawing/2014/main" id="{27FC47B4-02B4-46ED-A04A-5FCA45F33186}"/>
               </a:ext>
             </a:extLst>
           </p:cNvPr>
@@ -8326,7 +8216,7 @@
           <p:cNvPr id="13" name="">
             <a:extLst xmlns:a="http://schemas.openxmlformats.org/drawingml/2006/main">
               <a:ext uri="{FF2B5EF4-FFF2-40B4-BE49-F238E27FC236}">
-                <a16:creationId xmlns:a16="http://schemas.microsoft.com/office/drawing/2014/main" id="{67ACC6C9-DA07-4A7B-B678-D95422591FFD}"/>
+                <a16:creationId xmlns:a16="http://schemas.microsoft.com/office/drawing/2014/main" id="{51D144EF-40A6-47C4-9535-3A5B6B2D4095}"/>
               </a:ext>
             </a:extLst>
           </p:cNvPr>
@@ -8394,7 +8284,7 @@
           <p:cNvPr id="14" name="">
             <a:extLst xmlns:a="http://schemas.openxmlformats.org/drawingml/2006/main">
               <a:ext uri="{FF2B5EF4-FFF2-40B4-BE49-F238E27FC236}">
-                <a16:creationId xmlns:a16="http://schemas.microsoft.com/office/drawing/2014/main" id="{930552AF-6CDD-4E39-8AF7-74A7BA6174A5}"/>
+                <a16:creationId xmlns:a16="http://schemas.microsoft.com/office/drawing/2014/main" id="{0216AF3B-1CCF-4BD2-AEE6-079937DEBFDD}"/>
               </a:ext>
             </a:extLst>
           </p:cNvPr>
@@ -8452,7 +8342,7 @@
                 <a:ea typeface="Arial"/>
                 <a:cs typeface="Arial"/>
               </a:rPr>
-              <a:t>Результат в карточке Skillaz</a:t>
+              <a:t>Данные в API hh.ru</a:t>
             </a:r>
           </a:p>
         </p:txBody>
@@ -8462,7 +8352,7 @@
           <p:cNvPr id="15" name="">
             <a:extLst xmlns:a="http://schemas.openxmlformats.org/drawingml/2006/main">
               <a:ext uri="{FF2B5EF4-FFF2-40B4-BE49-F238E27FC236}">
-                <a16:creationId xmlns:a16="http://schemas.microsoft.com/office/drawing/2014/main" id="{2894B842-59E1-4A3F-9337-8B4608875811}"/>
+                <a16:creationId xmlns:a16="http://schemas.microsoft.com/office/drawing/2014/main" id="{D70C35D9-4620-4290-8C36-F60E5900BED9}"/>
               </a:ext>
             </a:extLst>
           </p:cNvPr>
@@ -8520,7 +8410,7 @@
                 <a:ea typeface="Arial"/>
                 <a:cs typeface="Arial"/>
               </a:rPr>
-              <a:t>Интеграция передаёт оценку и ответы кандидата.</a:t>
+              <a:t>В примерах ответа на запрос отклика есть оценка и ответы кандидата.</a:t>
             </a:r>
           </a:p>
         </p:txBody>
@@ -8530,7 +8420,7 @@
           <p:cNvPr id="16" name="">
             <a:extLst xmlns:a="http://schemas.openxmlformats.org/drawingml/2006/main">
               <a:ext uri="{FF2B5EF4-FFF2-40B4-BE49-F238E27FC236}">
-                <a16:creationId xmlns:a16="http://schemas.microsoft.com/office/drawing/2014/main" id="{58D276EC-2095-4999-AD7D-6AED5BFAE224}"/>
+                <a16:creationId xmlns:a16="http://schemas.microsoft.com/office/drawing/2014/main" id="{55A0D549-BEE5-4F7B-9E97-B33AA4A6C0AF}"/>
               </a:ext>
             </a:extLst>
           </p:cNvPr>
@@ -8598,7 +8488,7 @@
           <p:cNvPr id="17" name="">
             <a:extLst xmlns:a="http://schemas.openxmlformats.org/drawingml/2006/main">
               <a:ext uri="{FF2B5EF4-FFF2-40B4-BE49-F238E27FC236}">
-                <a16:creationId xmlns:a16="http://schemas.microsoft.com/office/drawing/2014/main" id="{1F4E7FFA-F87C-4D3B-B103-C8837F85B1A2}"/>
+                <a16:creationId xmlns:a16="http://schemas.microsoft.com/office/drawing/2014/main" id="{5A652903-E7B1-46A2-ABA9-065705660D3D}"/>
               </a:ext>
             </a:extLst>
           </p:cNvPr>
@@ -8666,7 +8556,7 @@
           <p:cNvPr id="18" name="">
             <a:extLst xmlns:a="http://schemas.openxmlformats.org/drawingml/2006/main">
               <a:ext uri="{FF2B5EF4-FFF2-40B4-BE49-F238E27FC236}">
-                <a16:creationId xmlns:a16="http://schemas.microsoft.com/office/drawing/2014/main" id="{6923B02B-4F8A-400D-9776-8FA8AA962FE6}"/>
+                <a16:creationId xmlns:a16="http://schemas.microsoft.com/office/drawing/2014/main" id="{D4067FF0-2DCC-4801-9A56-CE7759A89AB0}"/>
               </a:ext>
             </a:extLst>
           </p:cNvPr>
@@ -8732,7 +8622,7 @@
     </p:spTree>
     <p:extLst>
       <p:ext uri="{BB962C8B-B14F-4D97-AF65-F5344CB8AC3E}">
-        <p14:creationId xmlns:p14="http://schemas.microsoft.com/office/powerpoint/2010/main" val="1911813226"/>
+        <p14:creationId xmlns:p14="http://schemas.microsoft.com/office/powerpoint/2010/main" val="1160010293"/>
       </p:ext>
     </p:extLst>
   </p:cSld>
@@ -8763,7 +8653,7 @@
           <p:cNvPr id="13" name="">
             <a:extLst xmlns:a="http://schemas.openxmlformats.org/drawingml/2006/main">
               <a:ext uri="{FF2B5EF4-FFF2-40B4-BE49-F238E27FC236}">
-                <a16:creationId xmlns:a16="http://schemas.microsoft.com/office/drawing/2014/main" id="{D1C90C8E-B34C-48C5-AB7B-6581A47A9134}"/>
+                <a16:creationId xmlns:a16="http://schemas.microsoft.com/office/drawing/2014/main" id="{05C7DC38-44DE-470E-B673-798EA14257C9}"/>
               </a:ext>
             </a:extLst>
           </p:cNvPr>
@@ -8773,7 +8663,7 @@
           <p:nvPr/>
         </p:nvPicPr>
         <p:blipFill>
-          <a:blip xmlns:r="http://schemas.openxmlformats.org/officeDocument/2006/relationships" xmlns:a="http://schemas.openxmlformats.org/drawingml/2006/main" r:embed="R78f81bfd08604061"/>
+          <a:blip xmlns:r="http://schemas.openxmlformats.org/officeDocument/2006/relationships" xmlns:a="http://schemas.openxmlformats.org/drawingml/2006/main" r:embed="Rc54be6a5aaff4865"/>
           <a:stretch xmlns:a="http://schemas.openxmlformats.org/drawingml/2006/main"/>
         </p:blipFill>
         <p:spPr>
@@ -8791,7 +8681,7 @@
           <p:cNvPr id="2" name="">
             <a:extLst xmlns:a="http://schemas.openxmlformats.org/drawingml/2006/main">
               <a:ext uri="{FF2B5EF4-FFF2-40B4-BE49-F238E27FC236}">
-                <a16:creationId xmlns:a16="http://schemas.microsoft.com/office/drawing/2014/main" id="{6CDB3AF7-CC5D-4EB3-97DF-E010EF00D7C1}"/>
+                <a16:creationId xmlns:a16="http://schemas.microsoft.com/office/drawing/2014/main" id="{D12A527E-ADBF-44A6-842D-A27A21659A84}"/>
               </a:ext>
             </a:extLst>
           </p:cNvPr>
@@ -8859,7 +8749,7 @@
           <p:cNvPr id="3" name="">
             <a:extLst xmlns:a="http://schemas.openxmlformats.org/drawingml/2006/main">
               <a:ext uri="{FF2B5EF4-FFF2-40B4-BE49-F238E27FC236}">
-                <a16:creationId xmlns:a16="http://schemas.microsoft.com/office/drawing/2014/main" id="{894C9DA0-C231-4B70-8523-D1E112EDCE73}"/>
+                <a16:creationId xmlns:a16="http://schemas.microsoft.com/office/drawing/2014/main" id="{1CE43011-C359-4002-A113-5D8BCAD8935E}"/>
               </a:ext>
             </a:extLst>
           </p:cNvPr>
@@ -8917,7 +8807,7 @@
                 <a:ea typeface="Arial"/>
                 <a:cs typeface="Arial"/>
               </a:rPr>
-              <a:t>Сразу видно, кого рассматривать первым</a:t>
+              <a:t>Результат разбора и его основания</a:t>
             </a:r>
           </a:p>
         </p:txBody>
@@ -8927,7 +8817,7 @@
           <p:cNvPr id="4" name="">
             <a:extLst xmlns:a="http://schemas.openxmlformats.org/drawingml/2006/main">
               <a:ext uri="{FF2B5EF4-FFF2-40B4-BE49-F238E27FC236}">
-                <a16:creationId xmlns:a16="http://schemas.microsoft.com/office/drawing/2014/main" id="{9DCFFFBC-AF62-45A6-8EB1-281EF2012071}"/>
+                <a16:creationId xmlns:a16="http://schemas.microsoft.com/office/drawing/2014/main" id="{2B2655EA-1B89-4C59-BBD7-D97FBAEA752B}"/>
               </a:ext>
             </a:extLst>
           </p:cNvPr>
@@ -8995,7 +8885,7 @@
           <p:cNvPr id="5" name="">
             <a:extLst xmlns:a="http://schemas.openxmlformats.org/drawingml/2006/main">
               <a:ext uri="{FF2B5EF4-FFF2-40B4-BE49-F238E27FC236}">
-                <a16:creationId xmlns:a16="http://schemas.microsoft.com/office/drawing/2014/main" id="{943F222C-07CA-4823-BE9D-4FC51B9C7B6E}"/>
+                <a16:creationId xmlns:a16="http://schemas.microsoft.com/office/drawing/2014/main" id="{1977D3BF-B0AA-4B99-88D2-A390D5FAA02B}"/>
               </a:ext>
             </a:extLst>
           </p:cNvPr>
@@ -9063,7 +8953,7 @@
           <p:cNvPr id="6" name="">
             <a:extLst xmlns:a="http://schemas.openxmlformats.org/drawingml/2006/main">
               <a:ext uri="{FF2B5EF4-FFF2-40B4-BE49-F238E27FC236}">
-                <a16:creationId xmlns:a16="http://schemas.microsoft.com/office/drawing/2014/main" id="{2B40C25C-36BC-44BE-9FFA-CCD33BB044A2}"/>
+                <a16:creationId xmlns:a16="http://schemas.microsoft.com/office/drawing/2014/main" id="{861280BA-0330-4BE2-9A8E-32315BA3654F}"/>
               </a:ext>
             </a:extLst>
           </p:cNvPr>
@@ -9131,7 +9021,7 @@
           <p:cNvPr id="7" name="">
             <a:extLst xmlns:a="http://schemas.openxmlformats.org/drawingml/2006/main">
               <a:ext uri="{FF2B5EF4-FFF2-40B4-BE49-F238E27FC236}">
-                <a16:creationId xmlns:a16="http://schemas.microsoft.com/office/drawing/2014/main" id="{BF905023-C12E-42BA-B782-DB4978E9006F}"/>
+                <a16:creationId xmlns:a16="http://schemas.microsoft.com/office/drawing/2014/main" id="{9AB390E3-AC19-45F1-BCAF-F7D650FD0879}"/>
               </a:ext>
             </a:extLst>
           </p:cNvPr>
@@ -9141,7 +9031,7 @@
           <p:nvPr/>
         </p:nvPicPr>
         <p:blipFill>
-          <a:blip xmlns:r="http://schemas.openxmlformats.org/officeDocument/2006/relationships" xmlns:a="http://schemas.openxmlformats.org/drawingml/2006/main" r:embed="R3cf7103db92b400d"/>
+          <a:blip xmlns:r="http://schemas.openxmlformats.org/officeDocument/2006/relationships" xmlns:a="http://schemas.openxmlformats.org/drawingml/2006/main" r:embed="Rf02eaa9daf6343a7"/>
           <a:stretch xmlns:a="http://schemas.openxmlformats.org/drawingml/2006/main"/>
         </p:blipFill>
         <p:spPr>
@@ -9159,7 +9049,7 @@
           <p:cNvPr id="8" name="">
             <a:extLst xmlns:a="http://schemas.openxmlformats.org/drawingml/2006/main">
               <a:ext uri="{FF2B5EF4-FFF2-40B4-BE49-F238E27FC236}">
-                <a16:creationId xmlns:a16="http://schemas.microsoft.com/office/drawing/2014/main" id="{E0CA59CB-0D0C-4F06-A839-AB4B639DF092}"/>
+                <a16:creationId xmlns:a16="http://schemas.microsoft.com/office/drawing/2014/main" id="{B28664A7-B273-4097-B30F-74026BA1258A}"/>
               </a:ext>
             </a:extLst>
           </p:cNvPr>
@@ -9227,7 +9117,7 @@
           <p:cNvPr id="9" name="">
             <a:extLst xmlns:a="http://schemas.openxmlformats.org/drawingml/2006/main">
               <a:ext uri="{FF2B5EF4-FFF2-40B4-BE49-F238E27FC236}">
-                <a16:creationId xmlns:a16="http://schemas.microsoft.com/office/drawing/2014/main" id="{EEEE9B73-088C-49FE-B4F7-CB6A197A8108}"/>
+                <a16:creationId xmlns:a16="http://schemas.microsoft.com/office/drawing/2014/main" id="{582B48CA-55D3-4974-9E7E-0E498690DE3D}"/>
               </a:ext>
             </a:extLst>
           </p:cNvPr>
@@ -9318,7 +9208,7 @@
           <p:cNvPr id="10" name="">
             <a:extLst xmlns:a="http://schemas.openxmlformats.org/drawingml/2006/main">
               <a:ext uri="{FF2B5EF4-FFF2-40B4-BE49-F238E27FC236}">
-                <a16:creationId xmlns:a16="http://schemas.microsoft.com/office/drawing/2014/main" id="{3EDBBE64-6191-4D18-8F7C-A562439D89DF}"/>
+                <a16:creationId xmlns:a16="http://schemas.microsoft.com/office/drawing/2014/main" id="{4890887D-038B-4702-BB33-44961A024201}"/>
               </a:ext>
             </a:extLst>
           </p:cNvPr>
@@ -9386,7 +9276,7 @@
           <p:cNvPr id="11" name="">
             <a:extLst xmlns:a="http://schemas.openxmlformats.org/drawingml/2006/main">
               <a:ext uri="{FF2B5EF4-FFF2-40B4-BE49-F238E27FC236}">
-                <a16:creationId xmlns:a16="http://schemas.microsoft.com/office/drawing/2014/main" id="{8E9F6C45-9D05-4E7C-B243-78AE0EBF3500}"/>
+                <a16:creationId xmlns:a16="http://schemas.microsoft.com/office/drawing/2014/main" id="{C31356BA-2ABC-455A-A378-4D6BC4EC47F5}"/>
               </a:ext>
             </a:extLst>
           </p:cNvPr>
@@ -9477,7 +9367,7 @@
           <p:cNvPr id="12" name="">
             <a:extLst xmlns:a="http://schemas.openxmlformats.org/drawingml/2006/main">
               <a:ext uri="{FF2B5EF4-FFF2-40B4-BE49-F238E27FC236}">
-                <a16:creationId xmlns:a16="http://schemas.microsoft.com/office/drawing/2014/main" id="{0A931F36-91EB-49A4-BE0D-DDED56D9F8DE}"/>
+                <a16:creationId xmlns:a16="http://schemas.microsoft.com/office/drawing/2014/main" id="{5248DA57-F17A-439C-B693-4E8064CD59A5}"/>
               </a:ext>
             </a:extLst>
           </p:cNvPr>
@@ -9535,7 +9425,7 @@
                 <a:ea typeface="Arial"/>
                 <a:cs typeface="Arial"/>
               </a:rPr>
-              <a:t>Категория помогает ориентироваться. Решение остаётся за рекрутёром.</a:t>
+              <a:t>Иллюстрация из исходной презентации. Решение принимает рекрутёр.</a:t>
             </a:r>
           </a:p>
         </p:txBody>
@@ -9543,7 +9433,7 @@
     </p:spTree>
     <p:extLst>
       <p:ext uri="{BB962C8B-B14F-4D97-AF65-F5344CB8AC3E}">
-        <p14:creationId xmlns:p14="http://schemas.microsoft.com/office/powerpoint/2010/main" val="794746439"/>
+        <p14:creationId xmlns:p14="http://schemas.microsoft.com/office/powerpoint/2010/main" val="961685203"/>
       </p:ext>
     </p:extLst>
   </p:cSld>
@@ -9574,7 +9464,7 @@
           <p:cNvPr id="18" name="">
             <a:extLst xmlns:a="http://schemas.openxmlformats.org/drawingml/2006/main">
               <a:ext uri="{FF2B5EF4-FFF2-40B4-BE49-F238E27FC236}">
-                <a16:creationId xmlns:a16="http://schemas.microsoft.com/office/drawing/2014/main" id="{B2ADD92A-5680-4606-A76F-EF6BEA8EC770}"/>
+                <a16:creationId xmlns:a16="http://schemas.microsoft.com/office/drawing/2014/main" id="{D76F5143-3BC6-470D-BA67-57B2F0C18366}"/>
               </a:ext>
             </a:extLst>
           </p:cNvPr>
@@ -9584,7 +9474,7 @@
           <p:nvPr/>
         </p:nvPicPr>
         <p:blipFill>
-          <a:blip xmlns:r="http://schemas.openxmlformats.org/officeDocument/2006/relationships" xmlns:a="http://schemas.openxmlformats.org/drawingml/2006/main" r:embed="Ra4ad52ac18ce45ab"/>
+          <a:blip xmlns:r="http://schemas.openxmlformats.org/officeDocument/2006/relationships" xmlns:a="http://schemas.openxmlformats.org/drawingml/2006/main" r:embed="Rde5ba37cf19d43af"/>
           <a:stretch xmlns:a="http://schemas.openxmlformats.org/drawingml/2006/main"/>
         </p:blipFill>
         <p:spPr>
@@ -9602,7 +9492,7 @@
           <p:cNvPr id="2" name="">
             <a:extLst xmlns:a="http://schemas.openxmlformats.org/drawingml/2006/main">
               <a:ext uri="{FF2B5EF4-FFF2-40B4-BE49-F238E27FC236}">
-                <a16:creationId xmlns:a16="http://schemas.microsoft.com/office/drawing/2014/main" id="{C77A4839-C2CF-4C30-9346-B773E32E34AB}"/>
+                <a16:creationId xmlns:a16="http://schemas.microsoft.com/office/drawing/2014/main" id="{5A8F4053-F8A9-448F-BC70-DBE4B0490416}"/>
               </a:ext>
             </a:extLst>
           </p:cNvPr>
@@ -9670,7 +9560,7 @@
           <p:cNvPr id="3" name="">
             <a:extLst xmlns:a="http://schemas.openxmlformats.org/drawingml/2006/main">
               <a:ext uri="{FF2B5EF4-FFF2-40B4-BE49-F238E27FC236}">
-                <a16:creationId xmlns:a16="http://schemas.microsoft.com/office/drawing/2014/main" id="{74052D26-2147-4CED-88E5-83EC2259A1E1}"/>
+                <a16:creationId xmlns:a16="http://schemas.microsoft.com/office/drawing/2014/main" id="{A184AE56-6168-4A30-9843-109768C8BE3A}"/>
               </a:ext>
             </a:extLst>
           </p:cNvPr>
@@ -9728,7 +9618,7 @@
                 <a:ea typeface="Arial"/>
                 <a:cs typeface="Arial"/>
               </a:rPr>
-              <a:t>Ответы кандидата</a:t>
+              <a:t>Вопросы и ответы</a:t>
             </a:r>
           </a:p>
           <a:p xmlns:a="http://schemas.openxmlformats.org/drawingml/2006/main">
@@ -9751,7 +9641,7 @@
                 <a:ea typeface="Arial"/>
                 <a:cs typeface="Arial"/>
               </a:rPr>
-              <a:t>становятся данными карточки</a:t>
+              <a:t>в результатах доопроса</a:t>
             </a:r>
           </a:p>
         </p:txBody>
@@ -9761,7 +9651,7 @@
           <p:cNvPr id="4" name="">
             <a:extLst xmlns:a="http://schemas.openxmlformats.org/drawingml/2006/main">
               <a:ext uri="{FF2B5EF4-FFF2-40B4-BE49-F238E27FC236}">
-                <a16:creationId xmlns:a16="http://schemas.microsoft.com/office/drawing/2014/main" id="{1A71FC46-DA05-47F3-9F9D-1AD996D7EC32}"/>
+                <a16:creationId xmlns:a16="http://schemas.microsoft.com/office/drawing/2014/main" id="{E945F930-A7D5-4DB2-8097-AB6E20F64FA2}"/>
               </a:ext>
             </a:extLst>
           </p:cNvPr>
@@ -9829,7 +9719,7 @@
           <p:cNvPr id="5" name="">
             <a:extLst xmlns:a="http://schemas.openxmlformats.org/drawingml/2006/main">
               <a:ext uri="{FF2B5EF4-FFF2-40B4-BE49-F238E27FC236}">
-                <a16:creationId xmlns:a16="http://schemas.microsoft.com/office/drawing/2014/main" id="{7E9F9218-9643-4DD6-80AC-0BDCC4A03F15}"/>
+                <a16:creationId xmlns:a16="http://schemas.microsoft.com/office/drawing/2014/main" id="{57B3F2B9-AC5A-4AB8-9BB3-B9704824BED7}"/>
               </a:ext>
             </a:extLst>
           </p:cNvPr>
@@ -9897,7 +9787,7 @@
           <p:cNvPr id="6" name="">
             <a:extLst xmlns:a="http://schemas.openxmlformats.org/drawingml/2006/main">
               <a:ext uri="{FF2B5EF4-FFF2-40B4-BE49-F238E27FC236}">
-                <a16:creationId xmlns:a16="http://schemas.microsoft.com/office/drawing/2014/main" id="{AE4B15EA-5B0C-4805-B984-7C670CCC2610}"/>
+                <a16:creationId xmlns:a16="http://schemas.microsoft.com/office/drawing/2014/main" id="{7E704116-990A-4947-A3AC-642208209F72}"/>
               </a:ext>
             </a:extLst>
           </p:cNvPr>
@@ -9965,7 +9855,7 @@
           <p:cNvPr id="7" name="">
             <a:extLst xmlns:a="http://schemas.openxmlformats.org/drawingml/2006/main">
               <a:ext uri="{FF2B5EF4-FFF2-40B4-BE49-F238E27FC236}">
-                <a16:creationId xmlns:a16="http://schemas.microsoft.com/office/drawing/2014/main" id="{9D78D701-969A-4E1B-B0EB-F7D37494CAA6}"/>
+                <a16:creationId xmlns:a16="http://schemas.microsoft.com/office/drawing/2014/main" id="{B9691FE8-5B5D-457A-8B23-C420B807A73A}"/>
               </a:ext>
             </a:extLst>
           </p:cNvPr>
@@ -10033,7 +9923,7 @@
           <p:cNvPr id="8" name="">
             <a:extLst xmlns:a="http://schemas.openxmlformats.org/drawingml/2006/main">
               <a:ext uri="{FF2B5EF4-FFF2-40B4-BE49-F238E27FC236}">
-                <a16:creationId xmlns:a16="http://schemas.microsoft.com/office/drawing/2014/main" id="{5D037949-D83E-4F81-90B0-8CD256D7FB4F}"/>
+                <a16:creationId xmlns:a16="http://schemas.microsoft.com/office/drawing/2014/main" id="{6426D026-A42F-48DD-A2DD-D8313D72F8E2}"/>
               </a:ext>
             </a:extLst>
           </p:cNvPr>
@@ -10063,7 +9953,7 @@
           <p:cNvPr id="9" name="">
             <a:extLst xmlns:a="http://schemas.openxmlformats.org/drawingml/2006/main">
               <a:ext uri="{FF2B5EF4-FFF2-40B4-BE49-F238E27FC236}">
-                <a16:creationId xmlns:a16="http://schemas.microsoft.com/office/drawing/2014/main" id="{AB74E4E2-3848-41E0-8127-A6AC77F80818}"/>
+                <a16:creationId xmlns:a16="http://schemas.microsoft.com/office/drawing/2014/main" id="{3A4C615F-DE81-41DD-9D58-A6F97C9D6271}"/>
               </a:ext>
             </a:extLst>
           </p:cNvPr>
@@ -10154,7 +10044,7 @@
           <p:cNvPr id="10" name="">
             <a:extLst xmlns:a="http://schemas.openxmlformats.org/drawingml/2006/main">
               <a:ext uri="{FF2B5EF4-FFF2-40B4-BE49-F238E27FC236}">
-                <a16:creationId xmlns:a16="http://schemas.microsoft.com/office/drawing/2014/main" id="{68D91425-BBA0-4B4F-9B33-F634338413F4}"/>
+                <a16:creationId xmlns:a16="http://schemas.microsoft.com/office/drawing/2014/main" id="{F558976E-D69E-4B62-883F-4F0A0A6FB983}"/>
               </a:ext>
             </a:extLst>
           </p:cNvPr>
@@ -10222,7 +10112,7 @@
           <p:cNvPr id="11" name="">
             <a:extLst xmlns:a="http://schemas.openxmlformats.org/drawingml/2006/main">
               <a:ext uri="{FF2B5EF4-FFF2-40B4-BE49-F238E27FC236}">
-                <a16:creationId xmlns:a16="http://schemas.microsoft.com/office/drawing/2014/main" id="{E6D6FFD6-2CCE-470A-85DC-B79DBDAC3503}"/>
+                <a16:creationId xmlns:a16="http://schemas.microsoft.com/office/drawing/2014/main" id="{E0599A78-A22E-40B0-A277-3C0ED558B0D6}"/>
               </a:ext>
             </a:extLst>
           </p:cNvPr>
@@ -10252,7 +10142,7 @@
           <p:cNvPr id="12" name="">
             <a:extLst xmlns:a="http://schemas.openxmlformats.org/drawingml/2006/main">
               <a:ext uri="{FF2B5EF4-FFF2-40B4-BE49-F238E27FC236}">
-                <a16:creationId xmlns:a16="http://schemas.microsoft.com/office/drawing/2014/main" id="{3B6487EA-8BB7-4415-B566-930CE8A0D007}"/>
+                <a16:creationId xmlns:a16="http://schemas.microsoft.com/office/drawing/2014/main" id="{3534DB80-EDA6-4EA2-B4D8-6D91668B55DB}"/>
               </a:ext>
             </a:extLst>
           </p:cNvPr>
@@ -10343,7 +10233,7 @@
           <p:cNvPr id="13" name="">
             <a:extLst xmlns:a="http://schemas.openxmlformats.org/drawingml/2006/main">
               <a:ext uri="{FF2B5EF4-FFF2-40B4-BE49-F238E27FC236}">
-                <a16:creationId xmlns:a16="http://schemas.microsoft.com/office/drawing/2014/main" id="{7988BC30-7B4E-49AB-B122-BD627873A2AE}"/>
+                <a16:creationId xmlns:a16="http://schemas.microsoft.com/office/drawing/2014/main" id="{3B649582-37CF-4F0C-9DB3-2BF378CD69E2}"/>
               </a:ext>
             </a:extLst>
           </p:cNvPr>
@@ -10401,7 +10291,7 @@
                 <a:ea typeface="Courier New"/>
                 <a:cs typeface="Courier New"/>
               </a:rPr>
-              <a:t>КАРТОЧКА SKILLAZ</a:t>
+              <a:t>ДАННЫЕ В API HH.RU</a:t>
             </a:r>
           </a:p>
         </p:txBody>
@@ -10411,7 +10301,7 @@
           <p:cNvPr id="14" name="">
             <a:extLst xmlns:a="http://schemas.openxmlformats.org/drawingml/2006/main">
               <a:ext uri="{FF2B5EF4-FFF2-40B4-BE49-F238E27FC236}">
-                <a16:creationId xmlns:a16="http://schemas.microsoft.com/office/drawing/2014/main" id="{830D0BB2-0C4B-4723-884B-BC789CFD9316}"/>
+                <a16:creationId xmlns:a16="http://schemas.microsoft.com/office/drawing/2014/main" id="{4BA46C69-22BF-4EE9-A478-90663DAF51EA}"/>
               </a:ext>
             </a:extLst>
           </p:cNvPr>
@@ -10441,7 +10331,7 @@
           <p:cNvPr id="15" name="">
             <a:extLst xmlns:a="http://schemas.openxmlformats.org/drawingml/2006/main">
               <a:ext uri="{FF2B5EF4-FFF2-40B4-BE49-F238E27FC236}">
-                <a16:creationId xmlns:a16="http://schemas.microsoft.com/office/drawing/2014/main" id="{C967BB88-E292-4D5C-8C08-BFA5F4D0FC1E}"/>
+                <a16:creationId xmlns:a16="http://schemas.microsoft.com/office/drawing/2014/main" id="{01C82F41-562F-48DC-BA47-D949DA61344D}"/>
               </a:ext>
             </a:extLst>
           </p:cNvPr>
@@ -10499,7 +10389,7 @@
                 <a:ea typeface="Arial"/>
                 <a:cs typeface="Arial"/>
               </a:rPr>
-              <a:t>Готовность</a:t>
+              <a:t>Вопрос</a:t>
             </a:r>
           </a:p>
           <a:p xmlns:a="http://schemas.openxmlformats.org/drawingml/2006/main">
@@ -10522,7 +10412,7 @@
                 <a:ea typeface="Arial"/>
                 <a:cs typeface="Arial"/>
               </a:rPr>
-              <a:t>к графику: да</a:t>
+              <a:t>и цитата ответа</a:t>
             </a:r>
           </a:p>
         </p:txBody>
@@ -10532,7 +10422,7 @@
           <p:cNvPr id="16" name="">
             <a:extLst xmlns:a="http://schemas.openxmlformats.org/drawingml/2006/main">
               <a:ext uri="{FF2B5EF4-FFF2-40B4-BE49-F238E27FC236}">
-                <a16:creationId xmlns:a16="http://schemas.microsoft.com/office/drawing/2014/main" id="{B8899BBC-0D86-4F32-8C9B-CAA477F5522E}"/>
+                <a16:creationId xmlns:a16="http://schemas.microsoft.com/office/drawing/2014/main" id="{B246132B-A699-4163-B69E-57B9E572B756}"/>
               </a:ext>
             </a:extLst>
           </p:cNvPr>
@@ -10600,7 +10490,7 @@
           <p:cNvPr id="17" name="">
             <a:extLst xmlns:a="http://schemas.openxmlformats.org/drawingml/2006/main">
               <a:ext uri="{FF2B5EF4-FFF2-40B4-BE49-F238E27FC236}">
-                <a16:creationId xmlns:a16="http://schemas.microsoft.com/office/drawing/2014/main" id="{51955DA4-7968-45E6-BFF9-B0A786C2ABAF}"/>
+                <a16:creationId xmlns:a16="http://schemas.microsoft.com/office/drawing/2014/main" id="{1162DF9A-691B-4443-9765-AAC49EE706F5}"/>
               </a:ext>
             </a:extLst>
           </p:cNvPr>
@@ -10658,7 +10548,7 @@
                 <a:ea typeface="Arial"/>
                 <a:cs typeface="Arial"/>
               </a:rPr>
-              <a:t>Меньше повторного ввода. Больше информации для следующего разговора.</a:t>
+              <a:t>В примере API ответ сохраняется вместе с вопросом работодателя.</a:t>
             </a:r>
           </a:p>
         </p:txBody>
@@ -10666,7 +10556,7 @@
     </p:spTree>
     <p:extLst>
       <p:ext uri="{BB962C8B-B14F-4D97-AF65-F5344CB8AC3E}">
-        <p14:creationId xmlns:p14="http://schemas.microsoft.com/office/powerpoint/2010/main" val="755804390"/>
+        <p14:creationId xmlns:p14="http://schemas.microsoft.com/office/powerpoint/2010/main" val="1594044486"/>
       </p:ext>
     </p:extLst>
   </p:cSld>
@@ -10697,7 +10587,7 @@
           <p:cNvPr id="17" name="">
             <a:extLst xmlns:a="http://schemas.openxmlformats.org/drawingml/2006/main">
               <a:ext uri="{FF2B5EF4-FFF2-40B4-BE49-F238E27FC236}">
-                <a16:creationId xmlns:a16="http://schemas.microsoft.com/office/drawing/2014/main" id="{F7825342-EEFF-4F74-8B9B-6814205B8CC0}"/>
+                <a16:creationId xmlns:a16="http://schemas.microsoft.com/office/drawing/2014/main" id="{F02CC885-3CC9-4A36-B75A-8C2C349D04F8}"/>
               </a:ext>
             </a:extLst>
           </p:cNvPr>
@@ -10707,7 +10597,7 @@
           <p:nvPr/>
         </p:nvPicPr>
         <p:blipFill>
-          <a:blip xmlns:r="http://schemas.openxmlformats.org/officeDocument/2006/relationships" xmlns:a="http://schemas.openxmlformats.org/drawingml/2006/main" r:embed="R6b3203b43de04ff2"/>
+          <a:blip xmlns:r="http://schemas.openxmlformats.org/officeDocument/2006/relationships" xmlns:a="http://schemas.openxmlformats.org/drawingml/2006/main" r:embed="Rea4ac867d89c40cb"/>
           <a:stretch xmlns:a="http://schemas.openxmlformats.org/drawingml/2006/main"/>
         </p:blipFill>
         <p:spPr>
@@ -10725,7 +10615,7 @@
           <p:cNvPr id="2" name="">
             <a:extLst xmlns:a="http://schemas.openxmlformats.org/drawingml/2006/main">
               <a:ext uri="{FF2B5EF4-FFF2-40B4-BE49-F238E27FC236}">
-                <a16:creationId xmlns:a16="http://schemas.microsoft.com/office/drawing/2014/main" id="{88051AB6-E668-430D-B70E-8EEE274E2EBF}"/>
+                <a16:creationId xmlns:a16="http://schemas.microsoft.com/office/drawing/2014/main" id="{2E760800-336F-48DE-A6CA-DA18F7C2D536}"/>
               </a:ext>
             </a:extLst>
           </p:cNvPr>
@@ -10783,7 +10673,7 @@
                 <a:ea typeface="Courier New"/>
                 <a:cs typeface="Courier New"/>
               </a:rPr>
-              <a:t>КОНТРОЛЬ КОМАНДЫ</a:t>
+              <a:t>ОСНОВАНИЯ ОЦЕНКИ</a:t>
             </a:r>
           </a:p>
         </p:txBody>
@@ -10793,7 +10683,7 @@
           <p:cNvPr id="3" name="">
             <a:extLst xmlns:a="http://schemas.openxmlformats.org/drawingml/2006/main">
               <a:ext uri="{FF2B5EF4-FFF2-40B4-BE49-F238E27FC236}">
-                <a16:creationId xmlns:a16="http://schemas.microsoft.com/office/drawing/2014/main" id="{A30EFB10-400F-42DD-B78F-9728E0E14F72}"/>
+                <a16:creationId xmlns:a16="http://schemas.microsoft.com/office/drawing/2014/main" id="{6B60B848-5F39-44B6-BFD5-A19C8A1B0811}"/>
               </a:ext>
             </a:extLst>
           </p:cNvPr>
@@ -10851,7 +10741,7 @@
                 <a:ea typeface="Arial"/>
                 <a:cs typeface="Arial"/>
               </a:rPr>
-              <a:t>Решения команды остаются видимыми</a:t>
+              <a:t>Что объясняет оценку кандидата</a:t>
             </a:r>
           </a:p>
         </p:txBody>
@@ -10861,7 +10751,7 @@
           <p:cNvPr id="4" name="">
             <a:extLst xmlns:a="http://schemas.openxmlformats.org/drawingml/2006/main">
               <a:ext uri="{FF2B5EF4-FFF2-40B4-BE49-F238E27FC236}">
-                <a16:creationId xmlns:a16="http://schemas.microsoft.com/office/drawing/2014/main" id="{836F2514-0A36-4FF2-9AEB-041ACF9CBE4C}"/>
+                <a16:creationId xmlns:a16="http://schemas.microsoft.com/office/drawing/2014/main" id="{646BBAF3-79E2-4E06-B6B0-D8E476CF9F77}"/>
               </a:ext>
             </a:extLst>
           </p:cNvPr>
@@ -10929,7 +10819,7 @@
           <p:cNvPr id="5" name="">
             <a:extLst xmlns:a="http://schemas.openxmlformats.org/drawingml/2006/main">
               <a:ext uri="{FF2B5EF4-FFF2-40B4-BE49-F238E27FC236}">
-                <a16:creationId xmlns:a16="http://schemas.microsoft.com/office/drawing/2014/main" id="{1E9C5EBE-CFC4-4A1D-B369-F1AC4E7310AE}"/>
+                <a16:creationId xmlns:a16="http://schemas.microsoft.com/office/drawing/2014/main" id="{7C801FB1-5BBD-47C3-ACBC-DCBB7C517BDB}"/>
               </a:ext>
             </a:extLst>
           </p:cNvPr>
@@ -10997,7 +10887,7 @@
           <p:cNvPr id="6" name="">
             <a:extLst xmlns:a="http://schemas.openxmlformats.org/drawingml/2006/main">
               <a:ext uri="{FF2B5EF4-FFF2-40B4-BE49-F238E27FC236}">
-                <a16:creationId xmlns:a16="http://schemas.microsoft.com/office/drawing/2014/main" id="{7D00EB36-940E-4FAB-BC09-03B17AE0DEA7}"/>
+                <a16:creationId xmlns:a16="http://schemas.microsoft.com/office/drawing/2014/main" id="{B67D89B2-2423-45BC-A69A-0F844DAF42DF}"/>
               </a:ext>
             </a:extLst>
           </p:cNvPr>
@@ -11065,7 +10955,7 @@
           <p:cNvPr id="7" name="">
             <a:extLst xmlns:a="http://schemas.openxmlformats.org/drawingml/2006/main">
               <a:ext uri="{FF2B5EF4-FFF2-40B4-BE49-F238E27FC236}">
-                <a16:creationId xmlns:a16="http://schemas.microsoft.com/office/drawing/2014/main" id="{26795BEB-6F2B-4000-8A22-4364A16C01CE}"/>
+                <a16:creationId xmlns:a16="http://schemas.microsoft.com/office/drawing/2014/main" id="{ADC4869F-7EFC-423E-B4D4-FE5D92044F8E}"/>
               </a:ext>
             </a:extLst>
           </p:cNvPr>
@@ -11075,7 +10965,7 @@
           <p:nvPr/>
         </p:nvPicPr>
         <p:blipFill>
-          <a:blip xmlns:r="http://schemas.openxmlformats.org/officeDocument/2006/relationships" xmlns:a="http://schemas.openxmlformats.org/drawingml/2006/main" r:embed="R5a6b269a29b54b5c"/>
+          <a:blip xmlns:r="http://schemas.openxmlformats.org/officeDocument/2006/relationships" xmlns:a="http://schemas.openxmlformats.org/drawingml/2006/main" r:embed="R4e020c2a4942481e"/>
           <a:stretch xmlns:a="http://schemas.openxmlformats.org/drawingml/2006/main"/>
         </p:blipFill>
         <p:spPr>
@@ -11093,7 +10983,7 @@
           <p:cNvPr id="8" name="">
             <a:extLst xmlns:a="http://schemas.openxmlformats.org/drawingml/2006/main">
               <a:ext uri="{FF2B5EF4-FFF2-40B4-BE49-F238E27FC236}">
-                <a16:creationId xmlns:a16="http://schemas.microsoft.com/office/drawing/2014/main" id="{A2F81E4D-0618-4ECD-90D0-11EE23F8754A}"/>
+                <a16:creationId xmlns:a16="http://schemas.microsoft.com/office/drawing/2014/main" id="{03EDC815-8B23-4811-8EAC-C7394839C1B9}"/>
               </a:ext>
             </a:extLst>
           </p:cNvPr>
@@ -11151,7 +11041,7 @@
                 <a:ea typeface="Arial"/>
                 <a:cs typeface="Arial"/>
               </a:rPr>
-              <a:t>Проверка и ручной выбор</a:t>
+              <a:t>Проверка оснований</a:t>
             </a:r>
           </a:p>
         </p:txBody>
@@ -11161,7 +11051,7 @@
           <p:cNvPr id="9" name="">
             <a:extLst xmlns:a="http://schemas.openxmlformats.org/drawingml/2006/main">
               <a:ext uri="{FF2B5EF4-FFF2-40B4-BE49-F238E27FC236}">
-                <a16:creationId xmlns:a16="http://schemas.microsoft.com/office/drawing/2014/main" id="{20388924-577B-4041-89C0-6B1BB6BB6A36}"/>
+                <a16:creationId xmlns:a16="http://schemas.microsoft.com/office/drawing/2014/main" id="{7DAD2CFD-5D6F-4025-9E1C-49E7D93AFA40}"/>
               </a:ext>
             </a:extLst>
           </p:cNvPr>
@@ -11219,7 +11109,7 @@
                 <a:ea typeface="Arial"/>
                 <a:cs typeface="Arial"/>
               </a:rPr>
-              <a:t>Рекрутёр изучает основания оценки</a:t>
+              <a:t>Иллюстрация из исходной презентации.</a:t>
             </a:r>
           </a:p>
           <a:p xmlns:a="http://schemas.openxmlformats.org/drawingml/2006/main">
@@ -11242,7 +11132,7 @@
                 <a:ea typeface="Arial"/>
                 <a:cs typeface="Arial"/>
               </a:rPr>
-              <a:t>и при необходимости меняет категорию.</a:t>
+              <a:t>Рекрутёр проверяет выводы ИИ.</a:t>
             </a:r>
           </a:p>
         </p:txBody>
@@ -11252,7 +11142,7 @@
           <p:cNvPr id="10" name="">
             <a:extLst xmlns:a="http://schemas.openxmlformats.org/drawingml/2006/main">
               <a:ext uri="{FF2B5EF4-FFF2-40B4-BE49-F238E27FC236}">
-                <a16:creationId xmlns:a16="http://schemas.microsoft.com/office/drawing/2014/main" id="{4DC4D547-5E58-45C2-A3FE-A4911BFE57C6}"/>
+                <a16:creationId xmlns:a16="http://schemas.microsoft.com/office/drawing/2014/main" id="{443A5491-F5DF-4771-808F-32C5D7B4EE44}"/>
               </a:ext>
             </a:extLst>
           </p:cNvPr>
@@ -11310,7 +11200,7 @@
                 <a:ea typeface="Courier New"/>
                 <a:cs typeface="Courier New"/>
               </a:rPr>
-              <a:t>ИСТОРИЯ ИЗМЕНЕНИЙ</a:t>
+              <a:t>ДАННЫЕ ПО КРИТЕРИЮ</a:t>
             </a:r>
           </a:p>
         </p:txBody>
@@ -11320,7 +11210,7 @@
           <p:cNvPr id="11" name="">
             <a:extLst xmlns:a="http://schemas.openxmlformats.org/drawingml/2006/main">
               <a:ext uri="{FF2B5EF4-FFF2-40B4-BE49-F238E27FC236}">
-                <a16:creationId xmlns:a16="http://schemas.microsoft.com/office/drawing/2014/main" id="{81C1FA1D-863E-48B9-A2C1-C0C6E69518C8}"/>
+                <a16:creationId xmlns:a16="http://schemas.microsoft.com/office/drawing/2014/main" id="{D4A35D20-4694-4BB1-BDB7-F688CF0ADC8D}"/>
               </a:ext>
             </a:extLst>
           </p:cNvPr>
@@ -11388,7 +11278,7 @@
           <p:cNvPr id="12" name="">
             <a:extLst xmlns:a="http://schemas.openxmlformats.org/drawingml/2006/main">
               <a:ext uri="{FF2B5EF4-FFF2-40B4-BE49-F238E27FC236}">
-                <a16:creationId xmlns:a16="http://schemas.microsoft.com/office/drawing/2014/main" id="{E47767CF-03C1-483E-8A1E-A61550517C3C}"/>
+                <a16:creationId xmlns:a16="http://schemas.microsoft.com/office/drawing/2014/main" id="{57449519-C932-4238-9FD3-C3D1368B5306}"/>
               </a:ext>
             </a:extLst>
           </p:cNvPr>
@@ -11446,7 +11336,7 @@
                 <a:ea typeface="Arial"/>
                 <a:cs typeface="Arial"/>
               </a:rPr>
-              <a:t>Получена оценка ИИ</a:t>
+              <a:t>Выполнение требования</a:t>
             </a:r>
           </a:p>
         </p:txBody>
@@ -11456,7 +11346,7 @@
           <p:cNvPr id="13" name="">
             <a:extLst xmlns:a="http://schemas.openxmlformats.org/drawingml/2006/main">
               <a:ext uri="{FF2B5EF4-FFF2-40B4-BE49-F238E27FC236}">
-                <a16:creationId xmlns:a16="http://schemas.microsoft.com/office/drawing/2014/main" id="{635D9A68-1FBD-411D-95C9-60E389BE5C7A}"/>
+                <a16:creationId xmlns:a16="http://schemas.microsoft.com/office/drawing/2014/main" id="{D538FD4D-6CB4-4EEA-939A-AED78C6D0FAA}"/>
               </a:ext>
             </a:extLst>
           </p:cNvPr>
@@ -11524,7 +11414,7 @@
           <p:cNvPr id="14" name="">
             <a:extLst xmlns:a="http://schemas.openxmlformats.org/drawingml/2006/main">
               <a:ext uri="{FF2B5EF4-FFF2-40B4-BE49-F238E27FC236}">
-                <a16:creationId xmlns:a16="http://schemas.microsoft.com/office/drawing/2014/main" id="{7B954D3B-A315-4D49-A125-C838CECBC261}"/>
+                <a16:creationId xmlns:a16="http://schemas.microsoft.com/office/drawing/2014/main" id="{96B85803-D6AC-4BE0-AF65-E83080A0108C}"/>
               </a:ext>
             </a:extLst>
           </p:cNvPr>
@@ -11582,7 +11472,7 @@
                 <a:ea typeface="Arial"/>
                 <a:cs typeface="Arial"/>
               </a:rPr>
-              <a:t>Изменена категория</a:t>
+              <a:t>Объяснение оценки</a:t>
             </a:r>
           </a:p>
         </p:txBody>
@@ -11592,7 +11482,7 @@
           <p:cNvPr id="15" name="">
             <a:extLst xmlns:a="http://schemas.openxmlformats.org/drawingml/2006/main">
               <a:ext uri="{FF2B5EF4-FFF2-40B4-BE49-F238E27FC236}">
-                <a16:creationId xmlns:a16="http://schemas.microsoft.com/office/drawing/2014/main" id="{BB9A05A6-CFE0-4889-929E-A99DBDB5ABDC}"/>
+                <a16:creationId xmlns:a16="http://schemas.microsoft.com/office/drawing/2014/main" id="{F3019DA8-C984-4A06-AB00-8BBAD9392962}"/>
               </a:ext>
             </a:extLst>
           </p:cNvPr>
@@ -11660,7 +11550,7 @@
           <p:cNvPr id="16" name="">
             <a:extLst xmlns:a="http://schemas.openxmlformats.org/drawingml/2006/main">
               <a:ext uri="{FF2B5EF4-FFF2-40B4-BE49-F238E27FC236}">
-                <a16:creationId xmlns:a16="http://schemas.microsoft.com/office/drawing/2014/main" id="{3E9AA808-AABF-4B54-9D4B-FF15FF8A22B5}"/>
+                <a16:creationId xmlns:a16="http://schemas.microsoft.com/office/drawing/2014/main" id="{917FB0FC-AF1D-4B56-9CF6-62C0651A2B91}"/>
               </a:ext>
             </a:extLst>
           </p:cNvPr>
@@ -11718,7 +11608,7 @@
                 <a:ea typeface="Arial"/>
                 <a:cs typeface="Arial"/>
               </a:rPr>
-              <a:t>Обновлены критерии</a:t>
+              <a:t>Источник информации</a:t>
             </a:r>
           </a:p>
         </p:txBody>
@@ -11726,7 +11616,7 @@
     </p:spTree>
     <p:extLst>
       <p:ext uri="{BB962C8B-B14F-4D97-AF65-F5344CB8AC3E}">
-        <p14:creationId xmlns:p14="http://schemas.microsoft.com/office/powerpoint/2010/main" val="1566474429"/>
+        <p14:creationId xmlns:p14="http://schemas.microsoft.com/office/powerpoint/2010/main" val="1121940552"/>
       </p:ext>
     </p:extLst>
   </p:cSld>
@@ -11757,7 +11647,7 @@
           <p:cNvPr id="11" name="">
             <a:extLst xmlns:a="http://schemas.openxmlformats.org/drawingml/2006/main">
               <a:ext uri="{FF2B5EF4-FFF2-40B4-BE49-F238E27FC236}">
-                <a16:creationId xmlns:a16="http://schemas.microsoft.com/office/drawing/2014/main" id="{822EA993-96DE-429C-8409-C52E56609618}"/>
+                <a16:creationId xmlns:a16="http://schemas.microsoft.com/office/drawing/2014/main" id="{E54FA2A6-536F-4382-AC8A-1A90ACCA6AC0}"/>
               </a:ext>
             </a:extLst>
           </p:cNvPr>
@@ -11767,7 +11657,7 @@
           <p:nvPr/>
         </p:nvPicPr>
         <p:blipFill>
-          <a:blip xmlns:r="http://schemas.openxmlformats.org/officeDocument/2006/relationships" xmlns:a="http://schemas.openxmlformats.org/drawingml/2006/main" r:embed="Rafa49931017c4818"/>
+          <a:blip xmlns:r="http://schemas.openxmlformats.org/officeDocument/2006/relationships" xmlns:a="http://schemas.openxmlformats.org/drawingml/2006/main" r:embed="R3c7695abb22f42cf"/>
           <a:stretch xmlns:a="http://schemas.openxmlformats.org/drawingml/2006/main"/>
         </p:blipFill>
         <p:spPr>
@@ -11785,7 +11675,7 @@
           <p:cNvPr id="2" name="">
             <a:extLst xmlns:a="http://schemas.openxmlformats.org/drawingml/2006/main">
               <a:ext uri="{FF2B5EF4-FFF2-40B4-BE49-F238E27FC236}">
-                <a16:creationId xmlns:a16="http://schemas.microsoft.com/office/drawing/2014/main" id="{086CD911-6FE8-4405-9FB4-DF4226EADB86}"/>
+                <a16:creationId xmlns:a16="http://schemas.microsoft.com/office/drawing/2014/main" id="{3ED708B0-2217-428C-BF84-B41B0E624C18}"/>
               </a:ext>
             </a:extLst>
           </p:cNvPr>
@@ -11843,7 +11733,7 @@
                 <a:ea typeface="Courier New"/>
                 <a:cs typeface="Courier New"/>
               </a:rPr>
-              <a:t>ЭФФЕКТ ИНТЕГРАЦИИ</a:t>
+              <a:t>ОЦЕНКА ПОЛЬЗЫ</a:t>
             </a:r>
           </a:p>
         </p:txBody>
@@ -11853,7 +11743,7 @@
           <p:cNvPr id="3" name="">
             <a:extLst xmlns:a="http://schemas.openxmlformats.org/drawingml/2006/main">
               <a:ext uri="{FF2B5EF4-FFF2-40B4-BE49-F238E27FC236}">
-                <a16:creationId xmlns:a16="http://schemas.microsoft.com/office/drawing/2014/main" id="{FA94F5F7-2230-49FD-B077-5A21526B99BF}"/>
+                <a16:creationId xmlns:a16="http://schemas.microsoft.com/office/drawing/2014/main" id="{D7BCA2ED-930E-48FB-A58C-291A33D7DBBC}"/>
               </a:ext>
             </a:extLst>
           </p:cNvPr>
@@ -11911,7 +11801,7 @@
                 <a:ea typeface="Arial"/>
                 <a:cs typeface="Arial"/>
               </a:rPr>
-              <a:t>Польза в измеримых показателях</a:t>
+              <a:t>Как измерить пользу интеграции</a:t>
             </a:r>
           </a:p>
         </p:txBody>
@@ -11921,7 +11811,7 @@
           <p:cNvPr id="4" name="">
             <a:extLst xmlns:a="http://schemas.openxmlformats.org/drawingml/2006/main">
               <a:ext uri="{FF2B5EF4-FFF2-40B4-BE49-F238E27FC236}">
-                <a16:creationId xmlns:a16="http://schemas.microsoft.com/office/drawing/2014/main" id="{FE59C5DD-D528-43E9-B3CF-48597AA6FB2D}"/>
+                <a16:creationId xmlns:a16="http://schemas.microsoft.com/office/drawing/2014/main" id="{6FFD73E0-7E14-47E3-85FE-F8F57B28304C}"/>
               </a:ext>
             </a:extLst>
           </p:cNvPr>
@@ -11989,7 +11879,7 @@
           <p:cNvPr id="5" name="">
             <a:extLst xmlns:a="http://schemas.openxmlformats.org/drawingml/2006/main">
               <a:ext uri="{FF2B5EF4-FFF2-40B4-BE49-F238E27FC236}">
-                <a16:creationId xmlns:a16="http://schemas.microsoft.com/office/drawing/2014/main" id="{5A10F6C3-F21D-4C71-B269-127C9CFF5D30}"/>
+                <a16:creationId xmlns:a16="http://schemas.microsoft.com/office/drawing/2014/main" id="{41EFF9EA-BEB2-42B6-B87D-25C694F72F61}"/>
               </a:ext>
             </a:extLst>
           </p:cNvPr>
@@ -12057,7 +11947,7 @@
           <p:cNvPr id="6" name="">
             <a:extLst xmlns:a="http://schemas.openxmlformats.org/drawingml/2006/main">
               <a:ext uri="{FF2B5EF4-FFF2-40B4-BE49-F238E27FC236}">
-                <a16:creationId xmlns:a16="http://schemas.microsoft.com/office/drawing/2014/main" id="{F8ECED23-69DD-45D3-99F8-6D7BB7B2756F}"/>
+                <a16:creationId xmlns:a16="http://schemas.microsoft.com/office/drawing/2014/main" id="{D9B251F7-42D7-452C-94BE-CB3617C189F3}"/>
               </a:ext>
             </a:extLst>
           </p:cNvPr>
@@ -12125,7 +12015,7 @@
           <p:cNvPr id="7" name="">
             <a:extLst xmlns:a="http://schemas.openxmlformats.org/drawingml/2006/main">
               <a:ext uri="{FF2B5EF4-FFF2-40B4-BE49-F238E27FC236}">
-                <a16:creationId xmlns:a16="http://schemas.microsoft.com/office/drawing/2014/main" id="{0B61DB5C-018C-4728-870E-EB4B00CF3C2F}"/>
+                <a16:creationId xmlns:a16="http://schemas.microsoft.com/office/drawing/2014/main" id="{5665D3F4-FDEC-4A6E-94E3-7C1EBF2E3345}"/>
               </a:ext>
             </a:extLst>
           </p:cNvPr>
@@ -12183,7 +12073,7 @@
                 <a:ea typeface="Arial"/>
                 <a:cs typeface="Arial"/>
               </a:rPr>
-              <a:t>Сравним работу с ИИ в hh.ru и через Skillaz</a:t>
+              <a:t>План замеров для пилота интеграции со Skillaz</a:t>
             </a:r>
           </a:p>
         </p:txBody>
@@ -12193,7 +12083,7 @@
           <p:cNvPr id="8" name="">
             <a:extLst xmlns:a="http://schemas.openxmlformats.org/drawingml/2006/main">
               <a:ext uri="{FF2B5EF4-FFF2-40B4-BE49-F238E27FC236}">
-                <a16:creationId xmlns:a16="http://schemas.microsoft.com/office/drawing/2014/main" id="{E2212203-D1B1-40EB-B394-0D5202794B15}"/>
+                <a16:creationId xmlns:a16="http://schemas.microsoft.com/office/drawing/2014/main" id="{63F6BD13-D63A-4077-89FF-E1567142A431}"/>
               </a:ext>
             </a:extLst>
           </p:cNvPr>
@@ -12936,7 +12826,7 @@
           <p:cNvPr id="9" name="">
             <a:extLst xmlns:a="http://schemas.openxmlformats.org/drawingml/2006/main">
               <a:ext uri="{FF2B5EF4-FFF2-40B4-BE49-F238E27FC236}">
-                <a16:creationId xmlns:a16="http://schemas.microsoft.com/office/drawing/2014/main" id="{B12ED6CC-CF4E-4649-B744-CBD8FF874D15}"/>
+                <a16:creationId xmlns:a16="http://schemas.microsoft.com/office/drawing/2014/main" id="{9FC4F3A0-238D-4859-9684-98063EE37286}"/>
               </a:ext>
             </a:extLst>
           </p:cNvPr>
@@ -12966,7 +12856,7 @@
           <p:cNvPr id="10" name="">
             <a:extLst xmlns:a="http://schemas.openxmlformats.org/drawingml/2006/main">
               <a:ext uri="{FF2B5EF4-FFF2-40B4-BE49-F238E27FC236}">
-                <a16:creationId xmlns:a16="http://schemas.microsoft.com/office/drawing/2014/main" id="{E9F14DA8-2D20-43C8-927E-56A3E66C7AB3}"/>
+                <a16:creationId xmlns:a16="http://schemas.microsoft.com/office/drawing/2014/main" id="{81B49282-E97A-4CE1-8C75-C13A83AD2F0C}"/>
               </a:ext>
             </a:extLst>
           </p:cNvPr>
@@ -13032,7 +12922,7 @@
     </p:spTree>
     <p:extLst>
       <p:ext uri="{BB962C8B-B14F-4D97-AF65-F5344CB8AC3E}">
-        <p14:creationId xmlns:p14="http://schemas.microsoft.com/office/powerpoint/2010/main" val="2109522714"/>
+        <p14:creationId xmlns:p14="http://schemas.microsoft.com/office/powerpoint/2010/main" val="938802003"/>
       </p:ext>
     </p:extLst>
   </p:cSld>
@@ -13063,7 +12953,7 @@
           <p:cNvPr id="17" name="">
             <a:extLst xmlns:a="http://schemas.openxmlformats.org/drawingml/2006/main">
               <a:ext uri="{FF2B5EF4-FFF2-40B4-BE49-F238E27FC236}">
-                <a16:creationId xmlns:a16="http://schemas.microsoft.com/office/drawing/2014/main" id="{0E8BA12A-45B5-4F78-9592-23D3B84AC787}"/>
+                <a16:creationId xmlns:a16="http://schemas.microsoft.com/office/drawing/2014/main" id="{0710650D-94C2-400C-926F-422AF58BCEBA}"/>
               </a:ext>
             </a:extLst>
           </p:cNvPr>
@@ -13073,7 +12963,7 @@
           <p:nvPr/>
         </p:nvPicPr>
         <p:blipFill>
-          <a:blip xmlns:r="http://schemas.openxmlformats.org/officeDocument/2006/relationships" xmlns:a="http://schemas.openxmlformats.org/drawingml/2006/main" r:embed="R042fe9ad054b41cb"/>
+          <a:blip xmlns:r="http://schemas.openxmlformats.org/officeDocument/2006/relationships" xmlns:a="http://schemas.openxmlformats.org/drawingml/2006/main" r:embed="R43d1d046029349c9"/>
           <a:stretch xmlns:a="http://schemas.openxmlformats.org/drawingml/2006/main"/>
         </p:blipFill>
         <p:spPr>
@@ -13091,7 +12981,7 @@
           <p:cNvPr id="2" name="">
             <a:extLst xmlns:a="http://schemas.openxmlformats.org/drawingml/2006/main">
               <a:ext uri="{FF2B5EF4-FFF2-40B4-BE49-F238E27FC236}">
-                <a16:creationId xmlns:a16="http://schemas.microsoft.com/office/drawing/2014/main" id="{C4BB4FBD-0E2B-478C-BF08-2D69F0417C48}"/>
+                <a16:creationId xmlns:a16="http://schemas.microsoft.com/office/drawing/2014/main" id="{9E26FC9A-AFD0-487D-A4E0-BADD320F5E02}"/>
               </a:ext>
             </a:extLst>
           </p:cNvPr>
@@ -13149,7 +13039,7 @@
                 <a:ea typeface="Courier New"/>
                 <a:cs typeface="Courier New"/>
               </a:rPr>
-              <a:t>СОСТАВ ПРЕДЛОЖЕНИЯ</a:t>
+              <a:t>ПОДГОТОВКА К ПОДКЛЮЧЕНИЮ</a:t>
             </a:r>
           </a:p>
         </p:txBody>
@@ -13159,7 +13049,7 @@
           <p:cNvPr id="3" name="">
             <a:extLst xmlns:a="http://schemas.openxmlformats.org/drawingml/2006/main">
               <a:ext uri="{FF2B5EF4-FFF2-40B4-BE49-F238E27FC236}">
-                <a16:creationId xmlns:a16="http://schemas.microsoft.com/office/drawing/2014/main" id="{CF995550-30EC-43E5-99BF-FD8453D8DBD4}"/>
+                <a16:creationId xmlns:a16="http://schemas.microsoft.com/office/drawing/2014/main" id="{D65F34E2-CBDB-40EC-9FBE-F8165B23E795}"/>
               </a:ext>
             </a:extLst>
           </p:cNvPr>
@@ -13217,7 +13107,7 @@
                 <a:ea typeface="Arial"/>
                 <a:cs typeface="Arial"/>
               </a:rPr>
-              <a:t>Из чего складывается стоимость</a:t>
+              <a:t>Что оценить перед подключением</a:t>
             </a:r>
           </a:p>
         </p:txBody>
@@ -13227,7 +13117,7 @@
           <p:cNvPr id="4" name="">
             <a:extLst xmlns:a="http://schemas.openxmlformats.org/drawingml/2006/main">
               <a:ext uri="{FF2B5EF4-FFF2-40B4-BE49-F238E27FC236}">
-                <a16:creationId xmlns:a16="http://schemas.microsoft.com/office/drawing/2014/main" id="{0F497B6C-75B7-4065-8F2F-8ED9BCB05457}"/>
+                <a16:creationId xmlns:a16="http://schemas.microsoft.com/office/drawing/2014/main" id="{894B74D9-8F29-4EBD-B930-FB4B4187A7BF}"/>
               </a:ext>
             </a:extLst>
           </p:cNvPr>
@@ -13295,7 +13185,7 @@
           <p:cNvPr id="5" name="">
             <a:extLst xmlns:a="http://schemas.openxmlformats.org/drawingml/2006/main">
               <a:ext uri="{FF2B5EF4-FFF2-40B4-BE49-F238E27FC236}">
-                <a16:creationId xmlns:a16="http://schemas.microsoft.com/office/drawing/2014/main" id="{B7F36999-2B66-4577-AC1E-8D20B7B1DC4F}"/>
+                <a16:creationId xmlns:a16="http://schemas.microsoft.com/office/drawing/2014/main" id="{77B2DA60-ABFE-47E3-9641-9C25B7C699AF}"/>
               </a:ext>
             </a:extLst>
           </p:cNvPr>
@@ -13363,7 +13253,7 @@
           <p:cNvPr id="6" name="">
             <a:extLst xmlns:a="http://schemas.openxmlformats.org/drawingml/2006/main">
               <a:ext uri="{FF2B5EF4-FFF2-40B4-BE49-F238E27FC236}">
-                <a16:creationId xmlns:a16="http://schemas.microsoft.com/office/drawing/2014/main" id="{A02F22A3-4034-48A5-BE0F-1510726601DD}"/>
+                <a16:creationId xmlns:a16="http://schemas.microsoft.com/office/drawing/2014/main" id="{4F16D96F-417D-4605-BC60-7184E42BEE0D}"/>
               </a:ext>
             </a:extLst>
           </p:cNvPr>
@@ -13431,7 +13321,7 @@
           <p:cNvPr id="7" name="">
             <a:extLst xmlns:a="http://schemas.openxmlformats.org/drawingml/2006/main">
               <a:ext uri="{FF2B5EF4-FFF2-40B4-BE49-F238E27FC236}">
-                <a16:creationId xmlns:a16="http://schemas.microsoft.com/office/drawing/2014/main" id="{FF2F3FD1-E62E-49EC-8343-9F3F38C75EFD}"/>
+                <a16:creationId xmlns:a16="http://schemas.microsoft.com/office/drawing/2014/main" id="{4CC810C0-31CE-4AFA-82BB-CE994658984C}"/>
               </a:ext>
             </a:extLst>
           </p:cNvPr>
@@ -13461,7 +13351,7 @@
           <p:cNvPr id="8" name="">
             <a:extLst xmlns:a="http://schemas.openxmlformats.org/drawingml/2006/main">
               <a:ext uri="{FF2B5EF4-FFF2-40B4-BE49-F238E27FC236}">
-                <a16:creationId xmlns:a16="http://schemas.microsoft.com/office/drawing/2014/main" id="{EE3D98EC-AD49-40CC-B240-D4C6A1349A6F}"/>
+                <a16:creationId xmlns:a16="http://schemas.microsoft.com/office/drawing/2014/main" id="{F2A15142-DD76-4F40-A6BF-EBD46C216B7D}"/>
               </a:ext>
             </a:extLst>
           </p:cNvPr>
@@ -13519,7 +13409,7 @@
                 <a:ea typeface="Arial"/>
                 <a:cs typeface="Arial"/>
               </a:rPr>
-              <a:t>Внедрение</a:t>
+              <a:t>Процесс</a:t>
             </a:r>
           </a:p>
         </p:txBody>
@@ -13529,7 +13419,7 @@
           <p:cNvPr id="9" name="">
             <a:extLst xmlns:a="http://schemas.openxmlformats.org/drawingml/2006/main">
               <a:ext uri="{FF2B5EF4-FFF2-40B4-BE49-F238E27FC236}">
-                <a16:creationId xmlns:a16="http://schemas.microsoft.com/office/drawing/2014/main" id="{8972755A-6E07-4C9B-9522-AAADA243BBCE}"/>
+                <a16:creationId xmlns:a16="http://schemas.microsoft.com/office/drawing/2014/main" id="{2DFDF655-5218-4D38-B5D3-CFE73A24C7A8}"/>
               </a:ext>
             </a:extLst>
           </p:cNvPr>
@@ -13587,7 +13477,7 @@
                 <a:ea typeface="Arial"/>
                 <a:cs typeface="Arial"/>
               </a:rPr>
-              <a:t>Настройка обмена и полей.</a:t>
+              <a:t>Ручные действия.</a:t>
             </a:r>
           </a:p>
           <a:p xmlns:a="http://schemas.openxmlformats.org/drawingml/2006/main">
@@ -13610,7 +13500,7 @@
                 <a:ea typeface="Arial"/>
                 <a:cs typeface="Arial"/>
               </a:rPr>
-              <a:t>Проверка сценариев.</a:t>
+              <a:t>Переключения систем.</a:t>
             </a:r>
           </a:p>
           <a:p xmlns:a="http://schemas.openxmlformats.org/drawingml/2006/main">
@@ -13633,7 +13523,7 @@
                 <a:ea typeface="Arial"/>
                 <a:cs typeface="Arial"/>
               </a:rPr>
-              <a:t>Подготовка команды.</a:t>
+              <a:t>Время на один отклик.</a:t>
             </a:r>
           </a:p>
         </p:txBody>
@@ -13643,7 +13533,7 @@
           <p:cNvPr id="10" name="">
             <a:extLst xmlns:a="http://schemas.openxmlformats.org/drawingml/2006/main">
               <a:ext uri="{FF2B5EF4-FFF2-40B4-BE49-F238E27FC236}">
-                <a16:creationId xmlns:a16="http://schemas.microsoft.com/office/drawing/2014/main" id="{67D1BCAA-254A-4DF6-A5C2-D0E2D131B900}"/>
+                <a16:creationId xmlns:a16="http://schemas.microsoft.com/office/drawing/2014/main" id="{B166EC70-4E90-48BE-890D-7E7C3540216C}"/>
               </a:ext>
             </a:extLst>
           </p:cNvPr>
@@ -13673,7 +13563,7 @@
           <p:cNvPr id="11" name="">
             <a:extLst xmlns:a="http://schemas.openxmlformats.org/drawingml/2006/main">
               <a:ext uri="{FF2B5EF4-FFF2-40B4-BE49-F238E27FC236}">
-                <a16:creationId xmlns:a16="http://schemas.microsoft.com/office/drawing/2014/main" id="{1A9A02F7-F66A-4511-B1C8-02D560225B5A}"/>
+                <a16:creationId xmlns:a16="http://schemas.microsoft.com/office/drawing/2014/main" id="{EFE16DF8-0FCD-48FB-ACE8-DC0AF14DE8EF}"/>
               </a:ext>
             </a:extLst>
           </p:cNvPr>
@@ -13731,7 +13621,7 @@
                 <a:ea typeface="Arial"/>
                 <a:cs typeface="Arial"/>
               </a:rPr>
-              <a:t>Использование</a:t>
+              <a:t>Данные</a:t>
             </a:r>
           </a:p>
         </p:txBody>
@@ -13741,7 +13631,7 @@
           <p:cNvPr id="12" name="">
             <a:extLst xmlns:a="http://schemas.openxmlformats.org/drawingml/2006/main">
               <a:ext uri="{FF2B5EF4-FFF2-40B4-BE49-F238E27FC236}">
-                <a16:creationId xmlns:a16="http://schemas.microsoft.com/office/drawing/2014/main" id="{A09FA82C-E3E6-4D1A-A785-E6172EDEA042}"/>
+                <a16:creationId xmlns:a16="http://schemas.microsoft.com/office/drawing/2014/main" id="{DDB11252-93BC-471F-B2E6-576DB1D2FDAE}"/>
               </a:ext>
             </a:extLst>
           </p:cNvPr>
@@ -13799,7 +13689,7 @@
                 <a:ea typeface="Arial"/>
                 <a:cs typeface="Arial"/>
               </a:rPr>
-              <a:t>Результаты разбора</a:t>
+              <a:t>Какие результаты ИИ</a:t>
             </a:r>
           </a:p>
           <a:p xmlns:a="http://schemas.openxmlformats.org/drawingml/2006/main">
@@ -13822,7 +13712,7 @@
                 <a:ea typeface="Arial"/>
                 <a:cs typeface="Arial"/>
               </a:rPr>
-              <a:t>и ответы кандидатов</a:t>
+              <a:t>нужны рекрутёру</a:t>
             </a:r>
           </a:p>
           <a:p xmlns:a="http://schemas.openxmlformats.org/drawingml/2006/main">
@@ -13845,30 +13735,7 @@
                 <a:ea typeface="Arial"/>
                 <a:cs typeface="Arial"/>
               </a:rPr>
-              <a:t>в Skillaz в согласованном</a:t>
-            </a:r>
-          </a:p>
-          <a:p xmlns:a="http://schemas.openxmlformats.org/drawingml/2006/main">
-            <a:pPr>
-              <a:defRPr sz="1650" b="0">
-                <a:solidFill>
-                  <a:srgbClr val="737C96"/>
-                </a:solidFill>
-                <a:latin typeface="Arial"/>
-                <a:ea typeface="Arial"/>
-                <a:cs typeface="Arial"/>
-              </a:defRPr>
-            </a:pPr>
-            <a:r>
-              <a:rPr sz="1650" b="0">
-                <a:solidFill>
-                  <a:srgbClr val="737C96"/>
-                </a:solidFill>
-                <a:latin typeface="Arial"/>
-                <a:ea typeface="Arial"/>
-                <a:cs typeface="Arial"/>
-              </a:rPr>
-              <a:t>объёме.</a:t>
+              <a:t>для следующего шага.</a:t>
             </a:r>
           </a:p>
         </p:txBody>
@@ -13878,7 +13745,7 @@
           <p:cNvPr id="13" name="">
             <a:extLst xmlns:a="http://schemas.openxmlformats.org/drawingml/2006/main">
               <a:ext uri="{FF2B5EF4-FFF2-40B4-BE49-F238E27FC236}">
-                <a16:creationId xmlns:a16="http://schemas.microsoft.com/office/drawing/2014/main" id="{8E004F43-E034-4F17-A35F-9588676B59EA}"/>
+                <a16:creationId xmlns:a16="http://schemas.microsoft.com/office/drawing/2014/main" id="{826DD5B2-8CCD-49FC-8FD2-2339C222320E}"/>
               </a:ext>
             </a:extLst>
           </p:cNvPr>
@@ -13908,7 +13775,7 @@
           <p:cNvPr id="14" name="">
             <a:extLst xmlns:a="http://schemas.openxmlformats.org/drawingml/2006/main">
               <a:ext uri="{FF2B5EF4-FFF2-40B4-BE49-F238E27FC236}">
-                <a16:creationId xmlns:a16="http://schemas.microsoft.com/office/drawing/2014/main" id="{EA8FDE43-2355-4563-9AB0-ABC0766CD32A}"/>
+                <a16:creationId xmlns:a16="http://schemas.microsoft.com/office/drawing/2014/main" id="{A3CA3FA8-16DC-4236-A780-0371DEFDD8B5}"/>
               </a:ext>
             </a:extLst>
           </p:cNvPr>
@@ -13966,7 +13833,7 @@
                 <a:ea typeface="Arial"/>
                 <a:cs typeface="Arial"/>
               </a:rPr>
-              <a:t>Сопровождение</a:t>
+              <a:t>Экономика</a:t>
             </a:r>
           </a:p>
         </p:txBody>
@@ -13976,7 +13843,7 @@
           <p:cNvPr id="15" name="">
             <a:extLst xmlns:a="http://schemas.openxmlformats.org/drawingml/2006/main">
               <a:ext uri="{FF2B5EF4-FFF2-40B4-BE49-F238E27FC236}">
-                <a16:creationId xmlns:a16="http://schemas.microsoft.com/office/drawing/2014/main" id="{E50F4CB4-2819-46D5-838B-D7BFC615E6B4}"/>
+                <a16:creationId xmlns:a16="http://schemas.microsoft.com/office/drawing/2014/main" id="{4EB442C3-DCB1-4CE3-BE95-00D4EF12FF2F}"/>
               </a:ext>
             </a:extLst>
           </p:cNvPr>
@@ -14034,7 +13901,7 @@
                 <a:ea typeface="Arial"/>
                 <a:cs typeface="Arial"/>
               </a:rPr>
-              <a:t>Поддержка интеграции</a:t>
+              <a:t>Ожидаемая экономия</a:t>
             </a:r>
           </a:p>
           <a:p xmlns:a="http://schemas.openxmlformats.org/drawingml/2006/main">
@@ -14057,7 +13924,30 @@
                 <a:ea typeface="Arial"/>
                 <a:cs typeface="Arial"/>
               </a:rPr>
-              <a:t>на условиях договора.</a:t>
+              <a:t>времени и полная</a:t>
+            </a:r>
+          </a:p>
+          <a:p xmlns:a="http://schemas.openxmlformats.org/drawingml/2006/main">
+            <a:pPr>
+              <a:defRPr sz="1650" b="0">
+                <a:solidFill>
+                  <a:srgbClr val="737C96"/>
+                </a:solidFill>
+                <a:latin typeface="Arial"/>
+                <a:ea typeface="Arial"/>
+                <a:cs typeface="Arial"/>
+              </a:defRPr>
+            </a:pPr>
+            <a:r>
+              <a:rPr sz="1650" b="0">
+                <a:solidFill>
+                  <a:srgbClr val="737C96"/>
+                </a:solidFill>
+                <a:latin typeface="Arial"/>
+                <a:ea typeface="Arial"/>
+                <a:cs typeface="Arial"/>
+              </a:rPr>
+              <a:t>стоимость подключения.</a:t>
             </a:r>
           </a:p>
         </p:txBody>
@@ -14067,7 +13957,7 @@
           <p:cNvPr id="16" name="">
             <a:extLst xmlns:a="http://schemas.openxmlformats.org/drawingml/2006/main">
               <a:ext uri="{FF2B5EF4-FFF2-40B4-BE49-F238E27FC236}">
-                <a16:creationId xmlns:a16="http://schemas.microsoft.com/office/drawing/2014/main" id="{ADF1621D-F9E1-4885-A448-48BDDB33AC2B}"/>
+                <a16:creationId xmlns:a16="http://schemas.microsoft.com/office/drawing/2014/main" id="{19945637-C7B0-41B9-B142-C998933E19E3}"/>
               </a:ext>
             </a:extLst>
           </p:cNvPr>
@@ -14125,7 +14015,7 @@
                 <a:ea typeface="Arial"/>
                 <a:cs typeface="Arial"/>
               </a:rPr>
-              <a:t>В предложении фиксируем функции, лимиты и условия доступа к ИИ hh.ru.</a:t>
+              <a:t>Основа решения — результаты пилота и согласованное предложение.</a:t>
             </a:r>
           </a:p>
         </p:txBody>
@@ -14133,7 +14023,7 @@
     </p:spTree>
     <p:extLst>
       <p:ext uri="{BB962C8B-B14F-4D97-AF65-F5344CB8AC3E}">
-        <p14:creationId xmlns:p14="http://schemas.microsoft.com/office/powerpoint/2010/main" val="588340487"/>
+        <p14:creationId xmlns:p14="http://schemas.microsoft.com/office/powerpoint/2010/main" val="211405811"/>
       </p:ext>
     </p:extLst>
   </p:cSld>

</xml_diff>

<commit_message>
Document hh vacancy configuration, automatic analysis and API integration boundaries
</commit_message>
<xml_diff>
--- a/Skillaz-hh-Integration.pptx
+++ b/Skillaz-hh-Integration.pptx
@@ -2,22 +2,22 @@
 <file path=ppt/presentation.xml><?xml version="1.0" encoding="utf-8"?>
 <p:presentation xmlns:p="http://schemas.openxmlformats.org/presentationml/2006/main">
   <p:sldMasterIdLst>
-    <p:sldMasterId xmlns:r="http://schemas.openxmlformats.org/officeDocument/2006/relationships" id="2147483648" r:id="Rec1853f8204c4558"/>
+    <p:sldMasterId xmlns:r="http://schemas.openxmlformats.org/officeDocument/2006/relationships" id="2147483648" r:id="R9f2e538fcfa3423d"/>
   </p:sldMasterIdLst>
   <p:notesMasterIdLst>
-    <p:notesMasterId xmlns:r="http://schemas.openxmlformats.org/officeDocument/2006/relationships" r:id="R3539e99b55144c49"/>
+    <p:notesMasterId xmlns:r="http://schemas.openxmlformats.org/officeDocument/2006/relationships" r:id="R9dceda9bf76b4816"/>
   </p:notesMasterIdLst>
   <p:sldIdLst>
-    <p:sldId xmlns:r="http://schemas.openxmlformats.org/officeDocument/2006/relationships" id="256" r:id="R8133d69ff5ac4641"/>
-    <p:sldId xmlns:r="http://schemas.openxmlformats.org/officeDocument/2006/relationships" id="257" r:id="Rbf9bfd30a9dc41e1"/>
-    <p:sldId xmlns:r="http://schemas.openxmlformats.org/officeDocument/2006/relationships" id="258" r:id="Rc51783c445f94a2d"/>
-    <p:sldId xmlns:r="http://schemas.openxmlformats.org/officeDocument/2006/relationships" id="259" r:id="Rc8d420f9a86a4a64"/>
-    <p:sldId xmlns:r="http://schemas.openxmlformats.org/officeDocument/2006/relationships" id="260" r:id="Rce7a6ee2316646df"/>
-    <p:sldId xmlns:r="http://schemas.openxmlformats.org/officeDocument/2006/relationships" id="261" r:id="R051fed3287a3455e"/>
-    <p:sldId xmlns:r="http://schemas.openxmlformats.org/officeDocument/2006/relationships" id="262" r:id="Rfb77e45367db4aeb"/>
-    <p:sldId xmlns:r="http://schemas.openxmlformats.org/officeDocument/2006/relationships" id="263" r:id="Rb37a7979a4544d44"/>
-    <p:sldId xmlns:r="http://schemas.openxmlformats.org/officeDocument/2006/relationships" id="264" r:id="R9becae8d96b4464d"/>
-    <p:sldId xmlns:r="http://schemas.openxmlformats.org/officeDocument/2006/relationships" id="265" r:id="Rcbdde80158f84570"/>
+    <p:sldId xmlns:r="http://schemas.openxmlformats.org/officeDocument/2006/relationships" id="256" r:id="R232e305760c247b2"/>
+    <p:sldId xmlns:r="http://schemas.openxmlformats.org/officeDocument/2006/relationships" id="257" r:id="R3c4463c0a09a4e96"/>
+    <p:sldId xmlns:r="http://schemas.openxmlformats.org/officeDocument/2006/relationships" id="258" r:id="R9f2339d9bd51456b"/>
+    <p:sldId xmlns:r="http://schemas.openxmlformats.org/officeDocument/2006/relationships" id="259" r:id="Ra2ef08a3cdee4687"/>
+    <p:sldId xmlns:r="http://schemas.openxmlformats.org/officeDocument/2006/relationships" id="260" r:id="R2e0c72bb9e4042d9"/>
+    <p:sldId xmlns:r="http://schemas.openxmlformats.org/officeDocument/2006/relationships" id="261" r:id="R26a64c26bed84852"/>
+    <p:sldId xmlns:r="http://schemas.openxmlformats.org/officeDocument/2006/relationships" id="262" r:id="R73b0e0d9509e4b7e"/>
+    <p:sldId xmlns:r="http://schemas.openxmlformats.org/officeDocument/2006/relationships" id="263" r:id="Rf2f850f54b254919"/>
+    <p:sldId xmlns:r="http://schemas.openxmlformats.org/officeDocument/2006/relationships" id="264" r:id="Raf094cd6ae8247fa"/>
+    <p:sldId xmlns:r="http://schemas.openxmlformats.org/officeDocument/2006/relationships" id="265" r:id="Rab0eaac855b04b54"/>
   </p:sldIdLst>
   <p:sldSz cx="10692384" cy="6007608"/>
   <p:notesSz cx="6858000" cy="9144000"/>
@@ -464,6 +464,16 @@
               <a:t>Позиционирование: публичная документация описывает получение результатов ИИ, но не подтверждает готовую интеграцию Skillaz. Проверить токен приложения Skillaz, доступ клиента, наличие ai_assistant в реальном отклике и продуктовый релиз. Не обещать работу в карточке до проверки.</a:t>
             </a:r>
           </a:p>
+          <a:p xmlns:a="http://schemas.openxmlformats.org/drawingml/2006/main">
+            <a:r>
+              <a:t>Уточнения по документации hh: https://feedback.hh.ru/knowledge-base/article/033748 ; https://feedback.hh.ru/knowledge-base/article/022833 . Помощник подключается к конкретной вакансии; оба навыка включены по умолчанию. Критерии редактируемые, не закрытый справочник. 6 обязательных и 4 желательных — автоматическое выделение, не подтверждённый жёсткий лимит. При изменении портрета — переразбор с исключениями для некоторых статусов, включая ручной отказ. Доопрос касается новых откликов, не гарантирован каждому кандидату; до 3 своих вопросов, до 5 всего по инструкции. Запрос API получает результат, не запускает оценку.</a:t>
+            </a:r>
+          </a:p>
+          <a:p xmlns:a="http://schemas.openxmlformats.org/drawingml/2006/main">
+            <a:r>
+              <a:t/>
+            </a:r>
+          </a:p>
         </p:txBody>
       </p:sp>
       <p:sp>
@@ -544,6 +554,16 @@
               <a:t>Перед пилотом: получить реальный отклик с завершённым разбором и доопросом, выполнить GET /negotiations/{id} от приложения Skillaz, проверить ai_assistant и сопоставление данных. Запросить у hh документацию партнёрских методов, права, ограничения и коммерческие условия. Сроки, цена пилота, объём, ответственность и критерии приёмки не подтверждены.</a:t>
             </a:r>
           </a:p>
+          <a:p xmlns:a="http://schemas.openxmlformats.org/drawingml/2006/main">
+            <a:r>
+              <a:t>Уточнения по документации hh: https://feedback.hh.ru/knowledge-base/article/033748 ; https://feedback.hh.ru/knowledge-base/article/022833 . Помощник подключается к конкретной вакансии; оба навыка включены по умолчанию. Критерии редактируемые, не закрытый справочник. 6 обязательных и 4 желательных — автоматическое выделение, не подтверждённый жёсткий лимит. При изменении портрета — переразбор с исключениями для некоторых статусов, включая ручной отказ. Доопрос касается новых откликов, не гарантирован каждому кандидату; до 3 своих вопросов, до 5 всего по инструкции. Запрос API получает результат, не запускает оценку.</a:t>
+            </a:r>
+          </a:p>
+          <a:p xmlns:a="http://schemas.openxmlformats.org/drawingml/2006/main">
+            <a:r>
+              <a:t/>
+            </a:r>
+          </a:p>
         </p:txBody>
       </p:sp>
       <p:sp>
@@ -624,6 +644,16 @@
               <a:t>Подтверждены примеры данных neuro_response и neuro_invite. Блок найден в examples; подробной схемы ai_assistant в проверенной спецификации нет. Нужны реальные ответы API, перечень значений, nullable-поля и условия появления блока. Сокращение ручных действий — гипотеза пилота.</a:t>
             </a:r>
           </a:p>
+          <a:p xmlns:a="http://schemas.openxmlformats.org/drawingml/2006/main">
+            <a:r>
+              <a:t>Уточнения по документации hh: https://feedback.hh.ru/knowledge-base/article/033748 ; https://feedback.hh.ru/knowledge-base/article/022833 . Помощник подключается к конкретной вакансии; оба навыка включены по умолчанию. Критерии редактируемые, не закрытый справочник. 6 обязательных и 4 желательных — автоматическое выделение, не подтверждённый жёсткий лимит. При изменении портрета — переразбор с исключениями для некоторых статусов, включая ручной отказ. Доопрос касается новых откликов, не гарантирован каждому кандидату; до 3 своих вопросов, до 5 всего по инструкции. Запрос API получает результат, не запускает оценку.</a:t>
+            </a:r>
+          </a:p>
+          <a:p xmlns:a="http://schemas.openxmlformats.org/drawingml/2006/main">
+            <a:r>
+              <a:t/>
+            </a:r>
+          </a:p>
         </p:txBody>
       </p:sp>
       <p:sp>
@@ -704,6 +734,16 @@
               <a:t>Таблица отражает только поля официального примера API. Требуют проверки: показ результата в воронке Skillaz, работа с категориями, отображение подробного разбора, привязка вопросов к полям и автоматическое заполнение карточки. Цитата ответа в API не равна готовому структурированному полю Skillaz.</a:t>
             </a:r>
           </a:p>
+          <a:p xmlns:a="http://schemas.openxmlformats.org/drawingml/2006/main">
+            <a:r>
+              <a:t>Уточнения по документации hh: https://feedback.hh.ru/knowledge-base/article/033748 ; https://feedback.hh.ru/knowledge-base/article/022833 . Помощник подключается к конкретной вакансии; оба навыка включены по умолчанию. Критерии редактируемые, не закрытый справочник. 6 обязательных и 4 желательных — автоматическое выделение, не подтверждённый жёсткий лимит. При изменении портрета — переразбор с исключениями для некоторых статусов, включая ручной отказ. Доопрос касается новых откликов, не гарантирован каждому кандидату; до 3 своих вопросов, до 5 всего по инструкции. Запрос API получает результат, не запускает оценку.</a:t>
+            </a:r>
+          </a:p>
+          <a:p xmlns:a="http://schemas.openxmlformats.org/drawingml/2006/main">
+            <a:r>
+              <a:t/>
+            </a:r>
+          </a:p>
         </p:txBody>
       </p:sp>
       <p:sp>
@@ -784,6 +824,16 @@
               <a:t>НЕПОДТВЕРЖДЁННЫЕ ВОЗМОЖНОСТИ: настройка критериев и включение ИИ из Skillaz; запуск доопроса и управление вопросами через API; повторный разбор; получение уведомлений об изменении результатов. Публичные методы управления этими функциями не найдены. Отсутствие в публичной документации не исключает партнёрский API. Проверить периодичность обновлений и условия доступа.</a:t>
             </a:r>
           </a:p>
+          <a:p xmlns:a="http://schemas.openxmlformats.org/drawingml/2006/main">
+            <a:r>
+              <a:t>Уточнения по документации hh: https://feedback.hh.ru/knowledge-base/article/033748 ; https://feedback.hh.ru/knowledge-base/article/022833 . Помощник подключается к конкретной вакансии; оба навыка включены по умолчанию. Критерии редактируемые, не закрытый справочник. 6 обязательных и 4 желательных — автоматическое выделение, не подтверждённый жёсткий лимит. При изменении портрета — переразбор с исключениями для некоторых статусов, включая ручной отказ. Доопрос касается новых откликов, не гарантирован каждому кандидату; до 3 своих вопросов, до 5 всего по инструкции. Запрос API получает результат, не запускает оценку.</a:t>
+            </a:r>
+          </a:p>
+          <a:p xmlns:a="http://schemas.openxmlformats.org/drawingml/2006/main">
+            <a:r>
+              <a:t/>
+            </a:r>
+          </a:p>
         </p:txBody>
       </p:sp>
       <p:sp>
@@ -864,6 +914,16 @@
               <a:t>Скриншот сохранён из исходного PDF, слайд 6, как иллюстрация, а не свидетельство проверенной интеграции. Проверить наличие фильтров, счётчиков, названия категорий и сопоставление decision со статусами Skillaz. Не интерпретировать ACCEPT из примера как полный перечень категорий.</a:t>
             </a:r>
           </a:p>
+          <a:p xmlns:a="http://schemas.openxmlformats.org/drawingml/2006/main">
+            <a:r>
+              <a:t>Уточнения по документации hh: https://feedback.hh.ru/knowledge-base/article/033748 ; https://feedback.hh.ru/knowledge-base/article/022833 . Помощник подключается к конкретной вакансии; оба навыка включены по умолчанию. Критерии редактируемые, не закрытый справочник. 6 обязательных и 4 желательных — автоматическое выделение, не подтверждённый жёсткий лимит. При изменении портрета — переразбор с исключениями для некоторых статусов, включая ручной отказ. Доопрос касается новых откликов, не гарантирован каждому кандидату; до 3 своих вопросов, до 5 всего по инструкции. Запрос API получает результат, не запускает оценку.</a:t>
+            </a:r>
+          </a:p>
+          <a:p xmlns:a="http://schemas.openxmlformats.org/drawingml/2006/main">
+            <a:r>
+              <a:t/>
+            </a:r>
+          </a:p>
         </p:txBody>
       </p:sp>
       <p:sp>
@@ -944,6 +1004,16 @@
               <a:t>Диалог на слайде иллюстративный. Подтверждены question и quote в answers_to_questions_from_employer. Требуют проверки: запуск доопроса из Skillaz, настройка вопросов через API, автоматическое заполнение полей, типизация ответов, разбор неоднозначных ответов, обработка пропусков и повторных ответов.</a:t>
             </a:r>
           </a:p>
+          <a:p xmlns:a="http://schemas.openxmlformats.org/drawingml/2006/main">
+            <a:r>
+              <a:t>Уточнения по документации hh: https://feedback.hh.ru/knowledge-base/article/033748 ; https://feedback.hh.ru/knowledge-base/article/022833 . Помощник подключается к конкретной вакансии; оба навыка включены по умолчанию. Критерии редактируемые, не закрытый справочник. 6 обязательных и 4 желательных — автоматическое выделение, не подтверждённый жёсткий лимит. При изменении портрета — переразбор с исключениями для некоторых статусов, включая ручной отказ. Доопрос касается новых откликов, не гарантирован каждому кандидату; до 3 своих вопросов, до 5 всего по инструкции. Запрос API получает результат, не запускает оценку.</a:t>
+            </a:r>
+          </a:p>
+          <a:p xmlns:a="http://schemas.openxmlformats.org/drawingml/2006/main">
+            <a:r>
+              <a:t/>
+            </a:r>
+          </a:p>
         </p:txBody>
       </p:sp>
       <p:sp>
@@ -1024,6 +1094,16 @@
               <a:t>Скриншот сохранён из исходного PDF, слайд 11. Подтверждены поля критериев is_met, explanation, source. Требуют проверки: ручная смена категории в Skillaz; синхронизация с hh; сохранение ручного решения после повторного анализа; журнал изменений, права и типы событий. Схема истории изменений удалена из основного содержания.</a:t>
             </a:r>
           </a:p>
+          <a:p xmlns:a="http://schemas.openxmlformats.org/drawingml/2006/main">
+            <a:r>
+              <a:t>Уточнения по документации hh: https://feedback.hh.ru/knowledge-base/article/033748 ; https://feedback.hh.ru/knowledge-base/article/022833 . Помощник подключается к конкретной вакансии; оба навыка включены по умолчанию. Критерии редактируемые, не закрытый справочник. 6 обязательных и 4 желательных — автоматическое выделение, не подтверждённый жёсткий лимит. При изменении портрета — переразбор с исключениями для некоторых статусов, включая ручной отказ. Доопрос касается новых откликов, не гарантирован каждому кандидату; до 3 своих вопросов, до 5 всего по инструкции. Запрос API получает результат, не запускает оценку.</a:t>
+            </a:r>
+          </a:p>
+          <a:p xmlns:a="http://schemas.openxmlformats.org/drawingml/2006/main">
+            <a:r>
+              <a:t/>
+            </a:r>
+          </a:p>
         </p:txBody>
       </p:sp>
       <p:sp>
@@ -1104,6 +1184,21 @@
               <a:t>Это план пилота, а не подтверждённый эффект. После технической проверки сравнить сопоставимые вакансии и нагрузку: работа с ИИ непосредственно в hh.ru и через Skillaz. Не приписывать интеграции общий эффект ИИ. Сэкономленные часы не равны гарантированному сокращению расходов.</a:t>
             </a:r>
           </a:p>
+          <a:p xmlns:a="http://schemas.openxmlformats.org/drawingml/2006/main">
+            <a:r>
+              <a:t>Уточнения по документации hh: https://feedback.hh.ru/knowledge-base/article/033748 ; https://feedback.hh.ru/knowledge-base/article/022833 . Помощник подключается к конкретной вакансии; оба навыка включены по умолчанию. Критерии редактируемые, не закрытый справочник. 6 обязательных и 4 желательных — автоматическое выделение, не подтверждённый жёсткий лимит. При изменении портрета — переразбор с исключениями для некоторых статусов, включая ручной отказ. Доопрос касается новых откликов, не гарантирован каждому кандидату; до 3 своих вопросов, до 5 всего по инструкции. Запрос API получает результат, не запускает оценку.</a:t>
+            </a:r>
+          </a:p>
+          <a:p xmlns:a="http://schemas.openxmlformats.org/drawingml/2006/main">
+            <a:r>
+              <a:t/>
+            </a:r>
+          </a:p>
+          <a:p xmlns:a="http://schemas.openxmlformats.org/drawingml/2006/main">
+            <a:r>
+              <a:t>Слайд 8 заменён с методики пилота на явную таблицу границ подтверждения. Получение данных приложением Skillaz требует проверки; методов управления через публичный API не обнаружено.</a:t>
+            </a:r>
+          </a:p>
         </p:txBody>
       </p:sp>
       <p:sp>
@@ -1184,6 +1279,21 @@
               <a:t>НЕПОДТВЕРЖДЁННЫЕ УСЛОВИЯ ОПЛАТЫ: стоимость доступа к ИИ и API hh, входит ли она в тариф Skillaz, учёт уже оплаченных услуг hh, единица тарификации, лимиты, превышения, оплата доопроса, внедрение, сопровождение, SLA. Разделение на внедрение/использование/сопровождение было гипотезой предложения, не утверждённым тарифом. Условия оплаты не вынесены на слайд.</a:t>
             </a:r>
           </a:p>
+          <a:p xmlns:a="http://schemas.openxmlformats.org/drawingml/2006/main">
+            <a:r>
+              <a:t>Уточнения по документации hh: https://feedback.hh.ru/knowledge-base/article/033748 ; https://feedback.hh.ru/knowledge-base/article/022833 . Помощник подключается к конкретной вакансии; оба навыка включены по умолчанию. Критерии редактируемые, не закрытый справочник. 6 обязательных и 4 желательных — автоматическое выделение, не подтверждённый жёсткий лимит. При изменении портрета — переразбор с исключениями для некоторых статусов, включая ручной отказ. Доопрос касается новых откликов, не гарантирован каждому кандидату; до 3 своих вопросов, до 5 всего по инструкции. Запрос API получает результат, не запускает оценку.</a:t>
+            </a:r>
+          </a:p>
+          <a:p xmlns:a="http://schemas.openxmlformats.org/drawingml/2006/main">
+            <a:r>
+              <a:t/>
+            </a:r>
+          </a:p>
+          <a:p xmlns:a="http://schemas.openxmlformats.org/drawingml/2006/main">
+            <a:r>
+              <a:t>Слайд 9 показывает предлагаемый вариант, а не готовые возможности Skillaz. Запрос по ID отклика не содержит текст резюме; полученные данные и сам идентификатор не следует считать автоматически обезличенными. Отображение оценки и ответов в карточке требует реализации и проверки.</a:t>
+            </a:r>
+          </a:p>
         </p:txBody>
       </p:sp>
       <p:sp>
@@ -1228,7 +1338,7 @@
           <p:cNvPr id="3" name="Title">
             <a:extLst xmlns:a="http://schemas.openxmlformats.org/drawingml/2006/main">
               <a:ext uri="{FF2B5EF4-FFF2-40B4-BE49-F238E27FC236}">
-                <a16:creationId xmlns:a16="http://schemas.microsoft.com/office/drawing/2014/main" id="{0C3792D1-71BB-495F-ACCB-1489563BA02B}"/>
+                <a16:creationId xmlns:a16="http://schemas.microsoft.com/office/drawing/2014/main" id="{618C8D91-320F-4ECF-BEE7-7AABC48584DB}"/>
               </a:ext>
             </a:extLst>
           </p:cNvPr>
@@ -1385,7 +1495,7 @@
           <p:cNvPr id="2" name="Subtitle">
             <a:extLst xmlns:a="http://schemas.openxmlformats.org/drawingml/2006/main">
               <a:ext uri="{FF2B5EF4-FFF2-40B4-BE49-F238E27FC236}">
-                <a16:creationId xmlns:a16="http://schemas.microsoft.com/office/drawing/2014/main" id="{9A760E3B-5755-4D4B-86E9-F8B36CB710B0}"/>
+                <a16:creationId xmlns:a16="http://schemas.microsoft.com/office/drawing/2014/main" id="{D1B5A618-7BAA-475C-AD0B-0A7C275D5A68}"/>
               </a:ext>
             </a:extLst>
           </p:cNvPr>
@@ -1559,7 +1669,7 @@
           <p:cNvPr id="2" name="Section title">
             <a:extLst xmlns:a="http://schemas.openxmlformats.org/drawingml/2006/main">
               <a:ext uri="{FF2B5EF4-FFF2-40B4-BE49-F238E27FC236}">
-                <a16:creationId xmlns:a16="http://schemas.microsoft.com/office/drawing/2014/main" id="{FE4EF8BB-1AEE-426D-BB43-5AB271BD7120}"/>
+                <a16:creationId xmlns:a16="http://schemas.microsoft.com/office/drawing/2014/main" id="{F6723E76-BA19-4388-8CA0-BBFD233553BF}"/>
               </a:ext>
             </a:extLst>
           </p:cNvPr>
@@ -1733,7 +1843,7 @@
           <p:cNvPr id="3" name="Title">
             <a:extLst xmlns:a="http://schemas.openxmlformats.org/drawingml/2006/main">
               <a:ext uri="{FF2B5EF4-FFF2-40B4-BE49-F238E27FC236}">
-                <a16:creationId xmlns:a16="http://schemas.microsoft.com/office/drawing/2014/main" id="{AE0FAF67-0D0C-4509-9381-7E9E782FCBEB}"/>
+                <a16:creationId xmlns:a16="http://schemas.microsoft.com/office/drawing/2014/main" id="{F64FA09E-B835-4294-B5EA-68237BC68720}"/>
               </a:ext>
             </a:extLst>
           </p:cNvPr>
@@ -1890,7 +2000,7 @@
           <p:cNvPr id="2" name="Body">
             <a:extLst xmlns:a="http://schemas.openxmlformats.org/drawingml/2006/main">
               <a:ext uri="{FF2B5EF4-FFF2-40B4-BE49-F238E27FC236}">
-                <a16:creationId xmlns:a16="http://schemas.microsoft.com/office/drawing/2014/main" id="{BB7EA8C2-D827-4D30-96C2-BC00D87FF53A}"/>
+                <a16:creationId xmlns:a16="http://schemas.microsoft.com/office/drawing/2014/main" id="{8729281E-282F-48E3-9A4A-812D85A74424}"/>
               </a:ext>
             </a:extLst>
           </p:cNvPr>
@@ -2064,7 +2174,7 @@
           <p:cNvPr id="4" name="Title">
             <a:extLst xmlns:a="http://schemas.openxmlformats.org/drawingml/2006/main">
               <a:ext uri="{FF2B5EF4-FFF2-40B4-BE49-F238E27FC236}">
-                <a16:creationId xmlns:a16="http://schemas.microsoft.com/office/drawing/2014/main" id="{6B41E622-2BB8-4CC1-BA78-1C848A32F5AF}"/>
+                <a16:creationId xmlns:a16="http://schemas.microsoft.com/office/drawing/2014/main" id="{79CB5B3E-98D9-4515-82D7-FFCF549F0AF0}"/>
               </a:ext>
             </a:extLst>
           </p:cNvPr>
@@ -2221,7 +2331,7 @@
           <p:cNvPr id="2" name="Left column">
             <a:extLst xmlns:a="http://schemas.openxmlformats.org/drawingml/2006/main">
               <a:ext uri="{FF2B5EF4-FFF2-40B4-BE49-F238E27FC236}">
-                <a16:creationId xmlns:a16="http://schemas.microsoft.com/office/drawing/2014/main" id="{6C31319B-7A21-4F0B-8D15-B8FA8259D9E7}"/>
+                <a16:creationId xmlns:a16="http://schemas.microsoft.com/office/drawing/2014/main" id="{B323C66B-2F6B-4EBC-9A57-3EF4DF83B9A2}"/>
               </a:ext>
             </a:extLst>
           </p:cNvPr>
@@ -2378,7 +2488,7 @@
           <p:cNvPr id="3" name="Right column">
             <a:extLst xmlns:a="http://schemas.openxmlformats.org/drawingml/2006/main">
               <a:ext uri="{FF2B5EF4-FFF2-40B4-BE49-F238E27FC236}">
-                <a16:creationId xmlns:a16="http://schemas.microsoft.com/office/drawing/2014/main" id="{4E3BD7D9-4764-4FAD-B358-99E98A093346}"/>
+                <a16:creationId xmlns:a16="http://schemas.microsoft.com/office/drawing/2014/main" id="{D0792C7D-0863-489E-AEBA-E7DDE1420149}"/>
               </a:ext>
             </a:extLst>
           </p:cNvPr>
@@ -2552,7 +2662,7 @@
           <p:cNvPr id="3" name="Title">
             <a:extLst xmlns:a="http://schemas.openxmlformats.org/drawingml/2006/main">
               <a:ext uri="{FF2B5EF4-FFF2-40B4-BE49-F238E27FC236}">
-                <a16:creationId xmlns:a16="http://schemas.microsoft.com/office/drawing/2014/main" id="{89E1C9B9-7847-4619-91AF-4687D064D034}"/>
+                <a16:creationId xmlns:a16="http://schemas.microsoft.com/office/drawing/2014/main" id="{62B7BBD3-F635-45F6-8E36-5A221F4CC145}"/>
               </a:ext>
             </a:extLst>
           </p:cNvPr>
@@ -2709,7 +2819,7 @@
           <p:cNvPr id="2" name="Left column">
             <a:extLst xmlns:a="http://schemas.openxmlformats.org/drawingml/2006/main">
               <a:ext uri="{FF2B5EF4-FFF2-40B4-BE49-F238E27FC236}">
-                <a16:creationId xmlns:a16="http://schemas.microsoft.com/office/drawing/2014/main" id="{158E8202-CB85-4B64-9E24-6A9711CC6D13}"/>
+                <a16:creationId xmlns:a16="http://schemas.microsoft.com/office/drawing/2014/main" id="{B84E031C-4307-43B6-8BE9-3A2CB81129C7}"/>
               </a:ext>
             </a:extLst>
           </p:cNvPr>
@@ -2904,12 +3014,12 @@
   </p:cSld>
   <p:clrMap bg1="lt1" tx1="dk1" bg2="lt2" tx2="dk2" accent1="accent1" accent2="accent2" accent3="accent3" accent4="accent4" accent5="accent5" accent6="accent6" hlink="hlink" folHlink="folHlink"/>
   <p:sldLayoutIdLst>
-    <p:sldLayoutId xmlns:r="http://schemas.openxmlformats.org/officeDocument/2006/relationships" id="2147483649" r:id="Ra3360ede91714130"/>
-    <p:sldLayoutId xmlns:r="http://schemas.openxmlformats.org/officeDocument/2006/relationships" id="2147483650" r:id="R6f7dc655eaa04427"/>
-    <p:sldLayoutId xmlns:r="http://schemas.openxmlformats.org/officeDocument/2006/relationships" id="2147483651" r:id="R9cebfb75f3a94d31"/>
-    <p:sldLayoutId xmlns:r="http://schemas.openxmlformats.org/officeDocument/2006/relationships" id="2147483652" r:id="R7cc6affc99c04715"/>
-    <p:sldLayoutId xmlns:r="http://schemas.openxmlformats.org/officeDocument/2006/relationships" id="2147483653" r:id="R99407181344d46a3"/>
-    <p:sldLayoutId xmlns:r="http://schemas.openxmlformats.org/officeDocument/2006/relationships" id="2147483654" r:id="R783fda3549694cd4"/>
+    <p:sldLayoutId xmlns:r="http://schemas.openxmlformats.org/officeDocument/2006/relationships" id="2147483649" r:id="R4a9ed6c5c36048d3"/>
+    <p:sldLayoutId xmlns:r="http://schemas.openxmlformats.org/officeDocument/2006/relationships" id="2147483650" r:id="Rfb309429db044876"/>
+    <p:sldLayoutId xmlns:r="http://schemas.openxmlformats.org/officeDocument/2006/relationships" id="2147483651" r:id="Rd14c4f9430d64f3c"/>
+    <p:sldLayoutId xmlns:r="http://schemas.openxmlformats.org/officeDocument/2006/relationships" id="2147483652" r:id="R883f4d8dc5db4585"/>
+    <p:sldLayoutId xmlns:r="http://schemas.openxmlformats.org/officeDocument/2006/relationships" id="2147483653" r:id="R6e1eb9c9a3d44860"/>
+    <p:sldLayoutId xmlns:r="http://schemas.openxmlformats.org/officeDocument/2006/relationships" id="2147483654" r:id="Ra8b025aced1c40ec"/>
   </p:sldLayoutIdLst>
   <p:txStyles>
     <p:titleStyle>
@@ -3460,7 +3570,7 @@
           <p:cNvPr id="11" name="">
             <a:extLst xmlns:a="http://schemas.openxmlformats.org/drawingml/2006/main">
               <a:ext uri="{FF2B5EF4-FFF2-40B4-BE49-F238E27FC236}">
-                <a16:creationId xmlns:a16="http://schemas.microsoft.com/office/drawing/2014/main" id="{5C5A12FB-FCD2-47A9-831B-28F9BB344CF7}"/>
+                <a16:creationId xmlns:a16="http://schemas.microsoft.com/office/drawing/2014/main" id="{2E71653F-E48F-40AA-A6AB-34536210B65F}"/>
               </a:ext>
             </a:extLst>
           </p:cNvPr>
@@ -3470,7 +3580,7 @@
           <p:nvPr/>
         </p:nvPicPr>
         <p:blipFill>
-          <a:blip xmlns:r="http://schemas.openxmlformats.org/officeDocument/2006/relationships" xmlns:a="http://schemas.openxmlformats.org/drawingml/2006/main" r:embed="Rf75e69d75f014172"/>
+          <a:blip xmlns:r="http://schemas.openxmlformats.org/officeDocument/2006/relationships" xmlns:a="http://schemas.openxmlformats.org/drawingml/2006/main" r:embed="Rd004c8e21f0c4fde"/>
           <a:stretch xmlns:a="http://schemas.openxmlformats.org/drawingml/2006/main"/>
         </p:blipFill>
         <p:spPr>
@@ -3488,7 +3598,7 @@
           <p:cNvPr id="2" name="">
             <a:extLst xmlns:a="http://schemas.openxmlformats.org/drawingml/2006/main">
               <a:ext uri="{FF2B5EF4-FFF2-40B4-BE49-F238E27FC236}">
-                <a16:creationId xmlns:a16="http://schemas.microsoft.com/office/drawing/2014/main" id="{C8309E26-A284-41F2-BBE7-9880D781AC71}"/>
+                <a16:creationId xmlns:a16="http://schemas.microsoft.com/office/drawing/2014/main" id="{F96D15C7-4EE7-485E-9E16-8C470B37A5F0}"/>
               </a:ext>
             </a:extLst>
           </p:cNvPr>
@@ -3556,7 +3666,7 @@
           <p:cNvPr id="3" name="">
             <a:extLst xmlns:a="http://schemas.openxmlformats.org/drawingml/2006/main">
               <a:ext uri="{FF2B5EF4-FFF2-40B4-BE49-F238E27FC236}">
-                <a16:creationId xmlns:a16="http://schemas.microsoft.com/office/drawing/2014/main" id="{BE3393D1-853D-4B2A-AB2B-A47D9FBC9DCF}"/>
+                <a16:creationId xmlns:a16="http://schemas.microsoft.com/office/drawing/2014/main" id="{FD35B176-ED43-41E6-90F7-4D73F20E05CC}"/>
               </a:ext>
             </a:extLst>
           </p:cNvPr>
@@ -3624,7 +3734,7 @@
           <p:cNvPr id="4" name="">
             <a:extLst xmlns:a="http://schemas.openxmlformats.org/drawingml/2006/main">
               <a:ext uri="{FF2B5EF4-FFF2-40B4-BE49-F238E27FC236}">
-                <a16:creationId xmlns:a16="http://schemas.microsoft.com/office/drawing/2014/main" id="{9DBF8EC0-3AC2-43C5-A328-F4EE7DE153A5}"/>
+                <a16:creationId xmlns:a16="http://schemas.microsoft.com/office/drawing/2014/main" id="{A1E2F4E4-C5FA-47BD-9C58-C2055944D1BF}"/>
               </a:ext>
             </a:extLst>
           </p:cNvPr>
@@ -3692,7 +3802,7 @@
           <p:cNvPr id="5" name="">
             <a:extLst xmlns:a="http://schemas.openxmlformats.org/drawingml/2006/main">
               <a:ext uri="{FF2B5EF4-FFF2-40B4-BE49-F238E27FC236}">
-                <a16:creationId xmlns:a16="http://schemas.microsoft.com/office/drawing/2014/main" id="{29AADA15-05BD-492A-9481-E4353D2DF22E}"/>
+                <a16:creationId xmlns:a16="http://schemas.microsoft.com/office/drawing/2014/main" id="{D32A60F9-C44E-4857-86B2-CDFFB167351C}"/>
               </a:ext>
             </a:extLst>
           </p:cNvPr>
@@ -3760,7 +3870,7 @@
           <p:cNvPr id="6" name="">
             <a:extLst xmlns:a="http://schemas.openxmlformats.org/drawingml/2006/main">
               <a:ext uri="{FF2B5EF4-FFF2-40B4-BE49-F238E27FC236}">
-                <a16:creationId xmlns:a16="http://schemas.microsoft.com/office/drawing/2014/main" id="{5CD3D56D-80FB-41D0-8C40-B0ABA24C987F}"/>
+                <a16:creationId xmlns:a16="http://schemas.microsoft.com/office/drawing/2014/main" id="{37D6480C-BDAB-4161-B271-FC9BD4342D06}"/>
               </a:ext>
             </a:extLst>
           </p:cNvPr>
@@ -3790,7 +3900,7 @@
           <p:cNvPr id="7" name="">
             <a:extLst xmlns:a="http://schemas.openxmlformats.org/drawingml/2006/main">
               <a:ext uri="{FF2B5EF4-FFF2-40B4-BE49-F238E27FC236}">
-                <a16:creationId xmlns:a16="http://schemas.microsoft.com/office/drawing/2014/main" id="{C760562A-62B9-4CAE-A2BD-3C649F1FE10B}"/>
+                <a16:creationId xmlns:a16="http://schemas.microsoft.com/office/drawing/2014/main" id="{46621D9D-9902-4E0C-9786-675360687698}"/>
               </a:ext>
             </a:extLst>
           </p:cNvPr>
@@ -3848,7 +3958,7 @@
                 <a:ea typeface="Arial"/>
                 <a:cs typeface="Arial"/>
               </a:rPr>
-              <a:t>ИИ-разбор hh.ru</a:t>
+              <a:t>ИИ в hh.ru</a:t>
             </a:r>
           </a:p>
           <a:p xmlns:a="http://schemas.openxmlformats.org/drawingml/2006/main">
@@ -3871,7 +3981,7 @@
                 <a:ea typeface="Arial"/>
                 <a:cs typeface="Arial"/>
               </a:rPr>
-              <a:t>и данные для Skillaz</a:t>
+              <a:t>Результаты для Skillaz</a:t>
             </a:r>
           </a:p>
         </p:txBody>
@@ -3881,7 +3991,7 @@
           <p:cNvPr id="8" name="">
             <a:extLst xmlns:a="http://schemas.openxmlformats.org/drawingml/2006/main">
               <a:ext uri="{FF2B5EF4-FFF2-40B4-BE49-F238E27FC236}">
-                <a16:creationId xmlns:a16="http://schemas.microsoft.com/office/drawing/2014/main" id="{73085196-6DB4-4EF6-ACE5-307862CBE6F5}"/>
+                <a16:creationId xmlns:a16="http://schemas.microsoft.com/office/drawing/2014/main" id="{8DA59114-19C5-4476-AC62-B446762C0E3F}"/>
               </a:ext>
             </a:extLst>
           </p:cNvPr>
@@ -3939,7 +4049,7 @@
                 <a:ea typeface="Arial"/>
                 <a:cs typeface="Arial"/>
               </a:rPr>
-              <a:t>Результаты разбора и ответы кандидатов</a:t>
+              <a:t>Базовый вариант интеграции</a:t>
             </a:r>
           </a:p>
           <a:p xmlns:a="http://schemas.openxmlformats.org/drawingml/2006/main">
@@ -3962,7 +4072,7 @@
                 <a:ea typeface="Arial"/>
                 <a:cs typeface="Arial"/>
               </a:rPr>
-              <a:t>в публичной документации API hh.ru</a:t>
+              <a:t>на основе документации hh.ru</a:t>
             </a:r>
           </a:p>
         </p:txBody>
@@ -3972,7 +4082,7 @@
           <p:cNvPr id="9" name="">
             <a:extLst xmlns:a="http://schemas.openxmlformats.org/drawingml/2006/main">
               <a:ext uri="{FF2B5EF4-FFF2-40B4-BE49-F238E27FC236}">
-                <a16:creationId xmlns:a16="http://schemas.microsoft.com/office/drawing/2014/main" id="{4C38CBB7-9517-4ED1-A262-CEF8A55EFD86}"/>
+                <a16:creationId xmlns:a16="http://schemas.microsoft.com/office/drawing/2014/main" id="{3A60E2FA-760A-47BE-A472-1D36BD278A03}"/>
               </a:ext>
             </a:extLst>
           </p:cNvPr>
@@ -4040,7 +4150,7 @@
           <p:cNvPr id="10" name="">
             <a:extLst xmlns:a="http://schemas.openxmlformats.org/drawingml/2006/main">
               <a:ext uri="{FF2B5EF4-FFF2-40B4-BE49-F238E27FC236}">
-                <a16:creationId xmlns:a16="http://schemas.microsoft.com/office/drawing/2014/main" id="{CF181324-708B-4C25-92C9-7DE7FB9B9BED}"/>
+                <a16:creationId xmlns:a16="http://schemas.microsoft.com/office/drawing/2014/main" id="{90F1E914-01E8-4209-AD54-0205288AC690}"/>
               </a:ext>
             </a:extLst>
           </p:cNvPr>
@@ -4098,7 +4208,7 @@
                 <a:ea typeface="Arial"/>
                 <a:cs typeface="Arial"/>
               </a:rPr>
-              <a:t>Информация для первичного отбора.</a:t>
+              <a:t>Настройка и запуск — в hh.ru.</a:t>
             </a:r>
           </a:p>
           <a:p xmlns:a="http://schemas.openxmlformats.org/drawingml/2006/main">
@@ -4121,7 +4231,7 @@
                 <a:ea typeface="Arial"/>
                 <a:cs typeface="Arial"/>
               </a:rPr>
-              <a:t>Решение о следующем этапе принимает рекрутёр.</a:t>
+              <a:t>Получение данных в Skillaz требует проверки.</a:t>
             </a:r>
           </a:p>
         </p:txBody>
@@ -4129,7 +4239,7 @@
     </p:spTree>
     <p:extLst>
       <p:ext uri="{BB962C8B-B14F-4D97-AF65-F5344CB8AC3E}">
-        <p14:creationId xmlns:p14="http://schemas.microsoft.com/office/powerpoint/2010/main" val="2032271722"/>
+        <p14:creationId xmlns:p14="http://schemas.microsoft.com/office/powerpoint/2010/main" val="2108308437"/>
       </p:ext>
     </p:extLst>
   </p:cSld>
@@ -4160,7 +4270,7 @@
           <p:cNvPr id="21" name="">
             <a:extLst xmlns:a="http://schemas.openxmlformats.org/drawingml/2006/main">
               <a:ext uri="{FF2B5EF4-FFF2-40B4-BE49-F238E27FC236}">
-                <a16:creationId xmlns:a16="http://schemas.microsoft.com/office/drawing/2014/main" id="{48D92C47-6A89-48F6-833F-48C2338DD1BB}"/>
+                <a16:creationId xmlns:a16="http://schemas.microsoft.com/office/drawing/2014/main" id="{2BF70111-F4FE-4638-B291-8E17B06D17CD}"/>
               </a:ext>
             </a:extLst>
           </p:cNvPr>
@@ -4170,7 +4280,7 @@
           <p:nvPr/>
         </p:nvPicPr>
         <p:blipFill>
-          <a:blip xmlns:r="http://schemas.openxmlformats.org/officeDocument/2006/relationships" xmlns:a="http://schemas.openxmlformats.org/drawingml/2006/main" r:embed="R9796431a3f894f28"/>
+          <a:blip xmlns:r="http://schemas.openxmlformats.org/officeDocument/2006/relationships" xmlns:a="http://schemas.openxmlformats.org/drawingml/2006/main" r:embed="R7acd19212d854a12"/>
           <a:stretch xmlns:a="http://schemas.openxmlformats.org/drawingml/2006/main"/>
         </p:blipFill>
         <p:spPr>
@@ -4188,7 +4298,7 @@
           <p:cNvPr id="2" name="">
             <a:extLst xmlns:a="http://schemas.openxmlformats.org/drawingml/2006/main">
               <a:ext uri="{FF2B5EF4-FFF2-40B4-BE49-F238E27FC236}">
-                <a16:creationId xmlns:a16="http://schemas.microsoft.com/office/drawing/2014/main" id="{14B6C61A-958B-4AE1-BA68-2D44F4105FF9}"/>
+                <a16:creationId xmlns:a16="http://schemas.microsoft.com/office/drawing/2014/main" id="{B78376EB-ED41-4B77-8F56-4D347EC4B16B}"/>
               </a:ext>
             </a:extLst>
           </p:cNvPr>
@@ -4256,7 +4366,7 @@
           <p:cNvPr id="3" name="">
             <a:extLst xmlns:a="http://schemas.openxmlformats.org/drawingml/2006/main">
               <a:ext uri="{FF2B5EF4-FFF2-40B4-BE49-F238E27FC236}">
-                <a16:creationId xmlns:a16="http://schemas.microsoft.com/office/drawing/2014/main" id="{96F91C62-3109-4500-910A-914D486B1280}"/>
+                <a16:creationId xmlns:a16="http://schemas.microsoft.com/office/drawing/2014/main" id="{FCDB3AC1-7C77-41CC-A0D0-EDB15AD87F02}"/>
               </a:ext>
             </a:extLst>
           </p:cNvPr>
@@ -4324,7 +4434,7 @@
           <p:cNvPr id="4" name="">
             <a:extLst xmlns:a="http://schemas.openxmlformats.org/drawingml/2006/main">
               <a:ext uri="{FF2B5EF4-FFF2-40B4-BE49-F238E27FC236}">
-                <a16:creationId xmlns:a16="http://schemas.microsoft.com/office/drawing/2014/main" id="{C1C6A9FE-924E-4181-9C09-CBA571F465A6}"/>
+                <a16:creationId xmlns:a16="http://schemas.microsoft.com/office/drawing/2014/main" id="{EFB0ACC8-7EC2-4208-95F3-FBE3531AC374}"/>
               </a:ext>
             </a:extLst>
           </p:cNvPr>
@@ -4392,7 +4502,7 @@
           <p:cNvPr id="5" name="">
             <a:extLst xmlns:a="http://schemas.openxmlformats.org/drawingml/2006/main">
               <a:ext uri="{FF2B5EF4-FFF2-40B4-BE49-F238E27FC236}">
-                <a16:creationId xmlns:a16="http://schemas.microsoft.com/office/drawing/2014/main" id="{138A445C-A8CB-460E-B028-5C93C4DF766A}"/>
+                <a16:creationId xmlns:a16="http://schemas.microsoft.com/office/drawing/2014/main" id="{6A9D3148-A67E-4C2A-B302-843B4FBD2490}"/>
               </a:ext>
             </a:extLst>
           </p:cNvPr>
@@ -4460,7 +4570,7 @@
           <p:cNvPr id="6" name="">
             <a:extLst xmlns:a="http://schemas.openxmlformats.org/drawingml/2006/main">
               <a:ext uri="{FF2B5EF4-FFF2-40B4-BE49-F238E27FC236}">
-                <a16:creationId xmlns:a16="http://schemas.microsoft.com/office/drawing/2014/main" id="{832EF101-D76F-4C9D-ABBA-4F3D5FF5046A}"/>
+                <a16:creationId xmlns:a16="http://schemas.microsoft.com/office/drawing/2014/main" id="{6C7CD3EA-5DC5-4499-ADE7-0F48FF9B435C}"/>
               </a:ext>
             </a:extLst>
           </p:cNvPr>
@@ -4490,7 +4600,7 @@
           <p:cNvPr id="7" name="">
             <a:extLst xmlns:a="http://schemas.openxmlformats.org/drawingml/2006/main">
               <a:ext uri="{FF2B5EF4-FFF2-40B4-BE49-F238E27FC236}">
-                <a16:creationId xmlns:a16="http://schemas.microsoft.com/office/drawing/2014/main" id="{038861D7-E52E-42C8-B440-A00AFD358FF6}"/>
+                <a16:creationId xmlns:a16="http://schemas.microsoft.com/office/drawing/2014/main" id="{F73B30E1-5621-41EF-86D9-1FF727059456}"/>
               </a:ext>
             </a:extLst>
           </p:cNvPr>
@@ -4548,7 +4658,7 @@
                 <a:ea typeface="Arial"/>
                 <a:cs typeface="Arial"/>
               </a:rPr>
-              <a:t>Пилот интеграции со Skillaz</a:t>
+              <a:t>Сначала — проверка получения данных</a:t>
             </a:r>
           </a:p>
         </p:txBody>
@@ -4558,7 +4668,7 @@
           <p:cNvPr id="8" name="">
             <a:extLst xmlns:a="http://schemas.openxmlformats.org/drawingml/2006/main">
               <a:ext uri="{FF2B5EF4-FFF2-40B4-BE49-F238E27FC236}">
-                <a16:creationId xmlns:a16="http://schemas.microsoft.com/office/drawing/2014/main" id="{7E1DFCBB-B7B6-4899-BC0A-A5FB55F643DE}"/>
+                <a16:creationId xmlns:a16="http://schemas.microsoft.com/office/drawing/2014/main" id="{6532AA8D-B5D2-4B96-8AA1-75AEC163D84E}"/>
               </a:ext>
             </a:extLst>
           </p:cNvPr>
@@ -4626,7 +4736,7 @@
           <p:cNvPr id="9" name="">
             <a:extLst xmlns:a="http://schemas.openxmlformats.org/drawingml/2006/main">
               <a:ext uri="{FF2B5EF4-FFF2-40B4-BE49-F238E27FC236}">
-                <a16:creationId xmlns:a16="http://schemas.microsoft.com/office/drawing/2014/main" id="{B8785707-F9EF-44B3-A833-16D11F1CA997}"/>
+                <a16:creationId xmlns:a16="http://schemas.microsoft.com/office/drawing/2014/main" id="{BA9C2CFB-9238-4A53-A1AA-CD7A3590A258}"/>
               </a:ext>
             </a:extLst>
           </p:cNvPr>
@@ -4684,7 +4794,7 @@
                 <a:ea typeface="Arial"/>
                 <a:cs typeface="Arial"/>
               </a:rPr>
-              <a:t>Выбор процесса</a:t>
+              <a:t>Вакансия hh</a:t>
             </a:r>
           </a:p>
         </p:txBody>
@@ -4694,7 +4804,7 @@
           <p:cNvPr id="10" name="">
             <a:extLst xmlns:a="http://schemas.openxmlformats.org/drawingml/2006/main">
               <a:ext uri="{FF2B5EF4-FFF2-40B4-BE49-F238E27FC236}">
-                <a16:creationId xmlns:a16="http://schemas.microsoft.com/office/drawing/2014/main" id="{8D066444-230E-4D69-B963-622581587BF1}"/>
+                <a16:creationId xmlns:a16="http://schemas.microsoft.com/office/drawing/2014/main" id="{B454A198-8D9E-4D19-8AC8-F61238762B4E}"/>
               </a:ext>
             </a:extLst>
           </p:cNvPr>
@@ -4752,7 +4862,7 @@
                 <a:ea typeface="Arial"/>
                 <a:cs typeface="Arial"/>
               </a:rPr>
-              <a:t>Команда, вакансии и объём откликов</a:t>
+              <a:t>Включить навыки, настроить критерии и вопросы</a:t>
             </a:r>
           </a:p>
         </p:txBody>
@@ -4762,7 +4872,7 @@
           <p:cNvPr id="11" name="">
             <a:extLst xmlns:a="http://schemas.openxmlformats.org/drawingml/2006/main">
               <a:ext uri="{FF2B5EF4-FFF2-40B4-BE49-F238E27FC236}">
-                <a16:creationId xmlns:a16="http://schemas.microsoft.com/office/drawing/2014/main" id="{DFFE5E12-9DA9-47C4-A6AC-4AF55A1E41A3}"/>
+                <a16:creationId xmlns:a16="http://schemas.microsoft.com/office/drawing/2014/main" id="{58C00B82-3B14-412D-B1F7-3056A11DB3C3}"/>
               </a:ext>
             </a:extLst>
           </p:cNvPr>
@@ -4830,7 +4940,7 @@
           <p:cNvPr id="12" name="">
             <a:extLst xmlns:a="http://schemas.openxmlformats.org/drawingml/2006/main">
               <a:ext uri="{FF2B5EF4-FFF2-40B4-BE49-F238E27FC236}">
-                <a16:creationId xmlns:a16="http://schemas.microsoft.com/office/drawing/2014/main" id="{A3E1628E-4B39-42B9-ADD4-EB9F225CD5B9}"/>
+                <a16:creationId xmlns:a16="http://schemas.microsoft.com/office/drawing/2014/main" id="{71177637-5C09-497E-932F-22E5945AEF4F}"/>
               </a:ext>
             </a:extLst>
           </p:cNvPr>
@@ -4888,7 +4998,7 @@
                 <a:ea typeface="Arial"/>
                 <a:cs typeface="Arial"/>
               </a:rPr>
-              <a:t>Подготовка</a:t>
+              <a:t>Новый отклик</a:t>
             </a:r>
           </a:p>
         </p:txBody>
@@ -4898,7 +5008,7 @@
           <p:cNvPr id="13" name="">
             <a:extLst xmlns:a="http://schemas.openxmlformats.org/drawingml/2006/main">
               <a:ext uri="{FF2B5EF4-FFF2-40B4-BE49-F238E27FC236}">
-                <a16:creationId xmlns:a16="http://schemas.microsoft.com/office/drawing/2014/main" id="{25678793-9CEE-494F-A130-DEE188316827}"/>
+                <a16:creationId xmlns:a16="http://schemas.microsoft.com/office/drawing/2014/main" id="{14226174-AF2F-4B6A-B9ED-9299A7366881}"/>
               </a:ext>
             </a:extLst>
           </p:cNvPr>
@@ -4956,7 +5066,7 @@
                 <a:ea typeface="Arial"/>
                 <a:cs typeface="Arial"/>
               </a:rPr>
-              <a:t>Тестовый отклик и проверка получения данных</a:t>
+              <a:t>Получить разбор и ответы кандидата в hh</a:t>
             </a:r>
           </a:p>
         </p:txBody>
@@ -4966,7 +5076,7 @@
           <p:cNvPr id="14" name="">
             <a:extLst xmlns:a="http://schemas.openxmlformats.org/drawingml/2006/main">
               <a:ext uri="{FF2B5EF4-FFF2-40B4-BE49-F238E27FC236}">
-                <a16:creationId xmlns:a16="http://schemas.microsoft.com/office/drawing/2014/main" id="{8384F246-653A-4F2F-A845-584105E74EBD}"/>
+                <a16:creationId xmlns:a16="http://schemas.microsoft.com/office/drawing/2014/main" id="{A64055A8-75DB-451A-A9AF-C4F01C00B3B1}"/>
               </a:ext>
             </a:extLst>
           </p:cNvPr>
@@ -5034,7 +5144,7 @@
           <p:cNvPr id="15" name="">
             <a:extLst xmlns:a="http://schemas.openxmlformats.org/drawingml/2006/main">
               <a:ext uri="{FF2B5EF4-FFF2-40B4-BE49-F238E27FC236}">
-                <a16:creationId xmlns:a16="http://schemas.microsoft.com/office/drawing/2014/main" id="{FC777212-140F-4DAE-8476-1E3D50A07947}"/>
+                <a16:creationId xmlns:a16="http://schemas.microsoft.com/office/drawing/2014/main" id="{0F7C716A-67B5-4609-9ED6-EA4BB51BEA75}"/>
               </a:ext>
             </a:extLst>
           </p:cNvPr>
@@ -5092,7 +5202,7 @@
                 <a:ea typeface="Arial"/>
                 <a:cs typeface="Arial"/>
               </a:rPr>
-              <a:t>Пилот</a:t>
+              <a:t>Запрос API</a:t>
             </a:r>
           </a:p>
         </p:txBody>
@@ -5102,7 +5212,7 @@
           <p:cNvPr id="16" name="">
             <a:extLst xmlns:a="http://schemas.openxmlformats.org/drawingml/2006/main">
               <a:ext uri="{FF2B5EF4-FFF2-40B4-BE49-F238E27FC236}">
-                <a16:creationId xmlns:a16="http://schemas.microsoft.com/office/drawing/2014/main" id="{EF2FF0EF-1E4B-47AE-BFFD-A860B74CDCF8}"/>
+                <a16:creationId xmlns:a16="http://schemas.microsoft.com/office/drawing/2014/main" id="{A4A560CC-B20E-41DC-A95F-87F0BE26DFCB}"/>
               </a:ext>
             </a:extLst>
           </p:cNvPr>
@@ -5160,7 +5270,7 @@
                 <a:ea typeface="Arial"/>
                 <a:cs typeface="Arial"/>
               </a:rPr>
-              <a:t>Исходные показатели и изменения в работе</a:t>
+              <a:t>Проверить данные от имени приложения Skillaz</a:t>
             </a:r>
           </a:p>
         </p:txBody>
@@ -5170,7 +5280,7 @@
           <p:cNvPr id="17" name="">
             <a:extLst xmlns:a="http://schemas.openxmlformats.org/drawingml/2006/main">
               <a:ext uri="{FF2B5EF4-FFF2-40B4-BE49-F238E27FC236}">
-                <a16:creationId xmlns:a16="http://schemas.microsoft.com/office/drawing/2014/main" id="{5F1201B8-D20B-4D16-A6CB-3D1B74D4C20A}"/>
+                <a16:creationId xmlns:a16="http://schemas.microsoft.com/office/drawing/2014/main" id="{92631FE6-24EE-4A12-B6A5-DEE4C6952399}"/>
               </a:ext>
             </a:extLst>
           </p:cNvPr>
@@ -5238,7 +5348,7 @@
           <p:cNvPr id="18" name="">
             <a:extLst xmlns:a="http://schemas.openxmlformats.org/drawingml/2006/main">
               <a:ext uri="{FF2B5EF4-FFF2-40B4-BE49-F238E27FC236}">
-                <a16:creationId xmlns:a16="http://schemas.microsoft.com/office/drawing/2014/main" id="{C32EA530-5379-4A2E-BCB4-87C3BD057387}"/>
+                <a16:creationId xmlns:a16="http://schemas.microsoft.com/office/drawing/2014/main" id="{8D8BB9CF-7FDF-4F9F-A363-00D59744F178}"/>
               </a:ext>
             </a:extLst>
           </p:cNvPr>
@@ -5296,7 +5406,7 @@
                 <a:ea typeface="Arial"/>
                 <a:cs typeface="Arial"/>
               </a:rPr>
-              <a:t>Оценка</a:t>
+              <a:t>Результат</a:t>
             </a:r>
           </a:p>
         </p:txBody>
@@ -5306,7 +5416,7 @@
           <p:cNvPr id="19" name="">
             <a:extLst xmlns:a="http://schemas.openxmlformats.org/drawingml/2006/main">
               <a:ext uri="{FF2B5EF4-FFF2-40B4-BE49-F238E27FC236}">
-                <a16:creationId xmlns:a16="http://schemas.microsoft.com/office/drawing/2014/main" id="{E619D480-92F4-4506-BDE9-EBD63023EB92}"/>
+                <a16:creationId xmlns:a16="http://schemas.microsoft.com/office/drawing/2014/main" id="{BBD245A5-E1DD-4989-8988-697CE9D9F162}"/>
               </a:ext>
             </a:extLst>
           </p:cNvPr>
@@ -5364,7 +5474,7 @@
                 <a:ea typeface="Arial"/>
                 <a:cs typeface="Arial"/>
               </a:rPr>
-              <a:t>Высвобождённое время и стоимость использования</a:t>
+              <a:t>Подтвердить состав данных и доступ клиента</a:t>
             </a:r>
           </a:p>
         </p:txBody>
@@ -5374,7 +5484,7 @@
           <p:cNvPr id="20" name="">
             <a:extLst xmlns:a="http://schemas.openxmlformats.org/drawingml/2006/main">
               <a:ext uri="{FF2B5EF4-FFF2-40B4-BE49-F238E27FC236}">
-                <a16:creationId xmlns:a16="http://schemas.microsoft.com/office/drawing/2014/main" id="{97497242-C585-473D-A209-51EAD3E14979}"/>
+                <a16:creationId xmlns:a16="http://schemas.microsoft.com/office/drawing/2014/main" id="{EAE99F48-338B-46EC-87C7-AA435E61E415}"/>
               </a:ext>
             </a:extLst>
           </p:cNvPr>
@@ -5432,7 +5542,7 @@
                 <a:ea typeface="Arial"/>
                 <a:cs typeface="Arial"/>
               </a:rPr>
-              <a:t>Следующий шаг: рабочая встреча по сценарию и условиям пилота</a:t>
+              <a:t>Реализацию и предложение клиенту фиксируем после технической проверки</a:t>
             </a:r>
           </a:p>
         </p:txBody>
@@ -5440,7 +5550,7 @@
     </p:spTree>
     <p:extLst>
       <p:ext uri="{BB962C8B-B14F-4D97-AF65-F5344CB8AC3E}">
-        <p14:creationId xmlns:p14="http://schemas.microsoft.com/office/powerpoint/2010/main" val="875101982"/>
+        <p14:creationId xmlns:p14="http://schemas.microsoft.com/office/powerpoint/2010/main" val="267147850"/>
       </p:ext>
     </p:extLst>
   </p:cSld>
@@ -5471,7 +5581,7 @@
           <p:cNvPr id="15" name="">
             <a:extLst xmlns:a="http://schemas.openxmlformats.org/drawingml/2006/main">
               <a:ext uri="{FF2B5EF4-FFF2-40B4-BE49-F238E27FC236}">
-                <a16:creationId xmlns:a16="http://schemas.microsoft.com/office/drawing/2014/main" id="{E45057E6-9778-461E-9D00-937176DC049C}"/>
+                <a16:creationId xmlns:a16="http://schemas.microsoft.com/office/drawing/2014/main" id="{2ADCEDF9-4A32-46F1-AB3E-C98448A55CD2}"/>
               </a:ext>
             </a:extLst>
           </p:cNvPr>
@@ -5481,7 +5591,7 @@
           <p:nvPr/>
         </p:nvPicPr>
         <p:blipFill>
-          <a:blip xmlns:r="http://schemas.openxmlformats.org/officeDocument/2006/relationships" xmlns:a="http://schemas.openxmlformats.org/drawingml/2006/main" r:embed="Rb602084c2a6b4afc"/>
+          <a:blip xmlns:r="http://schemas.openxmlformats.org/officeDocument/2006/relationships" xmlns:a="http://schemas.openxmlformats.org/drawingml/2006/main" r:embed="R4477525c6c784047"/>
           <a:stretch xmlns:a="http://schemas.openxmlformats.org/drawingml/2006/main"/>
         </p:blipFill>
         <p:spPr>
@@ -5499,7 +5609,7 @@
           <p:cNvPr id="2" name="">
             <a:extLst xmlns:a="http://schemas.openxmlformats.org/drawingml/2006/main">
               <a:ext uri="{FF2B5EF4-FFF2-40B4-BE49-F238E27FC236}">
-                <a16:creationId xmlns:a16="http://schemas.microsoft.com/office/drawing/2014/main" id="{B6BCC6EA-593E-49ED-9B8B-412ADDA4BB2D}"/>
+                <a16:creationId xmlns:a16="http://schemas.microsoft.com/office/drawing/2014/main" id="{2FB3AEA3-1C1D-45DF-9C8A-7F73144DD810}"/>
               </a:ext>
             </a:extLst>
           </p:cNvPr>
@@ -5567,7 +5677,7 @@
           <p:cNvPr id="3" name="">
             <a:extLst xmlns:a="http://schemas.openxmlformats.org/drawingml/2006/main">
               <a:ext uri="{FF2B5EF4-FFF2-40B4-BE49-F238E27FC236}">
-                <a16:creationId xmlns:a16="http://schemas.microsoft.com/office/drawing/2014/main" id="{FDD3C684-A789-4DE5-A7C8-875E64090624}"/>
+                <a16:creationId xmlns:a16="http://schemas.microsoft.com/office/drawing/2014/main" id="{252D38D0-9A20-430B-A1F5-FFAB4C3BC09A}"/>
               </a:ext>
             </a:extLst>
           </p:cNvPr>
@@ -5625,7 +5735,7 @@
                 <a:ea typeface="Arial"/>
                 <a:cs typeface="Arial"/>
               </a:rPr>
-              <a:t>Какие данные описаны</a:t>
+              <a:t>Настройка для конкретной</a:t>
             </a:r>
           </a:p>
           <a:p xmlns:a="http://schemas.openxmlformats.org/drawingml/2006/main">
@@ -5648,7 +5758,7 @@
                 <a:ea typeface="Arial"/>
                 <a:cs typeface="Arial"/>
               </a:rPr>
-              <a:t>в API hh.ru</a:t>
+              <a:t>вакансии hh.ru</a:t>
             </a:r>
           </a:p>
         </p:txBody>
@@ -5658,7 +5768,7 @@
           <p:cNvPr id="4" name="">
             <a:extLst xmlns:a="http://schemas.openxmlformats.org/drawingml/2006/main">
               <a:ext uri="{FF2B5EF4-FFF2-40B4-BE49-F238E27FC236}">
-                <a16:creationId xmlns:a16="http://schemas.microsoft.com/office/drawing/2014/main" id="{06088BA2-AB6C-4D81-AB22-0AD0E703CD9D}"/>
+                <a16:creationId xmlns:a16="http://schemas.microsoft.com/office/drawing/2014/main" id="{D15311D1-D15A-4C9E-8E9F-8C6BCE8CB197}"/>
               </a:ext>
             </a:extLst>
           </p:cNvPr>
@@ -5726,7 +5836,7 @@
           <p:cNvPr id="5" name="">
             <a:extLst xmlns:a="http://schemas.openxmlformats.org/drawingml/2006/main">
               <a:ext uri="{FF2B5EF4-FFF2-40B4-BE49-F238E27FC236}">
-                <a16:creationId xmlns:a16="http://schemas.microsoft.com/office/drawing/2014/main" id="{8C50068A-31A3-4A12-95E4-10A8E9689408}"/>
+                <a16:creationId xmlns:a16="http://schemas.microsoft.com/office/drawing/2014/main" id="{9484571B-A60C-4A95-BAF3-9E87F805E708}"/>
               </a:ext>
             </a:extLst>
           </p:cNvPr>
@@ -5794,7 +5904,7 @@
           <p:cNvPr id="6" name="">
             <a:extLst xmlns:a="http://schemas.openxmlformats.org/drawingml/2006/main">
               <a:ext uri="{FF2B5EF4-FFF2-40B4-BE49-F238E27FC236}">
-                <a16:creationId xmlns:a16="http://schemas.microsoft.com/office/drawing/2014/main" id="{D3AA3F42-07BD-42FB-A867-E2B376B919D7}"/>
+                <a16:creationId xmlns:a16="http://schemas.microsoft.com/office/drawing/2014/main" id="{78273968-4222-4317-9B53-6AA5C707FD2B}"/>
               </a:ext>
             </a:extLst>
           </p:cNvPr>
@@ -5862,7 +5972,7 @@
           <p:cNvPr id="7" name="">
             <a:extLst xmlns:a="http://schemas.openxmlformats.org/drawingml/2006/main">
               <a:ext uri="{FF2B5EF4-FFF2-40B4-BE49-F238E27FC236}">
-                <a16:creationId xmlns:a16="http://schemas.microsoft.com/office/drawing/2014/main" id="{AF04AEB8-487D-453F-B4D3-FCBD23DF9F83}"/>
+                <a16:creationId xmlns:a16="http://schemas.microsoft.com/office/drawing/2014/main" id="{B93CDE19-5EA8-4926-9DDE-8818830BCF4B}"/>
               </a:ext>
             </a:extLst>
           </p:cNvPr>
@@ -5920,7 +6030,7 @@
                 <a:ea typeface="Courier New"/>
                 <a:cs typeface="Courier New"/>
               </a:rPr>
-              <a:t>РАЗБОР РЕЗЮМЕ</a:t>
+              <a:t>ПОРТРЕТ КАНДИДАТА</a:t>
             </a:r>
           </a:p>
         </p:txBody>
@@ -5930,7 +6040,7 @@
           <p:cNvPr id="8" name="">
             <a:extLst xmlns:a="http://schemas.openxmlformats.org/drawingml/2006/main">
               <a:ext uri="{FF2B5EF4-FFF2-40B4-BE49-F238E27FC236}">
-                <a16:creationId xmlns:a16="http://schemas.microsoft.com/office/drawing/2014/main" id="{6E526D7A-6F82-4539-AE86-4829BDBB54F1}"/>
+                <a16:creationId xmlns:a16="http://schemas.microsoft.com/office/drawing/2014/main" id="{EC04C88A-3285-4075-8BEB-44749E1458BE}"/>
               </a:ext>
             </a:extLst>
           </p:cNvPr>
@@ -5988,7 +6098,7 @@
                 <a:ea typeface="Arial"/>
                 <a:cs typeface="Arial"/>
               </a:rPr>
-              <a:t>Оценка и основания</a:t>
+              <a:t>Критерии вакансии</a:t>
             </a:r>
           </a:p>
         </p:txBody>
@@ -5998,7 +6108,7 @@
           <p:cNvPr id="9" name="">
             <a:extLst xmlns:a="http://schemas.openxmlformats.org/drawingml/2006/main">
               <a:ext uri="{FF2B5EF4-FFF2-40B4-BE49-F238E27FC236}">
-                <a16:creationId xmlns:a16="http://schemas.microsoft.com/office/drawing/2014/main" id="{82976782-ECDE-4162-8B41-AAD840F9BCC6}"/>
+                <a16:creationId xmlns:a16="http://schemas.microsoft.com/office/drawing/2014/main" id="{7097A0AA-46F1-46F7-9DD9-8869A24AF3E2}"/>
               </a:ext>
             </a:extLst>
           </p:cNvPr>
@@ -6056,7 +6166,7 @@
                 <a:ea typeface="Arial"/>
                 <a:cs typeface="Arial"/>
               </a:rPr>
-              <a:t>Результат оценки</a:t>
+              <a:t>Обязательные и желательные</a:t>
             </a:r>
           </a:p>
           <a:p xmlns:a="http://schemas.openxmlformats.org/drawingml/2006/main">
@@ -6079,7 +6189,7 @@
                 <a:ea typeface="Arial"/>
                 <a:cs typeface="Arial"/>
               </a:rPr>
-              <a:t>Краткая сводка</a:t>
+              <a:t>Извлекаются из текста вакансии</a:t>
             </a:r>
           </a:p>
           <a:p xmlns:a="http://schemas.openxmlformats.org/drawingml/2006/main">
@@ -6102,7 +6212,7 @@
                 <a:ea typeface="Arial"/>
                 <a:cs typeface="Arial"/>
               </a:rPr>
-              <a:t>Выполнение критериев</a:t>
+              <a:t>Можно менять и добавлять свои</a:t>
             </a:r>
           </a:p>
           <a:p xmlns:a="http://schemas.openxmlformats.org/drawingml/2006/main">
@@ -6125,7 +6235,7 @@
                 <a:ea typeface="Arial"/>
                 <a:cs typeface="Arial"/>
               </a:rPr>
-              <a:t>Объяснение по каждому критерию</a:t>
+              <a:t>Закрытого списка требований нет</a:t>
             </a:r>
           </a:p>
         </p:txBody>
@@ -6135,7 +6245,7 @@
           <p:cNvPr id="10" name="">
             <a:extLst xmlns:a="http://schemas.openxmlformats.org/drawingml/2006/main">
               <a:ext uri="{FF2B5EF4-FFF2-40B4-BE49-F238E27FC236}">
-                <a16:creationId xmlns:a16="http://schemas.microsoft.com/office/drawing/2014/main" id="{EDD77568-8068-41F1-AE12-C2A713AD6B8C}"/>
+                <a16:creationId xmlns:a16="http://schemas.microsoft.com/office/drawing/2014/main" id="{73695257-424B-4568-8609-C91369ABBB3D}"/>
               </a:ext>
             </a:extLst>
           </p:cNvPr>
@@ -6165,7 +6275,7 @@
           <p:cNvPr id="11" name="">
             <a:extLst xmlns:a="http://schemas.openxmlformats.org/drawingml/2006/main">
               <a:ext uri="{FF2B5EF4-FFF2-40B4-BE49-F238E27FC236}">
-                <a16:creationId xmlns:a16="http://schemas.microsoft.com/office/drawing/2014/main" id="{7824D4E7-39DA-4FB2-81D4-70CC131D48D7}"/>
+                <a16:creationId xmlns:a16="http://schemas.microsoft.com/office/drawing/2014/main" id="{8B467746-E217-40CA-A88F-9B734C777D40}"/>
               </a:ext>
             </a:extLst>
           </p:cNvPr>
@@ -6223,7 +6333,7 @@
                 <a:ea typeface="Courier New"/>
                 <a:cs typeface="Courier New"/>
               </a:rPr>
-              <a:t>ОТВЕТЫ КАНДИДАТА</a:t>
+              <a:t>ДВА НАВЫКА</a:t>
             </a:r>
           </a:p>
         </p:txBody>
@@ -6233,7 +6343,7 @@
           <p:cNvPr id="12" name="">
             <a:extLst xmlns:a="http://schemas.openxmlformats.org/drawingml/2006/main">
               <a:ext uri="{FF2B5EF4-FFF2-40B4-BE49-F238E27FC236}">
-                <a16:creationId xmlns:a16="http://schemas.microsoft.com/office/drawing/2014/main" id="{A9625768-437E-4081-8785-3AD7902B921F}"/>
+                <a16:creationId xmlns:a16="http://schemas.microsoft.com/office/drawing/2014/main" id="{38BFAD96-09D7-4B77-A608-7C9FBEC46F9D}"/>
               </a:ext>
             </a:extLst>
           </p:cNvPr>
@@ -6291,7 +6401,7 @@
                 <a:ea typeface="Arial"/>
                 <a:cs typeface="Arial"/>
               </a:rPr>
-              <a:t>Вопросы и ответы</a:t>
+              <a:t>Сортировка и вопросы</a:t>
             </a:r>
           </a:p>
         </p:txBody>
@@ -6301,7 +6411,7 @@
           <p:cNvPr id="13" name="">
             <a:extLst xmlns:a="http://schemas.openxmlformats.org/drawingml/2006/main">
               <a:ext uri="{FF2B5EF4-FFF2-40B4-BE49-F238E27FC236}">
-                <a16:creationId xmlns:a16="http://schemas.microsoft.com/office/drawing/2014/main" id="{C6FBB2B3-DF04-43BA-B384-C85A82B692B6}"/>
+                <a16:creationId xmlns:a16="http://schemas.microsoft.com/office/drawing/2014/main" id="{E6A14476-BDF9-4AF1-AE63-89C3B2714A70}"/>
               </a:ext>
             </a:extLst>
           </p:cNvPr>
@@ -6359,7 +6469,7 @@
                 <a:ea typeface="Arial"/>
                 <a:cs typeface="Arial"/>
               </a:rPr>
-              <a:t>Вопрос работодателя</a:t>
+              <a:t>При подключении включены оба</a:t>
             </a:r>
           </a:p>
           <a:p xmlns:a="http://schemas.openxmlformats.org/drawingml/2006/main">
@@ -6382,7 +6492,7 @@
                 <a:ea typeface="Arial"/>
                 <a:cs typeface="Arial"/>
               </a:rPr>
-              <a:t>Цитата ответа кандидата</a:t>
+              <a:t>Каждый можно отключить отдельно</a:t>
             </a:r>
           </a:p>
           <a:p xmlns:a="http://schemas.openxmlformats.org/drawingml/2006/main">
@@ -6405,7 +6515,7 @@
                 <a:ea typeface="Arial"/>
                 <a:cs typeface="Arial"/>
               </a:rPr>
-              <a:t>Статус ответов и вопросы кандидата</a:t>
+              <a:t>Настройки выполняются в hh.ru</a:t>
             </a:r>
           </a:p>
         </p:txBody>
@@ -6415,7 +6525,7 @@
           <p:cNvPr id="14" name="">
             <a:extLst xmlns:a="http://schemas.openxmlformats.org/drawingml/2006/main">
               <a:ext uri="{FF2B5EF4-FFF2-40B4-BE49-F238E27FC236}">
-                <a16:creationId xmlns:a16="http://schemas.microsoft.com/office/drawing/2014/main" id="{0B342E77-0647-40DE-8900-9F52C748BCEC}"/>
+                <a16:creationId xmlns:a16="http://schemas.microsoft.com/office/drawing/2014/main" id="{3899B57A-2192-478C-8068-2FC4FEC5F94A}"/>
               </a:ext>
             </a:extLst>
           </p:cNvPr>
@@ -6473,7 +6583,7 @@
                 <a:ea typeface="Arial"/>
                 <a:cs typeface="Arial"/>
               </a:rPr>
-              <a:t>Эти данные приведены в официальных примерах ответа API hh.ru.</a:t>
+              <a:t>Оценка относится к отклику на выбранную вакансию.</a:t>
             </a:r>
           </a:p>
         </p:txBody>
@@ -6481,7 +6591,7 @@
     </p:spTree>
     <p:extLst>
       <p:ext uri="{BB962C8B-B14F-4D97-AF65-F5344CB8AC3E}">
-        <p14:creationId xmlns:p14="http://schemas.microsoft.com/office/powerpoint/2010/main" val="1268114413"/>
+        <p14:creationId xmlns:p14="http://schemas.microsoft.com/office/powerpoint/2010/main" val="862981122"/>
       </p:ext>
     </p:extLst>
   </p:cSld>
@@ -6512,7 +6622,7 @@
           <p:cNvPr id="9" name="">
             <a:extLst xmlns:a="http://schemas.openxmlformats.org/drawingml/2006/main">
               <a:ext uri="{FF2B5EF4-FFF2-40B4-BE49-F238E27FC236}">
-                <a16:creationId xmlns:a16="http://schemas.microsoft.com/office/drawing/2014/main" id="{62A5C534-EBF5-4079-8077-B9C1C50FE6FA}"/>
+                <a16:creationId xmlns:a16="http://schemas.microsoft.com/office/drawing/2014/main" id="{41875E42-ACF9-4905-9309-B129175A7C41}"/>
               </a:ext>
             </a:extLst>
           </p:cNvPr>
@@ -6522,7 +6632,7 @@
           <p:nvPr/>
         </p:nvPicPr>
         <p:blipFill>
-          <a:blip xmlns:r="http://schemas.openxmlformats.org/officeDocument/2006/relationships" xmlns:a="http://schemas.openxmlformats.org/drawingml/2006/main" r:embed="R6994967d1a004831"/>
+          <a:blip xmlns:r="http://schemas.openxmlformats.org/officeDocument/2006/relationships" xmlns:a="http://schemas.openxmlformats.org/drawingml/2006/main" r:embed="R4fc508d193c04d84"/>
           <a:stretch xmlns:a="http://schemas.openxmlformats.org/drawingml/2006/main"/>
         </p:blipFill>
         <p:spPr>
@@ -6540,7 +6650,7 @@
           <p:cNvPr id="2" name="">
             <a:extLst xmlns:a="http://schemas.openxmlformats.org/drawingml/2006/main">
               <a:ext uri="{FF2B5EF4-FFF2-40B4-BE49-F238E27FC236}">
-                <a16:creationId xmlns:a16="http://schemas.microsoft.com/office/drawing/2014/main" id="{5CAC21E0-820F-4EBE-A44C-908671F291EB}"/>
+                <a16:creationId xmlns:a16="http://schemas.microsoft.com/office/drawing/2014/main" id="{E09B7C5F-1024-4B90-B27C-DE75A1138469}"/>
               </a:ext>
             </a:extLst>
           </p:cNvPr>
@@ -6608,7 +6718,7 @@
           <p:cNvPr id="3" name="">
             <a:extLst xmlns:a="http://schemas.openxmlformats.org/drawingml/2006/main">
               <a:ext uri="{FF2B5EF4-FFF2-40B4-BE49-F238E27FC236}">
-                <a16:creationId xmlns:a16="http://schemas.microsoft.com/office/drawing/2014/main" id="{C852FB7C-673B-477E-8587-C5BEA81EF740}"/>
+                <a16:creationId xmlns:a16="http://schemas.microsoft.com/office/drawing/2014/main" id="{402830B2-E820-4315-84CC-3C80AEDDAEE4}"/>
               </a:ext>
             </a:extLst>
           </p:cNvPr>
@@ -6699,7 +6809,7 @@
           <p:cNvPr id="4" name="">
             <a:extLst xmlns:a="http://schemas.openxmlformats.org/drawingml/2006/main">
               <a:ext uri="{FF2B5EF4-FFF2-40B4-BE49-F238E27FC236}">
-                <a16:creationId xmlns:a16="http://schemas.microsoft.com/office/drawing/2014/main" id="{1C6794CB-491E-48E6-9D30-EC384B037ED8}"/>
+                <a16:creationId xmlns:a16="http://schemas.microsoft.com/office/drawing/2014/main" id="{A15022D2-4ABC-4B8C-AFBC-B4257053B87F}"/>
               </a:ext>
             </a:extLst>
           </p:cNvPr>
@@ -6767,7 +6877,7 @@
           <p:cNvPr id="5" name="">
             <a:extLst xmlns:a="http://schemas.openxmlformats.org/drawingml/2006/main">
               <a:ext uri="{FF2B5EF4-FFF2-40B4-BE49-F238E27FC236}">
-                <a16:creationId xmlns:a16="http://schemas.microsoft.com/office/drawing/2014/main" id="{52789DD2-7605-4CE6-A8AF-0B495DF740F2}"/>
+                <a16:creationId xmlns:a16="http://schemas.microsoft.com/office/drawing/2014/main" id="{F4A920E2-2101-4B61-B252-36EB34625DD4}"/>
               </a:ext>
             </a:extLst>
           </p:cNvPr>
@@ -6835,7 +6945,7 @@
           <p:cNvPr id="6" name="">
             <a:extLst xmlns:a="http://schemas.openxmlformats.org/drawingml/2006/main">
               <a:ext uri="{FF2B5EF4-FFF2-40B4-BE49-F238E27FC236}">
-                <a16:creationId xmlns:a16="http://schemas.microsoft.com/office/drawing/2014/main" id="{EF5D73B5-A47F-4951-B667-F58E44D2712B}"/>
+                <a16:creationId xmlns:a16="http://schemas.microsoft.com/office/drawing/2014/main" id="{AA1F45BA-65B8-43F7-B1FE-B486BC6513F3}"/>
               </a:ext>
             </a:extLst>
           </p:cNvPr>
@@ -6903,7 +7013,7 @@
           <p:cNvPr id="7" name="">
             <a:extLst xmlns:a="http://schemas.openxmlformats.org/drawingml/2006/main">
               <a:ext uri="{FF2B5EF4-FFF2-40B4-BE49-F238E27FC236}">
-                <a16:creationId xmlns:a16="http://schemas.microsoft.com/office/drawing/2014/main" id="{4BB2493D-2DCC-4C26-A42E-8A7098862515}"/>
+                <a16:creationId xmlns:a16="http://schemas.microsoft.com/office/drawing/2014/main" id="{E78780A7-14B4-4F50-AFF7-F1A09C666CA2}"/>
               </a:ext>
             </a:extLst>
           </p:cNvPr>
@@ -7343,7 +7453,7 @@
           <p:cNvPr id="8" name="">
             <a:extLst xmlns:a="http://schemas.openxmlformats.org/drawingml/2006/main">
               <a:ext uri="{FF2B5EF4-FFF2-40B4-BE49-F238E27FC236}">
-                <a16:creationId xmlns:a16="http://schemas.microsoft.com/office/drawing/2014/main" id="{87D20C70-87F5-4C7B-98F9-3DB4D92624D8}"/>
+                <a16:creationId xmlns:a16="http://schemas.microsoft.com/office/drawing/2014/main" id="{D7AFC4AA-FE59-43C6-AD33-B5D721FABEDF}"/>
               </a:ext>
             </a:extLst>
           </p:cNvPr>
@@ -7409,7 +7519,7 @@
     </p:spTree>
     <p:extLst>
       <p:ext uri="{BB962C8B-B14F-4D97-AF65-F5344CB8AC3E}">
-        <p14:creationId xmlns:p14="http://schemas.microsoft.com/office/powerpoint/2010/main" val="364600141"/>
+        <p14:creationId xmlns:p14="http://schemas.microsoft.com/office/powerpoint/2010/main" val="185717131"/>
       </p:ext>
     </p:extLst>
   </p:cSld>
@@ -7440,7 +7550,7 @@
           <p:cNvPr id="19" name="">
             <a:extLst xmlns:a="http://schemas.openxmlformats.org/drawingml/2006/main">
               <a:ext uri="{FF2B5EF4-FFF2-40B4-BE49-F238E27FC236}">
-                <a16:creationId xmlns:a16="http://schemas.microsoft.com/office/drawing/2014/main" id="{D76A4182-4740-4E70-B917-EA29F8BB5209}"/>
+                <a16:creationId xmlns:a16="http://schemas.microsoft.com/office/drawing/2014/main" id="{DC83B017-BE14-4669-9ADC-532DC6C71DF6}"/>
               </a:ext>
             </a:extLst>
           </p:cNvPr>
@@ -7450,7 +7560,7 @@
           <p:nvPr/>
         </p:nvPicPr>
         <p:blipFill>
-          <a:blip xmlns:r="http://schemas.openxmlformats.org/officeDocument/2006/relationships" xmlns:a="http://schemas.openxmlformats.org/drawingml/2006/main" r:embed="Rb0430e2231ff4f95"/>
+          <a:blip xmlns:r="http://schemas.openxmlformats.org/officeDocument/2006/relationships" xmlns:a="http://schemas.openxmlformats.org/drawingml/2006/main" r:embed="Ra447ab1ef45c498b"/>
           <a:stretch xmlns:a="http://schemas.openxmlformats.org/drawingml/2006/main"/>
         </p:blipFill>
         <p:spPr>
@@ -7468,7 +7578,7 @@
           <p:cNvPr id="2" name="">
             <a:extLst xmlns:a="http://schemas.openxmlformats.org/drawingml/2006/main">
               <a:ext uri="{FF2B5EF4-FFF2-40B4-BE49-F238E27FC236}">
-                <a16:creationId xmlns:a16="http://schemas.microsoft.com/office/drawing/2014/main" id="{39A09D0A-8109-4AC8-AC5D-EC22D641A31A}"/>
+                <a16:creationId xmlns:a16="http://schemas.microsoft.com/office/drawing/2014/main" id="{13711F5B-D980-4CAC-8EF1-A031F8DD2B80}"/>
               </a:ext>
             </a:extLst>
           </p:cNvPr>
@@ -7536,7 +7646,7 @@
           <p:cNvPr id="3" name="">
             <a:extLst xmlns:a="http://schemas.openxmlformats.org/drawingml/2006/main">
               <a:ext uri="{FF2B5EF4-FFF2-40B4-BE49-F238E27FC236}">
-                <a16:creationId xmlns:a16="http://schemas.microsoft.com/office/drawing/2014/main" id="{7322CCDF-0BD7-4F92-AC02-A435F7D676FC}"/>
+                <a16:creationId xmlns:a16="http://schemas.microsoft.com/office/drawing/2014/main" id="{1CD87C1A-D58B-4553-8146-DDDD553E2DF4}"/>
               </a:ext>
             </a:extLst>
           </p:cNvPr>
@@ -7594,7 +7704,7 @@
                 <a:ea typeface="Arial"/>
                 <a:cs typeface="Arial"/>
               </a:rPr>
-              <a:t>Получение результатов ИИ</a:t>
+              <a:t>Когда запускается разбор</a:t>
             </a:r>
           </a:p>
         </p:txBody>
@@ -7604,7 +7714,7 @@
           <p:cNvPr id="4" name="">
             <a:extLst xmlns:a="http://schemas.openxmlformats.org/drawingml/2006/main">
               <a:ext uri="{FF2B5EF4-FFF2-40B4-BE49-F238E27FC236}">
-                <a16:creationId xmlns:a16="http://schemas.microsoft.com/office/drawing/2014/main" id="{A8DDED11-A9D1-4E8A-8955-E0865A236C03}"/>
+                <a16:creationId xmlns:a16="http://schemas.microsoft.com/office/drawing/2014/main" id="{EE2077FD-718A-4246-9D06-6BDC08AA26AD}"/>
               </a:ext>
             </a:extLst>
           </p:cNvPr>
@@ -7672,7 +7782,7 @@
           <p:cNvPr id="5" name="">
             <a:extLst xmlns:a="http://schemas.openxmlformats.org/drawingml/2006/main">
               <a:ext uri="{FF2B5EF4-FFF2-40B4-BE49-F238E27FC236}">
-                <a16:creationId xmlns:a16="http://schemas.microsoft.com/office/drawing/2014/main" id="{A06CAEAD-D163-4886-BE53-5BFDB8652936}"/>
+                <a16:creationId xmlns:a16="http://schemas.microsoft.com/office/drawing/2014/main" id="{D3262AA1-A5A6-4F86-B712-ED0CF8501C6D}"/>
               </a:ext>
             </a:extLst>
           </p:cNvPr>
@@ -7740,7 +7850,7 @@
           <p:cNvPr id="6" name="">
             <a:extLst xmlns:a="http://schemas.openxmlformats.org/drawingml/2006/main">
               <a:ext uri="{FF2B5EF4-FFF2-40B4-BE49-F238E27FC236}">
-                <a16:creationId xmlns:a16="http://schemas.microsoft.com/office/drawing/2014/main" id="{068B0571-5158-4010-903B-E7BAEDBE92D5}"/>
+                <a16:creationId xmlns:a16="http://schemas.microsoft.com/office/drawing/2014/main" id="{BAE8F5F5-F1C2-4564-961E-C74F505EA0C8}"/>
               </a:ext>
             </a:extLst>
           </p:cNvPr>
@@ -7808,7 +7918,7 @@
           <p:cNvPr id="7" name="">
             <a:extLst xmlns:a="http://schemas.openxmlformats.org/drawingml/2006/main">
               <a:ext uri="{FF2B5EF4-FFF2-40B4-BE49-F238E27FC236}">
-                <a16:creationId xmlns:a16="http://schemas.microsoft.com/office/drawing/2014/main" id="{BE97FCB3-9919-4896-9C57-A5232856A434}"/>
+                <a16:creationId xmlns:a16="http://schemas.microsoft.com/office/drawing/2014/main" id="{1CD0C714-2F35-405C-9537-1F08D1A12CE3}"/>
               </a:ext>
             </a:extLst>
           </p:cNvPr>
@@ -7876,7 +7986,7 @@
           <p:cNvPr id="8" name="">
             <a:extLst xmlns:a="http://schemas.openxmlformats.org/drawingml/2006/main">
               <a:ext uri="{FF2B5EF4-FFF2-40B4-BE49-F238E27FC236}">
-                <a16:creationId xmlns:a16="http://schemas.microsoft.com/office/drawing/2014/main" id="{45EE418D-F9F6-4DAB-A5E7-C1B809612EC1}"/>
+                <a16:creationId xmlns:a16="http://schemas.microsoft.com/office/drawing/2014/main" id="{31982F2A-A005-431C-B528-2F3BE3248C0B}"/>
               </a:ext>
             </a:extLst>
           </p:cNvPr>
@@ -7934,7 +8044,7 @@
                 <a:ea typeface="Arial"/>
                 <a:cs typeface="Arial"/>
               </a:rPr>
-              <a:t>Настройка в hh.ru</a:t>
+              <a:t>Подключение к вакансии</a:t>
             </a:r>
           </a:p>
         </p:txBody>
@@ -7944,7 +8054,7 @@
           <p:cNvPr id="9" name="">
             <a:extLst xmlns:a="http://schemas.openxmlformats.org/drawingml/2006/main">
               <a:ext uri="{FF2B5EF4-FFF2-40B4-BE49-F238E27FC236}">
-                <a16:creationId xmlns:a16="http://schemas.microsoft.com/office/drawing/2014/main" id="{BEDB52AB-A5BA-4724-B09F-06979F78A8F5}"/>
+                <a16:creationId xmlns:a16="http://schemas.microsoft.com/office/drawing/2014/main" id="{57646508-DB0A-4C1F-B362-CE5111D22C58}"/>
               </a:ext>
             </a:extLst>
           </p:cNvPr>
@@ -8002,7 +8112,7 @@
                 <a:ea typeface="Arial"/>
                 <a:cs typeface="Arial"/>
               </a:rPr>
-              <a:t>Критерии разбора и вопросы задаются в интерфейсе hh.ru.</a:t>
+              <a:t>hh начинает автоматически сортировать отклики этой вакансии.</a:t>
             </a:r>
           </a:p>
         </p:txBody>
@@ -8012,7 +8122,7 @@
           <p:cNvPr id="10" name="">
             <a:extLst xmlns:a="http://schemas.openxmlformats.org/drawingml/2006/main">
               <a:ext uri="{FF2B5EF4-FFF2-40B4-BE49-F238E27FC236}">
-                <a16:creationId xmlns:a16="http://schemas.microsoft.com/office/drawing/2014/main" id="{C36891B1-133C-49EB-A812-9BEFFAF5961E}"/>
+                <a16:creationId xmlns:a16="http://schemas.microsoft.com/office/drawing/2014/main" id="{F8806500-69E3-46BC-B77B-607DCEADF4C7}"/>
               </a:ext>
             </a:extLst>
           </p:cNvPr>
@@ -8080,7 +8190,7 @@
           <p:cNvPr id="11" name="">
             <a:extLst xmlns:a="http://schemas.openxmlformats.org/drawingml/2006/main">
               <a:ext uri="{FF2B5EF4-FFF2-40B4-BE49-F238E27FC236}">
-                <a16:creationId xmlns:a16="http://schemas.microsoft.com/office/drawing/2014/main" id="{4A2624B1-E903-4C31-856D-D5256B78FD08}"/>
+                <a16:creationId xmlns:a16="http://schemas.microsoft.com/office/drawing/2014/main" id="{7E8C0AD6-BFA7-491E-9830-3C2EF867E98C}"/>
               </a:ext>
             </a:extLst>
           </p:cNvPr>
@@ -8138,7 +8248,7 @@
                 <a:ea typeface="Arial"/>
                 <a:cs typeface="Arial"/>
               </a:rPr>
-              <a:t>Разбор и диалог в hh.ru</a:t>
+              <a:t>Новый отклик</a:t>
             </a:r>
           </a:p>
         </p:txBody>
@@ -8148,7 +8258,7 @@
           <p:cNvPr id="12" name="">
             <a:extLst xmlns:a="http://schemas.openxmlformats.org/drawingml/2006/main">
               <a:ext uri="{FF2B5EF4-FFF2-40B4-BE49-F238E27FC236}">
-                <a16:creationId xmlns:a16="http://schemas.microsoft.com/office/drawing/2014/main" id="{27FC47B4-02B4-46ED-A04A-5FCA45F33186}"/>
+                <a16:creationId xmlns:a16="http://schemas.microsoft.com/office/drawing/2014/main" id="{E247E48B-100A-4A58-B315-E9D7CCFD3CED}"/>
               </a:ext>
             </a:extLst>
           </p:cNvPr>
@@ -8206,7 +8316,7 @@
                 <a:ea typeface="Arial"/>
                 <a:cs typeface="Arial"/>
               </a:rPr>
-              <a:t>ИИ сопоставляет резюме с требованиями и уточняет недостающие сведения.</a:t>
+              <a:t>При включённом навыке hh автоматически анализирует резюме.</a:t>
             </a:r>
           </a:p>
         </p:txBody>
@@ -8216,7 +8326,7 @@
           <p:cNvPr id="13" name="">
             <a:extLst xmlns:a="http://schemas.openxmlformats.org/drawingml/2006/main">
               <a:ext uri="{FF2B5EF4-FFF2-40B4-BE49-F238E27FC236}">
-                <a16:creationId xmlns:a16="http://schemas.microsoft.com/office/drawing/2014/main" id="{51D144EF-40A6-47C4-9535-3A5B6B2D4095}"/>
+                <a16:creationId xmlns:a16="http://schemas.microsoft.com/office/drawing/2014/main" id="{99211D74-20E9-4604-8DD1-407B58E0498B}"/>
               </a:ext>
             </a:extLst>
           </p:cNvPr>
@@ -8284,7 +8394,7 @@
           <p:cNvPr id="14" name="">
             <a:extLst xmlns:a="http://schemas.openxmlformats.org/drawingml/2006/main">
               <a:ext uri="{FF2B5EF4-FFF2-40B4-BE49-F238E27FC236}">
-                <a16:creationId xmlns:a16="http://schemas.microsoft.com/office/drawing/2014/main" id="{0216AF3B-1CCF-4BD2-AEE6-079937DEBFDD}"/>
+                <a16:creationId xmlns:a16="http://schemas.microsoft.com/office/drawing/2014/main" id="{064DDEA7-3F1D-4512-97C3-B78F8A551D27}"/>
               </a:ext>
             </a:extLst>
           </p:cNvPr>
@@ -8342,7 +8452,7 @@
                 <a:ea typeface="Arial"/>
                 <a:cs typeface="Arial"/>
               </a:rPr>
-              <a:t>Данные в API hh.ru</a:t>
+              <a:t>Изменение критериев в hh.ru</a:t>
             </a:r>
           </a:p>
         </p:txBody>
@@ -8352,7 +8462,7 @@
           <p:cNvPr id="15" name="">
             <a:extLst xmlns:a="http://schemas.openxmlformats.org/drawingml/2006/main">
               <a:ext uri="{FF2B5EF4-FFF2-40B4-BE49-F238E27FC236}">
-                <a16:creationId xmlns:a16="http://schemas.microsoft.com/office/drawing/2014/main" id="{D70C35D9-4620-4290-8C36-F60E5900BED9}"/>
+                <a16:creationId xmlns:a16="http://schemas.microsoft.com/office/drawing/2014/main" id="{50CED218-4580-4F74-B0FF-FDC70E1CF6DC}"/>
               </a:ext>
             </a:extLst>
           </p:cNvPr>
@@ -8410,7 +8520,7 @@
                 <a:ea typeface="Arial"/>
                 <a:cs typeface="Arial"/>
               </a:rPr>
-              <a:t>В примерах ответа на запрос отклика есть оценка и ответы кандидата.</a:t>
+              <a:t>После сохранения портрета hh запускает повторную сортировку.</a:t>
             </a:r>
           </a:p>
         </p:txBody>
@@ -8420,7 +8530,7 @@
           <p:cNvPr id="16" name="">
             <a:extLst xmlns:a="http://schemas.openxmlformats.org/drawingml/2006/main">
               <a:ext uri="{FF2B5EF4-FFF2-40B4-BE49-F238E27FC236}">
-                <a16:creationId xmlns:a16="http://schemas.microsoft.com/office/drawing/2014/main" id="{55A0D549-BEE5-4F7B-9E97-B33AA4A6C0AF}"/>
+                <a16:creationId xmlns:a16="http://schemas.microsoft.com/office/drawing/2014/main" id="{337310A4-B9BD-450E-B5B9-DDF48B45B301}"/>
               </a:ext>
             </a:extLst>
           </p:cNvPr>
@@ -8488,7 +8598,7 @@
           <p:cNvPr id="17" name="">
             <a:extLst xmlns:a="http://schemas.openxmlformats.org/drawingml/2006/main">
               <a:ext uri="{FF2B5EF4-FFF2-40B4-BE49-F238E27FC236}">
-                <a16:creationId xmlns:a16="http://schemas.microsoft.com/office/drawing/2014/main" id="{5A652903-E7B1-46A2-ABA9-065705660D3D}"/>
+                <a16:creationId xmlns:a16="http://schemas.microsoft.com/office/drawing/2014/main" id="{686FA46A-9DD2-46F2-9003-06AAF46022D8}"/>
               </a:ext>
             </a:extLst>
           </p:cNvPr>
@@ -8546,7 +8656,7 @@
                 <a:ea typeface="Arial"/>
                 <a:cs typeface="Arial"/>
               </a:rPr>
-              <a:t>Решение рекрутёра</a:t>
+              <a:t>Получение готового результата</a:t>
             </a:r>
           </a:p>
         </p:txBody>
@@ -8556,7 +8666,7 @@
           <p:cNvPr id="18" name="">
             <a:extLst xmlns:a="http://schemas.openxmlformats.org/drawingml/2006/main">
               <a:ext uri="{FF2B5EF4-FFF2-40B4-BE49-F238E27FC236}">
-                <a16:creationId xmlns:a16="http://schemas.microsoft.com/office/drawing/2014/main" id="{D4067FF0-2DCC-4801-9A56-CE7759A89AB0}"/>
+                <a16:creationId xmlns:a16="http://schemas.microsoft.com/office/drawing/2014/main" id="{B9C3BE30-375E-42D3-8EC1-F1B2AE7FE2BD}"/>
               </a:ext>
             </a:extLst>
           </p:cNvPr>
@@ -8614,7 +8724,7 @@
                 <a:ea typeface="Arial"/>
                 <a:cs typeface="Arial"/>
               </a:rPr>
-              <a:t>Рекрутёр проверяет информацию и выбирает следующий этап.</a:t>
+              <a:t>Запрос результата через API не запускает новый анализ.</a:t>
             </a:r>
           </a:p>
         </p:txBody>
@@ -8622,7 +8732,7 @@
     </p:spTree>
     <p:extLst>
       <p:ext uri="{BB962C8B-B14F-4D97-AF65-F5344CB8AC3E}">
-        <p14:creationId xmlns:p14="http://schemas.microsoft.com/office/powerpoint/2010/main" val="1160010293"/>
+        <p14:creationId xmlns:p14="http://schemas.microsoft.com/office/powerpoint/2010/main" val="1259535334"/>
       </p:ext>
     </p:extLst>
   </p:cSld>
@@ -8653,7 +8763,7 @@
           <p:cNvPr id="13" name="">
             <a:extLst xmlns:a="http://schemas.openxmlformats.org/drawingml/2006/main">
               <a:ext uri="{FF2B5EF4-FFF2-40B4-BE49-F238E27FC236}">
-                <a16:creationId xmlns:a16="http://schemas.microsoft.com/office/drawing/2014/main" id="{05C7DC38-44DE-470E-B673-798EA14257C9}"/>
+                <a16:creationId xmlns:a16="http://schemas.microsoft.com/office/drawing/2014/main" id="{511D568E-165C-4556-ADB2-128CEC74B23E}"/>
               </a:ext>
             </a:extLst>
           </p:cNvPr>
@@ -8663,7 +8773,7 @@
           <p:nvPr/>
         </p:nvPicPr>
         <p:blipFill>
-          <a:blip xmlns:r="http://schemas.openxmlformats.org/officeDocument/2006/relationships" xmlns:a="http://schemas.openxmlformats.org/drawingml/2006/main" r:embed="Rc54be6a5aaff4865"/>
+          <a:blip xmlns:r="http://schemas.openxmlformats.org/officeDocument/2006/relationships" xmlns:a="http://schemas.openxmlformats.org/drawingml/2006/main" r:embed="R68757374331d4947"/>
           <a:stretch xmlns:a="http://schemas.openxmlformats.org/drawingml/2006/main"/>
         </p:blipFill>
         <p:spPr>
@@ -8681,7 +8791,7 @@
           <p:cNvPr id="2" name="">
             <a:extLst xmlns:a="http://schemas.openxmlformats.org/drawingml/2006/main">
               <a:ext uri="{FF2B5EF4-FFF2-40B4-BE49-F238E27FC236}">
-                <a16:creationId xmlns:a16="http://schemas.microsoft.com/office/drawing/2014/main" id="{D12A527E-ADBF-44A6-842D-A27A21659A84}"/>
+                <a16:creationId xmlns:a16="http://schemas.microsoft.com/office/drawing/2014/main" id="{217213F1-0009-4C68-BC2C-47C5F80847A6}"/>
               </a:ext>
             </a:extLst>
           </p:cNvPr>
@@ -8749,7 +8859,7 @@
           <p:cNvPr id="3" name="">
             <a:extLst xmlns:a="http://schemas.openxmlformats.org/drawingml/2006/main">
               <a:ext uri="{FF2B5EF4-FFF2-40B4-BE49-F238E27FC236}">
-                <a16:creationId xmlns:a16="http://schemas.microsoft.com/office/drawing/2014/main" id="{1CE43011-C359-4002-A113-5D8BCAD8935E}"/>
+                <a16:creationId xmlns:a16="http://schemas.microsoft.com/office/drawing/2014/main" id="{5F1D2EE2-447B-4065-9102-BBC11943DA43}"/>
               </a:ext>
             </a:extLst>
           </p:cNvPr>
@@ -8817,7 +8927,7 @@
           <p:cNvPr id="4" name="">
             <a:extLst xmlns:a="http://schemas.openxmlformats.org/drawingml/2006/main">
               <a:ext uri="{FF2B5EF4-FFF2-40B4-BE49-F238E27FC236}">
-                <a16:creationId xmlns:a16="http://schemas.microsoft.com/office/drawing/2014/main" id="{2B2655EA-1B89-4C59-BBD7-D97FBAEA752B}"/>
+                <a16:creationId xmlns:a16="http://schemas.microsoft.com/office/drawing/2014/main" id="{B0242C8E-FFD7-40E7-B74B-03E0B111BE15}"/>
               </a:ext>
             </a:extLst>
           </p:cNvPr>
@@ -8885,7 +8995,7 @@
           <p:cNvPr id="5" name="">
             <a:extLst xmlns:a="http://schemas.openxmlformats.org/drawingml/2006/main">
               <a:ext uri="{FF2B5EF4-FFF2-40B4-BE49-F238E27FC236}">
-                <a16:creationId xmlns:a16="http://schemas.microsoft.com/office/drawing/2014/main" id="{1977D3BF-B0AA-4B99-88D2-A390D5FAA02B}"/>
+                <a16:creationId xmlns:a16="http://schemas.microsoft.com/office/drawing/2014/main" id="{38CB1B27-770A-4F00-AF16-1FD21F484F56}"/>
               </a:ext>
             </a:extLst>
           </p:cNvPr>
@@ -8953,7 +9063,7 @@
           <p:cNvPr id="6" name="">
             <a:extLst xmlns:a="http://schemas.openxmlformats.org/drawingml/2006/main">
               <a:ext uri="{FF2B5EF4-FFF2-40B4-BE49-F238E27FC236}">
-                <a16:creationId xmlns:a16="http://schemas.microsoft.com/office/drawing/2014/main" id="{861280BA-0330-4BE2-9A8E-32315BA3654F}"/>
+                <a16:creationId xmlns:a16="http://schemas.microsoft.com/office/drawing/2014/main" id="{FA67D3E9-627E-4489-8BEF-675617F8D3AB}"/>
               </a:ext>
             </a:extLst>
           </p:cNvPr>
@@ -9021,7 +9131,7 @@
           <p:cNvPr id="7" name="">
             <a:extLst xmlns:a="http://schemas.openxmlformats.org/drawingml/2006/main">
               <a:ext uri="{FF2B5EF4-FFF2-40B4-BE49-F238E27FC236}">
-                <a16:creationId xmlns:a16="http://schemas.microsoft.com/office/drawing/2014/main" id="{9AB390E3-AC19-45F1-BCAF-F7D650FD0879}"/>
+                <a16:creationId xmlns:a16="http://schemas.microsoft.com/office/drawing/2014/main" id="{B8209ECF-60D7-4931-BF8C-365174C41DF5}"/>
               </a:ext>
             </a:extLst>
           </p:cNvPr>
@@ -9031,7 +9141,7 @@
           <p:nvPr/>
         </p:nvPicPr>
         <p:blipFill>
-          <a:blip xmlns:r="http://schemas.openxmlformats.org/officeDocument/2006/relationships" xmlns:a="http://schemas.openxmlformats.org/drawingml/2006/main" r:embed="Rf02eaa9daf6343a7"/>
+          <a:blip xmlns:r="http://schemas.openxmlformats.org/officeDocument/2006/relationships" xmlns:a="http://schemas.openxmlformats.org/drawingml/2006/main" r:embed="R8bf489e30a724145"/>
           <a:stretch xmlns:a="http://schemas.openxmlformats.org/drawingml/2006/main"/>
         </p:blipFill>
         <p:spPr>
@@ -9049,7 +9159,7 @@
           <p:cNvPr id="8" name="">
             <a:extLst xmlns:a="http://schemas.openxmlformats.org/drawingml/2006/main">
               <a:ext uri="{FF2B5EF4-FFF2-40B4-BE49-F238E27FC236}">
-                <a16:creationId xmlns:a16="http://schemas.microsoft.com/office/drawing/2014/main" id="{B28664A7-B273-4097-B30F-74026BA1258A}"/>
+                <a16:creationId xmlns:a16="http://schemas.microsoft.com/office/drawing/2014/main" id="{176C09CE-1059-4FBC-A4A8-89896568FE5D}"/>
               </a:ext>
             </a:extLst>
           </p:cNvPr>
@@ -9117,7 +9227,7 @@
           <p:cNvPr id="9" name="">
             <a:extLst xmlns:a="http://schemas.openxmlformats.org/drawingml/2006/main">
               <a:ext uri="{FF2B5EF4-FFF2-40B4-BE49-F238E27FC236}">
-                <a16:creationId xmlns:a16="http://schemas.microsoft.com/office/drawing/2014/main" id="{582B48CA-55D3-4974-9E7E-0E498690DE3D}"/>
+                <a16:creationId xmlns:a16="http://schemas.microsoft.com/office/drawing/2014/main" id="{176CA65F-77F8-435C-8FF8-EDC2AB7AE798}"/>
               </a:ext>
             </a:extLst>
           </p:cNvPr>
@@ -9208,7 +9318,7 @@
           <p:cNvPr id="10" name="">
             <a:extLst xmlns:a="http://schemas.openxmlformats.org/drawingml/2006/main">
               <a:ext uri="{FF2B5EF4-FFF2-40B4-BE49-F238E27FC236}">
-                <a16:creationId xmlns:a16="http://schemas.microsoft.com/office/drawing/2014/main" id="{4890887D-038B-4702-BB33-44961A024201}"/>
+                <a16:creationId xmlns:a16="http://schemas.microsoft.com/office/drawing/2014/main" id="{1FFAD134-233A-4562-A900-D0D21707F4B3}"/>
               </a:ext>
             </a:extLst>
           </p:cNvPr>
@@ -9276,7 +9386,7 @@
           <p:cNvPr id="11" name="">
             <a:extLst xmlns:a="http://schemas.openxmlformats.org/drawingml/2006/main">
               <a:ext uri="{FF2B5EF4-FFF2-40B4-BE49-F238E27FC236}">
-                <a16:creationId xmlns:a16="http://schemas.microsoft.com/office/drawing/2014/main" id="{C31356BA-2ABC-455A-A378-4D6BC4EC47F5}"/>
+                <a16:creationId xmlns:a16="http://schemas.microsoft.com/office/drawing/2014/main" id="{5A8264CA-42E8-456C-AC24-3035B3D2D0EE}"/>
               </a:ext>
             </a:extLst>
           </p:cNvPr>
@@ -9367,7 +9477,7 @@
           <p:cNvPr id="12" name="">
             <a:extLst xmlns:a="http://schemas.openxmlformats.org/drawingml/2006/main">
               <a:ext uri="{FF2B5EF4-FFF2-40B4-BE49-F238E27FC236}">
-                <a16:creationId xmlns:a16="http://schemas.microsoft.com/office/drawing/2014/main" id="{5248DA57-F17A-439C-B693-4E8064CD59A5}"/>
+                <a16:creationId xmlns:a16="http://schemas.microsoft.com/office/drawing/2014/main" id="{F0ECFB83-7E74-4686-92B0-AADBD4D66D9E}"/>
               </a:ext>
             </a:extLst>
           </p:cNvPr>
@@ -9433,7 +9543,7 @@
     </p:spTree>
     <p:extLst>
       <p:ext uri="{BB962C8B-B14F-4D97-AF65-F5344CB8AC3E}">
-        <p14:creationId xmlns:p14="http://schemas.microsoft.com/office/powerpoint/2010/main" val="961685203"/>
+        <p14:creationId xmlns:p14="http://schemas.microsoft.com/office/powerpoint/2010/main" val="916738540"/>
       </p:ext>
     </p:extLst>
   </p:cSld>
@@ -9464,7 +9574,7 @@
           <p:cNvPr id="18" name="">
             <a:extLst xmlns:a="http://schemas.openxmlformats.org/drawingml/2006/main">
               <a:ext uri="{FF2B5EF4-FFF2-40B4-BE49-F238E27FC236}">
-                <a16:creationId xmlns:a16="http://schemas.microsoft.com/office/drawing/2014/main" id="{D76F5143-3BC6-470D-BA67-57B2F0C18366}"/>
+                <a16:creationId xmlns:a16="http://schemas.microsoft.com/office/drawing/2014/main" id="{C817874D-BC75-4C2D-A65E-734BF7BAFAB2}"/>
               </a:ext>
             </a:extLst>
           </p:cNvPr>
@@ -9474,7 +9584,7 @@
           <p:nvPr/>
         </p:nvPicPr>
         <p:blipFill>
-          <a:blip xmlns:r="http://schemas.openxmlformats.org/officeDocument/2006/relationships" xmlns:a="http://schemas.openxmlformats.org/drawingml/2006/main" r:embed="Rde5ba37cf19d43af"/>
+          <a:blip xmlns:r="http://schemas.openxmlformats.org/officeDocument/2006/relationships" xmlns:a="http://schemas.openxmlformats.org/drawingml/2006/main" r:embed="R7dcbe91e550e43ed"/>
           <a:stretch xmlns:a="http://schemas.openxmlformats.org/drawingml/2006/main"/>
         </p:blipFill>
         <p:spPr>
@@ -9492,7 +9602,7 @@
           <p:cNvPr id="2" name="">
             <a:extLst xmlns:a="http://schemas.openxmlformats.org/drawingml/2006/main">
               <a:ext uri="{FF2B5EF4-FFF2-40B4-BE49-F238E27FC236}">
-                <a16:creationId xmlns:a16="http://schemas.microsoft.com/office/drawing/2014/main" id="{5A8F4053-F8A9-448F-BC70-DBE4B0490416}"/>
+                <a16:creationId xmlns:a16="http://schemas.microsoft.com/office/drawing/2014/main" id="{E9B963BC-3882-43C2-8C36-7B81164740AD}"/>
               </a:ext>
             </a:extLst>
           </p:cNvPr>
@@ -9560,7 +9670,7 @@
           <p:cNvPr id="3" name="">
             <a:extLst xmlns:a="http://schemas.openxmlformats.org/drawingml/2006/main">
               <a:ext uri="{FF2B5EF4-FFF2-40B4-BE49-F238E27FC236}">
-                <a16:creationId xmlns:a16="http://schemas.microsoft.com/office/drawing/2014/main" id="{A184AE56-6168-4A30-9843-109768C8BE3A}"/>
+                <a16:creationId xmlns:a16="http://schemas.microsoft.com/office/drawing/2014/main" id="{36DC32ED-F643-499E-9655-CB706C08C692}"/>
               </a:ext>
             </a:extLst>
           </p:cNvPr>
@@ -9618,30 +9728,7 @@
                 <a:ea typeface="Arial"/>
                 <a:cs typeface="Arial"/>
               </a:rPr>
-              <a:t>Вопросы и ответы</a:t>
-            </a:r>
-          </a:p>
-          <a:p xmlns:a="http://schemas.openxmlformats.org/drawingml/2006/main">
-            <a:pPr>
-              <a:defRPr sz="3150" b="0">
-                <a:solidFill>
-                  <a:srgbClr val="101022"/>
-                </a:solidFill>
-                <a:latin typeface="Arial"/>
-                <a:ea typeface="Arial"/>
-                <a:cs typeface="Arial"/>
-              </a:defRPr>
-            </a:pPr>
-            <a:r>
-              <a:rPr sz="3150" b="0">
-                <a:solidFill>
-                  <a:srgbClr val="101022"/>
-                </a:solidFill>
-                <a:latin typeface="Arial"/>
-                <a:ea typeface="Arial"/>
-                <a:cs typeface="Arial"/>
-              </a:rPr>
-              <a:t>в результатах доопроса</a:t>
+              <a:t>Как включается доопрос</a:t>
             </a:r>
           </a:p>
         </p:txBody>
@@ -9651,7 +9738,7 @@
           <p:cNvPr id="4" name="">
             <a:extLst xmlns:a="http://schemas.openxmlformats.org/drawingml/2006/main">
               <a:ext uri="{FF2B5EF4-FFF2-40B4-BE49-F238E27FC236}">
-                <a16:creationId xmlns:a16="http://schemas.microsoft.com/office/drawing/2014/main" id="{E945F930-A7D5-4DB2-8097-AB6E20F64FA2}"/>
+                <a16:creationId xmlns:a16="http://schemas.microsoft.com/office/drawing/2014/main" id="{43D1E37B-7A60-43BE-97E8-DC1998592C0A}"/>
               </a:ext>
             </a:extLst>
           </p:cNvPr>
@@ -9719,7 +9806,7 @@
           <p:cNvPr id="5" name="">
             <a:extLst xmlns:a="http://schemas.openxmlformats.org/drawingml/2006/main">
               <a:ext uri="{FF2B5EF4-FFF2-40B4-BE49-F238E27FC236}">
-                <a16:creationId xmlns:a16="http://schemas.microsoft.com/office/drawing/2014/main" id="{57B3F2B9-AC5A-4AB8-9BB3-B9704824BED7}"/>
+                <a16:creationId xmlns:a16="http://schemas.microsoft.com/office/drawing/2014/main" id="{F04FBD89-0D48-4BE7-B69F-6A2BA2D3A416}"/>
               </a:ext>
             </a:extLst>
           </p:cNvPr>
@@ -9787,7 +9874,7 @@
           <p:cNvPr id="6" name="">
             <a:extLst xmlns:a="http://schemas.openxmlformats.org/drawingml/2006/main">
               <a:ext uri="{FF2B5EF4-FFF2-40B4-BE49-F238E27FC236}">
-                <a16:creationId xmlns:a16="http://schemas.microsoft.com/office/drawing/2014/main" id="{7E704116-990A-4947-A3AC-642208209F72}"/>
+                <a16:creationId xmlns:a16="http://schemas.microsoft.com/office/drawing/2014/main" id="{4DCCD6A0-23B2-4801-AA0F-2098FF563E27}"/>
               </a:ext>
             </a:extLst>
           </p:cNvPr>
@@ -9855,7 +9942,7 @@
           <p:cNvPr id="7" name="">
             <a:extLst xmlns:a="http://schemas.openxmlformats.org/drawingml/2006/main">
               <a:ext uri="{FF2B5EF4-FFF2-40B4-BE49-F238E27FC236}">
-                <a16:creationId xmlns:a16="http://schemas.microsoft.com/office/drawing/2014/main" id="{B9691FE8-5B5D-457A-8B23-C420B807A73A}"/>
+                <a16:creationId xmlns:a16="http://schemas.microsoft.com/office/drawing/2014/main" id="{73E81D22-76B3-410F-A11C-ED4395D1DBD3}"/>
               </a:ext>
             </a:extLst>
           </p:cNvPr>
@@ -9913,7 +10000,7 @@
                 <a:ea typeface="Courier New"/>
                 <a:cs typeface="Courier New"/>
               </a:rPr>
-              <a:t>ВОПРОС В ЧАТЕ HH.RU</a:t>
+              <a:t>01 · ПОДКЛЮЧЕНИЕ</a:t>
             </a:r>
           </a:p>
         </p:txBody>
@@ -9923,7 +10010,7 @@
           <p:cNvPr id="8" name="">
             <a:extLst xmlns:a="http://schemas.openxmlformats.org/drawingml/2006/main">
               <a:ext uri="{FF2B5EF4-FFF2-40B4-BE49-F238E27FC236}">
-                <a16:creationId xmlns:a16="http://schemas.microsoft.com/office/drawing/2014/main" id="{6426D026-A42F-48DD-A2DD-D8313D72F8E2}"/>
+                <a16:creationId xmlns:a16="http://schemas.microsoft.com/office/drawing/2014/main" id="{7F3589FF-AF26-4E8C-AEA0-4D16D82FDBD7}"/>
               </a:ext>
             </a:extLst>
           </p:cNvPr>
@@ -9953,7 +10040,7 @@
           <p:cNvPr id="9" name="">
             <a:extLst xmlns:a="http://schemas.openxmlformats.org/drawingml/2006/main">
               <a:ext uri="{FF2B5EF4-FFF2-40B4-BE49-F238E27FC236}">
-                <a16:creationId xmlns:a16="http://schemas.microsoft.com/office/drawing/2014/main" id="{3A4C615F-DE81-41DD-9D58-A6F97C9D6271}"/>
+                <a16:creationId xmlns:a16="http://schemas.microsoft.com/office/drawing/2014/main" id="{5B8677C7-6E64-49F1-B1EE-280202BFA9BD}"/>
               </a:ext>
             </a:extLst>
           </p:cNvPr>
@@ -10011,7 +10098,7 @@
                 <a:ea typeface="Arial"/>
                 <a:cs typeface="Arial"/>
               </a:rPr>
-              <a:t>«Готовы работать</a:t>
+              <a:t>ИИ-помощник</a:t>
             </a:r>
           </a:p>
           <a:p xmlns:a="http://schemas.openxmlformats.org/drawingml/2006/main">
@@ -10034,7 +10121,30 @@
                 <a:ea typeface="Arial"/>
                 <a:cs typeface="Arial"/>
               </a:rPr>
-              <a:t>по графику 2/2?»</a:t>
+              <a:t>нужной вакансии</a:t>
+            </a:r>
+          </a:p>
+          <a:p xmlns:a="http://schemas.openxmlformats.org/drawingml/2006/main">
+            <a:pPr>
+              <a:defRPr sz="2025" b="1">
+                <a:solidFill>
+                  <a:srgbClr val="101022"/>
+                </a:solidFill>
+                <a:latin typeface="Arial"/>
+                <a:ea typeface="Arial"/>
+                <a:cs typeface="Arial"/>
+              </a:defRPr>
+            </a:pPr>
+            <a:r>
+              <a:rPr sz="2025" b="1">
+                <a:solidFill>
+                  <a:srgbClr val="101022"/>
+                </a:solidFill>
+                <a:latin typeface="Arial"/>
+                <a:ea typeface="Arial"/>
+                <a:cs typeface="Arial"/>
+              </a:rPr>
+              <a:t>в hh.ru</a:t>
             </a:r>
           </a:p>
         </p:txBody>
@@ -10044,7 +10154,7 @@
           <p:cNvPr id="10" name="">
             <a:extLst xmlns:a="http://schemas.openxmlformats.org/drawingml/2006/main">
               <a:ext uri="{FF2B5EF4-FFF2-40B4-BE49-F238E27FC236}">
-                <a16:creationId xmlns:a16="http://schemas.microsoft.com/office/drawing/2014/main" id="{F558976E-D69E-4B62-883F-4F0A0A6FB983}"/>
+                <a16:creationId xmlns:a16="http://schemas.microsoft.com/office/drawing/2014/main" id="{552270A1-DA70-4C37-A2D6-1B0D30DE2266}"/>
               </a:ext>
             </a:extLst>
           </p:cNvPr>
@@ -10102,7 +10212,7 @@
                 <a:ea typeface="Courier New"/>
                 <a:cs typeface="Courier New"/>
               </a:rPr>
-              <a:t>ОТВЕТ КАНДИДАТА</a:t>
+              <a:t>02 · НАСТРОЙКА</a:t>
             </a:r>
           </a:p>
         </p:txBody>
@@ -10112,7 +10222,7 @@
           <p:cNvPr id="11" name="">
             <a:extLst xmlns:a="http://schemas.openxmlformats.org/drawingml/2006/main">
               <a:ext uri="{FF2B5EF4-FFF2-40B4-BE49-F238E27FC236}">
-                <a16:creationId xmlns:a16="http://schemas.microsoft.com/office/drawing/2014/main" id="{E0599A78-A22E-40B0-A277-3C0ED558B0D6}"/>
+                <a16:creationId xmlns:a16="http://schemas.microsoft.com/office/drawing/2014/main" id="{9D83C964-8305-4A92-A9D6-0A3EF873CE41}"/>
               </a:ext>
             </a:extLst>
           </p:cNvPr>
@@ -10142,7 +10252,7 @@
           <p:cNvPr id="12" name="">
             <a:extLst xmlns:a="http://schemas.openxmlformats.org/drawingml/2006/main">
               <a:ext uri="{FF2B5EF4-FFF2-40B4-BE49-F238E27FC236}">
-                <a16:creationId xmlns:a16="http://schemas.microsoft.com/office/drawing/2014/main" id="{3534DB80-EDA6-4EA2-B4D8-6D91668B55DB}"/>
+                <a16:creationId xmlns:a16="http://schemas.microsoft.com/office/drawing/2014/main" id="{0FF8AA24-1052-4911-AB45-0A0D6386D21B}"/>
               </a:ext>
             </a:extLst>
           </p:cNvPr>
@@ -10200,7 +10310,7 @@
                 <a:ea typeface="Arial"/>
                 <a:cs typeface="Arial"/>
               </a:rPr>
-              <a:t>«Да, такой график</a:t>
+              <a:t>Навык «Вопросы</a:t>
             </a:r>
           </a:p>
           <a:p xmlns:a="http://schemas.openxmlformats.org/drawingml/2006/main">
@@ -10223,7 +10333,30 @@
                 <a:ea typeface="Arial"/>
                 <a:cs typeface="Arial"/>
               </a:rPr>
-              <a:t>мне подходит»</a:t>
+              <a:t>кандидату»</a:t>
+            </a:r>
+          </a:p>
+          <a:p xmlns:a="http://schemas.openxmlformats.org/drawingml/2006/main">
+            <a:pPr>
+              <a:defRPr sz="2025" b="1">
+                <a:solidFill>
+                  <a:srgbClr val="101022"/>
+                </a:solidFill>
+                <a:latin typeface="Arial"/>
+                <a:ea typeface="Arial"/>
+                <a:cs typeface="Arial"/>
+              </a:defRPr>
+            </a:pPr>
+            <a:r>
+              <a:rPr sz="2025" b="1">
+                <a:solidFill>
+                  <a:srgbClr val="101022"/>
+                </a:solidFill>
+                <a:latin typeface="Arial"/>
+                <a:ea typeface="Arial"/>
+                <a:cs typeface="Arial"/>
+              </a:rPr>
+              <a:t>До 3 своих вопросов</a:t>
             </a:r>
           </a:p>
         </p:txBody>
@@ -10233,7 +10366,7 @@
           <p:cNvPr id="13" name="">
             <a:extLst xmlns:a="http://schemas.openxmlformats.org/drawingml/2006/main">
               <a:ext uri="{FF2B5EF4-FFF2-40B4-BE49-F238E27FC236}">
-                <a16:creationId xmlns:a16="http://schemas.microsoft.com/office/drawing/2014/main" id="{3B649582-37CF-4F0C-9DB3-2BF378CD69E2}"/>
+                <a16:creationId xmlns:a16="http://schemas.microsoft.com/office/drawing/2014/main" id="{63A4B47F-ACF3-48B7-BB1F-7581623FB3F5}"/>
               </a:ext>
             </a:extLst>
           </p:cNvPr>
@@ -10291,7 +10424,7 @@
                 <a:ea typeface="Courier New"/>
                 <a:cs typeface="Courier New"/>
               </a:rPr>
-              <a:t>ДАННЫЕ В API HH.RU</a:t>
+              <a:t>03 · НОВЫЙ ОТКЛИК</a:t>
             </a:r>
           </a:p>
         </p:txBody>
@@ -10301,7 +10434,7 @@
           <p:cNvPr id="14" name="">
             <a:extLst xmlns:a="http://schemas.openxmlformats.org/drawingml/2006/main">
               <a:ext uri="{FF2B5EF4-FFF2-40B4-BE49-F238E27FC236}">
-                <a16:creationId xmlns:a16="http://schemas.microsoft.com/office/drawing/2014/main" id="{4BA46C69-22BF-4EE9-A478-90663DAF51EA}"/>
+                <a16:creationId xmlns:a16="http://schemas.microsoft.com/office/drawing/2014/main" id="{8518E957-93CA-4A00-9E9F-23B08FABC109}"/>
               </a:ext>
             </a:extLst>
           </p:cNvPr>
@@ -10331,7 +10464,7 @@
           <p:cNvPr id="15" name="">
             <a:extLst xmlns:a="http://schemas.openxmlformats.org/drawingml/2006/main">
               <a:ext uri="{FF2B5EF4-FFF2-40B4-BE49-F238E27FC236}">
-                <a16:creationId xmlns:a16="http://schemas.microsoft.com/office/drawing/2014/main" id="{01C82F41-562F-48DC-BA47-D949DA61344D}"/>
+                <a16:creationId xmlns:a16="http://schemas.microsoft.com/office/drawing/2014/main" id="{1596EC72-8E2D-4D82-A572-A58FEBB5BC88}"/>
               </a:ext>
             </a:extLst>
           </p:cNvPr>
@@ -10389,7 +10522,7 @@
                 <a:ea typeface="Arial"/>
                 <a:cs typeface="Arial"/>
               </a:rPr>
-              <a:t>Вопрос</a:t>
+              <a:t>hh задаёт вопросы,</a:t>
             </a:r>
           </a:p>
           <a:p xmlns:a="http://schemas.openxmlformats.org/drawingml/2006/main">
@@ -10412,7 +10545,30 @@
                 <a:ea typeface="Arial"/>
                 <a:cs typeface="Arial"/>
               </a:rPr>
-              <a:t>и цитата ответа</a:t>
+              <a:t>если информации</a:t>
+            </a:r>
+          </a:p>
+          <a:p xmlns:a="http://schemas.openxmlformats.org/drawingml/2006/main">
+            <a:pPr>
+              <a:defRPr sz="2025" b="1">
+                <a:solidFill>
+                  <a:srgbClr val="101022"/>
+                </a:solidFill>
+                <a:latin typeface="Arial"/>
+                <a:ea typeface="Arial"/>
+                <a:cs typeface="Arial"/>
+              </a:defRPr>
+            </a:pPr>
+            <a:r>
+              <a:rPr sz="2025" b="1">
+                <a:solidFill>
+                  <a:srgbClr val="101022"/>
+                </a:solidFill>
+                <a:latin typeface="Arial"/>
+                <a:ea typeface="Arial"/>
+                <a:cs typeface="Arial"/>
+              </a:rPr>
+              <a:t>недостаточно</a:t>
             </a:r>
           </a:p>
         </p:txBody>
@@ -10422,7 +10578,7 @@
           <p:cNvPr id="16" name="">
             <a:extLst xmlns:a="http://schemas.openxmlformats.org/drawingml/2006/main">
               <a:ext uri="{FF2B5EF4-FFF2-40B4-BE49-F238E27FC236}">
-                <a16:creationId xmlns:a16="http://schemas.microsoft.com/office/drawing/2014/main" id="{B246132B-A699-4163-B69E-57B9E572B756}"/>
+                <a16:creationId xmlns:a16="http://schemas.microsoft.com/office/drawing/2014/main" id="{BC436033-DE88-4916-A04D-A397D1F38599}"/>
               </a:ext>
             </a:extLst>
           </p:cNvPr>
@@ -10434,75 +10590,7 @@
         <p:spPr>
           <a:xfrm xmlns:a="http://schemas.openxmlformats.org/drawingml/2006/main">
             <a:off x="504825" y="4362450"/>
-            <a:ext cx="4762500" cy="228600"/>
-          </a:xfrm>
-          <a:prstGeom xmlns:a="http://schemas.openxmlformats.org/drawingml/2006/main" prst="rect">
-            <a:avLst/>
-          </a:prstGeom>
-          <a:noFill xmlns:a="http://schemas.openxmlformats.org/drawingml/2006/main"/>
-          <a:ln xmlns:a="http://schemas.openxmlformats.org/drawingml/2006/main" w="0">
-            <a:noFill/>
-          </a:ln>
-        </p:spPr>
-        <p:txBody>
-          <a:bodyPr xmlns:a="http://schemas.openxmlformats.org/drawingml/2006/main" lIns="0" tIns="0" rIns="0" bIns="0" anchor="t">
-            <a:noAutofit/>
-          </a:bodyPr>
-          <a:lstStyle xmlns:a="http://schemas.openxmlformats.org/drawingml/2006/main">
-            <a:defPPr>
-              <a:defRPr sz="1125" b="0">
-                <a:solidFill>
-                  <a:srgbClr val="737C96"/>
-                </a:solidFill>
-                <a:latin typeface="Arial"/>
-                <a:ea typeface="Arial"/>
-                <a:cs typeface="Arial"/>
-              </a:defRPr>
-            </a:defPPr>
-          </a:lstStyle>
-          <a:p xmlns:a="http://schemas.openxmlformats.org/drawingml/2006/main">
-            <a:pPr>
-              <a:defRPr sz="1125" b="0">
-                <a:solidFill>
-                  <a:srgbClr val="737C96"/>
-                </a:solidFill>
-                <a:latin typeface="Arial"/>
-                <a:ea typeface="Arial"/>
-                <a:cs typeface="Arial"/>
-              </a:defRPr>
-            </a:pPr>
-            <a:r>
-              <a:rPr sz="1125" b="0">
-                <a:solidFill>
-                  <a:srgbClr val="737C96"/>
-                </a:solidFill>
-                <a:latin typeface="Arial"/>
-                <a:ea typeface="Arial"/>
-                <a:cs typeface="Arial"/>
-              </a:rPr>
-              <a:t>Иллюстративный пример</a:t>
-            </a:r>
-          </a:p>
-        </p:txBody>
-      </p:sp>
-      <p:sp>
-        <p:nvSpPr>
-          <p:cNvPr id="17" name="">
-            <a:extLst xmlns:a="http://schemas.openxmlformats.org/drawingml/2006/main">
-              <a:ext uri="{FF2B5EF4-FFF2-40B4-BE49-F238E27FC236}">
-                <a16:creationId xmlns:a16="http://schemas.microsoft.com/office/drawing/2014/main" id="{1162DF9A-691B-4443-9765-AAC49EE706F5}"/>
-              </a:ext>
-            </a:extLst>
-          </p:cNvPr>
-          <p:cNvSpPr>
-            <a:spLocks xmlns:a="http://schemas.openxmlformats.org/drawingml/2006/main" noGrp="1"/>
-          </p:cNvSpPr>
-          <p:nvPr/>
-        </p:nvSpPr>
-        <p:spPr>
-          <a:xfrm xmlns:a="http://schemas.openxmlformats.org/drawingml/2006/main">
-            <a:off x="504825" y="5133975"/>
-            <a:ext cx="9696450" cy="400050"/>
+            <a:ext cx="9696450" cy="428625"/>
           </a:xfrm>
           <a:prstGeom xmlns:a="http://schemas.openxmlformats.org/drawingml/2006/main" prst="rect">
             <a:avLst/>
@@ -10548,7 +10636,75 @@
                 <a:ea typeface="Arial"/>
                 <a:cs typeface="Arial"/>
               </a:rPr>
-              <a:t>В примере API ответ сохраняется вместе с вопросом работодателя.</a:t>
+              <a:t>При подключении помощника навык включён по умолчанию. Всего — до 5 вопросов.</a:t>
+            </a:r>
+          </a:p>
+        </p:txBody>
+      </p:sp>
+      <p:sp>
+        <p:nvSpPr>
+          <p:cNvPr id="17" name="">
+            <a:extLst xmlns:a="http://schemas.openxmlformats.org/drawingml/2006/main">
+              <a:ext uri="{FF2B5EF4-FFF2-40B4-BE49-F238E27FC236}">
+                <a16:creationId xmlns:a16="http://schemas.microsoft.com/office/drawing/2014/main" id="{ADF1629E-2D54-4166-871A-F3552EC8C018}"/>
+              </a:ext>
+            </a:extLst>
+          </p:cNvPr>
+          <p:cNvSpPr>
+            <a:spLocks xmlns:a="http://schemas.openxmlformats.org/drawingml/2006/main" noGrp="1"/>
+          </p:cNvSpPr>
+          <p:nvPr/>
+        </p:nvSpPr>
+        <p:spPr>
+          <a:xfrm xmlns:a="http://schemas.openxmlformats.org/drawingml/2006/main">
+            <a:off x="504825" y="5133975"/>
+            <a:ext cx="9696450" cy="400050"/>
+          </a:xfrm>
+          <a:prstGeom xmlns:a="http://schemas.openxmlformats.org/drawingml/2006/main" prst="rect">
+            <a:avLst/>
+          </a:prstGeom>
+          <a:noFill xmlns:a="http://schemas.openxmlformats.org/drawingml/2006/main"/>
+          <a:ln xmlns:a="http://schemas.openxmlformats.org/drawingml/2006/main" w="0">
+            <a:noFill/>
+          </a:ln>
+        </p:spPr>
+        <p:txBody>
+          <a:bodyPr xmlns:a="http://schemas.openxmlformats.org/drawingml/2006/main" lIns="0" tIns="0" rIns="0" bIns="0" anchor="t">
+            <a:noAutofit/>
+          </a:bodyPr>
+          <a:lstStyle xmlns:a="http://schemas.openxmlformats.org/drawingml/2006/main">
+            <a:defPPr>
+              <a:defRPr sz="1350" b="0">
+                <a:solidFill>
+                  <a:srgbClr val="737C96"/>
+                </a:solidFill>
+                <a:latin typeface="Arial"/>
+                <a:ea typeface="Arial"/>
+                <a:cs typeface="Arial"/>
+              </a:defRPr>
+            </a:defPPr>
+          </a:lstStyle>
+          <a:p xmlns:a="http://schemas.openxmlformats.org/drawingml/2006/main">
+            <a:pPr>
+              <a:defRPr sz="1350" b="0">
+                <a:solidFill>
+                  <a:srgbClr val="737C96"/>
+                </a:solidFill>
+                <a:latin typeface="Arial"/>
+                <a:ea typeface="Arial"/>
+                <a:cs typeface="Arial"/>
+              </a:defRPr>
+            </a:pPr>
+            <a:r>
+              <a:rPr sz="1350" b="0">
+                <a:solidFill>
+                  <a:srgbClr val="737C96"/>
+                </a:solidFill>
+                <a:latin typeface="Arial"/>
+                <a:ea typeface="Arial"/>
+                <a:cs typeface="Arial"/>
+              </a:rPr>
+              <a:t>Изменение настроек не запускает повторный доопрос прежних кандидатов.</a:t>
             </a:r>
           </a:p>
         </p:txBody>
@@ -10556,7 +10712,7 @@
     </p:spTree>
     <p:extLst>
       <p:ext uri="{BB962C8B-B14F-4D97-AF65-F5344CB8AC3E}">
-        <p14:creationId xmlns:p14="http://schemas.microsoft.com/office/powerpoint/2010/main" val="1594044486"/>
+        <p14:creationId xmlns:p14="http://schemas.microsoft.com/office/powerpoint/2010/main" val="1126213756"/>
       </p:ext>
     </p:extLst>
   </p:cSld>
@@ -10587,7 +10743,7 @@
           <p:cNvPr id="17" name="">
             <a:extLst xmlns:a="http://schemas.openxmlformats.org/drawingml/2006/main">
               <a:ext uri="{FF2B5EF4-FFF2-40B4-BE49-F238E27FC236}">
-                <a16:creationId xmlns:a16="http://schemas.microsoft.com/office/drawing/2014/main" id="{F02CC885-3CC9-4A36-B75A-8C2C349D04F8}"/>
+                <a16:creationId xmlns:a16="http://schemas.microsoft.com/office/drawing/2014/main" id="{BD6A0689-2F5B-491C-8350-A7FD94BF853E}"/>
               </a:ext>
             </a:extLst>
           </p:cNvPr>
@@ -10597,7 +10753,7 @@
           <p:nvPr/>
         </p:nvPicPr>
         <p:blipFill>
-          <a:blip xmlns:r="http://schemas.openxmlformats.org/officeDocument/2006/relationships" xmlns:a="http://schemas.openxmlformats.org/drawingml/2006/main" r:embed="Rea4ac867d89c40cb"/>
+          <a:blip xmlns:r="http://schemas.openxmlformats.org/officeDocument/2006/relationships" xmlns:a="http://schemas.openxmlformats.org/drawingml/2006/main" r:embed="R16a4dda0bce84861"/>
           <a:stretch xmlns:a="http://schemas.openxmlformats.org/drawingml/2006/main"/>
         </p:blipFill>
         <p:spPr>
@@ -10615,7 +10771,7 @@
           <p:cNvPr id="2" name="">
             <a:extLst xmlns:a="http://schemas.openxmlformats.org/drawingml/2006/main">
               <a:ext uri="{FF2B5EF4-FFF2-40B4-BE49-F238E27FC236}">
-                <a16:creationId xmlns:a16="http://schemas.microsoft.com/office/drawing/2014/main" id="{2E760800-336F-48DE-A6CA-DA18F7C2D536}"/>
+                <a16:creationId xmlns:a16="http://schemas.microsoft.com/office/drawing/2014/main" id="{5FB1CE8E-1DA8-421F-8599-65A4F9BFCC09}"/>
               </a:ext>
             </a:extLst>
           </p:cNvPr>
@@ -10683,7 +10839,7 @@
           <p:cNvPr id="3" name="">
             <a:extLst xmlns:a="http://schemas.openxmlformats.org/drawingml/2006/main">
               <a:ext uri="{FF2B5EF4-FFF2-40B4-BE49-F238E27FC236}">
-                <a16:creationId xmlns:a16="http://schemas.microsoft.com/office/drawing/2014/main" id="{6B60B848-5F39-44B6-BFD5-A19C8A1B0811}"/>
+                <a16:creationId xmlns:a16="http://schemas.microsoft.com/office/drawing/2014/main" id="{5E1812A5-C747-4592-A039-DFB8E7C246CA}"/>
               </a:ext>
             </a:extLst>
           </p:cNvPr>
@@ -10751,7 +10907,7 @@
           <p:cNvPr id="4" name="">
             <a:extLst xmlns:a="http://schemas.openxmlformats.org/drawingml/2006/main">
               <a:ext uri="{FF2B5EF4-FFF2-40B4-BE49-F238E27FC236}">
-                <a16:creationId xmlns:a16="http://schemas.microsoft.com/office/drawing/2014/main" id="{646BBAF3-79E2-4E06-B6B0-D8E476CF9F77}"/>
+                <a16:creationId xmlns:a16="http://schemas.microsoft.com/office/drawing/2014/main" id="{CCB99200-6DBA-4D1C-9AD5-F4C9BD9A13C6}"/>
               </a:ext>
             </a:extLst>
           </p:cNvPr>
@@ -10819,7 +10975,7 @@
           <p:cNvPr id="5" name="">
             <a:extLst xmlns:a="http://schemas.openxmlformats.org/drawingml/2006/main">
               <a:ext uri="{FF2B5EF4-FFF2-40B4-BE49-F238E27FC236}">
-                <a16:creationId xmlns:a16="http://schemas.microsoft.com/office/drawing/2014/main" id="{7C801FB1-5BBD-47C3-ACBC-DCBB7C517BDB}"/>
+                <a16:creationId xmlns:a16="http://schemas.microsoft.com/office/drawing/2014/main" id="{411D5118-1175-485D-9266-EE8D352F33F3}"/>
               </a:ext>
             </a:extLst>
           </p:cNvPr>
@@ -10887,7 +11043,7 @@
           <p:cNvPr id="6" name="">
             <a:extLst xmlns:a="http://schemas.openxmlformats.org/drawingml/2006/main">
               <a:ext uri="{FF2B5EF4-FFF2-40B4-BE49-F238E27FC236}">
-                <a16:creationId xmlns:a16="http://schemas.microsoft.com/office/drawing/2014/main" id="{B67D89B2-2423-45BC-A69A-0F844DAF42DF}"/>
+                <a16:creationId xmlns:a16="http://schemas.microsoft.com/office/drawing/2014/main" id="{E8F0A12C-AFEB-4F0A-BEA5-1C970643A605}"/>
               </a:ext>
             </a:extLst>
           </p:cNvPr>
@@ -10955,7 +11111,7 @@
           <p:cNvPr id="7" name="">
             <a:extLst xmlns:a="http://schemas.openxmlformats.org/drawingml/2006/main">
               <a:ext uri="{FF2B5EF4-FFF2-40B4-BE49-F238E27FC236}">
-                <a16:creationId xmlns:a16="http://schemas.microsoft.com/office/drawing/2014/main" id="{ADC4869F-7EFC-423E-B4D4-FE5D92044F8E}"/>
+                <a16:creationId xmlns:a16="http://schemas.microsoft.com/office/drawing/2014/main" id="{3EECC451-AAA8-4B1F-9239-7582C3F4FBD2}"/>
               </a:ext>
             </a:extLst>
           </p:cNvPr>
@@ -10965,7 +11121,7 @@
           <p:nvPr/>
         </p:nvPicPr>
         <p:blipFill>
-          <a:blip xmlns:r="http://schemas.openxmlformats.org/officeDocument/2006/relationships" xmlns:a="http://schemas.openxmlformats.org/drawingml/2006/main" r:embed="R4e020c2a4942481e"/>
+          <a:blip xmlns:r="http://schemas.openxmlformats.org/officeDocument/2006/relationships" xmlns:a="http://schemas.openxmlformats.org/drawingml/2006/main" r:embed="R4ff8a55ee8914dbc"/>
           <a:stretch xmlns:a="http://schemas.openxmlformats.org/drawingml/2006/main"/>
         </p:blipFill>
         <p:spPr>
@@ -10983,7 +11139,7 @@
           <p:cNvPr id="8" name="">
             <a:extLst xmlns:a="http://schemas.openxmlformats.org/drawingml/2006/main">
               <a:ext uri="{FF2B5EF4-FFF2-40B4-BE49-F238E27FC236}">
-                <a16:creationId xmlns:a16="http://schemas.microsoft.com/office/drawing/2014/main" id="{03EDC815-8B23-4811-8EAC-C7394839C1B9}"/>
+                <a16:creationId xmlns:a16="http://schemas.microsoft.com/office/drawing/2014/main" id="{807D23C6-76A2-4ADA-8619-952C13511625}"/>
               </a:ext>
             </a:extLst>
           </p:cNvPr>
@@ -11051,7 +11207,7 @@
           <p:cNvPr id="9" name="">
             <a:extLst xmlns:a="http://schemas.openxmlformats.org/drawingml/2006/main">
               <a:ext uri="{FF2B5EF4-FFF2-40B4-BE49-F238E27FC236}">
-                <a16:creationId xmlns:a16="http://schemas.microsoft.com/office/drawing/2014/main" id="{7DAD2CFD-5D6F-4025-9E1C-49E7D93AFA40}"/>
+                <a16:creationId xmlns:a16="http://schemas.microsoft.com/office/drawing/2014/main" id="{690F036A-29F2-4314-8607-2B1ADB65C3A4}"/>
               </a:ext>
             </a:extLst>
           </p:cNvPr>
@@ -11142,7 +11298,7 @@
           <p:cNvPr id="10" name="">
             <a:extLst xmlns:a="http://schemas.openxmlformats.org/drawingml/2006/main">
               <a:ext uri="{FF2B5EF4-FFF2-40B4-BE49-F238E27FC236}">
-                <a16:creationId xmlns:a16="http://schemas.microsoft.com/office/drawing/2014/main" id="{443A5491-F5DF-4771-808F-32C5D7B4EE44}"/>
+                <a16:creationId xmlns:a16="http://schemas.microsoft.com/office/drawing/2014/main" id="{A5A68864-F2CB-4096-93F6-112B88BE3FDE}"/>
               </a:ext>
             </a:extLst>
           </p:cNvPr>
@@ -11210,7 +11366,7 @@
           <p:cNvPr id="11" name="">
             <a:extLst xmlns:a="http://schemas.openxmlformats.org/drawingml/2006/main">
               <a:ext uri="{FF2B5EF4-FFF2-40B4-BE49-F238E27FC236}">
-                <a16:creationId xmlns:a16="http://schemas.microsoft.com/office/drawing/2014/main" id="{D4A35D20-4694-4BB1-BDB7-F688CF0ADC8D}"/>
+                <a16:creationId xmlns:a16="http://schemas.microsoft.com/office/drawing/2014/main" id="{8C2826BD-1E77-4F24-A79C-5158FF811751}"/>
               </a:ext>
             </a:extLst>
           </p:cNvPr>
@@ -11278,7 +11434,7 @@
           <p:cNvPr id="12" name="">
             <a:extLst xmlns:a="http://schemas.openxmlformats.org/drawingml/2006/main">
               <a:ext uri="{FF2B5EF4-FFF2-40B4-BE49-F238E27FC236}">
-                <a16:creationId xmlns:a16="http://schemas.microsoft.com/office/drawing/2014/main" id="{57449519-C932-4238-9FD3-C3D1368B5306}"/>
+                <a16:creationId xmlns:a16="http://schemas.microsoft.com/office/drawing/2014/main" id="{C5C7BF19-86A1-4659-A13E-EA3866B06D75}"/>
               </a:ext>
             </a:extLst>
           </p:cNvPr>
@@ -11346,7 +11502,7 @@
           <p:cNvPr id="13" name="">
             <a:extLst xmlns:a="http://schemas.openxmlformats.org/drawingml/2006/main">
               <a:ext uri="{FF2B5EF4-FFF2-40B4-BE49-F238E27FC236}">
-                <a16:creationId xmlns:a16="http://schemas.microsoft.com/office/drawing/2014/main" id="{D538FD4D-6CB4-4EEA-939A-AED78C6D0FAA}"/>
+                <a16:creationId xmlns:a16="http://schemas.microsoft.com/office/drawing/2014/main" id="{FEA861BB-E3B6-42B8-8926-9D515E37E6DD}"/>
               </a:ext>
             </a:extLst>
           </p:cNvPr>
@@ -11414,7 +11570,7 @@
           <p:cNvPr id="14" name="">
             <a:extLst xmlns:a="http://schemas.openxmlformats.org/drawingml/2006/main">
               <a:ext uri="{FF2B5EF4-FFF2-40B4-BE49-F238E27FC236}">
-                <a16:creationId xmlns:a16="http://schemas.microsoft.com/office/drawing/2014/main" id="{96B85803-D6AC-4BE0-AF65-E83080A0108C}"/>
+                <a16:creationId xmlns:a16="http://schemas.microsoft.com/office/drawing/2014/main" id="{CEC47C64-E41D-4ADB-9722-F5176D812A73}"/>
               </a:ext>
             </a:extLst>
           </p:cNvPr>
@@ -11482,7 +11638,7 @@
           <p:cNvPr id="15" name="">
             <a:extLst xmlns:a="http://schemas.openxmlformats.org/drawingml/2006/main">
               <a:ext uri="{FF2B5EF4-FFF2-40B4-BE49-F238E27FC236}">
-                <a16:creationId xmlns:a16="http://schemas.microsoft.com/office/drawing/2014/main" id="{F3019DA8-C984-4A06-AB00-8BBAD9392962}"/>
+                <a16:creationId xmlns:a16="http://schemas.microsoft.com/office/drawing/2014/main" id="{7E6BECC0-8BFC-4772-93A5-FA9A59B8826D}"/>
               </a:ext>
             </a:extLst>
           </p:cNvPr>
@@ -11550,7 +11706,7 @@
           <p:cNvPr id="16" name="">
             <a:extLst xmlns:a="http://schemas.openxmlformats.org/drawingml/2006/main">
               <a:ext uri="{FF2B5EF4-FFF2-40B4-BE49-F238E27FC236}">
-                <a16:creationId xmlns:a16="http://schemas.microsoft.com/office/drawing/2014/main" id="{917FB0FC-AF1D-4B56-9CF6-62C0651A2B91}"/>
+                <a16:creationId xmlns:a16="http://schemas.microsoft.com/office/drawing/2014/main" id="{3DD81AA5-0E9B-4120-8ECA-ACE8442151A5}"/>
               </a:ext>
             </a:extLst>
           </p:cNvPr>
@@ -11616,7 +11772,7 @@
     </p:spTree>
     <p:extLst>
       <p:ext uri="{BB962C8B-B14F-4D97-AF65-F5344CB8AC3E}">
-        <p14:creationId xmlns:p14="http://schemas.microsoft.com/office/powerpoint/2010/main" val="1121940552"/>
+        <p14:creationId xmlns:p14="http://schemas.microsoft.com/office/powerpoint/2010/main" val="332890572"/>
       </p:ext>
     </p:extLst>
   </p:cSld>
@@ -11647,7 +11803,7 @@
           <p:cNvPr id="11" name="">
             <a:extLst xmlns:a="http://schemas.openxmlformats.org/drawingml/2006/main">
               <a:ext uri="{FF2B5EF4-FFF2-40B4-BE49-F238E27FC236}">
-                <a16:creationId xmlns:a16="http://schemas.microsoft.com/office/drawing/2014/main" id="{E54FA2A6-536F-4382-AC8A-1A90ACCA6AC0}"/>
+                <a16:creationId xmlns:a16="http://schemas.microsoft.com/office/drawing/2014/main" id="{41D5BBEA-C373-469C-886A-928ED12FB99E}"/>
               </a:ext>
             </a:extLst>
           </p:cNvPr>
@@ -11657,7 +11813,7 @@
           <p:nvPr/>
         </p:nvPicPr>
         <p:blipFill>
-          <a:blip xmlns:r="http://schemas.openxmlformats.org/officeDocument/2006/relationships" xmlns:a="http://schemas.openxmlformats.org/drawingml/2006/main" r:embed="R3c7695abb22f42cf"/>
+          <a:blip xmlns:r="http://schemas.openxmlformats.org/officeDocument/2006/relationships" xmlns:a="http://schemas.openxmlformats.org/drawingml/2006/main" r:embed="R68feb2a405544677"/>
           <a:stretch xmlns:a="http://schemas.openxmlformats.org/drawingml/2006/main"/>
         </p:blipFill>
         <p:spPr>
@@ -11675,7 +11831,7 @@
           <p:cNvPr id="2" name="">
             <a:extLst xmlns:a="http://schemas.openxmlformats.org/drawingml/2006/main">
               <a:ext uri="{FF2B5EF4-FFF2-40B4-BE49-F238E27FC236}">
-                <a16:creationId xmlns:a16="http://schemas.microsoft.com/office/drawing/2014/main" id="{3ED708B0-2217-428C-BF84-B41B0E624C18}"/>
+                <a16:creationId xmlns:a16="http://schemas.microsoft.com/office/drawing/2014/main" id="{6E1A5EC2-5E04-42AA-B136-18AAB4DDC7DA}"/>
               </a:ext>
             </a:extLst>
           </p:cNvPr>
@@ -11733,7 +11889,7 @@
                 <a:ea typeface="Courier New"/>
                 <a:cs typeface="Courier New"/>
               </a:rPr>
-              <a:t>ОЦЕНКА ПОЛЬЗЫ</a:t>
+              <a:t>ГРАНИЦЫ ПОДТВЕРЖДЕНИЯ</a:t>
             </a:r>
           </a:p>
         </p:txBody>
@@ -11743,7 +11899,7 @@
           <p:cNvPr id="3" name="">
             <a:extLst xmlns:a="http://schemas.openxmlformats.org/drawingml/2006/main">
               <a:ext uri="{FF2B5EF4-FFF2-40B4-BE49-F238E27FC236}">
-                <a16:creationId xmlns:a16="http://schemas.microsoft.com/office/drawing/2014/main" id="{D7BCA2ED-930E-48FB-A58C-291A33D7DBBC}"/>
+                <a16:creationId xmlns:a16="http://schemas.microsoft.com/office/drawing/2014/main" id="{EFF86988-FECB-462C-A9AF-A25370098CF7}"/>
               </a:ext>
             </a:extLst>
           </p:cNvPr>
@@ -11801,7 +11957,7 @@
                 <a:ea typeface="Arial"/>
                 <a:cs typeface="Arial"/>
               </a:rPr>
-              <a:t>Как измерить пользу интеграции</a:t>
+              <a:t>Что подтверждено документацией</a:t>
             </a:r>
           </a:p>
         </p:txBody>
@@ -11811,7 +11967,7 @@
           <p:cNvPr id="4" name="">
             <a:extLst xmlns:a="http://schemas.openxmlformats.org/drawingml/2006/main">
               <a:ext uri="{FF2B5EF4-FFF2-40B4-BE49-F238E27FC236}">
-                <a16:creationId xmlns:a16="http://schemas.microsoft.com/office/drawing/2014/main" id="{6FFD73E0-7E14-47E3-85FE-F8F57B28304C}"/>
+                <a16:creationId xmlns:a16="http://schemas.microsoft.com/office/drawing/2014/main" id="{A50D5C9B-55C4-415A-B3D0-BF2CC6AA1990}"/>
               </a:ext>
             </a:extLst>
           </p:cNvPr>
@@ -11879,7 +12035,7 @@
           <p:cNvPr id="5" name="">
             <a:extLst xmlns:a="http://schemas.openxmlformats.org/drawingml/2006/main">
               <a:ext uri="{FF2B5EF4-FFF2-40B4-BE49-F238E27FC236}">
-                <a16:creationId xmlns:a16="http://schemas.microsoft.com/office/drawing/2014/main" id="{41EFF9EA-BEB2-42B6-B87D-25C694F72F61}"/>
+                <a16:creationId xmlns:a16="http://schemas.microsoft.com/office/drawing/2014/main" id="{9D372F88-FB82-4F23-85E5-D6705AE0E422}"/>
               </a:ext>
             </a:extLst>
           </p:cNvPr>
@@ -11947,7 +12103,7 @@
           <p:cNvPr id="6" name="">
             <a:extLst xmlns:a="http://schemas.openxmlformats.org/drawingml/2006/main">
               <a:ext uri="{FF2B5EF4-FFF2-40B4-BE49-F238E27FC236}">
-                <a16:creationId xmlns:a16="http://schemas.microsoft.com/office/drawing/2014/main" id="{D9B251F7-42D7-452C-94BE-CB3617C189F3}"/>
+                <a16:creationId xmlns:a16="http://schemas.microsoft.com/office/drawing/2014/main" id="{B5006410-BC26-4C81-B1A7-7B9E9B19AF00}"/>
               </a:ext>
             </a:extLst>
           </p:cNvPr>
@@ -12015,7 +12171,7 @@
           <p:cNvPr id="7" name="">
             <a:extLst xmlns:a="http://schemas.openxmlformats.org/drawingml/2006/main">
               <a:ext uri="{FF2B5EF4-FFF2-40B4-BE49-F238E27FC236}">
-                <a16:creationId xmlns:a16="http://schemas.microsoft.com/office/drawing/2014/main" id="{5665D3F4-FDEC-4A6E-94E3-7C1EBF2E3345}"/>
+                <a16:creationId xmlns:a16="http://schemas.microsoft.com/office/drawing/2014/main" id="{A96CBD1B-1D14-4D38-8211-CCD8A9D66C56}"/>
               </a:ext>
             </a:extLst>
           </p:cNvPr>
@@ -12073,7 +12229,7 @@
                 <a:ea typeface="Arial"/>
                 <a:cs typeface="Arial"/>
               </a:rPr>
-              <a:t>План замеров для пилота интеграции со Skillaz</a:t>
+              <a:t>Документация hh описывает функции и примеры ответа API</a:t>
             </a:r>
           </a:p>
         </p:txBody>
@@ -12083,7 +12239,7 @@
           <p:cNvPr id="8" name="">
             <a:extLst xmlns:a="http://schemas.openxmlformats.org/drawingml/2006/main">
               <a:ext uri="{FF2B5EF4-FFF2-40B4-BE49-F238E27FC236}">
-                <a16:creationId xmlns:a16="http://schemas.microsoft.com/office/drawing/2014/main" id="{63F6BD13-D63A-4077-89FF-E1567142A431}"/>
+                <a16:creationId xmlns:a16="http://schemas.microsoft.com/office/drawing/2014/main" id="{CCAC3AAC-6A0A-43F1-ABF3-AD06E42DDF4B}"/>
               </a:ext>
             </a:extLst>
           </p:cNvPr>
@@ -12118,7 +12274,7 @@
                           <a:ea typeface="Arial"/>
                           <a:cs typeface="Arial"/>
                         </a:rPr>
-                        <a:t>Показатель</a:t>
+                        <a:t>Возможность</a:t>
                       </a:r>
                     </a:p>
                   </a:txBody>
@@ -12166,7 +12322,7 @@
                           <a:ea typeface="Arial"/>
                           <a:cs typeface="Arial"/>
                         </a:rPr>
-                        <a:t>До интеграции</a:t>
+                        <a:t>Где выполняется</a:t>
                       </a:r>
                     </a:p>
                   </a:txBody>
@@ -12208,7 +12364,7 @@
                           <a:ea typeface="Arial"/>
                           <a:cs typeface="Arial"/>
                         </a:rPr>
-                        <a:t>С интеграцией</a:t>
+                        <a:t>Статус</a:t>
                       </a:r>
                     </a:p>
                   </a:txBody>
@@ -12252,7 +12408,7 @@
                           <a:ea typeface="Arial"/>
                           <a:cs typeface="Arial"/>
                         </a:rPr>
-                        <a:t>Ручное время на отклик</a:t>
+                        <a:t>Настройка критериев и вопросов</a:t>
                       </a:r>
                     </a:p>
                   </a:txBody>
@@ -12294,7 +12450,7 @@
                           <a:ea typeface="Arial"/>
                           <a:cs typeface="Arial"/>
                         </a:rPr>
-                        <a:t>Замер</a:t>
+                        <a:t>В hh.ru</a:t>
                       </a:r>
                     </a:p>
                   </a:txBody>
@@ -12330,7 +12486,7 @@
                           <a:ea typeface="Arial"/>
                           <a:cs typeface="Arial"/>
                         </a:rPr>
-                        <a:t>Замер</a:t>
+                        <a:t>Описано hh</a:t>
                       </a:r>
                     </a:p>
                   </a:txBody>
@@ -12368,7 +12524,7 @@
                           <a:ea typeface="Arial"/>
                           <a:cs typeface="Arial"/>
                         </a:rPr>
-                        <a:t>Перенос данных между системами</a:t>
+                        <a:t>Разбор и доопрос новых откликов</a:t>
                       </a:r>
                     </a:p>
                   </a:txBody>
@@ -12410,7 +12566,7 @@
                           <a:ea typeface="Arial"/>
                           <a:cs typeface="Arial"/>
                         </a:rPr>
-                        <a:t>Замер</a:t>
+                        <a:t>В hh.ru</a:t>
                       </a:r>
                     </a:p>
                   </a:txBody>
@@ -12446,7 +12602,7 @@
                           <a:ea typeface="Arial"/>
                           <a:cs typeface="Arial"/>
                         </a:rPr>
-                        <a:t>Замер</a:t>
+                        <a:t>Описано hh</a:t>
                       </a:r>
                     </a:p>
                   </a:txBody>
@@ -12484,7 +12640,7 @@
                           <a:ea typeface="Arial"/>
                           <a:cs typeface="Arial"/>
                         </a:rPr>
-                        <a:t>Полнота карточки кандидата</a:t>
+                        <a:t>Выдача оценки и ответов</a:t>
                       </a:r>
                     </a:p>
                   </a:txBody>
@@ -12526,7 +12682,7 @@
                           <a:ea typeface="Arial"/>
                           <a:cs typeface="Arial"/>
                         </a:rPr>
-                        <a:t>Замер</a:t>
+                        <a:t>API hh.ru</a:t>
                       </a:r>
                     </a:p>
                   </a:txBody>
@@ -12562,7 +12718,7 @@
                           <a:ea typeface="Arial"/>
                           <a:cs typeface="Arial"/>
                         </a:rPr>
-                        <a:t>Замер</a:t>
+                        <a:t>Пример ответа</a:t>
                       </a:r>
                     </a:p>
                   </a:txBody>
@@ -12600,7 +12756,7 @@
                           <a:ea typeface="Arial"/>
                           <a:cs typeface="Arial"/>
                         </a:rPr>
-                        <a:t>Время до следующего этапа</a:t>
+                        <a:t>Получение данных в Skillaz</a:t>
                       </a:r>
                     </a:p>
                   </a:txBody>
@@ -12642,7 +12798,7 @@
                           <a:ea typeface="Arial"/>
                           <a:cs typeface="Arial"/>
                         </a:rPr>
-                        <a:t>Замер</a:t>
+                        <a:t>Наша интеграция</a:t>
                       </a:r>
                     </a:p>
                   </a:txBody>
@@ -12678,7 +12834,7 @@
                           <a:ea typeface="Arial"/>
                           <a:cs typeface="Arial"/>
                         </a:rPr>
-                        <a:t>Замер</a:t>
+                        <a:t>Нужен тест</a:t>
                       </a:r>
                     </a:p>
                   </a:txBody>
@@ -12716,7 +12872,7 @@
                           <a:ea typeface="Arial"/>
                           <a:cs typeface="Arial"/>
                         </a:rPr>
-                        <a:t>Доля ручных корректировок</a:t>
+                        <a:t>Запуск и настройка из Skillaz</a:t>
                       </a:r>
                     </a:p>
                   </a:txBody>
@@ -12758,7 +12914,7 @@
                           <a:ea typeface="Arial"/>
                           <a:cs typeface="Arial"/>
                         </a:rPr>
-                        <a:t>Замер</a:t>
+                        <a:t>API управления</a:t>
                       </a:r>
                     </a:p>
                   </a:txBody>
@@ -12794,7 +12950,7 @@
                           <a:ea typeface="Arial"/>
                           <a:cs typeface="Arial"/>
                         </a:rPr>
-                        <a:t>Замер</a:t>
+                        <a:t>Не подтверждено</a:t>
                       </a:r>
                     </a:p>
                   </a:txBody>
@@ -12826,7 +12982,7 @@
           <p:cNvPr id="9" name="">
             <a:extLst xmlns:a="http://schemas.openxmlformats.org/drawingml/2006/main">
               <a:ext uri="{FF2B5EF4-FFF2-40B4-BE49-F238E27FC236}">
-                <a16:creationId xmlns:a16="http://schemas.microsoft.com/office/drawing/2014/main" id="{9FC4F3A0-238D-4859-9684-98063EE37286}"/>
+                <a16:creationId xmlns:a16="http://schemas.microsoft.com/office/drawing/2014/main" id="{D2572603-C1EF-4AC4-86E4-9D3C84C1D337}"/>
               </a:ext>
             </a:extLst>
           </p:cNvPr>
@@ -12856,7 +13012,7 @@
           <p:cNvPr id="10" name="">
             <a:extLst xmlns:a="http://schemas.openxmlformats.org/drawingml/2006/main">
               <a:ext uri="{FF2B5EF4-FFF2-40B4-BE49-F238E27FC236}">
-                <a16:creationId xmlns:a16="http://schemas.microsoft.com/office/drawing/2014/main" id="{81B49282-E97A-4CE1-8C75-C13A83AD2F0C}"/>
+                <a16:creationId xmlns:a16="http://schemas.microsoft.com/office/drawing/2014/main" id="{E3061EAB-6831-4207-9E6F-5FC338AA6834}"/>
               </a:ext>
             </a:extLst>
           </p:cNvPr>
@@ -12914,7 +13070,7 @@
                 <a:ea typeface="Arial"/>
                 <a:cs typeface="Arial"/>
               </a:rPr>
-              <a:t>Отклики × сэкономленные минуты ÷ 60 = высвобождённые часы</a:t>
+              <a:t>Публичный пример API не подтверждает готовность обмена со Skillaz</a:t>
             </a:r>
           </a:p>
         </p:txBody>
@@ -12922,7 +13078,7 @@
     </p:spTree>
     <p:extLst>
       <p:ext uri="{BB962C8B-B14F-4D97-AF65-F5344CB8AC3E}">
-        <p14:creationId xmlns:p14="http://schemas.microsoft.com/office/powerpoint/2010/main" val="938802003"/>
+        <p14:creationId xmlns:p14="http://schemas.microsoft.com/office/powerpoint/2010/main" val="1673067621"/>
       </p:ext>
     </p:extLst>
   </p:cSld>
@@ -12953,7 +13109,7 @@
           <p:cNvPr id="17" name="">
             <a:extLst xmlns:a="http://schemas.openxmlformats.org/drawingml/2006/main">
               <a:ext uri="{FF2B5EF4-FFF2-40B4-BE49-F238E27FC236}">
-                <a16:creationId xmlns:a16="http://schemas.microsoft.com/office/drawing/2014/main" id="{0710650D-94C2-400C-926F-422AF58BCEBA}"/>
+                <a16:creationId xmlns:a16="http://schemas.microsoft.com/office/drawing/2014/main" id="{4F5829C8-9EDD-4796-BADF-D1D8E18098AA}"/>
               </a:ext>
             </a:extLst>
           </p:cNvPr>
@@ -12963,7 +13119,7 @@
           <p:nvPr/>
         </p:nvPicPr>
         <p:blipFill>
-          <a:blip xmlns:r="http://schemas.openxmlformats.org/officeDocument/2006/relationships" xmlns:a="http://schemas.openxmlformats.org/drawingml/2006/main" r:embed="R43d1d046029349c9"/>
+          <a:blip xmlns:r="http://schemas.openxmlformats.org/officeDocument/2006/relationships" xmlns:a="http://schemas.openxmlformats.org/drawingml/2006/main" r:embed="Re43aba2eaf0e491a"/>
           <a:stretch xmlns:a="http://schemas.openxmlformats.org/drawingml/2006/main"/>
         </p:blipFill>
         <p:spPr>
@@ -12981,7 +13137,7 @@
           <p:cNvPr id="2" name="">
             <a:extLst xmlns:a="http://schemas.openxmlformats.org/drawingml/2006/main">
               <a:ext uri="{FF2B5EF4-FFF2-40B4-BE49-F238E27FC236}">
-                <a16:creationId xmlns:a16="http://schemas.microsoft.com/office/drawing/2014/main" id="{9E26FC9A-AFD0-487D-A4E0-BADD320F5E02}"/>
+                <a16:creationId xmlns:a16="http://schemas.microsoft.com/office/drawing/2014/main" id="{9B867A24-8FA6-445D-961E-7C3DBC10802C}"/>
               </a:ext>
             </a:extLst>
           </p:cNvPr>
@@ -13039,7 +13195,7 @@
                 <a:ea typeface="Courier New"/>
                 <a:cs typeface="Courier New"/>
               </a:rPr>
-              <a:t>ПОДГОТОВКА К ПОДКЛЮЧЕНИЮ</a:t>
+              <a:t>БАЗОВЫЙ ВАРИАНТ</a:t>
             </a:r>
           </a:p>
         </p:txBody>
@@ -13049,7 +13205,7 @@
           <p:cNvPr id="3" name="">
             <a:extLst xmlns:a="http://schemas.openxmlformats.org/drawingml/2006/main">
               <a:ext uri="{FF2B5EF4-FFF2-40B4-BE49-F238E27FC236}">
-                <a16:creationId xmlns:a16="http://schemas.microsoft.com/office/drawing/2014/main" id="{D65F34E2-CBDB-40EC-9FBE-F8165B23E795}"/>
+                <a16:creationId xmlns:a16="http://schemas.microsoft.com/office/drawing/2014/main" id="{62A29C39-0328-4303-9F68-0E956CA8E220}"/>
               </a:ext>
             </a:extLst>
           </p:cNvPr>
@@ -13107,7 +13263,7 @@
                 <a:ea typeface="Arial"/>
                 <a:cs typeface="Arial"/>
               </a:rPr>
-              <a:t>Что оценить перед подключением</a:t>
+              <a:t>Настройка в hh.ru, результаты в Skillaz</a:t>
             </a:r>
           </a:p>
         </p:txBody>
@@ -13117,7 +13273,7 @@
           <p:cNvPr id="4" name="">
             <a:extLst xmlns:a="http://schemas.openxmlformats.org/drawingml/2006/main">
               <a:ext uri="{FF2B5EF4-FFF2-40B4-BE49-F238E27FC236}">
-                <a16:creationId xmlns:a16="http://schemas.microsoft.com/office/drawing/2014/main" id="{894B74D9-8F29-4EBD-B930-FB4B4187A7BF}"/>
+                <a16:creationId xmlns:a16="http://schemas.microsoft.com/office/drawing/2014/main" id="{75B57C6E-8D04-4538-A318-0E46D664886C}"/>
               </a:ext>
             </a:extLst>
           </p:cNvPr>
@@ -13185,7 +13341,7 @@
           <p:cNvPr id="5" name="">
             <a:extLst xmlns:a="http://schemas.openxmlformats.org/drawingml/2006/main">
               <a:ext uri="{FF2B5EF4-FFF2-40B4-BE49-F238E27FC236}">
-                <a16:creationId xmlns:a16="http://schemas.microsoft.com/office/drawing/2014/main" id="{77B2DA60-ABFE-47E3-9641-9C25B7C699AF}"/>
+                <a16:creationId xmlns:a16="http://schemas.microsoft.com/office/drawing/2014/main" id="{7D95CDD3-297D-4BD2-8C81-D9E27DDBE70E}"/>
               </a:ext>
             </a:extLst>
           </p:cNvPr>
@@ -13253,7 +13409,7 @@
           <p:cNvPr id="6" name="">
             <a:extLst xmlns:a="http://schemas.openxmlformats.org/drawingml/2006/main">
               <a:ext uri="{FF2B5EF4-FFF2-40B4-BE49-F238E27FC236}">
-                <a16:creationId xmlns:a16="http://schemas.microsoft.com/office/drawing/2014/main" id="{4F16D96F-417D-4605-BC60-7184E42BEE0D}"/>
+                <a16:creationId xmlns:a16="http://schemas.microsoft.com/office/drawing/2014/main" id="{21ECD9C4-20F2-499A-94FB-31821533B1D0}"/>
               </a:ext>
             </a:extLst>
           </p:cNvPr>
@@ -13321,7 +13477,7 @@
           <p:cNvPr id="7" name="">
             <a:extLst xmlns:a="http://schemas.openxmlformats.org/drawingml/2006/main">
               <a:ext uri="{FF2B5EF4-FFF2-40B4-BE49-F238E27FC236}">
-                <a16:creationId xmlns:a16="http://schemas.microsoft.com/office/drawing/2014/main" id="{4CC810C0-31CE-4AFA-82BB-CE994658984C}"/>
+                <a16:creationId xmlns:a16="http://schemas.microsoft.com/office/drawing/2014/main" id="{90245483-EF85-448C-98EC-7E5E14090ACE}"/>
               </a:ext>
             </a:extLst>
           </p:cNvPr>
@@ -13351,7 +13507,7 @@
           <p:cNvPr id="8" name="">
             <a:extLst xmlns:a="http://schemas.openxmlformats.org/drawingml/2006/main">
               <a:ext uri="{FF2B5EF4-FFF2-40B4-BE49-F238E27FC236}">
-                <a16:creationId xmlns:a16="http://schemas.microsoft.com/office/drawing/2014/main" id="{F2A15142-DD76-4F40-A6BF-EBD46C216B7D}"/>
+                <a16:creationId xmlns:a16="http://schemas.microsoft.com/office/drawing/2014/main" id="{E176FC53-D7D4-4C2B-8360-3A52EE861EE7}"/>
               </a:ext>
             </a:extLst>
           </p:cNvPr>
@@ -13409,7 +13565,7 @@
                 <a:ea typeface="Arial"/>
                 <a:cs typeface="Arial"/>
               </a:rPr>
-              <a:t>Процесс</a:t>
+              <a:t>В hh.ru</a:t>
             </a:r>
           </a:p>
         </p:txBody>
@@ -13419,7 +13575,7 @@
           <p:cNvPr id="9" name="">
             <a:extLst xmlns:a="http://schemas.openxmlformats.org/drawingml/2006/main">
               <a:ext uri="{FF2B5EF4-FFF2-40B4-BE49-F238E27FC236}">
-                <a16:creationId xmlns:a16="http://schemas.microsoft.com/office/drawing/2014/main" id="{2DFDF655-5218-4D38-B5D3-CFE73A24C7A8}"/>
+                <a16:creationId xmlns:a16="http://schemas.microsoft.com/office/drawing/2014/main" id="{579F5400-ABA9-423F-991F-7F0B6DD06068}"/>
               </a:ext>
             </a:extLst>
           </p:cNvPr>
@@ -13477,7 +13633,7 @@
                 <a:ea typeface="Arial"/>
                 <a:cs typeface="Arial"/>
               </a:rPr>
-              <a:t>Ручные действия.</a:t>
+              <a:t>Настройка вакансии.</a:t>
             </a:r>
           </a:p>
           <a:p xmlns:a="http://schemas.openxmlformats.org/drawingml/2006/main">
@@ -13500,7 +13656,7 @@
                 <a:ea typeface="Arial"/>
                 <a:cs typeface="Arial"/>
               </a:rPr>
-              <a:t>Переключения систем.</a:t>
+              <a:t>Критерии и вопросы.</a:t>
             </a:r>
           </a:p>
           <a:p xmlns:a="http://schemas.openxmlformats.org/drawingml/2006/main">
@@ -13523,7 +13679,7 @@
                 <a:ea typeface="Arial"/>
                 <a:cs typeface="Arial"/>
               </a:rPr>
-              <a:t>Время на один отклик.</a:t>
+              <a:t>Автоматический разбор.</a:t>
             </a:r>
           </a:p>
         </p:txBody>
@@ -13533,7 +13689,7 @@
           <p:cNvPr id="10" name="">
             <a:extLst xmlns:a="http://schemas.openxmlformats.org/drawingml/2006/main">
               <a:ext uri="{FF2B5EF4-FFF2-40B4-BE49-F238E27FC236}">
-                <a16:creationId xmlns:a16="http://schemas.microsoft.com/office/drawing/2014/main" id="{B166EC70-4E90-48BE-890D-7E7C3540216C}"/>
+                <a16:creationId xmlns:a16="http://schemas.microsoft.com/office/drawing/2014/main" id="{ED5FBA2D-CED0-4AA8-A159-FDE59AF037E8}"/>
               </a:ext>
             </a:extLst>
           </p:cNvPr>
@@ -13563,7 +13719,7 @@
           <p:cNvPr id="11" name="">
             <a:extLst xmlns:a="http://schemas.openxmlformats.org/drawingml/2006/main">
               <a:ext uri="{FF2B5EF4-FFF2-40B4-BE49-F238E27FC236}">
-                <a16:creationId xmlns:a16="http://schemas.microsoft.com/office/drawing/2014/main" id="{EFE16DF8-0FCD-48FB-ACE8-DC0AF14DE8EF}"/>
+                <a16:creationId xmlns:a16="http://schemas.microsoft.com/office/drawing/2014/main" id="{5FC3E867-C857-4891-84C9-A6F7CFD66278}"/>
               </a:ext>
             </a:extLst>
           </p:cNvPr>
@@ -13621,7 +13777,7 @@
                 <a:ea typeface="Arial"/>
                 <a:cs typeface="Arial"/>
               </a:rPr>
-              <a:t>Данные</a:t>
+              <a:t>Через API</a:t>
             </a:r>
           </a:p>
         </p:txBody>
@@ -13631,7 +13787,7 @@
           <p:cNvPr id="12" name="">
             <a:extLst xmlns:a="http://schemas.openxmlformats.org/drawingml/2006/main">
               <a:ext uri="{FF2B5EF4-FFF2-40B4-BE49-F238E27FC236}">
-                <a16:creationId xmlns:a16="http://schemas.microsoft.com/office/drawing/2014/main" id="{DDB11252-93BC-471F-B2E6-576DB1D2FDAE}"/>
+                <a16:creationId xmlns:a16="http://schemas.microsoft.com/office/drawing/2014/main" id="{D1E2F702-AACF-4E62-85BD-111101B12DDC}"/>
               </a:ext>
             </a:extLst>
           </p:cNvPr>
@@ -13689,7 +13845,7 @@
                 <a:ea typeface="Arial"/>
                 <a:cs typeface="Arial"/>
               </a:rPr>
-              <a:t>Какие результаты ИИ</a:t>
+              <a:t>Получение результата</a:t>
             </a:r>
           </a:p>
           <a:p xmlns:a="http://schemas.openxmlformats.org/drawingml/2006/main">
@@ -13712,7 +13868,7 @@
                 <a:ea typeface="Arial"/>
                 <a:cs typeface="Arial"/>
               </a:rPr>
-              <a:t>нужны рекрутёру</a:t>
+              <a:t>по ID отклика.</a:t>
             </a:r>
           </a:p>
           <a:p xmlns:a="http://schemas.openxmlformats.org/drawingml/2006/main">
@@ -13735,7 +13891,30 @@
                 <a:ea typeface="Arial"/>
                 <a:cs typeface="Arial"/>
               </a:rPr>
-              <a:t>для следующего шага.</a:t>
+              <a:t>Без отправки текста</a:t>
+            </a:r>
+          </a:p>
+          <a:p xmlns:a="http://schemas.openxmlformats.org/drawingml/2006/main">
+            <a:pPr>
+              <a:defRPr sz="1650" b="0">
+                <a:solidFill>
+                  <a:srgbClr val="737C96"/>
+                </a:solidFill>
+                <a:latin typeface="Arial"/>
+                <a:ea typeface="Arial"/>
+                <a:cs typeface="Arial"/>
+              </a:defRPr>
+            </a:pPr>
+            <a:r>
+              <a:rPr sz="1650" b="0">
+                <a:solidFill>
+                  <a:srgbClr val="737C96"/>
+                </a:solidFill>
+                <a:latin typeface="Arial"/>
+                <a:ea typeface="Arial"/>
+                <a:cs typeface="Arial"/>
+              </a:rPr>
+              <a:t>резюме из Skillaz.</a:t>
             </a:r>
           </a:p>
         </p:txBody>
@@ -13745,7 +13924,7 @@
           <p:cNvPr id="13" name="">
             <a:extLst xmlns:a="http://schemas.openxmlformats.org/drawingml/2006/main">
               <a:ext uri="{FF2B5EF4-FFF2-40B4-BE49-F238E27FC236}">
-                <a16:creationId xmlns:a16="http://schemas.microsoft.com/office/drawing/2014/main" id="{826DD5B2-8CCD-49FC-8FD2-2339C222320E}"/>
+                <a16:creationId xmlns:a16="http://schemas.microsoft.com/office/drawing/2014/main" id="{94B91FD8-534A-4D9B-BE5E-C97769AACF77}"/>
               </a:ext>
             </a:extLst>
           </p:cNvPr>
@@ -13775,7 +13954,7 @@
           <p:cNvPr id="14" name="">
             <a:extLst xmlns:a="http://schemas.openxmlformats.org/drawingml/2006/main">
               <a:ext uri="{FF2B5EF4-FFF2-40B4-BE49-F238E27FC236}">
-                <a16:creationId xmlns:a16="http://schemas.microsoft.com/office/drawing/2014/main" id="{A3CA3FA8-16DC-4236-A780-0371DEFDD8B5}"/>
+                <a16:creationId xmlns:a16="http://schemas.microsoft.com/office/drawing/2014/main" id="{9DE3ADDA-425E-4459-843D-06A920930B56}"/>
               </a:ext>
             </a:extLst>
           </p:cNvPr>
@@ -13833,7 +14012,7 @@
                 <a:ea typeface="Arial"/>
                 <a:cs typeface="Arial"/>
               </a:rPr>
-              <a:t>Экономика</a:t>
+              <a:t>В Skillaz</a:t>
             </a:r>
           </a:p>
         </p:txBody>
@@ -13843,7 +14022,7 @@
           <p:cNvPr id="15" name="">
             <a:extLst xmlns:a="http://schemas.openxmlformats.org/drawingml/2006/main">
               <a:ext uri="{FF2B5EF4-FFF2-40B4-BE49-F238E27FC236}">
-                <a16:creationId xmlns:a16="http://schemas.microsoft.com/office/drawing/2014/main" id="{4EB442C3-DCB1-4CE3-BE95-00D4EF12FF2F}"/>
+                <a16:creationId xmlns:a16="http://schemas.microsoft.com/office/drawing/2014/main" id="{77E534F3-849E-4FA4-940D-317E8C48A9CE}"/>
               </a:ext>
             </a:extLst>
           </p:cNvPr>
@@ -13901,7 +14080,7 @@
                 <a:ea typeface="Arial"/>
                 <a:cs typeface="Arial"/>
               </a:rPr>
-              <a:t>Ожидаемая экономия</a:t>
+              <a:t>Предлагаем показывать</a:t>
             </a:r>
           </a:p>
           <a:p xmlns:a="http://schemas.openxmlformats.org/drawingml/2006/main">
@@ -13924,7 +14103,7 @@
                 <a:ea typeface="Arial"/>
                 <a:cs typeface="Arial"/>
               </a:rPr>
-              <a:t>времени и полная</a:t>
+              <a:t>оценку и ответы</a:t>
             </a:r>
           </a:p>
           <a:p xmlns:a="http://schemas.openxmlformats.org/drawingml/2006/main">
@@ -13947,7 +14126,30 @@
                 <a:ea typeface="Arial"/>
                 <a:cs typeface="Arial"/>
               </a:rPr>
-              <a:t>стоимость подключения.</a:t>
+              <a:t>рядом с откликом</a:t>
+            </a:r>
+          </a:p>
+          <a:p xmlns:a="http://schemas.openxmlformats.org/drawingml/2006/main">
+            <a:pPr>
+              <a:defRPr sz="1650" b="0">
+                <a:solidFill>
+                  <a:srgbClr val="737C96"/>
+                </a:solidFill>
+                <a:latin typeface="Arial"/>
+                <a:ea typeface="Arial"/>
+                <a:cs typeface="Arial"/>
+              </a:defRPr>
+            </a:pPr>
+            <a:r>
+              <a:rPr sz="1650" b="0">
+                <a:solidFill>
+                  <a:srgbClr val="737C96"/>
+                </a:solidFill>
+                <a:latin typeface="Arial"/>
+                <a:ea typeface="Arial"/>
+                <a:cs typeface="Arial"/>
+              </a:rPr>
+              <a:t>после проверки обмена.</a:t>
             </a:r>
           </a:p>
         </p:txBody>
@@ -13957,7 +14159,7 @@
           <p:cNvPr id="16" name="">
             <a:extLst xmlns:a="http://schemas.openxmlformats.org/drawingml/2006/main">
               <a:ext uri="{FF2B5EF4-FFF2-40B4-BE49-F238E27FC236}">
-                <a16:creationId xmlns:a16="http://schemas.microsoft.com/office/drawing/2014/main" id="{19945637-C7B0-41B9-B142-C998933E19E3}"/>
+                <a16:creationId xmlns:a16="http://schemas.microsoft.com/office/drawing/2014/main" id="{66E6BE4E-DCEB-4779-9670-751CA5713977}"/>
               </a:ext>
             </a:extLst>
           </p:cNvPr>
@@ -14015,7 +14217,7 @@
                 <a:ea typeface="Arial"/>
                 <a:cs typeface="Arial"/>
               </a:rPr>
-              <a:t>Основа решения — результаты пилота и согласованное предложение.</a:t>
+              <a:t>Вариант для реализации; доступ приложения Skillaz к данным ещё не проверен.</a:t>
             </a:r>
           </a:p>
         </p:txBody>
@@ -14023,7 +14225,7 @@
     </p:spTree>
     <p:extLst>
       <p:ext uri="{BB962C8B-B14F-4D97-AF65-F5344CB8AC3E}">
-        <p14:creationId xmlns:p14="http://schemas.microsoft.com/office/powerpoint/2010/main" val="211405811"/>
+        <p14:creationId xmlns:p14="http://schemas.microsoft.com/office/powerpoint/2010/main" val="1225450610"/>
       </p:ext>
     </p:extLst>
   </p:cSld>

</xml_diff>

<commit_message>
Remove two slide captions requested in review
</commit_message>
<xml_diff>
--- a/Skillaz-hh-Integration.pptx
+++ b/Skillaz-hh-Integration.pptx
@@ -2,22 +2,22 @@
 <file path=ppt/presentation.xml><?xml version="1.0" encoding="utf-8"?>
 <p:presentation xmlns:p="http://schemas.openxmlformats.org/presentationml/2006/main">
   <p:sldMasterIdLst>
-    <p:sldMasterId xmlns:r="http://schemas.openxmlformats.org/officeDocument/2006/relationships" id="2147483648" r:id="R9f2e538fcfa3423d"/>
+    <p:sldMasterId xmlns:r="http://schemas.openxmlformats.org/officeDocument/2006/relationships" id="2147483648" r:id="R9c2f2de8383d4564"/>
   </p:sldMasterIdLst>
   <p:notesMasterIdLst>
-    <p:notesMasterId xmlns:r="http://schemas.openxmlformats.org/officeDocument/2006/relationships" r:id="R9dceda9bf76b4816"/>
+    <p:notesMasterId xmlns:r="http://schemas.openxmlformats.org/officeDocument/2006/relationships" r:id="Ra6c3a64e2e374ab2"/>
   </p:notesMasterIdLst>
   <p:sldIdLst>
-    <p:sldId xmlns:r="http://schemas.openxmlformats.org/officeDocument/2006/relationships" id="256" r:id="R232e305760c247b2"/>
-    <p:sldId xmlns:r="http://schemas.openxmlformats.org/officeDocument/2006/relationships" id="257" r:id="R3c4463c0a09a4e96"/>
-    <p:sldId xmlns:r="http://schemas.openxmlformats.org/officeDocument/2006/relationships" id="258" r:id="R9f2339d9bd51456b"/>
-    <p:sldId xmlns:r="http://schemas.openxmlformats.org/officeDocument/2006/relationships" id="259" r:id="Ra2ef08a3cdee4687"/>
-    <p:sldId xmlns:r="http://schemas.openxmlformats.org/officeDocument/2006/relationships" id="260" r:id="R2e0c72bb9e4042d9"/>
-    <p:sldId xmlns:r="http://schemas.openxmlformats.org/officeDocument/2006/relationships" id="261" r:id="R26a64c26bed84852"/>
-    <p:sldId xmlns:r="http://schemas.openxmlformats.org/officeDocument/2006/relationships" id="262" r:id="R73b0e0d9509e4b7e"/>
-    <p:sldId xmlns:r="http://schemas.openxmlformats.org/officeDocument/2006/relationships" id="263" r:id="Rf2f850f54b254919"/>
-    <p:sldId xmlns:r="http://schemas.openxmlformats.org/officeDocument/2006/relationships" id="264" r:id="Raf094cd6ae8247fa"/>
-    <p:sldId xmlns:r="http://schemas.openxmlformats.org/officeDocument/2006/relationships" id="265" r:id="Rab0eaac855b04b54"/>
+    <p:sldId xmlns:r="http://schemas.openxmlformats.org/officeDocument/2006/relationships" id="256" r:id="Rfde312104e8e418f"/>
+    <p:sldId xmlns:r="http://schemas.openxmlformats.org/officeDocument/2006/relationships" id="257" r:id="Rd2ad115011294b7c"/>
+    <p:sldId xmlns:r="http://schemas.openxmlformats.org/officeDocument/2006/relationships" id="258" r:id="R9dc72c17529c42da"/>
+    <p:sldId xmlns:r="http://schemas.openxmlformats.org/officeDocument/2006/relationships" id="259" r:id="R6ae650de37f54b65"/>
+    <p:sldId xmlns:r="http://schemas.openxmlformats.org/officeDocument/2006/relationships" id="260" r:id="R2607b0990d5c4d95"/>
+    <p:sldId xmlns:r="http://schemas.openxmlformats.org/officeDocument/2006/relationships" id="261" r:id="R1e8f8bc9e13d4fb7"/>
+    <p:sldId xmlns:r="http://schemas.openxmlformats.org/officeDocument/2006/relationships" id="262" r:id="Rf98e9425316e4331"/>
+    <p:sldId xmlns:r="http://schemas.openxmlformats.org/officeDocument/2006/relationships" id="263" r:id="Rfb871bebd6354a81"/>
+    <p:sldId xmlns:r="http://schemas.openxmlformats.org/officeDocument/2006/relationships" id="264" r:id="Rafa7de84b1ee48d2"/>
+    <p:sldId xmlns:r="http://schemas.openxmlformats.org/officeDocument/2006/relationships" id="265" r:id="R03cee2fdd1894a66"/>
   </p:sldIdLst>
   <p:sldSz cx="10692384" cy="6007608"/>
   <p:notesSz cx="6858000" cy="9144000"/>
@@ -1338,7 +1338,7 @@
           <p:cNvPr id="3" name="Title">
             <a:extLst xmlns:a="http://schemas.openxmlformats.org/drawingml/2006/main">
               <a:ext uri="{FF2B5EF4-FFF2-40B4-BE49-F238E27FC236}">
-                <a16:creationId xmlns:a16="http://schemas.microsoft.com/office/drawing/2014/main" id="{618C8D91-320F-4ECF-BEE7-7AABC48584DB}"/>
+                <a16:creationId xmlns:a16="http://schemas.microsoft.com/office/drawing/2014/main" id="{B5F1A045-CBAF-4CD5-A84C-E6C0E0F2023F}"/>
               </a:ext>
             </a:extLst>
           </p:cNvPr>
@@ -1495,7 +1495,7 @@
           <p:cNvPr id="2" name="Subtitle">
             <a:extLst xmlns:a="http://schemas.openxmlformats.org/drawingml/2006/main">
               <a:ext uri="{FF2B5EF4-FFF2-40B4-BE49-F238E27FC236}">
-                <a16:creationId xmlns:a16="http://schemas.microsoft.com/office/drawing/2014/main" id="{D1B5A618-7BAA-475C-AD0B-0A7C275D5A68}"/>
+                <a16:creationId xmlns:a16="http://schemas.microsoft.com/office/drawing/2014/main" id="{13B6DB34-B7FB-497C-8C2F-E39FA7180347}"/>
               </a:ext>
             </a:extLst>
           </p:cNvPr>
@@ -1669,7 +1669,7 @@
           <p:cNvPr id="2" name="Section title">
             <a:extLst xmlns:a="http://schemas.openxmlformats.org/drawingml/2006/main">
               <a:ext uri="{FF2B5EF4-FFF2-40B4-BE49-F238E27FC236}">
-                <a16:creationId xmlns:a16="http://schemas.microsoft.com/office/drawing/2014/main" id="{F6723E76-BA19-4388-8CA0-BBFD233553BF}"/>
+                <a16:creationId xmlns:a16="http://schemas.microsoft.com/office/drawing/2014/main" id="{6C37E80E-0ED6-4DC7-B10C-96CF668FC121}"/>
               </a:ext>
             </a:extLst>
           </p:cNvPr>
@@ -1843,7 +1843,7 @@
           <p:cNvPr id="3" name="Title">
             <a:extLst xmlns:a="http://schemas.openxmlformats.org/drawingml/2006/main">
               <a:ext uri="{FF2B5EF4-FFF2-40B4-BE49-F238E27FC236}">
-                <a16:creationId xmlns:a16="http://schemas.microsoft.com/office/drawing/2014/main" id="{F64FA09E-B835-4294-B5EA-68237BC68720}"/>
+                <a16:creationId xmlns:a16="http://schemas.microsoft.com/office/drawing/2014/main" id="{08861548-6651-49F2-9E53-DDF2D296EB97}"/>
               </a:ext>
             </a:extLst>
           </p:cNvPr>
@@ -2000,7 +2000,7 @@
           <p:cNvPr id="2" name="Body">
             <a:extLst xmlns:a="http://schemas.openxmlformats.org/drawingml/2006/main">
               <a:ext uri="{FF2B5EF4-FFF2-40B4-BE49-F238E27FC236}">
-                <a16:creationId xmlns:a16="http://schemas.microsoft.com/office/drawing/2014/main" id="{8729281E-282F-48E3-9A4A-812D85A74424}"/>
+                <a16:creationId xmlns:a16="http://schemas.microsoft.com/office/drawing/2014/main" id="{799477C1-1A84-42E6-AAF2-C8E1128FDEF5}"/>
               </a:ext>
             </a:extLst>
           </p:cNvPr>
@@ -2174,7 +2174,7 @@
           <p:cNvPr id="4" name="Title">
             <a:extLst xmlns:a="http://schemas.openxmlformats.org/drawingml/2006/main">
               <a:ext uri="{FF2B5EF4-FFF2-40B4-BE49-F238E27FC236}">
-                <a16:creationId xmlns:a16="http://schemas.microsoft.com/office/drawing/2014/main" id="{79CB5B3E-98D9-4515-82D7-FFCF549F0AF0}"/>
+                <a16:creationId xmlns:a16="http://schemas.microsoft.com/office/drawing/2014/main" id="{3CDBF0A6-26A6-4F19-ADFE-055B85A4D18B}"/>
               </a:ext>
             </a:extLst>
           </p:cNvPr>
@@ -2331,7 +2331,7 @@
           <p:cNvPr id="2" name="Left column">
             <a:extLst xmlns:a="http://schemas.openxmlformats.org/drawingml/2006/main">
               <a:ext uri="{FF2B5EF4-FFF2-40B4-BE49-F238E27FC236}">
-                <a16:creationId xmlns:a16="http://schemas.microsoft.com/office/drawing/2014/main" id="{B323C66B-2F6B-4EBC-9A57-3EF4DF83B9A2}"/>
+                <a16:creationId xmlns:a16="http://schemas.microsoft.com/office/drawing/2014/main" id="{6B282A8F-0DDD-4011-9AAF-233EA7C55D32}"/>
               </a:ext>
             </a:extLst>
           </p:cNvPr>
@@ -2488,7 +2488,7 @@
           <p:cNvPr id="3" name="Right column">
             <a:extLst xmlns:a="http://schemas.openxmlformats.org/drawingml/2006/main">
               <a:ext uri="{FF2B5EF4-FFF2-40B4-BE49-F238E27FC236}">
-                <a16:creationId xmlns:a16="http://schemas.microsoft.com/office/drawing/2014/main" id="{D0792C7D-0863-489E-AEBA-E7DDE1420149}"/>
+                <a16:creationId xmlns:a16="http://schemas.microsoft.com/office/drawing/2014/main" id="{5083456A-2175-4637-A046-DDBC92FA8486}"/>
               </a:ext>
             </a:extLst>
           </p:cNvPr>
@@ -2662,7 +2662,7 @@
           <p:cNvPr id="3" name="Title">
             <a:extLst xmlns:a="http://schemas.openxmlformats.org/drawingml/2006/main">
               <a:ext uri="{FF2B5EF4-FFF2-40B4-BE49-F238E27FC236}">
-                <a16:creationId xmlns:a16="http://schemas.microsoft.com/office/drawing/2014/main" id="{62B7BBD3-F635-45F6-8E36-5A221F4CC145}"/>
+                <a16:creationId xmlns:a16="http://schemas.microsoft.com/office/drawing/2014/main" id="{37C74EB7-F3F8-4BF3-BF57-1FBCD3F2753F}"/>
               </a:ext>
             </a:extLst>
           </p:cNvPr>
@@ -2819,7 +2819,7 @@
           <p:cNvPr id="2" name="Left column">
             <a:extLst xmlns:a="http://schemas.openxmlformats.org/drawingml/2006/main">
               <a:ext uri="{FF2B5EF4-FFF2-40B4-BE49-F238E27FC236}">
-                <a16:creationId xmlns:a16="http://schemas.microsoft.com/office/drawing/2014/main" id="{B84E031C-4307-43B6-8BE9-3A2CB81129C7}"/>
+                <a16:creationId xmlns:a16="http://schemas.microsoft.com/office/drawing/2014/main" id="{9D381C58-676D-41E7-B53D-8AEC7B751BB1}"/>
               </a:ext>
             </a:extLst>
           </p:cNvPr>
@@ -3014,12 +3014,12 @@
   </p:cSld>
   <p:clrMap bg1="lt1" tx1="dk1" bg2="lt2" tx2="dk2" accent1="accent1" accent2="accent2" accent3="accent3" accent4="accent4" accent5="accent5" accent6="accent6" hlink="hlink" folHlink="folHlink"/>
   <p:sldLayoutIdLst>
-    <p:sldLayoutId xmlns:r="http://schemas.openxmlformats.org/officeDocument/2006/relationships" id="2147483649" r:id="R4a9ed6c5c36048d3"/>
-    <p:sldLayoutId xmlns:r="http://schemas.openxmlformats.org/officeDocument/2006/relationships" id="2147483650" r:id="Rfb309429db044876"/>
-    <p:sldLayoutId xmlns:r="http://schemas.openxmlformats.org/officeDocument/2006/relationships" id="2147483651" r:id="Rd14c4f9430d64f3c"/>
-    <p:sldLayoutId xmlns:r="http://schemas.openxmlformats.org/officeDocument/2006/relationships" id="2147483652" r:id="R883f4d8dc5db4585"/>
-    <p:sldLayoutId xmlns:r="http://schemas.openxmlformats.org/officeDocument/2006/relationships" id="2147483653" r:id="R6e1eb9c9a3d44860"/>
-    <p:sldLayoutId xmlns:r="http://schemas.openxmlformats.org/officeDocument/2006/relationships" id="2147483654" r:id="Ra8b025aced1c40ec"/>
+    <p:sldLayoutId xmlns:r="http://schemas.openxmlformats.org/officeDocument/2006/relationships" id="2147483649" r:id="R9215ff60f0694d31"/>
+    <p:sldLayoutId xmlns:r="http://schemas.openxmlformats.org/officeDocument/2006/relationships" id="2147483650" r:id="R91d6670cde4940cb"/>
+    <p:sldLayoutId xmlns:r="http://schemas.openxmlformats.org/officeDocument/2006/relationships" id="2147483651" r:id="R2cc159e8d2954d4a"/>
+    <p:sldLayoutId xmlns:r="http://schemas.openxmlformats.org/officeDocument/2006/relationships" id="2147483652" r:id="R13d8d149a7da4d45"/>
+    <p:sldLayoutId xmlns:r="http://schemas.openxmlformats.org/officeDocument/2006/relationships" id="2147483653" r:id="R235aba9296e142e3"/>
+    <p:sldLayoutId xmlns:r="http://schemas.openxmlformats.org/officeDocument/2006/relationships" id="2147483654" r:id="R477f21c0f1da4bed"/>
   </p:sldLayoutIdLst>
   <p:txStyles>
     <p:titleStyle>
@@ -3570,7 +3570,7 @@
           <p:cNvPr id="11" name="">
             <a:extLst xmlns:a="http://schemas.openxmlformats.org/drawingml/2006/main">
               <a:ext uri="{FF2B5EF4-FFF2-40B4-BE49-F238E27FC236}">
-                <a16:creationId xmlns:a16="http://schemas.microsoft.com/office/drawing/2014/main" id="{2E71653F-E48F-40AA-A6AB-34536210B65F}"/>
+                <a16:creationId xmlns:a16="http://schemas.microsoft.com/office/drawing/2014/main" id="{B799D45C-6920-4443-912D-3BFD4746B0D0}"/>
               </a:ext>
             </a:extLst>
           </p:cNvPr>
@@ -3580,7 +3580,7 @@
           <p:nvPr/>
         </p:nvPicPr>
         <p:blipFill>
-          <a:blip xmlns:r="http://schemas.openxmlformats.org/officeDocument/2006/relationships" xmlns:a="http://schemas.openxmlformats.org/drawingml/2006/main" r:embed="Rd004c8e21f0c4fde"/>
+          <a:blip xmlns:r="http://schemas.openxmlformats.org/officeDocument/2006/relationships" xmlns:a="http://schemas.openxmlformats.org/drawingml/2006/main" r:embed="R39cd529606614253"/>
           <a:stretch xmlns:a="http://schemas.openxmlformats.org/drawingml/2006/main"/>
         </p:blipFill>
         <p:spPr>
@@ -3598,7 +3598,7 @@
           <p:cNvPr id="2" name="">
             <a:extLst xmlns:a="http://schemas.openxmlformats.org/drawingml/2006/main">
               <a:ext uri="{FF2B5EF4-FFF2-40B4-BE49-F238E27FC236}">
-                <a16:creationId xmlns:a16="http://schemas.microsoft.com/office/drawing/2014/main" id="{F96D15C7-4EE7-485E-9E16-8C470B37A5F0}"/>
+                <a16:creationId xmlns:a16="http://schemas.microsoft.com/office/drawing/2014/main" id="{88B8DDB2-5520-4E11-94AC-E4B510329036}"/>
               </a:ext>
             </a:extLst>
           </p:cNvPr>
@@ -3666,7 +3666,7 @@
           <p:cNvPr id="3" name="">
             <a:extLst xmlns:a="http://schemas.openxmlformats.org/drawingml/2006/main">
               <a:ext uri="{FF2B5EF4-FFF2-40B4-BE49-F238E27FC236}">
-                <a16:creationId xmlns:a16="http://schemas.microsoft.com/office/drawing/2014/main" id="{FD35B176-ED43-41E6-90F7-4D73F20E05CC}"/>
+                <a16:creationId xmlns:a16="http://schemas.microsoft.com/office/drawing/2014/main" id="{9B0CF87A-0DA4-4F8F-82E6-1F161BA9E55D}"/>
               </a:ext>
             </a:extLst>
           </p:cNvPr>
@@ -3734,7 +3734,7 @@
           <p:cNvPr id="4" name="">
             <a:extLst xmlns:a="http://schemas.openxmlformats.org/drawingml/2006/main">
               <a:ext uri="{FF2B5EF4-FFF2-40B4-BE49-F238E27FC236}">
-                <a16:creationId xmlns:a16="http://schemas.microsoft.com/office/drawing/2014/main" id="{A1E2F4E4-C5FA-47BD-9C58-C2055944D1BF}"/>
+                <a16:creationId xmlns:a16="http://schemas.microsoft.com/office/drawing/2014/main" id="{6F8465EA-EFAD-4B03-BF94-8DA4A6EE2072}"/>
               </a:ext>
             </a:extLst>
           </p:cNvPr>
@@ -3802,7 +3802,7 @@
           <p:cNvPr id="5" name="">
             <a:extLst xmlns:a="http://schemas.openxmlformats.org/drawingml/2006/main">
               <a:ext uri="{FF2B5EF4-FFF2-40B4-BE49-F238E27FC236}">
-                <a16:creationId xmlns:a16="http://schemas.microsoft.com/office/drawing/2014/main" id="{D32A60F9-C44E-4857-86B2-CDFFB167351C}"/>
+                <a16:creationId xmlns:a16="http://schemas.microsoft.com/office/drawing/2014/main" id="{F509B47D-1694-4DDE-A692-388CB535A5D5}"/>
               </a:ext>
             </a:extLst>
           </p:cNvPr>
@@ -3870,7 +3870,7 @@
           <p:cNvPr id="6" name="">
             <a:extLst xmlns:a="http://schemas.openxmlformats.org/drawingml/2006/main">
               <a:ext uri="{FF2B5EF4-FFF2-40B4-BE49-F238E27FC236}">
-                <a16:creationId xmlns:a16="http://schemas.microsoft.com/office/drawing/2014/main" id="{37D6480C-BDAB-4161-B271-FC9BD4342D06}"/>
+                <a16:creationId xmlns:a16="http://schemas.microsoft.com/office/drawing/2014/main" id="{33BD1EE7-FFF7-4D5A-8128-D8F816D88B6D}"/>
               </a:ext>
             </a:extLst>
           </p:cNvPr>
@@ -3900,7 +3900,7 @@
           <p:cNvPr id="7" name="">
             <a:extLst xmlns:a="http://schemas.openxmlformats.org/drawingml/2006/main">
               <a:ext uri="{FF2B5EF4-FFF2-40B4-BE49-F238E27FC236}">
-                <a16:creationId xmlns:a16="http://schemas.microsoft.com/office/drawing/2014/main" id="{46621D9D-9902-4E0C-9786-675360687698}"/>
+                <a16:creationId xmlns:a16="http://schemas.microsoft.com/office/drawing/2014/main" id="{45C6B426-B11E-4DEC-829B-8A1F1BE74114}"/>
               </a:ext>
             </a:extLst>
           </p:cNvPr>
@@ -3991,7 +3991,7 @@
           <p:cNvPr id="8" name="">
             <a:extLst xmlns:a="http://schemas.openxmlformats.org/drawingml/2006/main">
               <a:ext uri="{FF2B5EF4-FFF2-40B4-BE49-F238E27FC236}">
-                <a16:creationId xmlns:a16="http://schemas.microsoft.com/office/drawing/2014/main" id="{8DA59114-19C5-4476-AC62-B446762C0E3F}"/>
+                <a16:creationId xmlns:a16="http://schemas.microsoft.com/office/drawing/2014/main" id="{0AC6DB30-0A31-4D64-8D65-9483FFC0C91F}"/>
               </a:ext>
             </a:extLst>
           </p:cNvPr>
@@ -4082,7 +4082,7 @@
           <p:cNvPr id="9" name="">
             <a:extLst xmlns:a="http://schemas.openxmlformats.org/drawingml/2006/main">
               <a:ext uri="{FF2B5EF4-FFF2-40B4-BE49-F238E27FC236}">
-                <a16:creationId xmlns:a16="http://schemas.microsoft.com/office/drawing/2014/main" id="{3A60E2FA-760A-47BE-A472-1D36BD278A03}"/>
+                <a16:creationId xmlns:a16="http://schemas.microsoft.com/office/drawing/2014/main" id="{00357A85-D1AD-4C0C-A5CA-3504C8EF8309}"/>
               </a:ext>
             </a:extLst>
           </p:cNvPr>
@@ -4150,7 +4150,7 @@
           <p:cNvPr id="10" name="">
             <a:extLst xmlns:a="http://schemas.openxmlformats.org/drawingml/2006/main">
               <a:ext uri="{FF2B5EF4-FFF2-40B4-BE49-F238E27FC236}">
-                <a16:creationId xmlns:a16="http://schemas.microsoft.com/office/drawing/2014/main" id="{90F1E914-01E8-4209-AD54-0205288AC690}"/>
+                <a16:creationId xmlns:a16="http://schemas.microsoft.com/office/drawing/2014/main" id="{8E7C14A4-0998-41F1-AB89-D105AF23EC90}"/>
               </a:ext>
             </a:extLst>
           </p:cNvPr>
@@ -4239,7 +4239,7 @@
     </p:spTree>
     <p:extLst>
       <p:ext uri="{BB962C8B-B14F-4D97-AF65-F5344CB8AC3E}">
-        <p14:creationId xmlns:p14="http://schemas.microsoft.com/office/powerpoint/2010/main" val="2108308437"/>
+        <p14:creationId xmlns:p14="http://schemas.microsoft.com/office/powerpoint/2010/main" val="695841019"/>
       </p:ext>
     </p:extLst>
   </p:cSld>
@@ -4270,7 +4270,7 @@
           <p:cNvPr id="21" name="">
             <a:extLst xmlns:a="http://schemas.openxmlformats.org/drawingml/2006/main">
               <a:ext uri="{FF2B5EF4-FFF2-40B4-BE49-F238E27FC236}">
-                <a16:creationId xmlns:a16="http://schemas.microsoft.com/office/drawing/2014/main" id="{2BF70111-F4FE-4638-B291-8E17B06D17CD}"/>
+                <a16:creationId xmlns:a16="http://schemas.microsoft.com/office/drawing/2014/main" id="{83DA52DF-1928-4297-84DE-303241F2B70D}"/>
               </a:ext>
             </a:extLst>
           </p:cNvPr>
@@ -4280,7 +4280,7 @@
           <p:nvPr/>
         </p:nvPicPr>
         <p:blipFill>
-          <a:blip xmlns:r="http://schemas.openxmlformats.org/officeDocument/2006/relationships" xmlns:a="http://schemas.openxmlformats.org/drawingml/2006/main" r:embed="R7acd19212d854a12"/>
+          <a:blip xmlns:r="http://schemas.openxmlformats.org/officeDocument/2006/relationships" xmlns:a="http://schemas.openxmlformats.org/drawingml/2006/main" r:embed="Rc18e316f86b54ff4"/>
           <a:stretch xmlns:a="http://schemas.openxmlformats.org/drawingml/2006/main"/>
         </p:blipFill>
         <p:spPr>
@@ -4298,7 +4298,7 @@
           <p:cNvPr id="2" name="">
             <a:extLst xmlns:a="http://schemas.openxmlformats.org/drawingml/2006/main">
               <a:ext uri="{FF2B5EF4-FFF2-40B4-BE49-F238E27FC236}">
-                <a16:creationId xmlns:a16="http://schemas.microsoft.com/office/drawing/2014/main" id="{B78376EB-ED41-4B77-8F56-4D347EC4B16B}"/>
+                <a16:creationId xmlns:a16="http://schemas.microsoft.com/office/drawing/2014/main" id="{5E53B8B3-7526-491B-A1FA-6854CA5C33E0}"/>
               </a:ext>
             </a:extLst>
           </p:cNvPr>
@@ -4366,7 +4366,7 @@
           <p:cNvPr id="3" name="">
             <a:extLst xmlns:a="http://schemas.openxmlformats.org/drawingml/2006/main">
               <a:ext uri="{FF2B5EF4-FFF2-40B4-BE49-F238E27FC236}">
-                <a16:creationId xmlns:a16="http://schemas.microsoft.com/office/drawing/2014/main" id="{FCDB3AC1-7C77-41CC-A0D0-EDB15AD87F02}"/>
+                <a16:creationId xmlns:a16="http://schemas.microsoft.com/office/drawing/2014/main" id="{EC346983-0509-4146-9482-90F4CE368594}"/>
               </a:ext>
             </a:extLst>
           </p:cNvPr>
@@ -4434,7 +4434,7 @@
           <p:cNvPr id="4" name="">
             <a:extLst xmlns:a="http://schemas.openxmlformats.org/drawingml/2006/main">
               <a:ext uri="{FF2B5EF4-FFF2-40B4-BE49-F238E27FC236}">
-                <a16:creationId xmlns:a16="http://schemas.microsoft.com/office/drawing/2014/main" id="{EFB0ACC8-7EC2-4208-95F3-FBE3531AC374}"/>
+                <a16:creationId xmlns:a16="http://schemas.microsoft.com/office/drawing/2014/main" id="{F48D0ACD-6677-4ADA-98FE-37B04145AAF2}"/>
               </a:ext>
             </a:extLst>
           </p:cNvPr>
@@ -4502,7 +4502,7 @@
           <p:cNvPr id="5" name="">
             <a:extLst xmlns:a="http://schemas.openxmlformats.org/drawingml/2006/main">
               <a:ext uri="{FF2B5EF4-FFF2-40B4-BE49-F238E27FC236}">
-                <a16:creationId xmlns:a16="http://schemas.microsoft.com/office/drawing/2014/main" id="{6A9D3148-A67E-4C2A-B302-843B4FBD2490}"/>
+                <a16:creationId xmlns:a16="http://schemas.microsoft.com/office/drawing/2014/main" id="{7C757A9A-CF66-4A79-8385-8EACDFD5C1A9}"/>
               </a:ext>
             </a:extLst>
           </p:cNvPr>
@@ -4570,7 +4570,7 @@
           <p:cNvPr id="6" name="">
             <a:extLst xmlns:a="http://schemas.openxmlformats.org/drawingml/2006/main">
               <a:ext uri="{FF2B5EF4-FFF2-40B4-BE49-F238E27FC236}">
-                <a16:creationId xmlns:a16="http://schemas.microsoft.com/office/drawing/2014/main" id="{6C7CD3EA-5DC5-4499-ADE7-0F48FF9B435C}"/>
+                <a16:creationId xmlns:a16="http://schemas.microsoft.com/office/drawing/2014/main" id="{FC254528-C687-4B74-A95D-388A2C299B77}"/>
               </a:ext>
             </a:extLst>
           </p:cNvPr>
@@ -4600,7 +4600,7 @@
           <p:cNvPr id="7" name="">
             <a:extLst xmlns:a="http://schemas.openxmlformats.org/drawingml/2006/main">
               <a:ext uri="{FF2B5EF4-FFF2-40B4-BE49-F238E27FC236}">
-                <a16:creationId xmlns:a16="http://schemas.microsoft.com/office/drawing/2014/main" id="{F73B30E1-5621-41EF-86D9-1FF727059456}"/>
+                <a16:creationId xmlns:a16="http://schemas.microsoft.com/office/drawing/2014/main" id="{6A44664C-FB85-46DE-BF3A-83F4CF76FE2C}"/>
               </a:ext>
             </a:extLst>
           </p:cNvPr>
@@ -4668,7 +4668,7 @@
           <p:cNvPr id="8" name="">
             <a:extLst xmlns:a="http://schemas.openxmlformats.org/drawingml/2006/main">
               <a:ext uri="{FF2B5EF4-FFF2-40B4-BE49-F238E27FC236}">
-                <a16:creationId xmlns:a16="http://schemas.microsoft.com/office/drawing/2014/main" id="{6532AA8D-B5D2-4B96-8AA1-75AEC163D84E}"/>
+                <a16:creationId xmlns:a16="http://schemas.microsoft.com/office/drawing/2014/main" id="{3D8B442C-E381-471C-82ED-A15D6E67CD32}"/>
               </a:ext>
             </a:extLst>
           </p:cNvPr>
@@ -4736,7 +4736,7 @@
           <p:cNvPr id="9" name="">
             <a:extLst xmlns:a="http://schemas.openxmlformats.org/drawingml/2006/main">
               <a:ext uri="{FF2B5EF4-FFF2-40B4-BE49-F238E27FC236}">
-                <a16:creationId xmlns:a16="http://schemas.microsoft.com/office/drawing/2014/main" id="{BA9C2CFB-9238-4A53-A1AA-CD7A3590A258}"/>
+                <a16:creationId xmlns:a16="http://schemas.microsoft.com/office/drawing/2014/main" id="{1197EE3B-4D3B-44D5-89C2-56177BDDA995}"/>
               </a:ext>
             </a:extLst>
           </p:cNvPr>
@@ -4804,7 +4804,7 @@
           <p:cNvPr id="10" name="">
             <a:extLst xmlns:a="http://schemas.openxmlformats.org/drawingml/2006/main">
               <a:ext uri="{FF2B5EF4-FFF2-40B4-BE49-F238E27FC236}">
-                <a16:creationId xmlns:a16="http://schemas.microsoft.com/office/drawing/2014/main" id="{B454A198-8D9E-4D19-8AC8-F61238762B4E}"/>
+                <a16:creationId xmlns:a16="http://schemas.microsoft.com/office/drawing/2014/main" id="{9C98CDF9-77A3-4E5D-8586-15B419EF1099}"/>
               </a:ext>
             </a:extLst>
           </p:cNvPr>
@@ -4872,7 +4872,7 @@
           <p:cNvPr id="11" name="">
             <a:extLst xmlns:a="http://schemas.openxmlformats.org/drawingml/2006/main">
               <a:ext uri="{FF2B5EF4-FFF2-40B4-BE49-F238E27FC236}">
-                <a16:creationId xmlns:a16="http://schemas.microsoft.com/office/drawing/2014/main" id="{58C00B82-3B14-412D-B1F7-3056A11DB3C3}"/>
+                <a16:creationId xmlns:a16="http://schemas.microsoft.com/office/drawing/2014/main" id="{1A00DF37-D240-4320-9E9E-9F7C7643571B}"/>
               </a:ext>
             </a:extLst>
           </p:cNvPr>
@@ -4940,7 +4940,7 @@
           <p:cNvPr id="12" name="">
             <a:extLst xmlns:a="http://schemas.openxmlformats.org/drawingml/2006/main">
               <a:ext uri="{FF2B5EF4-FFF2-40B4-BE49-F238E27FC236}">
-                <a16:creationId xmlns:a16="http://schemas.microsoft.com/office/drawing/2014/main" id="{71177637-5C09-497E-932F-22E5945AEF4F}"/>
+                <a16:creationId xmlns:a16="http://schemas.microsoft.com/office/drawing/2014/main" id="{E6D0D820-A2B9-4B43-B90E-392D4D487A33}"/>
               </a:ext>
             </a:extLst>
           </p:cNvPr>
@@ -5008,7 +5008,7 @@
           <p:cNvPr id="13" name="">
             <a:extLst xmlns:a="http://schemas.openxmlformats.org/drawingml/2006/main">
               <a:ext uri="{FF2B5EF4-FFF2-40B4-BE49-F238E27FC236}">
-                <a16:creationId xmlns:a16="http://schemas.microsoft.com/office/drawing/2014/main" id="{14226174-AF2F-4B6A-B9ED-9299A7366881}"/>
+                <a16:creationId xmlns:a16="http://schemas.microsoft.com/office/drawing/2014/main" id="{68B60299-3F69-4BCD-98C0-438C93ABAAFB}"/>
               </a:ext>
             </a:extLst>
           </p:cNvPr>
@@ -5076,7 +5076,7 @@
           <p:cNvPr id="14" name="">
             <a:extLst xmlns:a="http://schemas.openxmlformats.org/drawingml/2006/main">
               <a:ext uri="{FF2B5EF4-FFF2-40B4-BE49-F238E27FC236}">
-                <a16:creationId xmlns:a16="http://schemas.microsoft.com/office/drawing/2014/main" id="{A64055A8-75DB-451A-A9AF-C4F01C00B3B1}"/>
+                <a16:creationId xmlns:a16="http://schemas.microsoft.com/office/drawing/2014/main" id="{5CE370A7-D86A-42E9-9A3A-4F24F97B395C}"/>
               </a:ext>
             </a:extLst>
           </p:cNvPr>
@@ -5144,7 +5144,7 @@
           <p:cNvPr id="15" name="">
             <a:extLst xmlns:a="http://schemas.openxmlformats.org/drawingml/2006/main">
               <a:ext uri="{FF2B5EF4-FFF2-40B4-BE49-F238E27FC236}">
-                <a16:creationId xmlns:a16="http://schemas.microsoft.com/office/drawing/2014/main" id="{0F7C716A-67B5-4609-9ED6-EA4BB51BEA75}"/>
+                <a16:creationId xmlns:a16="http://schemas.microsoft.com/office/drawing/2014/main" id="{71D725FB-7C62-4081-9D17-01EEA9AABAAA}"/>
               </a:ext>
             </a:extLst>
           </p:cNvPr>
@@ -5212,7 +5212,7 @@
           <p:cNvPr id="16" name="">
             <a:extLst xmlns:a="http://schemas.openxmlformats.org/drawingml/2006/main">
               <a:ext uri="{FF2B5EF4-FFF2-40B4-BE49-F238E27FC236}">
-                <a16:creationId xmlns:a16="http://schemas.microsoft.com/office/drawing/2014/main" id="{A4A560CC-B20E-41DC-A95F-87F0BE26DFCB}"/>
+                <a16:creationId xmlns:a16="http://schemas.microsoft.com/office/drawing/2014/main" id="{04CC4CD7-FB43-421C-9163-3C2A00A7ACAC}"/>
               </a:ext>
             </a:extLst>
           </p:cNvPr>
@@ -5280,7 +5280,7 @@
           <p:cNvPr id="17" name="">
             <a:extLst xmlns:a="http://schemas.openxmlformats.org/drawingml/2006/main">
               <a:ext uri="{FF2B5EF4-FFF2-40B4-BE49-F238E27FC236}">
-                <a16:creationId xmlns:a16="http://schemas.microsoft.com/office/drawing/2014/main" id="{92631FE6-24EE-4A12-B6A5-DEE4C6952399}"/>
+                <a16:creationId xmlns:a16="http://schemas.microsoft.com/office/drawing/2014/main" id="{C24C1CD4-4D6E-4858-8A34-19B5B12915B0}"/>
               </a:ext>
             </a:extLst>
           </p:cNvPr>
@@ -5348,7 +5348,7 @@
           <p:cNvPr id="18" name="">
             <a:extLst xmlns:a="http://schemas.openxmlformats.org/drawingml/2006/main">
               <a:ext uri="{FF2B5EF4-FFF2-40B4-BE49-F238E27FC236}">
-                <a16:creationId xmlns:a16="http://schemas.microsoft.com/office/drawing/2014/main" id="{8D8BB9CF-7FDF-4F9F-A363-00D59744F178}"/>
+                <a16:creationId xmlns:a16="http://schemas.microsoft.com/office/drawing/2014/main" id="{8A4E396B-4727-426B-BE7B-3B88DFD1CB02}"/>
               </a:ext>
             </a:extLst>
           </p:cNvPr>
@@ -5416,7 +5416,7 @@
           <p:cNvPr id="19" name="">
             <a:extLst xmlns:a="http://schemas.openxmlformats.org/drawingml/2006/main">
               <a:ext uri="{FF2B5EF4-FFF2-40B4-BE49-F238E27FC236}">
-                <a16:creationId xmlns:a16="http://schemas.microsoft.com/office/drawing/2014/main" id="{BBD245A5-E1DD-4989-8988-697CE9D9F162}"/>
+                <a16:creationId xmlns:a16="http://schemas.microsoft.com/office/drawing/2014/main" id="{38A6D686-95BA-451D-8863-DC8AE36477E5}"/>
               </a:ext>
             </a:extLst>
           </p:cNvPr>
@@ -5484,7 +5484,7 @@
           <p:cNvPr id="20" name="">
             <a:extLst xmlns:a="http://schemas.openxmlformats.org/drawingml/2006/main">
               <a:ext uri="{FF2B5EF4-FFF2-40B4-BE49-F238E27FC236}">
-                <a16:creationId xmlns:a16="http://schemas.microsoft.com/office/drawing/2014/main" id="{EAE99F48-338B-46EC-87C7-AA435E61E415}"/>
+                <a16:creationId xmlns:a16="http://schemas.microsoft.com/office/drawing/2014/main" id="{D9DD6C78-AF14-4BCC-ADE5-75D4FAACE7A5}"/>
               </a:ext>
             </a:extLst>
           </p:cNvPr>
@@ -5550,7 +5550,7 @@
     </p:spTree>
     <p:extLst>
       <p:ext uri="{BB962C8B-B14F-4D97-AF65-F5344CB8AC3E}">
-        <p14:creationId xmlns:p14="http://schemas.microsoft.com/office/powerpoint/2010/main" val="267147850"/>
+        <p14:creationId xmlns:p14="http://schemas.microsoft.com/office/powerpoint/2010/main" val="1525273103"/>
       </p:ext>
     </p:extLst>
   </p:cSld>
@@ -5581,7 +5581,7 @@
           <p:cNvPr id="15" name="">
             <a:extLst xmlns:a="http://schemas.openxmlformats.org/drawingml/2006/main">
               <a:ext uri="{FF2B5EF4-FFF2-40B4-BE49-F238E27FC236}">
-                <a16:creationId xmlns:a16="http://schemas.microsoft.com/office/drawing/2014/main" id="{2ADCEDF9-4A32-46F1-AB3E-C98448A55CD2}"/>
+                <a16:creationId xmlns:a16="http://schemas.microsoft.com/office/drawing/2014/main" id="{CE760BF7-674D-4133-A9AB-74B95F18CBD7}"/>
               </a:ext>
             </a:extLst>
           </p:cNvPr>
@@ -5591,7 +5591,7 @@
           <p:nvPr/>
         </p:nvPicPr>
         <p:blipFill>
-          <a:blip xmlns:r="http://schemas.openxmlformats.org/officeDocument/2006/relationships" xmlns:a="http://schemas.openxmlformats.org/drawingml/2006/main" r:embed="R4477525c6c784047"/>
+          <a:blip xmlns:r="http://schemas.openxmlformats.org/officeDocument/2006/relationships" xmlns:a="http://schemas.openxmlformats.org/drawingml/2006/main" r:embed="R80bf39dc06034a91"/>
           <a:stretch xmlns:a="http://schemas.openxmlformats.org/drawingml/2006/main"/>
         </p:blipFill>
         <p:spPr>
@@ -5609,7 +5609,7 @@
           <p:cNvPr id="2" name="">
             <a:extLst xmlns:a="http://schemas.openxmlformats.org/drawingml/2006/main">
               <a:ext uri="{FF2B5EF4-FFF2-40B4-BE49-F238E27FC236}">
-                <a16:creationId xmlns:a16="http://schemas.microsoft.com/office/drawing/2014/main" id="{2FB3AEA3-1C1D-45DF-9C8A-7F73144DD810}"/>
+                <a16:creationId xmlns:a16="http://schemas.microsoft.com/office/drawing/2014/main" id="{7D21DD70-0297-49CC-B4E1-5B742BA73D1D}"/>
               </a:ext>
             </a:extLst>
           </p:cNvPr>
@@ -5677,7 +5677,7 @@
           <p:cNvPr id="3" name="">
             <a:extLst xmlns:a="http://schemas.openxmlformats.org/drawingml/2006/main">
               <a:ext uri="{FF2B5EF4-FFF2-40B4-BE49-F238E27FC236}">
-                <a16:creationId xmlns:a16="http://schemas.microsoft.com/office/drawing/2014/main" id="{252D38D0-9A20-430B-A1F5-FFAB4C3BC09A}"/>
+                <a16:creationId xmlns:a16="http://schemas.microsoft.com/office/drawing/2014/main" id="{3B51626A-1967-449D-9BB2-660B49967060}"/>
               </a:ext>
             </a:extLst>
           </p:cNvPr>
@@ -5768,7 +5768,7 @@
           <p:cNvPr id="4" name="">
             <a:extLst xmlns:a="http://schemas.openxmlformats.org/drawingml/2006/main">
               <a:ext uri="{FF2B5EF4-FFF2-40B4-BE49-F238E27FC236}">
-                <a16:creationId xmlns:a16="http://schemas.microsoft.com/office/drawing/2014/main" id="{D15311D1-D15A-4C9E-8E9F-8C6BCE8CB197}"/>
+                <a16:creationId xmlns:a16="http://schemas.microsoft.com/office/drawing/2014/main" id="{1C3C8EAC-C0EB-4F66-AF59-6539F62697A0}"/>
               </a:ext>
             </a:extLst>
           </p:cNvPr>
@@ -5836,7 +5836,7 @@
           <p:cNvPr id="5" name="">
             <a:extLst xmlns:a="http://schemas.openxmlformats.org/drawingml/2006/main">
               <a:ext uri="{FF2B5EF4-FFF2-40B4-BE49-F238E27FC236}">
-                <a16:creationId xmlns:a16="http://schemas.microsoft.com/office/drawing/2014/main" id="{9484571B-A60C-4A95-BAF3-9E87F805E708}"/>
+                <a16:creationId xmlns:a16="http://schemas.microsoft.com/office/drawing/2014/main" id="{EE4CC3CB-E938-4DE9-B019-3FCC3C665CAE}"/>
               </a:ext>
             </a:extLst>
           </p:cNvPr>
@@ -5904,7 +5904,7 @@
           <p:cNvPr id="6" name="">
             <a:extLst xmlns:a="http://schemas.openxmlformats.org/drawingml/2006/main">
               <a:ext uri="{FF2B5EF4-FFF2-40B4-BE49-F238E27FC236}">
-                <a16:creationId xmlns:a16="http://schemas.microsoft.com/office/drawing/2014/main" id="{78273968-4222-4317-9B53-6AA5C707FD2B}"/>
+                <a16:creationId xmlns:a16="http://schemas.microsoft.com/office/drawing/2014/main" id="{72E52B6B-5ABB-4C4A-8C56-DA686753D788}"/>
               </a:ext>
             </a:extLst>
           </p:cNvPr>
@@ -5972,7 +5972,7 @@
           <p:cNvPr id="7" name="">
             <a:extLst xmlns:a="http://schemas.openxmlformats.org/drawingml/2006/main">
               <a:ext uri="{FF2B5EF4-FFF2-40B4-BE49-F238E27FC236}">
-                <a16:creationId xmlns:a16="http://schemas.microsoft.com/office/drawing/2014/main" id="{B93CDE19-5EA8-4926-9DDE-8818830BCF4B}"/>
+                <a16:creationId xmlns:a16="http://schemas.microsoft.com/office/drawing/2014/main" id="{F4670BDE-5CD0-46AE-BFBD-D49D0EEAAF7D}"/>
               </a:ext>
             </a:extLst>
           </p:cNvPr>
@@ -6040,7 +6040,7 @@
           <p:cNvPr id="8" name="">
             <a:extLst xmlns:a="http://schemas.openxmlformats.org/drawingml/2006/main">
               <a:ext uri="{FF2B5EF4-FFF2-40B4-BE49-F238E27FC236}">
-                <a16:creationId xmlns:a16="http://schemas.microsoft.com/office/drawing/2014/main" id="{EC04C88A-3285-4075-8BEB-44749E1458BE}"/>
+                <a16:creationId xmlns:a16="http://schemas.microsoft.com/office/drawing/2014/main" id="{FB38B1F6-15C5-4EE4-8E4F-DFB5B9A4BB64}"/>
               </a:ext>
             </a:extLst>
           </p:cNvPr>
@@ -6108,7 +6108,7 @@
           <p:cNvPr id="9" name="">
             <a:extLst xmlns:a="http://schemas.openxmlformats.org/drawingml/2006/main">
               <a:ext uri="{FF2B5EF4-FFF2-40B4-BE49-F238E27FC236}">
-                <a16:creationId xmlns:a16="http://schemas.microsoft.com/office/drawing/2014/main" id="{7097A0AA-46F1-46F7-9DD9-8869A24AF3E2}"/>
+                <a16:creationId xmlns:a16="http://schemas.microsoft.com/office/drawing/2014/main" id="{A37E3F91-030C-4870-B939-32145CB014C2}"/>
               </a:ext>
             </a:extLst>
           </p:cNvPr>
@@ -6245,7 +6245,7 @@
           <p:cNvPr id="10" name="">
             <a:extLst xmlns:a="http://schemas.openxmlformats.org/drawingml/2006/main">
               <a:ext uri="{FF2B5EF4-FFF2-40B4-BE49-F238E27FC236}">
-                <a16:creationId xmlns:a16="http://schemas.microsoft.com/office/drawing/2014/main" id="{73695257-424B-4568-8609-C91369ABBB3D}"/>
+                <a16:creationId xmlns:a16="http://schemas.microsoft.com/office/drawing/2014/main" id="{BDA33FF9-4D61-4118-81D3-0D36C186C6EB}"/>
               </a:ext>
             </a:extLst>
           </p:cNvPr>
@@ -6275,7 +6275,7 @@
           <p:cNvPr id="11" name="">
             <a:extLst xmlns:a="http://schemas.openxmlformats.org/drawingml/2006/main">
               <a:ext uri="{FF2B5EF4-FFF2-40B4-BE49-F238E27FC236}">
-                <a16:creationId xmlns:a16="http://schemas.microsoft.com/office/drawing/2014/main" id="{8B467746-E217-40CA-A88F-9B734C777D40}"/>
+                <a16:creationId xmlns:a16="http://schemas.microsoft.com/office/drawing/2014/main" id="{D4A56874-4E71-4A27-A9D8-0301E8CC67A3}"/>
               </a:ext>
             </a:extLst>
           </p:cNvPr>
@@ -6343,7 +6343,7 @@
           <p:cNvPr id="12" name="">
             <a:extLst xmlns:a="http://schemas.openxmlformats.org/drawingml/2006/main">
               <a:ext uri="{FF2B5EF4-FFF2-40B4-BE49-F238E27FC236}">
-                <a16:creationId xmlns:a16="http://schemas.microsoft.com/office/drawing/2014/main" id="{38BFAD96-09D7-4B77-A608-7C9FBEC46F9D}"/>
+                <a16:creationId xmlns:a16="http://schemas.microsoft.com/office/drawing/2014/main" id="{54235AFA-7E4A-4741-830F-B216F0655DC4}"/>
               </a:ext>
             </a:extLst>
           </p:cNvPr>
@@ -6411,7 +6411,7 @@
           <p:cNvPr id="13" name="">
             <a:extLst xmlns:a="http://schemas.openxmlformats.org/drawingml/2006/main">
               <a:ext uri="{FF2B5EF4-FFF2-40B4-BE49-F238E27FC236}">
-                <a16:creationId xmlns:a16="http://schemas.microsoft.com/office/drawing/2014/main" id="{E6A14476-BDF9-4AF1-AE63-89C3B2714A70}"/>
+                <a16:creationId xmlns:a16="http://schemas.microsoft.com/office/drawing/2014/main" id="{4CF282B9-9A49-4500-9BD1-B164B2643123}"/>
               </a:ext>
             </a:extLst>
           </p:cNvPr>
@@ -6525,7 +6525,7 @@
           <p:cNvPr id="14" name="">
             <a:extLst xmlns:a="http://schemas.openxmlformats.org/drawingml/2006/main">
               <a:ext uri="{FF2B5EF4-FFF2-40B4-BE49-F238E27FC236}">
-                <a16:creationId xmlns:a16="http://schemas.microsoft.com/office/drawing/2014/main" id="{3899B57A-2192-478C-8068-2FC4FEC5F94A}"/>
+                <a16:creationId xmlns:a16="http://schemas.microsoft.com/office/drawing/2014/main" id="{91EE5588-AADD-4D3B-BFBD-48D003614C9D}"/>
               </a:ext>
             </a:extLst>
           </p:cNvPr>
@@ -6591,7 +6591,7 @@
     </p:spTree>
     <p:extLst>
       <p:ext uri="{BB962C8B-B14F-4D97-AF65-F5344CB8AC3E}">
-        <p14:creationId xmlns:p14="http://schemas.microsoft.com/office/powerpoint/2010/main" val="862981122"/>
+        <p14:creationId xmlns:p14="http://schemas.microsoft.com/office/powerpoint/2010/main" val="1576083486"/>
       </p:ext>
     </p:extLst>
   </p:cSld>
@@ -6622,7 +6622,7 @@
           <p:cNvPr id="9" name="">
             <a:extLst xmlns:a="http://schemas.openxmlformats.org/drawingml/2006/main">
               <a:ext uri="{FF2B5EF4-FFF2-40B4-BE49-F238E27FC236}">
-                <a16:creationId xmlns:a16="http://schemas.microsoft.com/office/drawing/2014/main" id="{41875E42-ACF9-4905-9309-B129175A7C41}"/>
+                <a16:creationId xmlns:a16="http://schemas.microsoft.com/office/drawing/2014/main" id="{926F48ED-9B46-416D-93D5-1349E40625CA}"/>
               </a:ext>
             </a:extLst>
           </p:cNvPr>
@@ -6632,7 +6632,7 @@
           <p:nvPr/>
         </p:nvPicPr>
         <p:blipFill>
-          <a:blip xmlns:r="http://schemas.openxmlformats.org/officeDocument/2006/relationships" xmlns:a="http://schemas.openxmlformats.org/drawingml/2006/main" r:embed="R4fc508d193c04d84"/>
+          <a:blip xmlns:r="http://schemas.openxmlformats.org/officeDocument/2006/relationships" xmlns:a="http://schemas.openxmlformats.org/drawingml/2006/main" r:embed="R13c59dc1a3064d37"/>
           <a:stretch xmlns:a="http://schemas.openxmlformats.org/drawingml/2006/main"/>
         </p:blipFill>
         <p:spPr>
@@ -6650,7 +6650,7 @@
           <p:cNvPr id="2" name="">
             <a:extLst xmlns:a="http://schemas.openxmlformats.org/drawingml/2006/main">
               <a:ext uri="{FF2B5EF4-FFF2-40B4-BE49-F238E27FC236}">
-                <a16:creationId xmlns:a16="http://schemas.microsoft.com/office/drawing/2014/main" id="{E09B7C5F-1024-4B90-B27C-DE75A1138469}"/>
+                <a16:creationId xmlns:a16="http://schemas.microsoft.com/office/drawing/2014/main" id="{D94966B2-1011-4F24-A49D-34A40B465712}"/>
               </a:ext>
             </a:extLst>
           </p:cNvPr>
@@ -6718,7 +6718,7 @@
           <p:cNvPr id="3" name="">
             <a:extLst xmlns:a="http://schemas.openxmlformats.org/drawingml/2006/main">
               <a:ext uri="{FF2B5EF4-FFF2-40B4-BE49-F238E27FC236}">
-                <a16:creationId xmlns:a16="http://schemas.microsoft.com/office/drawing/2014/main" id="{402830B2-E820-4315-84CC-3C80AEDDAEE4}"/>
+                <a16:creationId xmlns:a16="http://schemas.microsoft.com/office/drawing/2014/main" id="{C369DCC5-8D5E-4144-A61B-A924785DDFE0}"/>
               </a:ext>
             </a:extLst>
           </p:cNvPr>
@@ -6809,7 +6809,7 @@
           <p:cNvPr id="4" name="">
             <a:extLst xmlns:a="http://schemas.openxmlformats.org/drawingml/2006/main">
               <a:ext uri="{FF2B5EF4-FFF2-40B4-BE49-F238E27FC236}">
-                <a16:creationId xmlns:a16="http://schemas.microsoft.com/office/drawing/2014/main" id="{A15022D2-4ABC-4B8C-AFBC-B4257053B87F}"/>
+                <a16:creationId xmlns:a16="http://schemas.microsoft.com/office/drawing/2014/main" id="{B227A6ED-0567-4E39-BDB3-C8C793BC0499}"/>
               </a:ext>
             </a:extLst>
           </p:cNvPr>
@@ -6877,7 +6877,7 @@
           <p:cNvPr id="5" name="">
             <a:extLst xmlns:a="http://schemas.openxmlformats.org/drawingml/2006/main">
               <a:ext uri="{FF2B5EF4-FFF2-40B4-BE49-F238E27FC236}">
-                <a16:creationId xmlns:a16="http://schemas.microsoft.com/office/drawing/2014/main" id="{F4A920E2-2101-4B61-B252-36EB34625DD4}"/>
+                <a16:creationId xmlns:a16="http://schemas.microsoft.com/office/drawing/2014/main" id="{A8AC477F-37E2-4119-916D-1A4B8AAED2D4}"/>
               </a:ext>
             </a:extLst>
           </p:cNvPr>
@@ -6945,7 +6945,7 @@
           <p:cNvPr id="6" name="">
             <a:extLst xmlns:a="http://schemas.openxmlformats.org/drawingml/2006/main">
               <a:ext uri="{FF2B5EF4-FFF2-40B4-BE49-F238E27FC236}">
-                <a16:creationId xmlns:a16="http://schemas.microsoft.com/office/drawing/2014/main" id="{AA1F45BA-65B8-43F7-B1FE-B486BC6513F3}"/>
+                <a16:creationId xmlns:a16="http://schemas.microsoft.com/office/drawing/2014/main" id="{C4AB787B-ECA3-408C-BB79-8BA6B11DACCF}"/>
               </a:ext>
             </a:extLst>
           </p:cNvPr>
@@ -7013,7 +7013,7 @@
           <p:cNvPr id="7" name="">
             <a:extLst xmlns:a="http://schemas.openxmlformats.org/drawingml/2006/main">
               <a:ext uri="{FF2B5EF4-FFF2-40B4-BE49-F238E27FC236}">
-                <a16:creationId xmlns:a16="http://schemas.microsoft.com/office/drawing/2014/main" id="{E78780A7-14B4-4F50-AFF7-F1A09C666CA2}"/>
+                <a16:creationId xmlns:a16="http://schemas.microsoft.com/office/drawing/2014/main" id="{F2CB6615-A9B2-47C8-9C0D-E9A9F0549341}"/>
               </a:ext>
             </a:extLst>
           </p:cNvPr>
@@ -7453,7 +7453,7 @@
           <p:cNvPr id="8" name="">
             <a:extLst xmlns:a="http://schemas.openxmlformats.org/drawingml/2006/main">
               <a:ext uri="{FF2B5EF4-FFF2-40B4-BE49-F238E27FC236}">
-                <a16:creationId xmlns:a16="http://schemas.microsoft.com/office/drawing/2014/main" id="{D7AFC4AA-FE59-43C6-AD33-B5D721FABEDF}"/>
+                <a16:creationId xmlns:a16="http://schemas.microsoft.com/office/drawing/2014/main" id="{A22F252B-AA10-4239-875C-DF469FB73762}"/>
               </a:ext>
             </a:extLst>
           </p:cNvPr>
@@ -7519,7 +7519,7 @@
     </p:spTree>
     <p:extLst>
       <p:ext uri="{BB962C8B-B14F-4D97-AF65-F5344CB8AC3E}">
-        <p14:creationId xmlns:p14="http://schemas.microsoft.com/office/powerpoint/2010/main" val="185717131"/>
+        <p14:creationId xmlns:p14="http://schemas.microsoft.com/office/powerpoint/2010/main" val="1501322075"/>
       </p:ext>
     </p:extLst>
   </p:cSld>
@@ -7550,7 +7550,7 @@
           <p:cNvPr id="19" name="">
             <a:extLst xmlns:a="http://schemas.openxmlformats.org/drawingml/2006/main">
               <a:ext uri="{FF2B5EF4-FFF2-40B4-BE49-F238E27FC236}">
-                <a16:creationId xmlns:a16="http://schemas.microsoft.com/office/drawing/2014/main" id="{DC83B017-BE14-4669-9ADC-532DC6C71DF6}"/>
+                <a16:creationId xmlns:a16="http://schemas.microsoft.com/office/drawing/2014/main" id="{140392D2-68B2-423B-9A38-EBD6FE148C08}"/>
               </a:ext>
             </a:extLst>
           </p:cNvPr>
@@ -7560,7 +7560,7 @@
           <p:nvPr/>
         </p:nvPicPr>
         <p:blipFill>
-          <a:blip xmlns:r="http://schemas.openxmlformats.org/officeDocument/2006/relationships" xmlns:a="http://schemas.openxmlformats.org/drawingml/2006/main" r:embed="Ra447ab1ef45c498b"/>
+          <a:blip xmlns:r="http://schemas.openxmlformats.org/officeDocument/2006/relationships" xmlns:a="http://schemas.openxmlformats.org/drawingml/2006/main" r:embed="Rfd933c2d2a624561"/>
           <a:stretch xmlns:a="http://schemas.openxmlformats.org/drawingml/2006/main"/>
         </p:blipFill>
         <p:spPr>
@@ -7578,7 +7578,7 @@
           <p:cNvPr id="2" name="">
             <a:extLst xmlns:a="http://schemas.openxmlformats.org/drawingml/2006/main">
               <a:ext uri="{FF2B5EF4-FFF2-40B4-BE49-F238E27FC236}">
-                <a16:creationId xmlns:a16="http://schemas.microsoft.com/office/drawing/2014/main" id="{13711F5B-D980-4CAC-8EF1-A031F8DD2B80}"/>
+                <a16:creationId xmlns:a16="http://schemas.microsoft.com/office/drawing/2014/main" id="{E69EBCD3-1E7E-4DBB-A79B-CBC792C7301B}"/>
               </a:ext>
             </a:extLst>
           </p:cNvPr>
@@ -7646,7 +7646,7 @@
           <p:cNvPr id="3" name="">
             <a:extLst xmlns:a="http://schemas.openxmlformats.org/drawingml/2006/main">
               <a:ext uri="{FF2B5EF4-FFF2-40B4-BE49-F238E27FC236}">
-                <a16:creationId xmlns:a16="http://schemas.microsoft.com/office/drawing/2014/main" id="{1CD87C1A-D58B-4553-8146-DDDD553E2DF4}"/>
+                <a16:creationId xmlns:a16="http://schemas.microsoft.com/office/drawing/2014/main" id="{3E2D5EFD-9DB1-4BE5-80DC-1327F3DA9579}"/>
               </a:ext>
             </a:extLst>
           </p:cNvPr>
@@ -7714,7 +7714,7 @@
           <p:cNvPr id="4" name="">
             <a:extLst xmlns:a="http://schemas.openxmlformats.org/drawingml/2006/main">
               <a:ext uri="{FF2B5EF4-FFF2-40B4-BE49-F238E27FC236}">
-                <a16:creationId xmlns:a16="http://schemas.microsoft.com/office/drawing/2014/main" id="{EE2077FD-718A-4246-9D06-6BDC08AA26AD}"/>
+                <a16:creationId xmlns:a16="http://schemas.microsoft.com/office/drawing/2014/main" id="{3F02E113-6B05-48FA-A50E-214FCFA75593}"/>
               </a:ext>
             </a:extLst>
           </p:cNvPr>
@@ -7782,7 +7782,7 @@
           <p:cNvPr id="5" name="">
             <a:extLst xmlns:a="http://schemas.openxmlformats.org/drawingml/2006/main">
               <a:ext uri="{FF2B5EF4-FFF2-40B4-BE49-F238E27FC236}">
-                <a16:creationId xmlns:a16="http://schemas.microsoft.com/office/drawing/2014/main" id="{D3262AA1-A5A6-4F86-B712-ED0CF8501C6D}"/>
+                <a16:creationId xmlns:a16="http://schemas.microsoft.com/office/drawing/2014/main" id="{3209732A-79F6-4C98-AE99-90C7FBD1957D}"/>
               </a:ext>
             </a:extLst>
           </p:cNvPr>
@@ -7850,7 +7850,7 @@
           <p:cNvPr id="6" name="">
             <a:extLst xmlns:a="http://schemas.openxmlformats.org/drawingml/2006/main">
               <a:ext uri="{FF2B5EF4-FFF2-40B4-BE49-F238E27FC236}">
-                <a16:creationId xmlns:a16="http://schemas.microsoft.com/office/drawing/2014/main" id="{BAE8F5F5-F1C2-4564-961E-C74F505EA0C8}"/>
+                <a16:creationId xmlns:a16="http://schemas.microsoft.com/office/drawing/2014/main" id="{F9192DA1-DBF1-4644-ACBE-AE87DDAE80BE}"/>
               </a:ext>
             </a:extLst>
           </p:cNvPr>
@@ -7918,7 +7918,7 @@
           <p:cNvPr id="7" name="">
             <a:extLst xmlns:a="http://schemas.openxmlformats.org/drawingml/2006/main">
               <a:ext uri="{FF2B5EF4-FFF2-40B4-BE49-F238E27FC236}">
-                <a16:creationId xmlns:a16="http://schemas.microsoft.com/office/drawing/2014/main" id="{1CD0C714-2F35-405C-9537-1F08D1A12CE3}"/>
+                <a16:creationId xmlns:a16="http://schemas.microsoft.com/office/drawing/2014/main" id="{83301FC0-8359-4E2A-B633-F70FC217D4EB}"/>
               </a:ext>
             </a:extLst>
           </p:cNvPr>
@@ -7986,7 +7986,7 @@
           <p:cNvPr id="8" name="">
             <a:extLst xmlns:a="http://schemas.openxmlformats.org/drawingml/2006/main">
               <a:ext uri="{FF2B5EF4-FFF2-40B4-BE49-F238E27FC236}">
-                <a16:creationId xmlns:a16="http://schemas.microsoft.com/office/drawing/2014/main" id="{31982F2A-A005-431C-B528-2F3BE3248C0B}"/>
+                <a16:creationId xmlns:a16="http://schemas.microsoft.com/office/drawing/2014/main" id="{B0613F79-84AA-4251-AD2C-BCAB7F5063FB}"/>
               </a:ext>
             </a:extLst>
           </p:cNvPr>
@@ -8054,7 +8054,7 @@
           <p:cNvPr id="9" name="">
             <a:extLst xmlns:a="http://schemas.openxmlformats.org/drawingml/2006/main">
               <a:ext uri="{FF2B5EF4-FFF2-40B4-BE49-F238E27FC236}">
-                <a16:creationId xmlns:a16="http://schemas.microsoft.com/office/drawing/2014/main" id="{57646508-DB0A-4C1F-B362-CE5111D22C58}"/>
+                <a16:creationId xmlns:a16="http://schemas.microsoft.com/office/drawing/2014/main" id="{170F559D-4311-47F5-88FC-9C8FAF71357C}"/>
               </a:ext>
             </a:extLst>
           </p:cNvPr>
@@ -8122,7 +8122,7 @@
           <p:cNvPr id="10" name="">
             <a:extLst xmlns:a="http://schemas.openxmlformats.org/drawingml/2006/main">
               <a:ext uri="{FF2B5EF4-FFF2-40B4-BE49-F238E27FC236}">
-                <a16:creationId xmlns:a16="http://schemas.microsoft.com/office/drawing/2014/main" id="{F8806500-69E3-46BC-B77B-607DCEADF4C7}"/>
+                <a16:creationId xmlns:a16="http://schemas.microsoft.com/office/drawing/2014/main" id="{07AC0D07-5C5C-464F-B8F5-CC809DDB73F8}"/>
               </a:ext>
             </a:extLst>
           </p:cNvPr>
@@ -8190,7 +8190,7 @@
           <p:cNvPr id="11" name="">
             <a:extLst xmlns:a="http://schemas.openxmlformats.org/drawingml/2006/main">
               <a:ext uri="{FF2B5EF4-FFF2-40B4-BE49-F238E27FC236}">
-                <a16:creationId xmlns:a16="http://schemas.microsoft.com/office/drawing/2014/main" id="{7E8C0AD6-BFA7-491E-9830-3C2EF867E98C}"/>
+                <a16:creationId xmlns:a16="http://schemas.microsoft.com/office/drawing/2014/main" id="{BACEBD3D-521A-47AD-8B9A-EE5C9258B724}"/>
               </a:ext>
             </a:extLst>
           </p:cNvPr>
@@ -8258,7 +8258,7 @@
           <p:cNvPr id="12" name="">
             <a:extLst xmlns:a="http://schemas.openxmlformats.org/drawingml/2006/main">
               <a:ext uri="{FF2B5EF4-FFF2-40B4-BE49-F238E27FC236}">
-                <a16:creationId xmlns:a16="http://schemas.microsoft.com/office/drawing/2014/main" id="{E247E48B-100A-4A58-B315-E9D7CCFD3CED}"/>
+                <a16:creationId xmlns:a16="http://schemas.microsoft.com/office/drawing/2014/main" id="{0657862D-B315-4ACC-B8E1-1FB592EC61B3}"/>
               </a:ext>
             </a:extLst>
           </p:cNvPr>
@@ -8326,7 +8326,7 @@
           <p:cNvPr id="13" name="">
             <a:extLst xmlns:a="http://schemas.openxmlformats.org/drawingml/2006/main">
               <a:ext uri="{FF2B5EF4-FFF2-40B4-BE49-F238E27FC236}">
-                <a16:creationId xmlns:a16="http://schemas.microsoft.com/office/drawing/2014/main" id="{99211D74-20E9-4604-8DD1-407B58E0498B}"/>
+                <a16:creationId xmlns:a16="http://schemas.microsoft.com/office/drawing/2014/main" id="{3B7615A8-4311-49E2-A964-9A939BFAEC2B}"/>
               </a:ext>
             </a:extLst>
           </p:cNvPr>
@@ -8394,7 +8394,7 @@
           <p:cNvPr id="14" name="">
             <a:extLst xmlns:a="http://schemas.openxmlformats.org/drawingml/2006/main">
               <a:ext uri="{FF2B5EF4-FFF2-40B4-BE49-F238E27FC236}">
-                <a16:creationId xmlns:a16="http://schemas.microsoft.com/office/drawing/2014/main" id="{064DDEA7-3F1D-4512-97C3-B78F8A551D27}"/>
+                <a16:creationId xmlns:a16="http://schemas.microsoft.com/office/drawing/2014/main" id="{9AEA0063-2187-479F-8526-769DED955369}"/>
               </a:ext>
             </a:extLst>
           </p:cNvPr>
@@ -8462,7 +8462,7 @@
           <p:cNvPr id="15" name="">
             <a:extLst xmlns:a="http://schemas.openxmlformats.org/drawingml/2006/main">
               <a:ext uri="{FF2B5EF4-FFF2-40B4-BE49-F238E27FC236}">
-                <a16:creationId xmlns:a16="http://schemas.microsoft.com/office/drawing/2014/main" id="{50CED218-4580-4F74-B0FF-FDC70E1CF6DC}"/>
+                <a16:creationId xmlns:a16="http://schemas.microsoft.com/office/drawing/2014/main" id="{E29BEE41-EF7C-4481-8433-0670D0CEBB8B}"/>
               </a:ext>
             </a:extLst>
           </p:cNvPr>
@@ -8530,7 +8530,7 @@
           <p:cNvPr id="16" name="">
             <a:extLst xmlns:a="http://schemas.openxmlformats.org/drawingml/2006/main">
               <a:ext uri="{FF2B5EF4-FFF2-40B4-BE49-F238E27FC236}">
-                <a16:creationId xmlns:a16="http://schemas.microsoft.com/office/drawing/2014/main" id="{337310A4-B9BD-450E-B5B9-DDF48B45B301}"/>
+                <a16:creationId xmlns:a16="http://schemas.microsoft.com/office/drawing/2014/main" id="{E69B8012-25CC-4772-B57E-C70FD544D541}"/>
               </a:ext>
             </a:extLst>
           </p:cNvPr>
@@ -8598,7 +8598,7 @@
           <p:cNvPr id="17" name="">
             <a:extLst xmlns:a="http://schemas.openxmlformats.org/drawingml/2006/main">
               <a:ext uri="{FF2B5EF4-FFF2-40B4-BE49-F238E27FC236}">
-                <a16:creationId xmlns:a16="http://schemas.microsoft.com/office/drawing/2014/main" id="{686FA46A-9DD2-46F2-9003-06AAF46022D8}"/>
+                <a16:creationId xmlns:a16="http://schemas.microsoft.com/office/drawing/2014/main" id="{F820ABC7-41CD-45E1-8531-EFB76C19BF99}"/>
               </a:ext>
             </a:extLst>
           </p:cNvPr>
@@ -8666,7 +8666,7 @@
           <p:cNvPr id="18" name="">
             <a:extLst xmlns:a="http://schemas.openxmlformats.org/drawingml/2006/main">
               <a:ext uri="{FF2B5EF4-FFF2-40B4-BE49-F238E27FC236}">
-                <a16:creationId xmlns:a16="http://schemas.microsoft.com/office/drawing/2014/main" id="{B9C3BE30-375E-42D3-8EC1-F1B2AE7FE2BD}"/>
+                <a16:creationId xmlns:a16="http://schemas.microsoft.com/office/drawing/2014/main" id="{5256BB3D-9784-4A7C-92C5-8A2C1CF1D772}"/>
               </a:ext>
             </a:extLst>
           </p:cNvPr>
@@ -8732,7 +8732,7 @@
     </p:spTree>
     <p:extLst>
       <p:ext uri="{BB962C8B-B14F-4D97-AF65-F5344CB8AC3E}">
-        <p14:creationId xmlns:p14="http://schemas.microsoft.com/office/powerpoint/2010/main" val="1259535334"/>
+        <p14:creationId xmlns:p14="http://schemas.microsoft.com/office/powerpoint/2010/main" val="734259294"/>
       </p:ext>
     </p:extLst>
   </p:cSld>
@@ -8763,7 +8763,7 @@
           <p:cNvPr id="13" name="">
             <a:extLst xmlns:a="http://schemas.openxmlformats.org/drawingml/2006/main">
               <a:ext uri="{FF2B5EF4-FFF2-40B4-BE49-F238E27FC236}">
-                <a16:creationId xmlns:a16="http://schemas.microsoft.com/office/drawing/2014/main" id="{511D568E-165C-4556-ADB2-128CEC74B23E}"/>
+                <a16:creationId xmlns:a16="http://schemas.microsoft.com/office/drawing/2014/main" id="{30A1FB6B-AF57-476C-A658-4F4D1583AFFE}"/>
               </a:ext>
             </a:extLst>
           </p:cNvPr>
@@ -8773,7 +8773,7 @@
           <p:nvPr/>
         </p:nvPicPr>
         <p:blipFill>
-          <a:blip xmlns:r="http://schemas.openxmlformats.org/officeDocument/2006/relationships" xmlns:a="http://schemas.openxmlformats.org/drawingml/2006/main" r:embed="R68757374331d4947"/>
+          <a:blip xmlns:r="http://schemas.openxmlformats.org/officeDocument/2006/relationships" xmlns:a="http://schemas.openxmlformats.org/drawingml/2006/main" r:embed="R79faf7169d5c480c"/>
           <a:stretch xmlns:a="http://schemas.openxmlformats.org/drawingml/2006/main"/>
         </p:blipFill>
         <p:spPr>
@@ -8791,7 +8791,7 @@
           <p:cNvPr id="2" name="">
             <a:extLst xmlns:a="http://schemas.openxmlformats.org/drawingml/2006/main">
               <a:ext uri="{FF2B5EF4-FFF2-40B4-BE49-F238E27FC236}">
-                <a16:creationId xmlns:a16="http://schemas.microsoft.com/office/drawing/2014/main" id="{217213F1-0009-4C68-BC2C-47C5F80847A6}"/>
+                <a16:creationId xmlns:a16="http://schemas.microsoft.com/office/drawing/2014/main" id="{B094FF00-66C7-4B49-99F5-26F0C47C6AEE}"/>
               </a:ext>
             </a:extLst>
           </p:cNvPr>
@@ -8859,7 +8859,7 @@
           <p:cNvPr id="3" name="">
             <a:extLst xmlns:a="http://schemas.openxmlformats.org/drawingml/2006/main">
               <a:ext uri="{FF2B5EF4-FFF2-40B4-BE49-F238E27FC236}">
-                <a16:creationId xmlns:a16="http://schemas.microsoft.com/office/drawing/2014/main" id="{5F1D2EE2-447B-4065-9102-BBC11943DA43}"/>
+                <a16:creationId xmlns:a16="http://schemas.microsoft.com/office/drawing/2014/main" id="{A15F0D60-D646-4257-A86C-7ABDA54D71E4}"/>
               </a:ext>
             </a:extLst>
           </p:cNvPr>
@@ -8927,7 +8927,7 @@
           <p:cNvPr id="4" name="">
             <a:extLst xmlns:a="http://schemas.openxmlformats.org/drawingml/2006/main">
               <a:ext uri="{FF2B5EF4-FFF2-40B4-BE49-F238E27FC236}">
-                <a16:creationId xmlns:a16="http://schemas.microsoft.com/office/drawing/2014/main" id="{B0242C8E-FFD7-40E7-B74B-03E0B111BE15}"/>
+                <a16:creationId xmlns:a16="http://schemas.microsoft.com/office/drawing/2014/main" id="{42A97936-22E1-4D5D-AE11-A78062226DAC}"/>
               </a:ext>
             </a:extLst>
           </p:cNvPr>
@@ -8995,7 +8995,7 @@
           <p:cNvPr id="5" name="">
             <a:extLst xmlns:a="http://schemas.openxmlformats.org/drawingml/2006/main">
               <a:ext uri="{FF2B5EF4-FFF2-40B4-BE49-F238E27FC236}">
-                <a16:creationId xmlns:a16="http://schemas.microsoft.com/office/drawing/2014/main" id="{38CB1B27-770A-4F00-AF16-1FD21F484F56}"/>
+                <a16:creationId xmlns:a16="http://schemas.microsoft.com/office/drawing/2014/main" id="{79938F41-70D8-46BF-9ED4-CE3F88739A70}"/>
               </a:ext>
             </a:extLst>
           </p:cNvPr>
@@ -9063,7 +9063,7 @@
           <p:cNvPr id="6" name="">
             <a:extLst xmlns:a="http://schemas.openxmlformats.org/drawingml/2006/main">
               <a:ext uri="{FF2B5EF4-FFF2-40B4-BE49-F238E27FC236}">
-                <a16:creationId xmlns:a16="http://schemas.microsoft.com/office/drawing/2014/main" id="{FA67D3E9-627E-4489-8BEF-675617F8D3AB}"/>
+                <a16:creationId xmlns:a16="http://schemas.microsoft.com/office/drawing/2014/main" id="{5EB08DC3-0D6A-4E21-826C-8F439BD67001}"/>
               </a:ext>
             </a:extLst>
           </p:cNvPr>
@@ -9131,7 +9131,7 @@
           <p:cNvPr id="7" name="">
             <a:extLst xmlns:a="http://schemas.openxmlformats.org/drawingml/2006/main">
               <a:ext uri="{FF2B5EF4-FFF2-40B4-BE49-F238E27FC236}">
-                <a16:creationId xmlns:a16="http://schemas.microsoft.com/office/drawing/2014/main" id="{B8209ECF-60D7-4931-BF8C-365174C41DF5}"/>
+                <a16:creationId xmlns:a16="http://schemas.microsoft.com/office/drawing/2014/main" id="{900F6602-A5B4-42C1-99E5-AB01A4FD9D9A}"/>
               </a:ext>
             </a:extLst>
           </p:cNvPr>
@@ -9141,7 +9141,7 @@
           <p:nvPr/>
         </p:nvPicPr>
         <p:blipFill>
-          <a:blip xmlns:r="http://schemas.openxmlformats.org/officeDocument/2006/relationships" xmlns:a="http://schemas.openxmlformats.org/drawingml/2006/main" r:embed="R8bf489e30a724145"/>
+          <a:blip xmlns:r="http://schemas.openxmlformats.org/officeDocument/2006/relationships" xmlns:a="http://schemas.openxmlformats.org/drawingml/2006/main" r:embed="Ra7d2b6b6b1eb4ac4"/>
           <a:stretch xmlns:a="http://schemas.openxmlformats.org/drawingml/2006/main"/>
         </p:blipFill>
         <p:spPr>
@@ -9159,7 +9159,7 @@
           <p:cNvPr id="8" name="">
             <a:extLst xmlns:a="http://schemas.openxmlformats.org/drawingml/2006/main">
               <a:ext uri="{FF2B5EF4-FFF2-40B4-BE49-F238E27FC236}">
-                <a16:creationId xmlns:a16="http://schemas.microsoft.com/office/drawing/2014/main" id="{176C09CE-1059-4FBC-A4A8-89896568FE5D}"/>
+                <a16:creationId xmlns:a16="http://schemas.microsoft.com/office/drawing/2014/main" id="{1101C651-852F-48F3-AAEB-9939422C1E15}"/>
               </a:ext>
             </a:extLst>
           </p:cNvPr>
@@ -9227,7 +9227,7 @@
           <p:cNvPr id="9" name="">
             <a:extLst xmlns:a="http://schemas.openxmlformats.org/drawingml/2006/main">
               <a:ext uri="{FF2B5EF4-FFF2-40B4-BE49-F238E27FC236}">
-                <a16:creationId xmlns:a16="http://schemas.microsoft.com/office/drawing/2014/main" id="{176CA65F-77F8-435C-8FF8-EDC2AB7AE798}"/>
+                <a16:creationId xmlns:a16="http://schemas.microsoft.com/office/drawing/2014/main" id="{4504939D-E214-44D7-BCB2-0194E2C758ED}"/>
               </a:ext>
             </a:extLst>
           </p:cNvPr>
@@ -9318,7 +9318,7 @@
           <p:cNvPr id="10" name="">
             <a:extLst xmlns:a="http://schemas.openxmlformats.org/drawingml/2006/main">
               <a:ext uri="{FF2B5EF4-FFF2-40B4-BE49-F238E27FC236}">
-                <a16:creationId xmlns:a16="http://schemas.microsoft.com/office/drawing/2014/main" id="{1FFAD134-233A-4562-A900-D0D21707F4B3}"/>
+                <a16:creationId xmlns:a16="http://schemas.microsoft.com/office/drawing/2014/main" id="{3FD9DF71-FA55-48EC-B844-0444BD02A630}"/>
               </a:ext>
             </a:extLst>
           </p:cNvPr>
@@ -9386,7 +9386,7 @@
           <p:cNvPr id="11" name="">
             <a:extLst xmlns:a="http://schemas.openxmlformats.org/drawingml/2006/main">
               <a:ext uri="{FF2B5EF4-FFF2-40B4-BE49-F238E27FC236}">
-                <a16:creationId xmlns:a16="http://schemas.microsoft.com/office/drawing/2014/main" id="{5A8264CA-42E8-456C-AC24-3035B3D2D0EE}"/>
+                <a16:creationId xmlns:a16="http://schemas.microsoft.com/office/drawing/2014/main" id="{D996EA50-DFFC-4671-9020-82EACDD69BCD}"/>
               </a:ext>
             </a:extLst>
           </p:cNvPr>
@@ -9477,7 +9477,7 @@
           <p:cNvPr id="12" name="">
             <a:extLst xmlns:a="http://schemas.openxmlformats.org/drawingml/2006/main">
               <a:ext uri="{FF2B5EF4-FFF2-40B4-BE49-F238E27FC236}">
-                <a16:creationId xmlns:a16="http://schemas.microsoft.com/office/drawing/2014/main" id="{F0ECFB83-7E74-4686-92B0-AADBD4D66D9E}"/>
+                <a16:creationId xmlns:a16="http://schemas.microsoft.com/office/drawing/2014/main" id="{0A26B467-BBDB-47CE-B852-AEFF373433C1}"/>
               </a:ext>
             </a:extLst>
           </p:cNvPr>
@@ -9543,7 +9543,7 @@
     </p:spTree>
     <p:extLst>
       <p:ext uri="{BB962C8B-B14F-4D97-AF65-F5344CB8AC3E}">
-        <p14:creationId xmlns:p14="http://schemas.microsoft.com/office/powerpoint/2010/main" val="916738540"/>
+        <p14:creationId xmlns:p14="http://schemas.microsoft.com/office/powerpoint/2010/main" val="133301226"/>
       </p:ext>
     </p:extLst>
   </p:cSld>
@@ -9574,7 +9574,7 @@
           <p:cNvPr id="18" name="">
             <a:extLst xmlns:a="http://schemas.openxmlformats.org/drawingml/2006/main">
               <a:ext uri="{FF2B5EF4-FFF2-40B4-BE49-F238E27FC236}">
-                <a16:creationId xmlns:a16="http://schemas.microsoft.com/office/drawing/2014/main" id="{C817874D-BC75-4C2D-A65E-734BF7BAFAB2}"/>
+                <a16:creationId xmlns:a16="http://schemas.microsoft.com/office/drawing/2014/main" id="{E43B0131-FA7E-48DA-8E3F-9A13E1C24AB7}"/>
               </a:ext>
             </a:extLst>
           </p:cNvPr>
@@ -9584,7 +9584,7 @@
           <p:nvPr/>
         </p:nvPicPr>
         <p:blipFill>
-          <a:blip xmlns:r="http://schemas.openxmlformats.org/officeDocument/2006/relationships" xmlns:a="http://schemas.openxmlformats.org/drawingml/2006/main" r:embed="R7dcbe91e550e43ed"/>
+          <a:blip xmlns:r="http://schemas.openxmlformats.org/officeDocument/2006/relationships" xmlns:a="http://schemas.openxmlformats.org/drawingml/2006/main" r:embed="R0b6e3a6e5aca418d"/>
           <a:stretch xmlns:a="http://schemas.openxmlformats.org/drawingml/2006/main"/>
         </p:blipFill>
         <p:spPr>
@@ -9602,7 +9602,7 @@
           <p:cNvPr id="2" name="">
             <a:extLst xmlns:a="http://schemas.openxmlformats.org/drawingml/2006/main">
               <a:ext uri="{FF2B5EF4-FFF2-40B4-BE49-F238E27FC236}">
-                <a16:creationId xmlns:a16="http://schemas.microsoft.com/office/drawing/2014/main" id="{E9B963BC-3882-43C2-8C36-7B81164740AD}"/>
+                <a16:creationId xmlns:a16="http://schemas.microsoft.com/office/drawing/2014/main" id="{E23FC8B4-2004-449B-9431-22CFA6E32A81}"/>
               </a:ext>
             </a:extLst>
           </p:cNvPr>
@@ -9670,7 +9670,7 @@
           <p:cNvPr id="3" name="">
             <a:extLst xmlns:a="http://schemas.openxmlformats.org/drawingml/2006/main">
               <a:ext uri="{FF2B5EF4-FFF2-40B4-BE49-F238E27FC236}">
-                <a16:creationId xmlns:a16="http://schemas.microsoft.com/office/drawing/2014/main" id="{36DC32ED-F643-499E-9655-CB706C08C692}"/>
+                <a16:creationId xmlns:a16="http://schemas.microsoft.com/office/drawing/2014/main" id="{0F05A1E5-CC7E-4876-A660-7A82F7E96F94}"/>
               </a:ext>
             </a:extLst>
           </p:cNvPr>
@@ -9738,7 +9738,7 @@
           <p:cNvPr id="4" name="">
             <a:extLst xmlns:a="http://schemas.openxmlformats.org/drawingml/2006/main">
               <a:ext uri="{FF2B5EF4-FFF2-40B4-BE49-F238E27FC236}">
-                <a16:creationId xmlns:a16="http://schemas.microsoft.com/office/drawing/2014/main" id="{43D1E37B-7A60-43BE-97E8-DC1998592C0A}"/>
+                <a16:creationId xmlns:a16="http://schemas.microsoft.com/office/drawing/2014/main" id="{F73299EE-4011-4731-8155-A55C7C5C0404}"/>
               </a:ext>
             </a:extLst>
           </p:cNvPr>
@@ -9806,7 +9806,7 @@
           <p:cNvPr id="5" name="">
             <a:extLst xmlns:a="http://schemas.openxmlformats.org/drawingml/2006/main">
               <a:ext uri="{FF2B5EF4-FFF2-40B4-BE49-F238E27FC236}">
-                <a16:creationId xmlns:a16="http://schemas.microsoft.com/office/drawing/2014/main" id="{F04FBD89-0D48-4BE7-B69F-6A2BA2D3A416}"/>
+                <a16:creationId xmlns:a16="http://schemas.microsoft.com/office/drawing/2014/main" id="{1CB8C294-4DB6-4E1F-989A-D6B657190D91}"/>
               </a:ext>
             </a:extLst>
           </p:cNvPr>
@@ -9874,7 +9874,7 @@
           <p:cNvPr id="6" name="">
             <a:extLst xmlns:a="http://schemas.openxmlformats.org/drawingml/2006/main">
               <a:ext uri="{FF2B5EF4-FFF2-40B4-BE49-F238E27FC236}">
-                <a16:creationId xmlns:a16="http://schemas.microsoft.com/office/drawing/2014/main" id="{4DCCD6A0-23B2-4801-AA0F-2098FF563E27}"/>
+                <a16:creationId xmlns:a16="http://schemas.microsoft.com/office/drawing/2014/main" id="{79E699A6-158D-4F9E-B512-ED03A55588F8}"/>
               </a:ext>
             </a:extLst>
           </p:cNvPr>
@@ -9942,7 +9942,7 @@
           <p:cNvPr id="7" name="">
             <a:extLst xmlns:a="http://schemas.openxmlformats.org/drawingml/2006/main">
               <a:ext uri="{FF2B5EF4-FFF2-40B4-BE49-F238E27FC236}">
-                <a16:creationId xmlns:a16="http://schemas.microsoft.com/office/drawing/2014/main" id="{73E81D22-76B3-410F-A11C-ED4395D1DBD3}"/>
+                <a16:creationId xmlns:a16="http://schemas.microsoft.com/office/drawing/2014/main" id="{AAC15428-BAA9-48B8-AE55-EE6329CD1D30}"/>
               </a:ext>
             </a:extLst>
           </p:cNvPr>
@@ -10010,7 +10010,7 @@
           <p:cNvPr id="8" name="">
             <a:extLst xmlns:a="http://schemas.openxmlformats.org/drawingml/2006/main">
               <a:ext uri="{FF2B5EF4-FFF2-40B4-BE49-F238E27FC236}">
-                <a16:creationId xmlns:a16="http://schemas.microsoft.com/office/drawing/2014/main" id="{7F3589FF-AF26-4E8C-AEA0-4D16D82FDBD7}"/>
+                <a16:creationId xmlns:a16="http://schemas.microsoft.com/office/drawing/2014/main" id="{3047964D-9C24-424C-9FCB-23CAE4FCA914}"/>
               </a:ext>
             </a:extLst>
           </p:cNvPr>
@@ -10040,7 +10040,7 @@
           <p:cNvPr id="9" name="">
             <a:extLst xmlns:a="http://schemas.openxmlformats.org/drawingml/2006/main">
               <a:ext uri="{FF2B5EF4-FFF2-40B4-BE49-F238E27FC236}">
-                <a16:creationId xmlns:a16="http://schemas.microsoft.com/office/drawing/2014/main" id="{5B8677C7-6E64-49F1-B1EE-280202BFA9BD}"/>
+                <a16:creationId xmlns:a16="http://schemas.microsoft.com/office/drawing/2014/main" id="{1CCB6922-75C9-4D9F-B334-DA15CBCC154A}"/>
               </a:ext>
             </a:extLst>
           </p:cNvPr>
@@ -10154,7 +10154,7 @@
           <p:cNvPr id="10" name="">
             <a:extLst xmlns:a="http://schemas.openxmlformats.org/drawingml/2006/main">
               <a:ext uri="{FF2B5EF4-FFF2-40B4-BE49-F238E27FC236}">
-                <a16:creationId xmlns:a16="http://schemas.microsoft.com/office/drawing/2014/main" id="{552270A1-DA70-4C37-A2D6-1B0D30DE2266}"/>
+                <a16:creationId xmlns:a16="http://schemas.microsoft.com/office/drawing/2014/main" id="{8C0E1DAE-4E60-435C-A2A3-99F16FD75567}"/>
               </a:ext>
             </a:extLst>
           </p:cNvPr>
@@ -10222,7 +10222,7 @@
           <p:cNvPr id="11" name="">
             <a:extLst xmlns:a="http://schemas.openxmlformats.org/drawingml/2006/main">
               <a:ext uri="{FF2B5EF4-FFF2-40B4-BE49-F238E27FC236}">
-                <a16:creationId xmlns:a16="http://schemas.microsoft.com/office/drawing/2014/main" id="{9D83C964-8305-4A92-A9D6-0A3EF873CE41}"/>
+                <a16:creationId xmlns:a16="http://schemas.microsoft.com/office/drawing/2014/main" id="{F961BAE9-AECA-4F85-AE79-D8062261B5C2}"/>
               </a:ext>
             </a:extLst>
           </p:cNvPr>
@@ -10252,7 +10252,7 @@
           <p:cNvPr id="12" name="">
             <a:extLst xmlns:a="http://schemas.openxmlformats.org/drawingml/2006/main">
               <a:ext uri="{FF2B5EF4-FFF2-40B4-BE49-F238E27FC236}">
-                <a16:creationId xmlns:a16="http://schemas.microsoft.com/office/drawing/2014/main" id="{0FF8AA24-1052-4911-AB45-0A0D6386D21B}"/>
+                <a16:creationId xmlns:a16="http://schemas.microsoft.com/office/drawing/2014/main" id="{C2885B28-9ABA-4C5F-B93B-A2CAB14790CA}"/>
               </a:ext>
             </a:extLst>
           </p:cNvPr>
@@ -10366,7 +10366,7 @@
           <p:cNvPr id="13" name="">
             <a:extLst xmlns:a="http://schemas.openxmlformats.org/drawingml/2006/main">
               <a:ext uri="{FF2B5EF4-FFF2-40B4-BE49-F238E27FC236}">
-                <a16:creationId xmlns:a16="http://schemas.microsoft.com/office/drawing/2014/main" id="{63A4B47F-ACF3-48B7-BB1F-7581623FB3F5}"/>
+                <a16:creationId xmlns:a16="http://schemas.microsoft.com/office/drawing/2014/main" id="{949D0560-0C63-43F9-A7CC-64BBAF131BD2}"/>
               </a:ext>
             </a:extLst>
           </p:cNvPr>
@@ -10434,7 +10434,7 @@
           <p:cNvPr id="14" name="">
             <a:extLst xmlns:a="http://schemas.openxmlformats.org/drawingml/2006/main">
               <a:ext uri="{FF2B5EF4-FFF2-40B4-BE49-F238E27FC236}">
-                <a16:creationId xmlns:a16="http://schemas.microsoft.com/office/drawing/2014/main" id="{8518E957-93CA-4A00-9E9F-23B08FABC109}"/>
+                <a16:creationId xmlns:a16="http://schemas.microsoft.com/office/drawing/2014/main" id="{12B8D1DB-BFAA-41D6-931D-88524C43A846}"/>
               </a:ext>
             </a:extLst>
           </p:cNvPr>
@@ -10464,7 +10464,7 @@
           <p:cNvPr id="15" name="">
             <a:extLst xmlns:a="http://schemas.openxmlformats.org/drawingml/2006/main">
               <a:ext uri="{FF2B5EF4-FFF2-40B4-BE49-F238E27FC236}">
-                <a16:creationId xmlns:a16="http://schemas.microsoft.com/office/drawing/2014/main" id="{1596EC72-8E2D-4D82-A572-A58FEBB5BC88}"/>
+                <a16:creationId xmlns:a16="http://schemas.microsoft.com/office/drawing/2014/main" id="{99120E9B-34C0-4FCD-A0AB-E8DA50D06E47}"/>
               </a:ext>
             </a:extLst>
           </p:cNvPr>
@@ -10578,7 +10578,7 @@
           <p:cNvPr id="16" name="">
             <a:extLst xmlns:a="http://schemas.openxmlformats.org/drawingml/2006/main">
               <a:ext uri="{FF2B5EF4-FFF2-40B4-BE49-F238E27FC236}">
-                <a16:creationId xmlns:a16="http://schemas.microsoft.com/office/drawing/2014/main" id="{BC436033-DE88-4916-A04D-A397D1F38599}"/>
+                <a16:creationId xmlns:a16="http://schemas.microsoft.com/office/drawing/2014/main" id="{B9A0BD4E-CFA5-4710-8BA8-EC408017CBA1}"/>
               </a:ext>
             </a:extLst>
           </p:cNvPr>
@@ -10646,7 +10646,7 @@
           <p:cNvPr id="17" name="">
             <a:extLst xmlns:a="http://schemas.openxmlformats.org/drawingml/2006/main">
               <a:ext uri="{FF2B5EF4-FFF2-40B4-BE49-F238E27FC236}">
-                <a16:creationId xmlns:a16="http://schemas.microsoft.com/office/drawing/2014/main" id="{ADF1629E-2D54-4166-871A-F3552EC8C018}"/>
+                <a16:creationId xmlns:a16="http://schemas.microsoft.com/office/drawing/2014/main" id="{820FD8C6-35C9-4BAB-A619-FD140D72D575}"/>
               </a:ext>
             </a:extLst>
           </p:cNvPr>
@@ -10712,7 +10712,7 @@
     </p:spTree>
     <p:extLst>
       <p:ext uri="{BB962C8B-B14F-4D97-AF65-F5344CB8AC3E}">
-        <p14:creationId xmlns:p14="http://schemas.microsoft.com/office/powerpoint/2010/main" val="1126213756"/>
+        <p14:creationId xmlns:p14="http://schemas.microsoft.com/office/powerpoint/2010/main" val="475000416"/>
       </p:ext>
     </p:extLst>
   </p:cSld>
@@ -10743,7 +10743,7 @@
           <p:cNvPr id="17" name="">
             <a:extLst xmlns:a="http://schemas.openxmlformats.org/drawingml/2006/main">
               <a:ext uri="{FF2B5EF4-FFF2-40B4-BE49-F238E27FC236}">
-                <a16:creationId xmlns:a16="http://schemas.microsoft.com/office/drawing/2014/main" id="{BD6A0689-2F5B-491C-8350-A7FD94BF853E}"/>
+                <a16:creationId xmlns:a16="http://schemas.microsoft.com/office/drawing/2014/main" id="{578E9196-94F0-451B-93EF-69EE8F5689FD}"/>
               </a:ext>
             </a:extLst>
           </p:cNvPr>
@@ -10753,7 +10753,7 @@
           <p:nvPr/>
         </p:nvPicPr>
         <p:blipFill>
-          <a:blip xmlns:r="http://schemas.openxmlformats.org/officeDocument/2006/relationships" xmlns:a="http://schemas.openxmlformats.org/drawingml/2006/main" r:embed="R16a4dda0bce84861"/>
+          <a:blip xmlns:r="http://schemas.openxmlformats.org/officeDocument/2006/relationships" xmlns:a="http://schemas.openxmlformats.org/drawingml/2006/main" r:embed="R24c216d00ce54a2a"/>
           <a:stretch xmlns:a="http://schemas.openxmlformats.org/drawingml/2006/main"/>
         </p:blipFill>
         <p:spPr>
@@ -10771,7 +10771,7 @@
           <p:cNvPr id="2" name="">
             <a:extLst xmlns:a="http://schemas.openxmlformats.org/drawingml/2006/main">
               <a:ext uri="{FF2B5EF4-FFF2-40B4-BE49-F238E27FC236}">
-                <a16:creationId xmlns:a16="http://schemas.microsoft.com/office/drawing/2014/main" id="{5FB1CE8E-1DA8-421F-8599-65A4F9BFCC09}"/>
+                <a16:creationId xmlns:a16="http://schemas.microsoft.com/office/drawing/2014/main" id="{E7E5BCA6-32AE-4C6F-8CB1-A9D8D0AB8FE5}"/>
               </a:ext>
             </a:extLst>
           </p:cNvPr>
@@ -10839,7 +10839,7 @@
           <p:cNvPr id="3" name="">
             <a:extLst xmlns:a="http://schemas.openxmlformats.org/drawingml/2006/main">
               <a:ext uri="{FF2B5EF4-FFF2-40B4-BE49-F238E27FC236}">
-                <a16:creationId xmlns:a16="http://schemas.microsoft.com/office/drawing/2014/main" id="{5E1812A5-C747-4592-A039-DFB8E7C246CA}"/>
+                <a16:creationId xmlns:a16="http://schemas.microsoft.com/office/drawing/2014/main" id="{27A2E4D2-C9EF-4A03-9325-2598039EEA0B}"/>
               </a:ext>
             </a:extLst>
           </p:cNvPr>
@@ -10907,7 +10907,7 @@
           <p:cNvPr id="4" name="">
             <a:extLst xmlns:a="http://schemas.openxmlformats.org/drawingml/2006/main">
               <a:ext uri="{FF2B5EF4-FFF2-40B4-BE49-F238E27FC236}">
-                <a16:creationId xmlns:a16="http://schemas.microsoft.com/office/drawing/2014/main" id="{CCB99200-6DBA-4D1C-9AD5-F4C9BD9A13C6}"/>
+                <a16:creationId xmlns:a16="http://schemas.microsoft.com/office/drawing/2014/main" id="{D0F0C91C-1ABA-4F46-94E1-963BE7A52462}"/>
               </a:ext>
             </a:extLst>
           </p:cNvPr>
@@ -10975,7 +10975,7 @@
           <p:cNvPr id="5" name="">
             <a:extLst xmlns:a="http://schemas.openxmlformats.org/drawingml/2006/main">
               <a:ext uri="{FF2B5EF4-FFF2-40B4-BE49-F238E27FC236}">
-                <a16:creationId xmlns:a16="http://schemas.microsoft.com/office/drawing/2014/main" id="{411D5118-1175-485D-9266-EE8D352F33F3}"/>
+                <a16:creationId xmlns:a16="http://schemas.microsoft.com/office/drawing/2014/main" id="{C4D1136D-432F-4DAD-8081-C3670B34AC5F}"/>
               </a:ext>
             </a:extLst>
           </p:cNvPr>
@@ -11043,7 +11043,7 @@
           <p:cNvPr id="6" name="">
             <a:extLst xmlns:a="http://schemas.openxmlformats.org/drawingml/2006/main">
               <a:ext uri="{FF2B5EF4-FFF2-40B4-BE49-F238E27FC236}">
-                <a16:creationId xmlns:a16="http://schemas.microsoft.com/office/drawing/2014/main" id="{E8F0A12C-AFEB-4F0A-BEA5-1C970643A605}"/>
+                <a16:creationId xmlns:a16="http://schemas.microsoft.com/office/drawing/2014/main" id="{9DE65E15-F6B0-4FDB-A11A-5A2402375E29}"/>
               </a:ext>
             </a:extLst>
           </p:cNvPr>
@@ -11111,7 +11111,7 @@
           <p:cNvPr id="7" name="">
             <a:extLst xmlns:a="http://schemas.openxmlformats.org/drawingml/2006/main">
               <a:ext uri="{FF2B5EF4-FFF2-40B4-BE49-F238E27FC236}">
-                <a16:creationId xmlns:a16="http://schemas.microsoft.com/office/drawing/2014/main" id="{3EECC451-AAA8-4B1F-9239-7582C3F4FBD2}"/>
+                <a16:creationId xmlns:a16="http://schemas.microsoft.com/office/drawing/2014/main" id="{9EDB76DA-72E0-4C4D-90B8-70A6D971814A}"/>
               </a:ext>
             </a:extLst>
           </p:cNvPr>
@@ -11121,7 +11121,7 @@
           <p:nvPr/>
         </p:nvPicPr>
         <p:blipFill>
-          <a:blip xmlns:r="http://schemas.openxmlformats.org/officeDocument/2006/relationships" xmlns:a="http://schemas.openxmlformats.org/drawingml/2006/main" r:embed="R4ff8a55ee8914dbc"/>
+          <a:blip xmlns:r="http://schemas.openxmlformats.org/officeDocument/2006/relationships" xmlns:a="http://schemas.openxmlformats.org/drawingml/2006/main" r:embed="Rbe77fbbef33d441d"/>
           <a:stretch xmlns:a="http://schemas.openxmlformats.org/drawingml/2006/main"/>
         </p:blipFill>
         <p:spPr>
@@ -11139,7 +11139,7 @@
           <p:cNvPr id="8" name="">
             <a:extLst xmlns:a="http://schemas.openxmlformats.org/drawingml/2006/main">
               <a:ext uri="{FF2B5EF4-FFF2-40B4-BE49-F238E27FC236}">
-                <a16:creationId xmlns:a16="http://schemas.microsoft.com/office/drawing/2014/main" id="{807D23C6-76A2-4ADA-8619-952C13511625}"/>
+                <a16:creationId xmlns:a16="http://schemas.microsoft.com/office/drawing/2014/main" id="{5A0E89E7-44A2-4D08-9D4F-534C1870BFD3}"/>
               </a:ext>
             </a:extLst>
           </p:cNvPr>
@@ -11207,7 +11207,7 @@
           <p:cNvPr id="9" name="">
             <a:extLst xmlns:a="http://schemas.openxmlformats.org/drawingml/2006/main">
               <a:ext uri="{FF2B5EF4-FFF2-40B4-BE49-F238E27FC236}">
-                <a16:creationId xmlns:a16="http://schemas.microsoft.com/office/drawing/2014/main" id="{690F036A-29F2-4314-8607-2B1ADB65C3A4}"/>
+                <a16:creationId xmlns:a16="http://schemas.microsoft.com/office/drawing/2014/main" id="{C23A3737-F9DB-47FE-9D68-F852D5708BD5}"/>
               </a:ext>
             </a:extLst>
           </p:cNvPr>
@@ -11298,7 +11298,7 @@
           <p:cNvPr id="10" name="">
             <a:extLst xmlns:a="http://schemas.openxmlformats.org/drawingml/2006/main">
               <a:ext uri="{FF2B5EF4-FFF2-40B4-BE49-F238E27FC236}">
-                <a16:creationId xmlns:a16="http://schemas.microsoft.com/office/drawing/2014/main" id="{A5A68864-F2CB-4096-93F6-112B88BE3FDE}"/>
+                <a16:creationId xmlns:a16="http://schemas.microsoft.com/office/drawing/2014/main" id="{09284687-410D-4B6F-9AFC-87A0AAC067FA}"/>
               </a:ext>
             </a:extLst>
           </p:cNvPr>
@@ -11366,7 +11366,7 @@
           <p:cNvPr id="11" name="">
             <a:extLst xmlns:a="http://schemas.openxmlformats.org/drawingml/2006/main">
               <a:ext uri="{FF2B5EF4-FFF2-40B4-BE49-F238E27FC236}">
-                <a16:creationId xmlns:a16="http://schemas.microsoft.com/office/drawing/2014/main" id="{8C2826BD-1E77-4F24-A79C-5158FF811751}"/>
+                <a16:creationId xmlns:a16="http://schemas.microsoft.com/office/drawing/2014/main" id="{D4CE3178-4DC2-4D70-84F8-F61B2043E7D4}"/>
               </a:ext>
             </a:extLst>
           </p:cNvPr>
@@ -11434,7 +11434,7 @@
           <p:cNvPr id="12" name="">
             <a:extLst xmlns:a="http://schemas.openxmlformats.org/drawingml/2006/main">
               <a:ext uri="{FF2B5EF4-FFF2-40B4-BE49-F238E27FC236}">
-                <a16:creationId xmlns:a16="http://schemas.microsoft.com/office/drawing/2014/main" id="{C5C7BF19-86A1-4659-A13E-EA3866B06D75}"/>
+                <a16:creationId xmlns:a16="http://schemas.microsoft.com/office/drawing/2014/main" id="{7D5EC4F8-C2C3-4685-9C1D-B44FFAC4F443}"/>
               </a:ext>
             </a:extLst>
           </p:cNvPr>
@@ -11502,7 +11502,7 @@
           <p:cNvPr id="13" name="">
             <a:extLst xmlns:a="http://schemas.openxmlformats.org/drawingml/2006/main">
               <a:ext uri="{FF2B5EF4-FFF2-40B4-BE49-F238E27FC236}">
-                <a16:creationId xmlns:a16="http://schemas.microsoft.com/office/drawing/2014/main" id="{FEA861BB-E3B6-42B8-8926-9D515E37E6DD}"/>
+                <a16:creationId xmlns:a16="http://schemas.microsoft.com/office/drawing/2014/main" id="{CBCD37F4-35B5-4B64-B1D7-D85B82D4A26F}"/>
               </a:ext>
             </a:extLst>
           </p:cNvPr>
@@ -11570,7 +11570,7 @@
           <p:cNvPr id="14" name="">
             <a:extLst xmlns:a="http://schemas.openxmlformats.org/drawingml/2006/main">
               <a:ext uri="{FF2B5EF4-FFF2-40B4-BE49-F238E27FC236}">
-                <a16:creationId xmlns:a16="http://schemas.microsoft.com/office/drawing/2014/main" id="{CEC47C64-E41D-4ADB-9722-F5176D812A73}"/>
+                <a16:creationId xmlns:a16="http://schemas.microsoft.com/office/drawing/2014/main" id="{B608F23F-9371-4833-A0CB-68DA0BF93E94}"/>
               </a:ext>
             </a:extLst>
           </p:cNvPr>
@@ -11638,7 +11638,7 @@
           <p:cNvPr id="15" name="">
             <a:extLst xmlns:a="http://schemas.openxmlformats.org/drawingml/2006/main">
               <a:ext uri="{FF2B5EF4-FFF2-40B4-BE49-F238E27FC236}">
-                <a16:creationId xmlns:a16="http://schemas.microsoft.com/office/drawing/2014/main" id="{7E6BECC0-8BFC-4772-93A5-FA9A59B8826D}"/>
+                <a16:creationId xmlns:a16="http://schemas.microsoft.com/office/drawing/2014/main" id="{EC0CE4E4-4FE4-43E5-8E39-1A224F953110}"/>
               </a:ext>
             </a:extLst>
           </p:cNvPr>
@@ -11706,7 +11706,7 @@
           <p:cNvPr id="16" name="">
             <a:extLst xmlns:a="http://schemas.openxmlformats.org/drawingml/2006/main">
               <a:ext uri="{FF2B5EF4-FFF2-40B4-BE49-F238E27FC236}">
-                <a16:creationId xmlns:a16="http://schemas.microsoft.com/office/drawing/2014/main" id="{3DD81AA5-0E9B-4120-8ECA-ACE8442151A5}"/>
+                <a16:creationId xmlns:a16="http://schemas.microsoft.com/office/drawing/2014/main" id="{1FD04717-FDA6-4DAB-A2BD-C7A808C85217}"/>
               </a:ext>
             </a:extLst>
           </p:cNvPr>
@@ -11772,7 +11772,7 @@
     </p:spTree>
     <p:extLst>
       <p:ext uri="{BB962C8B-B14F-4D97-AF65-F5344CB8AC3E}">
-        <p14:creationId xmlns:p14="http://schemas.microsoft.com/office/powerpoint/2010/main" val="332890572"/>
+        <p14:creationId xmlns:p14="http://schemas.microsoft.com/office/powerpoint/2010/main" val="528331529"/>
       </p:ext>
     </p:extLst>
   </p:cSld>
@@ -11800,10 +11800,10 @@
       </p:grpSpPr>
       <p:pic>
         <p:nvPicPr>
-          <p:cNvPr id="11" name="">
-            <a:extLst xmlns:a="http://schemas.openxmlformats.org/drawingml/2006/main">
-              <a:ext uri="{FF2B5EF4-FFF2-40B4-BE49-F238E27FC236}">
-                <a16:creationId xmlns:a16="http://schemas.microsoft.com/office/drawing/2014/main" id="{41D5BBEA-C373-469C-886A-928ED12FB99E}"/>
+          <p:cNvPr id="9" name="">
+            <a:extLst xmlns:a="http://schemas.openxmlformats.org/drawingml/2006/main">
+              <a:ext uri="{FF2B5EF4-FFF2-40B4-BE49-F238E27FC236}">
+                <a16:creationId xmlns:a16="http://schemas.microsoft.com/office/drawing/2014/main" id="{7883C52B-982D-4631-9AC0-EE2DD5E9E472}"/>
               </a:ext>
             </a:extLst>
           </p:cNvPr>
@@ -11813,7 +11813,7 @@
           <p:nvPr/>
         </p:nvPicPr>
         <p:blipFill>
-          <a:blip xmlns:r="http://schemas.openxmlformats.org/officeDocument/2006/relationships" xmlns:a="http://schemas.openxmlformats.org/drawingml/2006/main" r:embed="R68feb2a405544677"/>
+          <a:blip xmlns:r="http://schemas.openxmlformats.org/officeDocument/2006/relationships" xmlns:a="http://schemas.openxmlformats.org/drawingml/2006/main" r:embed="Radafa393d8f94931"/>
           <a:stretch xmlns:a="http://schemas.openxmlformats.org/drawingml/2006/main"/>
         </p:blipFill>
         <p:spPr>
@@ -11831,7 +11831,7 @@
           <p:cNvPr id="2" name="">
             <a:extLst xmlns:a="http://schemas.openxmlformats.org/drawingml/2006/main">
               <a:ext uri="{FF2B5EF4-FFF2-40B4-BE49-F238E27FC236}">
-                <a16:creationId xmlns:a16="http://schemas.microsoft.com/office/drawing/2014/main" id="{6E1A5EC2-5E04-42AA-B136-18AAB4DDC7DA}"/>
+                <a16:creationId xmlns:a16="http://schemas.microsoft.com/office/drawing/2014/main" id="{70D7CE1E-8C4C-4B0F-9DCA-D866A6CA25F6}"/>
               </a:ext>
             </a:extLst>
           </p:cNvPr>
@@ -11899,7 +11899,7 @@
           <p:cNvPr id="3" name="">
             <a:extLst xmlns:a="http://schemas.openxmlformats.org/drawingml/2006/main">
               <a:ext uri="{FF2B5EF4-FFF2-40B4-BE49-F238E27FC236}">
-                <a16:creationId xmlns:a16="http://schemas.microsoft.com/office/drawing/2014/main" id="{EFF86988-FECB-462C-A9AF-A25370098CF7}"/>
+                <a16:creationId xmlns:a16="http://schemas.microsoft.com/office/drawing/2014/main" id="{6628B2ED-44C0-4CF9-A89E-A7BBD8B1AE55}"/>
               </a:ext>
             </a:extLst>
           </p:cNvPr>
@@ -11967,7 +11967,7 @@
           <p:cNvPr id="4" name="">
             <a:extLst xmlns:a="http://schemas.openxmlformats.org/drawingml/2006/main">
               <a:ext uri="{FF2B5EF4-FFF2-40B4-BE49-F238E27FC236}">
-                <a16:creationId xmlns:a16="http://schemas.microsoft.com/office/drawing/2014/main" id="{A50D5C9B-55C4-415A-B3D0-BF2CC6AA1990}"/>
+                <a16:creationId xmlns:a16="http://schemas.microsoft.com/office/drawing/2014/main" id="{140720BC-9A45-49DC-8D7D-F98ACC84A38F}"/>
               </a:ext>
             </a:extLst>
           </p:cNvPr>
@@ -12035,7 +12035,7 @@
           <p:cNvPr id="5" name="">
             <a:extLst xmlns:a="http://schemas.openxmlformats.org/drawingml/2006/main">
               <a:ext uri="{FF2B5EF4-FFF2-40B4-BE49-F238E27FC236}">
-                <a16:creationId xmlns:a16="http://schemas.microsoft.com/office/drawing/2014/main" id="{9D372F88-FB82-4F23-85E5-D6705AE0E422}"/>
+                <a16:creationId xmlns:a16="http://schemas.microsoft.com/office/drawing/2014/main" id="{53F8E6D9-F77D-4680-92AE-53BD818DE2A4}"/>
               </a:ext>
             </a:extLst>
           </p:cNvPr>
@@ -12103,7 +12103,7 @@
           <p:cNvPr id="6" name="">
             <a:extLst xmlns:a="http://schemas.openxmlformats.org/drawingml/2006/main">
               <a:ext uri="{FF2B5EF4-FFF2-40B4-BE49-F238E27FC236}">
-                <a16:creationId xmlns:a16="http://schemas.microsoft.com/office/drawing/2014/main" id="{B5006410-BC26-4C81-B1A7-7B9E9B19AF00}"/>
+                <a16:creationId xmlns:a16="http://schemas.microsoft.com/office/drawing/2014/main" id="{CD934B1F-7F68-4F4C-82DF-4FDFB22156F8}"/>
               </a:ext>
             </a:extLst>
           </p:cNvPr>
@@ -12171,7 +12171,7 @@
           <p:cNvPr id="7" name="">
             <a:extLst xmlns:a="http://schemas.openxmlformats.org/drawingml/2006/main">
               <a:ext uri="{FF2B5EF4-FFF2-40B4-BE49-F238E27FC236}">
-                <a16:creationId xmlns:a16="http://schemas.microsoft.com/office/drawing/2014/main" id="{A96CBD1B-1D14-4D38-8211-CCD8A9D66C56}"/>
+                <a16:creationId xmlns:a16="http://schemas.microsoft.com/office/drawing/2014/main" id="{B7D30AC1-74AC-4E1B-B568-D4178502CF5D}"/>
               </a:ext>
             </a:extLst>
           </p:cNvPr>
@@ -12239,7 +12239,7 @@
           <p:cNvPr id="8" name="">
             <a:extLst xmlns:a="http://schemas.openxmlformats.org/drawingml/2006/main">
               <a:ext uri="{FF2B5EF4-FFF2-40B4-BE49-F238E27FC236}">
-                <a16:creationId xmlns:a16="http://schemas.microsoft.com/office/drawing/2014/main" id="{CCAC3AAC-6A0A-43F1-ABF3-AD06E42DDF4B}"/>
+                <a16:creationId xmlns:a16="http://schemas.microsoft.com/office/drawing/2014/main" id="{53EE8414-813B-44C1-98CA-380E644706F3}"/>
               </a:ext>
             </a:extLst>
           </p:cNvPr>
@@ -12977,108 +12977,10 @@
           </a:graphicData>
         </a:graphic>
       </p:graphicFrame>
-      <p:sp>
-        <p:nvSpPr>
-          <p:cNvPr id="9" name="">
-            <a:extLst xmlns:a="http://schemas.openxmlformats.org/drawingml/2006/main">
-              <a:ext uri="{FF2B5EF4-FFF2-40B4-BE49-F238E27FC236}">
-                <a16:creationId xmlns:a16="http://schemas.microsoft.com/office/drawing/2014/main" id="{D2572603-C1EF-4AC4-86E4-9D3C84C1D337}"/>
-              </a:ext>
-            </a:extLst>
-          </p:cNvPr>
-          <p:cNvSpPr>
-            <a:spLocks xmlns:a="http://schemas.openxmlformats.org/drawingml/2006/main" noGrp="1"/>
-          </p:cNvSpPr>
-          <p:nvPr/>
-        </p:nvSpPr>
-        <p:spPr>
-          <a:xfrm xmlns:a="http://schemas.openxmlformats.org/drawingml/2006/main">
-            <a:off x="504825" y="4886325"/>
-            <a:ext cx="9686925" cy="495300"/>
-          </a:xfrm>
-          <a:prstGeom xmlns:a="http://schemas.openxmlformats.org/drawingml/2006/main" prst="rect">
-            <a:avLst/>
-          </a:prstGeom>
-          <a:solidFill xmlns:a="http://schemas.openxmlformats.org/drawingml/2006/main">
-            <a:srgbClr val="FFCC00"/>
-          </a:solidFill>
-          <a:ln xmlns:a="http://schemas.openxmlformats.org/drawingml/2006/main" w="0">
-            <a:noFill/>
-          </a:ln>
-        </p:spPr>
-      </p:sp>
-      <p:sp>
-        <p:nvSpPr>
-          <p:cNvPr id="10" name="">
-            <a:extLst xmlns:a="http://schemas.openxmlformats.org/drawingml/2006/main">
-              <a:ext uri="{FF2B5EF4-FFF2-40B4-BE49-F238E27FC236}">
-                <a16:creationId xmlns:a16="http://schemas.microsoft.com/office/drawing/2014/main" id="{E3061EAB-6831-4207-9E6F-5FC338AA6834}"/>
-              </a:ext>
-            </a:extLst>
-          </p:cNvPr>
-          <p:cNvSpPr>
-            <a:spLocks xmlns:a="http://schemas.openxmlformats.org/drawingml/2006/main" noGrp="1"/>
-          </p:cNvSpPr>
-          <p:nvPr/>
-        </p:nvSpPr>
-        <p:spPr>
-          <a:xfrm xmlns:a="http://schemas.openxmlformats.org/drawingml/2006/main">
-            <a:off x="666750" y="5029200"/>
-            <a:ext cx="9353550" cy="276225"/>
-          </a:xfrm>
-          <a:prstGeom xmlns:a="http://schemas.openxmlformats.org/drawingml/2006/main" prst="rect">
-            <a:avLst/>
-          </a:prstGeom>
-          <a:noFill xmlns:a="http://schemas.openxmlformats.org/drawingml/2006/main"/>
-          <a:ln xmlns:a="http://schemas.openxmlformats.org/drawingml/2006/main" w="0">
-            <a:noFill/>
-          </a:ln>
-        </p:spPr>
-        <p:txBody>
-          <a:bodyPr xmlns:a="http://schemas.openxmlformats.org/drawingml/2006/main" lIns="0" tIns="0" rIns="0" bIns="0" anchor="t">
-            <a:noAutofit/>
-          </a:bodyPr>
-          <a:lstStyle xmlns:a="http://schemas.openxmlformats.org/drawingml/2006/main">
-            <a:defPPr>
-              <a:defRPr sz="1725" b="1">
-                <a:solidFill>
-                  <a:srgbClr val="101022"/>
-                </a:solidFill>
-                <a:latin typeface="Arial"/>
-                <a:ea typeface="Arial"/>
-                <a:cs typeface="Arial"/>
-              </a:defRPr>
-            </a:defPPr>
-          </a:lstStyle>
-          <a:p xmlns:a="http://schemas.openxmlformats.org/drawingml/2006/main">
-            <a:pPr>
-              <a:defRPr sz="1725" b="1">
-                <a:solidFill>
-                  <a:srgbClr val="101022"/>
-                </a:solidFill>
-                <a:latin typeface="Arial"/>
-                <a:ea typeface="Arial"/>
-                <a:cs typeface="Arial"/>
-              </a:defRPr>
-            </a:pPr>
-            <a:r>
-              <a:rPr sz="1725" b="1">
-                <a:solidFill>
-                  <a:srgbClr val="101022"/>
-                </a:solidFill>
-                <a:latin typeface="Arial"/>
-                <a:ea typeface="Arial"/>
-                <a:cs typeface="Arial"/>
-              </a:rPr>
-              <a:t>Публичный пример API не подтверждает готовность обмена со Skillaz</a:t>
-            </a:r>
-          </a:p>
-        </p:txBody>
-      </p:sp>
     </p:spTree>
     <p:extLst>
       <p:ext uri="{BB962C8B-B14F-4D97-AF65-F5344CB8AC3E}">
-        <p14:creationId xmlns:p14="http://schemas.microsoft.com/office/powerpoint/2010/main" val="1673067621"/>
+        <p14:creationId xmlns:p14="http://schemas.microsoft.com/office/powerpoint/2010/main" val="1914722273"/>
       </p:ext>
     </p:extLst>
   </p:cSld>
@@ -13106,10 +13008,10 @@
       </p:grpSpPr>
       <p:pic>
         <p:nvPicPr>
-          <p:cNvPr id="17" name="">
-            <a:extLst xmlns:a="http://schemas.openxmlformats.org/drawingml/2006/main">
-              <a:ext uri="{FF2B5EF4-FFF2-40B4-BE49-F238E27FC236}">
-                <a16:creationId xmlns:a16="http://schemas.microsoft.com/office/drawing/2014/main" id="{4F5829C8-9EDD-4796-BADF-D1D8E18098AA}"/>
+          <p:cNvPr id="16" name="">
+            <a:extLst xmlns:a="http://schemas.openxmlformats.org/drawingml/2006/main">
+              <a:ext uri="{FF2B5EF4-FFF2-40B4-BE49-F238E27FC236}">
+                <a16:creationId xmlns:a16="http://schemas.microsoft.com/office/drawing/2014/main" id="{AD3C0AEB-FDEF-4835-9C9E-A65001055806}"/>
               </a:ext>
             </a:extLst>
           </p:cNvPr>
@@ -13119,7 +13021,7 @@
           <p:nvPr/>
         </p:nvPicPr>
         <p:blipFill>
-          <a:blip xmlns:r="http://schemas.openxmlformats.org/officeDocument/2006/relationships" xmlns:a="http://schemas.openxmlformats.org/drawingml/2006/main" r:embed="Re43aba2eaf0e491a"/>
+          <a:blip xmlns:r="http://schemas.openxmlformats.org/officeDocument/2006/relationships" xmlns:a="http://schemas.openxmlformats.org/drawingml/2006/main" r:embed="R7d944180a3c24e36"/>
           <a:stretch xmlns:a="http://schemas.openxmlformats.org/drawingml/2006/main"/>
         </p:blipFill>
         <p:spPr>
@@ -13137,7 +13039,7 @@
           <p:cNvPr id="2" name="">
             <a:extLst xmlns:a="http://schemas.openxmlformats.org/drawingml/2006/main">
               <a:ext uri="{FF2B5EF4-FFF2-40B4-BE49-F238E27FC236}">
-                <a16:creationId xmlns:a16="http://schemas.microsoft.com/office/drawing/2014/main" id="{9B867A24-8FA6-445D-961E-7C3DBC10802C}"/>
+                <a16:creationId xmlns:a16="http://schemas.microsoft.com/office/drawing/2014/main" id="{205FFBAB-2C2F-4D2D-BA95-4B42581A707C}"/>
               </a:ext>
             </a:extLst>
           </p:cNvPr>
@@ -13205,7 +13107,7 @@
           <p:cNvPr id="3" name="">
             <a:extLst xmlns:a="http://schemas.openxmlformats.org/drawingml/2006/main">
               <a:ext uri="{FF2B5EF4-FFF2-40B4-BE49-F238E27FC236}">
-                <a16:creationId xmlns:a16="http://schemas.microsoft.com/office/drawing/2014/main" id="{62A29C39-0328-4303-9F68-0E956CA8E220}"/>
+                <a16:creationId xmlns:a16="http://schemas.microsoft.com/office/drawing/2014/main" id="{F87ECA64-03C7-40C1-A421-49D2168C7D15}"/>
               </a:ext>
             </a:extLst>
           </p:cNvPr>
@@ -13273,7 +13175,7 @@
           <p:cNvPr id="4" name="">
             <a:extLst xmlns:a="http://schemas.openxmlformats.org/drawingml/2006/main">
               <a:ext uri="{FF2B5EF4-FFF2-40B4-BE49-F238E27FC236}">
-                <a16:creationId xmlns:a16="http://schemas.microsoft.com/office/drawing/2014/main" id="{75B57C6E-8D04-4538-A318-0E46D664886C}"/>
+                <a16:creationId xmlns:a16="http://schemas.microsoft.com/office/drawing/2014/main" id="{0976A03D-75E5-4D3D-B55F-066BF69C9739}"/>
               </a:ext>
             </a:extLst>
           </p:cNvPr>
@@ -13341,7 +13243,7 @@
           <p:cNvPr id="5" name="">
             <a:extLst xmlns:a="http://schemas.openxmlformats.org/drawingml/2006/main">
               <a:ext uri="{FF2B5EF4-FFF2-40B4-BE49-F238E27FC236}">
-                <a16:creationId xmlns:a16="http://schemas.microsoft.com/office/drawing/2014/main" id="{7D95CDD3-297D-4BD2-8C81-D9E27DDBE70E}"/>
+                <a16:creationId xmlns:a16="http://schemas.microsoft.com/office/drawing/2014/main" id="{3309376F-7D92-4100-A00A-99B852DDD73A}"/>
               </a:ext>
             </a:extLst>
           </p:cNvPr>
@@ -13409,7 +13311,7 @@
           <p:cNvPr id="6" name="">
             <a:extLst xmlns:a="http://schemas.openxmlformats.org/drawingml/2006/main">
               <a:ext uri="{FF2B5EF4-FFF2-40B4-BE49-F238E27FC236}">
-                <a16:creationId xmlns:a16="http://schemas.microsoft.com/office/drawing/2014/main" id="{21ECD9C4-20F2-499A-94FB-31821533B1D0}"/>
+                <a16:creationId xmlns:a16="http://schemas.microsoft.com/office/drawing/2014/main" id="{1491ED50-23FF-40A4-9BEA-7E9C2E821248}"/>
               </a:ext>
             </a:extLst>
           </p:cNvPr>
@@ -13477,7 +13379,7 @@
           <p:cNvPr id="7" name="">
             <a:extLst xmlns:a="http://schemas.openxmlformats.org/drawingml/2006/main">
               <a:ext uri="{FF2B5EF4-FFF2-40B4-BE49-F238E27FC236}">
-                <a16:creationId xmlns:a16="http://schemas.microsoft.com/office/drawing/2014/main" id="{90245483-EF85-448C-98EC-7E5E14090ACE}"/>
+                <a16:creationId xmlns:a16="http://schemas.microsoft.com/office/drawing/2014/main" id="{54A56E2C-DA3F-4283-9FF3-B426D5A2E7EA}"/>
               </a:ext>
             </a:extLst>
           </p:cNvPr>
@@ -13507,7 +13409,7 @@
           <p:cNvPr id="8" name="">
             <a:extLst xmlns:a="http://schemas.openxmlformats.org/drawingml/2006/main">
               <a:ext uri="{FF2B5EF4-FFF2-40B4-BE49-F238E27FC236}">
-                <a16:creationId xmlns:a16="http://schemas.microsoft.com/office/drawing/2014/main" id="{E176FC53-D7D4-4C2B-8360-3A52EE861EE7}"/>
+                <a16:creationId xmlns:a16="http://schemas.microsoft.com/office/drawing/2014/main" id="{F9C95042-39E9-4410-8A16-05798577FCC2}"/>
               </a:ext>
             </a:extLst>
           </p:cNvPr>
@@ -13575,7 +13477,7 @@
           <p:cNvPr id="9" name="">
             <a:extLst xmlns:a="http://schemas.openxmlformats.org/drawingml/2006/main">
               <a:ext uri="{FF2B5EF4-FFF2-40B4-BE49-F238E27FC236}">
-                <a16:creationId xmlns:a16="http://schemas.microsoft.com/office/drawing/2014/main" id="{579F5400-ABA9-423F-991F-7F0B6DD06068}"/>
+                <a16:creationId xmlns:a16="http://schemas.microsoft.com/office/drawing/2014/main" id="{74E71C64-355D-45CF-BB0C-FEF692721679}"/>
               </a:ext>
             </a:extLst>
           </p:cNvPr>
@@ -13689,7 +13591,7 @@
           <p:cNvPr id="10" name="">
             <a:extLst xmlns:a="http://schemas.openxmlformats.org/drawingml/2006/main">
               <a:ext uri="{FF2B5EF4-FFF2-40B4-BE49-F238E27FC236}">
-                <a16:creationId xmlns:a16="http://schemas.microsoft.com/office/drawing/2014/main" id="{ED5FBA2D-CED0-4AA8-A159-FDE59AF037E8}"/>
+                <a16:creationId xmlns:a16="http://schemas.microsoft.com/office/drawing/2014/main" id="{269B1787-8884-4676-A5C3-1B766143AD83}"/>
               </a:ext>
             </a:extLst>
           </p:cNvPr>
@@ -13719,7 +13621,7 @@
           <p:cNvPr id="11" name="">
             <a:extLst xmlns:a="http://schemas.openxmlformats.org/drawingml/2006/main">
               <a:ext uri="{FF2B5EF4-FFF2-40B4-BE49-F238E27FC236}">
-                <a16:creationId xmlns:a16="http://schemas.microsoft.com/office/drawing/2014/main" id="{5FC3E867-C857-4891-84C9-A6F7CFD66278}"/>
+                <a16:creationId xmlns:a16="http://schemas.microsoft.com/office/drawing/2014/main" id="{9C791B5B-A82B-4B37-B4C0-CD9DD34FFFD6}"/>
               </a:ext>
             </a:extLst>
           </p:cNvPr>
@@ -13787,7 +13689,7 @@
           <p:cNvPr id="12" name="">
             <a:extLst xmlns:a="http://schemas.openxmlformats.org/drawingml/2006/main">
               <a:ext uri="{FF2B5EF4-FFF2-40B4-BE49-F238E27FC236}">
-                <a16:creationId xmlns:a16="http://schemas.microsoft.com/office/drawing/2014/main" id="{D1E2F702-AACF-4E62-85BD-111101B12DDC}"/>
+                <a16:creationId xmlns:a16="http://schemas.microsoft.com/office/drawing/2014/main" id="{F70DC02E-8A37-450D-8C6A-9F1A267F9E8B}"/>
               </a:ext>
             </a:extLst>
           </p:cNvPr>
@@ -13924,7 +13826,7 @@
           <p:cNvPr id="13" name="">
             <a:extLst xmlns:a="http://schemas.openxmlformats.org/drawingml/2006/main">
               <a:ext uri="{FF2B5EF4-FFF2-40B4-BE49-F238E27FC236}">
-                <a16:creationId xmlns:a16="http://schemas.microsoft.com/office/drawing/2014/main" id="{94B91FD8-534A-4D9B-BE5E-C97769AACF77}"/>
+                <a16:creationId xmlns:a16="http://schemas.microsoft.com/office/drawing/2014/main" id="{674A06E4-37A3-496B-8207-4BAE357A9EA3}"/>
               </a:ext>
             </a:extLst>
           </p:cNvPr>
@@ -13954,7 +13856,7 @@
           <p:cNvPr id="14" name="">
             <a:extLst xmlns:a="http://schemas.openxmlformats.org/drawingml/2006/main">
               <a:ext uri="{FF2B5EF4-FFF2-40B4-BE49-F238E27FC236}">
-                <a16:creationId xmlns:a16="http://schemas.microsoft.com/office/drawing/2014/main" id="{9DE3ADDA-425E-4459-843D-06A920930B56}"/>
+                <a16:creationId xmlns:a16="http://schemas.microsoft.com/office/drawing/2014/main" id="{75BC9817-75FA-4C3D-BA5E-921895534DA1}"/>
               </a:ext>
             </a:extLst>
           </p:cNvPr>
@@ -14022,7 +13924,7 @@
           <p:cNvPr id="15" name="">
             <a:extLst xmlns:a="http://schemas.openxmlformats.org/drawingml/2006/main">
               <a:ext uri="{FF2B5EF4-FFF2-40B4-BE49-F238E27FC236}">
-                <a16:creationId xmlns:a16="http://schemas.microsoft.com/office/drawing/2014/main" id="{77E534F3-849E-4FA4-940D-317E8C48A9CE}"/>
+                <a16:creationId xmlns:a16="http://schemas.microsoft.com/office/drawing/2014/main" id="{28B6625A-5CD6-458F-B516-D1951C4F5699}"/>
               </a:ext>
             </a:extLst>
           </p:cNvPr>
@@ -14154,78 +14056,10 @@
           </a:p>
         </p:txBody>
       </p:sp>
-      <p:sp>
-        <p:nvSpPr>
-          <p:cNvPr id="16" name="">
-            <a:extLst xmlns:a="http://schemas.openxmlformats.org/drawingml/2006/main">
-              <a:ext uri="{FF2B5EF4-FFF2-40B4-BE49-F238E27FC236}">
-                <a16:creationId xmlns:a16="http://schemas.microsoft.com/office/drawing/2014/main" id="{66E6BE4E-DCEB-4779-9670-751CA5713977}"/>
-              </a:ext>
-            </a:extLst>
-          </p:cNvPr>
-          <p:cNvSpPr>
-            <a:spLocks xmlns:a="http://schemas.openxmlformats.org/drawingml/2006/main" noGrp="1"/>
-          </p:cNvSpPr>
-          <p:nvPr/>
-        </p:nvSpPr>
-        <p:spPr>
-          <a:xfrm xmlns:a="http://schemas.openxmlformats.org/drawingml/2006/main">
-            <a:off x="504825" y="5133975"/>
-            <a:ext cx="9696450" cy="400050"/>
-          </a:xfrm>
-          <a:prstGeom xmlns:a="http://schemas.openxmlformats.org/drawingml/2006/main" prst="rect">
-            <a:avLst/>
-          </a:prstGeom>
-          <a:noFill xmlns:a="http://schemas.openxmlformats.org/drawingml/2006/main"/>
-          <a:ln xmlns:a="http://schemas.openxmlformats.org/drawingml/2006/main" w="0">
-            <a:noFill/>
-          </a:ln>
-        </p:spPr>
-        <p:txBody>
-          <a:bodyPr xmlns:a="http://schemas.openxmlformats.org/drawingml/2006/main" lIns="0" tIns="0" rIns="0" bIns="0" anchor="t">
-            <a:noAutofit/>
-          </a:bodyPr>
-          <a:lstStyle xmlns:a="http://schemas.openxmlformats.org/drawingml/2006/main">
-            <a:defPPr>
-              <a:defRPr sz="1350" b="0">
-                <a:solidFill>
-                  <a:srgbClr val="737C96"/>
-                </a:solidFill>
-                <a:latin typeface="Arial"/>
-                <a:ea typeface="Arial"/>
-                <a:cs typeface="Arial"/>
-              </a:defRPr>
-            </a:defPPr>
-          </a:lstStyle>
-          <a:p xmlns:a="http://schemas.openxmlformats.org/drawingml/2006/main">
-            <a:pPr>
-              <a:defRPr sz="1350" b="0">
-                <a:solidFill>
-                  <a:srgbClr val="737C96"/>
-                </a:solidFill>
-                <a:latin typeface="Arial"/>
-                <a:ea typeface="Arial"/>
-                <a:cs typeface="Arial"/>
-              </a:defRPr>
-            </a:pPr>
-            <a:r>
-              <a:rPr sz="1350" b="0">
-                <a:solidFill>
-                  <a:srgbClr val="737C96"/>
-                </a:solidFill>
-                <a:latin typeface="Arial"/>
-                <a:ea typeface="Arial"/>
-                <a:cs typeface="Arial"/>
-              </a:rPr>
-              <a:t>Вариант для реализации; доступ приложения Skillaz к данным ещё не проверен.</a:t>
-            </a:r>
-          </a:p>
-        </p:txBody>
-      </p:sp>
     </p:spTree>
     <p:extLst>
       <p:ext uri="{BB962C8B-B14F-4D97-AF65-F5344CB8AC3E}">
-        <p14:creationId xmlns:p14="http://schemas.microsoft.com/office/powerpoint/2010/main" val="1225450610"/>
+        <p14:creationId xmlns:p14="http://schemas.microsoft.com/office/powerpoint/2010/main" val="553293467"/>
       </p:ext>
     </p:extLst>
   </p:cSld>

</xml_diff>

<commit_message>
Explain recruiter benefits and Skillaz value without guaranteed savings
</commit_message>
<xml_diff>
--- a/Skillaz-hh-Integration.pptx
+++ b/Skillaz-hh-Integration.pptx
@@ -2,22 +2,22 @@
 <file path=ppt/presentation.xml><?xml version="1.0" encoding="utf-8"?>
 <p:presentation xmlns:p="http://schemas.openxmlformats.org/presentationml/2006/main">
   <p:sldMasterIdLst>
-    <p:sldMasterId xmlns:r="http://schemas.openxmlformats.org/officeDocument/2006/relationships" id="2147483648" r:id="R9c2f2de8383d4564"/>
+    <p:sldMasterId xmlns:r="http://schemas.openxmlformats.org/officeDocument/2006/relationships" id="2147483648" r:id="R9b7f2c14ae974cfb"/>
   </p:sldMasterIdLst>
   <p:notesMasterIdLst>
-    <p:notesMasterId xmlns:r="http://schemas.openxmlformats.org/officeDocument/2006/relationships" r:id="Ra6c3a64e2e374ab2"/>
+    <p:notesMasterId xmlns:r="http://schemas.openxmlformats.org/officeDocument/2006/relationships" r:id="Rdba5a264c1b341cf"/>
   </p:notesMasterIdLst>
   <p:sldIdLst>
-    <p:sldId xmlns:r="http://schemas.openxmlformats.org/officeDocument/2006/relationships" id="256" r:id="Rfde312104e8e418f"/>
-    <p:sldId xmlns:r="http://schemas.openxmlformats.org/officeDocument/2006/relationships" id="257" r:id="Rd2ad115011294b7c"/>
-    <p:sldId xmlns:r="http://schemas.openxmlformats.org/officeDocument/2006/relationships" id="258" r:id="R9dc72c17529c42da"/>
-    <p:sldId xmlns:r="http://schemas.openxmlformats.org/officeDocument/2006/relationships" id="259" r:id="R6ae650de37f54b65"/>
-    <p:sldId xmlns:r="http://schemas.openxmlformats.org/officeDocument/2006/relationships" id="260" r:id="R2607b0990d5c4d95"/>
-    <p:sldId xmlns:r="http://schemas.openxmlformats.org/officeDocument/2006/relationships" id="261" r:id="R1e8f8bc9e13d4fb7"/>
-    <p:sldId xmlns:r="http://schemas.openxmlformats.org/officeDocument/2006/relationships" id="262" r:id="Rf98e9425316e4331"/>
-    <p:sldId xmlns:r="http://schemas.openxmlformats.org/officeDocument/2006/relationships" id="263" r:id="Rfb871bebd6354a81"/>
-    <p:sldId xmlns:r="http://schemas.openxmlformats.org/officeDocument/2006/relationships" id="264" r:id="Rafa7de84b1ee48d2"/>
-    <p:sldId xmlns:r="http://schemas.openxmlformats.org/officeDocument/2006/relationships" id="265" r:id="R03cee2fdd1894a66"/>
+    <p:sldId xmlns:r="http://schemas.openxmlformats.org/officeDocument/2006/relationships" id="256" r:id="R92439d5e70924068"/>
+    <p:sldId xmlns:r="http://schemas.openxmlformats.org/officeDocument/2006/relationships" id="257" r:id="R280a4c424c864b5e"/>
+    <p:sldId xmlns:r="http://schemas.openxmlformats.org/officeDocument/2006/relationships" id="258" r:id="Rabb4b10347e94a10"/>
+    <p:sldId xmlns:r="http://schemas.openxmlformats.org/officeDocument/2006/relationships" id="259" r:id="R6500e320098b48ff"/>
+    <p:sldId xmlns:r="http://schemas.openxmlformats.org/officeDocument/2006/relationships" id="260" r:id="Rf3ee07fbee9a4e35"/>
+    <p:sldId xmlns:r="http://schemas.openxmlformats.org/officeDocument/2006/relationships" id="261" r:id="R137de607918948d4"/>
+    <p:sldId xmlns:r="http://schemas.openxmlformats.org/officeDocument/2006/relationships" id="262" r:id="Rcaa556f0b2ae44db"/>
+    <p:sldId xmlns:r="http://schemas.openxmlformats.org/officeDocument/2006/relationships" id="263" r:id="R23c522181f034c12"/>
+    <p:sldId xmlns:r="http://schemas.openxmlformats.org/officeDocument/2006/relationships" id="264" r:id="Rab0346e111974aa5"/>
+    <p:sldId xmlns:r="http://schemas.openxmlformats.org/officeDocument/2006/relationships" id="265" r:id="Rc7740d039bc242f6"/>
   </p:sldIdLst>
   <p:sldSz cx="10692384" cy="6007608"/>
   <p:notesSz cx="6858000" cy="9144000"/>
@@ -564,6 +564,16 @@
               <a:t/>
             </a:r>
           </a:p>
+          <a:p xmlns:a="http://schemas.openxmlformats.org/drawingml/2006/main">
+            <a:r>
+              <a:t/>
+            </a:r>
+          </a:p>
+          <a:p xmlns:a="http://schemas.openxmlformats.org/drawingml/2006/main">
+            <a:r>
+              <a:t>Пилот сравнивает работу с ИИ непосредственно в hh и с теми же результатами через Skillaz на сопоставимых вакансиях и нагрузке. Отдельно учитывать время проверки выводов и исправлений. Не приписывать интеграции общий эффект ИИ hh. Замерять время первичного рассмотрения, число переходов и объём ручного переноса. Не обещать проценты экономии, ускорение найма или снижение затрат без измерений.</a:t>
+            </a:r>
+          </a:p>
         </p:txBody>
       </p:sp>
       <p:sp>
@@ -744,6 +754,16 @@
               <a:t/>
             </a:r>
           </a:p>
+          <a:p xmlns:a="http://schemas.openxmlformats.org/drawingml/2006/main">
+            <a:r>
+              <a:t/>
+            </a:r>
+          </a:p>
+          <a:p xmlns:a="http://schemas.openxmlformats.org/drawingml/2006/main">
+            <a:r>
+              <a:t>Польза сформулирована как назначение данных, не как измеренный эффект. В примерах API есть decision, summary, criteria с explanation/source и вопросы с цитатами ответов. Использование этих данных в Skillaz требует проверки обмена. Доопрос помогает подготовиться только при наличии ответов кандидата.</a:t>
+            </a:r>
+          </a:p>
         </p:txBody>
       </p:sp>
       <p:sp>
@@ -1294,6 +1314,16 @@
               <a:t>Слайд 9 показывает предлагаемый вариант, а не готовые возможности Skillaz. Запрос по ID отклика не содержит текст резюме; полученные данные и сам идентификатор не следует считать автоматически обезличенными. Отображение оценки и ответов в карточке требует реализации и проверки.</a:t>
             </a:r>
           </a:p>
+          <a:p xmlns:a="http://schemas.openxmlformats.org/drawingml/2006/main">
+            <a:r>
+              <a:t/>
+            </a:r>
+          </a:p>
+          <a:p xmlns:a="http://schemas.openxmlformats.org/drawingml/2006/main">
+            <a:r>
+              <a:t>Предлагаемое позиционирование: клиент оплачивает использование результатов hh в рабочем процессе Skillaz. Это не утверждённый тариф или перечень уже реализованных функций. Требуют проверки получение данных, привязка к отклику и вакансии, состав отображения, обновление и доступ клиента. Условия оплаты, включение услуг hh, внедрение, сопровождение и SLA согласуются отдельно. Возможное сокращение переходов и копирования является гипотезой, не обещанием экономии.</a:t>
+            </a:r>
+          </a:p>
         </p:txBody>
       </p:sp>
       <p:sp>
@@ -1338,7 +1368,7 @@
           <p:cNvPr id="3" name="Title">
             <a:extLst xmlns:a="http://schemas.openxmlformats.org/drawingml/2006/main">
               <a:ext uri="{FF2B5EF4-FFF2-40B4-BE49-F238E27FC236}">
-                <a16:creationId xmlns:a16="http://schemas.microsoft.com/office/drawing/2014/main" id="{B5F1A045-CBAF-4CD5-A84C-E6C0E0F2023F}"/>
+                <a16:creationId xmlns:a16="http://schemas.microsoft.com/office/drawing/2014/main" id="{70CBDAEE-428C-4A5A-95F8-CFB4E8D373C5}"/>
               </a:ext>
             </a:extLst>
           </p:cNvPr>
@@ -1495,7 +1525,7 @@
           <p:cNvPr id="2" name="Subtitle">
             <a:extLst xmlns:a="http://schemas.openxmlformats.org/drawingml/2006/main">
               <a:ext uri="{FF2B5EF4-FFF2-40B4-BE49-F238E27FC236}">
-                <a16:creationId xmlns:a16="http://schemas.microsoft.com/office/drawing/2014/main" id="{13B6DB34-B7FB-497C-8C2F-E39FA7180347}"/>
+                <a16:creationId xmlns:a16="http://schemas.microsoft.com/office/drawing/2014/main" id="{A4C0C9BB-23D4-431A-B126-E0E4ACF3FFF8}"/>
               </a:ext>
             </a:extLst>
           </p:cNvPr>
@@ -1669,7 +1699,7 @@
           <p:cNvPr id="2" name="Section title">
             <a:extLst xmlns:a="http://schemas.openxmlformats.org/drawingml/2006/main">
               <a:ext uri="{FF2B5EF4-FFF2-40B4-BE49-F238E27FC236}">
-                <a16:creationId xmlns:a16="http://schemas.microsoft.com/office/drawing/2014/main" id="{6C37E80E-0ED6-4DC7-B10C-96CF668FC121}"/>
+                <a16:creationId xmlns:a16="http://schemas.microsoft.com/office/drawing/2014/main" id="{96D1EA03-FC33-4794-B1AE-596382346A9B}"/>
               </a:ext>
             </a:extLst>
           </p:cNvPr>
@@ -1843,7 +1873,7 @@
           <p:cNvPr id="3" name="Title">
             <a:extLst xmlns:a="http://schemas.openxmlformats.org/drawingml/2006/main">
               <a:ext uri="{FF2B5EF4-FFF2-40B4-BE49-F238E27FC236}">
-                <a16:creationId xmlns:a16="http://schemas.microsoft.com/office/drawing/2014/main" id="{08861548-6651-49F2-9E53-DDF2D296EB97}"/>
+                <a16:creationId xmlns:a16="http://schemas.microsoft.com/office/drawing/2014/main" id="{49C396E3-2BAF-4CF6-B7C9-D02A5F943BDD}"/>
               </a:ext>
             </a:extLst>
           </p:cNvPr>
@@ -2000,7 +2030,7 @@
           <p:cNvPr id="2" name="Body">
             <a:extLst xmlns:a="http://schemas.openxmlformats.org/drawingml/2006/main">
               <a:ext uri="{FF2B5EF4-FFF2-40B4-BE49-F238E27FC236}">
-                <a16:creationId xmlns:a16="http://schemas.microsoft.com/office/drawing/2014/main" id="{799477C1-1A84-42E6-AAF2-C8E1128FDEF5}"/>
+                <a16:creationId xmlns:a16="http://schemas.microsoft.com/office/drawing/2014/main" id="{B111C37A-0141-42E0-9506-2F3B33054ADC}"/>
               </a:ext>
             </a:extLst>
           </p:cNvPr>
@@ -2174,7 +2204,7 @@
           <p:cNvPr id="4" name="Title">
             <a:extLst xmlns:a="http://schemas.openxmlformats.org/drawingml/2006/main">
               <a:ext uri="{FF2B5EF4-FFF2-40B4-BE49-F238E27FC236}">
-                <a16:creationId xmlns:a16="http://schemas.microsoft.com/office/drawing/2014/main" id="{3CDBF0A6-26A6-4F19-ADFE-055B85A4D18B}"/>
+                <a16:creationId xmlns:a16="http://schemas.microsoft.com/office/drawing/2014/main" id="{02DF3DC3-64B5-473D-BB3D-0C532FD59362}"/>
               </a:ext>
             </a:extLst>
           </p:cNvPr>
@@ -2331,7 +2361,7 @@
           <p:cNvPr id="2" name="Left column">
             <a:extLst xmlns:a="http://schemas.openxmlformats.org/drawingml/2006/main">
               <a:ext uri="{FF2B5EF4-FFF2-40B4-BE49-F238E27FC236}">
-                <a16:creationId xmlns:a16="http://schemas.microsoft.com/office/drawing/2014/main" id="{6B282A8F-0DDD-4011-9AAF-233EA7C55D32}"/>
+                <a16:creationId xmlns:a16="http://schemas.microsoft.com/office/drawing/2014/main" id="{3F3A26D7-B643-451C-AC2F-2101F0E099F8}"/>
               </a:ext>
             </a:extLst>
           </p:cNvPr>
@@ -2488,7 +2518,7 @@
           <p:cNvPr id="3" name="Right column">
             <a:extLst xmlns:a="http://schemas.openxmlformats.org/drawingml/2006/main">
               <a:ext uri="{FF2B5EF4-FFF2-40B4-BE49-F238E27FC236}">
-                <a16:creationId xmlns:a16="http://schemas.microsoft.com/office/drawing/2014/main" id="{5083456A-2175-4637-A046-DDBC92FA8486}"/>
+                <a16:creationId xmlns:a16="http://schemas.microsoft.com/office/drawing/2014/main" id="{42A01FAD-5130-475B-A2DA-12FD3DD2E833}"/>
               </a:ext>
             </a:extLst>
           </p:cNvPr>
@@ -2662,7 +2692,7 @@
           <p:cNvPr id="3" name="Title">
             <a:extLst xmlns:a="http://schemas.openxmlformats.org/drawingml/2006/main">
               <a:ext uri="{FF2B5EF4-FFF2-40B4-BE49-F238E27FC236}">
-                <a16:creationId xmlns:a16="http://schemas.microsoft.com/office/drawing/2014/main" id="{37C74EB7-F3F8-4BF3-BF57-1FBCD3F2753F}"/>
+                <a16:creationId xmlns:a16="http://schemas.microsoft.com/office/drawing/2014/main" id="{D54DF071-489D-4D33-BA7E-54F4618D36E3}"/>
               </a:ext>
             </a:extLst>
           </p:cNvPr>
@@ -2819,7 +2849,7 @@
           <p:cNvPr id="2" name="Left column">
             <a:extLst xmlns:a="http://schemas.openxmlformats.org/drawingml/2006/main">
               <a:ext uri="{FF2B5EF4-FFF2-40B4-BE49-F238E27FC236}">
-                <a16:creationId xmlns:a16="http://schemas.microsoft.com/office/drawing/2014/main" id="{9D381C58-676D-41E7-B53D-8AEC7B751BB1}"/>
+                <a16:creationId xmlns:a16="http://schemas.microsoft.com/office/drawing/2014/main" id="{2D94EF84-DF09-4096-BB54-6A6110628F80}"/>
               </a:ext>
             </a:extLst>
           </p:cNvPr>
@@ -3014,12 +3044,12 @@
   </p:cSld>
   <p:clrMap bg1="lt1" tx1="dk1" bg2="lt2" tx2="dk2" accent1="accent1" accent2="accent2" accent3="accent3" accent4="accent4" accent5="accent5" accent6="accent6" hlink="hlink" folHlink="folHlink"/>
   <p:sldLayoutIdLst>
-    <p:sldLayoutId xmlns:r="http://schemas.openxmlformats.org/officeDocument/2006/relationships" id="2147483649" r:id="R9215ff60f0694d31"/>
-    <p:sldLayoutId xmlns:r="http://schemas.openxmlformats.org/officeDocument/2006/relationships" id="2147483650" r:id="R91d6670cde4940cb"/>
-    <p:sldLayoutId xmlns:r="http://schemas.openxmlformats.org/officeDocument/2006/relationships" id="2147483651" r:id="R2cc159e8d2954d4a"/>
-    <p:sldLayoutId xmlns:r="http://schemas.openxmlformats.org/officeDocument/2006/relationships" id="2147483652" r:id="R13d8d149a7da4d45"/>
-    <p:sldLayoutId xmlns:r="http://schemas.openxmlformats.org/officeDocument/2006/relationships" id="2147483653" r:id="R235aba9296e142e3"/>
-    <p:sldLayoutId xmlns:r="http://schemas.openxmlformats.org/officeDocument/2006/relationships" id="2147483654" r:id="R477f21c0f1da4bed"/>
+    <p:sldLayoutId xmlns:r="http://schemas.openxmlformats.org/officeDocument/2006/relationships" id="2147483649" r:id="Rc448b1be9487452d"/>
+    <p:sldLayoutId xmlns:r="http://schemas.openxmlformats.org/officeDocument/2006/relationships" id="2147483650" r:id="Rcddf079f1f564ae1"/>
+    <p:sldLayoutId xmlns:r="http://schemas.openxmlformats.org/officeDocument/2006/relationships" id="2147483651" r:id="Rfaf7724d19bf4956"/>
+    <p:sldLayoutId xmlns:r="http://schemas.openxmlformats.org/officeDocument/2006/relationships" id="2147483652" r:id="R16155753913c4bbd"/>
+    <p:sldLayoutId xmlns:r="http://schemas.openxmlformats.org/officeDocument/2006/relationships" id="2147483653" r:id="Rdb92c6ece0b44332"/>
+    <p:sldLayoutId xmlns:r="http://schemas.openxmlformats.org/officeDocument/2006/relationships" id="2147483654" r:id="R83149f7faac7469a"/>
   </p:sldLayoutIdLst>
   <p:txStyles>
     <p:titleStyle>
@@ -3570,7 +3600,7 @@
           <p:cNvPr id="11" name="">
             <a:extLst xmlns:a="http://schemas.openxmlformats.org/drawingml/2006/main">
               <a:ext uri="{FF2B5EF4-FFF2-40B4-BE49-F238E27FC236}">
-                <a16:creationId xmlns:a16="http://schemas.microsoft.com/office/drawing/2014/main" id="{B799D45C-6920-4443-912D-3BFD4746B0D0}"/>
+                <a16:creationId xmlns:a16="http://schemas.microsoft.com/office/drawing/2014/main" id="{13272986-F999-4056-955E-6D7D56D31EF5}"/>
               </a:ext>
             </a:extLst>
           </p:cNvPr>
@@ -3580,7 +3610,7 @@
           <p:nvPr/>
         </p:nvPicPr>
         <p:blipFill>
-          <a:blip xmlns:r="http://schemas.openxmlformats.org/officeDocument/2006/relationships" xmlns:a="http://schemas.openxmlformats.org/drawingml/2006/main" r:embed="R39cd529606614253"/>
+          <a:blip xmlns:r="http://schemas.openxmlformats.org/officeDocument/2006/relationships" xmlns:a="http://schemas.openxmlformats.org/drawingml/2006/main" r:embed="R2be1080710a54e04"/>
           <a:stretch xmlns:a="http://schemas.openxmlformats.org/drawingml/2006/main"/>
         </p:blipFill>
         <p:spPr>
@@ -3598,7 +3628,7 @@
           <p:cNvPr id="2" name="">
             <a:extLst xmlns:a="http://schemas.openxmlformats.org/drawingml/2006/main">
               <a:ext uri="{FF2B5EF4-FFF2-40B4-BE49-F238E27FC236}">
-                <a16:creationId xmlns:a16="http://schemas.microsoft.com/office/drawing/2014/main" id="{88B8DDB2-5520-4E11-94AC-E4B510329036}"/>
+                <a16:creationId xmlns:a16="http://schemas.microsoft.com/office/drawing/2014/main" id="{70EDB820-E03C-496C-A511-3D646AC28759}"/>
               </a:ext>
             </a:extLst>
           </p:cNvPr>
@@ -3666,7 +3696,7 @@
           <p:cNvPr id="3" name="">
             <a:extLst xmlns:a="http://schemas.openxmlformats.org/drawingml/2006/main">
               <a:ext uri="{FF2B5EF4-FFF2-40B4-BE49-F238E27FC236}">
-                <a16:creationId xmlns:a16="http://schemas.microsoft.com/office/drawing/2014/main" id="{9B0CF87A-0DA4-4F8F-82E6-1F161BA9E55D}"/>
+                <a16:creationId xmlns:a16="http://schemas.microsoft.com/office/drawing/2014/main" id="{1644B83B-C4C0-4792-AE29-93588F8D03E7}"/>
               </a:ext>
             </a:extLst>
           </p:cNvPr>
@@ -3734,7 +3764,7 @@
           <p:cNvPr id="4" name="">
             <a:extLst xmlns:a="http://schemas.openxmlformats.org/drawingml/2006/main">
               <a:ext uri="{FF2B5EF4-FFF2-40B4-BE49-F238E27FC236}">
-                <a16:creationId xmlns:a16="http://schemas.microsoft.com/office/drawing/2014/main" id="{6F8465EA-EFAD-4B03-BF94-8DA4A6EE2072}"/>
+                <a16:creationId xmlns:a16="http://schemas.microsoft.com/office/drawing/2014/main" id="{37CC5797-3786-463C-A10A-BA53BC4C1CFF}"/>
               </a:ext>
             </a:extLst>
           </p:cNvPr>
@@ -3802,7 +3832,7 @@
           <p:cNvPr id="5" name="">
             <a:extLst xmlns:a="http://schemas.openxmlformats.org/drawingml/2006/main">
               <a:ext uri="{FF2B5EF4-FFF2-40B4-BE49-F238E27FC236}">
-                <a16:creationId xmlns:a16="http://schemas.microsoft.com/office/drawing/2014/main" id="{F509B47D-1694-4DDE-A692-388CB535A5D5}"/>
+                <a16:creationId xmlns:a16="http://schemas.microsoft.com/office/drawing/2014/main" id="{104916AB-6602-4274-BC4B-2CF632653EB6}"/>
               </a:ext>
             </a:extLst>
           </p:cNvPr>
@@ -3870,7 +3900,7 @@
           <p:cNvPr id="6" name="">
             <a:extLst xmlns:a="http://schemas.openxmlformats.org/drawingml/2006/main">
               <a:ext uri="{FF2B5EF4-FFF2-40B4-BE49-F238E27FC236}">
-                <a16:creationId xmlns:a16="http://schemas.microsoft.com/office/drawing/2014/main" id="{33BD1EE7-FFF7-4D5A-8128-D8F816D88B6D}"/>
+                <a16:creationId xmlns:a16="http://schemas.microsoft.com/office/drawing/2014/main" id="{B514B7BD-3835-4655-BD35-4225AEBCA135}"/>
               </a:ext>
             </a:extLst>
           </p:cNvPr>
@@ -3900,7 +3930,7 @@
           <p:cNvPr id="7" name="">
             <a:extLst xmlns:a="http://schemas.openxmlformats.org/drawingml/2006/main">
               <a:ext uri="{FF2B5EF4-FFF2-40B4-BE49-F238E27FC236}">
-                <a16:creationId xmlns:a16="http://schemas.microsoft.com/office/drawing/2014/main" id="{45C6B426-B11E-4DEC-829B-8A1F1BE74114}"/>
+                <a16:creationId xmlns:a16="http://schemas.microsoft.com/office/drawing/2014/main" id="{33057292-8D1F-4490-B51B-745DF5F18ACA}"/>
               </a:ext>
             </a:extLst>
           </p:cNvPr>
@@ -3991,7 +4021,7 @@
           <p:cNvPr id="8" name="">
             <a:extLst xmlns:a="http://schemas.openxmlformats.org/drawingml/2006/main">
               <a:ext uri="{FF2B5EF4-FFF2-40B4-BE49-F238E27FC236}">
-                <a16:creationId xmlns:a16="http://schemas.microsoft.com/office/drawing/2014/main" id="{0AC6DB30-0A31-4D64-8D65-9483FFC0C91F}"/>
+                <a16:creationId xmlns:a16="http://schemas.microsoft.com/office/drawing/2014/main" id="{322DEEFF-61A5-4A68-BB53-0796C349C986}"/>
               </a:ext>
             </a:extLst>
           </p:cNvPr>
@@ -4049,7 +4079,7 @@
                 <a:ea typeface="Arial"/>
                 <a:cs typeface="Arial"/>
               </a:rPr>
-              <a:t>Базовый вариант интеграции</a:t>
+              <a:t>Оценка и ответы кандидата</a:t>
             </a:r>
           </a:p>
           <a:p xmlns:a="http://schemas.openxmlformats.org/drawingml/2006/main">
@@ -4072,7 +4102,7 @@
                 <a:ea typeface="Arial"/>
                 <a:cs typeface="Arial"/>
               </a:rPr>
-              <a:t>на основе документации hh.ru</a:t>
+              <a:t>в рабочем процессе рекрутера</a:t>
             </a:r>
           </a:p>
         </p:txBody>
@@ -4082,7 +4112,7 @@
           <p:cNvPr id="9" name="">
             <a:extLst xmlns:a="http://schemas.openxmlformats.org/drawingml/2006/main">
               <a:ext uri="{FF2B5EF4-FFF2-40B4-BE49-F238E27FC236}">
-                <a16:creationId xmlns:a16="http://schemas.microsoft.com/office/drawing/2014/main" id="{00357A85-D1AD-4C0C-A5CA-3504C8EF8309}"/>
+                <a16:creationId xmlns:a16="http://schemas.microsoft.com/office/drawing/2014/main" id="{A6EC1CC9-BAF3-42F0-BD5A-B65D14EFE71C}"/>
               </a:ext>
             </a:extLst>
           </p:cNvPr>
@@ -4150,7 +4180,7 @@
           <p:cNvPr id="10" name="">
             <a:extLst xmlns:a="http://schemas.openxmlformats.org/drawingml/2006/main">
               <a:ext uri="{FF2B5EF4-FFF2-40B4-BE49-F238E27FC236}">
-                <a16:creationId xmlns:a16="http://schemas.microsoft.com/office/drawing/2014/main" id="{8E7C14A4-0998-41F1-AB89-D105AF23EC90}"/>
+                <a16:creationId xmlns:a16="http://schemas.microsoft.com/office/drawing/2014/main" id="{C88D5DDE-6EF4-4A1E-B67F-C74001830B3D}"/>
               </a:ext>
             </a:extLst>
           </p:cNvPr>
@@ -4239,7 +4269,7 @@
     </p:spTree>
     <p:extLst>
       <p:ext uri="{BB962C8B-B14F-4D97-AF65-F5344CB8AC3E}">
-        <p14:creationId xmlns:p14="http://schemas.microsoft.com/office/powerpoint/2010/main" val="695841019"/>
+        <p14:creationId xmlns:p14="http://schemas.microsoft.com/office/powerpoint/2010/main" val="1665989767"/>
       </p:ext>
     </p:extLst>
   </p:cSld>
@@ -4270,7 +4300,7 @@
           <p:cNvPr id="21" name="">
             <a:extLst xmlns:a="http://schemas.openxmlformats.org/drawingml/2006/main">
               <a:ext uri="{FF2B5EF4-FFF2-40B4-BE49-F238E27FC236}">
-                <a16:creationId xmlns:a16="http://schemas.microsoft.com/office/drawing/2014/main" id="{83DA52DF-1928-4297-84DE-303241F2B70D}"/>
+                <a16:creationId xmlns:a16="http://schemas.microsoft.com/office/drawing/2014/main" id="{6DF9E8EF-B071-4442-830E-AE9068920AE3}"/>
               </a:ext>
             </a:extLst>
           </p:cNvPr>
@@ -4280,7 +4310,7 @@
           <p:nvPr/>
         </p:nvPicPr>
         <p:blipFill>
-          <a:blip xmlns:r="http://schemas.openxmlformats.org/officeDocument/2006/relationships" xmlns:a="http://schemas.openxmlformats.org/drawingml/2006/main" r:embed="Rc18e316f86b54ff4"/>
+          <a:blip xmlns:r="http://schemas.openxmlformats.org/officeDocument/2006/relationships" xmlns:a="http://schemas.openxmlformats.org/drawingml/2006/main" r:embed="R779165f359864af7"/>
           <a:stretch xmlns:a="http://schemas.openxmlformats.org/drawingml/2006/main"/>
         </p:blipFill>
         <p:spPr>
@@ -4298,7 +4328,7 @@
           <p:cNvPr id="2" name="">
             <a:extLst xmlns:a="http://schemas.openxmlformats.org/drawingml/2006/main">
               <a:ext uri="{FF2B5EF4-FFF2-40B4-BE49-F238E27FC236}">
-                <a16:creationId xmlns:a16="http://schemas.microsoft.com/office/drawing/2014/main" id="{5E53B8B3-7526-491B-A1FA-6854CA5C33E0}"/>
+                <a16:creationId xmlns:a16="http://schemas.microsoft.com/office/drawing/2014/main" id="{47B8DDA5-C5B4-49FE-B14B-366E25A7905C}"/>
               </a:ext>
             </a:extLst>
           </p:cNvPr>
@@ -4366,7 +4396,7 @@
           <p:cNvPr id="3" name="">
             <a:extLst xmlns:a="http://schemas.openxmlformats.org/drawingml/2006/main">
               <a:ext uri="{FF2B5EF4-FFF2-40B4-BE49-F238E27FC236}">
-                <a16:creationId xmlns:a16="http://schemas.microsoft.com/office/drawing/2014/main" id="{EC346983-0509-4146-9482-90F4CE368594}"/>
+                <a16:creationId xmlns:a16="http://schemas.microsoft.com/office/drawing/2014/main" id="{23A920E4-E886-4BBF-8BFE-EEA0DA6EA7EF}"/>
               </a:ext>
             </a:extLst>
           </p:cNvPr>
@@ -4434,7 +4464,7 @@
           <p:cNvPr id="4" name="">
             <a:extLst xmlns:a="http://schemas.openxmlformats.org/drawingml/2006/main">
               <a:ext uri="{FF2B5EF4-FFF2-40B4-BE49-F238E27FC236}">
-                <a16:creationId xmlns:a16="http://schemas.microsoft.com/office/drawing/2014/main" id="{F48D0ACD-6677-4ADA-98FE-37B04145AAF2}"/>
+                <a16:creationId xmlns:a16="http://schemas.microsoft.com/office/drawing/2014/main" id="{FF221E52-12F9-4951-A3F2-0B81B639F7AF}"/>
               </a:ext>
             </a:extLst>
           </p:cNvPr>
@@ -4502,7 +4532,7 @@
           <p:cNvPr id="5" name="">
             <a:extLst xmlns:a="http://schemas.openxmlformats.org/drawingml/2006/main">
               <a:ext uri="{FF2B5EF4-FFF2-40B4-BE49-F238E27FC236}">
-                <a16:creationId xmlns:a16="http://schemas.microsoft.com/office/drawing/2014/main" id="{7C757A9A-CF66-4A79-8385-8EACDFD5C1A9}"/>
+                <a16:creationId xmlns:a16="http://schemas.microsoft.com/office/drawing/2014/main" id="{F4029CC3-DF30-4D5F-A1A6-DEF4D2B70A85}"/>
               </a:ext>
             </a:extLst>
           </p:cNvPr>
@@ -4570,7 +4600,7 @@
           <p:cNvPr id="6" name="">
             <a:extLst xmlns:a="http://schemas.openxmlformats.org/drawingml/2006/main">
               <a:ext uri="{FF2B5EF4-FFF2-40B4-BE49-F238E27FC236}">
-                <a16:creationId xmlns:a16="http://schemas.microsoft.com/office/drawing/2014/main" id="{FC254528-C687-4B74-A95D-388A2C299B77}"/>
+                <a16:creationId xmlns:a16="http://schemas.microsoft.com/office/drawing/2014/main" id="{534C2C49-E2A3-434B-A8D7-123B0603213E}"/>
               </a:ext>
             </a:extLst>
           </p:cNvPr>
@@ -4600,7 +4630,7 @@
           <p:cNvPr id="7" name="">
             <a:extLst xmlns:a="http://schemas.openxmlformats.org/drawingml/2006/main">
               <a:ext uri="{FF2B5EF4-FFF2-40B4-BE49-F238E27FC236}">
-                <a16:creationId xmlns:a16="http://schemas.microsoft.com/office/drawing/2014/main" id="{6A44664C-FB85-46DE-BF3A-83F4CF76FE2C}"/>
+                <a16:creationId xmlns:a16="http://schemas.microsoft.com/office/drawing/2014/main" id="{D877476E-EBE9-4027-A9A5-9CFC2C1A18F3}"/>
               </a:ext>
             </a:extLst>
           </p:cNvPr>
@@ -4658,7 +4688,7 @@
                 <a:ea typeface="Arial"/>
                 <a:cs typeface="Arial"/>
               </a:rPr>
-              <a:t>Сначала — проверка получения данных</a:t>
+              <a:t>Как проверить пользу интеграции</a:t>
             </a:r>
           </a:p>
         </p:txBody>
@@ -4668,7 +4698,7 @@
           <p:cNvPr id="8" name="">
             <a:extLst xmlns:a="http://schemas.openxmlformats.org/drawingml/2006/main">
               <a:ext uri="{FF2B5EF4-FFF2-40B4-BE49-F238E27FC236}">
-                <a16:creationId xmlns:a16="http://schemas.microsoft.com/office/drawing/2014/main" id="{3D8B442C-E381-471C-82ED-A15D6E67CD32}"/>
+                <a16:creationId xmlns:a16="http://schemas.microsoft.com/office/drawing/2014/main" id="{F688F629-9E0D-45E4-BC03-98AB91275E32}"/>
               </a:ext>
             </a:extLst>
           </p:cNvPr>
@@ -4736,7 +4766,7 @@
           <p:cNvPr id="9" name="">
             <a:extLst xmlns:a="http://schemas.openxmlformats.org/drawingml/2006/main">
               <a:ext uri="{FF2B5EF4-FFF2-40B4-BE49-F238E27FC236}">
-                <a16:creationId xmlns:a16="http://schemas.microsoft.com/office/drawing/2014/main" id="{1197EE3B-4D3B-44D5-89C2-56177BDDA995}"/>
+                <a16:creationId xmlns:a16="http://schemas.microsoft.com/office/drawing/2014/main" id="{095E2480-B5E9-44FF-BA5D-707ED98590C0}"/>
               </a:ext>
             </a:extLst>
           </p:cNvPr>
@@ -4794,7 +4824,7 @@
                 <a:ea typeface="Arial"/>
                 <a:cs typeface="Arial"/>
               </a:rPr>
-              <a:t>Вакансия hh</a:t>
+              <a:t>Доступ к данным</a:t>
             </a:r>
           </a:p>
         </p:txBody>
@@ -4804,7 +4834,7 @@
           <p:cNvPr id="10" name="">
             <a:extLst xmlns:a="http://schemas.openxmlformats.org/drawingml/2006/main">
               <a:ext uri="{FF2B5EF4-FFF2-40B4-BE49-F238E27FC236}">
-                <a16:creationId xmlns:a16="http://schemas.microsoft.com/office/drawing/2014/main" id="{9C98CDF9-77A3-4E5D-8586-15B419EF1099}"/>
+                <a16:creationId xmlns:a16="http://schemas.microsoft.com/office/drawing/2014/main" id="{21AF3D37-D292-4EC4-BDB0-DB5D76BC3D26}"/>
               </a:ext>
             </a:extLst>
           </p:cNvPr>
@@ -4862,7 +4892,7 @@
                 <a:ea typeface="Arial"/>
                 <a:cs typeface="Arial"/>
               </a:rPr>
-              <a:t>Включить навыки, настроить критерии и вопросы</a:t>
+              <a:t>Проверить получение результатов приложением Skillaz</a:t>
             </a:r>
           </a:p>
         </p:txBody>
@@ -4872,7 +4902,7 @@
           <p:cNvPr id="11" name="">
             <a:extLst xmlns:a="http://schemas.openxmlformats.org/drawingml/2006/main">
               <a:ext uri="{FF2B5EF4-FFF2-40B4-BE49-F238E27FC236}">
-                <a16:creationId xmlns:a16="http://schemas.microsoft.com/office/drawing/2014/main" id="{1A00DF37-D240-4320-9E9E-9F7C7643571B}"/>
+                <a16:creationId xmlns:a16="http://schemas.microsoft.com/office/drawing/2014/main" id="{24C8413C-AA37-4AC4-A42A-6D42A5D38911}"/>
               </a:ext>
             </a:extLst>
           </p:cNvPr>
@@ -4940,7 +4970,7 @@
           <p:cNvPr id="12" name="">
             <a:extLst xmlns:a="http://schemas.openxmlformats.org/drawingml/2006/main">
               <a:ext uri="{FF2B5EF4-FFF2-40B4-BE49-F238E27FC236}">
-                <a16:creationId xmlns:a16="http://schemas.microsoft.com/office/drawing/2014/main" id="{E6D0D820-A2B9-4B43-B90E-392D4D487A33}"/>
+                <a16:creationId xmlns:a16="http://schemas.microsoft.com/office/drawing/2014/main" id="{C6D058F7-B198-455C-8E57-FFD12B93E8C0}"/>
               </a:ext>
             </a:extLst>
           </p:cNvPr>
@@ -4998,7 +5028,7 @@
                 <a:ea typeface="Arial"/>
                 <a:cs typeface="Arial"/>
               </a:rPr>
-              <a:t>Новый отклик</a:t>
+              <a:t>Сравнение</a:t>
             </a:r>
           </a:p>
         </p:txBody>
@@ -5008,7 +5038,7 @@
           <p:cNvPr id="13" name="">
             <a:extLst xmlns:a="http://schemas.openxmlformats.org/drawingml/2006/main">
               <a:ext uri="{FF2B5EF4-FFF2-40B4-BE49-F238E27FC236}">
-                <a16:creationId xmlns:a16="http://schemas.microsoft.com/office/drawing/2014/main" id="{68B60299-3F69-4BCD-98C0-438C93ABAAFB}"/>
+                <a16:creationId xmlns:a16="http://schemas.microsoft.com/office/drawing/2014/main" id="{6ECBF438-77FD-46B4-9F84-BA6194601E15}"/>
               </a:ext>
             </a:extLst>
           </p:cNvPr>
@@ -5066,7 +5096,7 @@
                 <a:ea typeface="Arial"/>
                 <a:cs typeface="Arial"/>
               </a:rPr>
-              <a:t>Получить разбор и ответы кандидата в hh</a:t>
+              <a:t>Работа в hh и с теми же результатами в Skillaz</a:t>
             </a:r>
           </a:p>
         </p:txBody>
@@ -5076,7 +5106,7 @@
           <p:cNvPr id="14" name="">
             <a:extLst xmlns:a="http://schemas.openxmlformats.org/drawingml/2006/main">
               <a:ext uri="{FF2B5EF4-FFF2-40B4-BE49-F238E27FC236}">
-                <a16:creationId xmlns:a16="http://schemas.microsoft.com/office/drawing/2014/main" id="{5CE370A7-D86A-42E9-9A3A-4F24F97B395C}"/>
+                <a16:creationId xmlns:a16="http://schemas.microsoft.com/office/drawing/2014/main" id="{C35CEF6A-7F70-4FAB-A643-919AB768D470}"/>
               </a:ext>
             </a:extLst>
           </p:cNvPr>
@@ -5144,7 +5174,7 @@
           <p:cNvPr id="15" name="">
             <a:extLst xmlns:a="http://schemas.openxmlformats.org/drawingml/2006/main">
               <a:ext uri="{FF2B5EF4-FFF2-40B4-BE49-F238E27FC236}">
-                <a16:creationId xmlns:a16="http://schemas.microsoft.com/office/drawing/2014/main" id="{71D725FB-7C62-4081-9D17-01EEA9AABAAA}"/>
+                <a16:creationId xmlns:a16="http://schemas.microsoft.com/office/drawing/2014/main" id="{E815B137-CCAC-43B9-B3AD-E1D7D9574955}"/>
               </a:ext>
             </a:extLst>
           </p:cNvPr>
@@ -5202,7 +5232,7 @@
                 <a:ea typeface="Arial"/>
                 <a:cs typeface="Arial"/>
               </a:rPr>
-              <a:t>Запрос API</a:t>
+              <a:t>Замеры</a:t>
             </a:r>
           </a:p>
         </p:txBody>
@@ -5212,7 +5242,7 @@
           <p:cNvPr id="16" name="">
             <a:extLst xmlns:a="http://schemas.openxmlformats.org/drawingml/2006/main">
               <a:ext uri="{FF2B5EF4-FFF2-40B4-BE49-F238E27FC236}">
-                <a16:creationId xmlns:a16="http://schemas.microsoft.com/office/drawing/2014/main" id="{04CC4CD7-FB43-421C-9163-3C2A00A7ACAC}"/>
+                <a16:creationId xmlns:a16="http://schemas.microsoft.com/office/drawing/2014/main" id="{CECD4F8A-9188-4C41-8B48-7200639D7383}"/>
               </a:ext>
             </a:extLst>
           </p:cNvPr>
@@ -5270,7 +5300,7 @@
                 <a:ea typeface="Arial"/>
                 <a:cs typeface="Arial"/>
               </a:rPr>
-              <a:t>Проверить данные от имени приложения Skillaz</a:t>
+              <a:t>Время просмотра, переходы и ручной перенос</a:t>
             </a:r>
           </a:p>
         </p:txBody>
@@ -5280,7 +5310,7 @@
           <p:cNvPr id="17" name="">
             <a:extLst xmlns:a="http://schemas.openxmlformats.org/drawingml/2006/main">
               <a:ext uri="{FF2B5EF4-FFF2-40B4-BE49-F238E27FC236}">
-                <a16:creationId xmlns:a16="http://schemas.microsoft.com/office/drawing/2014/main" id="{C24C1CD4-4D6E-4858-8A34-19B5B12915B0}"/>
+                <a16:creationId xmlns:a16="http://schemas.microsoft.com/office/drawing/2014/main" id="{2298ECF2-8E1C-4FBC-AF74-3520A787DB46}"/>
               </a:ext>
             </a:extLst>
           </p:cNvPr>
@@ -5348,7 +5378,7 @@
           <p:cNvPr id="18" name="">
             <a:extLst xmlns:a="http://schemas.openxmlformats.org/drawingml/2006/main">
               <a:ext uri="{FF2B5EF4-FFF2-40B4-BE49-F238E27FC236}">
-                <a16:creationId xmlns:a16="http://schemas.microsoft.com/office/drawing/2014/main" id="{8A4E396B-4727-426B-BE7B-3B88DFD1CB02}"/>
+                <a16:creationId xmlns:a16="http://schemas.microsoft.com/office/drawing/2014/main" id="{602AFF02-781E-4533-91AB-80F086C17F07}"/>
               </a:ext>
             </a:extLst>
           </p:cNvPr>
@@ -5406,7 +5436,7 @@
                 <a:ea typeface="Arial"/>
                 <a:cs typeface="Arial"/>
               </a:rPr>
-              <a:t>Результат</a:t>
+              <a:t>Оценка пользы</a:t>
             </a:r>
           </a:p>
         </p:txBody>
@@ -5416,7 +5446,7 @@
           <p:cNvPr id="19" name="">
             <a:extLst xmlns:a="http://schemas.openxmlformats.org/drawingml/2006/main">
               <a:ext uri="{FF2B5EF4-FFF2-40B4-BE49-F238E27FC236}">
-                <a16:creationId xmlns:a16="http://schemas.microsoft.com/office/drawing/2014/main" id="{38A6D686-95BA-451D-8863-DC8AE36477E5}"/>
+                <a16:creationId xmlns:a16="http://schemas.microsoft.com/office/drawing/2014/main" id="{FB181EAA-9059-4CD9-8804-297651FCBCB5}"/>
               </a:ext>
             </a:extLst>
           </p:cNvPr>
@@ -5474,7 +5504,7 @@
                 <a:ea typeface="Arial"/>
                 <a:cs typeface="Arial"/>
               </a:rPr>
-              <a:t>Подтвердить состав данных и доступ клиента</a:t>
+              <a:t>Учесть проверку ИИ и отзывы рекрутеров</a:t>
             </a:r>
           </a:p>
         </p:txBody>
@@ -5484,7 +5514,7 @@
           <p:cNvPr id="20" name="">
             <a:extLst xmlns:a="http://schemas.openxmlformats.org/drawingml/2006/main">
               <a:ext uri="{FF2B5EF4-FFF2-40B4-BE49-F238E27FC236}">
-                <a16:creationId xmlns:a16="http://schemas.microsoft.com/office/drawing/2014/main" id="{D9DD6C78-AF14-4BCC-ADE5-75D4FAACE7A5}"/>
+                <a16:creationId xmlns:a16="http://schemas.microsoft.com/office/drawing/2014/main" id="{7ABCC267-1DFC-4962-BD10-E142CC563D54}"/>
               </a:ext>
             </a:extLst>
           </p:cNvPr>
@@ -5542,7 +5572,7 @@
                 <a:ea typeface="Arial"/>
                 <a:cs typeface="Arial"/>
               </a:rPr>
-              <a:t>Реализацию и предложение клиенту фиксируем после технической проверки</a:t>
+              <a:t>Экономию времени и затрат определяем по пилоту, заранее не обещаем</a:t>
             </a:r>
           </a:p>
         </p:txBody>
@@ -5550,7 +5580,7 @@
     </p:spTree>
     <p:extLst>
       <p:ext uri="{BB962C8B-B14F-4D97-AF65-F5344CB8AC3E}">
-        <p14:creationId xmlns:p14="http://schemas.microsoft.com/office/powerpoint/2010/main" val="1525273103"/>
+        <p14:creationId xmlns:p14="http://schemas.microsoft.com/office/powerpoint/2010/main" val="1489886624"/>
       </p:ext>
     </p:extLst>
   </p:cSld>
@@ -5581,7 +5611,7 @@
           <p:cNvPr id="15" name="">
             <a:extLst xmlns:a="http://schemas.openxmlformats.org/drawingml/2006/main">
               <a:ext uri="{FF2B5EF4-FFF2-40B4-BE49-F238E27FC236}">
-                <a16:creationId xmlns:a16="http://schemas.microsoft.com/office/drawing/2014/main" id="{CE760BF7-674D-4133-A9AB-74B95F18CBD7}"/>
+                <a16:creationId xmlns:a16="http://schemas.microsoft.com/office/drawing/2014/main" id="{D6608279-43C6-4CB6-BD61-C9E6690637AD}"/>
               </a:ext>
             </a:extLst>
           </p:cNvPr>
@@ -5591,7 +5621,7 @@
           <p:nvPr/>
         </p:nvPicPr>
         <p:blipFill>
-          <a:blip xmlns:r="http://schemas.openxmlformats.org/officeDocument/2006/relationships" xmlns:a="http://schemas.openxmlformats.org/drawingml/2006/main" r:embed="R80bf39dc06034a91"/>
+          <a:blip xmlns:r="http://schemas.openxmlformats.org/officeDocument/2006/relationships" xmlns:a="http://schemas.openxmlformats.org/drawingml/2006/main" r:embed="Rdafd1c96a1d849ca"/>
           <a:stretch xmlns:a="http://schemas.openxmlformats.org/drawingml/2006/main"/>
         </p:blipFill>
         <p:spPr>
@@ -5609,7 +5639,7 @@
           <p:cNvPr id="2" name="">
             <a:extLst xmlns:a="http://schemas.openxmlformats.org/drawingml/2006/main">
               <a:ext uri="{FF2B5EF4-FFF2-40B4-BE49-F238E27FC236}">
-                <a16:creationId xmlns:a16="http://schemas.microsoft.com/office/drawing/2014/main" id="{7D21DD70-0297-49CC-B4E1-5B742BA73D1D}"/>
+                <a16:creationId xmlns:a16="http://schemas.microsoft.com/office/drawing/2014/main" id="{73CCD09F-8F94-469C-8E97-2C684F3B9114}"/>
               </a:ext>
             </a:extLst>
           </p:cNvPr>
@@ -5677,7 +5707,7 @@
           <p:cNvPr id="3" name="">
             <a:extLst xmlns:a="http://schemas.openxmlformats.org/drawingml/2006/main">
               <a:ext uri="{FF2B5EF4-FFF2-40B4-BE49-F238E27FC236}">
-                <a16:creationId xmlns:a16="http://schemas.microsoft.com/office/drawing/2014/main" id="{3B51626A-1967-449D-9BB2-660B49967060}"/>
+                <a16:creationId xmlns:a16="http://schemas.microsoft.com/office/drawing/2014/main" id="{F819E429-C167-44CD-9A55-CDD629296D16}"/>
               </a:ext>
             </a:extLst>
           </p:cNvPr>
@@ -5768,7 +5798,7 @@
           <p:cNvPr id="4" name="">
             <a:extLst xmlns:a="http://schemas.openxmlformats.org/drawingml/2006/main">
               <a:ext uri="{FF2B5EF4-FFF2-40B4-BE49-F238E27FC236}">
-                <a16:creationId xmlns:a16="http://schemas.microsoft.com/office/drawing/2014/main" id="{1C3C8EAC-C0EB-4F66-AF59-6539F62697A0}"/>
+                <a16:creationId xmlns:a16="http://schemas.microsoft.com/office/drawing/2014/main" id="{6EF920CD-CB2C-4D74-A21A-57B7A58850B8}"/>
               </a:ext>
             </a:extLst>
           </p:cNvPr>
@@ -5836,7 +5866,7 @@
           <p:cNvPr id="5" name="">
             <a:extLst xmlns:a="http://schemas.openxmlformats.org/drawingml/2006/main">
               <a:ext uri="{FF2B5EF4-FFF2-40B4-BE49-F238E27FC236}">
-                <a16:creationId xmlns:a16="http://schemas.microsoft.com/office/drawing/2014/main" id="{EE4CC3CB-E938-4DE9-B019-3FCC3C665CAE}"/>
+                <a16:creationId xmlns:a16="http://schemas.microsoft.com/office/drawing/2014/main" id="{4E45E8B9-362A-42E4-9A18-98DACE07D943}"/>
               </a:ext>
             </a:extLst>
           </p:cNvPr>
@@ -5904,7 +5934,7 @@
           <p:cNvPr id="6" name="">
             <a:extLst xmlns:a="http://schemas.openxmlformats.org/drawingml/2006/main">
               <a:ext uri="{FF2B5EF4-FFF2-40B4-BE49-F238E27FC236}">
-                <a16:creationId xmlns:a16="http://schemas.microsoft.com/office/drawing/2014/main" id="{72E52B6B-5ABB-4C4A-8C56-DA686753D788}"/>
+                <a16:creationId xmlns:a16="http://schemas.microsoft.com/office/drawing/2014/main" id="{80DC1DE0-ACCE-486A-A3F4-0E4F012E6362}"/>
               </a:ext>
             </a:extLst>
           </p:cNvPr>
@@ -5972,7 +6002,7 @@
           <p:cNvPr id="7" name="">
             <a:extLst xmlns:a="http://schemas.openxmlformats.org/drawingml/2006/main">
               <a:ext uri="{FF2B5EF4-FFF2-40B4-BE49-F238E27FC236}">
-                <a16:creationId xmlns:a16="http://schemas.microsoft.com/office/drawing/2014/main" id="{F4670BDE-5CD0-46AE-BFBD-D49D0EEAAF7D}"/>
+                <a16:creationId xmlns:a16="http://schemas.microsoft.com/office/drawing/2014/main" id="{50A4DFED-4C34-4ADB-A83D-7E5762AF584E}"/>
               </a:ext>
             </a:extLst>
           </p:cNvPr>
@@ -6040,7 +6070,7 @@
           <p:cNvPr id="8" name="">
             <a:extLst xmlns:a="http://schemas.openxmlformats.org/drawingml/2006/main">
               <a:ext uri="{FF2B5EF4-FFF2-40B4-BE49-F238E27FC236}">
-                <a16:creationId xmlns:a16="http://schemas.microsoft.com/office/drawing/2014/main" id="{FB38B1F6-15C5-4EE4-8E4F-DFB5B9A4BB64}"/>
+                <a16:creationId xmlns:a16="http://schemas.microsoft.com/office/drawing/2014/main" id="{BBC6DCA6-1246-4F1E-9F99-C2579E2FF4D0}"/>
               </a:ext>
             </a:extLst>
           </p:cNvPr>
@@ -6108,7 +6138,7 @@
           <p:cNvPr id="9" name="">
             <a:extLst xmlns:a="http://schemas.openxmlformats.org/drawingml/2006/main">
               <a:ext uri="{FF2B5EF4-FFF2-40B4-BE49-F238E27FC236}">
-                <a16:creationId xmlns:a16="http://schemas.microsoft.com/office/drawing/2014/main" id="{A37E3F91-030C-4870-B939-32145CB014C2}"/>
+                <a16:creationId xmlns:a16="http://schemas.microsoft.com/office/drawing/2014/main" id="{D6652E46-0553-479B-B62C-6E11C05B1251}"/>
               </a:ext>
             </a:extLst>
           </p:cNvPr>
@@ -6245,7 +6275,7 @@
           <p:cNvPr id="10" name="">
             <a:extLst xmlns:a="http://schemas.openxmlformats.org/drawingml/2006/main">
               <a:ext uri="{FF2B5EF4-FFF2-40B4-BE49-F238E27FC236}">
-                <a16:creationId xmlns:a16="http://schemas.microsoft.com/office/drawing/2014/main" id="{BDA33FF9-4D61-4118-81D3-0D36C186C6EB}"/>
+                <a16:creationId xmlns:a16="http://schemas.microsoft.com/office/drawing/2014/main" id="{F347DD9B-7DC6-42D7-8022-4FE8F0B2E230}"/>
               </a:ext>
             </a:extLst>
           </p:cNvPr>
@@ -6275,7 +6305,7 @@
           <p:cNvPr id="11" name="">
             <a:extLst xmlns:a="http://schemas.openxmlformats.org/drawingml/2006/main">
               <a:ext uri="{FF2B5EF4-FFF2-40B4-BE49-F238E27FC236}">
-                <a16:creationId xmlns:a16="http://schemas.microsoft.com/office/drawing/2014/main" id="{D4A56874-4E71-4A27-A9D8-0301E8CC67A3}"/>
+                <a16:creationId xmlns:a16="http://schemas.microsoft.com/office/drawing/2014/main" id="{61930F10-54EF-43B7-9C26-CFF28858026E}"/>
               </a:ext>
             </a:extLst>
           </p:cNvPr>
@@ -6343,7 +6373,7 @@
           <p:cNvPr id="12" name="">
             <a:extLst xmlns:a="http://schemas.openxmlformats.org/drawingml/2006/main">
               <a:ext uri="{FF2B5EF4-FFF2-40B4-BE49-F238E27FC236}">
-                <a16:creationId xmlns:a16="http://schemas.microsoft.com/office/drawing/2014/main" id="{54235AFA-7E4A-4741-830F-B216F0655DC4}"/>
+                <a16:creationId xmlns:a16="http://schemas.microsoft.com/office/drawing/2014/main" id="{D86C5156-2266-4325-BE28-E57D6B3EC26E}"/>
               </a:ext>
             </a:extLst>
           </p:cNvPr>
@@ -6411,7 +6441,7 @@
           <p:cNvPr id="13" name="">
             <a:extLst xmlns:a="http://schemas.openxmlformats.org/drawingml/2006/main">
               <a:ext uri="{FF2B5EF4-FFF2-40B4-BE49-F238E27FC236}">
-                <a16:creationId xmlns:a16="http://schemas.microsoft.com/office/drawing/2014/main" id="{4CF282B9-9A49-4500-9BD1-B164B2643123}"/>
+                <a16:creationId xmlns:a16="http://schemas.microsoft.com/office/drawing/2014/main" id="{4EAB2D3B-3E83-4AEA-938A-5E630F67296E}"/>
               </a:ext>
             </a:extLst>
           </p:cNvPr>
@@ -6525,7 +6555,7 @@
           <p:cNvPr id="14" name="">
             <a:extLst xmlns:a="http://schemas.openxmlformats.org/drawingml/2006/main">
               <a:ext uri="{FF2B5EF4-FFF2-40B4-BE49-F238E27FC236}">
-                <a16:creationId xmlns:a16="http://schemas.microsoft.com/office/drawing/2014/main" id="{91EE5588-AADD-4D3B-BFBD-48D003614C9D}"/>
+                <a16:creationId xmlns:a16="http://schemas.microsoft.com/office/drawing/2014/main" id="{AE268FDB-971A-4FEA-A718-6CF15C6D9E10}"/>
               </a:ext>
             </a:extLst>
           </p:cNvPr>
@@ -6591,7 +6621,7 @@
     </p:spTree>
     <p:extLst>
       <p:ext uri="{BB962C8B-B14F-4D97-AF65-F5344CB8AC3E}">
-        <p14:creationId xmlns:p14="http://schemas.microsoft.com/office/powerpoint/2010/main" val="1576083486"/>
+        <p14:creationId xmlns:p14="http://schemas.microsoft.com/office/powerpoint/2010/main" val="1754469295"/>
       </p:ext>
     </p:extLst>
   </p:cSld>
@@ -6622,7 +6652,7 @@
           <p:cNvPr id="9" name="">
             <a:extLst xmlns:a="http://schemas.openxmlformats.org/drawingml/2006/main">
               <a:ext uri="{FF2B5EF4-FFF2-40B4-BE49-F238E27FC236}">
-                <a16:creationId xmlns:a16="http://schemas.microsoft.com/office/drawing/2014/main" id="{926F48ED-9B46-416D-93D5-1349E40625CA}"/>
+                <a16:creationId xmlns:a16="http://schemas.microsoft.com/office/drawing/2014/main" id="{8289379E-13A7-4B48-B47F-13CB638AEB67}"/>
               </a:ext>
             </a:extLst>
           </p:cNvPr>
@@ -6632,7 +6662,7 @@
           <p:nvPr/>
         </p:nvPicPr>
         <p:blipFill>
-          <a:blip xmlns:r="http://schemas.openxmlformats.org/officeDocument/2006/relationships" xmlns:a="http://schemas.openxmlformats.org/drawingml/2006/main" r:embed="R13c59dc1a3064d37"/>
+          <a:blip xmlns:r="http://schemas.openxmlformats.org/officeDocument/2006/relationships" xmlns:a="http://schemas.openxmlformats.org/drawingml/2006/main" r:embed="R94754869789d47fc"/>
           <a:stretch xmlns:a="http://schemas.openxmlformats.org/drawingml/2006/main"/>
         </p:blipFill>
         <p:spPr>
@@ -6650,7 +6680,7 @@
           <p:cNvPr id="2" name="">
             <a:extLst xmlns:a="http://schemas.openxmlformats.org/drawingml/2006/main">
               <a:ext uri="{FF2B5EF4-FFF2-40B4-BE49-F238E27FC236}">
-                <a16:creationId xmlns:a16="http://schemas.microsoft.com/office/drawing/2014/main" id="{D94966B2-1011-4F24-A49D-34A40B465712}"/>
+                <a16:creationId xmlns:a16="http://schemas.microsoft.com/office/drawing/2014/main" id="{ADDA7939-131C-4334-B344-088C9AE8D7F7}"/>
               </a:ext>
             </a:extLst>
           </p:cNvPr>
@@ -6708,7 +6738,7 @@
                 <a:ea typeface="Courier New"/>
                 <a:cs typeface="Courier New"/>
               </a:rPr>
-              <a:t>РАЗДЕЛЕНИЕ ВОЗМОЖНОСТЕЙ</a:t>
+              <a:t>ПОЛЬЗА ДЛЯ РЕКРУТЕРА</a:t>
             </a:r>
           </a:p>
         </p:txBody>
@@ -6718,7 +6748,7 @@
           <p:cNvPr id="3" name="">
             <a:extLst xmlns:a="http://schemas.openxmlformats.org/drawingml/2006/main">
               <a:ext uri="{FF2B5EF4-FFF2-40B4-BE49-F238E27FC236}">
-                <a16:creationId xmlns:a16="http://schemas.microsoft.com/office/drawing/2014/main" id="{C369DCC5-8D5E-4144-A61B-A924785DDFE0}"/>
+                <a16:creationId xmlns:a16="http://schemas.microsoft.com/office/drawing/2014/main" id="{08680E2F-CBBA-405D-98F7-4F3CB29EFEA8}"/>
               </a:ext>
             </a:extLst>
           </p:cNvPr>
@@ -6776,30 +6806,7 @@
                 <a:ea typeface="Arial"/>
                 <a:cs typeface="Arial"/>
               </a:rPr>
-              <a:t>Результаты ИИ</a:t>
-            </a:r>
-          </a:p>
-          <a:p xmlns:a="http://schemas.openxmlformats.org/drawingml/2006/main">
-            <a:pPr>
-              <a:defRPr sz="3150" b="0">
-                <a:solidFill>
-                  <a:srgbClr val="101022"/>
-                </a:solidFill>
-                <a:latin typeface="Arial"/>
-                <a:ea typeface="Arial"/>
-                <a:cs typeface="Arial"/>
-              </a:defRPr>
-            </a:pPr>
-            <a:r>
-              <a:rPr sz="3150" b="0">
-                <a:solidFill>
-                  <a:srgbClr val="101022"/>
-                </a:solidFill>
-                <a:latin typeface="Arial"/>
-                <a:ea typeface="Arial"/>
-                <a:cs typeface="Arial"/>
-              </a:rPr>
-              <a:t>в документации API hh.ru</a:t>
+              <a:t>Что помогает в работе с откликами</a:t>
             </a:r>
           </a:p>
         </p:txBody>
@@ -6809,7 +6816,7 @@
           <p:cNvPr id="4" name="">
             <a:extLst xmlns:a="http://schemas.openxmlformats.org/drawingml/2006/main">
               <a:ext uri="{FF2B5EF4-FFF2-40B4-BE49-F238E27FC236}">
-                <a16:creationId xmlns:a16="http://schemas.microsoft.com/office/drawing/2014/main" id="{B227A6ED-0567-4E39-BDB3-C8C793BC0499}"/>
+                <a16:creationId xmlns:a16="http://schemas.microsoft.com/office/drawing/2014/main" id="{8F1321B6-9F60-4B76-80BA-777EB9360E68}"/>
               </a:ext>
             </a:extLst>
           </p:cNvPr>
@@ -6877,7 +6884,7 @@
           <p:cNvPr id="5" name="">
             <a:extLst xmlns:a="http://schemas.openxmlformats.org/drawingml/2006/main">
               <a:ext uri="{FF2B5EF4-FFF2-40B4-BE49-F238E27FC236}">
-                <a16:creationId xmlns:a16="http://schemas.microsoft.com/office/drawing/2014/main" id="{A8AC477F-37E2-4119-916D-1A4B8AAED2D4}"/>
+                <a16:creationId xmlns:a16="http://schemas.microsoft.com/office/drawing/2014/main" id="{A947B73B-5EE5-4985-B3FF-04BB363D3B03}"/>
               </a:ext>
             </a:extLst>
           </p:cNvPr>
@@ -6945,7 +6952,7 @@
           <p:cNvPr id="6" name="">
             <a:extLst xmlns:a="http://schemas.openxmlformats.org/drawingml/2006/main">
               <a:ext uri="{FF2B5EF4-FFF2-40B4-BE49-F238E27FC236}">
-                <a16:creationId xmlns:a16="http://schemas.microsoft.com/office/drawing/2014/main" id="{C4AB787B-ECA3-408C-BB79-8BA6B11DACCF}"/>
+                <a16:creationId xmlns:a16="http://schemas.microsoft.com/office/drawing/2014/main" id="{B178AA1C-6A70-48CA-B9B3-FDB582A8FE5B}"/>
               </a:ext>
             </a:extLst>
           </p:cNvPr>
@@ -7013,7 +7020,7 @@
           <p:cNvPr id="7" name="">
             <a:extLst xmlns:a="http://schemas.openxmlformats.org/drawingml/2006/main">
               <a:ext uri="{FF2B5EF4-FFF2-40B4-BE49-F238E27FC236}">
-                <a16:creationId xmlns:a16="http://schemas.microsoft.com/office/drawing/2014/main" id="{F2CB6615-A9B2-47C8-9C0D-E9A9F0549341}"/>
+                <a16:creationId xmlns:a16="http://schemas.microsoft.com/office/drawing/2014/main" id="{63CC5310-2F98-4EB3-BF0C-3A1F878320A4}"/>
               </a:ext>
             </a:extLst>
           </p:cNvPr>
@@ -7047,7 +7054,7 @@
                           <a:ea typeface="Arial"/>
                           <a:cs typeface="Arial"/>
                         </a:rPr>
-                        <a:t>Результат работы ИИ</a:t>
+                        <a:t>Данные hh</a:t>
                       </a:r>
                     </a:p>
                   </a:txBody>
@@ -7095,7 +7102,7 @@
                           <a:ea typeface="Arial"/>
                           <a:cs typeface="Arial"/>
                         </a:rPr>
-                        <a:t>Данные в примере ответа API</a:t>
+                        <a:t>Практическая польза</a:t>
                       </a:r>
                     </a:p>
                   </a:txBody>
@@ -7139,7 +7146,7 @@
                           <a:ea typeface="Arial"/>
                           <a:cs typeface="Arial"/>
                         </a:rPr>
-                        <a:t>Итог разбора</a:t>
+                        <a:t>Итоговая оценка и сводка</a:t>
                       </a:r>
                     </a:p>
                   </a:txBody>
@@ -7181,7 +7188,7 @@
                           <a:ea typeface="Arial"/>
                           <a:cs typeface="Arial"/>
                         </a:rPr>
-                        <a:t>Решение ИИ и краткая сводка</a:t>
+                        <a:t>Выбрать порядок просмотра откликов</a:t>
                       </a:r>
                     </a:p>
                   </a:txBody>
@@ -7261,7 +7268,7 @@
                           <a:ea typeface="Arial"/>
                           <a:cs typeface="Arial"/>
                         </a:rPr>
-                        <a:t>Критерии и степень выполнения</a:t>
+                        <a:t>Найти факты по критериям вакансии</a:t>
                       </a:r>
                     </a:p>
                   </a:txBody>
@@ -7299,7 +7306,7 @@
                           <a:ea typeface="Arial"/>
                           <a:cs typeface="Arial"/>
                         </a:rPr>
-                        <a:t>Основания оценки</a:t>
+                        <a:t>Объяснение и источник</a:t>
                       </a:r>
                     </a:p>
                   </a:txBody>
@@ -7341,7 +7348,7 @@
                           <a:ea typeface="Arial"/>
                           <a:cs typeface="Arial"/>
                         </a:rPr>
-                        <a:t>Объяснение и источник информации</a:t>
+                        <a:t>Проверить основания вывода ИИ</a:t>
                       </a:r>
                     </a:p>
                   </a:txBody>
@@ -7379,7 +7386,7 @@
                           <a:ea typeface="Arial"/>
                           <a:cs typeface="Arial"/>
                         </a:rPr>
-                        <a:t>Ответы кандидата</a:t>
+                        <a:t>Вопросы и ответы кандидата</a:t>
                       </a:r>
                     </a:p>
                   </a:txBody>
@@ -7421,7 +7428,7 @@
                           <a:ea typeface="Arial"/>
                           <a:cs typeface="Arial"/>
                         </a:rPr>
-                        <a:t>Вопросы и цитаты ответов</a:t>
+                        <a:t>Подготовиться к первому разговору</a:t>
                       </a:r>
                     </a:p>
                   </a:txBody>
@@ -7453,7 +7460,7 @@
           <p:cNvPr id="8" name="">
             <a:extLst xmlns:a="http://schemas.openxmlformats.org/drawingml/2006/main">
               <a:ext uri="{FF2B5EF4-FFF2-40B4-BE49-F238E27FC236}">
-                <a16:creationId xmlns:a16="http://schemas.microsoft.com/office/drawing/2014/main" id="{A22F252B-AA10-4239-875C-DF469FB73762}"/>
+                <a16:creationId xmlns:a16="http://schemas.microsoft.com/office/drawing/2014/main" id="{68801BDA-484C-44D3-B2E7-C5994A756116}"/>
               </a:ext>
             </a:extLst>
           </p:cNvPr>
@@ -7511,7 +7518,7 @@
                 <a:ea typeface="Arial"/>
                 <a:cs typeface="Arial"/>
               </a:rPr>
-              <a:t>Публичный пример API описывает получение результатов ИИ.</a:t>
+              <a:t>Эти данные есть в примерах API hh. Итоговое решение принимает рекрутёр.</a:t>
             </a:r>
           </a:p>
         </p:txBody>
@@ -7519,7 +7526,7 @@
     </p:spTree>
     <p:extLst>
       <p:ext uri="{BB962C8B-B14F-4D97-AF65-F5344CB8AC3E}">
-        <p14:creationId xmlns:p14="http://schemas.microsoft.com/office/powerpoint/2010/main" val="1501322075"/>
+        <p14:creationId xmlns:p14="http://schemas.microsoft.com/office/powerpoint/2010/main" val="1838413515"/>
       </p:ext>
     </p:extLst>
   </p:cSld>
@@ -7550,7 +7557,7 @@
           <p:cNvPr id="19" name="">
             <a:extLst xmlns:a="http://schemas.openxmlformats.org/drawingml/2006/main">
               <a:ext uri="{FF2B5EF4-FFF2-40B4-BE49-F238E27FC236}">
-                <a16:creationId xmlns:a16="http://schemas.microsoft.com/office/drawing/2014/main" id="{140392D2-68B2-423B-9A38-EBD6FE148C08}"/>
+                <a16:creationId xmlns:a16="http://schemas.microsoft.com/office/drawing/2014/main" id="{78E7C96A-D9AA-4BBF-9DA4-877DAF36B5D4}"/>
               </a:ext>
             </a:extLst>
           </p:cNvPr>
@@ -7560,7 +7567,7 @@
           <p:nvPr/>
         </p:nvPicPr>
         <p:blipFill>
-          <a:blip xmlns:r="http://schemas.openxmlformats.org/officeDocument/2006/relationships" xmlns:a="http://schemas.openxmlformats.org/drawingml/2006/main" r:embed="Rfd933c2d2a624561"/>
+          <a:blip xmlns:r="http://schemas.openxmlformats.org/officeDocument/2006/relationships" xmlns:a="http://schemas.openxmlformats.org/drawingml/2006/main" r:embed="R5bed6b8873e24e64"/>
           <a:stretch xmlns:a="http://schemas.openxmlformats.org/drawingml/2006/main"/>
         </p:blipFill>
         <p:spPr>
@@ -7578,7 +7585,7 @@
           <p:cNvPr id="2" name="">
             <a:extLst xmlns:a="http://schemas.openxmlformats.org/drawingml/2006/main">
               <a:ext uri="{FF2B5EF4-FFF2-40B4-BE49-F238E27FC236}">
-                <a16:creationId xmlns:a16="http://schemas.microsoft.com/office/drawing/2014/main" id="{E69EBCD3-1E7E-4DBB-A79B-CBC792C7301B}"/>
+                <a16:creationId xmlns:a16="http://schemas.microsoft.com/office/drawing/2014/main" id="{C47C6162-868D-4F6E-BD3C-5C2E0FAF17E9}"/>
               </a:ext>
             </a:extLst>
           </p:cNvPr>
@@ -7646,7 +7653,7 @@
           <p:cNvPr id="3" name="">
             <a:extLst xmlns:a="http://schemas.openxmlformats.org/drawingml/2006/main">
               <a:ext uri="{FF2B5EF4-FFF2-40B4-BE49-F238E27FC236}">
-                <a16:creationId xmlns:a16="http://schemas.microsoft.com/office/drawing/2014/main" id="{3E2D5EFD-9DB1-4BE5-80DC-1327F3DA9579}"/>
+                <a16:creationId xmlns:a16="http://schemas.microsoft.com/office/drawing/2014/main" id="{EDC20335-DDAF-4211-AF9F-D032B954A290}"/>
               </a:ext>
             </a:extLst>
           </p:cNvPr>
@@ -7714,7 +7721,7 @@
           <p:cNvPr id="4" name="">
             <a:extLst xmlns:a="http://schemas.openxmlformats.org/drawingml/2006/main">
               <a:ext uri="{FF2B5EF4-FFF2-40B4-BE49-F238E27FC236}">
-                <a16:creationId xmlns:a16="http://schemas.microsoft.com/office/drawing/2014/main" id="{3F02E113-6B05-48FA-A50E-214FCFA75593}"/>
+                <a16:creationId xmlns:a16="http://schemas.microsoft.com/office/drawing/2014/main" id="{D2535C6A-E884-4935-BE05-F9A6BCEA7B9D}"/>
               </a:ext>
             </a:extLst>
           </p:cNvPr>
@@ -7782,7 +7789,7 @@
           <p:cNvPr id="5" name="">
             <a:extLst xmlns:a="http://schemas.openxmlformats.org/drawingml/2006/main">
               <a:ext uri="{FF2B5EF4-FFF2-40B4-BE49-F238E27FC236}">
-                <a16:creationId xmlns:a16="http://schemas.microsoft.com/office/drawing/2014/main" id="{3209732A-79F6-4C98-AE99-90C7FBD1957D}"/>
+                <a16:creationId xmlns:a16="http://schemas.microsoft.com/office/drawing/2014/main" id="{78B580AC-D6B5-4CCD-8D11-02465026A485}"/>
               </a:ext>
             </a:extLst>
           </p:cNvPr>
@@ -7850,7 +7857,7 @@
           <p:cNvPr id="6" name="">
             <a:extLst xmlns:a="http://schemas.openxmlformats.org/drawingml/2006/main">
               <a:ext uri="{FF2B5EF4-FFF2-40B4-BE49-F238E27FC236}">
-                <a16:creationId xmlns:a16="http://schemas.microsoft.com/office/drawing/2014/main" id="{F9192DA1-DBF1-4644-ACBE-AE87DDAE80BE}"/>
+                <a16:creationId xmlns:a16="http://schemas.microsoft.com/office/drawing/2014/main" id="{F97CBCA5-0C3E-4236-9211-87D381F18DCD}"/>
               </a:ext>
             </a:extLst>
           </p:cNvPr>
@@ -7918,7 +7925,7 @@
           <p:cNvPr id="7" name="">
             <a:extLst xmlns:a="http://schemas.openxmlformats.org/drawingml/2006/main">
               <a:ext uri="{FF2B5EF4-FFF2-40B4-BE49-F238E27FC236}">
-                <a16:creationId xmlns:a16="http://schemas.microsoft.com/office/drawing/2014/main" id="{83301FC0-8359-4E2A-B633-F70FC217D4EB}"/>
+                <a16:creationId xmlns:a16="http://schemas.microsoft.com/office/drawing/2014/main" id="{1ACB0F18-7B6C-4DB5-9F30-155AFCA83376}"/>
               </a:ext>
             </a:extLst>
           </p:cNvPr>
@@ -7986,7 +7993,7 @@
           <p:cNvPr id="8" name="">
             <a:extLst xmlns:a="http://schemas.openxmlformats.org/drawingml/2006/main">
               <a:ext uri="{FF2B5EF4-FFF2-40B4-BE49-F238E27FC236}">
-                <a16:creationId xmlns:a16="http://schemas.microsoft.com/office/drawing/2014/main" id="{B0613F79-84AA-4251-AD2C-BCAB7F5063FB}"/>
+                <a16:creationId xmlns:a16="http://schemas.microsoft.com/office/drawing/2014/main" id="{04D50199-CCA4-4ED8-8D29-EEC2AC2613BF}"/>
               </a:ext>
             </a:extLst>
           </p:cNvPr>
@@ -8054,7 +8061,7 @@
           <p:cNvPr id="9" name="">
             <a:extLst xmlns:a="http://schemas.openxmlformats.org/drawingml/2006/main">
               <a:ext uri="{FF2B5EF4-FFF2-40B4-BE49-F238E27FC236}">
-                <a16:creationId xmlns:a16="http://schemas.microsoft.com/office/drawing/2014/main" id="{170F559D-4311-47F5-88FC-9C8FAF71357C}"/>
+                <a16:creationId xmlns:a16="http://schemas.microsoft.com/office/drawing/2014/main" id="{C95A6ECD-BF8F-4AE5-BEC8-0110E669CF01}"/>
               </a:ext>
             </a:extLst>
           </p:cNvPr>
@@ -8122,7 +8129,7 @@
           <p:cNvPr id="10" name="">
             <a:extLst xmlns:a="http://schemas.openxmlformats.org/drawingml/2006/main">
               <a:ext uri="{FF2B5EF4-FFF2-40B4-BE49-F238E27FC236}">
-                <a16:creationId xmlns:a16="http://schemas.microsoft.com/office/drawing/2014/main" id="{07AC0D07-5C5C-464F-B8F5-CC809DDB73F8}"/>
+                <a16:creationId xmlns:a16="http://schemas.microsoft.com/office/drawing/2014/main" id="{5B1AE02E-5CFB-4B52-9C8E-01D4AD8D1669}"/>
               </a:ext>
             </a:extLst>
           </p:cNvPr>
@@ -8190,7 +8197,7 @@
           <p:cNvPr id="11" name="">
             <a:extLst xmlns:a="http://schemas.openxmlformats.org/drawingml/2006/main">
               <a:ext uri="{FF2B5EF4-FFF2-40B4-BE49-F238E27FC236}">
-                <a16:creationId xmlns:a16="http://schemas.microsoft.com/office/drawing/2014/main" id="{BACEBD3D-521A-47AD-8B9A-EE5C9258B724}"/>
+                <a16:creationId xmlns:a16="http://schemas.microsoft.com/office/drawing/2014/main" id="{69ACF678-C27D-411B-AC5D-26089B774C3D}"/>
               </a:ext>
             </a:extLst>
           </p:cNvPr>
@@ -8258,7 +8265,7 @@
           <p:cNvPr id="12" name="">
             <a:extLst xmlns:a="http://schemas.openxmlformats.org/drawingml/2006/main">
               <a:ext uri="{FF2B5EF4-FFF2-40B4-BE49-F238E27FC236}">
-                <a16:creationId xmlns:a16="http://schemas.microsoft.com/office/drawing/2014/main" id="{0657862D-B315-4ACC-B8E1-1FB592EC61B3}"/>
+                <a16:creationId xmlns:a16="http://schemas.microsoft.com/office/drawing/2014/main" id="{79623FCA-E387-4AF3-ADEE-C5326D0A71EB}"/>
               </a:ext>
             </a:extLst>
           </p:cNvPr>
@@ -8326,7 +8333,7 @@
           <p:cNvPr id="13" name="">
             <a:extLst xmlns:a="http://schemas.openxmlformats.org/drawingml/2006/main">
               <a:ext uri="{FF2B5EF4-FFF2-40B4-BE49-F238E27FC236}">
-                <a16:creationId xmlns:a16="http://schemas.microsoft.com/office/drawing/2014/main" id="{3B7615A8-4311-49E2-A964-9A939BFAEC2B}"/>
+                <a16:creationId xmlns:a16="http://schemas.microsoft.com/office/drawing/2014/main" id="{C7ABABD4-1924-4D96-AB66-4ADE00C3B3DE}"/>
               </a:ext>
             </a:extLst>
           </p:cNvPr>
@@ -8394,7 +8401,7 @@
           <p:cNvPr id="14" name="">
             <a:extLst xmlns:a="http://schemas.openxmlformats.org/drawingml/2006/main">
               <a:ext uri="{FF2B5EF4-FFF2-40B4-BE49-F238E27FC236}">
-                <a16:creationId xmlns:a16="http://schemas.microsoft.com/office/drawing/2014/main" id="{9AEA0063-2187-479F-8526-769DED955369}"/>
+                <a16:creationId xmlns:a16="http://schemas.microsoft.com/office/drawing/2014/main" id="{B6959F6C-BEE9-474A-8D99-9ADDA6CAABD3}"/>
               </a:ext>
             </a:extLst>
           </p:cNvPr>
@@ -8462,7 +8469,7 @@
           <p:cNvPr id="15" name="">
             <a:extLst xmlns:a="http://schemas.openxmlformats.org/drawingml/2006/main">
               <a:ext uri="{FF2B5EF4-FFF2-40B4-BE49-F238E27FC236}">
-                <a16:creationId xmlns:a16="http://schemas.microsoft.com/office/drawing/2014/main" id="{E29BEE41-EF7C-4481-8433-0670D0CEBB8B}"/>
+                <a16:creationId xmlns:a16="http://schemas.microsoft.com/office/drawing/2014/main" id="{06CD7634-AF06-4BC6-95CE-88874AEC3B15}"/>
               </a:ext>
             </a:extLst>
           </p:cNvPr>
@@ -8530,7 +8537,7 @@
           <p:cNvPr id="16" name="">
             <a:extLst xmlns:a="http://schemas.openxmlformats.org/drawingml/2006/main">
               <a:ext uri="{FF2B5EF4-FFF2-40B4-BE49-F238E27FC236}">
-                <a16:creationId xmlns:a16="http://schemas.microsoft.com/office/drawing/2014/main" id="{E69B8012-25CC-4772-B57E-C70FD544D541}"/>
+                <a16:creationId xmlns:a16="http://schemas.microsoft.com/office/drawing/2014/main" id="{9DA55254-4921-4F4E-8831-4FB632E50034}"/>
               </a:ext>
             </a:extLst>
           </p:cNvPr>
@@ -8598,7 +8605,7 @@
           <p:cNvPr id="17" name="">
             <a:extLst xmlns:a="http://schemas.openxmlformats.org/drawingml/2006/main">
               <a:ext uri="{FF2B5EF4-FFF2-40B4-BE49-F238E27FC236}">
-                <a16:creationId xmlns:a16="http://schemas.microsoft.com/office/drawing/2014/main" id="{F820ABC7-41CD-45E1-8531-EFB76C19BF99}"/>
+                <a16:creationId xmlns:a16="http://schemas.microsoft.com/office/drawing/2014/main" id="{01991F30-5A49-40EE-A5DD-0DC9DD58D6C3}"/>
               </a:ext>
             </a:extLst>
           </p:cNvPr>
@@ -8666,7 +8673,7 @@
           <p:cNvPr id="18" name="">
             <a:extLst xmlns:a="http://schemas.openxmlformats.org/drawingml/2006/main">
               <a:ext uri="{FF2B5EF4-FFF2-40B4-BE49-F238E27FC236}">
-                <a16:creationId xmlns:a16="http://schemas.microsoft.com/office/drawing/2014/main" id="{5256BB3D-9784-4A7C-92C5-8A2C1CF1D772}"/>
+                <a16:creationId xmlns:a16="http://schemas.microsoft.com/office/drawing/2014/main" id="{3FA73D55-3041-4E33-A660-8B5D23B8EFD4}"/>
               </a:ext>
             </a:extLst>
           </p:cNvPr>
@@ -8732,7 +8739,7 @@
     </p:spTree>
     <p:extLst>
       <p:ext uri="{BB962C8B-B14F-4D97-AF65-F5344CB8AC3E}">
-        <p14:creationId xmlns:p14="http://schemas.microsoft.com/office/powerpoint/2010/main" val="734259294"/>
+        <p14:creationId xmlns:p14="http://schemas.microsoft.com/office/powerpoint/2010/main" val="752945491"/>
       </p:ext>
     </p:extLst>
   </p:cSld>
@@ -8763,7 +8770,7 @@
           <p:cNvPr id="13" name="">
             <a:extLst xmlns:a="http://schemas.openxmlformats.org/drawingml/2006/main">
               <a:ext uri="{FF2B5EF4-FFF2-40B4-BE49-F238E27FC236}">
-                <a16:creationId xmlns:a16="http://schemas.microsoft.com/office/drawing/2014/main" id="{30A1FB6B-AF57-476C-A658-4F4D1583AFFE}"/>
+                <a16:creationId xmlns:a16="http://schemas.microsoft.com/office/drawing/2014/main" id="{6B0EB4E5-F547-46CC-B1D4-8B30BB4513CA}"/>
               </a:ext>
             </a:extLst>
           </p:cNvPr>
@@ -8773,7 +8780,7 @@
           <p:nvPr/>
         </p:nvPicPr>
         <p:blipFill>
-          <a:blip xmlns:r="http://schemas.openxmlformats.org/officeDocument/2006/relationships" xmlns:a="http://schemas.openxmlformats.org/drawingml/2006/main" r:embed="R79faf7169d5c480c"/>
+          <a:blip xmlns:r="http://schemas.openxmlformats.org/officeDocument/2006/relationships" xmlns:a="http://schemas.openxmlformats.org/drawingml/2006/main" r:embed="R92da2a13db934269"/>
           <a:stretch xmlns:a="http://schemas.openxmlformats.org/drawingml/2006/main"/>
         </p:blipFill>
         <p:spPr>
@@ -8791,7 +8798,7 @@
           <p:cNvPr id="2" name="">
             <a:extLst xmlns:a="http://schemas.openxmlformats.org/drawingml/2006/main">
               <a:ext uri="{FF2B5EF4-FFF2-40B4-BE49-F238E27FC236}">
-                <a16:creationId xmlns:a16="http://schemas.microsoft.com/office/drawing/2014/main" id="{B094FF00-66C7-4B49-99F5-26F0C47C6AEE}"/>
+                <a16:creationId xmlns:a16="http://schemas.microsoft.com/office/drawing/2014/main" id="{29783AED-B0C5-4276-AB1F-A11094029306}"/>
               </a:ext>
             </a:extLst>
           </p:cNvPr>
@@ -8859,7 +8866,7 @@
           <p:cNvPr id="3" name="">
             <a:extLst xmlns:a="http://schemas.openxmlformats.org/drawingml/2006/main">
               <a:ext uri="{FF2B5EF4-FFF2-40B4-BE49-F238E27FC236}">
-                <a16:creationId xmlns:a16="http://schemas.microsoft.com/office/drawing/2014/main" id="{A15F0D60-D646-4257-A86C-7ABDA54D71E4}"/>
+                <a16:creationId xmlns:a16="http://schemas.microsoft.com/office/drawing/2014/main" id="{725625C2-F261-4DE8-82F6-2C9AAB9DDA09}"/>
               </a:ext>
             </a:extLst>
           </p:cNvPr>
@@ -8917,7 +8924,7 @@
                 <a:ea typeface="Arial"/>
                 <a:cs typeface="Arial"/>
               </a:rPr>
-              <a:t>Результат разбора и его основания</a:t>
+              <a:t>С чего начать просмотр откликов</a:t>
             </a:r>
           </a:p>
         </p:txBody>
@@ -8927,7 +8934,7 @@
           <p:cNvPr id="4" name="">
             <a:extLst xmlns:a="http://schemas.openxmlformats.org/drawingml/2006/main">
               <a:ext uri="{FF2B5EF4-FFF2-40B4-BE49-F238E27FC236}">
-                <a16:creationId xmlns:a16="http://schemas.microsoft.com/office/drawing/2014/main" id="{42A97936-22E1-4D5D-AE11-A78062226DAC}"/>
+                <a16:creationId xmlns:a16="http://schemas.microsoft.com/office/drawing/2014/main" id="{FE8E8FC8-D713-48CA-B9D7-8393AF2A87BD}"/>
               </a:ext>
             </a:extLst>
           </p:cNvPr>
@@ -8995,7 +9002,7 @@
           <p:cNvPr id="5" name="">
             <a:extLst xmlns:a="http://schemas.openxmlformats.org/drawingml/2006/main">
               <a:ext uri="{FF2B5EF4-FFF2-40B4-BE49-F238E27FC236}">
-                <a16:creationId xmlns:a16="http://schemas.microsoft.com/office/drawing/2014/main" id="{79938F41-70D8-46BF-9ED4-CE3F88739A70}"/>
+                <a16:creationId xmlns:a16="http://schemas.microsoft.com/office/drawing/2014/main" id="{39A73EDF-E672-457D-A336-05D40BF9D95B}"/>
               </a:ext>
             </a:extLst>
           </p:cNvPr>
@@ -9063,7 +9070,7 @@
           <p:cNvPr id="6" name="">
             <a:extLst xmlns:a="http://schemas.openxmlformats.org/drawingml/2006/main">
               <a:ext uri="{FF2B5EF4-FFF2-40B4-BE49-F238E27FC236}">
-                <a16:creationId xmlns:a16="http://schemas.microsoft.com/office/drawing/2014/main" id="{5EB08DC3-0D6A-4E21-826C-8F439BD67001}"/>
+                <a16:creationId xmlns:a16="http://schemas.microsoft.com/office/drawing/2014/main" id="{35C8ADB1-7ED1-49BB-84BC-D13E9FBE8CD4}"/>
               </a:ext>
             </a:extLst>
           </p:cNvPr>
@@ -9131,7 +9138,7 @@
           <p:cNvPr id="7" name="">
             <a:extLst xmlns:a="http://schemas.openxmlformats.org/drawingml/2006/main">
               <a:ext uri="{FF2B5EF4-FFF2-40B4-BE49-F238E27FC236}">
-                <a16:creationId xmlns:a16="http://schemas.microsoft.com/office/drawing/2014/main" id="{900F6602-A5B4-42C1-99E5-AB01A4FD9D9A}"/>
+                <a16:creationId xmlns:a16="http://schemas.microsoft.com/office/drawing/2014/main" id="{0D851B08-AA49-4EF3-B866-BCC1509762B7}"/>
               </a:ext>
             </a:extLst>
           </p:cNvPr>
@@ -9141,7 +9148,7 @@
           <p:nvPr/>
         </p:nvPicPr>
         <p:blipFill>
-          <a:blip xmlns:r="http://schemas.openxmlformats.org/officeDocument/2006/relationships" xmlns:a="http://schemas.openxmlformats.org/drawingml/2006/main" r:embed="Ra7d2b6b6b1eb4ac4"/>
+          <a:blip xmlns:r="http://schemas.openxmlformats.org/officeDocument/2006/relationships" xmlns:a="http://schemas.openxmlformats.org/drawingml/2006/main" r:embed="R12e604c484324d3a"/>
           <a:stretch xmlns:a="http://schemas.openxmlformats.org/drawingml/2006/main"/>
         </p:blipFill>
         <p:spPr>
@@ -9159,7 +9166,7 @@
           <p:cNvPr id="8" name="">
             <a:extLst xmlns:a="http://schemas.openxmlformats.org/drawingml/2006/main">
               <a:ext uri="{FF2B5EF4-FFF2-40B4-BE49-F238E27FC236}">
-                <a16:creationId xmlns:a16="http://schemas.microsoft.com/office/drawing/2014/main" id="{1101C651-852F-48F3-AAEB-9939422C1E15}"/>
+                <a16:creationId xmlns:a16="http://schemas.microsoft.com/office/drawing/2014/main" id="{1099C897-8998-47C0-B97F-D930AA7F6604}"/>
               </a:ext>
             </a:extLst>
           </p:cNvPr>
@@ -9227,7 +9234,7 @@
           <p:cNvPr id="9" name="">
             <a:extLst xmlns:a="http://schemas.openxmlformats.org/drawingml/2006/main">
               <a:ext uri="{FF2B5EF4-FFF2-40B4-BE49-F238E27FC236}">
-                <a16:creationId xmlns:a16="http://schemas.microsoft.com/office/drawing/2014/main" id="{4504939D-E214-44D7-BCB2-0194E2C758ED}"/>
+                <a16:creationId xmlns:a16="http://schemas.microsoft.com/office/drawing/2014/main" id="{BDBA1B88-C9B4-4888-A22A-194967B2CAA0}"/>
               </a:ext>
             </a:extLst>
           </p:cNvPr>
@@ -9318,7 +9325,7 @@
           <p:cNvPr id="10" name="">
             <a:extLst xmlns:a="http://schemas.openxmlformats.org/drawingml/2006/main">
               <a:ext uri="{FF2B5EF4-FFF2-40B4-BE49-F238E27FC236}">
-                <a16:creationId xmlns:a16="http://schemas.microsoft.com/office/drawing/2014/main" id="{3FD9DF71-FA55-48EC-B844-0444BD02A630}"/>
+                <a16:creationId xmlns:a16="http://schemas.microsoft.com/office/drawing/2014/main" id="{E84EDC03-F5A9-4621-A8C3-4AB32FCE72F3}"/>
               </a:ext>
             </a:extLst>
           </p:cNvPr>
@@ -9386,7 +9393,7 @@
           <p:cNvPr id="11" name="">
             <a:extLst xmlns:a="http://schemas.openxmlformats.org/drawingml/2006/main">
               <a:ext uri="{FF2B5EF4-FFF2-40B4-BE49-F238E27FC236}">
-                <a16:creationId xmlns:a16="http://schemas.microsoft.com/office/drawing/2014/main" id="{D996EA50-DFFC-4671-9020-82EACDD69BCD}"/>
+                <a16:creationId xmlns:a16="http://schemas.microsoft.com/office/drawing/2014/main" id="{AA18868A-6538-4448-BD3C-26DF055077EF}"/>
               </a:ext>
             </a:extLst>
           </p:cNvPr>
@@ -9477,7 +9484,7 @@
           <p:cNvPr id="12" name="">
             <a:extLst xmlns:a="http://schemas.openxmlformats.org/drawingml/2006/main">
               <a:ext uri="{FF2B5EF4-FFF2-40B4-BE49-F238E27FC236}">
-                <a16:creationId xmlns:a16="http://schemas.microsoft.com/office/drawing/2014/main" id="{0A26B467-BBDB-47CE-B852-AEFF373433C1}"/>
+                <a16:creationId xmlns:a16="http://schemas.microsoft.com/office/drawing/2014/main" id="{A9D8F903-3057-490A-BFAC-08F69DC3FD2A}"/>
               </a:ext>
             </a:extLst>
           </p:cNvPr>
@@ -9543,7 +9550,7 @@
     </p:spTree>
     <p:extLst>
       <p:ext uri="{BB962C8B-B14F-4D97-AF65-F5344CB8AC3E}">
-        <p14:creationId xmlns:p14="http://schemas.microsoft.com/office/powerpoint/2010/main" val="133301226"/>
+        <p14:creationId xmlns:p14="http://schemas.microsoft.com/office/powerpoint/2010/main" val="970819568"/>
       </p:ext>
     </p:extLst>
   </p:cSld>
@@ -9574,7 +9581,7 @@
           <p:cNvPr id="18" name="">
             <a:extLst xmlns:a="http://schemas.openxmlformats.org/drawingml/2006/main">
               <a:ext uri="{FF2B5EF4-FFF2-40B4-BE49-F238E27FC236}">
-                <a16:creationId xmlns:a16="http://schemas.microsoft.com/office/drawing/2014/main" id="{E43B0131-FA7E-48DA-8E3F-9A13E1C24AB7}"/>
+                <a16:creationId xmlns:a16="http://schemas.microsoft.com/office/drawing/2014/main" id="{06DBBBBF-C042-478E-A369-EDEE06D95709}"/>
               </a:ext>
             </a:extLst>
           </p:cNvPr>
@@ -9584,7 +9591,7 @@
           <p:nvPr/>
         </p:nvPicPr>
         <p:blipFill>
-          <a:blip xmlns:r="http://schemas.openxmlformats.org/officeDocument/2006/relationships" xmlns:a="http://schemas.openxmlformats.org/drawingml/2006/main" r:embed="R0b6e3a6e5aca418d"/>
+          <a:blip xmlns:r="http://schemas.openxmlformats.org/officeDocument/2006/relationships" xmlns:a="http://schemas.openxmlformats.org/drawingml/2006/main" r:embed="Rbf340f85b8e44ee4"/>
           <a:stretch xmlns:a="http://schemas.openxmlformats.org/drawingml/2006/main"/>
         </p:blipFill>
         <p:spPr>
@@ -9602,7 +9609,7 @@
           <p:cNvPr id="2" name="">
             <a:extLst xmlns:a="http://schemas.openxmlformats.org/drawingml/2006/main">
               <a:ext uri="{FF2B5EF4-FFF2-40B4-BE49-F238E27FC236}">
-                <a16:creationId xmlns:a16="http://schemas.microsoft.com/office/drawing/2014/main" id="{E23FC8B4-2004-449B-9431-22CFA6E32A81}"/>
+                <a16:creationId xmlns:a16="http://schemas.microsoft.com/office/drawing/2014/main" id="{F57388CE-7005-4FEB-9F0A-E45CFF58D0D8}"/>
               </a:ext>
             </a:extLst>
           </p:cNvPr>
@@ -9670,7 +9677,7 @@
           <p:cNvPr id="3" name="">
             <a:extLst xmlns:a="http://schemas.openxmlformats.org/drawingml/2006/main">
               <a:ext uri="{FF2B5EF4-FFF2-40B4-BE49-F238E27FC236}">
-                <a16:creationId xmlns:a16="http://schemas.microsoft.com/office/drawing/2014/main" id="{0F05A1E5-CC7E-4876-A660-7A82F7E96F94}"/>
+                <a16:creationId xmlns:a16="http://schemas.microsoft.com/office/drawing/2014/main" id="{51305F8D-4826-4EFB-AC2C-B800C1BF9924}"/>
               </a:ext>
             </a:extLst>
           </p:cNvPr>
@@ -9738,7 +9745,7 @@
           <p:cNvPr id="4" name="">
             <a:extLst xmlns:a="http://schemas.openxmlformats.org/drawingml/2006/main">
               <a:ext uri="{FF2B5EF4-FFF2-40B4-BE49-F238E27FC236}">
-                <a16:creationId xmlns:a16="http://schemas.microsoft.com/office/drawing/2014/main" id="{F73299EE-4011-4731-8155-A55C7C5C0404}"/>
+                <a16:creationId xmlns:a16="http://schemas.microsoft.com/office/drawing/2014/main" id="{23703EB1-5DC6-442B-9769-1BF59462E50C}"/>
               </a:ext>
             </a:extLst>
           </p:cNvPr>
@@ -9806,7 +9813,7 @@
           <p:cNvPr id="5" name="">
             <a:extLst xmlns:a="http://schemas.openxmlformats.org/drawingml/2006/main">
               <a:ext uri="{FF2B5EF4-FFF2-40B4-BE49-F238E27FC236}">
-                <a16:creationId xmlns:a16="http://schemas.microsoft.com/office/drawing/2014/main" id="{1CB8C294-4DB6-4E1F-989A-D6B657190D91}"/>
+                <a16:creationId xmlns:a16="http://schemas.microsoft.com/office/drawing/2014/main" id="{FBD35989-BE7F-48A7-98DA-6F1C8C525A0D}"/>
               </a:ext>
             </a:extLst>
           </p:cNvPr>
@@ -9874,7 +9881,7 @@
           <p:cNvPr id="6" name="">
             <a:extLst xmlns:a="http://schemas.openxmlformats.org/drawingml/2006/main">
               <a:ext uri="{FF2B5EF4-FFF2-40B4-BE49-F238E27FC236}">
-                <a16:creationId xmlns:a16="http://schemas.microsoft.com/office/drawing/2014/main" id="{79E699A6-158D-4F9E-B512-ED03A55588F8}"/>
+                <a16:creationId xmlns:a16="http://schemas.microsoft.com/office/drawing/2014/main" id="{EECA520F-183F-46AD-B952-C1C3481A7D93}"/>
               </a:ext>
             </a:extLst>
           </p:cNvPr>
@@ -9942,7 +9949,7 @@
           <p:cNvPr id="7" name="">
             <a:extLst xmlns:a="http://schemas.openxmlformats.org/drawingml/2006/main">
               <a:ext uri="{FF2B5EF4-FFF2-40B4-BE49-F238E27FC236}">
-                <a16:creationId xmlns:a16="http://schemas.microsoft.com/office/drawing/2014/main" id="{AAC15428-BAA9-48B8-AE55-EE6329CD1D30}"/>
+                <a16:creationId xmlns:a16="http://schemas.microsoft.com/office/drawing/2014/main" id="{A67A94EB-D7CC-495B-9BDE-36199FB57730}"/>
               </a:ext>
             </a:extLst>
           </p:cNvPr>
@@ -10010,7 +10017,7 @@
           <p:cNvPr id="8" name="">
             <a:extLst xmlns:a="http://schemas.openxmlformats.org/drawingml/2006/main">
               <a:ext uri="{FF2B5EF4-FFF2-40B4-BE49-F238E27FC236}">
-                <a16:creationId xmlns:a16="http://schemas.microsoft.com/office/drawing/2014/main" id="{3047964D-9C24-424C-9FCB-23CAE4FCA914}"/>
+                <a16:creationId xmlns:a16="http://schemas.microsoft.com/office/drawing/2014/main" id="{23809C0E-B319-452C-B525-84D651EEFAB4}"/>
               </a:ext>
             </a:extLst>
           </p:cNvPr>
@@ -10040,7 +10047,7 @@
           <p:cNvPr id="9" name="">
             <a:extLst xmlns:a="http://schemas.openxmlformats.org/drawingml/2006/main">
               <a:ext uri="{FF2B5EF4-FFF2-40B4-BE49-F238E27FC236}">
-                <a16:creationId xmlns:a16="http://schemas.microsoft.com/office/drawing/2014/main" id="{1CCB6922-75C9-4D9F-B334-DA15CBCC154A}"/>
+                <a16:creationId xmlns:a16="http://schemas.microsoft.com/office/drawing/2014/main" id="{799A1395-FA41-438A-AB13-86F1FD7D9AB0}"/>
               </a:ext>
             </a:extLst>
           </p:cNvPr>
@@ -10154,7 +10161,7 @@
           <p:cNvPr id="10" name="">
             <a:extLst xmlns:a="http://schemas.openxmlformats.org/drawingml/2006/main">
               <a:ext uri="{FF2B5EF4-FFF2-40B4-BE49-F238E27FC236}">
-                <a16:creationId xmlns:a16="http://schemas.microsoft.com/office/drawing/2014/main" id="{8C0E1DAE-4E60-435C-A2A3-99F16FD75567}"/>
+                <a16:creationId xmlns:a16="http://schemas.microsoft.com/office/drawing/2014/main" id="{CD199F9C-21C8-4C1D-8666-D79B338415D3}"/>
               </a:ext>
             </a:extLst>
           </p:cNvPr>
@@ -10222,7 +10229,7 @@
           <p:cNvPr id="11" name="">
             <a:extLst xmlns:a="http://schemas.openxmlformats.org/drawingml/2006/main">
               <a:ext uri="{FF2B5EF4-FFF2-40B4-BE49-F238E27FC236}">
-                <a16:creationId xmlns:a16="http://schemas.microsoft.com/office/drawing/2014/main" id="{F961BAE9-AECA-4F85-AE79-D8062261B5C2}"/>
+                <a16:creationId xmlns:a16="http://schemas.microsoft.com/office/drawing/2014/main" id="{7BE24F13-59FE-4E5E-8227-616246F6660F}"/>
               </a:ext>
             </a:extLst>
           </p:cNvPr>
@@ -10252,7 +10259,7 @@
           <p:cNvPr id="12" name="">
             <a:extLst xmlns:a="http://schemas.openxmlformats.org/drawingml/2006/main">
               <a:ext uri="{FF2B5EF4-FFF2-40B4-BE49-F238E27FC236}">
-                <a16:creationId xmlns:a16="http://schemas.microsoft.com/office/drawing/2014/main" id="{C2885B28-9ABA-4C5F-B93B-A2CAB14790CA}"/>
+                <a16:creationId xmlns:a16="http://schemas.microsoft.com/office/drawing/2014/main" id="{2AB1BB72-34D7-4623-AFB1-9D82F77D2714}"/>
               </a:ext>
             </a:extLst>
           </p:cNvPr>
@@ -10366,7 +10373,7 @@
           <p:cNvPr id="13" name="">
             <a:extLst xmlns:a="http://schemas.openxmlformats.org/drawingml/2006/main">
               <a:ext uri="{FF2B5EF4-FFF2-40B4-BE49-F238E27FC236}">
-                <a16:creationId xmlns:a16="http://schemas.microsoft.com/office/drawing/2014/main" id="{949D0560-0C63-43F9-A7CC-64BBAF131BD2}"/>
+                <a16:creationId xmlns:a16="http://schemas.microsoft.com/office/drawing/2014/main" id="{AB0F574F-B916-4D58-B2DE-4DFEB2985374}"/>
               </a:ext>
             </a:extLst>
           </p:cNvPr>
@@ -10434,7 +10441,7 @@
           <p:cNvPr id="14" name="">
             <a:extLst xmlns:a="http://schemas.openxmlformats.org/drawingml/2006/main">
               <a:ext uri="{FF2B5EF4-FFF2-40B4-BE49-F238E27FC236}">
-                <a16:creationId xmlns:a16="http://schemas.microsoft.com/office/drawing/2014/main" id="{12B8D1DB-BFAA-41D6-931D-88524C43A846}"/>
+                <a16:creationId xmlns:a16="http://schemas.microsoft.com/office/drawing/2014/main" id="{80D1A6C1-F1CD-45DA-8FCC-0CCA6BBB6587}"/>
               </a:ext>
             </a:extLst>
           </p:cNvPr>
@@ -10464,7 +10471,7 @@
           <p:cNvPr id="15" name="">
             <a:extLst xmlns:a="http://schemas.openxmlformats.org/drawingml/2006/main">
               <a:ext uri="{FF2B5EF4-FFF2-40B4-BE49-F238E27FC236}">
-                <a16:creationId xmlns:a16="http://schemas.microsoft.com/office/drawing/2014/main" id="{99120E9B-34C0-4FCD-A0AB-E8DA50D06E47}"/>
+                <a16:creationId xmlns:a16="http://schemas.microsoft.com/office/drawing/2014/main" id="{8F09813B-FE5E-4A1E-B030-13B1956EF734}"/>
               </a:ext>
             </a:extLst>
           </p:cNvPr>
@@ -10578,7 +10585,7 @@
           <p:cNvPr id="16" name="">
             <a:extLst xmlns:a="http://schemas.openxmlformats.org/drawingml/2006/main">
               <a:ext uri="{FF2B5EF4-FFF2-40B4-BE49-F238E27FC236}">
-                <a16:creationId xmlns:a16="http://schemas.microsoft.com/office/drawing/2014/main" id="{B9A0BD4E-CFA5-4710-8BA8-EC408017CBA1}"/>
+                <a16:creationId xmlns:a16="http://schemas.microsoft.com/office/drawing/2014/main" id="{CB160F8C-7BE5-4DCD-99BD-25485F36BE02}"/>
               </a:ext>
             </a:extLst>
           </p:cNvPr>
@@ -10646,7 +10653,7 @@
           <p:cNvPr id="17" name="">
             <a:extLst xmlns:a="http://schemas.openxmlformats.org/drawingml/2006/main">
               <a:ext uri="{FF2B5EF4-FFF2-40B4-BE49-F238E27FC236}">
-                <a16:creationId xmlns:a16="http://schemas.microsoft.com/office/drawing/2014/main" id="{820FD8C6-35C9-4BAB-A619-FD140D72D575}"/>
+                <a16:creationId xmlns:a16="http://schemas.microsoft.com/office/drawing/2014/main" id="{9D593F45-A91A-47A6-8C4D-7AE08D0F1C87}"/>
               </a:ext>
             </a:extLst>
           </p:cNvPr>
@@ -10712,7 +10719,7 @@
     </p:spTree>
     <p:extLst>
       <p:ext uri="{BB962C8B-B14F-4D97-AF65-F5344CB8AC3E}">
-        <p14:creationId xmlns:p14="http://schemas.microsoft.com/office/powerpoint/2010/main" val="475000416"/>
+        <p14:creationId xmlns:p14="http://schemas.microsoft.com/office/powerpoint/2010/main" val="308833806"/>
       </p:ext>
     </p:extLst>
   </p:cSld>
@@ -10743,7 +10750,7 @@
           <p:cNvPr id="17" name="">
             <a:extLst xmlns:a="http://schemas.openxmlformats.org/drawingml/2006/main">
               <a:ext uri="{FF2B5EF4-FFF2-40B4-BE49-F238E27FC236}">
-                <a16:creationId xmlns:a16="http://schemas.microsoft.com/office/drawing/2014/main" id="{578E9196-94F0-451B-93EF-69EE8F5689FD}"/>
+                <a16:creationId xmlns:a16="http://schemas.microsoft.com/office/drawing/2014/main" id="{632B0893-43DE-4DA3-BEAB-109761C3AF52}"/>
               </a:ext>
             </a:extLst>
           </p:cNvPr>
@@ -10753,7 +10760,7 @@
           <p:nvPr/>
         </p:nvPicPr>
         <p:blipFill>
-          <a:blip xmlns:r="http://schemas.openxmlformats.org/officeDocument/2006/relationships" xmlns:a="http://schemas.openxmlformats.org/drawingml/2006/main" r:embed="R24c216d00ce54a2a"/>
+          <a:blip xmlns:r="http://schemas.openxmlformats.org/officeDocument/2006/relationships" xmlns:a="http://schemas.openxmlformats.org/drawingml/2006/main" r:embed="R4b852417b5404e3d"/>
           <a:stretch xmlns:a="http://schemas.openxmlformats.org/drawingml/2006/main"/>
         </p:blipFill>
         <p:spPr>
@@ -10771,7 +10778,7 @@
           <p:cNvPr id="2" name="">
             <a:extLst xmlns:a="http://schemas.openxmlformats.org/drawingml/2006/main">
               <a:ext uri="{FF2B5EF4-FFF2-40B4-BE49-F238E27FC236}">
-                <a16:creationId xmlns:a16="http://schemas.microsoft.com/office/drawing/2014/main" id="{E7E5BCA6-32AE-4C6F-8CB1-A9D8D0AB8FE5}"/>
+                <a16:creationId xmlns:a16="http://schemas.microsoft.com/office/drawing/2014/main" id="{6DC8825F-A36F-4D1B-8617-4AD95E0A2D90}"/>
               </a:ext>
             </a:extLst>
           </p:cNvPr>
@@ -10839,7 +10846,7 @@
           <p:cNvPr id="3" name="">
             <a:extLst xmlns:a="http://schemas.openxmlformats.org/drawingml/2006/main">
               <a:ext uri="{FF2B5EF4-FFF2-40B4-BE49-F238E27FC236}">
-                <a16:creationId xmlns:a16="http://schemas.microsoft.com/office/drawing/2014/main" id="{27A2E4D2-C9EF-4A03-9325-2598039EEA0B}"/>
+                <a16:creationId xmlns:a16="http://schemas.microsoft.com/office/drawing/2014/main" id="{ED0D2348-3A61-49A2-9C55-B363B17C567B}"/>
               </a:ext>
             </a:extLst>
           </p:cNvPr>
@@ -10897,7 +10904,7 @@
                 <a:ea typeface="Arial"/>
                 <a:cs typeface="Arial"/>
               </a:rPr>
-              <a:t>Что объясняет оценку кандидата</a:t>
+              <a:t>На чём основана оценка кандидата</a:t>
             </a:r>
           </a:p>
         </p:txBody>
@@ -10907,7 +10914,7 @@
           <p:cNvPr id="4" name="">
             <a:extLst xmlns:a="http://schemas.openxmlformats.org/drawingml/2006/main">
               <a:ext uri="{FF2B5EF4-FFF2-40B4-BE49-F238E27FC236}">
-                <a16:creationId xmlns:a16="http://schemas.microsoft.com/office/drawing/2014/main" id="{D0F0C91C-1ABA-4F46-94E1-963BE7A52462}"/>
+                <a16:creationId xmlns:a16="http://schemas.microsoft.com/office/drawing/2014/main" id="{32E70627-1FFF-4F74-82CE-75EB390C02D8}"/>
               </a:ext>
             </a:extLst>
           </p:cNvPr>
@@ -10975,7 +10982,7 @@
           <p:cNvPr id="5" name="">
             <a:extLst xmlns:a="http://schemas.openxmlformats.org/drawingml/2006/main">
               <a:ext uri="{FF2B5EF4-FFF2-40B4-BE49-F238E27FC236}">
-                <a16:creationId xmlns:a16="http://schemas.microsoft.com/office/drawing/2014/main" id="{C4D1136D-432F-4DAD-8081-C3670B34AC5F}"/>
+                <a16:creationId xmlns:a16="http://schemas.microsoft.com/office/drawing/2014/main" id="{EA98141E-C13B-4866-A851-9908A2751C5B}"/>
               </a:ext>
             </a:extLst>
           </p:cNvPr>
@@ -11043,7 +11050,7 @@
           <p:cNvPr id="6" name="">
             <a:extLst xmlns:a="http://schemas.openxmlformats.org/drawingml/2006/main">
               <a:ext uri="{FF2B5EF4-FFF2-40B4-BE49-F238E27FC236}">
-                <a16:creationId xmlns:a16="http://schemas.microsoft.com/office/drawing/2014/main" id="{9DE65E15-F6B0-4FDB-A11A-5A2402375E29}"/>
+                <a16:creationId xmlns:a16="http://schemas.microsoft.com/office/drawing/2014/main" id="{BEA89BDB-196B-42E4-A1F5-CB531BA370FA}"/>
               </a:ext>
             </a:extLst>
           </p:cNvPr>
@@ -11111,7 +11118,7 @@
           <p:cNvPr id="7" name="">
             <a:extLst xmlns:a="http://schemas.openxmlformats.org/drawingml/2006/main">
               <a:ext uri="{FF2B5EF4-FFF2-40B4-BE49-F238E27FC236}">
-                <a16:creationId xmlns:a16="http://schemas.microsoft.com/office/drawing/2014/main" id="{9EDB76DA-72E0-4C4D-90B8-70A6D971814A}"/>
+                <a16:creationId xmlns:a16="http://schemas.microsoft.com/office/drawing/2014/main" id="{BDCCF07D-A2BB-467A-B53C-20B5184DCDCB}"/>
               </a:ext>
             </a:extLst>
           </p:cNvPr>
@@ -11121,7 +11128,7 @@
           <p:nvPr/>
         </p:nvPicPr>
         <p:blipFill>
-          <a:blip xmlns:r="http://schemas.openxmlformats.org/officeDocument/2006/relationships" xmlns:a="http://schemas.openxmlformats.org/drawingml/2006/main" r:embed="Rbe77fbbef33d441d"/>
+          <a:blip xmlns:r="http://schemas.openxmlformats.org/officeDocument/2006/relationships" xmlns:a="http://schemas.openxmlformats.org/drawingml/2006/main" r:embed="R02f1cde46f614665"/>
           <a:stretch xmlns:a="http://schemas.openxmlformats.org/drawingml/2006/main"/>
         </p:blipFill>
         <p:spPr>
@@ -11139,7 +11146,7 @@
           <p:cNvPr id="8" name="">
             <a:extLst xmlns:a="http://schemas.openxmlformats.org/drawingml/2006/main">
               <a:ext uri="{FF2B5EF4-FFF2-40B4-BE49-F238E27FC236}">
-                <a16:creationId xmlns:a16="http://schemas.microsoft.com/office/drawing/2014/main" id="{5A0E89E7-44A2-4D08-9D4F-534C1870BFD3}"/>
+                <a16:creationId xmlns:a16="http://schemas.microsoft.com/office/drawing/2014/main" id="{E7588643-611A-4B8D-A325-759D8147764E}"/>
               </a:ext>
             </a:extLst>
           </p:cNvPr>
@@ -11207,7 +11214,7 @@
           <p:cNvPr id="9" name="">
             <a:extLst xmlns:a="http://schemas.openxmlformats.org/drawingml/2006/main">
               <a:ext uri="{FF2B5EF4-FFF2-40B4-BE49-F238E27FC236}">
-                <a16:creationId xmlns:a16="http://schemas.microsoft.com/office/drawing/2014/main" id="{C23A3737-F9DB-47FE-9D68-F852D5708BD5}"/>
+                <a16:creationId xmlns:a16="http://schemas.microsoft.com/office/drawing/2014/main" id="{9A50EE64-19C7-41EE-8ADD-A4B4D1D0B2F0}"/>
               </a:ext>
             </a:extLst>
           </p:cNvPr>
@@ -11298,7 +11305,7 @@
           <p:cNvPr id="10" name="">
             <a:extLst xmlns:a="http://schemas.openxmlformats.org/drawingml/2006/main">
               <a:ext uri="{FF2B5EF4-FFF2-40B4-BE49-F238E27FC236}">
-                <a16:creationId xmlns:a16="http://schemas.microsoft.com/office/drawing/2014/main" id="{09284687-410D-4B6F-9AFC-87A0AAC067FA}"/>
+                <a16:creationId xmlns:a16="http://schemas.microsoft.com/office/drawing/2014/main" id="{CF75BB9D-774A-41CB-9EFB-ADB32015FFB7}"/>
               </a:ext>
             </a:extLst>
           </p:cNvPr>
@@ -11366,7 +11373,7 @@
           <p:cNvPr id="11" name="">
             <a:extLst xmlns:a="http://schemas.openxmlformats.org/drawingml/2006/main">
               <a:ext uri="{FF2B5EF4-FFF2-40B4-BE49-F238E27FC236}">
-                <a16:creationId xmlns:a16="http://schemas.microsoft.com/office/drawing/2014/main" id="{D4CE3178-4DC2-4D70-84F8-F61B2043E7D4}"/>
+                <a16:creationId xmlns:a16="http://schemas.microsoft.com/office/drawing/2014/main" id="{F8CB845B-2648-4A70-8AAD-79FC997B15A0}"/>
               </a:ext>
             </a:extLst>
           </p:cNvPr>
@@ -11434,7 +11441,7 @@
           <p:cNvPr id="12" name="">
             <a:extLst xmlns:a="http://schemas.openxmlformats.org/drawingml/2006/main">
               <a:ext uri="{FF2B5EF4-FFF2-40B4-BE49-F238E27FC236}">
-                <a16:creationId xmlns:a16="http://schemas.microsoft.com/office/drawing/2014/main" id="{7D5EC4F8-C2C3-4685-9C1D-B44FFAC4F443}"/>
+                <a16:creationId xmlns:a16="http://schemas.microsoft.com/office/drawing/2014/main" id="{763F734C-F8F1-4C50-B0E7-722928176AAF}"/>
               </a:ext>
             </a:extLst>
           </p:cNvPr>
@@ -11502,7 +11509,7 @@
           <p:cNvPr id="13" name="">
             <a:extLst xmlns:a="http://schemas.openxmlformats.org/drawingml/2006/main">
               <a:ext uri="{FF2B5EF4-FFF2-40B4-BE49-F238E27FC236}">
-                <a16:creationId xmlns:a16="http://schemas.microsoft.com/office/drawing/2014/main" id="{CBCD37F4-35B5-4B64-B1D7-D85B82D4A26F}"/>
+                <a16:creationId xmlns:a16="http://schemas.microsoft.com/office/drawing/2014/main" id="{C338A650-6D98-40A9-A2D1-01E3C0A73D08}"/>
               </a:ext>
             </a:extLst>
           </p:cNvPr>
@@ -11570,7 +11577,7 @@
           <p:cNvPr id="14" name="">
             <a:extLst xmlns:a="http://schemas.openxmlformats.org/drawingml/2006/main">
               <a:ext uri="{FF2B5EF4-FFF2-40B4-BE49-F238E27FC236}">
-                <a16:creationId xmlns:a16="http://schemas.microsoft.com/office/drawing/2014/main" id="{B608F23F-9371-4833-A0CB-68DA0BF93E94}"/>
+                <a16:creationId xmlns:a16="http://schemas.microsoft.com/office/drawing/2014/main" id="{3328D9DC-9978-4FE4-BC31-22073A68E982}"/>
               </a:ext>
             </a:extLst>
           </p:cNvPr>
@@ -11638,7 +11645,7 @@
           <p:cNvPr id="15" name="">
             <a:extLst xmlns:a="http://schemas.openxmlformats.org/drawingml/2006/main">
               <a:ext uri="{FF2B5EF4-FFF2-40B4-BE49-F238E27FC236}">
-                <a16:creationId xmlns:a16="http://schemas.microsoft.com/office/drawing/2014/main" id="{EC0CE4E4-4FE4-43E5-8E39-1A224F953110}"/>
+                <a16:creationId xmlns:a16="http://schemas.microsoft.com/office/drawing/2014/main" id="{6C92BB4B-E367-4CA2-B4CE-9C537A034E68}"/>
               </a:ext>
             </a:extLst>
           </p:cNvPr>
@@ -11706,7 +11713,7 @@
           <p:cNvPr id="16" name="">
             <a:extLst xmlns:a="http://schemas.openxmlformats.org/drawingml/2006/main">
               <a:ext uri="{FF2B5EF4-FFF2-40B4-BE49-F238E27FC236}">
-                <a16:creationId xmlns:a16="http://schemas.microsoft.com/office/drawing/2014/main" id="{1FD04717-FDA6-4DAB-A2BD-C7A808C85217}"/>
+                <a16:creationId xmlns:a16="http://schemas.microsoft.com/office/drawing/2014/main" id="{A21F33FC-041D-41C9-BFB1-D9AEB88D5583}"/>
               </a:ext>
             </a:extLst>
           </p:cNvPr>
@@ -11772,7 +11779,7 @@
     </p:spTree>
     <p:extLst>
       <p:ext uri="{BB962C8B-B14F-4D97-AF65-F5344CB8AC3E}">
-        <p14:creationId xmlns:p14="http://schemas.microsoft.com/office/powerpoint/2010/main" val="528331529"/>
+        <p14:creationId xmlns:p14="http://schemas.microsoft.com/office/powerpoint/2010/main" val="433236836"/>
       </p:ext>
     </p:extLst>
   </p:cSld>
@@ -11803,7 +11810,7 @@
           <p:cNvPr id="9" name="">
             <a:extLst xmlns:a="http://schemas.openxmlformats.org/drawingml/2006/main">
               <a:ext uri="{FF2B5EF4-FFF2-40B4-BE49-F238E27FC236}">
-                <a16:creationId xmlns:a16="http://schemas.microsoft.com/office/drawing/2014/main" id="{7883C52B-982D-4631-9AC0-EE2DD5E9E472}"/>
+                <a16:creationId xmlns:a16="http://schemas.microsoft.com/office/drawing/2014/main" id="{370BA55B-9926-4579-A52B-C76FC39311CB}"/>
               </a:ext>
             </a:extLst>
           </p:cNvPr>
@@ -11813,7 +11820,7 @@
           <p:nvPr/>
         </p:nvPicPr>
         <p:blipFill>
-          <a:blip xmlns:r="http://schemas.openxmlformats.org/officeDocument/2006/relationships" xmlns:a="http://schemas.openxmlformats.org/drawingml/2006/main" r:embed="Radafa393d8f94931"/>
+          <a:blip xmlns:r="http://schemas.openxmlformats.org/officeDocument/2006/relationships" xmlns:a="http://schemas.openxmlformats.org/drawingml/2006/main" r:embed="Rc6dc6cefb0684230"/>
           <a:stretch xmlns:a="http://schemas.openxmlformats.org/drawingml/2006/main"/>
         </p:blipFill>
         <p:spPr>
@@ -11831,7 +11838,7 @@
           <p:cNvPr id="2" name="">
             <a:extLst xmlns:a="http://schemas.openxmlformats.org/drawingml/2006/main">
               <a:ext uri="{FF2B5EF4-FFF2-40B4-BE49-F238E27FC236}">
-                <a16:creationId xmlns:a16="http://schemas.microsoft.com/office/drawing/2014/main" id="{70D7CE1E-8C4C-4B0F-9DCA-D866A6CA25F6}"/>
+                <a16:creationId xmlns:a16="http://schemas.microsoft.com/office/drawing/2014/main" id="{70B1366D-AAD2-4579-8DCE-4EC5091BC443}"/>
               </a:ext>
             </a:extLst>
           </p:cNvPr>
@@ -11899,7 +11906,7 @@
           <p:cNvPr id="3" name="">
             <a:extLst xmlns:a="http://schemas.openxmlformats.org/drawingml/2006/main">
               <a:ext uri="{FF2B5EF4-FFF2-40B4-BE49-F238E27FC236}">
-                <a16:creationId xmlns:a16="http://schemas.microsoft.com/office/drawing/2014/main" id="{6628B2ED-44C0-4CF9-A89E-A7BBD8B1AE55}"/>
+                <a16:creationId xmlns:a16="http://schemas.microsoft.com/office/drawing/2014/main" id="{AE1B6EE0-756B-41F2-8FFA-35ED4CF949C5}"/>
               </a:ext>
             </a:extLst>
           </p:cNvPr>
@@ -11967,7 +11974,7 @@
           <p:cNvPr id="4" name="">
             <a:extLst xmlns:a="http://schemas.openxmlformats.org/drawingml/2006/main">
               <a:ext uri="{FF2B5EF4-FFF2-40B4-BE49-F238E27FC236}">
-                <a16:creationId xmlns:a16="http://schemas.microsoft.com/office/drawing/2014/main" id="{140720BC-9A45-49DC-8D7D-F98ACC84A38F}"/>
+                <a16:creationId xmlns:a16="http://schemas.microsoft.com/office/drawing/2014/main" id="{6DEC5B3A-C511-4061-B2D9-24AA972752B8}"/>
               </a:ext>
             </a:extLst>
           </p:cNvPr>
@@ -12035,7 +12042,7 @@
           <p:cNvPr id="5" name="">
             <a:extLst xmlns:a="http://schemas.openxmlformats.org/drawingml/2006/main">
               <a:ext uri="{FF2B5EF4-FFF2-40B4-BE49-F238E27FC236}">
-                <a16:creationId xmlns:a16="http://schemas.microsoft.com/office/drawing/2014/main" id="{53F8E6D9-F77D-4680-92AE-53BD818DE2A4}"/>
+                <a16:creationId xmlns:a16="http://schemas.microsoft.com/office/drawing/2014/main" id="{388C8114-05DE-433C-8A7B-C9FE79CC3046}"/>
               </a:ext>
             </a:extLst>
           </p:cNvPr>
@@ -12103,7 +12110,7 @@
           <p:cNvPr id="6" name="">
             <a:extLst xmlns:a="http://schemas.openxmlformats.org/drawingml/2006/main">
               <a:ext uri="{FF2B5EF4-FFF2-40B4-BE49-F238E27FC236}">
-                <a16:creationId xmlns:a16="http://schemas.microsoft.com/office/drawing/2014/main" id="{CD934B1F-7F68-4F4C-82DF-4FDFB22156F8}"/>
+                <a16:creationId xmlns:a16="http://schemas.microsoft.com/office/drawing/2014/main" id="{A2C9249B-769F-4C7E-B073-AFF25A6DEEF2}"/>
               </a:ext>
             </a:extLst>
           </p:cNvPr>
@@ -12171,7 +12178,7 @@
           <p:cNvPr id="7" name="">
             <a:extLst xmlns:a="http://schemas.openxmlformats.org/drawingml/2006/main">
               <a:ext uri="{FF2B5EF4-FFF2-40B4-BE49-F238E27FC236}">
-                <a16:creationId xmlns:a16="http://schemas.microsoft.com/office/drawing/2014/main" id="{B7D30AC1-74AC-4E1B-B568-D4178502CF5D}"/>
+                <a16:creationId xmlns:a16="http://schemas.microsoft.com/office/drawing/2014/main" id="{1EE70617-F91C-4992-852E-E3962A2B922B}"/>
               </a:ext>
             </a:extLst>
           </p:cNvPr>
@@ -12239,7 +12246,7 @@
           <p:cNvPr id="8" name="">
             <a:extLst xmlns:a="http://schemas.openxmlformats.org/drawingml/2006/main">
               <a:ext uri="{FF2B5EF4-FFF2-40B4-BE49-F238E27FC236}">
-                <a16:creationId xmlns:a16="http://schemas.microsoft.com/office/drawing/2014/main" id="{53EE8414-813B-44C1-98CA-380E644706F3}"/>
+                <a16:creationId xmlns:a16="http://schemas.microsoft.com/office/drawing/2014/main" id="{A86E8926-062F-48D7-96ED-6AE27B962254}"/>
               </a:ext>
             </a:extLst>
           </p:cNvPr>
@@ -12980,7 +12987,7 @@
     </p:spTree>
     <p:extLst>
       <p:ext uri="{BB962C8B-B14F-4D97-AF65-F5344CB8AC3E}">
-        <p14:creationId xmlns:p14="http://schemas.microsoft.com/office/powerpoint/2010/main" val="1914722273"/>
+        <p14:creationId xmlns:p14="http://schemas.microsoft.com/office/powerpoint/2010/main" val="2005984503"/>
       </p:ext>
     </p:extLst>
   </p:cSld>
@@ -13008,10 +13015,10 @@
       </p:grpSpPr>
       <p:pic>
         <p:nvPicPr>
-          <p:cNvPr id="16" name="">
-            <a:extLst xmlns:a="http://schemas.openxmlformats.org/drawingml/2006/main">
-              <a:ext uri="{FF2B5EF4-FFF2-40B4-BE49-F238E27FC236}">
-                <a16:creationId xmlns:a16="http://schemas.microsoft.com/office/drawing/2014/main" id="{AD3C0AEB-FDEF-4835-9C9E-A65001055806}"/>
+          <p:cNvPr id="17" name="">
+            <a:extLst xmlns:a="http://schemas.openxmlformats.org/drawingml/2006/main">
+              <a:ext uri="{FF2B5EF4-FFF2-40B4-BE49-F238E27FC236}">
+                <a16:creationId xmlns:a16="http://schemas.microsoft.com/office/drawing/2014/main" id="{17889EC6-5A0F-427F-A302-D4C40963F61F}"/>
               </a:ext>
             </a:extLst>
           </p:cNvPr>
@@ -13021,7 +13028,7 @@
           <p:nvPr/>
         </p:nvPicPr>
         <p:blipFill>
-          <a:blip xmlns:r="http://schemas.openxmlformats.org/officeDocument/2006/relationships" xmlns:a="http://schemas.openxmlformats.org/drawingml/2006/main" r:embed="R7d944180a3c24e36"/>
+          <a:blip xmlns:r="http://schemas.openxmlformats.org/officeDocument/2006/relationships" xmlns:a="http://schemas.openxmlformats.org/drawingml/2006/main" r:embed="R16c6ade7cc8b4d27"/>
           <a:stretch xmlns:a="http://schemas.openxmlformats.org/drawingml/2006/main"/>
         </p:blipFill>
         <p:spPr>
@@ -13039,7 +13046,7 @@
           <p:cNvPr id="2" name="">
             <a:extLst xmlns:a="http://schemas.openxmlformats.org/drawingml/2006/main">
               <a:ext uri="{FF2B5EF4-FFF2-40B4-BE49-F238E27FC236}">
-                <a16:creationId xmlns:a16="http://schemas.microsoft.com/office/drawing/2014/main" id="{205FFBAB-2C2F-4D2D-BA95-4B42581A707C}"/>
+                <a16:creationId xmlns:a16="http://schemas.microsoft.com/office/drawing/2014/main" id="{DFAF97A6-F34D-4771-94EB-341231672381}"/>
               </a:ext>
             </a:extLst>
           </p:cNvPr>
@@ -13097,7 +13104,7 @@
                 <a:ea typeface="Courier New"/>
                 <a:cs typeface="Courier New"/>
               </a:rPr>
-              <a:t>БАЗОВЫЙ ВАРИАНТ</a:t>
+              <a:t>ЦЕННОСТЬ ИНТЕГРАЦИИ</a:t>
             </a:r>
           </a:p>
         </p:txBody>
@@ -13107,7 +13114,7 @@
           <p:cNvPr id="3" name="">
             <a:extLst xmlns:a="http://schemas.openxmlformats.org/drawingml/2006/main">
               <a:ext uri="{FF2B5EF4-FFF2-40B4-BE49-F238E27FC236}">
-                <a16:creationId xmlns:a16="http://schemas.microsoft.com/office/drawing/2014/main" id="{F87ECA64-03C7-40C1-A421-49D2168C7D15}"/>
+                <a16:creationId xmlns:a16="http://schemas.microsoft.com/office/drawing/2014/main" id="{79CC2824-C4B6-4968-AEB9-CFB0080943D9}"/>
               </a:ext>
             </a:extLst>
           </p:cNvPr>
@@ -13165,7 +13172,7 @@
                 <a:ea typeface="Arial"/>
                 <a:cs typeface="Arial"/>
               </a:rPr>
-              <a:t>Настройка в hh.ru, результаты в Skillaz</a:t>
+              <a:t>За что клиент платит Skillaz</a:t>
             </a:r>
           </a:p>
         </p:txBody>
@@ -13175,7 +13182,7 @@
           <p:cNvPr id="4" name="">
             <a:extLst xmlns:a="http://schemas.openxmlformats.org/drawingml/2006/main">
               <a:ext uri="{FF2B5EF4-FFF2-40B4-BE49-F238E27FC236}">
-                <a16:creationId xmlns:a16="http://schemas.microsoft.com/office/drawing/2014/main" id="{0976A03D-75E5-4D3D-B55F-066BF69C9739}"/>
+                <a16:creationId xmlns:a16="http://schemas.microsoft.com/office/drawing/2014/main" id="{C0BDD5E7-A18D-4C52-BB28-ED7D6D263880}"/>
               </a:ext>
             </a:extLst>
           </p:cNvPr>
@@ -13243,7 +13250,7 @@
           <p:cNvPr id="5" name="">
             <a:extLst xmlns:a="http://schemas.openxmlformats.org/drawingml/2006/main">
               <a:ext uri="{FF2B5EF4-FFF2-40B4-BE49-F238E27FC236}">
-                <a16:creationId xmlns:a16="http://schemas.microsoft.com/office/drawing/2014/main" id="{3309376F-7D92-4100-A00A-99B852DDD73A}"/>
+                <a16:creationId xmlns:a16="http://schemas.microsoft.com/office/drawing/2014/main" id="{041980EF-18AF-4FC7-9E2E-4ED32008143E}"/>
               </a:ext>
             </a:extLst>
           </p:cNvPr>
@@ -13311,7 +13318,7 @@
           <p:cNvPr id="6" name="">
             <a:extLst xmlns:a="http://schemas.openxmlformats.org/drawingml/2006/main">
               <a:ext uri="{FF2B5EF4-FFF2-40B4-BE49-F238E27FC236}">
-                <a16:creationId xmlns:a16="http://schemas.microsoft.com/office/drawing/2014/main" id="{1491ED50-23FF-40A4-9BEA-7E9C2E821248}"/>
+                <a16:creationId xmlns:a16="http://schemas.microsoft.com/office/drawing/2014/main" id="{7D977DC2-F5C1-4544-AE70-E750903EC183}"/>
               </a:ext>
             </a:extLst>
           </p:cNvPr>
@@ -13379,7 +13386,7 @@
           <p:cNvPr id="7" name="">
             <a:extLst xmlns:a="http://schemas.openxmlformats.org/drawingml/2006/main">
               <a:ext uri="{FF2B5EF4-FFF2-40B4-BE49-F238E27FC236}">
-                <a16:creationId xmlns:a16="http://schemas.microsoft.com/office/drawing/2014/main" id="{54A56E2C-DA3F-4283-9FF3-B426D5A2E7EA}"/>
+                <a16:creationId xmlns:a16="http://schemas.microsoft.com/office/drawing/2014/main" id="{9B4562DE-8202-43C1-BFDA-F032A8B2B93A}"/>
               </a:ext>
             </a:extLst>
           </p:cNvPr>
@@ -13409,7 +13416,7 @@
           <p:cNvPr id="8" name="">
             <a:extLst xmlns:a="http://schemas.openxmlformats.org/drawingml/2006/main">
               <a:ext uri="{FF2B5EF4-FFF2-40B4-BE49-F238E27FC236}">
-                <a16:creationId xmlns:a16="http://schemas.microsoft.com/office/drawing/2014/main" id="{F9C95042-39E9-4410-8A16-05798577FCC2}"/>
+                <a16:creationId xmlns:a16="http://schemas.microsoft.com/office/drawing/2014/main" id="{E8CABEC8-C632-4B0C-9645-EE4DE53BC368}"/>
               </a:ext>
             </a:extLst>
           </p:cNvPr>
@@ -13437,7 +13444,7 @@
           </a:bodyPr>
           <a:lstStyle xmlns:a="http://schemas.openxmlformats.org/drawingml/2006/main">
             <a:defPPr>
-              <a:defRPr sz="2175" b="1">
+              <a:defRPr sz="2025" b="1">
                 <a:solidFill>
                   <a:srgbClr val="101022"/>
                 </a:solidFill>
@@ -13449,7 +13456,7 @@
           </a:lstStyle>
           <a:p xmlns:a="http://schemas.openxmlformats.org/drawingml/2006/main">
             <a:pPr>
-              <a:defRPr sz="2175" b="1">
+              <a:defRPr sz="2025" b="1">
                 <a:solidFill>
                   <a:srgbClr val="101022"/>
                 </a:solidFill>
@@ -13459,7 +13466,7 @@
               </a:defRPr>
             </a:pPr>
             <a:r>
-              <a:rPr sz="2175" b="1">
+              <a:rPr sz="2025" b="1">
                 <a:solidFill>
                   <a:srgbClr val="101022"/>
                 </a:solidFill>
@@ -13467,7 +13474,7 @@
                 <a:ea typeface="Arial"/>
                 <a:cs typeface="Arial"/>
               </a:rPr>
-              <a:t>В hh.ru</a:t>
+              <a:t>Рядом с откликом</a:t>
             </a:r>
           </a:p>
         </p:txBody>
@@ -13477,7 +13484,7 @@
           <p:cNvPr id="9" name="">
             <a:extLst xmlns:a="http://schemas.openxmlformats.org/drawingml/2006/main">
               <a:ext uri="{FF2B5EF4-FFF2-40B4-BE49-F238E27FC236}">
-                <a16:creationId xmlns:a16="http://schemas.microsoft.com/office/drawing/2014/main" id="{74E71C64-355D-45CF-BB0C-FEF692721679}"/>
+                <a16:creationId xmlns:a16="http://schemas.microsoft.com/office/drawing/2014/main" id="{6BE4D11E-5D25-474D-9D7F-290F4CB7FE08}"/>
               </a:ext>
             </a:extLst>
           </p:cNvPr>
@@ -13535,7 +13542,7 @@
                 <a:ea typeface="Arial"/>
                 <a:cs typeface="Arial"/>
               </a:rPr>
-              <a:t>Настройка вакансии.</a:t>
+              <a:t>Предлагаем показывать</a:t>
             </a:r>
           </a:p>
           <a:p xmlns:a="http://schemas.openxmlformats.org/drawingml/2006/main">
@@ -13558,7 +13565,7 @@
                 <a:ea typeface="Arial"/>
                 <a:cs typeface="Arial"/>
               </a:rPr>
-              <a:t>Критерии и вопросы.</a:t>
+              <a:t>оценку и ответы</a:t>
             </a:r>
           </a:p>
           <a:p xmlns:a="http://schemas.openxmlformats.org/drawingml/2006/main">
@@ -13581,7 +13588,30 @@
                 <a:ea typeface="Arial"/>
                 <a:cs typeface="Arial"/>
               </a:rPr>
-              <a:t>Автоматический разбор.</a:t>
+              <a:t>в контексте кандидата</a:t>
+            </a:r>
+          </a:p>
+          <a:p xmlns:a="http://schemas.openxmlformats.org/drawingml/2006/main">
+            <a:pPr>
+              <a:defRPr sz="1650" b="0">
+                <a:solidFill>
+                  <a:srgbClr val="737C96"/>
+                </a:solidFill>
+                <a:latin typeface="Arial"/>
+                <a:ea typeface="Arial"/>
+                <a:cs typeface="Arial"/>
+              </a:defRPr>
+            </a:pPr>
+            <a:r>
+              <a:rPr sz="1650" b="0">
+                <a:solidFill>
+                  <a:srgbClr val="737C96"/>
+                </a:solidFill>
+                <a:latin typeface="Arial"/>
+                <a:ea typeface="Arial"/>
+                <a:cs typeface="Arial"/>
+              </a:rPr>
+              <a:t>и вакансии в Skillaz.</a:t>
             </a:r>
           </a:p>
         </p:txBody>
@@ -13591,7 +13621,7 @@
           <p:cNvPr id="10" name="">
             <a:extLst xmlns:a="http://schemas.openxmlformats.org/drawingml/2006/main">
               <a:ext uri="{FF2B5EF4-FFF2-40B4-BE49-F238E27FC236}">
-                <a16:creationId xmlns:a16="http://schemas.microsoft.com/office/drawing/2014/main" id="{269B1787-8884-4676-A5C3-1B766143AD83}"/>
+                <a16:creationId xmlns:a16="http://schemas.microsoft.com/office/drawing/2014/main" id="{84C0BBED-5AA8-47F5-B9FF-D6C4F14A748D}"/>
               </a:ext>
             </a:extLst>
           </p:cNvPr>
@@ -13621,7 +13651,7 @@
           <p:cNvPr id="11" name="">
             <a:extLst xmlns:a="http://schemas.openxmlformats.org/drawingml/2006/main">
               <a:ext uri="{FF2B5EF4-FFF2-40B4-BE49-F238E27FC236}">
-                <a16:creationId xmlns:a16="http://schemas.microsoft.com/office/drawing/2014/main" id="{9C791B5B-A82B-4B37-B4C0-CD9DD34FFFD6}"/>
+                <a16:creationId xmlns:a16="http://schemas.microsoft.com/office/drawing/2014/main" id="{8BCC3754-CC0C-4273-8D2A-43B7A87C7807}"/>
               </a:ext>
             </a:extLst>
           </p:cNvPr>
@@ -13649,7 +13679,7 @@
           </a:bodyPr>
           <a:lstStyle xmlns:a="http://schemas.openxmlformats.org/drawingml/2006/main">
             <a:defPPr>
-              <a:defRPr sz="2175" b="1">
+              <a:defRPr sz="2025" b="1">
                 <a:solidFill>
                   <a:srgbClr val="101022"/>
                 </a:solidFill>
@@ -13661,7 +13691,7 @@
           </a:lstStyle>
           <a:p xmlns:a="http://schemas.openxmlformats.org/drawingml/2006/main">
             <a:pPr>
-              <a:defRPr sz="2175" b="1">
+              <a:defRPr sz="2025" b="1">
                 <a:solidFill>
                   <a:srgbClr val="101022"/>
                 </a:solidFill>
@@ -13671,7 +13701,7 @@
               </a:defRPr>
             </a:pPr>
             <a:r>
-              <a:rPr sz="2175" b="1">
+              <a:rPr sz="2025" b="1">
                 <a:solidFill>
                   <a:srgbClr val="101022"/>
                 </a:solidFill>
@@ -13679,7 +13709,7 @@
                 <a:ea typeface="Arial"/>
                 <a:cs typeface="Arial"/>
               </a:rPr>
-              <a:t>Через API</a:t>
+              <a:t>В одном процессе</a:t>
             </a:r>
           </a:p>
         </p:txBody>
@@ -13689,7 +13719,7 @@
           <p:cNvPr id="12" name="">
             <a:extLst xmlns:a="http://schemas.openxmlformats.org/drawingml/2006/main">
               <a:ext uri="{FF2B5EF4-FFF2-40B4-BE49-F238E27FC236}">
-                <a16:creationId xmlns:a16="http://schemas.microsoft.com/office/drawing/2014/main" id="{F70DC02E-8A37-450D-8C6A-9F1A267F9E8B}"/>
+                <a16:creationId xmlns:a16="http://schemas.microsoft.com/office/drawing/2014/main" id="{8E54251B-9706-4A8D-AE87-C21AD357988A}"/>
               </a:ext>
             </a:extLst>
           </p:cNvPr>
@@ -13747,7 +13777,7 @@
                 <a:ea typeface="Arial"/>
                 <a:cs typeface="Arial"/>
               </a:rPr>
-              <a:t>Получение результата</a:t>
+              <a:t>Рекрутёр изучает</a:t>
             </a:r>
           </a:p>
           <a:p xmlns:a="http://schemas.openxmlformats.org/drawingml/2006/main">
@@ -13770,7 +13800,7 @@
                 <a:ea typeface="Arial"/>
                 <a:cs typeface="Arial"/>
               </a:rPr>
-              <a:t>по ID отклика.</a:t>
+              <a:t>результат там, где</a:t>
             </a:r>
           </a:p>
           <a:p xmlns:a="http://schemas.openxmlformats.org/drawingml/2006/main">
@@ -13793,7 +13823,7 @@
                 <a:ea typeface="Arial"/>
                 <a:cs typeface="Arial"/>
               </a:rPr>
-              <a:t>Без отправки текста</a:t>
+              <a:t>ведёт подбор и работу</a:t>
             </a:r>
           </a:p>
           <a:p xmlns:a="http://schemas.openxmlformats.org/drawingml/2006/main">
@@ -13816,7 +13846,7 @@
                 <a:ea typeface="Arial"/>
                 <a:cs typeface="Arial"/>
               </a:rPr>
-              <a:t>резюме из Skillaz.</a:t>
+              <a:t>с кандидатом.</a:t>
             </a:r>
           </a:p>
         </p:txBody>
@@ -13826,7 +13856,7 @@
           <p:cNvPr id="13" name="">
             <a:extLst xmlns:a="http://schemas.openxmlformats.org/drawingml/2006/main">
               <a:ext uri="{FF2B5EF4-FFF2-40B4-BE49-F238E27FC236}">
-                <a16:creationId xmlns:a16="http://schemas.microsoft.com/office/drawing/2014/main" id="{674A06E4-37A3-496B-8207-4BAE357A9EA3}"/>
+                <a16:creationId xmlns:a16="http://schemas.microsoft.com/office/drawing/2014/main" id="{993C7F42-8D0B-4D3B-9F68-3F96C6188ADD}"/>
               </a:ext>
             </a:extLst>
           </p:cNvPr>
@@ -13856,7 +13886,7 @@
           <p:cNvPr id="14" name="">
             <a:extLst xmlns:a="http://schemas.openxmlformats.org/drawingml/2006/main">
               <a:ext uri="{FF2B5EF4-FFF2-40B4-BE49-F238E27FC236}">
-                <a16:creationId xmlns:a16="http://schemas.microsoft.com/office/drawing/2014/main" id="{75BC9817-75FA-4C3D-BA5E-921895534DA1}"/>
+                <a16:creationId xmlns:a16="http://schemas.microsoft.com/office/drawing/2014/main" id="{ACB2329B-E538-42F8-A697-4FC5DCA64A1E}"/>
               </a:ext>
             </a:extLst>
           </p:cNvPr>
@@ -13884,7 +13914,7 @@
           </a:bodyPr>
           <a:lstStyle xmlns:a="http://schemas.openxmlformats.org/drawingml/2006/main">
             <a:defPPr>
-              <a:defRPr sz="2175" b="1">
+              <a:defRPr sz="2025" b="1">
                 <a:solidFill>
                   <a:srgbClr val="101022"/>
                 </a:solidFill>
@@ -13896,7 +13926,7 @@
           </a:lstStyle>
           <a:p xmlns:a="http://schemas.openxmlformats.org/drawingml/2006/main">
             <a:pPr>
-              <a:defRPr sz="2175" b="1">
+              <a:defRPr sz="2025" b="1">
                 <a:solidFill>
                   <a:srgbClr val="101022"/>
                 </a:solidFill>
@@ -13906,7 +13936,7 @@
               </a:defRPr>
             </a:pPr>
             <a:r>
-              <a:rPr sz="2175" b="1">
+              <a:rPr sz="2025" b="1">
                 <a:solidFill>
                   <a:srgbClr val="101022"/>
                 </a:solidFill>
@@ -13914,7 +13944,7 @@
                 <a:ea typeface="Arial"/>
                 <a:cs typeface="Arial"/>
               </a:rPr>
-              <a:t>В Skillaz</a:t>
+              <a:t>Меньше рутины</a:t>
             </a:r>
           </a:p>
         </p:txBody>
@@ -13924,7 +13954,7 @@
           <p:cNvPr id="15" name="">
             <a:extLst xmlns:a="http://schemas.openxmlformats.org/drawingml/2006/main">
               <a:ext uri="{FF2B5EF4-FFF2-40B4-BE49-F238E27FC236}">
-                <a16:creationId xmlns:a16="http://schemas.microsoft.com/office/drawing/2014/main" id="{28B6625A-5CD6-458F-B516-D1951C4F5699}"/>
+                <a16:creationId xmlns:a16="http://schemas.microsoft.com/office/drawing/2014/main" id="{30113B5A-DEE2-46FA-BD4F-DEB5D98D7EBA}"/>
               </a:ext>
             </a:extLst>
           </p:cNvPr>
@@ -13982,7 +14012,7 @@
                 <a:ea typeface="Arial"/>
                 <a:cs typeface="Arial"/>
               </a:rPr>
-              <a:t>Предлагаем показывать</a:t>
+              <a:t>Это может сократить</a:t>
             </a:r>
           </a:p>
           <a:p xmlns:a="http://schemas.openxmlformats.org/drawingml/2006/main">
@@ -14005,7 +14035,7 @@
                 <a:ea typeface="Arial"/>
                 <a:cs typeface="Arial"/>
               </a:rPr>
-              <a:t>оценку и ответы</a:t>
+              <a:t>переходы в hh</a:t>
             </a:r>
           </a:p>
           <a:p xmlns:a="http://schemas.openxmlformats.org/drawingml/2006/main">
@@ -14028,7 +14058,7 @@
                 <a:ea typeface="Arial"/>
                 <a:cs typeface="Arial"/>
               </a:rPr>
-              <a:t>рядом с откликом</a:t>
+              <a:t>и ручной перенос</a:t>
             </a:r>
           </a:p>
           <a:p xmlns:a="http://schemas.openxmlformats.org/drawingml/2006/main">
@@ -14051,7 +14081,75 @@
                 <a:ea typeface="Arial"/>
                 <a:cs typeface="Arial"/>
               </a:rPr>
-              <a:t>после проверки обмена.</a:t>
+              <a:t>информации.</a:t>
+            </a:r>
+          </a:p>
+        </p:txBody>
+      </p:sp>
+      <p:sp>
+        <p:nvSpPr>
+          <p:cNvPr id="16" name="">
+            <a:extLst xmlns:a="http://schemas.openxmlformats.org/drawingml/2006/main">
+              <a:ext uri="{FF2B5EF4-FFF2-40B4-BE49-F238E27FC236}">
+                <a16:creationId xmlns:a16="http://schemas.microsoft.com/office/drawing/2014/main" id="{E5185733-01AC-4E5F-99E1-07B73213DDE5}"/>
+              </a:ext>
+            </a:extLst>
+          </p:cNvPr>
+          <p:cNvSpPr>
+            <a:spLocks xmlns:a="http://schemas.openxmlformats.org/drawingml/2006/main" noGrp="1"/>
+          </p:cNvSpPr>
+          <p:nvPr/>
+        </p:nvSpPr>
+        <p:spPr>
+          <a:xfrm xmlns:a="http://schemas.openxmlformats.org/drawingml/2006/main">
+            <a:off x="504825" y="5133975"/>
+            <a:ext cx="9696450" cy="400050"/>
+          </a:xfrm>
+          <a:prstGeom xmlns:a="http://schemas.openxmlformats.org/drawingml/2006/main" prst="rect">
+            <a:avLst/>
+          </a:prstGeom>
+          <a:noFill xmlns:a="http://schemas.openxmlformats.org/drawingml/2006/main"/>
+          <a:ln xmlns:a="http://schemas.openxmlformats.org/drawingml/2006/main" w="0">
+            <a:noFill/>
+          </a:ln>
+        </p:spPr>
+        <p:txBody>
+          <a:bodyPr xmlns:a="http://schemas.openxmlformats.org/drawingml/2006/main" lIns="0" tIns="0" rIns="0" bIns="0" anchor="t">
+            <a:noAutofit/>
+          </a:bodyPr>
+          <a:lstStyle xmlns:a="http://schemas.openxmlformats.org/drawingml/2006/main">
+            <a:defPPr>
+              <a:defRPr sz="1350" b="0">
+                <a:solidFill>
+                  <a:srgbClr val="737C96"/>
+                </a:solidFill>
+                <a:latin typeface="Arial"/>
+                <a:ea typeface="Arial"/>
+                <a:cs typeface="Arial"/>
+              </a:defRPr>
+            </a:defPPr>
+          </a:lstStyle>
+          <a:p xmlns:a="http://schemas.openxmlformats.org/drawingml/2006/main">
+            <a:pPr>
+              <a:defRPr sz="1350" b="0">
+                <a:solidFill>
+                  <a:srgbClr val="737C96"/>
+                </a:solidFill>
+                <a:latin typeface="Arial"/>
+                <a:ea typeface="Arial"/>
+                <a:cs typeface="Arial"/>
+              </a:defRPr>
+            </a:pPr>
+            <a:r>
+              <a:rPr sz="1350" b="0">
+                <a:solidFill>
+                  <a:srgbClr val="737C96"/>
+                </a:solidFill>
+                <a:latin typeface="Arial"/>
+                <a:ea typeface="Arial"/>
+                <a:cs typeface="Arial"/>
+              </a:rPr>
+              <a:t>Ценность Skillaz — использование результатов hh в привычном рабочем процессе.</a:t>
             </a:r>
           </a:p>
         </p:txBody>
@@ -14059,7 +14157,7 @@
     </p:spTree>
     <p:extLst>
       <p:ext uri="{BB962C8B-B14F-4D97-AF65-F5344CB8AC3E}">
-        <p14:creationId xmlns:p14="http://schemas.microsoft.com/office/powerpoint/2010/main" val="553293467"/>
+        <p14:creationId xmlns:p14="http://schemas.microsoft.com/office/powerpoint/2010/main" val="2139791138"/>
       </p:ext>
     </p:extLst>
   </p:cSld>

</xml_diff>

<commit_message>
Remove pilot slide and renumber nine slides
</commit_message>
<xml_diff>
--- a/Skillaz-hh-Integration.pptx
+++ b/Skillaz-hh-Integration.pptx
@@ -2,22 +2,21 @@
 <file path=ppt/presentation.xml><?xml version="1.0" encoding="utf-8"?>
 <p:presentation xmlns:p="http://schemas.openxmlformats.org/presentationml/2006/main">
   <p:sldMasterIdLst>
-    <p:sldMasterId xmlns:r="http://schemas.openxmlformats.org/officeDocument/2006/relationships" id="2147483648" r:id="R9b7f2c14ae974cfb"/>
+    <p:sldMasterId xmlns:r="http://schemas.openxmlformats.org/officeDocument/2006/relationships" id="2147483648" r:id="Re09ee5b715384e37"/>
   </p:sldMasterIdLst>
   <p:notesMasterIdLst>
-    <p:notesMasterId xmlns:r="http://schemas.openxmlformats.org/officeDocument/2006/relationships" r:id="Rdba5a264c1b341cf"/>
+    <p:notesMasterId xmlns:r="http://schemas.openxmlformats.org/officeDocument/2006/relationships" r:id="Rb622a9d7e8564fd0"/>
   </p:notesMasterIdLst>
   <p:sldIdLst>
-    <p:sldId xmlns:r="http://schemas.openxmlformats.org/officeDocument/2006/relationships" id="256" r:id="R92439d5e70924068"/>
-    <p:sldId xmlns:r="http://schemas.openxmlformats.org/officeDocument/2006/relationships" id="257" r:id="R280a4c424c864b5e"/>
-    <p:sldId xmlns:r="http://schemas.openxmlformats.org/officeDocument/2006/relationships" id="258" r:id="Rabb4b10347e94a10"/>
-    <p:sldId xmlns:r="http://schemas.openxmlformats.org/officeDocument/2006/relationships" id="259" r:id="R6500e320098b48ff"/>
-    <p:sldId xmlns:r="http://schemas.openxmlformats.org/officeDocument/2006/relationships" id="260" r:id="Rf3ee07fbee9a4e35"/>
-    <p:sldId xmlns:r="http://schemas.openxmlformats.org/officeDocument/2006/relationships" id="261" r:id="R137de607918948d4"/>
-    <p:sldId xmlns:r="http://schemas.openxmlformats.org/officeDocument/2006/relationships" id="262" r:id="Rcaa556f0b2ae44db"/>
-    <p:sldId xmlns:r="http://schemas.openxmlformats.org/officeDocument/2006/relationships" id="263" r:id="R23c522181f034c12"/>
-    <p:sldId xmlns:r="http://schemas.openxmlformats.org/officeDocument/2006/relationships" id="264" r:id="Rab0346e111974aa5"/>
-    <p:sldId xmlns:r="http://schemas.openxmlformats.org/officeDocument/2006/relationships" id="265" r:id="Rc7740d039bc242f6"/>
+    <p:sldId xmlns:r="http://schemas.openxmlformats.org/officeDocument/2006/relationships" id="256" r:id="Ra3bbb7702e474578"/>
+    <p:sldId xmlns:r="http://schemas.openxmlformats.org/officeDocument/2006/relationships" id="257" r:id="R6a40122e1da843ff"/>
+    <p:sldId xmlns:r="http://schemas.openxmlformats.org/officeDocument/2006/relationships" id="258" r:id="R24a5de7543484c1c"/>
+    <p:sldId xmlns:r="http://schemas.openxmlformats.org/officeDocument/2006/relationships" id="259" r:id="R5d322da80ca5402c"/>
+    <p:sldId xmlns:r="http://schemas.openxmlformats.org/officeDocument/2006/relationships" id="260" r:id="R1edd613e1513439b"/>
+    <p:sldId xmlns:r="http://schemas.openxmlformats.org/officeDocument/2006/relationships" id="261" r:id="R2b1d37e70e5f4d79"/>
+    <p:sldId xmlns:r="http://schemas.openxmlformats.org/officeDocument/2006/relationships" id="262" r:id="Rd2239c9141d94b70"/>
+    <p:sldId xmlns:r="http://schemas.openxmlformats.org/officeDocument/2006/relationships" id="263" r:id="Ra363279a7390402f"/>
+    <p:sldId xmlns:r="http://schemas.openxmlformats.org/officeDocument/2006/relationships" id="264" r:id="R72748ee5243048f9"/>
   </p:sldIdLst>
   <p:sldSz cx="10692384" cy="6007608"/>
   <p:notesSz cx="6858000" cy="9144000"/>
@@ -501,106 +500,6 @@
 </p:notes>
 </file>
 
-<file path=ppt/notesSlides/notesSlide10.xml><?xml version="1.0" encoding="utf-8"?>
-<p:notes xmlns:p="http://schemas.openxmlformats.org/presentationml/2006/main">
-  <p:cSld>
-    <p:spTree>
-      <p:nvGrpSpPr>
-        <p:cNvPr id="1" name=""/>
-        <p:cNvGrpSpPr/>
-        <p:nvPr/>
-      </p:nvGrpSpPr>
-      <p:grpSpPr>
-        <a:xfrm xmlns:a="http://schemas.openxmlformats.org/drawingml/2006/main"/>
-      </p:grpSpPr>
-      <p:sp>
-        <p:nvSpPr>
-          <p:cNvPr id="2" name="Slide Image Placeholder 1"/>
-          <p:cNvSpPr>
-            <a:spLocks xmlns:a="http://schemas.openxmlformats.org/drawingml/2006/main" noGrp="1"/>
-          </p:cNvSpPr>
-          <p:nvPr>
-            <p:ph type="sldImg" idx="0"/>
-          </p:nvPr>
-        </p:nvSpPr>
-        <p:spPr/>
-      </p:sp>
-      <p:sp>
-        <p:nvSpPr>
-          <p:cNvPr id="3" name="Notes Placeholder 2"/>
-          <p:cNvSpPr>
-            <a:spLocks xmlns:a="http://schemas.openxmlformats.org/drawingml/2006/main" noGrp="1"/>
-          </p:cNvSpPr>
-          <p:nvPr>
-            <p:ph type="body" idx="1"/>
-          </p:nvPr>
-        </p:nvSpPr>
-        <p:spPr/>
-        <p:txBody>
-          <a:bodyPr xmlns:a="http://schemas.openxmlformats.org/drawingml/2006/main"/>
-          <a:lstStyle xmlns:a="http://schemas.openxmlformats.org/drawingml/2006/main"/>
-          <a:p xmlns:a="http://schemas.openxmlformats.org/drawingml/2006/main">
-            <a:r>
-              <a:t>ПРОВЕРКА API, 16.10.2026. Источники: https://api.hh.ru/openapi/specification/public ; https://api.hh.ru/openapi/redoc#tag/Otklikipriglasheniya-rabotodatelya/operation/get-negotiation-item . В официальных примерах GET /negotiations/{id} и списка откликов есть ai_assistant.neuro_response и ai_assistant.neuro_invite. Реальный авторизованный запрос от Skillaz не выполнялся; доступность для конкретного клиента, полнота, гарантии и условия оплаты не подтверждены. Источник экранов: предоставленный Presentation-Razbor-Doopros.pdf.</a:t>
-            </a:r>
-          </a:p>
-          <a:p xmlns:a="http://schemas.openxmlformats.org/drawingml/2006/main">
-            <a:r>
-              <a:t/>
-            </a:r>
-          </a:p>
-          <a:p xmlns:a="http://schemas.openxmlformats.org/drawingml/2006/main">
-            <a:r>
-              <a:t>Перед пилотом: получить реальный отклик с завершённым разбором и доопросом, выполнить GET /negotiations/{id} от приложения Skillaz, проверить ai_assistant и сопоставление данных. Запросить у hh документацию партнёрских методов, права, ограничения и коммерческие условия. Сроки, цена пилота, объём, ответственность и критерии приёмки не подтверждены.</a:t>
-            </a:r>
-          </a:p>
-          <a:p xmlns:a="http://schemas.openxmlformats.org/drawingml/2006/main">
-            <a:r>
-              <a:t>Уточнения по документации hh: https://feedback.hh.ru/knowledge-base/article/033748 ; https://feedback.hh.ru/knowledge-base/article/022833 . Помощник подключается к конкретной вакансии; оба навыка включены по умолчанию. Критерии редактируемые, не закрытый справочник. 6 обязательных и 4 желательных — автоматическое выделение, не подтверждённый жёсткий лимит. При изменении портрета — переразбор с исключениями для некоторых статусов, включая ручной отказ. Доопрос касается новых откликов, не гарантирован каждому кандидату; до 3 своих вопросов, до 5 всего по инструкции. Запрос API получает результат, не запускает оценку.</a:t>
-            </a:r>
-          </a:p>
-          <a:p xmlns:a="http://schemas.openxmlformats.org/drawingml/2006/main">
-            <a:r>
-              <a:t/>
-            </a:r>
-          </a:p>
-          <a:p xmlns:a="http://schemas.openxmlformats.org/drawingml/2006/main">
-            <a:r>
-              <a:t/>
-            </a:r>
-          </a:p>
-          <a:p xmlns:a="http://schemas.openxmlformats.org/drawingml/2006/main">
-            <a:r>
-              <a:t>Пилот сравнивает работу с ИИ непосредственно в hh и с теми же результатами через Skillaz на сопоставимых вакансиях и нагрузке. Отдельно учитывать время проверки выводов и исправлений. Не приписывать интеграции общий эффект ИИ hh. Замерять время первичного рассмотрения, число переходов и объём ручного переноса. Не обещать проценты экономии, ускорение найма или снижение затрат без измерений.</a:t>
-            </a:r>
-          </a:p>
-        </p:txBody>
-      </p:sp>
-      <p:sp>
-        <p:nvSpPr>
-          <p:cNvPr id="4" name="Slide Number Placeholder 3"/>
-          <p:cNvSpPr>
-            <a:spLocks xmlns:a="http://schemas.openxmlformats.org/drawingml/2006/main" noGrp="1"/>
-          </p:cNvSpPr>
-          <p:nvPr>
-            <p:ph type="sldNum" idx="5"/>
-          </p:nvPr>
-        </p:nvSpPr>
-        <p:spPr/>
-        <p:txBody>
-          <a:bodyPr xmlns:a="http://schemas.openxmlformats.org/drawingml/2006/main"/>
-          <a:lstStyle xmlns:a="http://schemas.openxmlformats.org/drawingml/2006/main"/>
-          <a:p xmlns:a="http://schemas.openxmlformats.org/drawingml/2006/main"/>
-        </p:txBody>
-      </p:sp>
-    </p:spTree>
-  </p:cSld>
-  <p:clrMapOvr>
-    <a:masterClrMapping xmlns:a="http://schemas.openxmlformats.org/drawingml/2006/main"/>
-  </p:clrMapOvr>
-</p:notes>
-</file>
-
 <file path=ppt/notesSlides/notesSlide2.xml><?xml version="1.0" encoding="utf-8"?>
 <p:notes xmlns:p="http://schemas.openxmlformats.org/presentationml/2006/main">
   <p:cSld>
@@ -1368,7 +1267,7 @@
           <p:cNvPr id="3" name="Title">
             <a:extLst xmlns:a="http://schemas.openxmlformats.org/drawingml/2006/main">
               <a:ext uri="{FF2B5EF4-FFF2-40B4-BE49-F238E27FC236}">
-                <a16:creationId xmlns:a16="http://schemas.microsoft.com/office/drawing/2014/main" id="{70CBDAEE-428C-4A5A-95F8-CFB4E8D373C5}"/>
+                <a16:creationId xmlns:a16="http://schemas.microsoft.com/office/drawing/2014/main" id="{7A9C3460-A835-4CCF-A0C6-45C2B907550A}"/>
               </a:ext>
             </a:extLst>
           </p:cNvPr>
@@ -1525,7 +1424,7 @@
           <p:cNvPr id="2" name="Subtitle">
             <a:extLst xmlns:a="http://schemas.openxmlformats.org/drawingml/2006/main">
               <a:ext uri="{FF2B5EF4-FFF2-40B4-BE49-F238E27FC236}">
-                <a16:creationId xmlns:a16="http://schemas.microsoft.com/office/drawing/2014/main" id="{A4C0C9BB-23D4-431A-B126-E0E4ACF3FFF8}"/>
+                <a16:creationId xmlns:a16="http://schemas.microsoft.com/office/drawing/2014/main" id="{0C99B38F-96EA-4F43-9012-FF6277B140B1}"/>
               </a:ext>
             </a:extLst>
           </p:cNvPr>
@@ -1699,7 +1598,7 @@
           <p:cNvPr id="2" name="Section title">
             <a:extLst xmlns:a="http://schemas.openxmlformats.org/drawingml/2006/main">
               <a:ext uri="{FF2B5EF4-FFF2-40B4-BE49-F238E27FC236}">
-                <a16:creationId xmlns:a16="http://schemas.microsoft.com/office/drawing/2014/main" id="{96D1EA03-FC33-4794-B1AE-596382346A9B}"/>
+                <a16:creationId xmlns:a16="http://schemas.microsoft.com/office/drawing/2014/main" id="{5E9B12E5-70E2-4162-B776-77AB3D58DC5D}"/>
               </a:ext>
             </a:extLst>
           </p:cNvPr>
@@ -1873,7 +1772,7 @@
           <p:cNvPr id="3" name="Title">
             <a:extLst xmlns:a="http://schemas.openxmlformats.org/drawingml/2006/main">
               <a:ext uri="{FF2B5EF4-FFF2-40B4-BE49-F238E27FC236}">
-                <a16:creationId xmlns:a16="http://schemas.microsoft.com/office/drawing/2014/main" id="{49C396E3-2BAF-4CF6-B7C9-D02A5F943BDD}"/>
+                <a16:creationId xmlns:a16="http://schemas.microsoft.com/office/drawing/2014/main" id="{718B3E2E-5461-4B9F-AD25-916E22A24375}"/>
               </a:ext>
             </a:extLst>
           </p:cNvPr>
@@ -2030,7 +1929,7 @@
           <p:cNvPr id="2" name="Body">
             <a:extLst xmlns:a="http://schemas.openxmlformats.org/drawingml/2006/main">
               <a:ext uri="{FF2B5EF4-FFF2-40B4-BE49-F238E27FC236}">
-                <a16:creationId xmlns:a16="http://schemas.microsoft.com/office/drawing/2014/main" id="{B111C37A-0141-42E0-9506-2F3B33054ADC}"/>
+                <a16:creationId xmlns:a16="http://schemas.microsoft.com/office/drawing/2014/main" id="{7168B983-7AEB-4683-BB84-07EF6DBE8A61}"/>
               </a:ext>
             </a:extLst>
           </p:cNvPr>
@@ -2204,7 +2103,7 @@
           <p:cNvPr id="4" name="Title">
             <a:extLst xmlns:a="http://schemas.openxmlformats.org/drawingml/2006/main">
               <a:ext uri="{FF2B5EF4-FFF2-40B4-BE49-F238E27FC236}">
-                <a16:creationId xmlns:a16="http://schemas.microsoft.com/office/drawing/2014/main" id="{02DF3DC3-64B5-473D-BB3D-0C532FD59362}"/>
+                <a16:creationId xmlns:a16="http://schemas.microsoft.com/office/drawing/2014/main" id="{A0D0F6D2-7BD7-4B53-9663-7A5D149901E3}"/>
               </a:ext>
             </a:extLst>
           </p:cNvPr>
@@ -2361,7 +2260,7 @@
           <p:cNvPr id="2" name="Left column">
             <a:extLst xmlns:a="http://schemas.openxmlformats.org/drawingml/2006/main">
               <a:ext uri="{FF2B5EF4-FFF2-40B4-BE49-F238E27FC236}">
-                <a16:creationId xmlns:a16="http://schemas.microsoft.com/office/drawing/2014/main" id="{3F3A26D7-B643-451C-AC2F-2101F0E099F8}"/>
+                <a16:creationId xmlns:a16="http://schemas.microsoft.com/office/drawing/2014/main" id="{40A2BFCE-BC77-4ECA-BDB0-20D1259B03EC}"/>
               </a:ext>
             </a:extLst>
           </p:cNvPr>
@@ -2518,7 +2417,7 @@
           <p:cNvPr id="3" name="Right column">
             <a:extLst xmlns:a="http://schemas.openxmlformats.org/drawingml/2006/main">
               <a:ext uri="{FF2B5EF4-FFF2-40B4-BE49-F238E27FC236}">
-                <a16:creationId xmlns:a16="http://schemas.microsoft.com/office/drawing/2014/main" id="{42A01FAD-5130-475B-A2DA-12FD3DD2E833}"/>
+                <a16:creationId xmlns:a16="http://schemas.microsoft.com/office/drawing/2014/main" id="{B2702A96-2CA3-438E-9A5E-9AA4B31DFC74}"/>
               </a:ext>
             </a:extLst>
           </p:cNvPr>
@@ -2692,7 +2591,7 @@
           <p:cNvPr id="3" name="Title">
             <a:extLst xmlns:a="http://schemas.openxmlformats.org/drawingml/2006/main">
               <a:ext uri="{FF2B5EF4-FFF2-40B4-BE49-F238E27FC236}">
-                <a16:creationId xmlns:a16="http://schemas.microsoft.com/office/drawing/2014/main" id="{D54DF071-489D-4D33-BA7E-54F4618D36E3}"/>
+                <a16:creationId xmlns:a16="http://schemas.microsoft.com/office/drawing/2014/main" id="{537B795B-C8F4-463C-90DA-E70134EA5787}"/>
               </a:ext>
             </a:extLst>
           </p:cNvPr>
@@ -2849,7 +2748,7 @@
           <p:cNvPr id="2" name="Left column">
             <a:extLst xmlns:a="http://schemas.openxmlformats.org/drawingml/2006/main">
               <a:ext uri="{FF2B5EF4-FFF2-40B4-BE49-F238E27FC236}">
-                <a16:creationId xmlns:a16="http://schemas.microsoft.com/office/drawing/2014/main" id="{2D94EF84-DF09-4096-BB54-6A6110628F80}"/>
+                <a16:creationId xmlns:a16="http://schemas.microsoft.com/office/drawing/2014/main" id="{0F43AA4A-5905-4EFC-875F-A1134F326BB2}"/>
               </a:ext>
             </a:extLst>
           </p:cNvPr>
@@ -3044,12 +2943,12 @@
   </p:cSld>
   <p:clrMap bg1="lt1" tx1="dk1" bg2="lt2" tx2="dk2" accent1="accent1" accent2="accent2" accent3="accent3" accent4="accent4" accent5="accent5" accent6="accent6" hlink="hlink" folHlink="folHlink"/>
   <p:sldLayoutIdLst>
-    <p:sldLayoutId xmlns:r="http://schemas.openxmlformats.org/officeDocument/2006/relationships" id="2147483649" r:id="Rc448b1be9487452d"/>
-    <p:sldLayoutId xmlns:r="http://schemas.openxmlformats.org/officeDocument/2006/relationships" id="2147483650" r:id="Rcddf079f1f564ae1"/>
-    <p:sldLayoutId xmlns:r="http://schemas.openxmlformats.org/officeDocument/2006/relationships" id="2147483651" r:id="Rfaf7724d19bf4956"/>
-    <p:sldLayoutId xmlns:r="http://schemas.openxmlformats.org/officeDocument/2006/relationships" id="2147483652" r:id="R16155753913c4bbd"/>
-    <p:sldLayoutId xmlns:r="http://schemas.openxmlformats.org/officeDocument/2006/relationships" id="2147483653" r:id="Rdb92c6ece0b44332"/>
-    <p:sldLayoutId xmlns:r="http://schemas.openxmlformats.org/officeDocument/2006/relationships" id="2147483654" r:id="R83149f7faac7469a"/>
+    <p:sldLayoutId xmlns:r="http://schemas.openxmlformats.org/officeDocument/2006/relationships" id="2147483649" r:id="R24283f8ce88348c5"/>
+    <p:sldLayoutId xmlns:r="http://schemas.openxmlformats.org/officeDocument/2006/relationships" id="2147483650" r:id="Rba5455dad8a940b6"/>
+    <p:sldLayoutId xmlns:r="http://schemas.openxmlformats.org/officeDocument/2006/relationships" id="2147483651" r:id="Rec22e302bc534351"/>
+    <p:sldLayoutId xmlns:r="http://schemas.openxmlformats.org/officeDocument/2006/relationships" id="2147483652" r:id="Rf532e766c52346ae"/>
+    <p:sldLayoutId xmlns:r="http://schemas.openxmlformats.org/officeDocument/2006/relationships" id="2147483653" r:id="Ra69390122ff54005"/>
+    <p:sldLayoutId xmlns:r="http://schemas.openxmlformats.org/officeDocument/2006/relationships" id="2147483654" r:id="Rf2639f1be455473b"/>
   </p:sldLayoutIdLst>
   <p:txStyles>
     <p:titleStyle>
@@ -3600,7 +3499,7 @@
           <p:cNvPr id="11" name="">
             <a:extLst xmlns:a="http://schemas.openxmlformats.org/drawingml/2006/main">
               <a:ext uri="{FF2B5EF4-FFF2-40B4-BE49-F238E27FC236}">
-                <a16:creationId xmlns:a16="http://schemas.microsoft.com/office/drawing/2014/main" id="{13272986-F999-4056-955E-6D7D56D31EF5}"/>
+                <a16:creationId xmlns:a16="http://schemas.microsoft.com/office/drawing/2014/main" id="{487AAE78-7D1E-441E-B6B0-3850CCC1F493}"/>
               </a:ext>
             </a:extLst>
           </p:cNvPr>
@@ -3610,7 +3509,7 @@
           <p:nvPr/>
         </p:nvPicPr>
         <p:blipFill>
-          <a:blip xmlns:r="http://schemas.openxmlformats.org/officeDocument/2006/relationships" xmlns:a="http://schemas.openxmlformats.org/drawingml/2006/main" r:embed="R2be1080710a54e04"/>
+          <a:blip xmlns:r="http://schemas.openxmlformats.org/officeDocument/2006/relationships" xmlns:a="http://schemas.openxmlformats.org/drawingml/2006/main" r:embed="R9f72e30c45214085"/>
           <a:stretch xmlns:a="http://schemas.openxmlformats.org/drawingml/2006/main"/>
         </p:blipFill>
         <p:spPr>
@@ -3628,7 +3527,7 @@
           <p:cNvPr id="2" name="">
             <a:extLst xmlns:a="http://schemas.openxmlformats.org/drawingml/2006/main">
               <a:ext uri="{FF2B5EF4-FFF2-40B4-BE49-F238E27FC236}">
-                <a16:creationId xmlns:a16="http://schemas.microsoft.com/office/drawing/2014/main" id="{70EDB820-E03C-496C-A511-3D646AC28759}"/>
+                <a16:creationId xmlns:a16="http://schemas.microsoft.com/office/drawing/2014/main" id="{D47BD302-3AFD-4793-B4DC-D6F711666DBA}"/>
               </a:ext>
             </a:extLst>
           </p:cNvPr>
@@ -3696,7 +3595,7 @@
           <p:cNvPr id="3" name="">
             <a:extLst xmlns:a="http://schemas.openxmlformats.org/drawingml/2006/main">
               <a:ext uri="{FF2B5EF4-FFF2-40B4-BE49-F238E27FC236}">
-                <a16:creationId xmlns:a16="http://schemas.microsoft.com/office/drawing/2014/main" id="{1644B83B-C4C0-4792-AE29-93588F8D03E7}"/>
+                <a16:creationId xmlns:a16="http://schemas.microsoft.com/office/drawing/2014/main" id="{64A45808-FBCE-472F-9B10-518C9E2C9D8F}"/>
               </a:ext>
             </a:extLst>
           </p:cNvPr>
@@ -3764,7 +3663,7 @@
           <p:cNvPr id="4" name="">
             <a:extLst xmlns:a="http://schemas.openxmlformats.org/drawingml/2006/main">
               <a:ext uri="{FF2B5EF4-FFF2-40B4-BE49-F238E27FC236}">
-                <a16:creationId xmlns:a16="http://schemas.microsoft.com/office/drawing/2014/main" id="{37CC5797-3786-463C-A10A-BA53BC4C1CFF}"/>
+                <a16:creationId xmlns:a16="http://schemas.microsoft.com/office/drawing/2014/main" id="{73501BC5-537A-4156-95D7-11B88FD454CB}"/>
               </a:ext>
             </a:extLst>
           </p:cNvPr>
@@ -3832,7 +3731,7 @@
           <p:cNvPr id="5" name="">
             <a:extLst xmlns:a="http://schemas.openxmlformats.org/drawingml/2006/main">
               <a:ext uri="{FF2B5EF4-FFF2-40B4-BE49-F238E27FC236}">
-                <a16:creationId xmlns:a16="http://schemas.microsoft.com/office/drawing/2014/main" id="{104916AB-6602-4274-BC4B-2CF632653EB6}"/>
+                <a16:creationId xmlns:a16="http://schemas.microsoft.com/office/drawing/2014/main" id="{B51DC122-021B-4F14-A88C-F0274F2A51B9}"/>
               </a:ext>
             </a:extLst>
           </p:cNvPr>
@@ -3890,7 +3789,7 @@
                 <a:ea typeface="Courier New"/>
                 <a:cs typeface="Courier New"/>
               </a:rPr>
-              <a:t>01 / 10</a:t>
+              <a:t>01 / 09</a:t>
             </a:r>
           </a:p>
         </p:txBody>
@@ -3900,7 +3799,7 @@
           <p:cNvPr id="6" name="">
             <a:extLst xmlns:a="http://schemas.openxmlformats.org/drawingml/2006/main">
               <a:ext uri="{FF2B5EF4-FFF2-40B4-BE49-F238E27FC236}">
-                <a16:creationId xmlns:a16="http://schemas.microsoft.com/office/drawing/2014/main" id="{B514B7BD-3835-4655-BD35-4225AEBCA135}"/>
+                <a16:creationId xmlns:a16="http://schemas.microsoft.com/office/drawing/2014/main" id="{840A86C1-3238-46EB-8BC3-90E6F2FDDB99}"/>
               </a:ext>
             </a:extLst>
           </p:cNvPr>
@@ -3930,7 +3829,7 @@
           <p:cNvPr id="7" name="">
             <a:extLst xmlns:a="http://schemas.openxmlformats.org/drawingml/2006/main">
               <a:ext uri="{FF2B5EF4-FFF2-40B4-BE49-F238E27FC236}">
-                <a16:creationId xmlns:a16="http://schemas.microsoft.com/office/drawing/2014/main" id="{33057292-8D1F-4490-B51B-745DF5F18ACA}"/>
+                <a16:creationId xmlns:a16="http://schemas.microsoft.com/office/drawing/2014/main" id="{3F5C33C3-5005-4566-88EA-F55F22D3B705}"/>
               </a:ext>
             </a:extLst>
           </p:cNvPr>
@@ -4021,7 +3920,7 @@
           <p:cNvPr id="8" name="">
             <a:extLst xmlns:a="http://schemas.openxmlformats.org/drawingml/2006/main">
               <a:ext uri="{FF2B5EF4-FFF2-40B4-BE49-F238E27FC236}">
-                <a16:creationId xmlns:a16="http://schemas.microsoft.com/office/drawing/2014/main" id="{322DEEFF-61A5-4A68-BB53-0796C349C986}"/>
+                <a16:creationId xmlns:a16="http://schemas.microsoft.com/office/drawing/2014/main" id="{68BB82F7-0418-4DF3-ABFD-66C6869B61AC}"/>
               </a:ext>
             </a:extLst>
           </p:cNvPr>
@@ -4112,7 +4011,7 @@
           <p:cNvPr id="9" name="">
             <a:extLst xmlns:a="http://schemas.openxmlformats.org/drawingml/2006/main">
               <a:ext uri="{FF2B5EF4-FFF2-40B4-BE49-F238E27FC236}">
-                <a16:creationId xmlns:a16="http://schemas.microsoft.com/office/drawing/2014/main" id="{A6EC1CC9-BAF3-42F0-BD5A-B65D14EFE71C}"/>
+                <a16:creationId xmlns:a16="http://schemas.microsoft.com/office/drawing/2014/main" id="{BD699A3B-BEF5-4F67-8F35-4FA9FDD16580}"/>
               </a:ext>
             </a:extLst>
           </p:cNvPr>
@@ -4180,7 +4079,7 @@
           <p:cNvPr id="10" name="">
             <a:extLst xmlns:a="http://schemas.openxmlformats.org/drawingml/2006/main">
               <a:ext uri="{FF2B5EF4-FFF2-40B4-BE49-F238E27FC236}">
-                <a16:creationId xmlns:a16="http://schemas.microsoft.com/office/drawing/2014/main" id="{C88D5DDE-6EF4-4A1E-B67F-C74001830B3D}"/>
+                <a16:creationId xmlns:a16="http://schemas.microsoft.com/office/drawing/2014/main" id="{50770BB5-9D7E-4934-8F31-246DD51A9D0E}"/>
               </a:ext>
             </a:extLst>
           </p:cNvPr>
@@ -4269,1318 +4168,7 @@
     </p:spTree>
     <p:extLst>
       <p:ext uri="{BB962C8B-B14F-4D97-AF65-F5344CB8AC3E}">
-        <p14:creationId xmlns:p14="http://schemas.microsoft.com/office/powerpoint/2010/main" val="1665989767"/>
-      </p:ext>
-    </p:extLst>
-  </p:cSld>
-</p:sld>
-</file>
-
-<file path=ppt/slides/slide10.xml><?xml version="1.0" encoding="utf-8"?>
-<p:sld xmlns:p="http://schemas.openxmlformats.org/presentationml/2006/main">
-  <p:cSld>
-    <p:bg>
-      <p:bgPr>
-        <a:solidFill xmlns:a="http://schemas.openxmlformats.org/drawingml/2006/main">
-          <a:srgbClr val="F6F5F2"/>
-        </a:solidFill>
-      </p:bgPr>
-    </p:bg>
-    <p:spTree>
-      <p:nvGrpSpPr>
-        <p:cNvPr id="1" name=""/>
-        <p:cNvGrpSpPr/>
-        <p:nvPr/>
-      </p:nvGrpSpPr>
-      <p:grpSpPr>
-        <a:xfrm xmlns:a="http://schemas.openxmlformats.org/drawingml/2006/main"/>
-      </p:grpSpPr>
-      <p:pic>
-        <p:nvPicPr>
-          <p:cNvPr id="21" name="">
-            <a:extLst xmlns:a="http://schemas.openxmlformats.org/drawingml/2006/main">
-              <a:ext uri="{FF2B5EF4-FFF2-40B4-BE49-F238E27FC236}">
-                <a16:creationId xmlns:a16="http://schemas.microsoft.com/office/drawing/2014/main" id="{6DF9E8EF-B071-4442-830E-AE9068920AE3}"/>
-              </a:ext>
-            </a:extLst>
-          </p:cNvPr>
-          <p:cNvPicPr>
-            <a:picLocks xmlns:a="http://schemas.openxmlformats.org/drawingml/2006/main" noChangeAspect="1"/>
-          </p:cNvPicPr>
-          <p:nvPr/>
-        </p:nvPicPr>
-        <p:blipFill>
-          <a:blip xmlns:r="http://schemas.openxmlformats.org/officeDocument/2006/relationships" xmlns:a="http://schemas.openxmlformats.org/drawingml/2006/main" r:embed="R779165f359864af7"/>
-          <a:stretch xmlns:a="http://schemas.openxmlformats.org/drawingml/2006/main"/>
-        </p:blipFill>
-        <p:spPr>
-          <a:xfrm xmlns:a="http://schemas.openxmlformats.org/drawingml/2006/main">
-            <a:off x="504825" y="278130"/>
-            <a:ext cx="1600200" cy="320040"/>
-          </a:xfrm>
-          <a:prstGeom xmlns:a="http://schemas.openxmlformats.org/drawingml/2006/main" prst="rect">
-            <a:avLst/>
-          </a:prstGeom>
-        </p:spPr>
-      </p:pic>
-      <p:sp>
-        <p:nvSpPr>
-          <p:cNvPr id="2" name="">
-            <a:extLst xmlns:a="http://schemas.openxmlformats.org/drawingml/2006/main">
-              <a:ext uri="{FF2B5EF4-FFF2-40B4-BE49-F238E27FC236}">
-                <a16:creationId xmlns:a16="http://schemas.microsoft.com/office/drawing/2014/main" id="{47B8DDA5-C5B4-49FE-B14B-366E25A7905C}"/>
-              </a:ext>
-            </a:extLst>
-          </p:cNvPr>
-          <p:cNvSpPr>
-            <a:spLocks xmlns:a="http://schemas.openxmlformats.org/drawingml/2006/main" noGrp="1"/>
-          </p:cNvSpPr>
-          <p:nvPr/>
-        </p:nvSpPr>
-        <p:spPr>
-          <a:xfrm xmlns:a="http://schemas.openxmlformats.org/drawingml/2006/main">
-            <a:off x="6858000" y="323850"/>
-            <a:ext cx="3333750" cy="228600"/>
-          </a:xfrm>
-          <a:prstGeom xmlns:a="http://schemas.openxmlformats.org/drawingml/2006/main" prst="rect">
-            <a:avLst/>
-          </a:prstGeom>
-          <a:noFill xmlns:a="http://schemas.openxmlformats.org/drawingml/2006/main"/>
-          <a:ln xmlns:a="http://schemas.openxmlformats.org/drawingml/2006/main" w="0">
-            <a:noFill/>
-          </a:ln>
-        </p:spPr>
-        <p:txBody>
-          <a:bodyPr xmlns:a="http://schemas.openxmlformats.org/drawingml/2006/main" lIns="0" tIns="0" rIns="0" bIns="0" anchor="t">
-            <a:noAutofit/>
-          </a:bodyPr>
-          <a:lstStyle xmlns:a="http://schemas.openxmlformats.org/drawingml/2006/main">
-            <a:defPPr algn="r">
-              <a:defRPr sz="975" b="0">
-                <a:solidFill>
-                  <a:srgbClr val="737C96"/>
-                </a:solidFill>
-                <a:latin typeface="Courier New"/>
-                <a:ea typeface="Courier New"/>
-                <a:cs typeface="Courier New"/>
-              </a:defRPr>
-            </a:defPPr>
-          </a:lstStyle>
-          <a:p xmlns:a="http://schemas.openxmlformats.org/drawingml/2006/main">
-            <a:pPr algn="r">
-              <a:defRPr sz="975" b="0">
-                <a:solidFill>
-                  <a:srgbClr val="737C96"/>
-                </a:solidFill>
-                <a:latin typeface="Courier New"/>
-                <a:ea typeface="Courier New"/>
-                <a:cs typeface="Courier New"/>
-              </a:defRPr>
-            </a:pPr>
-            <a:r>
-              <a:rPr sz="975" b="0">
-                <a:solidFill>
-                  <a:srgbClr val="737C96"/>
-                </a:solidFill>
-                <a:latin typeface="Courier New"/>
-                <a:ea typeface="Courier New"/>
-                <a:cs typeface="Courier New"/>
-              </a:rPr>
-              <a:t>ПИЛОТ</a:t>
-            </a:r>
-          </a:p>
-        </p:txBody>
-      </p:sp>
-      <p:sp>
-        <p:nvSpPr>
-          <p:cNvPr id="3" name="">
-            <a:extLst xmlns:a="http://schemas.openxmlformats.org/drawingml/2006/main">
-              <a:ext uri="{FF2B5EF4-FFF2-40B4-BE49-F238E27FC236}">
-                <a16:creationId xmlns:a16="http://schemas.microsoft.com/office/drawing/2014/main" id="{23A920E4-E886-4BBF-8BFE-EEA0DA6EA7EF}"/>
-              </a:ext>
-            </a:extLst>
-          </p:cNvPr>
-          <p:cNvSpPr>
-            <a:spLocks xmlns:a="http://schemas.openxmlformats.org/drawingml/2006/main" noGrp="1"/>
-          </p:cNvSpPr>
-          <p:nvPr/>
-        </p:nvSpPr>
-        <p:spPr>
-          <a:xfrm xmlns:a="http://schemas.openxmlformats.org/drawingml/2006/main">
-            <a:off x="504825" y="5657850"/>
-            <a:ext cx="1028700" cy="171450"/>
-          </a:xfrm>
-          <a:prstGeom xmlns:a="http://schemas.openxmlformats.org/drawingml/2006/main" prst="rect">
-            <a:avLst/>
-          </a:prstGeom>
-          <a:noFill xmlns:a="http://schemas.openxmlformats.org/drawingml/2006/main"/>
-          <a:ln xmlns:a="http://schemas.openxmlformats.org/drawingml/2006/main" w="0">
-            <a:noFill/>
-          </a:ln>
-        </p:spPr>
-        <p:txBody>
-          <a:bodyPr xmlns:a="http://schemas.openxmlformats.org/drawingml/2006/main" lIns="0" tIns="0" rIns="0" bIns="0" anchor="t">
-            <a:noAutofit/>
-          </a:bodyPr>
-          <a:lstStyle xmlns:a="http://schemas.openxmlformats.org/drawingml/2006/main">
-            <a:defPPr>
-              <a:defRPr sz="900" b="1">
-                <a:solidFill>
-                  <a:srgbClr val="737C96"/>
-                </a:solidFill>
-                <a:latin typeface="Courier New"/>
-                <a:ea typeface="Courier New"/>
-                <a:cs typeface="Courier New"/>
-              </a:defRPr>
-            </a:defPPr>
-          </a:lstStyle>
-          <a:p xmlns:a="http://schemas.openxmlformats.org/drawingml/2006/main">
-            <a:pPr>
-              <a:defRPr sz="900" b="1">
-                <a:solidFill>
-                  <a:srgbClr val="737C96"/>
-                </a:solidFill>
-                <a:latin typeface="Courier New"/>
-                <a:ea typeface="Courier New"/>
-                <a:cs typeface="Courier New"/>
-              </a:defRPr>
-            </a:pPr>
-            <a:r>
-              <a:rPr sz="900" b="1">
-                <a:solidFill>
-                  <a:srgbClr val="737C96"/>
-                </a:solidFill>
-                <a:latin typeface="Courier New"/>
-                <a:ea typeface="Courier New"/>
-                <a:cs typeface="Courier New"/>
-              </a:rPr>
-              <a:t>SKILLAZ ×</a:t>
-            </a:r>
-          </a:p>
-        </p:txBody>
-      </p:sp>
-      <p:sp>
-        <p:nvSpPr>
-          <p:cNvPr id="4" name="">
-            <a:extLst xmlns:a="http://schemas.openxmlformats.org/drawingml/2006/main">
-              <a:ext uri="{FF2B5EF4-FFF2-40B4-BE49-F238E27FC236}">
-                <a16:creationId xmlns:a16="http://schemas.microsoft.com/office/drawing/2014/main" id="{FF221E52-12F9-4951-A3F2-0B81B639F7AF}"/>
-              </a:ext>
-            </a:extLst>
-          </p:cNvPr>
-          <p:cNvSpPr>
-            <a:spLocks xmlns:a="http://schemas.openxmlformats.org/drawingml/2006/main" noGrp="1"/>
-          </p:cNvSpPr>
-          <p:nvPr/>
-        </p:nvSpPr>
-        <p:spPr>
-          <a:xfrm xmlns:a="http://schemas.openxmlformats.org/drawingml/2006/main">
-            <a:off x="1552575" y="5657850"/>
-            <a:ext cx="571500" cy="171450"/>
-          </a:xfrm>
-          <a:prstGeom xmlns:a="http://schemas.openxmlformats.org/drawingml/2006/main" prst="rect">
-            <a:avLst/>
-          </a:prstGeom>
-          <a:noFill xmlns:a="http://schemas.openxmlformats.org/drawingml/2006/main"/>
-          <a:ln xmlns:a="http://schemas.openxmlformats.org/drawingml/2006/main" w="0">
-            <a:noFill/>
-          </a:ln>
-        </p:spPr>
-        <p:txBody>
-          <a:bodyPr xmlns:a="http://schemas.openxmlformats.org/drawingml/2006/main" lIns="0" tIns="0" rIns="0" bIns="0" anchor="t">
-            <a:noAutofit/>
-          </a:bodyPr>
-          <a:lstStyle xmlns:a="http://schemas.openxmlformats.org/drawingml/2006/main">
-            <a:defPPr>
-              <a:defRPr sz="900" b="1">
-                <a:solidFill>
-                  <a:srgbClr val="E60023"/>
-                </a:solidFill>
-                <a:latin typeface="Courier New"/>
-                <a:ea typeface="Courier New"/>
-                <a:cs typeface="Courier New"/>
-              </a:defRPr>
-            </a:defPPr>
-          </a:lstStyle>
-          <a:p xmlns:a="http://schemas.openxmlformats.org/drawingml/2006/main">
-            <a:pPr>
-              <a:defRPr sz="900" b="1">
-                <a:solidFill>
-                  <a:srgbClr val="E60023"/>
-                </a:solidFill>
-                <a:latin typeface="Courier New"/>
-                <a:ea typeface="Courier New"/>
-                <a:cs typeface="Courier New"/>
-              </a:defRPr>
-            </a:pPr>
-            <a:r>
-              <a:rPr sz="900" b="1">
-                <a:solidFill>
-                  <a:srgbClr val="E60023"/>
-                </a:solidFill>
-                <a:latin typeface="Courier New"/>
-                <a:ea typeface="Courier New"/>
-                <a:cs typeface="Courier New"/>
-              </a:rPr>
-              <a:t>HH.RU</a:t>
-            </a:r>
-          </a:p>
-        </p:txBody>
-      </p:sp>
-      <p:sp>
-        <p:nvSpPr>
-          <p:cNvPr id="5" name="">
-            <a:extLst xmlns:a="http://schemas.openxmlformats.org/drawingml/2006/main">
-              <a:ext uri="{FF2B5EF4-FFF2-40B4-BE49-F238E27FC236}">
-                <a16:creationId xmlns:a16="http://schemas.microsoft.com/office/drawing/2014/main" id="{F4029CC3-DF30-4D5F-A1A6-DEF4D2B70A85}"/>
-              </a:ext>
-            </a:extLst>
-          </p:cNvPr>
-          <p:cNvSpPr>
-            <a:spLocks xmlns:a="http://schemas.openxmlformats.org/drawingml/2006/main" noGrp="1"/>
-          </p:cNvSpPr>
-          <p:nvPr/>
-        </p:nvSpPr>
-        <p:spPr>
-          <a:xfrm xmlns:a="http://schemas.openxmlformats.org/drawingml/2006/main">
-            <a:off x="9410700" y="5657850"/>
-            <a:ext cx="790575" cy="171450"/>
-          </a:xfrm>
-          <a:prstGeom xmlns:a="http://schemas.openxmlformats.org/drawingml/2006/main" prst="rect">
-            <a:avLst/>
-          </a:prstGeom>
-          <a:noFill xmlns:a="http://schemas.openxmlformats.org/drawingml/2006/main"/>
-          <a:ln xmlns:a="http://schemas.openxmlformats.org/drawingml/2006/main" w="0">
-            <a:noFill/>
-          </a:ln>
-        </p:spPr>
-        <p:txBody>
-          <a:bodyPr xmlns:a="http://schemas.openxmlformats.org/drawingml/2006/main" lIns="0" tIns="0" rIns="0" bIns="0" anchor="t">
-            <a:noAutofit/>
-          </a:bodyPr>
-          <a:lstStyle xmlns:a="http://schemas.openxmlformats.org/drawingml/2006/main">
-            <a:defPPr>
-              <a:defRPr sz="900" b="1">
-                <a:solidFill>
-                  <a:srgbClr val="737C96"/>
-                </a:solidFill>
-                <a:latin typeface="Courier New"/>
-                <a:ea typeface="Courier New"/>
-                <a:cs typeface="Courier New"/>
-              </a:defRPr>
-            </a:defPPr>
-          </a:lstStyle>
-          <a:p xmlns:a="http://schemas.openxmlformats.org/drawingml/2006/main">
-            <a:pPr>
-              <a:defRPr sz="900" b="1">
-                <a:solidFill>
-                  <a:srgbClr val="737C96"/>
-                </a:solidFill>
-                <a:latin typeface="Courier New"/>
-                <a:ea typeface="Courier New"/>
-                <a:cs typeface="Courier New"/>
-              </a:defRPr>
-            </a:pPr>
-            <a:r>
-              <a:rPr sz="900" b="1">
-                <a:solidFill>
-                  <a:srgbClr val="737C96"/>
-                </a:solidFill>
-                <a:latin typeface="Courier New"/>
-                <a:ea typeface="Courier New"/>
-                <a:cs typeface="Courier New"/>
-              </a:rPr>
-              <a:t>10 / 10</a:t>
-            </a:r>
-          </a:p>
-        </p:txBody>
-      </p:sp>
-      <p:sp>
-        <p:nvSpPr>
-          <p:cNvPr id="6" name="">
-            <a:extLst xmlns:a="http://schemas.openxmlformats.org/drawingml/2006/main">
-              <a:ext uri="{FF2B5EF4-FFF2-40B4-BE49-F238E27FC236}">
-                <a16:creationId xmlns:a16="http://schemas.microsoft.com/office/drawing/2014/main" id="{534C2C49-E2A3-434B-A8D7-123B0603213E}"/>
-              </a:ext>
-            </a:extLst>
-          </p:cNvPr>
-          <p:cNvSpPr>
-            <a:spLocks xmlns:a="http://schemas.openxmlformats.org/drawingml/2006/main" noGrp="1"/>
-          </p:cNvSpPr>
-          <p:nvPr/>
-        </p:nvSpPr>
-        <p:spPr>
-          <a:xfrm xmlns:a="http://schemas.openxmlformats.org/drawingml/2006/main">
-            <a:off x="0" y="971550"/>
-            <a:ext cx="10692384" cy="1285875"/>
-          </a:xfrm>
-          <a:prstGeom xmlns:a="http://schemas.openxmlformats.org/drawingml/2006/main" prst="rect">
-            <a:avLst/>
-          </a:prstGeom>
-          <a:solidFill xmlns:a="http://schemas.openxmlformats.org/drawingml/2006/main">
-            <a:srgbClr val="FFCC00"/>
-          </a:solidFill>
-          <a:ln xmlns:a="http://schemas.openxmlformats.org/drawingml/2006/main" w="0">
-            <a:noFill/>
-          </a:ln>
-        </p:spPr>
-      </p:sp>
-      <p:sp>
-        <p:nvSpPr>
-          <p:cNvPr id="7" name="">
-            <a:extLst xmlns:a="http://schemas.openxmlformats.org/drawingml/2006/main">
-              <a:ext uri="{FF2B5EF4-FFF2-40B4-BE49-F238E27FC236}">
-                <a16:creationId xmlns:a16="http://schemas.microsoft.com/office/drawing/2014/main" id="{D877476E-EBE9-4027-A9A5-9CFC2C1A18F3}"/>
-              </a:ext>
-            </a:extLst>
-          </p:cNvPr>
-          <p:cNvSpPr>
-            <a:spLocks xmlns:a="http://schemas.openxmlformats.org/drawingml/2006/main" noGrp="1"/>
-          </p:cNvSpPr>
-          <p:nvPr/>
-        </p:nvSpPr>
-        <p:spPr>
-          <a:xfrm xmlns:a="http://schemas.openxmlformats.org/drawingml/2006/main">
-            <a:off x="504825" y="1314450"/>
-            <a:ext cx="9810750" cy="619125"/>
-          </a:xfrm>
-          <a:prstGeom xmlns:a="http://schemas.openxmlformats.org/drawingml/2006/main" prst="rect">
-            <a:avLst/>
-          </a:prstGeom>
-          <a:noFill xmlns:a="http://schemas.openxmlformats.org/drawingml/2006/main"/>
-          <a:ln xmlns:a="http://schemas.openxmlformats.org/drawingml/2006/main" w="0">
-            <a:noFill/>
-          </a:ln>
-        </p:spPr>
-        <p:txBody>
-          <a:bodyPr xmlns:a="http://schemas.openxmlformats.org/drawingml/2006/main" lIns="0" tIns="0" rIns="0" bIns="0" anchor="t">
-            <a:noAutofit/>
-          </a:bodyPr>
-          <a:lstStyle xmlns:a="http://schemas.openxmlformats.org/drawingml/2006/main">
-            <a:defPPr>
-              <a:defRPr sz="3225" b="1">
-                <a:solidFill>
-                  <a:srgbClr val="101022"/>
-                </a:solidFill>
-                <a:latin typeface="Arial"/>
-                <a:ea typeface="Arial"/>
-                <a:cs typeface="Arial"/>
-              </a:defRPr>
-            </a:defPPr>
-          </a:lstStyle>
-          <a:p xmlns:a="http://schemas.openxmlformats.org/drawingml/2006/main">
-            <a:pPr>
-              <a:defRPr sz="3225" b="1">
-                <a:solidFill>
-                  <a:srgbClr val="101022"/>
-                </a:solidFill>
-                <a:latin typeface="Arial"/>
-                <a:ea typeface="Arial"/>
-                <a:cs typeface="Arial"/>
-              </a:defRPr>
-            </a:pPr>
-            <a:r>
-              <a:rPr sz="3225" b="1">
-                <a:solidFill>
-                  <a:srgbClr val="101022"/>
-                </a:solidFill>
-                <a:latin typeface="Arial"/>
-                <a:ea typeface="Arial"/>
-                <a:cs typeface="Arial"/>
-              </a:rPr>
-              <a:t>Как проверить пользу интеграции</a:t>
-            </a:r>
-          </a:p>
-        </p:txBody>
-      </p:sp>
-      <p:sp>
-        <p:nvSpPr>
-          <p:cNvPr id="8" name="">
-            <a:extLst xmlns:a="http://schemas.openxmlformats.org/drawingml/2006/main">
-              <a:ext uri="{FF2B5EF4-FFF2-40B4-BE49-F238E27FC236}">
-                <a16:creationId xmlns:a16="http://schemas.microsoft.com/office/drawing/2014/main" id="{F688F629-9E0D-45E4-BC03-98AB91275E32}"/>
-              </a:ext>
-            </a:extLst>
-          </p:cNvPr>
-          <p:cNvSpPr>
-            <a:spLocks xmlns:a="http://schemas.openxmlformats.org/drawingml/2006/main" noGrp="1"/>
-          </p:cNvSpPr>
-          <p:nvPr/>
-        </p:nvSpPr>
-        <p:spPr>
-          <a:xfrm xmlns:a="http://schemas.openxmlformats.org/drawingml/2006/main">
-            <a:off x="504825" y="2600325"/>
-            <a:ext cx="447675" cy="304800"/>
-          </a:xfrm>
-          <a:prstGeom xmlns:a="http://schemas.openxmlformats.org/drawingml/2006/main" prst="rect">
-            <a:avLst/>
-          </a:prstGeom>
-          <a:noFill xmlns:a="http://schemas.openxmlformats.org/drawingml/2006/main"/>
-          <a:ln xmlns:a="http://schemas.openxmlformats.org/drawingml/2006/main" w="0">
-            <a:noFill/>
-          </a:ln>
-        </p:spPr>
-        <p:txBody>
-          <a:bodyPr xmlns:a="http://schemas.openxmlformats.org/drawingml/2006/main" lIns="0" tIns="0" rIns="0" bIns="0" anchor="t">
-            <a:noAutofit/>
-          </a:bodyPr>
-          <a:lstStyle xmlns:a="http://schemas.openxmlformats.org/drawingml/2006/main">
-            <a:defPPr>
-              <a:defRPr sz="1575" b="1">
-                <a:solidFill>
-                  <a:srgbClr val="101022"/>
-                </a:solidFill>
-                <a:latin typeface="Courier New"/>
-                <a:ea typeface="Courier New"/>
-                <a:cs typeface="Courier New"/>
-              </a:defRPr>
-            </a:defPPr>
-          </a:lstStyle>
-          <a:p xmlns:a="http://schemas.openxmlformats.org/drawingml/2006/main">
-            <a:pPr>
-              <a:defRPr sz="1575" b="1">
-                <a:solidFill>
-                  <a:srgbClr val="101022"/>
-                </a:solidFill>
-                <a:latin typeface="Courier New"/>
-                <a:ea typeface="Courier New"/>
-                <a:cs typeface="Courier New"/>
-              </a:defRPr>
-            </a:pPr>
-            <a:r>
-              <a:rPr sz="1575" b="1">
-                <a:solidFill>
-                  <a:srgbClr val="101022"/>
-                </a:solidFill>
-                <a:latin typeface="Courier New"/>
-                <a:ea typeface="Courier New"/>
-                <a:cs typeface="Courier New"/>
-              </a:rPr>
-              <a:t>01</a:t>
-            </a:r>
-          </a:p>
-        </p:txBody>
-      </p:sp>
-      <p:sp>
-        <p:nvSpPr>
-          <p:cNvPr id="9" name="">
-            <a:extLst xmlns:a="http://schemas.openxmlformats.org/drawingml/2006/main">
-              <a:ext uri="{FF2B5EF4-FFF2-40B4-BE49-F238E27FC236}">
-                <a16:creationId xmlns:a16="http://schemas.microsoft.com/office/drawing/2014/main" id="{095E2480-B5E9-44FF-BA5D-707ED98590C0}"/>
-              </a:ext>
-            </a:extLst>
-          </p:cNvPr>
-          <p:cNvSpPr>
-            <a:spLocks xmlns:a="http://schemas.openxmlformats.org/drawingml/2006/main" noGrp="1"/>
-          </p:cNvSpPr>
-          <p:nvPr/>
-        </p:nvSpPr>
-        <p:spPr>
-          <a:xfrm xmlns:a="http://schemas.openxmlformats.org/drawingml/2006/main">
-            <a:off x="1190625" y="2600325"/>
-            <a:ext cx="2286000" cy="304800"/>
-          </a:xfrm>
-          <a:prstGeom xmlns:a="http://schemas.openxmlformats.org/drawingml/2006/main" prst="rect">
-            <a:avLst/>
-          </a:prstGeom>
-          <a:noFill xmlns:a="http://schemas.openxmlformats.org/drawingml/2006/main"/>
-          <a:ln xmlns:a="http://schemas.openxmlformats.org/drawingml/2006/main" w="0">
-            <a:noFill/>
-          </a:ln>
-        </p:spPr>
-        <p:txBody>
-          <a:bodyPr xmlns:a="http://schemas.openxmlformats.org/drawingml/2006/main" lIns="0" tIns="0" rIns="0" bIns="0" anchor="t">
-            <a:noAutofit/>
-          </a:bodyPr>
-          <a:lstStyle xmlns:a="http://schemas.openxmlformats.org/drawingml/2006/main">
-            <a:defPPr>
-              <a:defRPr sz="1725" b="1">
-                <a:solidFill>
-                  <a:srgbClr val="101022"/>
-                </a:solidFill>
-                <a:latin typeface="Arial"/>
-                <a:ea typeface="Arial"/>
-                <a:cs typeface="Arial"/>
-              </a:defRPr>
-            </a:defPPr>
-          </a:lstStyle>
-          <a:p xmlns:a="http://schemas.openxmlformats.org/drawingml/2006/main">
-            <a:pPr>
-              <a:defRPr sz="1725" b="1">
-                <a:solidFill>
-                  <a:srgbClr val="101022"/>
-                </a:solidFill>
-                <a:latin typeface="Arial"/>
-                <a:ea typeface="Arial"/>
-                <a:cs typeface="Arial"/>
-              </a:defRPr>
-            </a:pPr>
-            <a:r>
-              <a:rPr sz="1725" b="1">
-                <a:solidFill>
-                  <a:srgbClr val="101022"/>
-                </a:solidFill>
-                <a:latin typeface="Arial"/>
-                <a:ea typeface="Arial"/>
-                <a:cs typeface="Arial"/>
-              </a:rPr>
-              <a:t>Доступ к данным</a:t>
-            </a:r>
-          </a:p>
-        </p:txBody>
-      </p:sp>
-      <p:sp>
-        <p:nvSpPr>
-          <p:cNvPr id="10" name="">
-            <a:extLst xmlns:a="http://schemas.openxmlformats.org/drawingml/2006/main">
-              <a:ext uri="{FF2B5EF4-FFF2-40B4-BE49-F238E27FC236}">
-                <a16:creationId xmlns:a16="http://schemas.microsoft.com/office/drawing/2014/main" id="{21AF3D37-D292-4EC4-BDB0-DB5D76BC3D26}"/>
-              </a:ext>
-            </a:extLst>
-          </p:cNvPr>
-          <p:cNvSpPr>
-            <a:spLocks xmlns:a="http://schemas.openxmlformats.org/drawingml/2006/main" noGrp="1"/>
-          </p:cNvSpPr>
-          <p:nvPr/>
-        </p:nvSpPr>
-        <p:spPr>
-          <a:xfrm xmlns:a="http://schemas.openxmlformats.org/drawingml/2006/main">
-            <a:off x="3714750" y="2600325"/>
-            <a:ext cx="6477000" cy="342900"/>
-          </a:xfrm>
-          <a:prstGeom xmlns:a="http://schemas.openxmlformats.org/drawingml/2006/main" prst="rect">
-            <a:avLst/>
-          </a:prstGeom>
-          <a:noFill xmlns:a="http://schemas.openxmlformats.org/drawingml/2006/main"/>
-          <a:ln xmlns:a="http://schemas.openxmlformats.org/drawingml/2006/main" w="0">
-            <a:noFill/>
-          </a:ln>
-        </p:spPr>
-        <p:txBody>
-          <a:bodyPr xmlns:a="http://schemas.openxmlformats.org/drawingml/2006/main" lIns="0" tIns="0" rIns="0" bIns="0" anchor="t">
-            <a:noAutofit/>
-          </a:bodyPr>
-          <a:lstStyle xmlns:a="http://schemas.openxmlformats.org/drawingml/2006/main">
-            <a:defPPr>
-              <a:defRPr sz="1575" b="0">
-                <a:solidFill>
-                  <a:srgbClr val="737C96"/>
-                </a:solidFill>
-                <a:latin typeface="Arial"/>
-                <a:ea typeface="Arial"/>
-                <a:cs typeface="Arial"/>
-              </a:defRPr>
-            </a:defPPr>
-          </a:lstStyle>
-          <a:p xmlns:a="http://schemas.openxmlformats.org/drawingml/2006/main">
-            <a:pPr>
-              <a:defRPr sz="1575" b="0">
-                <a:solidFill>
-                  <a:srgbClr val="737C96"/>
-                </a:solidFill>
-                <a:latin typeface="Arial"/>
-                <a:ea typeface="Arial"/>
-                <a:cs typeface="Arial"/>
-              </a:defRPr>
-            </a:pPr>
-            <a:r>
-              <a:rPr sz="1575" b="0">
-                <a:solidFill>
-                  <a:srgbClr val="737C96"/>
-                </a:solidFill>
-                <a:latin typeface="Arial"/>
-                <a:ea typeface="Arial"/>
-                <a:cs typeface="Arial"/>
-              </a:rPr>
-              <a:t>Проверить получение результатов приложением Skillaz</a:t>
-            </a:r>
-          </a:p>
-        </p:txBody>
-      </p:sp>
-      <p:sp>
-        <p:nvSpPr>
-          <p:cNvPr id="11" name="">
-            <a:extLst xmlns:a="http://schemas.openxmlformats.org/drawingml/2006/main">
-              <a:ext uri="{FF2B5EF4-FFF2-40B4-BE49-F238E27FC236}">
-                <a16:creationId xmlns:a16="http://schemas.microsoft.com/office/drawing/2014/main" id="{24C8413C-AA37-4AC4-A42A-6D42A5D38911}"/>
-              </a:ext>
-            </a:extLst>
-          </p:cNvPr>
-          <p:cNvSpPr>
-            <a:spLocks xmlns:a="http://schemas.openxmlformats.org/drawingml/2006/main" noGrp="1"/>
-          </p:cNvSpPr>
-          <p:nvPr/>
-        </p:nvSpPr>
-        <p:spPr>
-          <a:xfrm xmlns:a="http://schemas.openxmlformats.org/drawingml/2006/main">
-            <a:off x="504825" y="3190875"/>
-            <a:ext cx="447675" cy="304800"/>
-          </a:xfrm>
-          <a:prstGeom xmlns:a="http://schemas.openxmlformats.org/drawingml/2006/main" prst="rect">
-            <a:avLst/>
-          </a:prstGeom>
-          <a:noFill xmlns:a="http://schemas.openxmlformats.org/drawingml/2006/main"/>
-          <a:ln xmlns:a="http://schemas.openxmlformats.org/drawingml/2006/main" w="0">
-            <a:noFill/>
-          </a:ln>
-        </p:spPr>
-        <p:txBody>
-          <a:bodyPr xmlns:a="http://schemas.openxmlformats.org/drawingml/2006/main" lIns="0" tIns="0" rIns="0" bIns="0" anchor="t">
-            <a:noAutofit/>
-          </a:bodyPr>
-          <a:lstStyle xmlns:a="http://schemas.openxmlformats.org/drawingml/2006/main">
-            <a:defPPr>
-              <a:defRPr sz="1575" b="1">
-                <a:solidFill>
-                  <a:srgbClr val="101022"/>
-                </a:solidFill>
-                <a:latin typeface="Courier New"/>
-                <a:ea typeface="Courier New"/>
-                <a:cs typeface="Courier New"/>
-              </a:defRPr>
-            </a:defPPr>
-          </a:lstStyle>
-          <a:p xmlns:a="http://schemas.openxmlformats.org/drawingml/2006/main">
-            <a:pPr>
-              <a:defRPr sz="1575" b="1">
-                <a:solidFill>
-                  <a:srgbClr val="101022"/>
-                </a:solidFill>
-                <a:latin typeface="Courier New"/>
-                <a:ea typeface="Courier New"/>
-                <a:cs typeface="Courier New"/>
-              </a:defRPr>
-            </a:pPr>
-            <a:r>
-              <a:rPr sz="1575" b="1">
-                <a:solidFill>
-                  <a:srgbClr val="101022"/>
-                </a:solidFill>
-                <a:latin typeface="Courier New"/>
-                <a:ea typeface="Courier New"/>
-                <a:cs typeface="Courier New"/>
-              </a:rPr>
-              <a:t>02</a:t>
-            </a:r>
-          </a:p>
-        </p:txBody>
-      </p:sp>
-      <p:sp>
-        <p:nvSpPr>
-          <p:cNvPr id="12" name="">
-            <a:extLst xmlns:a="http://schemas.openxmlformats.org/drawingml/2006/main">
-              <a:ext uri="{FF2B5EF4-FFF2-40B4-BE49-F238E27FC236}">
-                <a16:creationId xmlns:a16="http://schemas.microsoft.com/office/drawing/2014/main" id="{C6D058F7-B198-455C-8E57-FFD12B93E8C0}"/>
-              </a:ext>
-            </a:extLst>
-          </p:cNvPr>
-          <p:cNvSpPr>
-            <a:spLocks xmlns:a="http://schemas.openxmlformats.org/drawingml/2006/main" noGrp="1"/>
-          </p:cNvSpPr>
-          <p:nvPr/>
-        </p:nvSpPr>
-        <p:spPr>
-          <a:xfrm xmlns:a="http://schemas.openxmlformats.org/drawingml/2006/main">
-            <a:off x="1190625" y="3190875"/>
-            <a:ext cx="2286000" cy="304800"/>
-          </a:xfrm>
-          <a:prstGeom xmlns:a="http://schemas.openxmlformats.org/drawingml/2006/main" prst="rect">
-            <a:avLst/>
-          </a:prstGeom>
-          <a:noFill xmlns:a="http://schemas.openxmlformats.org/drawingml/2006/main"/>
-          <a:ln xmlns:a="http://schemas.openxmlformats.org/drawingml/2006/main" w="0">
-            <a:noFill/>
-          </a:ln>
-        </p:spPr>
-        <p:txBody>
-          <a:bodyPr xmlns:a="http://schemas.openxmlformats.org/drawingml/2006/main" lIns="0" tIns="0" rIns="0" bIns="0" anchor="t">
-            <a:noAutofit/>
-          </a:bodyPr>
-          <a:lstStyle xmlns:a="http://schemas.openxmlformats.org/drawingml/2006/main">
-            <a:defPPr>
-              <a:defRPr sz="1725" b="1">
-                <a:solidFill>
-                  <a:srgbClr val="101022"/>
-                </a:solidFill>
-                <a:latin typeface="Arial"/>
-                <a:ea typeface="Arial"/>
-                <a:cs typeface="Arial"/>
-              </a:defRPr>
-            </a:defPPr>
-          </a:lstStyle>
-          <a:p xmlns:a="http://schemas.openxmlformats.org/drawingml/2006/main">
-            <a:pPr>
-              <a:defRPr sz="1725" b="1">
-                <a:solidFill>
-                  <a:srgbClr val="101022"/>
-                </a:solidFill>
-                <a:latin typeface="Arial"/>
-                <a:ea typeface="Arial"/>
-                <a:cs typeface="Arial"/>
-              </a:defRPr>
-            </a:pPr>
-            <a:r>
-              <a:rPr sz="1725" b="1">
-                <a:solidFill>
-                  <a:srgbClr val="101022"/>
-                </a:solidFill>
-                <a:latin typeface="Arial"/>
-                <a:ea typeface="Arial"/>
-                <a:cs typeface="Arial"/>
-              </a:rPr>
-              <a:t>Сравнение</a:t>
-            </a:r>
-          </a:p>
-        </p:txBody>
-      </p:sp>
-      <p:sp>
-        <p:nvSpPr>
-          <p:cNvPr id="13" name="">
-            <a:extLst xmlns:a="http://schemas.openxmlformats.org/drawingml/2006/main">
-              <a:ext uri="{FF2B5EF4-FFF2-40B4-BE49-F238E27FC236}">
-                <a16:creationId xmlns:a16="http://schemas.microsoft.com/office/drawing/2014/main" id="{6ECBF438-77FD-46B4-9F84-BA6194601E15}"/>
-              </a:ext>
-            </a:extLst>
-          </p:cNvPr>
-          <p:cNvSpPr>
-            <a:spLocks xmlns:a="http://schemas.openxmlformats.org/drawingml/2006/main" noGrp="1"/>
-          </p:cNvSpPr>
-          <p:nvPr/>
-        </p:nvSpPr>
-        <p:spPr>
-          <a:xfrm xmlns:a="http://schemas.openxmlformats.org/drawingml/2006/main">
-            <a:off x="3714750" y="3190875"/>
-            <a:ext cx="6477000" cy="342900"/>
-          </a:xfrm>
-          <a:prstGeom xmlns:a="http://schemas.openxmlformats.org/drawingml/2006/main" prst="rect">
-            <a:avLst/>
-          </a:prstGeom>
-          <a:noFill xmlns:a="http://schemas.openxmlformats.org/drawingml/2006/main"/>
-          <a:ln xmlns:a="http://schemas.openxmlformats.org/drawingml/2006/main" w="0">
-            <a:noFill/>
-          </a:ln>
-        </p:spPr>
-        <p:txBody>
-          <a:bodyPr xmlns:a="http://schemas.openxmlformats.org/drawingml/2006/main" lIns="0" tIns="0" rIns="0" bIns="0" anchor="t">
-            <a:noAutofit/>
-          </a:bodyPr>
-          <a:lstStyle xmlns:a="http://schemas.openxmlformats.org/drawingml/2006/main">
-            <a:defPPr>
-              <a:defRPr sz="1575" b="0">
-                <a:solidFill>
-                  <a:srgbClr val="737C96"/>
-                </a:solidFill>
-                <a:latin typeface="Arial"/>
-                <a:ea typeface="Arial"/>
-                <a:cs typeface="Arial"/>
-              </a:defRPr>
-            </a:defPPr>
-          </a:lstStyle>
-          <a:p xmlns:a="http://schemas.openxmlformats.org/drawingml/2006/main">
-            <a:pPr>
-              <a:defRPr sz="1575" b="0">
-                <a:solidFill>
-                  <a:srgbClr val="737C96"/>
-                </a:solidFill>
-                <a:latin typeface="Arial"/>
-                <a:ea typeface="Arial"/>
-                <a:cs typeface="Arial"/>
-              </a:defRPr>
-            </a:pPr>
-            <a:r>
-              <a:rPr sz="1575" b="0">
-                <a:solidFill>
-                  <a:srgbClr val="737C96"/>
-                </a:solidFill>
-                <a:latin typeface="Arial"/>
-                <a:ea typeface="Arial"/>
-                <a:cs typeface="Arial"/>
-              </a:rPr>
-              <a:t>Работа в hh и с теми же результатами в Skillaz</a:t>
-            </a:r>
-          </a:p>
-        </p:txBody>
-      </p:sp>
-      <p:sp>
-        <p:nvSpPr>
-          <p:cNvPr id="14" name="">
-            <a:extLst xmlns:a="http://schemas.openxmlformats.org/drawingml/2006/main">
-              <a:ext uri="{FF2B5EF4-FFF2-40B4-BE49-F238E27FC236}">
-                <a16:creationId xmlns:a16="http://schemas.microsoft.com/office/drawing/2014/main" id="{C35CEF6A-7F70-4FAB-A643-919AB768D470}"/>
-              </a:ext>
-            </a:extLst>
-          </p:cNvPr>
-          <p:cNvSpPr>
-            <a:spLocks xmlns:a="http://schemas.openxmlformats.org/drawingml/2006/main" noGrp="1"/>
-          </p:cNvSpPr>
-          <p:nvPr/>
-        </p:nvSpPr>
-        <p:spPr>
-          <a:xfrm xmlns:a="http://schemas.openxmlformats.org/drawingml/2006/main">
-            <a:off x="504825" y="3781425"/>
-            <a:ext cx="447675" cy="304800"/>
-          </a:xfrm>
-          <a:prstGeom xmlns:a="http://schemas.openxmlformats.org/drawingml/2006/main" prst="rect">
-            <a:avLst/>
-          </a:prstGeom>
-          <a:noFill xmlns:a="http://schemas.openxmlformats.org/drawingml/2006/main"/>
-          <a:ln xmlns:a="http://schemas.openxmlformats.org/drawingml/2006/main" w="0">
-            <a:noFill/>
-          </a:ln>
-        </p:spPr>
-        <p:txBody>
-          <a:bodyPr xmlns:a="http://schemas.openxmlformats.org/drawingml/2006/main" lIns="0" tIns="0" rIns="0" bIns="0" anchor="t">
-            <a:noAutofit/>
-          </a:bodyPr>
-          <a:lstStyle xmlns:a="http://schemas.openxmlformats.org/drawingml/2006/main">
-            <a:defPPr>
-              <a:defRPr sz="1575" b="1">
-                <a:solidFill>
-                  <a:srgbClr val="101022"/>
-                </a:solidFill>
-                <a:latin typeface="Courier New"/>
-                <a:ea typeface="Courier New"/>
-                <a:cs typeface="Courier New"/>
-              </a:defRPr>
-            </a:defPPr>
-          </a:lstStyle>
-          <a:p xmlns:a="http://schemas.openxmlformats.org/drawingml/2006/main">
-            <a:pPr>
-              <a:defRPr sz="1575" b="1">
-                <a:solidFill>
-                  <a:srgbClr val="101022"/>
-                </a:solidFill>
-                <a:latin typeface="Courier New"/>
-                <a:ea typeface="Courier New"/>
-                <a:cs typeface="Courier New"/>
-              </a:defRPr>
-            </a:pPr>
-            <a:r>
-              <a:rPr sz="1575" b="1">
-                <a:solidFill>
-                  <a:srgbClr val="101022"/>
-                </a:solidFill>
-                <a:latin typeface="Courier New"/>
-                <a:ea typeface="Courier New"/>
-                <a:cs typeface="Courier New"/>
-              </a:rPr>
-              <a:t>03</a:t>
-            </a:r>
-          </a:p>
-        </p:txBody>
-      </p:sp>
-      <p:sp>
-        <p:nvSpPr>
-          <p:cNvPr id="15" name="">
-            <a:extLst xmlns:a="http://schemas.openxmlformats.org/drawingml/2006/main">
-              <a:ext uri="{FF2B5EF4-FFF2-40B4-BE49-F238E27FC236}">
-                <a16:creationId xmlns:a16="http://schemas.microsoft.com/office/drawing/2014/main" id="{E815B137-CCAC-43B9-B3AD-E1D7D9574955}"/>
-              </a:ext>
-            </a:extLst>
-          </p:cNvPr>
-          <p:cNvSpPr>
-            <a:spLocks xmlns:a="http://schemas.openxmlformats.org/drawingml/2006/main" noGrp="1"/>
-          </p:cNvSpPr>
-          <p:nvPr/>
-        </p:nvSpPr>
-        <p:spPr>
-          <a:xfrm xmlns:a="http://schemas.openxmlformats.org/drawingml/2006/main">
-            <a:off x="1190625" y="3781425"/>
-            <a:ext cx="2286000" cy="304800"/>
-          </a:xfrm>
-          <a:prstGeom xmlns:a="http://schemas.openxmlformats.org/drawingml/2006/main" prst="rect">
-            <a:avLst/>
-          </a:prstGeom>
-          <a:noFill xmlns:a="http://schemas.openxmlformats.org/drawingml/2006/main"/>
-          <a:ln xmlns:a="http://schemas.openxmlformats.org/drawingml/2006/main" w="0">
-            <a:noFill/>
-          </a:ln>
-        </p:spPr>
-        <p:txBody>
-          <a:bodyPr xmlns:a="http://schemas.openxmlformats.org/drawingml/2006/main" lIns="0" tIns="0" rIns="0" bIns="0" anchor="t">
-            <a:noAutofit/>
-          </a:bodyPr>
-          <a:lstStyle xmlns:a="http://schemas.openxmlformats.org/drawingml/2006/main">
-            <a:defPPr>
-              <a:defRPr sz="1725" b="1">
-                <a:solidFill>
-                  <a:srgbClr val="101022"/>
-                </a:solidFill>
-                <a:latin typeface="Arial"/>
-                <a:ea typeface="Arial"/>
-                <a:cs typeface="Arial"/>
-              </a:defRPr>
-            </a:defPPr>
-          </a:lstStyle>
-          <a:p xmlns:a="http://schemas.openxmlformats.org/drawingml/2006/main">
-            <a:pPr>
-              <a:defRPr sz="1725" b="1">
-                <a:solidFill>
-                  <a:srgbClr val="101022"/>
-                </a:solidFill>
-                <a:latin typeface="Arial"/>
-                <a:ea typeface="Arial"/>
-                <a:cs typeface="Arial"/>
-              </a:defRPr>
-            </a:pPr>
-            <a:r>
-              <a:rPr sz="1725" b="1">
-                <a:solidFill>
-                  <a:srgbClr val="101022"/>
-                </a:solidFill>
-                <a:latin typeface="Arial"/>
-                <a:ea typeface="Arial"/>
-                <a:cs typeface="Arial"/>
-              </a:rPr>
-              <a:t>Замеры</a:t>
-            </a:r>
-          </a:p>
-        </p:txBody>
-      </p:sp>
-      <p:sp>
-        <p:nvSpPr>
-          <p:cNvPr id="16" name="">
-            <a:extLst xmlns:a="http://schemas.openxmlformats.org/drawingml/2006/main">
-              <a:ext uri="{FF2B5EF4-FFF2-40B4-BE49-F238E27FC236}">
-                <a16:creationId xmlns:a16="http://schemas.microsoft.com/office/drawing/2014/main" id="{CECD4F8A-9188-4C41-8B48-7200639D7383}"/>
-              </a:ext>
-            </a:extLst>
-          </p:cNvPr>
-          <p:cNvSpPr>
-            <a:spLocks xmlns:a="http://schemas.openxmlformats.org/drawingml/2006/main" noGrp="1"/>
-          </p:cNvSpPr>
-          <p:nvPr/>
-        </p:nvSpPr>
-        <p:spPr>
-          <a:xfrm xmlns:a="http://schemas.openxmlformats.org/drawingml/2006/main">
-            <a:off x="3714750" y="3781425"/>
-            <a:ext cx="6477000" cy="342900"/>
-          </a:xfrm>
-          <a:prstGeom xmlns:a="http://schemas.openxmlformats.org/drawingml/2006/main" prst="rect">
-            <a:avLst/>
-          </a:prstGeom>
-          <a:noFill xmlns:a="http://schemas.openxmlformats.org/drawingml/2006/main"/>
-          <a:ln xmlns:a="http://schemas.openxmlformats.org/drawingml/2006/main" w="0">
-            <a:noFill/>
-          </a:ln>
-        </p:spPr>
-        <p:txBody>
-          <a:bodyPr xmlns:a="http://schemas.openxmlformats.org/drawingml/2006/main" lIns="0" tIns="0" rIns="0" bIns="0" anchor="t">
-            <a:noAutofit/>
-          </a:bodyPr>
-          <a:lstStyle xmlns:a="http://schemas.openxmlformats.org/drawingml/2006/main">
-            <a:defPPr>
-              <a:defRPr sz="1575" b="0">
-                <a:solidFill>
-                  <a:srgbClr val="737C96"/>
-                </a:solidFill>
-                <a:latin typeface="Arial"/>
-                <a:ea typeface="Arial"/>
-                <a:cs typeface="Arial"/>
-              </a:defRPr>
-            </a:defPPr>
-          </a:lstStyle>
-          <a:p xmlns:a="http://schemas.openxmlformats.org/drawingml/2006/main">
-            <a:pPr>
-              <a:defRPr sz="1575" b="0">
-                <a:solidFill>
-                  <a:srgbClr val="737C96"/>
-                </a:solidFill>
-                <a:latin typeface="Arial"/>
-                <a:ea typeface="Arial"/>
-                <a:cs typeface="Arial"/>
-              </a:defRPr>
-            </a:pPr>
-            <a:r>
-              <a:rPr sz="1575" b="0">
-                <a:solidFill>
-                  <a:srgbClr val="737C96"/>
-                </a:solidFill>
-                <a:latin typeface="Arial"/>
-                <a:ea typeface="Arial"/>
-                <a:cs typeface="Arial"/>
-              </a:rPr>
-              <a:t>Время просмотра, переходы и ручной перенос</a:t>
-            </a:r>
-          </a:p>
-        </p:txBody>
-      </p:sp>
-      <p:sp>
-        <p:nvSpPr>
-          <p:cNvPr id="17" name="">
-            <a:extLst xmlns:a="http://schemas.openxmlformats.org/drawingml/2006/main">
-              <a:ext uri="{FF2B5EF4-FFF2-40B4-BE49-F238E27FC236}">
-                <a16:creationId xmlns:a16="http://schemas.microsoft.com/office/drawing/2014/main" id="{2298ECF2-8E1C-4FBC-AF74-3520A787DB46}"/>
-              </a:ext>
-            </a:extLst>
-          </p:cNvPr>
-          <p:cNvSpPr>
-            <a:spLocks xmlns:a="http://schemas.openxmlformats.org/drawingml/2006/main" noGrp="1"/>
-          </p:cNvSpPr>
-          <p:nvPr/>
-        </p:nvSpPr>
-        <p:spPr>
-          <a:xfrm xmlns:a="http://schemas.openxmlformats.org/drawingml/2006/main">
-            <a:off x="504825" y="4371975"/>
-            <a:ext cx="447675" cy="304800"/>
-          </a:xfrm>
-          <a:prstGeom xmlns:a="http://schemas.openxmlformats.org/drawingml/2006/main" prst="rect">
-            <a:avLst/>
-          </a:prstGeom>
-          <a:noFill xmlns:a="http://schemas.openxmlformats.org/drawingml/2006/main"/>
-          <a:ln xmlns:a="http://schemas.openxmlformats.org/drawingml/2006/main" w="0">
-            <a:noFill/>
-          </a:ln>
-        </p:spPr>
-        <p:txBody>
-          <a:bodyPr xmlns:a="http://schemas.openxmlformats.org/drawingml/2006/main" lIns="0" tIns="0" rIns="0" bIns="0" anchor="t">
-            <a:noAutofit/>
-          </a:bodyPr>
-          <a:lstStyle xmlns:a="http://schemas.openxmlformats.org/drawingml/2006/main">
-            <a:defPPr>
-              <a:defRPr sz="1575" b="1">
-                <a:solidFill>
-                  <a:srgbClr val="101022"/>
-                </a:solidFill>
-                <a:latin typeface="Courier New"/>
-                <a:ea typeface="Courier New"/>
-                <a:cs typeface="Courier New"/>
-              </a:defRPr>
-            </a:defPPr>
-          </a:lstStyle>
-          <a:p xmlns:a="http://schemas.openxmlformats.org/drawingml/2006/main">
-            <a:pPr>
-              <a:defRPr sz="1575" b="1">
-                <a:solidFill>
-                  <a:srgbClr val="101022"/>
-                </a:solidFill>
-                <a:latin typeface="Courier New"/>
-                <a:ea typeface="Courier New"/>
-                <a:cs typeface="Courier New"/>
-              </a:defRPr>
-            </a:pPr>
-            <a:r>
-              <a:rPr sz="1575" b="1">
-                <a:solidFill>
-                  <a:srgbClr val="101022"/>
-                </a:solidFill>
-                <a:latin typeface="Courier New"/>
-                <a:ea typeface="Courier New"/>
-                <a:cs typeface="Courier New"/>
-              </a:rPr>
-              <a:t>04</a:t>
-            </a:r>
-          </a:p>
-        </p:txBody>
-      </p:sp>
-      <p:sp>
-        <p:nvSpPr>
-          <p:cNvPr id="18" name="">
-            <a:extLst xmlns:a="http://schemas.openxmlformats.org/drawingml/2006/main">
-              <a:ext uri="{FF2B5EF4-FFF2-40B4-BE49-F238E27FC236}">
-                <a16:creationId xmlns:a16="http://schemas.microsoft.com/office/drawing/2014/main" id="{602AFF02-781E-4533-91AB-80F086C17F07}"/>
-              </a:ext>
-            </a:extLst>
-          </p:cNvPr>
-          <p:cNvSpPr>
-            <a:spLocks xmlns:a="http://schemas.openxmlformats.org/drawingml/2006/main" noGrp="1"/>
-          </p:cNvSpPr>
-          <p:nvPr/>
-        </p:nvSpPr>
-        <p:spPr>
-          <a:xfrm xmlns:a="http://schemas.openxmlformats.org/drawingml/2006/main">
-            <a:off x="1190625" y="4371975"/>
-            <a:ext cx="2286000" cy="304800"/>
-          </a:xfrm>
-          <a:prstGeom xmlns:a="http://schemas.openxmlformats.org/drawingml/2006/main" prst="rect">
-            <a:avLst/>
-          </a:prstGeom>
-          <a:noFill xmlns:a="http://schemas.openxmlformats.org/drawingml/2006/main"/>
-          <a:ln xmlns:a="http://schemas.openxmlformats.org/drawingml/2006/main" w="0">
-            <a:noFill/>
-          </a:ln>
-        </p:spPr>
-        <p:txBody>
-          <a:bodyPr xmlns:a="http://schemas.openxmlformats.org/drawingml/2006/main" lIns="0" tIns="0" rIns="0" bIns="0" anchor="t">
-            <a:noAutofit/>
-          </a:bodyPr>
-          <a:lstStyle xmlns:a="http://schemas.openxmlformats.org/drawingml/2006/main">
-            <a:defPPr>
-              <a:defRPr sz="1725" b="1">
-                <a:solidFill>
-                  <a:srgbClr val="101022"/>
-                </a:solidFill>
-                <a:latin typeface="Arial"/>
-                <a:ea typeface="Arial"/>
-                <a:cs typeface="Arial"/>
-              </a:defRPr>
-            </a:defPPr>
-          </a:lstStyle>
-          <a:p xmlns:a="http://schemas.openxmlformats.org/drawingml/2006/main">
-            <a:pPr>
-              <a:defRPr sz="1725" b="1">
-                <a:solidFill>
-                  <a:srgbClr val="101022"/>
-                </a:solidFill>
-                <a:latin typeface="Arial"/>
-                <a:ea typeface="Arial"/>
-                <a:cs typeface="Arial"/>
-              </a:defRPr>
-            </a:pPr>
-            <a:r>
-              <a:rPr sz="1725" b="1">
-                <a:solidFill>
-                  <a:srgbClr val="101022"/>
-                </a:solidFill>
-                <a:latin typeface="Arial"/>
-                <a:ea typeface="Arial"/>
-                <a:cs typeface="Arial"/>
-              </a:rPr>
-              <a:t>Оценка пользы</a:t>
-            </a:r>
-          </a:p>
-        </p:txBody>
-      </p:sp>
-      <p:sp>
-        <p:nvSpPr>
-          <p:cNvPr id="19" name="">
-            <a:extLst xmlns:a="http://schemas.openxmlformats.org/drawingml/2006/main">
-              <a:ext uri="{FF2B5EF4-FFF2-40B4-BE49-F238E27FC236}">
-                <a16:creationId xmlns:a16="http://schemas.microsoft.com/office/drawing/2014/main" id="{FB181EAA-9059-4CD9-8804-297651FCBCB5}"/>
-              </a:ext>
-            </a:extLst>
-          </p:cNvPr>
-          <p:cNvSpPr>
-            <a:spLocks xmlns:a="http://schemas.openxmlformats.org/drawingml/2006/main" noGrp="1"/>
-          </p:cNvSpPr>
-          <p:nvPr/>
-        </p:nvSpPr>
-        <p:spPr>
-          <a:xfrm xmlns:a="http://schemas.openxmlformats.org/drawingml/2006/main">
-            <a:off x="3714750" y="4371975"/>
-            <a:ext cx="6477000" cy="342900"/>
-          </a:xfrm>
-          <a:prstGeom xmlns:a="http://schemas.openxmlformats.org/drawingml/2006/main" prst="rect">
-            <a:avLst/>
-          </a:prstGeom>
-          <a:noFill xmlns:a="http://schemas.openxmlformats.org/drawingml/2006/main"/>
-          <a:ln xmlns:a="http://schemas.openxmlformats.org/drawingml/2006/main" w="0">
-            <a:noFill/>
-          </a:ln>
-        </p:spPr>
-        <p:txBody>
-          <a:bodyPr xmlns:a="http://schemas.openxmlformats.org/drawingml/2006/main" lIns="0" tIns="0" rIns="0" bIns="0" anchor="t">
-            <a:noAutofit/>
-          </a:bodyPr>
-          <a:lstStyle xmlns:a="http://schemas.openxmlformats.org/drawingml/2006/main">
-            <a:defPPr>
-              <a:defRPr sz="1575" b="0">
-                <a:solidFill>
-                  <a:srgbClr val="737C96"/>
-                </a:solidFill>
-                <a:latin typeface="Arial"/>
-                <a:ea typeface="Arial"/>
-                <a:cs typeface="Arial"/>
-              </a:defRPr>
-            </a:defPPr>
-          </a:lstStyle>
-          <a:p xmlns:a="http://schemas.openxmlformats.org/drawingml/2006/main">
-            <a:pPr>
-              <a:defRPr sz="1575" b="0">
-                <a:solidFill>
-                  <a:srgbClr val="737C96"/>
-                </a:solidFill>
-                <a:latin typeface="Arial"/>
-                <a:ea typeface="Arial"/>
-                <a:cs typeface="Arial"/>
-              </a:defRPr>
-            </a:pPr>
-            <a:r>
-              <a:rPr sz="1575" b="0">
-                <a:solidFill>
-                  <a:srgbClr val="737C96"/>
-                </a:solidFill>
-                <a:latin typeface="Arial"/>
-                <a:ea typeface="Arial"/>
-                <a:cs typeface="Arial"/>
-              </a:rPr>
-              <a:t>Учесть проверку ИИ и отзывы рекрутеров</a:t>
-            </a:r>
-          </a:p>
-        </p:txBody>
-      </p:sp>
-      <p:sp>
-        <p:nvSpPr>
-          <p:cNvPr id="20" name="">
-            <a:extLst xmlns:a="http://schemas.openxmlformats.org/drawingml/2006/main">
-              <a:ext uri="{FF2B5EF4-FFF2-40B4-BE49-F238E27FC236}">
-                <a16:creationId xmlns:a16="http://schemas.microsoft.com/office/drawing/2014/main" id="{7ABCC267-1DFC-4962-BD10-E142CC563D54}"/>
-              </a:ext>
-            </a:extLst>
-          </p:cNvPr>
-          <p:cNvSpPr>
-            <a:spLocks xmlns:a="http://schemas.openxmlformats.org/drawingml/2006/main" noGrp="1"/>
-          </p:cNvSpPr>
-          <p:nvPr/>
-        </p:nvSpPr>
-        <p:spPr>
-          <a:xfrm xmlns:a="http://schemas.openxmlformats.org/drawingml/2006/main">
-            <a:off x="504825" y="5229225"/>
-            <a:ext cx="9715500" cy="285750"/>
-          </a:xfrm>
-          <a:prstGeom xmlns:a="http://schemas.openxmlformats.org/drawingml/2006/main" prst="rect">
-            <a:avLst/>
-          </a:prstGeom>
-          <a:noFill xmlns:a="http://schemas.openxmlformats.org/drawingml/2006/main"/>
-          <a:ln xmlns:a="http://schemas.openxmlformats.org/drawingml/2006/main" w="0">
-            <a:noFill/>
-          </a:ln>
-        </p:spPr>
-        <p:txBody>
-          <a:bodyPr xmlns:a="http://schemas.openxmlformats.org/drawingml/2006/main" lIns="0" tIns="0" rIns="0" bIns="0" anchor="t">
-            <a:noAutofit/>
-          </a:bodyPr>
-          <a:lstStyle xmlns:a="http://schemas.openxmlformats.org/drawingml/2006/main">
-            <a:defPPr>
-              <a:defRPr sz="1575" b="1">
-                <a:solidFill>
-                  <a:srgbClr val="101022"/>
-                </a:solidFill>
-                <a:latin typeface="Arial"/>
-                <a:ea typeface="Arial"/>
-                <a:cs typeface="Arial"/>
-              </a:defRPr>
-            </a:defPPr>
-          </a:lstStyle>
-          <a:p xmlns:a="http://schemas.openxmlformats.org/drawingml/2006/main">
-            <a:pPr>
-              <a:defRPr sz="1575" b="1">
-                <a:solidFill>
-                  <a:srgbClr val="101022"/>
-                </a:solidFill>
-                <a:latin typeface="Arial"/>
-                <a:ea typeface="Arial"/>
-                <a:cs typeface="Arial"/>
-              </a:defRPr>
-            </a:pPr>
-            <a:r>
-              <a:rPr sz="1575" b="1">
-                <a:solidFill>
-                  <a:srgbClr val="101022"/>
-                </a:solidFill>
-                <a:latin typeface="Arial"/>
-                <a:ea typeface="Arial"/>
-                <a:cs typeface="Arial"/>
-              </a:rPr>
-              <a:t>Экономию времени и затрат определяем по пилоту, заранее не обещаем</a:t>
-            </a:r>
-          </a:p>
-        </p:txBody>
-      </p:sp>
-    </p:spTree>
-    <p:extLst>
-      <p:ext uri="{BB962C8B-B14F-4D97-AF65-F5344CB8AC3E}">
-        <p14:creationId xmlns:p14="http://schemas.microsoft.com/office/powerpoint/2010/main" val="1489886624"/>
+        <p14:creationId xmlns:p14="http://schemas.microsoft.com/office/powerpoint/2010/main" val="1877669418"/>
       </p:ext>
     </p:extLst>
   </p:cSld>
@@ -5611,7 +4199,7 @@
           <p:cNvPr id="15" name="">
             <a:extLst xmlns:a="http://schemas.openxmlformats.org/drawingml/2006/main">
               <a:ext uri="{FF2B5EF4-FFF2-40B4-BE49-F238E27FC236}">
-                <a16:creationId xmlns:a16="http://schemas.microsoft.com/office/drawing/2014/main" id="{D6608279-43C6-4CB6-BD61-C9E6690637AD}"/>
+                <a16:creationId xmlns:a16="http://schemas.microsoft.com/office/drawing/2014/main" id="{9C25A106-212E-4212-88D0-B9AA8A7FF7F6}"/>
               </a:ext>
             </a:extLst>
           </p:cNvPr>
@@ -5621,7 +4209,7 @@
           <p:nvPr/>
         </p:nvPicPr>
         <p:blipFill>
-          <a:blip xmlns:r="http://schemas.openxmlformats.org/officeDocument/2006/relationships" xmlns:a="http://schemas.openxmlformats.org/drawingml/2006/main" r:embed="Rdafd1c96a1d849ca"/>
+          <a:blip xmlns:r="http://schemas.openxmlformats.org/officeDocument/2006/relationships" xmlns:a="http://schemas.openxmlformats.org/drawingml/2006/main" r:embed="R6b8adb68ec9444f0"/>
           <a:stretch xmlns:a="http://schemas.openxmlformats.org/drawingml/2006/main"/>
         </p:blipFill>
         <p:spPr>
@@ -5639,7 +4227,7 @@
           <p:cNvPr id="2" name="">
             <a:extLst xmlns:a="http://schemas.openxmlformats.org/drawingml/2006/main">
               <a:ext uri="{FF2B5EF4-FFF2-40B4-BE49-F238E27FC236}">
-                <a16:creationId xmlns:a16="http://schemas.microsoft.com/office/drawing/2014/main" id="{73CCD09F-8F94-469C-8E97-2C684F3B9114}"/>
+                <a16:creationId xmlns:a16="http://schemas.microsoft.com/office/drawing/2014/main" id="{F9D65799-CD7F-46AE-8725-13E60F9E1B6B}"/>
               </a:ext>
             </a:extLst>
           </p:cNvPr>
@@ -5707,7 +4295,7 @@
           <p:cNvPr id="3" name="">
             <a:extLst xmlns:a="http://schemas.openxmlformats.org/drawingml/2006/main">
               <a:ext uri="{FF2B5EF4-FFF2-40B4-BE49-F238E27FC236}">
-                <a16:creationId xmlns:a16="http://schemas.microsoft.com/office/drawing/2014/main" id="{F819E429-C167-44CD-9A55-CDD629296D16}"/>
+                <a16:creationId xmlns:a16="http://schemas.microsoft.com/office/drawing/2014/main" id="{78B7CE03-5052-4CF8-8002-7ED8E470D847}"/>
               </a:ext>
             </a:extLst>
           </p:cNvPr>
@@ -5798,7 +4386,7 @@
           <p:cNvPr id="4" name="">
             <a:extLst xmlns:a="http://schemas.openxmlformats.org/drawingml/2006/main">
               <a:ext uri="{FF2B5EF4-FFF2-40B4-BE49-F238E27FC236}">
-                <a16:creationId xmlns:a16="http://schemas.microsoft.com/office/drawing/2014/main" id="{6EF920CD-CB2C-4D74-A21A-57B7A58850B8}"/>
+                <a16:creationId xmlns:a16="http://schemas.microsoft.com/office/drawing/2014/main" id="{11FA3428-0FCE-407E-BC82-A0856F725189}"/>
               </a:ext>
             </a:extLst>
           </p:cNvPr>
@@ -5866,7 +4454,7 @@
           <p:cNvPr id="5" name="">
             <a:extLst xmlns:a="http://schemas.openxmlformats.org/drawingml/2006/main">
               <a:ext uri="{FF2B5EF4-FFF2-40B4-BE49-F238E27FC236}">
-                <a16:creationId xmlns:a16="http://schemas.microsoft.com/office/drawing/2014/main" id="{4E45E8B9-362A-42E4-9A18-98DACE07D943}"/>
+                <a16:creationId xmlns:a16="http://schemas.microsoft.com/office/drawing/2014/main" id="{1504E802-F77D-4296-A4E8-D539BC755ED0}"/>
               </a:ext>
             </a:extLst>
           </p:cNvPr>
@@ -5934,7 +4522,7 @@
           <p:cNvPr id="6" name="">
             <a:extLst xmlns:a="http://schemas.openxmlformats.org/drawingml/2006/main">
               <a:ext uri="{FF2B5EF4-FFF2-40B4-BE49-F238E27FC236}">
-                <a16:creationId xmlns:a16="http://schemas.microsoft.com/office/drawing/2014/main" id="{80DC1DE0-ACCE-486A-A3F4-0E4F012E6362}"/>
+                <a16:creationId xmlns:a16="http://schemas.microsoft.com/office/drawing/2014/main" id="{FA546A1D-C474-4CED-BA6B-8962BAB33A86}"/>
               </a:ext>
             </a:extLst>
           </p:cNvPr>
@@ -5992,7 +4580,7 @@
                 <a:ea typeface="Courier New"/>
                 <a:cs typeface="Courier New"/>
               </a:rPr>
-              <a:t>02 / 10</a:t>
+              <a:t>02 / 09</a:t>
             </a:r>
           </a:p>
         </p:txBody>
@@ -6002,7 +4590,7 @@
           <p:cNvPr id="7" name="">
             <a:extLst xmlns:a="http://schemas.openxmlformats.org/drawingml/2006/main">
               <a:ext uri="{FF2B5EF4-FFF2-40B4-BE49-F238E27FC236}">
-                <a16:creationId xmlns:a16="http://schemas.microsoft.com/office/drawing/2014/main" id="{50A4DFED-4C34-4ADB-A83D-7E5762AF584E}"/>
+                <a16:creationId xmlns:a16="http://schemas.microsoft.com/office/drawing/2014/main" id="{3C881349-8410-49F7-9195-A274477EDD0D}"/>
               </a:ext>
             </a:extLst>
           </p:cNvPr>
@@ -6070,7 +4658,7 @@
           <p:cNvPr id="8" name="">
             <a:extLst xmlns:a="http://schemas.openxmlformats.org/drawingml/2006/main">
               <a:ext uri="{FF2B5EF4-FFF2-40B4-BE49-F238E27FC236}">
-                <a16:creationId xmlns:a16="http://schemas.microsoft.com/office/drawing/2014/main" id="{BBC6DCA6-1246-4F1E-9F99-C2579E2FF4D0}"/>
+                <a16:creationId xmlns:a16="http://schemas.microsoft.com/office/drawing/2014/main" id="{CDB16D42-2720-4608-A587-1FFC4533EEE4}"/>
               </a:ext>
             </a:extLst>
           </p:cNvPr>
@@ -6138,7 +4726,7 @@
           <p:cNvPr id="9" name="">
             <a:extLst xmlns:a="http://schemas.openxmlformats.org/drawingml/2006/main">
               <a:ext uri="{FF2B5EF4-FFF2-40B4-BE49-F238E27FC236}">
-                <a16:creationId xmlns:a16="http://schemas.microsoft.com/office/drawing/2014/main" id="{D6652E46-0553-479B-B62C-6E11C05B1251}"/>
+                <a16:creationId xmlns:a16="http://schemas.microsoft.com/office/drawing/2014/main" id="{9BD6DCDD-BB1C-43D4-973B-F80F0817EEE0}"/>
               </a:ext>
             </a:extLst>
           </p:cNvPr>
@@ -6275,7 +4863,7 @@
           <p:cNvPr id="10" name="">
             <a:extLst xmlns:a="http://schemas.openxmlformats.org/drawingml/2006/main">
               <a:ext uri="{FF2B5EF4-FFF2-40B4-BE49-F238E27FC236}">
-                <a16:creationId xmlns:a16="http://schemas.microsoft.com/office/drawing/2014/main" id="{F347DD9B-7DC6-42D7-8022-4FE8F0B2E230}"/>
+                <a16:creationId xmlns:a16="http://schemas.microsoft.com/office/drawing/2014/main" id="{52928910-0C4F-4D47-9718-E20CA97414B3}"/>
               </a:ext>
             </a:extLst>
           </p:cNvPr>
@@ -6305,7 +4893,7 @@
           <p:cNvPr id="11" name="">
             <a:extLst xmlns:a="http://schemas.openxmlformats.org/drawingml/2006/main">
               <a:ext uri="{FF2B5EF4-FFF2-40B4-BE49-F238E27FC236}">
-                <a16:creationId xmlns:a16="http://schemas.microsoft.com/office/drawing/2014/main" id="{61930F10-54EF-43B7-9C26-CFF28858026E}"/>
+                <a16:creationId xmlns:a16="http://schemas.microsoft.com/office/drawing/2014/main" id="{13877E94-B0FD-4678-8F5F-507672EA8E1F}"/>
               </a:ext>
             </a:extLst>
           </p:cNvPr>
@@ -6373,7 +4961,7 @@
           <p:cNvPr id="12" name="">
             <a:extLst xmlns:a="http://schemas.openxmlformats.org/drawingml/2006/main">
               <a:ext uri="{FF2B5EF4-FFF2-40B4-BE49-F238E27FC236}">
-                <a16:creationId xmlns:a16="http://schemas.microsoft.com/office/drawing/2014/main" id="{D86C5156-2266-4325-BE28-E57D6B3EC26E}"/>
+                <a16:creationId xmlns:a16="http://schemas.microsoft.com/office/drawing/2014/main" id="{29AD058E-6939-4702-87FE-7D414FFF6241}"/>
               </a:ext>
             </a:extLst>
           </p:cNvPr>
@@ -6441,7 +5029,7 @@
           <p:cNvPr id="13" name="">
             <a:extLst xmlns:a="http://schemas.openxmlformats.org/drawingml/2006/main">
               <a:ext uri="{FF2B5EF4-FFF2-40B4-BE49-F238E27FC236}">
-                <a16:creationId xmlns:a16="http://schemas.microsoft.com/office/drawing/2014/main" id="{4EAB2D3B-3E83-4AEA-938A-5E630F67296E}"/>
+                <a16:creationId xmlns:a16="http://schemas.microsoft.com/office/drawing/2014/main" id="{981FDC6E-D3CA-431D-A1FD-501833797468}"/>
               </a:ext>
             </a:extLst>
           </p:cNvPr>
@@ -6555,7 +5143,7 @@
           <p:cNvPr id="14" name="">
             <a:extLst xmlns:a="http://schemas.openxmlformats.org/drawingml/2006/main">
               <a:ext uri="{FF2B5EF4-FFF2-40B4-BE49-F238E27FC236}">
-                <a16:creationId xmlns:a16="http://schemas.microsoft.com/office/drawing/2014/main" id="{AE268FDB-971A-4FEA-A718-6CF15C6D9E10}"/>
+                <a16:creationId xmlns:a16="http://schemas.microsoft.com/office/drawing/2014/main" id="{218C1D32-7559-4924-B1E6-10392794B6C4}"/>
               </a:ext>
             </a:extLst>
           </p:cNvPr>
@@ -6621,7 +5209,7 @@
     </p:spTree>
     <p:extLst>
       <p:ext uri="{BB962C8B-B14F-4D97-AF65-F5344CB8AC3E}">
-        <p14:creationId xmlns:p14="http://schemas.microsoft.com/office/powerpoint/2010/main" val="1754469295"/>
+        <p14:creationId xmlns:p14="http://schemas.microsoft.com/office/powerpoint/2010/main" val="556303211"/>
       </p:ext>
     </p:extLst>
   </p:cSld>
@@ -6652,7 +5240,7 @@
           <p:cNvPr id="9" name="">
             <a:extLst xmlns:a="http://schemas.openxmlformats.org/drawingml/2006/main">
               <a:ext uri="{FF2B5EF4-FFF2-40B4-BE49-F238E27FC236}">
-                <a16:creationId xmlns:a16="http://schemas.microsoft.com/office/drawing/2014/main" id="{8289379E-13A7-4B48-B47F-13CB638AEB67}"/>
+                <a16:creationId xmlns:a16="http://schemas.microsoft.com/office/drawing/2014/main" id="{187A85CD-175E-4548-81E2-D9A10A3F0587}"/>
               </a:ext>
             </a:extLst>
           </p:cNvPr>
@@ -6662,7 +5250,7 @@
           <p:nvPr/>
         </p:nvPicPr>
         <p:blipFill>
-          <a:blip xmlns:r="http://schemas.openxmlformats.org/officeDocument/2006/relationships" xmlns:a="http://schemas.openxmlformats.org/drawingml/2006/main" r:embed="R94754869789d47fc"/>
+          <a:blip xmlns:r="http://schemas.openxmlformats.org/officeDocument/2006/relationships" xmlns:a="http://schemas.openxmlformats.org/drawingml/2006/main" r:embed="R0828872672f84294"/>
           <a:stretch xmlns:a="http://schemas.openxmlformats.org/drawingml/2006/main"/>
         </p:blipFill>
         <p:spPr>
@@ -6680,7 +5268,7 @@
           <p:cNvPr id="2" name="">
             <a:extLst xmlns:a="http://schemas.openxmlformats.org/drawingml/2006/main">
               <a:ext uri="{FF2B5EF4-FFF2-40B4-BE49-F238E27FC236}">
-                <a16:creationId xmlns:a16="http://schemas.microsoft.com/office/drawing/2014/main" id="{ADDA7939-131C-4334-B344-088C9AE8D7F7}"/>
+                <a16:creationId xmlns:a16="http://schemas.microsoft.com/office/drawing/2014/main" id="{F27091D3-1562-45DA-B3FB-B597265337DC}"/>
               </a:ext>
             </a:extLst>
           </p:cNvPr>
@@ -6748,7 +5336,7 @@
           <p:cNvPr id="3" name="">
             <a:extLst xmlns:a="http://schemas.openxmlformats.org/drawingml/2006/main">
               <a:ext uri="{FF2B5EF4-FFF2-40B4-BE49-F238E27FC236}">
-                <a16:creationId xmlns:a16="http://schemas.microsoft.com/office/drawing/2014/main" id="{08680E2F-CBBA-405D-98F7-4F3CB29EFEA8}"/>
+                <a16:creationId xmlns:a16="http://schemas.microsoft.com/office/drawing/2014/main" id="{BAC037BB-93DB-446E-BC1D-6CBE2A2720EB}"/>
               </a:ext>
             </a:extLst>
           </p:cNvPr>
@@ -6816,7 +5404,7 @@
           <p:cNvPr id="4" name="">
             <a:extLst xmlns:a="http://schemas.openxmlformats.org/drawingml/2006/main">
               <a:ext uri="{FF2B5EF4-FFF2-40B4-BE49-F238E27FC236}">
-                <a16:creationId xmlns:a16="http://schemas.microsoft.com/office/drawing/2014/main" id="{8F1321B6-9F60-4B76-80BA-777EB9360E68}"/>
+                <a16:creationId xmlns:a16="http://schemas.microsoft.com/office/drawing/2014/main" id="{FCC334C7-F736-4082-9AA9-A071CF42F328}"/>
               </a:ext>
             </a:extLst>
           </p:cNvPr>
@@ -6884,7 +5472,7 @@
           <p:cNvPr id="5" name="">
             <a:extLst xmlns:a="http://schemas.openxmlformats.org/drawingml/2006/main">
               <a:ext uri="{FF2B5EF4-FFF2-40B4-BE49-F238E27FC236}">
-                <a16:creationId xmlns:a16="http://schemas.microsoft.com/office/drawing/2014/main" id="{A947B73B-5EE5-4985-B3FF-04BB363D3B03}"/>
+                <a16:creationId xmlns:a16="http://schemas.microsoft.com/office/drawing/2014/main" id="{CCE2182D-8496-4919-A43D-5ADC0D0AC813}"/>
               </a:ext>
             </a:extLst>
           </p:cNvPr>
@@ -6952,7 +5540,7 @@
           <p:cNvPr id="6" name="">
             <a:extLst xmlns:a="http://schemas.openxmlformats.org/drawingml/2006/main">
               <a:ext uri="{FF2B5EF4-FFF2-40B4-BE49-F238E27FC236}">
-                <a16:creationId xmlns:a16="http://schemas.microsoft.com/office/drawing/2014/main" id="{B178AA1C-6A70-48CA-B9B3-FDB582A8FE5B}"/>
+                <a16:creationId xmlns:a16="http://schemas.microsoft.com/office/drawing/2014/main" id="{0E949A0F-6CA9-437C-9F49-EFA391765422}"/>
               </a:ext>
             </a:extLst>
           </p:cNvPr>
@@ -7010,7 +5598,7 @@
                 <a:ea typeface="Courier New"/>
                 <a:cs typeface="Courier New"/>
               </a:rPr>
-              <a:t>03 / 10</a:t>
+              <a:t>03 / 09</a:t>
             </a:r>
           </a:p>
         </p:txBody>
@@ -7020,7 +5608,7 @@
           <p:cNvPr id="7" name="">
             <a:extLst xmlns:a="http://schemas.openxmlformats.org/drawingml/2006/main">
               <a:ext uri="{FF2B5EF4-FFF2-40B4-BE49-F238E27FC236}">
-                <a16:creationId xmlns:a16="http://schemas.microsoft.com/office/drawing/2014/main" id="{63CC5310-2F98-4EB3-BF0C-3A1F878320A4}"/>
+                <a16:creationId xmlns:a16="http://schemas.microsoft.com/office/drawing/2014/main" id="{A97DAB94-FC93-4296-9B53-E2329EF97868}"/>
               </a:ext>
             </a:extLst>
           </p:cNvPr>
@@ -7460,7 +6048,7 @@
           <p:cNvPr id="8" name="">
             <a:extLst xmlns:a="http://schemas.openxmlformats.org/drawingml/2006/main">
               <a:ext uri="{FF2B5EF4-FFF2-40B4-BE49-F238E27FC236}">
-                <a16:creationId xmlns:a16="http://schemas.microsoft.com/office/drawing/2014/main" id="{68801BDA-484C-44D3-B2E7-C5994A756116}"/>
+                <a16:creationId xmlns:a16="http://schemas.microsoft.com/office/drawing/2014/main" id="{A4AF1512-821C-4F52-A9D8-F4C9567A39EB}"/>
               </a:ext>
             </a:extLst>
           </p:cNvPr>
@@ -7526,7 +6114,7 @@
     </p:spTree>
     <p:extLst>
       <p:ext uri="{BB962C8B-B14F-4D97-AF65-F5344CB8AC3E}">
-        <p14:creationId xmlns:p14="http://schemas.microsoft.com/office/powerpoint/2010/main" val="1838413515"/>
+        <p14:creationId xmlns:p14="http://schemas.microsoft.com/office/powerpoint/2010/main" val="1628399454"/>
       </p:ext>
     </p:extLst>
   </p:cSld>
@@ -7557,7 +6145,7 @@
           <p:cNvPr id="19" name="">
             <a:extLst xmlns:a="http://schemas.openxmlformats.org/drawingml/2006/main">
               <a:ext uri="{FF2B5EF4-FFF2-40B4-BE49-F238E27FC236}">
-                <a16:creationId xmlns:a16="http://schemas.microsoft.com/office/drawing/2014/main" id="{78E7C96A-D9AA-4BBF-9DA4-877DAF36B5D4}"/>
+                <a16:creationId xmlns:a16="http://schemas.microsoft.com/office/drawing/2014/main" id="{39869C6E-B777-4269-A3DC-E8741F1D3597}"/>
               </a:ext>
             </a:extLst>
           </p:cNvPr>
@@ -7567,7 +6155,7 @@
           <p:nvPr/>
         </p:nvPicPr>
         <p:blipFill>
-          <a:blip xmlns:r="http://schemas.openxmlformats.org/officeDocument/2006/relationships" xmlns:a="http://schemas.openxmlformats.org/drawingml/2006/main" r:embed="R5bed6b8873e24e64"/>
+          <a:blip xmlns:r="http://schemas.openxmlformats.org/officeDocument/2006/relationships" xmlns:a="http://schemas.openxmlformats.org/drawingml/2006/main" r:embed="Re64fcc730d234090"/>
           <a:stretch xmlns:a="http://schemas.openxmlformats.org/drawingml/2006/main"/>
         </p:blipFill>
         <p:spPr>
@@ -7585,7 +6173,7 @@
           <p:cNvPr id="2" name="">
             <a:extLst xmlns:a="http://schemas.openxmlformats.org/drawingml/2006/main">
               <a:ext uri="{FF2B5EF4-FFF2-40B4-BE49-F238E27FC236}">
-                <a16:creationId xmlns:a16="http://schemas.microsoft.com/office/drawing/2014/main" id="{C47C6162-868D-4F6E-BD3C-5C2E0FAF17E9}"/>
+                <a16:creationId xmlns:a16="http://schemas.microsoft.com/office/drawing/2014/main" id="{1B009000-E8D5-4CF4-B071-562CCDB0D318}"/>
               </a:ext>
             </a:extLst>
           </p:cNvPr>
@@ -7653,7 +6241,7 @@
           <p:cNvPr id="3" name="">
             <a:extLst xmlns:a="http://schemas.openxmlformats.org/drawingml/2006/main">
               <a:ext uri="{FF2B5EF4-FFF2-40B4-BE49-F238E27FC236}">
-                <a16:creationId xmlns:a16="http://schemas.microsoft.com/office/drawing/2014/main" id="{EDC20335-DDAF-4211-AF9F-D032B954A290}"/>
+                <a16:creationId xmlns:a16="http://schemas.microsoft.com/office/drawing/2014/main" id="{395AFD83-5C97-4DF5-890C-CF279D0AEB15}"/>
               </a:ext>
             </a:extLst>
           </p:cNvPr>
@@ -7721,7 +6309,7 @@
           <p:cNvPr id="4" name="">
             <a:extLst xmlns:a="http://schemas.openxmlformats.org/drawingml/2006/main">
               <a:ext uri="{FF2B5EF4-FFF2-40B4-BE49-F238E27FC236}">
-                <a16:creationId xmlns:a16="http://schemas.microsoft.com/office/drawing/2014/main" id="{D2535C6A-E884-4935-BE05-F9A6BCEA7B9D}"/>
+                <a16:creationId xmlns:a16="http://schemas.microsoft.com/office/drawing/2014/main" id="{279DFFB8-CCDC-4D03-895B-A96867AC23F5}"/>
               </a:ext>
             </a:extLst>
           </p:cNvPr>
@@ -7789,7 +6377,7 @@
           <p:cNvPr id="5" name="">
             <a:extLst xmlns:a="http://schemas.openxmlformats.org/drawingml/2006/main">
               <a:ext uri="{FF2B5EF4-FFF2-40B4-BE49-F238E27FC236}">
-                <a16:creationId xmlns:a16="http://schemas.microsoft.com/office/drawing/2014/main" id="{78B580AC-D6B5-4CCD-8D11-02465026A485}"/>
+                <a16:creationId xmlns:a16="http://schemas.microsoft.com/office/drawing/2014/main" id="{A399ED9A-721E-4837-A62E-4B319C74A8BD}"/>
               </a:ext>
             </a:extLst>
           </p:cNvPr>
@@ -7857,7 +6445,7 @@
           <p:cNvPr id="6" name="">
             <a:extLst xmlns:a="http://schemas.openxmlformats.org/drawingml/2006/main">
               <a:ext uri="{FF2B5EF4-FFF2-40B4-BE49-F238E27FC236}">
-                <a16:creationId xmlns:a16="http://schemas.microsoft.com/office/drawing/2014/main" id="{F97CBCA5-0C3E-4236-9211-87D381F18DCD}"/>
+                <a16:creationId xmlns:a16="http://schemas.microsoft.com/office/drawing/2014/main" id="{21CA6560-E703-4E23-854C-E849AA7EE6F7}"/>
               </a:ext>
             </a:extLst>
           </p:cNvPr>
@@ -7915,7 +6503,7 @@
                 <a:ea typeface="Courier New"/>
                 <a:cs typeface="Courier New"/>
               </a:rPr>
-              <a:t>04 / 10</a:t>
+              <a:t>04 / 09</a:t>
             </a:r>
           </a:p>
         </p:txBody>
@@ -7925,7 +6513,7 @@
           <p:cNvPr id="7" name="">
             <a:extLst xmlns:a="http://schemas.openxmlformats.org/drawingml/2006/main">
               <a:ext uri="{FF2B5EF4-FFF2-40B4-BE49-F238E27FC236}">
-                <a16:creationId xmlns:a16="http://schemas.microsoft.com/office/drawing/2014/main" id="{1ACB0F18-7B6C-4DB5-9F30-155AFCA83376}"/>
+                <a16:creationId xmlns:a16="http://schemas.microsoft.com/office/drawing/2014/main" id="{F9DC5C90-6684-4F74-A713-88B2F50ACBF3}"/>
               </a:ext>
             </a:extLst>
           </p:cNvPr>
@@ -7993,7 +6581,7 @@
           <p:cNvPr id="8" name="">
             <a:extLst xmlns:a="http://schemas.openxmlformats.org/drawingml/2006/main">
               <a:ext uri="{FF2B5EF4-FFF2-40B4-BE49-F238E27FC236}">
-                <a16:creationId xmlns:a16="http://schemas.microsoft.com/office/drawing/2014/main" id="{04D50199-CCA4-4ED8-8D29-EEC2AC2613BF}"/>
+                <a16:creationId xmlns:a16="http://schemas.microsoft.com/office/drawing/2014/main" id="{A73B6ED6-0EFC-489C-A646-BFCB3D778CC5}"/>
               </a:ext>
             </a:extLst>
           </p:cNvPr>
@@ -8061,7 +6649,7 @@
           <p:cNvPr id="9" name="">
             <a:extLst xmlns:a="http://schemas.openxmlformats.org/drawingml/2006/main">
               <a:ext uri="{FF2B5EF4-FFF2-40B4-BE49-F238E27FC236}">
-                <a16:creationId xmlns:a16="http://schemas.microsoft.com/office/drawing/2014/main" id="{C95A6ECD-BF8F-4AE5-BEC8-0110E669CF01}"/>
+                <a16:creationId xmlns:a16="http://schemas.microsoft.com/office/drawing/2014/main" id="{C98A73FD-F32C-4345-87E2-FD11F5AE3699}"/>
               </a:ext>
             </a:extLst>
           </p:cNvPr>
@@ -8129,7 +6717,7 @@
           <p:cNvPr id="10" name="">
             <a:extLst xmlns:a="http://schemas.openxmlformats.org/drawingml/2006/main">
               <a:ext uri="{FF2B5EF4-FFF2-40B4-BE49-F238E27FC236}">
-                <a16:creationId xmlns:a16="http://schemas.microsoft.com/office/drawing/2014/main" id="{5B1AE02E-5CFB-4B52-9C8E-01D4AD8D1669}"/>
+                <a16:creationId xmlns:a16="http://schemas.microsoft.com/office/drawing/2014/main" id="{20580813-F88F-4409-AA14-F6300B57BA24}"/>
               </a:ext>
             </a:extLst>
           </p:cNvPr>
@@ -8197,7 +6785,7 @@
           <p:cNvPr id="11" name="">
             <a:extLst xmlns:a="http://schemas.openxmlformats.org/drawingml/2006/main">
               <a:ext uri="{FF2B5EF4-FFF2-40B4-BE49-F238E27FC236}">
-                <a16:creationId xmlns:a16="http://schemas.microsoft.com/office/drawing/2014/main" id="{69ACF678-C27D-411B-AC5D-26089B774C3D}"/>
+                <a16:creationId xmlns:a16="http://schemas.microsoft.com/office/drawing/2014/main" id="{D851A729-DB42-4175-940C-2E504E17DF43}"/>
               </a:ext>
             </a:extLst>
           </p:cNvPr>
@@ -8265,7 +6853,7 @@
           <p:cNvPr id="12" name="">
             <a:extLst xmlns:a="http://schemas.openxmlformats.org/drawingml/2006/main">
               <a:ext uri="{FF2B5EF4-FFF2-40B4-BE49-F238E27FC236}">
-                <a16:creationId xmlns:a16="http://schemas.microsoft.com/office/drawing/2014/main" id="{79623FCA-E387-4AF3-ADEE-C5326D0A71EB}"/>
+                <a16:creationId xmlns:a16="http://schemas.microsoft.com/office/drawing/2014/main" id="{98746E65-4B70-4F1F-BCFB-C17AA5807029}"/>
               </a:ext>
             </a:extLst>
           </p:cNvPr>
@@ -8333,7 +6921,7 @@
           <p:cNvPr id="13" name="">
             <a:extLst xmlns:a="http://schemas.openxmlformats.org/drawingml/2006/main">
               <a:ext uri="{FF2B5EF4-FFF2-40B4-BE49-F238E27FC236}">
-                <a16:creationId xmlns:a16="http://schemas.microsoft.com/office/drawing/2014/main" id="{C7ABABD4-1924-4D96-AB66-4ADE00C3B3DE}"/>
+                <a16:creationId xmlns:a16="http://schemas.microsoft.com/office/drawing/2014/main" id="{3ACC916A-570D-4185-87A9-CA83FB5E7EAA}"/>
               </a:ext>
             </a:extLst>
           </p:cNvPr>
@@ -8401,7 +6989,7 @@
           <p:cNvPr id="14" name="">
             <a:extLst xmlns:a="http://schemas.openxmlformats.org/drawingml/2006/main">
               <a:ext uri="{FF2B5EF4-FFF2-40B4-BE49-F238E27FC236}">
-                <a16:creationId xmlns:a16="http://schemas.microsoft.com/office/drawing/2014/main" id="{B6959F6C-BEE9-474A-8D99-9ADDA6CAABD3}"/>
+                <a16:creationId xmlns:a16="http://schemas.microsoft.com/office/drawing/2014/main" id="{C7130F85-34D0-4A3C-AB88-F9B3FD1B2FB4}"/>
               </a:ext>
             </a:extLst>
           </p:cNvPr>
@@ -8469,7 +7057,7 @@
           <p:cNvPr id="15" name="">
             <a:extLst xmlns:a="http://schemas.openxmlformats.org/drawingml/2006/main">
               <a:ext uri="{FF2B5EF4-FFF2-40B4-BE49-F238E27FC236}">
-                <a16:creationId xmlns:a16="http://schemas.microsoft.com/office/drawing/2014/main" id="{06CD7634-AF06-4BC6-95CE-88874AEC3B15}"/>
+                <a16:creationId xmlns:a16="http://schemas.microsoft.com/office/drawing/2014/main" id="{7CEE7E32-47EF-41D4-A4D7-02F06EBD48D4}"/>
               </a:ext>
             </a:extLst>
           </p:cNvPr>
@@ -8537,7 +7125,7 @@
           <p:cNvPr id="16" name="">
             <a:extLst xmlns:a="http://schemas.openxmlformats.org/drawingml/2006/main">
               <a:ext uri="{FF2B5EF4-FFF2-40B4-BE49-F238E27FC236}">
-                <a16:creationId xmlns:a16="http://schemas.microsoft.com/office/drawing/2014/main" id="{9DA55254-4921-4F4E-8831-4FB632E50034}"/>
+                <a16:creationId xmlns:a16="http://schemas.microsoft.com/office/drawing/2014/main" id="{594C4B64-0944-451A-A82F-172014214C7F}"/>
               </a:ext>
             </a:extLst>
           </p:cNvPr>
@@ -8605,7 +7193,7 @@
           <p:cNvPr id="17" name="">
             <a:extLst xmlns:a="http://schemas.openxmlformats.org/drawingml/2006/main">
               <a:ext uri="{FF2B5EF4-FFF2-40B4-BE49-F238E27FC236}">
-                <a16:creationId xmlns:a16="http://schemas.microsoft.com/office/drawing/2014/main" id="{01991F30-5A49-40EE-A5DD-0DC9DD58D6C3}"/>
+                <a16:creationId xmlns:a16="http://schemas.microsoft.com/office/drawing/2014/main" id="{0CB357E4-E0B5-49ED-8677-BF032E9D7F50}"/>
               </a:ext>
             </a:extLst>
           </p:cNvPr>
@@ -8673,7 +7261,7 @@
           <p:cNvPr id="18" name="">
             <a:extLst xmlns:a="http://schemas.openxmlformats.org/drawingml/2006/main">
               <a:ext uri="{FF2B5EF4-FFF2-40B4-BE49-F238E27FC236}">
-                <a16:creationId xmlns:a16="http://schemas.microsoft.com/office/drawing/2014/main" id="{3FA73D55-3041-4E33-A660-8B5D23B8EFD4}"/>
+                <a16:creationId xmlns:a16="http://schemas.microsoft.com/office/drawing/2014/main" id="{B9B023F7-471F-461D-845E-D62E5B1B0F6B}"/>
               </a:ext>
             </a:extLst>
           </p:cNvPr>
@@ -8739,7 +7327,7 @@
     </p:spTree>
     <p:extLst>
       <p:ext uri="{BB962C8B-B14F-4D97-AF65-F5344CB8AC3E}">
-        <p14:creationId xmlns:p14="http://schemas.microsoft.com/office/powerpoint/2010/main" val="752945491"/>
+        <p14:creationId xmlns:p14="http://schemas.microsoft.com/office/powerpoint/2010/main" val="14229121"/>
       </p:ext>
     </p:extLst>
   </p:cSld>
@@ -8770,7 +7358,7 @@
           <p:cNvPr id="13" name="">
             <a:extLst xmlns:a="http://schemas.openxmlformats.org/drawingml/2006/main">
               <a:ext uri="{FF2B5EF4-FFF2-40B4-BE49-F238E27FC236}">
-                <a16:creationId xmlns:a16="http://schemas.microsoft.com/office/drawing/2014/main" id="{6B0EB4E5-F547-46CC-B1D4-8B30BB4513CA}"/>
+                <a16:creationId xmlns:a16="http://schemas.microsoft.com/office/drawing/2014/main" id="{903CD8E7-1B56-4A22-B000-95C6A82A2BFC}"/>
               </a:ext>
             </a:extLst>
           </p:cNvPr>
@@ -8780,7 +7368,7 @@
           <p:nvPr/>
         </p:nvPicPr>
         <p:blipFill>
-          <a:blip xmlns:r="http://schemas.openxmlformats.org/officeDocument/2006/relationships" xmlns:a="http://schemas.openxmlformats.org/drawingml/2006/main" r:embed="R92da2a13db934269"/>
+          <a:blip xmlns:r="http://schemas.openxmlformats.org/officeDocument/2006/relationships" xmlns:a="http://schemas.openxmlformats.org/drawingml/2006/main" r:embed="Rcec172d8d4494f9f"/>
           <a:stretch xmlns:a="http://schemas.openxmlformats.org/drawingml/2006/main"/>
         </p:blipFill>
         <p:spPr>
@@ -8798,7 +7386,7 @@
           <p:cNvPr id="2" name="">
             <a:extLst xmlns:a="http://schemas.openxmlformats.org/drawingml/2006/main">
               <a:ext uri="{FF2B5EF4-FFF2-40B4-BE49-F238E27FC236}">
-                <a16:creationId xmlns:a16="http://schemas.microsoft.com/office/drawing/2014/main" id="{29783AED-B0C5-4276-AB1F-A11094029306}"/>
+                <a16:creationId xmlns:a16="http://schemas.microsoft.com/office/drawing/2014/main" id="{171DF907-236C-48D9-8A9B-D62F35A7D4DA}"/>
               </a:ext>
             </a:extLst>
           </p:cNvPr>
@@ -8866,7 +7454,7 @@
           <p:cNvPr id="3" name="">
             <a:extLst xmlns:a="http://schemas.openxmlformats.org/drawingml/2006/main">
               <a:ext uri="{FF2B5EF4-FFF2-40B4-BE49-F238E27FC236}">
-                <a16:creationId xmlns:a16="http://schemas.microsoft.com/office/drawing/2014/main" id="{725625C2-F261-4DE8-82F6-2C9AAB9DDA09}"/>
+                <a16:creationId xmlns:a16="http://schemas.microsoft.com/office/drawing/2014/main" id="{CE9B1B1A-A9A1-4F64-89E5-428A56B58701}"/>
               </a:ext>
             </a:extLst>
           </p:cNvPr>
@@ -8934,7 +7522,7 @@
           <p:cNvPr id="4" name="">
             <a:extLst xmlns:a="http://schemas.openxmlformats.org/drawingml/2006/main">
               <a:ext uri="{FF2B5EF4-FFF2-40B4-BE49-F238E27FC236}">
-                <a16:creationId xmlns:a16="http://schemas.microsoft.com/office/drawing/2014/main" id="{FE8E8FC8-D713-48CA-B9D7-8393AF2A87BD}"/>
+                <a16:creationId xmlns:a16="http://schemas.microsoft.com/office/drawing/2014/main" id="{9A426E7E-FD5E-47F4-9D24-27D90D120716}"/>
               </a:ext>
             </a:extLst>
           </p:cNvPr>
@@ -9002,7 +7590,7 @@
           <p:cNvPr id="5" name="">
             <a:extLst xmlns:a="http://schemas.openxmlformats.org/drawingml/2006/main">
               <a:ext uri="{FF2B5EF4-FFF2-40B4-BE49-F238E27FC236}">
-                <a16:creationId xmlns:a16="http://schemas.microsoft.com/office/drawing/2014/main" id="{39A73EDF-E672-457D-A336-05D40BF9D95B}"/>
+                <a16:creationId xmlns:a16="http://schemas.microsoft.com/office/drawing/2014/main" id="{4A4361CE-D8B7-4640-9721-6FBF3CD77A8F}"/>
               </a:ext>
             </a:extLst>
           </p:cNvPr>
@@ -9070,7 +7658,7 @@
           <p:cNvPr id="6" name="">
             <a:extLst xmlns:a="http://schemas.openxmlformats.org/drawingml/2006/main">
               <a:ext uri="{FF2B5EF4-FFF2-40B4-BE49-F238E27FC236}">
-                <a16:creationId xmlns:a16="http://schemas.microsoft.com/office/drawing/2014/main" id="{35C8ADB1-7ED1-49BB-84BC-D13E9FBE8CD4}"/>
+                <a16:creationId xmlns:a16="http://schemas.microsoft.com/office/drawing/2014/main" id="{FB8D036C-74FF-4217-9BA5-84EA41C2223D}"/>
               </a:ext>
             </a:extLst>
           </p:cNvPr>
@@ -9128,7 +7716,7 @@
                 <a:ea typeface="Courier New"/>
                 <a:cs typeface="Courier New"/>
               </a:rPr>
-              <a:t>05 / 10</a:t>
+              <a:t>05 / 09</a:t>
             </a:r>
           </a:p>
         </p:txBody>
@@ -9138,7 +7726,7 @@
           <p:cNvPr id="7" name="">
             <a:extLst xmlns:a="http://schemas.openxmlformats.org/drawingml/2006/main">
               <a:ext uri="{FF2B5EF4-FFF2-40B4-BE49-F238E27FC236}">
-                <a16:creationId xmlns:a16="http://schemas.microsoft.com/office/drawing/2014/main" id="{0D851B08-AA49-4EF3-B866-BCC1509762B7}"/>
+                <a16:creationId xmlns:a16="http://schemas.microsoft.com/office/drawing/2014/main" id="{4760C544-B183-4A30-AB50-B1BA91871286}"/>
               </a:ext>
             </a:extLst>
           </p:cNvPr>
@@ -9148,7 +7736,7 @@
           <p:nvPr/>
         </p:nvPicPr>
         <p:blipFill>
-          <a:blip xmlns:r="http://schemas.openxmlformats.org/officeDocument/2006/relationships" xmlns:a="http://schemas.openxmlformats.org/drawingml/2006/main" r:embed="R12e604c484324d3a"/>
+          <a:blip xmlns:r="http://schemas.openxmlformats.org/officeDocument/2006/relationships" xmlns:a="http://schemas.openxmlformats.org/drawingml/2006/main" r:embed="Rca81c2f7ef5140e2"/>
           <a:stretch xmlns:a="http://schemas.openxmlformats.org/drawingml/2006/main"/>
         </p:blipFill>
         <p:spPr>
@@ -9166,7 +7754,7 @@
           <p:cNvPr id="8" name="">
             <a:extLst xmlns:a="http://schemas.openxmlformats.org/drawingml/2006/main">
               <a:ext uri="{FF2B5EF4-FFF2-40B4-BE49-F238E27FC236}">
-                <a16:creationId xmlns:a16="http://schemas.microsoft.com/office/drawing/2014/main" id="{1099C897-8998-47C0-B97F-D930AA7F6604}"/>
+                <a16:creationId xmlns:a16="http://schemas.microsoft.com/office/drawing/2014/main" id="{1AD79BD4-CC74-4853-911B-7BCA53D5D9DD}"/>
               </a:ext>
             </a:extLst>
           </p:cNvPr>
@@ -9234,7 +7822,7 @@
           <p:cNvPr id="9" name="">
             <a:extLst xmlns:a="http://schemas.openxmlformats.org/drawingml/2006/main">
               <a:ext uri="{FF2B5EF4-FFF2-40B4-BE49-F238E27FC236}">
-                <a16:creationId xmlns:a16="http://schemas.microsoft.com/office/drawing/2014/main" id="{BDBA1B88-C9B4-4888-A22A-194967B2CAA0}"/>
+                <a16:creationId xmlns:a16="http://schemas.microsoft.com/office/drawing/2014/main" id="{5A2417FF-55EA-4F5D-BF12-ACBF5AB1F727}"/>
               </a:ext>
             </a:extLst>
           </p:cNvPr>
@@ -9325,7 +7913,7 @@
           <p:cNvPr id="10" name="">
             <a:extLst xmlns:a="http://schemas.openxmlformats.org/drawingml/2006/main">
               <a:ext uri="{FF2B5EF4-FFF2-40B4-BE49-F238E27FC236}">
-                <a16:creationId xmlns:a16="http://schemas.microsoft.com/office/drawing/2014/main" id="{E84EDC03-F5A9-4621-A8C3-4AB32FCE72F3}"/>
+                <a16:creationId xmlns:a16="http://schemas.microsoft.com/office/drawing/2014/main" id="{F41A5D25-F171-46BE-9364-D104BBFAD195}"/>
               </a:ext>
             </a:extLst>
           </p:cNvPr>
@@ -9393,7 +7981,7 @@
           <p:cNvPr id="11" name="">
             <a:extLst xmlns:a="http://schemas.openxmlformats.org/drawingml/2006/main">
               <a:ext uri="{FF2B5EF4-FFF2-40B4-BE49-F238E27FC236}">
-                <a16:creationId xmlns:a16="http://schemas.microsoft.com/office/drawing/2014/main" id="{AA18868A-6538-4448-BD3C-26DF055077EF}"/>
+                <a16:creationId xmlns:a16="http://schemas.microsoft.com/office/drawing/2014/main" id="{05099070-B290-4B17-9CC0-AC39D1C667D8}"/>
               </a:ext>
             </a:extLst>
           </p:cNvPr>
@@ -9484,7 +8072,7 @@
           <p:cNvPr id="12" name="">
             <a:extLst xmlns:a="http://schemas.openxmlformats.org/drawingml/2006/main">
               <a:ext uri="{FF2B5EF4-FFF2-40B4-BE49-F238E27FC236}">
-                <a16:creationId xmlns:a16="http://schemas.microsoft.com/office/drawing/2014/main" id="{A9D8F903-3057-490A-BFAC-08F69DC3FD2A}"/>
+                <a16:creationId xmlns:a16="http://schemas.microsoft.com/office/drawing/2014/main" id="{082AD757-7726-43A8-8A6C-4B7FAF5DBC1E}"/>
               </a:ext>
             </a:extLst>
           </p:cNvPr>
@@ -9550,7 +8138,7 @@
     </p:spTree>
     <p:extLst>
       <p:ext uri="{BB962C8B-B14F-4D97-AF65-F5344CB8AC3E}">
-        <p14:creationId xmlns:p14="http://schemas.microsoft.com/office/powerpoint/2010/main" val="970819568"/>
+        <p14:creationId xmlns:p14="http://schemas.microsoft.com/office/powerpoint/2010/main" val="1506576495"/>
       </p:ext>
     </p:extLst>
   </p:cSld>
@@ -9581,7 +8169,7 @@
           <p:cNvPr id="18" name="">
             <a:extLst xmlns:a="http://schemas.openxmlformats.org/drawingml/2006/main">
               <a:ext uri="{FF2B5EF4-FFF2-40B4-BE49-F238E27FC236}">
-                <a16:creationId xmlns:a16="http://schemas.microsoft.com/office/drawing/2014/main" id="{06DBBBBF-C042-478E-A369-EDEE06D95709}"/>
+                <a16:creationId xmlns:a16="http://schemas.microsoft.com/office/drawing/2014/main" id="{E614C6EC-5824-4BE4-A4F4-690B45A5B086}"/>
               </a:ext>
             </a:extLst>
           </p:cNvPr>
@@ -9591,7 +8179,7 @@
           <p:nvPr/>
         </p:nvPicPr>
         <p:blipFill>
-          <a:blip xmlns:r="http://schemas.openxmlformats.org/officeDocument/2006/relationships" xmlns:a="http://schemas.openxmlformats.org/drawingml/2006/main" r:embed="Rbf340f85b8e44ee4"/>
+          <a:blip xmlns:r="http://schemas.openxmlformats.org/officeDocument/2006/relationships" xmlns:a="http://schemas.openxmlformats.org/drawingml/2006/main" r:embed="R582b6f3598904f88"/>
           <a:stretch xmlns:a="http://schemas.openxmlformats.org/drawingml/2006/main"/>
         </p:blipFill>
         <p:spPr>
@@ -9609,7 +8197,7 @@
           <p:cNvPr id="2" name="">
             <a:extLst xmlns:a="http://schemas.openxmlformats.org/drawingml/2006/main">
               <a:ext uri="{FF2B5EF4-FFF2-40B4-BE49-F238E27FC236}">
-                <a16:creationId xmlns:a16="http://schemas.microsoft.com/office/drawing/2014/main" id="{F57388CE-7005-4FEB-9F0A-E45CFF58D0D8}"/>
+                <a16:creationId xmlns:a16="http://schemas.microsoft.com/office/drawing/2014/main" id="{F152DC1A-A30B-42EC-AEA2-F6DC20AB459E}"/>
               </a:ext>
             </a:extLst>
           </p:cNvPr>
@@ -9677,7 +8265,7 @@
           <p:cNvPr id="3" name="">
             <a:extLst xmlns:a="http://schemas.openxmlformats.org/drawingml/2006/main">
               <a:ext uri="{FF2B5EF4-FFF2-40B4-BE49-F238E27FC236}">
-                <a16:creationId xmlns:a16="http://schemas.microsoft.com/office/drawing/2014/main" id="{51305F8D-4826-4EFB-AC2C-B800C1BF9924}"/>
+                <a16:creationId xmlns:a16="http://schemas.microsoft.com/office/drawing/2014/main" id="{7D60F50D-912F-4655-82DF-589BCBAF4DEC}"/>
               </a:ext>
             </a:extLst>
           </p:cNvPr>
@@ -9745,7 +8333,7 @@
           <p:cNvPr id="4" name="">
             <a:extLst xmlns:a="http://schemas.openxmlformats.org/drawingml/2006/main">
               <a:ext uri="{FF2B5EF4-FFF2-40B4-BE49-F238E27FC236}">
-                <a16:creationId xmlns:a16="http://schemas.microsoft.com/office/drawing/2014/main" id="{23703EB1-5DC6-442B-9769-1BF59462E50C}"/>
+                <a16:creationId xmlns:a16="http://schemas.microsoft.com/office/drawing/2014/main" id="{425D59EF-AF5F-4644-B4D9-A04F91658B65}"/>
               </a:ext>
             </a:extLst>
           </p:cNvPr>
@@ -9813,7 +8401,7 @@
           <p:cNvPr id="5" name="">
             <a:extLst xmlns:a="http://schemas.openxmlformats.org/drawingml/2006/main">
               <a:ext uri="{FF2B5EF4-FFF2-40B4-BE49-F238E27FC236}">
-                <a16:creationId xmlns:a16="http://schemas.microsoft.com/office/drawing/2014/main" id="{FBD35989-BE7F-48A7-98DA-6F1C8C525A0D}"/>
+                <a16:creationId xmlns:a16="http://schemas.microsoft.com/office/drawing/2014/main" id="{2A23D650-CC77-44D7-A596-3F33B72B4E1D}"/>
               </a:ext>
             </a:extLst>
           </p:cNvPr>
@@ -9881,7 +8469,7 @@
           <p:cNvPr id="6" name="">
             <a:extLst xmlns:a="http://schemas.openxmlformats.org/drawingml/2006/main">
               <a:ext uri="{FF2B5EF4-FFF2-40B4-BE49-F238E27FC236}">
-                <a16:creationId xmlns:a16="http://schemas.microsoft.com/office/drawing/2014/main" id="{EECA520F-183F-46AD-B952-C1C3481A7D93}"/>
+                <a16:creationId xmlns:a16="http://schemas.microsoft.com/office/drawing/2014/main" id="{5C484B57-6CF5-4F41-9607-3DD0DADEB185}"/>
               </a:ext>
             </a:extLst>
           </p:cNvPr>
@@ -9939,7 +8527,7 @@
                 <a:ea typeface="Courier New"/>
                 <a:cs typeface="Courier New"/>
               </a:rPr>
-              <a:t>06 / 10</a:t>
+              <a:t>06 / 09</a:t>
             </a:r>
           </a:p>
         </p:txBody>
@@ -9949,7 +8537,7 @@
           <p:cNvPr id="7" name="">
             <a:extLst xmlns:a="http://schemas.openxmlformats.org/drawingml/2006/main">
               <a:ext uri="{FF2B5EF4-FFF2-40B4-BE49-F238E27FC236}">
-                <a16:creationId xmlns:a16="http://schemas.microsoft.com/office/drawing/2014/main" id="{A67A94EB-D7CC-495B-9BDE-36199FB57730}"/>
+                <a16:creationId xmlns:a16="http://schemas.microsoft.com/office/drawing/2014/main" id="{38ADF194-14E6-4B12-8C24-740B31C8A75E}"/>
               </a:ext>
             </a:extLst>
           </p:cNvPr>
@@ -10017,7 +8605,7 @@
           <p:cNvPr id="8" name="">
             <a:extLst xmlns:a="http://schemas.openxmlformats.org/drawingml/2006/main">
               <a:ext uri="{FF2B5EF4-FFF2-40B4-BE49-F238E27FC236}">
-                <a16:creationId xmlns:a16="http://schemas.microsoft.com/office/drawing/2014/main" id="{23809C0E-B319-452C-B525-84D651EEFAB4}"/>
+                <a16:creationId xmlns:a16="http://schemas.microsoft.com/office/drawing/2014/main" id="{C14253C2-7D34-4868-8B84-DFB648A2E74D}"/>
               </a:ext>
             </a:extLst>
           </p:cNvPr>
@@ -10047,7 +8635,7 @@
           <p:cNvPr id="9" name="">
             <a:extLst xmlns:a="http://schemas.openxmlformats.org/drawingml/2006/main">
               <a:ext uri="{FF2B5EF4-FFF2-40B4-BE49-F238E27FC236}">
-                <a16:creationId xmlns:a16="http://schemas.microsoft.com/office/drawing/2014/main" id="{799A1395-FA41-438A-AB13-86F1FD7D9AB0}"/>
+                <a16:creationId xmlns:a16="http://schemas.microsoft.com/office/drawing/2014/main" id="{8D4BF4AD-B1CF-4F72-B999-65BA01AC47FF}"/>
               </a:ext>
             </a:extLst>
           </p:cNvPr>
@@ -10161,7 +8749,7 @@
           <p:cNvPr id="10" name="">
             <a:extLst xmlns:a="http://schemas.openxmlformats.org/drawingml/2006/main">
               <a:ext uri="{FF2B5EF4-FFF2-40B4-BE49-F238E27FC236}">
-                <a16:creationId xmlns:a16="http://schemas.microsoft.com/office/drawing/2014/main" id="{CD199F9C-21C8-4C1D-8666-D79B338415D3}"/>
+                <a16:creationId xmlns:a16="http://schemas.microsoft.com/office/drawing/2014/main" id="{0C7BA360-AF97-4DCF-A683-3DE08A3B4061}"/>
               </a:ext>
             </a:extLst>
           </p:cNvPr>
@@ -10229,7 +8817,7 @@
           <p:cNvPr id="11" name="">
             <a:extLst xmlns:a="http://schemas.openxmlformats.org/drawingml/2006/main">
               <a:ext uri="{FF2B5EF4-FFF2-40B4-BE49-F238E27FC236}">
-                <a16:creationId xmlns:a16="http://schemas.microsoft.com/office/drawing/2014/main" id="{7BE24F13-59FE-4E5E-8227-616246F6660F}"/>
+                <a16:creationId xmlns:a16="http://schemas.microsoft.com/office/drawing/2014/main" id="{F901D86F-6BEE-4EEB-9FFA-0746E408F867}"/>
               </a:ext>
             </a:extLst>
           </p:cNvPr>
@@ -10259,7 +8847,7 @@
           <p:cNvPr id="12" name="">
             <a:extLst xmlns:a="http://schemas.openxmlformats.org/drawingml/2006/main">
               <a:ext uri="{FF2B5EF4-FFF2-40B4-BE49-F238E27FC236}">
-                <a16:creationId xmlns:a16="http://schemas.microsoft.com/office/drawing/2014/main" id="{2AB1BB72-34D7-4623-AFB1-9D82F77D2714}"/>
+                <a16:creationId xmlns:a16="http://schemas.microsoft.com/office/drawing/2014/main" id="{01FD62DB-D41A-4448-9139-85F0E5822D82}"/>
               </a:ext>
             </a:extLst>
           </p:cNvPr>
@@ -10373,7 +8961,7 @@
           <p:cNvPr id="13" name="">
             <a:extLst xmlns:a="http://schemas.openxmlformats.org/drawingml/2006/main">
               <a:ext uri="{FF2B5EF4-FFF2-40B4-BE49-F238E27FC236}">
-                <a16:creationId xmlns:a16="http://schemas.microsoft.com/office/drawing/2014/main" id="{AB0F574F-B916-4D58-B2DE-4DFEB2985374}"/>
+                <a16:creationId xmlns:a16="http://schemas.microsoft.com/office/drawing/2014/main" id="{D9F8D8ED-0AFB-4133-89EB-2C19EB601615}"/>
               </a:ext>
             </a:extLst>
           </p:cNvPr>
@@ -10441,7 +9029,7 @@
           <p:cNvPr id="14" name="">
             <a:extLst xmlns:a="http://schemas.openxmlformats.org/drawingml/2006/main">
               <a:ext uri="{FF2B5EF4-FFF2-40B4-BE49-F238E27FC236}">
-                <a16:creationId xmlns:a16="http://schemas.microsoft.com/office/drawing/2014/main" id="{80D1A6C1-F1CD-45DA-8FCC-0CCA6BBB6587}"/>
+                <a16:creationId xmlns:a16="http://schemas.microsoft.com/office/drawing/2014/main" id="{3F4FF383-736A-421C-9D15-DD47F64B887B}"/>
               </a:ext>
             </a:extLst>
           </p:cNvPr>
@@ -10471,7 +9059,7 @@
           <p:cNvPr id="15" name="">
             <a:extLst xmlns:a="http://schemas.openxmlformats.org/drawingml/2006/main">
               <a:ext uri="{FF2B5EF4-FFF2-40B4-BE49-F238E27FC236}">
-                <a16:creationId xmlns:a16="http://schemas.microsoft.com/office/drawing/2014/main" id="{8F09813B-FE5E-4A1E-B030-13B1956EF734}"/>
+                <a16:creationId xmlns:a16="http://schemas.microsoft.com/office/drawing/2014/main" id="{A4987C2D-9EF5-452C-B2E2-55683D36B16F}"/>
               </a:ext>
             </a:extLst>
           </p:cNvPr>
@@ -10585,7 +9173,7 @@
           <p:cNvPr id="16" name="">
             <a:extLst xmlns:a="http://schemas.openxmlformats.org/drawingml/2006/main">
               <a:ext uri="{FF2B5EF4-FFF2-40B4-BE49-F238E27FC236}">
-                <a16:creationId xmlns:a16="http://schemas.microsoft.com/office/drawing/2014/main" id="{CB160F8C-7BE5-4DCD-99BD-25485F36BE02}"/>
+                <a16:creationId xmlns:a16="http://schemas.microsoft.com/office/drawing/2014/main" id="{E581C7EC-8286-4466-AB6D-BD099F4A6D07}"/>
               </a:ext>
             </a:extLst>
           </p:cNvPr>
@@ -10653,7 +9241,7 @@
           <p:cNvPr id="17" name="">
             <a:extLst xmlns:a="http://schemas.openxmlformats.org/drawingml/2006/main">
               <a:ext uri="{FF2B5EF4-FFF2-40B4-BE49-F238E27FC236}">
-                <a16:creationId xmlns:a16="http://schemas.microsoft.com/office/drawing/2014/main" id="{9D593F45-A91A-47A6-8C4D-7AE08D0F1C87}"/>
+                <a16:creationId xmlns:a16="http://schemas.microsoft.com/office/drawing/2014/main" id="{AFA62024-542A-46FF-B8F5-A253C51CB0D4}"/>
               </a:ext>
             </a:extLst>
           </p:cNvPr>
@@ -10719,7 +9307,7 @@
     </p:spTree>
     <p:extLst>
       <p:ext uri="{BB962C8B-B14F-4D97-AF65-F5344CB8AC3E}">
-        <p14:creationId xmlns:p14="http://schemas.microsoft.com/office/powerpoint/2010/main" val="308833806"/>
+        <p14:creationId xmlns:p14="http://schemas.microsoft.com/office/powerpoint/2010/main" val="966167488"/>
       </p:ext>
     </p:extLst>
   </p:cSld>
@@ -10750,7 +9338,7 @@
           <p:cNvPr id="17" name="">
             <a:extLst xmlns:a="http://schemas.openxmlformats.org/drawingml/2006/main">
               <a:ext uri="{FF2B5EF4-FFF2-40B4-BE49-F238E27FC236}">
-                <a16:creationId xmlns:a16="http://schemas.microsoft.com/office/drawing/2014/main" id="{632B0893-43DE-4DA3-BEAB-109761C3AF52}"/>
+                <a16:creationId xmlns:a16="http://schemas.microsoft.com/office/drawing/2014/main" id="{ABE62BDD-B51F-4EEB-8184-F410F49EC942}"/>
               </a:ext>
             </a:extLst>
           </p:cNvPr>
@@ -10760,7 +9348,7 @@
           <p:nvPr/>
         </p:nvPicPr>
         <p:blipFill>
-          <a:blip xmlns:r="http://schemas.openxmlformats.org/officeDocument/2006/relationships" xmlns:a="http://schemas.openxmlformats.org/drawingml/2006/main" r:embed="R4b852417b5404e3d"/>
+          <a:blip xmlns:r="http://schemas.openxmlformats.org/officeDocument/2006/relationships" xmlns:a="http://schemas.openxmlformats.org/drawingml/2006/main" r:embed="Rc8bcf862706a49f6"/>
           <a:stretch xmlns:a="http://schemas.openxmlformats.org/drawingml/2006/main"/>
         </p:blipFill>
         <p:spPr>
@@ -10778,7 +9366,7 @@
           <p:cNvPr id="2" name="">
             <a:extLst xmlns:a="http://schemas.openxmlformats.org/drawingml/2006/main">
               <a:ext uri="{FF2B5EF4-FFF2-40B4-BE49-F238E27FC236}">
-                <a16:creationId xmlns:a16="http://schemas.microsoft.com/office/drawing/2014/main" id="{6DC8825F-A36F-4D1B-8617-4AD95E0A2D90}"/>
+                <a16:creationId xmlns:a16="http://schemas.microsoft.com/office/drawing/2014/main" id="{9B539B16-F57B-40FE-96FD-A8115856F3E7}"/>
               </a:ext>
             </a:extLst>
           </p:cNvPr>
@@ -10846,7 +9434,7 @@
           <p:cNvPr id="3" name="">
             <a:extLst xmlns:a="http://schemas.openxmlformats.org/drawingml/2006/main">
               <a:ext uri="{FF2B5EF4-FFF2-40B4-BE49-F238E27FC236}">
-                <a16:creationId xmlns:a16="http://schemas.microsoft.com/office/drawing/2014/main" id="{ED0D2348-3A61-49A2-9C55-B363B17C567B}"/>
+                <a16:creationId xmlns:a16="http://schemas.microsoft.com/office/drawing/2014/main" id="{32DBB345-A669-4933-B87A-1521E5845753}"/>
               </a:ext>
             </a:extLst>
           </p:cNvPr>
@@ -10914,7 +9502,7 @@
           <p:cNvPr id="4" name="">
             <a:extLst xmlns:a="http://schemas.openxmlformats.org/drawingml/2006/main">
               <a:ext uri="{FF2B5EF4-FFF2-40B4-BE49-F238E27FC236}">
-                <a16:creationId xmlns:a16="http://schemas.microsoft.com/office/drawing/2014/main" id="{32E70627-1FFF-4F74-82CE-75EB390C02D8}"/>
+                <a16:creationId xmlns:a16="http://schemas.microsoft.com/office/drawing/2014/main" id="{18092C44-3EFC-45B7-8389-88C7394E7CFD}"/>
               </a:ext>
             </a:extLst>
           </p:cNvPr>
@@ -10982,7 +9570,7 @@
           <p:cNvPr id="5" name="">
             <a:extLst xmlns:a="http://schemas.openxmlformats.org/drawingml/2006/main">
               <a:ext uri="{FF2B5EF4-FFF2-40B4-BE49-F238E27FC236}">
-                <a16:creationId xmlns:a16="http://schemas.microsoft.com/office/drawing/2014/main" id="{EA98141E-C13B-4866-A851-9908A2751C5B}"/>
+                <a16:creationId xmlns:a16="http://schemas.microsoft.com/office/drawing/2014/main" id="{B24665EA-3EE5-464D-BA38-8152A8A5479B}"/>
               </a:ext>
             </a:extLst>
           </p:cNvPr>
@@ -11050,7 +9638,7 @@
           <p:cNvPr id="6" name="">
             <a:extLst xmlns:a="http://schemas.openxmlformats.org/drawingml/2006/main">
               <a:ext uri="{FF2B5EF4-FFF2-40B4-BE49-F238E27FC236}">
-                <a16:creationId xmlns:a16="http://schemas.microsoft.com/office/drawing/2014/main" id="{BEA89BDB-196B-42E4-A1F5-CB531BA370FA}"/>
+                <a16:creationId xmlns:a16="http://schemas.microsoft.com/office/drawing/2014/main" id="{E8C8A1D4-D5C1-4E3A-983C-FD03FEF9F59F}"/>
               </a:ext>
             </a:extLst>
           </p:cNvPr>
@@ -11108,7 +9696,7 @@
                 <a:ea typeface="Courier New"/>
                 <a:cs typeface="Courier New"/>
               </a:rPr>
-              <a:t>07 / 10</a:t>
+              <a:t>07 / 09</a:t>
             </a:r>
           </a:p>
         </p:txBody>
@@ -11118,7 +9706,7 @@
           <p:cNvPr id="7" name="">
             <a:extLst xmlns:a="http://schemas.openxmlformats.org/drawingml/2006/main">
               <a:ext uri="{FF2B5EF4-FFF2-40B4-BE49-F238E27FC236}">
-                <a16:creationId xmlns:a16="http://schemas.microsoft.com/office/drawing/2014/main" id="{BDCCF07D-A2BB-467A-B53C-20B5184DCDCB}"/>
+                <a16:creationId xmlns:a16="http://schemas.microsoft.com/office/drawing/2014/main" id="{A7ACA4EB-717D-4D7D-9178-E1CB813DD790}"/>
               </a:ext>
             </a:extLst>
           </p:cNvPr>
@@ -11128,7 +9716,7 @@
           <p:nvPr/>
         </p:nvPicPr>
         <p:blipFill>
-          <a:blip xmlns:r="http://schemas.openxmlformats.org/officeDocument/2006/relationships" xmlns:a="http://schemas.openxmlformats.org/drawingml/2006/main" r:embed="R02f1cde46f614665"/>
+          <a:blip xmlns:r="http://schemas.openxmlformats.org/officeDocument/2006/relationships" xmlns:a="http://schemas.openxmlformats.org/drawingml/2006/main" r:embed="Reba94fabd50e4d8b"/>
           <a:stretch xmlns:a="http://schemas.openxmlformats.org/drawingml/2006/main"/>
         </p:blipFill>
         <p:spPr>
@@ -11146,7 +9734,7 @@
           <p:cNvPr id="8" name="">
             <a:extLst xmlns:a="http://schemas.openxmlformats.org/drawingml/2006/main">
               <a:ext uri="{FF2B5EF4-FFF2-40B4-BE49-F238E27FC236}">
-                <a16:creationId xmlns:a16="http://schemas.microsoft.com/office/drawing/2014/main" id="{E7588643-611A-4B8D-A325-759D8147764E}"/>
+                <a16:creationId xmlns:a16="http://schemas.microsoft.com/office/drawing/2014/main" id="{C7F0E4D3-EC8C-46FA-9B6F-095593B87EC4}"/>
               </a:ext>
             </a:extLst>
           </p:cNvPr>
@@ -11214,7 +9802,7 @@
           <p:cNvPr id="9" name="">
             <a:extLst xmlns:a="http://schemas.openxmlformats.org/drawingml/2006/main">
               <a:ext uri="{FF2B5EF4-FFF2-40B4-BE49-F238E27FC236}">
-                <a16:creationId xmlns:a16="http://schemas.microsoft.com/office/drawing/2014/main" id="{9A50EE64-19C7-41EE-8ADD-A4B4D1D0B2F0}"/>
+                <a16:creationId xmlns:a16="http://schemas.microsoft.com/office/drawing/2014/main" id="{9D255D7A-A020-44A9-9D7C-AF31CB123D0A}"/>
               </a:ext>
             </a:extLst>
           </p:cNvPr>
@@ -11305,7 +9893,7 @@
           <p:cNvPr id="10" name="">
             <a:extLst xmlns:a="http://schemas.openxmlformats.org/drawingml/2006/main">
               <a:ext uri="{FF2B5EF4-FFF2-40B4-BE49-F238E27FC236}">
-                <a16:creationId xmlns:a16="http://schemas.microsoft.com/office/drawing/2014/main" id="{CF75BB9D-774A-41CB-9EFB-ADB32015FFB7}"/>
+                <a16:creationId xmlns:a16="http://schemas.microsoft.com/office/drawing/2014/main" id="{7F7828AB-3055-4DEE-AE0C-5E1B4D2F585F}"/>
               </a:ext>
             </a:extLst>
           </p:cNvPr>
@@ -11373,7 +9961,7 @@
           <p:cNvPr id="11" name="">
             <a:extLst xmlns:a="http://schemas.openxmlformats.org/drawingml/2006/main">
               <a:ext uri="{FF2B5EF4-FFF2-40B4-BE49-F238E27FC236}">
-                <a16:creationId xmlns:a16="http://schemas.microsoft.com/office/drawing/2014/main" id="{F8CB845B-2648-4A70-8AAD-79FC997B15A0}"/>
+                <a16:creationId xmlns:a16="http://schemas.microsoft.com/office/drawing/2014/main" id="{20760D1E-3A55-49A1-86C0-D5ABD5BFDB66}"/>
               </a:ext>
             </a:extLst>
           </p:cNvPr>
@@ -11441,7 +10029,7 @@
           <p:cNvPr id="12" name="">
             <a:extLst xmlns:a="http://schemas.openxmlformats.org/drawingml/2006/main">
               <a:ext uri="{FF2B5EF4-FFF2-40B4-BE49-F238E27FC236}">
-                <a16:creationId xmlns:a16="http://schemas.microsoft.com/office/drawing/2014/main" id="{763F734C-F8F1-4C50-B0E7-722928176AAF}"/>
+                <a16:creationId xmlns:a16="http://schemas.microsoft.com/office/drawing/2014/main" id="{254BE6EE-19BD-4FAE-BD31-307D0ACA8FAE}"/>
               </a:ext>
             </a:extLst>
           </p:cNvPr>
@@ -11509,7 +10097,7 @@
           <p:cNvPr id="13" name="">
             <a:extLst xmlns:a="http://schemas.openxmlformats.org/drawingml/2006/main">
               <a:ext uri="{FF2B5EF4-FFF2-40B4-BE49-F238E27FC236}">
-                <a16:creationId xmlns:a16="http://schemas.microsoft.com/office/drawing/2014/main" id="{C338A650-6D98-40A9-A2D1-01E3C0A73D08}"/>
+                <a16:creationId xmlns:a16="http://schemas.microsoft.com/office/drawing/2014/main" id="{3B03AAC5-D4D3-41FD-A290-D51C6DA288F1}"/>
               </a:ext>
             </a:extLst>
           </p:cNvPr>
@@ -11577,7 +10165,7 @@
           <p:cNvPr id="14" name="">
             <a:extLst xmlns:a="http://schemas.openxmlformats.org/drawingml/2006/main">
               <a:ext uri="{FF2B5EF4-FFF2-40B4-BE49-F238E27FC236}">
-                <a16:creationId xmlns:a16="http://schemas.microsoft.com/office/drawing/2014/main" id="{3328D9DC-9978-4FE4-BC31-22073A68E982}"/>
+                <a16:creationId xmlns:a16="http://schemas.microsoft.com/office/drawing/2014/main" id="{526C2213-A7B2-4A78-ACEB-754FE7B9554F}"/>
               </a:ext>
             </a:extLst>
           </p:cNvPr>
@@ -11645,7 +10233,7 @@
           <p:cNvPr id="15" name="">
             <a:extLst xmlns:a="http://schemas.openxmlformats.org/drawingml/2006/main">
               <a:ext uri="{FF2B5EF4-FFF2-40B4-BE49-F238E27FC236}">
-                <a16:creationId xmlns:a16="http://schemas.microsoft.com/office/drawing/2014/main" id="{6C92BB4B-E367-4CA2-B4CE-9C537A034E68}"/>
+                <a16:creationId xmlns:a16="http://schemas.microsoft.com/office/drawing/2014/main" id="{489C5FE2-4357-4B4A-97E4-FC72EB038138}"/>
               </a:ext>
             </a:extLst>
           </p:cNvPr>
@@ -11713,7 +10301,7 @@
           <p:cNvPr id="16" name="">
             <a:extLst xmlns:a="http://schemas.openxmlformats.org/drawingml/2006/main">
               <a:ext uri="{FF2B5EF4-FFF2-40B4-BE49-F238E27FC236}">
-                <a16:creationId xmlns:a16="http://schemas.microsoft.com/office/drawing/2014/main" id="{A21F33FC-041D-41C9-BFB1-D9AEB88D5583}"/>
+                <a16:creationId xmlns:a16="http://schemas.microsoft.com/office/drawing/2014/main" id="{8353DB86-9B22-4290-A1D3-6A12F56DFF36}"/>
               </a:ext>
             </a:extLst>
           </p:cNvPr>
@@ -11779,7 +10367,7 @@
     </p:spTree>
     <p:extLst>
       <p:ext uri="{BB962C8B-B14F-4D97-AF65-F5344CB8AC3E}">
-        <p14:creationId xmlns:p14="http://schemas.microsoft.com/office/powerpoint/2010/main" val="433236836"/>
+        <p14:creationId xmlns:p14="http://schemas.microsoft.com/office/powerpoint/2010/main" val="671921808"/>
       </p:ext>
     </p:extLst>
   </p:cSld>
@@ -11810,7 +10398,7 @@
           <p:cNvPr id="9" name="">
             <a:extLst xmlns:a="http://schemas.openxmlformats.org/drawingml/2006/main">
               <a:ext uri="{FF2B5EF4-FFF2-40B4-BE49-F238E27FC236}">
-                <a16:creationId xmlns:a16="http://schemas.microsoft.com/office/drawing/2014/main" id="{370BA55B-9926-4579-A52B-C76FC39311CB}"/>
+                <a16:creationId xmlns:a16="http://schemas.microsoft.com/office/drawing/2014/main" id="{6A818035-1334-458E-924D-6AF2C72BA1A2}"/>
               </a:ext>
             </a:extLst>
           </p:cNvPr>
@@ -11820,7 +10408,7 @@
           <p:nvPr/>
         </p:nvPicPr>
         <p:blipFill>
-          <a:blip xmlns:r="http://schemas.openxmlformats.org/officeDocument/2006/relationships" xmlns:a="http://schemas.openxmlformats.org/drawingml/2006/main" r:embed="Rc6dc6cefb0684230"/>
+          <a:blip xmlns:r="http://schemas.openxmlformats.org/officeDocument/2006/relationships" xmlns:a="http://schemas.openxmlformats.org/drawingml/2006/main" r:embed="Re35fca750adb4300"/>
           <a:stretch xmlns:a="http://schemas.openxmlformats.org/drawingml/2006/main"/>
         </p:blipFill>
         <p:spPr>
@@ -11838,7 +10426,7 @@
           <p:cNvPr id="2" name="">
             <a:extLst xmlns:a="http://schemas.openxmlformats.org/drawingml/2006/main">
               <a:ext uri="{FF2B5EF4-FFF2-40B4-BE49-F238E27FC236}">
-                <a16:creationId xmlns:a16="http://schemas.microsoft.com/office/drawing/2014/main" id="{70B1366D-AAD2-4579-8DCE-4EC5091BC443}"/>
+                <a16:creationId xmlns:a16="http://schemas.microsoft.com/office/drawing/2014/main" id="{112CAE62-6F80-4EAA-BAD8-2CCA48A3E681}"/>
               </a:ext>
             </a:extLst>
           </p:cNvPr>
@@ -11906,7 +10494,7 @@
           <p:cNvPr id="3" name="">
             <a:extLst xmlns:a="http://schemas.openxmlformats.org/drawingml/2006/main">
               <a:ext uri="{FF2B5EF4-FFF2-40B4-BE49-F238E27FC236}">
-                <a16:creationId xmlns:a16="http://schemas.microsoft.com/office/drawing/2014/main" id="{AE1B6EE0-756B-41F2-8FFA-35ED4CF949C5}"/>
+                <a16:creationId xmlns:a16="http://schemas.microsoft.com/office/drawing/2014/main" id="{996544D6-B15D-49E5-8DC5-066990CAF1EB}"/>
               </a:ext>
             </a:extLst>
           </p:cNvPr>
@@ -11974,7 +10562,7 @@
           <p:cNvPr id="4" name="">
             <a:extLst xmlns:a="http://schemas.openxmlformats.org/drawingml/2006/main">
               <a:ext uri="{FF2B5EF4-FFF2-40B4-BE49-F238E27FC236}">
-                <a16:creationId xmlns:a16="http://schemas.microsoft.com/office/drawing/2014/main" id="{6DEC5B3A-C511-4061-B2D9-24AA972752B8}"/>
+                <a16:creationId xmlns:a16="http://schemas.microsoft.com/office/drawing/2014/main" id="{2FF7C0FB-B8D0-428D-AEC0-A1D6BDAF7E94}"/>
               </a:ext>
             </a:extLst>
           </p:cNvPr>
@@ -12042,7 +10630,7 @@
           <p:cNvPr id="5" name="">
             <a:extLst xmlns:a="http://schemas.openxmlformats.org/drawingml/2006/main">
               <a:ext uri="{FF2B5EF4-FFF2-40B4-BE49-F238E27FC236}">
-                <a16:creationId xmlns:a16="http://schemas.microsoft.com/office/drawing/2014/main" id="{388C8114-05DE-433C-8A7B-C9FE79CC3046}"/>
+                <a16:creationId xmlns:a16="http://schemas.microsoft.com/office/drawing/2014/main" id="{EADF7A27-92D9-488F-B9C0-35E54A15A2E1}"/>
               </a:ext>
             </a:extLst>
           </p:cNvPr>
@@ -12110,7 +10698,7 @@
           <p:cNvPr id="6" name="">
             <a:extLst xmlns:a="http://schemas.openxmlformats.org/drawingml/2006/main">
               <a:ext uri="{FF2B5EF4-FFF2-40B4-BE49-F238E27FC236}">
-                <a16:creationId xmlns:a16="http://schemas.microsoft.com/office/drawing/2014/main" id="{A2C9249B-769F-4C7E-B073-AFF25A6DEEF2}"/>
+                <a16:creationId xmlns:a16="http://schemas.microsoft.com/office/drawing/2014/main" id="{EAC18411-F698-40A8-8195-DAD9C39B140A}"/>
               </a:ext>
             </a:extLst>
           </p:cNvPr>
@@ -12168,7 +10756,7 @@
                 <a:ea typeface="Courier New"/>
                 <a:cs typeface="Courier New"/>
               </a:rPr>
-              <a:t>08 / 10</a:t>
+              <a:t>08 / 09</a:t>
             </a:r>
           </a:p>
         </p:txBody>
@@ -12178,7 +10766,7 @@
           <p:cNvPr id="7" name="">
             <a:extLst xmlns:a="http://schemas.openxmlformats.org/drawingml/2006/main">
               <a:ext uri="{FF2B5EF4-FFF2-40B4-BE49-F238E27FC236}">
-                <a16:creationId xmlns:a16="http://schemas.microsoft.com/office/drawing/2014/main" id="{1EE70617-F91C-4992-852E-E3962A2B922B}"/>
+                <a16:creationId xmlns:a16="http://schemas.microsoft.com/office/drawing/2014/main" id="{B4BC3A6E-26F9-4A9C-97A1-0F856A5B8FC0}"/>
               </a:ext>
             </a:extLst>
           </p:cNvPr>
@@ -12246,7 +10834,7 @@
           <p:cNvPr id="8" name="">
             <a:extLst xmlns:a="http://schemas.openxmlformats.org/drawingml/2006/main">
               <a:ext uri="{FF2B5EF4-FFF2-40B4-BE49-F238E27FC236}">
-                <a16:creationId xmlns:a16="http://schemas.microsoft.com/office/drawing/2014/main" id="{A86E8926-062F-48D7-96ED-6AE27B962254}"/>
+                <a16:creationId xmlns:a16="http://schemas.microsoft.com/office/drawing/2014/main" id="{F2556F3F-6016-4F4E-9AB2-C67936EF876C}"/>
               </a:ext>
             </a:extLst>
           </p:cNvPr>
@@ -12987,7 +11575,7 @@
     </p:spTree>
     <p:extLst>
       <p:ext uri="{BB962C8B-B14F-4D97-AF65-F5344CB8AC3E}">
-        <p14:creationId xmlns:p14="http://schemas.microsoft.com/office/powerpoint/2010/main" val="2005984503"/>
+        <p14:creationId xmlns:p14="http://schemas.microsoft.com/office/powerpoint/2010/main" val="853094982"/>
       </p:ext>
     </p:extLst>
   </p:cSld>
@@ -13018,7 +11606,7 @@
           <p:cNvPr id="17" name="">
             <a:extLst xmlns:a="http://schemas.openxmlformats.org/drawingml/2006/main">
               <a:ext uri="{FF2B5EF4-FFF2-40B4-BE49-F238E27FC236}">
-                <a16:creationId xmlns:a16="http://schemas.microsoft.com/office/drawing/2014/main" id="{17889EC6-5A0F-427F-A302-D4C40963F61F}"/>
+                <a16:creationId xmlns:a16="http://schemas.microsoft.com/office/drawing/2014/main" id="{EC35A450-0897-4169-8266-D6A16190BA20}"/>
               </a:ext>
             </a:extLst>
           </p:cNvPr>
@@ -13028,7 +11616,7 @@
           <p:nvPr/>
         </p:nvPicPr>
         <p:blipFill>
-          <a:blip xmlns:r="http://schemas.openxmlformats.org/officeDocument/2006/relationships" xmlns:a="http://schemas.openxmlformats.org/drawingml/2006/main" r:embed="R16c6ade7cc8b4d27"/>
+          <a:blip xmlns:r="http://schemas.openxmlformats.org/officeDocument/2006/relationships" xmlns:a="http://schemas.openxmlformats.org/drawingml/2006/main" r:embed="R296c827564f448f8"/>
           <a:stretch xmlns:a="http://schemas.openxmlformats.org/drawingml/2006/main"/>
         </p:blipFill>
         <p:spPr>
@@ -13046,7 +11634,7 @@
           <p:cNvPr id="2" name="">
             <a:extLst xmlns:a="http://schemas.openxmlformats.org/drawingml/2006/main">
               <a:ext uri="{FF2B5EF4-FFF2-40B4-BE49-F238E27FC236}">
-                <a16:creationId xmlns:a16="http://schemas.microsoft.com/office/drawing/2014/main" id="{DFAF97A6-F34D-4771-94EB-341231672381}"/>
+                <a16:creationId xmlns:a16="http://schemas.microsoft.com/office/drawing/2014/main" id="{5B298ABC-E6C4-4306-A068-E8F7261346A8}"/>
               </a:ext>
             </a:extLst>
           </p:cNvPr>
@@ -13114,7 +11702,7 @@
           <p:cNvPr id="3" name="">
             <a:extLst xmlns:a="http://schemas.openxmlformats.org/drawingml/2006/main">
               <a:ext uri="{FF2B5EF4-FFF2-40B4-BE49-F238E27FC236}">
-                <a16:creationId xmlns:a16="http://schemas.microsoft.com/office/drawing/2014/main" id="{79CC2824-C4B6-4968-AEB9-CFB0080943D9}"/>
+                <a16:creationId xmlns:a16="http://schemas.microsoft.com/office/drawing/2014/main" id="{D28EC344-A5F1-4B51-9C35-AA2F10CEA755}"/>
               </a:ext>
             </a:extLst>
           </p:cNvPr>
@@ -13182,7 +11770,7 @@
           <p:cNvPr id="4" name="">
             <a:extLst xmlns:a="http://schemas.openxmlformats.org/drawingml/2006/main">
               <a:ext uri="{FF2B5EF4-FFF2-40B4-BE49-F238E27FC236}">
-                <a16:creationId xmlns:a16="http://schemas.microsoft.com/office/drawing/2014/main" id="{C0BDD5E7-A18D-4C52-BB28-ED7D6D263880}"/>
+                <a16:creationId xmlns:a16="http://schemas.microsoft.com/office/drawing/2014/main" id="{4963C9B5-FD04-4418-9FE6-4F2D324487AE}"/>
               </a:ext>
             </a:extLst>
           </p:cNvPr>
@@ -13250,7 +11838,7 @@
           <p:cNvPr id="5" name="">
             <a:extLst xmlns:a="http://schemas.openxmlformats.org/drawingml/2006/main">
               <a:ext uri="{FF2B5EF4-FFF2-40B4-BE49-F238E27FC236}">
-                <a16:creationId xmlns:a16="http://schemas.microsoft.com/office/drawing/2014/main" id="{041980EF-18AF-4FC7-9E2E-4ED32008143E}"/>
+                <a16:creationId xmlns:a16="http://schemas.microsoft.com/office/drawing/2014/main" id="{F4C98A13-804B-4102-A35D-0EC0FF75CCE6}"/>
               </a:ext>
             </a:extLst>
           </p:cNvPr>
@@ -13318,7 +11906,7 @@
           <p:cNvPr id="6" name="">
             <a:extLst xmlns:a="http://schemas.openxmlformats.org/drawingml/2006/main">
               <a:ext uri="{FF2B5EF4-FFF2-40B4-BE49-F238E27FC236}">
-                <a16:creationId xmlns:a16="http://schemas.microsoft.com/office/drawing/2014/main" id="{7D977DC2-F5C1-4544-AE70-E750903EC183}"/>
+                <a16:creationId xmlns:a16="http://schemas.microsoft.com/office/drawing/2014/main" id="{C5668523-827D-4772-9636-8086AE8476ED}"/>
               </a:ext>
             </a:extLst>
           </p:cNvPr>
@@ -13376,7 +11964,7 @@
                 <a:ea typeface="Courier New"/>
                 <a:cs typeface="Courier New"/>
               </a:rPr>
-              <a:t>09 / 10</a:t>
+              <a:t>09 / 09</a:t>
             </a:r>
           </a:p>
         </p:txBody>
@@ -13386,7 +11974,7 @@
           <p:cNvPr id="7" name="">
             <a:extLst xmlns:a="http://schemas.openxmlformats.org/drawingml/2006/main">
               <a:ext uri="{FF2B5EF4-FFF2-40B4-BE49-F238E27FC236}">
-                <a16:creationId xmlns:a16="http://schemas.microsoft.com/office/drawing/2014/main" id="{9B4562DE-8202-43C1-BFDA-F032A8B2B93A}"/>
+                <a16:creationId xmlns:a16="http://schemas.microsoft.com/office/drawing/2014/main" id="{56ACB112-1F3A-463A-A615-60B12E3D4D1D}"/>
               </a:ext>
             </a:extLst>
           </p:cNvPr>
@@ -13416,7 +12004,7 @@
           <p:cNvPr id="8" name="">
             <a:extLst xmlns:a="http://schemas.openxmlformats.org/drawingml/2006/main">
               <a:ext uri="{FF2B5EF4-FFF2-40B4-BE49-F238E27FC236}">
-                <a16:creationId xmlns:a16="http://schemas.microsoft.com/office/drawing/2014/main" id="{E8CABEC8-C632-4B0C-9645-EE4DE53BC368}"/>
+                <a16:creationId xmlns:a16="http://schemas.microsoft.com/office/drawing/2014/main" id="{FCBAE2FE-41FF-482A-A490-DFCD365BF9AC}"/>
               </a:ext>
             </a:extLst>
           </p:cNvPr>
@@ -13484,7 +12072,7 @@
           <p:cNvPr id="9" name="">
             <a:extLst xmlns:a="http://schemas.openxmlformats.org/drawingml/2006/main">
               <a:ext uri="{FF2B5EF4-FFF2-40B4-BE49-F238E27FC236}">
-                <a16:creationId xmlns:a16="http://schemas.microsoft.com/office/drawing/2014/main" id="{6BE4D11E-5D25-474D-9D7F-290F4CB7FE08}"/>
+                <a16:creationId xmlns:a16="http://schemas.microsoft.com/office/drawing/2014/main" id="{D953EA7C-F2D3-4EEE-BF44-77EA4018832F}"/>
               </a:ext>
             </a:extLst>
           </p:cNvPr>
@@ -13621,7 +12209,7 @@
           <p:cNvPr id="10" name="">
             <a:extLst xmlns:a="http://schemas.openxmlformats.org/drawingml/2006/main">
               <a:ext uri="{FF2B5EF4-FFF2-40B4-BE49-F238E27FC236}">
-                <a16:creationId xmlns:a16="http://schemas.microsoft.com/office/drawing/2014/main" id="{84C0BBED-5AA8-47F5-B9FF-D6C4F14A748D}"/>
+                <a16:creationId xmlns:a16="http://schemas.microsoft.com/office/drawing/2014/main" id="{E4FDFAD5-FB75-4117-823A-A904C7A9DF4B}"/>
               </a:ext>
             </a:extLst>
           </p:cNvPr>
@@ -13651,7 +12239,7 @@
           <p:cNvPr id="11" name="">
             <a:extLst xmlns:a="http://schemas.openxmlformats.org/drawingml/2006/main">
               <a:ext uri="{FF2B5EF4-FFF2-40B4-BE49-F238E27FC236}">
-                <a16:creationId xmlns:a16="http://schemas.microsoft.com/office/drawing/2014/main" id="{8BCC3754-CC0C-4273-8D2A-43B7A87C7807}"/>
+                <a16:creationId xmlns:a16="http://schemas.microsoft.com/office/drawing/2014/main" id="{1981A974-A448-4FF9-AB7D-0B61CC481F35}"/>
               </a:ext>
             </a:extLst>
           </p:cNvPr>
@@ -13719,7 +12307,7 @@
           <p:cNvPr id="12" name="">
             <a:extLst xmlns:a="http://schemas.openxmlformats.org/drawingml/2006/main">
               <a:ext uri="{FF2B5EF4-FFF2-40B4-BE49-F238E27FC236}">
-                <a16:creationId xmlns:a16="http://schemas.microsoft.com/office/drawing/2014/main" id="{8E54251B-9706-4A8D-AE87-C21AD357988A}"/>
+                <a16:creationId xmlns:a16="http://schemas.microsoft.com/office/drawing/2014/main" id="{9A312295-1A10-4429-AEA7-72B88950B1B9}"/>
               </a:ext>
             </a:extLst>
           </p:cNvPr>
@@ -13856,7 +12444,7 @@
           <p:cNvPr id="13" name="">
             <a:extLst xmlns:a="http://schemas.openxmlformats.org/drawingml/2006/main">
               <a:ext uri="{FF2B5EF4-FFF2-40B4-BE49-F238E27FC236}">
-                <a16:creationId xmlns:a16="http://schemas.microsoft.com/office/drawing/2014/main" id="{993C7F42-8D0B-4D3B-9F68-3F96C6188ADD}"/>
+                <a16:creationId xmlns:a16="http://schemas.microsoft.com/office/drawing/2014/main" id="{8E6A0B85-0F37-4F4A-B76B-2F6FCF00058F}"/>
               </a:ext>
             </a:extLst>
           </p:cNvPr>
@@ -13886,7 +12474,7 @@
           <p:cNvPr id="14" name="">
             <a:extLst xmlns:a="http://schemas.openxmlformats.org/drawingml/2006/main">
               <a:ext uri="{FF2B5EF4-FFF2-40B4-BE49-F238E27FC236}">
-                <a16:creationId xmlns:a16="http://schemas.microsoft.com/office/drawing/2014/main" id="{ACB2329B-E538-42F8-A697-4FC5DCA64A1E}"/>
+                <a16:creationId xmlns:a16="http://schemas.microsoft.com/office/drawing/2014/main" id="{69C1AB03-CE48-434D-B6B6-E6BB7DE74C57}"/>
               </a:ext>
             </a:extLst>
           </p:cNvPr>
@@ -13954,7 +12542,7 @@
           <p:cNvPr id="15" name="">
             <a:extLst xmlns:a="http://schemas.openxmlformats.org/drawingml/2006/main">
               <a:ext uri="{FF2B5EF4-FFF2-40B4-BE49-F238E27FC236}">
-                <a16:creationId xmlns:a16="http://schemas.microsoft.com/office/drawing/2014/main" id="{30113B5A-DEE2-46FA-BD4F-DEB5D98D7EBA}"/>
+                <a16:creationId xmlns:a16="http://schemas.microsoft.com/office/drawing/2014/main" id="{87D3F370-9E9F-488A-951C-B519E6978195}"/>
               </a:ext>
             </a:extLst>
           </p:cNvPr>
@@ -14091,7 +12679,7 @@
           <p:cNvPr id="16" name="">
             <a:extLst xmlns:a="http://schemas.openxmlformats.org/drawingml/2006/main">
               <a:ext uri="{FF2B5EF4-FFF2-40B4-BE49-F238E27FC236}">
-                <a16:creationId xmlns:a16="http://schemas.microsoft.com/office/drawing/2014/main" id="{E5185733-01AC-4E5F-99E1-07B73213DDE5}"/>
+                <a16:creationId xmlns:a16="http://schemas.microsoft.com/office/drawing/2014/main" id="{638529C3-8B6E-4C75-A579-FC6C4F6013D8}"/>
               </a:ext>
             </a:extLst>
           </p:cNvPr>
@@ -14157,7 +12745,7 @@
     </p:spTree>
     <p:extLst>
       <p:ext uri="{BB962C8B-B14F-4D97-AF65-F5344CB8AC3E}">
-        <p14:creationId xmlns:p14="http://schemas.microsoft.com/office/powerpoint/2010/main" val="2139791138"/>
+        <p14:creationId xmlns:p14="http://schemas.microsoft.com/office/powerpoint/2010/main" val="80216380"/>
       </p:ext>
     </p:extLst>
   </p:cSld>

</xml_diff>